<commit_message>
Merge cloud submission guidance into student tutorial
</commit_message>
<xml_diff>
--- a/docs/交我算平台Lab运行指南-学生版.pptx
+++ b/docs/交我算平台Lab运行指南-学生版.pptx
@@ -2,38 +2,41 @@
 <file path=ppt/presentation.xml><?xml version="1.0" encoding="utf-8"?>
 <p:presentation xmlns:p="http://schemas.openxmlformats.org/presentationml/2006/main">
   <p:sldMasterIdLst>
-    <p:sldMasterId xmlns:r="http://schemas.openxmlformats.org/officeDocument/2006/relationships" id="2147483648" r:id="R009db73397b34413"/>
+    <p:sldMasterId xmlns:r="http://schemas.openxmlformats.org/officeDocument/2006/relationships" id="2147483648" r:id="R8e8b2b72a4e4427a"/>
   </p:sldMasterIdLst>
   <p:notesMasterIdLst>
-    <p:notesMasterId xmlns:r="http://schemas.openxmlformats.org/officeDocument/2006/relationships" r:id="Rd176917aa69e4331"/>
+    <p:notesMasterId xmlns:r="http://schemas.openxmlformats.org/officeDocument/2006/relationships" r:id="R4a1295cde87746a5"/>
   </p:notesMasterIdLst>
   <p:sldIdLst>
-    <p:sldId xmlns:r="http://schemas.openxmlformats.org/officeDocument/2006/relationships" id="256" r:id="R5b95cdaa1dd54934"/>
-    <p:sldId xmlns:r="http://schemas.openxmlformats.org/officeDocument/2006/relationships" id="257" r:id="Re210a8ab189742a2"/>
-    <p:sldId xmlns:r="http://schemas.openxmlformats.org/officeDocument/2006/relationships" id="258" r:id="R471b62e28af64ae8"/>
-    <p:sldId xmlns:r="http://schemas.openxmlformats.org/officeDocument/2006/relationships" id="259" r:id="Rf3eff3e5c80346de"/>
-    <p:sldId xmlns:r="http://schemas.openxmlformats.org/officeDocument/2006/relationships" id="260" r:id="R2836ef8bfc984188"/>
-    <p:sldId xmlns:r="http://schemas.openxmlformats.org/officeDocument/2006/relationships" id="261" r:id="R3d2e8e26c702455f"/>
-    <p:sldId xmlns:r="http://schemas.openxmlformats.org/officeDocument/2006/relationships" id="262" r:id="R2d3c702676d04d75"/>
-    <p:sldId xmlns:r="http://schemas.openxmlformats.org/officeDocument/2006/relationships" id="263" r:id="R50314067dce74d29"/>
-    <p:sldId xmlns:r="http://schemas.openxmlformats.org/officeDocument/2006/relationships" id="264" r:id="Rdf98dc78b4c84dd9"/>
-    <p:sldId xmlns:r="http://schemas.openxmlformats.org/officeDocument/2006/relationships" id="265" r:id="R02b1ca6450f9486b"/>
-    <p:sldId xmlns:r="http://schemas.openxmlformats.org/officeDocument/2006/relationships" id="266" r:id="R5229ad3329154d42"/>
-    <p:sldId xmlns:r="http://schemas.openxmlformats.org/officeDocument/2006/relationships" id="267" r:id="R10a68851be4c4a03"/>
-    <p:sldId xmlns:r="http://schemas.openxmlformats.org/officeDocument/2006/relationships" id="268" r:id="Rec9c263d08754a82"/>
-    <p:sldId xmlns:r="http://schemas.openxmlformats.org/officeDocument/2006/relationships" id="269" r:id="R48f37ccb004243cf"/>
-    <p:sldId xmlns:r="http://schemas.openxmlformats.org/officeDocument/2006/relationships" id="270" r:id="R3861af8d822347a5"/>
-    <p:sldId xmlns:r="http://schemas.openxmlformats.org/officeDocument/2006/relationships" id="271" r:id="R0c3962ee5cfc4f83"/>
-    <p:sldId xmlns:r="http://schemas.openxmlformats.org/officeDocument/2006/relationships" id="272" r:id="Rf177f733c0a94913"/>
-    <p:sldId xmlns:r="http://schemas.openxmlformats.org/officeDocument/2006/relationships" id="273" r:id="Ree81869746c54b5f"/>
-    <p:sldId xmlns:r="http://schemas.openxmlformats.org/officeDocument/2006/relationships" id="274" r:id="R2fbc520762124f8f"/>
-    <p:sldId xmlns:r="http://schemas.openxmlformats.org/officeDocument/2006/relationships" id="275" r:id="Rddf472b108e44d1e"/>
-    <p:sldId xmlns:r="http://schemas.openxmlformats.org/officeDocument/2006/relationships" id="276" r:id="R41e35ae54b6d4ef6"/>
-    <p:sldId xmlns:r="http://schemas.openxmlformats.org/officeDocument/2006/relationships" id="277" r:id="Rf87db668066f4ad5"/>
-    <p:sldId xmlns:r="http://schemas.openxmlformats.org/officeDocument/2006/relationships" id="278" r:id="R95bef04d600747d5"/>
-    <p:sldId xmlns:r="http://schemas.openxmlformats.org/officeDocument/2006/relationships" id="279" r:id="R65b0007b01594410"/>
-    <p:sldId xmlns:r="http://schemas.openxmlformats.org/officeDocument/2006/relationships" id="280" r:id="R0c47916eff9a4886"/>
-    <p:sldId xmlns:r="http://schemas.openxmlformats.org/officeDocument/2006/relationships" id="281" r:id="Rc52bf92182c84a40"/>
+    <p:sldId xmlns:r="http://schemas.openxmlformats.org/officeDocument/2006/relationships" id="256" r:id="R7fee738532d746e1"/>
+    <p:sldId xmlns:r="http://schemas.openxmlformats.org/officeDocument/2006/relationships" id="257" r:id="R697a093346934758"/>
+    <p:sldId xmlns:r="http://schemas.openxmlformats.org/officeDocument/2006/relationships" id="258" r:id="R978f60e158e34e1a"/>
+    <p:sldId xmlns:r="http://schemas.openxmlformats.org/officeDocument/2006/relationships" id="259" r:id="Ree067b619d48410e"/>
+    <p:sldId xmlns:r="http://schemas.openxmlformats.org/officeDocument/2006/relationships" id="260" r:id="R769425df93e04fa6"/>
+    <p:sldId xmlns:r="http://schemas.openxmlformats.org/officeDocument/2006/relationships" id="261" r:id="R0f4db516a1f64eef"/>
+    <p:sldId xmlns:r="http://schemas.openxmlformats.org/officeDocument/2006/relationships" id="262" r:id="Rc0b1a19997fb4dfc"/>
+    <p:sldId xmlns:r="http://schemas.openxmlformats.org/officeDocument/2006/relationships" id="263" r:id="Raa213ea74d02432a"/>
+    <p:sldId xmlns:r="http://schemas.openxmlformats.org/officeDocument/2006/relationships" id="264" r:id="R198c39ae379a4152"/>
+    <p:sldId xmlns:r="http://schemas.openxmlformats.org/officeDocument/2006/relationships" id="265" r:id="R492a68928f7f4161"/>
+    <p:sldId xmlns:r="http://schemas.openxmlformats.org/officeDocument/2006/relationships" id="266" r:id="R1134c625252940b1"/>
+    <p:sldId xmlns:r="http://schemas.openxmlformats.org/officeDocument/2006/relationships" id="267" r:id="Rc7620d0c8c124863"/>
+    <p:sldId xmlns:r="http://schemas.openxmlformats.org/officeDocument/2006/relationships" id="268" r:id="R8c4ab4dd80364d87"/>
+    <p:sldId xmlns:r="http://schemas.openxmlformats.org/officeDocument/2006/relationships" id="269" r:id="Re7c70e650fe24c03"/>
+    <p:sldId xmlns:r="http://schemas.openxmlformats.org/officeDocument/2006/relationships" id="270" r:id="Rb478e241d3a44a81"/>
+    <p:sldId xmlns:r="http://schemas.openxmlformats.org/officeDocument/2006/relationships" id="271" r:id="R6108d92f0ac046f9"/>
+    <p:sldId xmlns:r="http://schemas.openxmlformats.org/officeDocument/2006/relationships" id="272" r:id="Rfee98f6ffe5843cb"/>
+    <p:sldId xmlns:r="http://schemas.openxmlformats.org/officeDocument/2006/relationships" id="273" r:id="R1425fda4eb404fbb"/>
+    <p:sldId xmlns:r="http://schemas.openxmlformats.org/officeDocument/2006/relationships" id="274" r:id="R627b1938d9334a24"/>
+    <p:sldId xmlns:r="http://schemas.openxmlformats.org/officeDocument/2006/relationships" id="275" r:id="R135c7721aa964f9b"/>
+    <p:sldId xmlns:r="http://schemas.openxmlformats.org/officeDocument/2006/relationships" id="276" r:id="R3fe350374cad449a"/>
+    <p:sldId xmlns:r="http://schemas.openxmlformats.org/officeDocument/2006/relationships" id="277" r:id="R731551d6f50f4a0e"/>
+    <p:sldId xmlns:r="http://schemas.openxmlformats.org/officeDocument/2006/relationships" id="278" r:id="R47ae73d605bd44d6"/>
+    <p:sldId xmlns:r="http://schemas.openxmlformats.org/officeDocument/2006/relationships" id="279" r:id="R825a2d3fb6d24de5"/>
+    <p:sldId xmlns:r="http://schemas.openxmlformats.org/officeDocument/2006/relationships" id="280" r:id="Re6256507a12f422a"/>
+    <p:sldId xmlns:r="http://schemas.openxmlformats.org/officeDocument/2006/relationships" id="281" r:id="R8af782a649704f12"/>
+    <p:sldId xmlns:r="http://schemas.openxmlformats.org/officeDocument/2006/relationships" id="282" r:id="Rb69d1f6484a2470b"/>
+    <p:sldId xmlns:r="http://schemas.openxmlformats.org/officeDocument/2006/relationships" id="283" r:id="Ra41586e90b134f66"/>
+    <p:sldId xmlns:r="http://schemas.openxmlformats.org/officeDocument/2006/relationships" id="284" r:id="R30d346fe10364253"/>
   </p:sldIdLst>
   <p:sldSz cx="15240000" cy="8572500"/>
   <p:notesSz cx="6858000" cy="9144000"/>
@@ -1872,22 +1875,12 @@
           <a:lstStyle xmlns:a="http://schemas.openxmlformats.org/drawingml/2006/main"/>
           <a:p xmlns:a="http://schemas.openxmlformats.org/drawingml/2006/main">
             <a:r>
-              <a:t>下载示例同时收集两个 Lab，正式按每个 Lab 题面分别打包。pi2-submission 若已存在，应核对版本或换新目录，避免混淆。不要上传构建目录、可执行文件或个人 SSH 配置。教师维护课程仓库，学生通过指定的云盘收件入口交作业，无需 PR。</a:t>
-            </a:r>
-          </a:p>
-          <a:p xmlns:a="http://schemas.openxmlformats.org/drawingml/2006/main">
-            <a:r>
-              <a:t/>
-            </a:r>
-          </a:p>
-          <a:p xmlns:a="http://schemas.openxmlformats.org/drawingml/2006/main">
-            <a:r>
-              <a:t>来源：</a:t>
-            </a:r>
-          </a:p>
-          <a:p xmlns:a="http://schemas.openxmlformats.org/drawingml/2006/main">
-            <a:r>
-              <a:t/>
+              <a:t>按当前 Lab 选择下载命令。学生在云盘源码收集任务中上传单个 .c 文件；云盘可按学号和姓名重命名。报告与日志按教师指定的其他入口提交。</a:t>
+            </a:r>
+          </a:p>
+          <a:p xmlns:a="http://schemas.openxmlformats.org/drawingml/2006/main">
+            <a:r>
+              <a:t>来源：https://pan.sjtu.edu.cn/pandoc/file-collection.html</a:t>
             </a:r>
           </a:p>
         </p:txBody>
@@ -1957,37 +1950,12 @@
           <a:lstStyle xmlns:a="http://schemas.openxmlformats.org/drawingml/2006/main"/>
           <a:p xmlns:a="http://schemas.openxmlformats.org/drawingml/2006/main">
             <a:r>
-              <a:t>若 cmake 不存在或版本过旧，在分配的计算节点上 module avail cmake，再 module load 实际存在的完整模块名，随后验证 cmake --version。旧 CMake 缓存必须使用新的构建目录，不能跨本地和集群复用。当前 labs/lab2-matrix/scripts/submit.sh 仅是 run_all.sh 的包装，不调用 sbatch，因此不能直接在登录节点使用。</a:t>
-            </a:r>
-          </a:p>
-          <a:p xmlns:a="http://schemas.openxmlformats.org/drawingml/2006/main">
-            <a:r>
-              <a:t/>
-            </a:r>
-          </a:p>
-          <a:p xmlns:a="http://schemas.openxmlformats.org/drawingml/2006/main">
-            <a:r>
-              <a:t>来源：</a:t>
-            </a:r>
-          </a:p>
-          <a:p xmlns:a="http://schemas.openxmlformats.org/drawingml/2006/main">
-            <a:r>
-              <a:t>https://docs.hpc.sjtu.edu.cn/job/slurm.html</a:t>
-            </a:r>
-          </a:p>
-          <a:p xmlns:a="http://schemas.openxmlformats.org/drawingml/2006/main">
-            <a:r>
-              <a:t>https://docs.hpc.sjtu.edu.cn/job/kos.html</a:t>
-            </a:r>
-          </a:p>
-          <a:p xmlns:a="http://schemas.openxmlformats.org/drawingml/2006/main">
-            <a:r>
-              <a:t>课程仓库 labs/lab1-datalab/README.md、Makefile、bits.c（2026-09-27）</a:t>
-            </a:r>
-          </a:p>
-          <a:p xmlns:a="http://schemas.openxmlformats.org/drawingml/2006/main">
-            <a:r>
-              <a:t>课程仓库 labs/lab2-matrix/CMakeLists.txt、README.md、benchmarks/*.c、scripts/*.sh（2026-09-27）</a:t>
+              <a:t>示例学号与姓名为虚构。课程收集任务设置学号和姓名命名字段，学生按字段填写。当前 Lab 1/2 的源码各为一个文件。教师给出具体链接、报告入口与截止时间。</a:t>
+            </a:r>
+          </a:p>
+          <a:p xmlns:a="http://schemas.openxmlformats.org/drawingml/2006/main">
+            <a:r>
+              <a:t>来源：https://pan.sjtu.edu.cn/pandoc/file-collection.html</a:t>
             </a:r>
           </a:p>
         </p:txBody>
@@ -2018,6 +1986,251 @@
 </file>
 
 <file path=ppt/notesSlides/notesSlide26.xml><?xml version="1.0" encoding="utf-8"?>
+<p:notes xmlns:p="http://schemas.openxmlformats.org/presentationml/2006/main">
+  <p:cSld>
+    <p:spTree>
+      <p:nvGrpSpPr>
+        <p:cNvPr id="1" name=""/>
+        <p:cNvGrpSpPr/>
+        <p:nvPr/>
+      </p:nvGrpSpPr>
+      <p:grpSpPr>
+        <a:xfrm xmlns:a="http://schemas.openxmlformats.org/drawingml/2006/main"/>
+      </p:grpSpPr>
+      <p:sp>
+        <p:nvSpPr>
+          <p:cNvPr id="2" name="Slide Image Placeholder 1"/>
+          <p:cNvSpPr>
+            <a:spLocks xmlns:a="http://schemas.openxmlformats.org/drawingml/2006/main" noGrp="1"/>
+          </p:cNvSpPr>
+          <p:nvPr>
+            <p:ph type="sldImg" idx="0"/>
+          </p:nvPr>
+        </p:nvSpPr>
+        <p:spPr/>
+      </p:sp>
+      <p:sp>
+        <p:nvSpPr>
+          <p:cNvPr id="3" name="Notes Placeholder 2"/>
+          <p:cNvSpPr>
+            <a:spLocks xmlns:a="http://schemas.openxmlformats.org/drawingml/2006/main" noGrp="1"/>
+          </p:cNvSpPr>
+          <p:nvPr>
+            <p:ph type="body" idx="1"/>
+          </p:nvPr>
+        </p:nvSpPr>
+        <p:spPr/>
+        <p:txBody>
+          <a:bodyPr xmlns:a="http://schemas.openxmlformats.org/drawingml/2006/main"/>
+          <a:lstStyle xmlns:a="http://schemas.openxmlformats.org/drawingml/2006/main"/>
+          <a:p xmlns:a="http://schemas.openxmlformats.org/drawingml/2006/main">
+            <a:r>
+              <a:t>云盘支持多次提交，同名文件可选择替换旧文件或保存两份。本课程建议替换，避免多版本无法确定。截止时间由收集任务有效期和课程通知确定。</a:t>
+            </a:r>
+          </a:p>
+          <a:p xmlns:a="http://schemas.openxmlformats.org/drawingml/2006/main">
+            <a:r>
+              <a:t>来源：https://pan.sjtu.edu.cn/pandoc/file-collection.html</a:t>
+            </a:r>
+          </a:p>
+        </p:txBody>
+      </p:sp>
+      <p:sp>
+        <p:nvSpPr>
+          <p:cNvPr id="4" name="Slide Number Placeholder 3"/>
+          <p:cNvSpPr>
+            <a:spLocks xmlns:a="http://schemas.openxmlformats.org/drawingml/2006/main" noGrp="1"/>
+          </p:cNvSpPr>
+          <p:nvPr>
+            <p:ph type="sldNum" idx="5"/>
+          </p:nvPr>
+        </p:nvSpPr>
+        <p:spPr/>
+        <p:txBody>
+          <a:bodyPr xmlns:a="http://schemas.openxmlformats.org/drawingml/2006/main"/>
+          <a:lstStyle xmlns:a="http://schemas.openxmlformats.org/drawingml/2006/main"/>
+          <a:p xmlns:a="http://schemas.openxmlformats.org/drawingml/2006/main"/>
+        </p:txBody>
+      </p:sp>
+    </p:spTree>
+  </p:cSld>
+  <p:clrMapOvr>
+    <a:masterClrMapping xmlns:a="http://schemas.openxmlformats.org/drawingml/2006/main"/>
+  </p:clrMapOvr>
+</p:notes>
+</file>
+
+<file path=ppt/notesSlides/notesSlide27.xml><?xml version="1.0" encoding="utf-8"?>
+<p:notes xmlns:p="http://schemas.openxmlformats.org/presentationml/2006/main">
+  <p:cSld>
+    <p:spTree>
+      <p:nvGrpSpPr>
+        <p:cNvPr id="1" name=""/>
+        <p:cNvGrpSpPr/>
+        <p:nvPr/>
+      </p:nvGrpSpPr>
+      <p:grpSpPr>
+        <a:xfrm xmlns:a="http://schemas.openxmlformats.org/drawingml/2006/main"/>
+      </p:grpSpPr>
+      <p:sp>
+        <p:nvSpPr>
+          <p:cNvPr id="2" name="Slide Image Placeholder 1"/>
+          <p:cNvSpPr>
+            <a:spLocks xmlns:a="http://schemas.openxmlformats.org/drawingml/2006/main" noGrp="1"/>
+          </p:cNvSpPr>
+          <p:nvPr>
+            <p:ph type="sldImg" idx="0"/>
+          </p:nvPr>
+        </p:nvSpPr>
+        <p:spPr/>
+      </p:sp>
+      <p:sp>
+        <p:nvSpPr>
+          <p:cNvPr id="3" name="Notes Placeholder 2"/>
+          <p:cNvSpPr>
+            <a:spLocks xmlns:a="http://schemas.openxmlformats.org/drawingml/2006/main" noGrp="1"/>
+          </p:cNvSpPr>
+          <p:nvPr>
+            <p:ph type="body" idx="1"/>
+          </p:nvPr>
+        </p:nvSpPr>
+        <p:spPr/>
+        <p:txBody>
+          <a:bodyPr xmlns:a="http://schemas.openxmlformats.org/drawingml/2006/main"/>
+          <a:lstStyle xmlns:a="http://schemas.openxmlformats.org/drawingml/2006/main"/>
+          <a:p xmlns:a="http://schemas.openxmlformats.org/drawingml/2006/main">
+            <a:r>
+              <a:t>当前流水线自动评分只覆盖数值/位级正确性。Lab 1 保留 50 分制及单个错误半分规则；Lab 2 保留 100 分制。未决收件与环境问题保留空分待处理。教师统一处理反馈，不在学生共享目录发布全班成绩。依据课程 grader/README.md 与 docs/作业提交说明.md。</a:t>
+            </a:r>
+          </a:p>
+        </p:txBody>
+      </p:sp>
+      <p:sp>
+        <p:nvSpPr>
+          <p:cNvPr id="4" name="Slide Number Placeholder 3"/>
+          <p:cNvSpPr>
+            <a:spLocks xmlns:a="http://schemas.openxmlformats.org/drawingml/2006/main" noGrp="1"/>
+          </p:cNvSpPr>
+          <p:nvPr>
+            <p:ph type="sldNum" idx="5"/>
+          </p:nvPr>
+        </p:nvSpPr>
+        <p:spPr/>
+        <p:txBody>
+          <a:bodyPr xmlns:a="http://schemas.openxmlformats.org/drawingml/2006/main"/>
+          <a:lstStyle xmlns:a="http://schemas.openxmlformats.org/drawingml/2006/main"/>
+          <a:p xmlns:a="http://schemas.openxmlformats.org/drawingml/2006/main"/>
+        </p:txBody>
+      </p:sp>
+    </p:spTree>
+  </p:cSld>
+  <p:clrMapOvr>
+    <a:masterClrMapping xmlns:a="http://schemas.openxmlformats.org/drawingml/2006/main"/>
+  </p:clrMapOvr>
+</p:notes>
+</file>
+
+<file path=ppt/notesSlides/notesSlide28.xml><?xml version="1.0" encoding="utf-8"?>
+<p:notes xmlns:p="http://schemas.openxmlformats.org/presentationml/2006/main">
+  <p:cSld>
+    <p:spTree>
+      <p:nvGrpSpPr>
+        <p:cNvPr id="1" name=""/>
+        <p:cNvGrpSpPr/>
+        <p:nvPr/>
+      </p:nvGrpSpPr>
+      <p:grpSpPr>
+        <a:xfrm xmlns:a="http://schemas.openxmlformats.org/drawingml/2006/main"/>
+      </p:grpSpPr>
+      <p:sp>
+        <p:nvSpPr>
+          <p:cNvPr id="2" name="Slide Image Placeholder 1"/>
+          <p:cNvSpPr>
+            <a:spLocks xmlns:a="http://schemas.openxmlformats.org/drawingml/2006/main" noGrp="1"/>
+          </p:cNvSpPr>
+          <p:nvPr>
+            <p:ph type="sldImg" idx="0"/>
+          </p:nvPr>
+        </p:nvSpPr>
+        <p:spPr/>
+      </p:sp>
+      <p:sp>
+        <p:nvSpPr>
+          <p:cNvPr id="3" name="Notes Placeholder 2"/>
+          <p:cNvSpPr>
+            <a:spLocks xmlns:a="http://schemas.openxmlformats.org/drawingml/2006/main" noGrp="1"/>
+          </p:cNvSpPr>
+          <p:nvPr>
+            <p:ph type="body" idx="1"/>
+          </p:nvPr>
+        </p:nvSpPr>
+        <p:spPr/>
+        <p:txBody>
+          <a:bodyPr xmlns:a="http://schemas.openxmlformats.org/drawingml/2006/main"/>
+          <a:lstStyle xmlns:a="http://schemas.openxmlformats.org/drawingml/2006/main"/>
+          <a:p xmlns:a="http://schemas.openxmlformats.org/drawingml/2006/main">
+            <a:r>
+              <a:t>若 cmake 不存在或版本过旧，在分配的计算节点上 module avail cmake，再 module load 实际存在的完整模块名，随后验证 cmake --version。旧 CMake 缓存必须使用新的构建目录，不能跨本地和集群复用。当前 labs/lab2-matrix/scripts/submit.sh 仅是 run_all.sh 的包装，不调用 sbatch，因此不能直接在登录节点使用。</a:t>
+            </a:r>
+          </a:p>
+          <a:p xmlns:a="http://schemas.openxmlformats.org/drawingml/2006/main">
+            <a:r>
+              <a:t/>
+            </a:r>
+          </a:p>
+          <a:p xmlns:a="http://schemas.openxmlformats.org/drawingml/2006/main">
+            <a:r>
+              <a:t>来源：</a:t>
+            </a:r>
+          </a:p>
+          <a:p xmlns:a="http://schemas.openxmlformats.org/drawingml/2006/main">
+            <a:r>
+              <a:t>https://docs.hpc.sjtu.edu.cn/job/slurm.html</a:t>
+            </a:r>
+          </a:p>
+          <a:p xmlns:a="http://schemas.openxmlformats.org/drawingml/2006/main">
+            <a:r>
+              <a:t>https://docs.hpc.sjtu.edu.cn/job/kos.html</a:t>
+            </a:r>
+          </a:p>
+          <a:p xmlns:a="http://schemas.openxmlformats.org/drawingml/2006/main">
+            <a:r>
+              <a:t>课程仓库 labs/lab1-datalab/README.md、Makefile、bits.c（2026-09-27）</a:t>
+            </a:r>
+          </a:p>
+          <a:p xmlns:a="http://schemas.openxmlformats.org/drawingml/2006/main">
+            <a:r>
+              <a:t>课程仓库 labs/lab2-matrix/CMakeLists.txt、README.md、benchmarks/*.c、scripts/*.sh（2026-09-27）</a:t>
+            </a:r>
+          </a:p>
+        </p:txBody>
+      </p:sp>
+      <p:sp>
+        <p:nvSpPr>
+          <p:cNvPr id="4" name="Slide Number Placeholder 3"/>
+          <p:cNvSpPr>
+            <a:spLocks xmlns:a="http://schemas.openxmlformats.org/drawingml/2006/main" noGrp="1"/>
+          </p:cNvSpPr>
+          <p:nvPr>
+            <p:ph type="sldNum" idx="5"/>
+          </p:nvPr>
+        </p:nvSpPr>
+        <p:spPr/>
+        <p:txBody>
+          <a:bodyPr xmlns:a="http://schemas.openxmlformats.org/drawingml/2006/main"/>
+          <a:lstStyle xmlns:a="http://schemas.openxmlformats.org/drawingml/2006/main"/>
+          <a:p xmlns:a="http://schemas.openxmlformats.org/drawingml/2006/main"/>
+        </p:txBody>
+      </p:sp>
+    </p:spTree>
+  </p:cSld>
+  <p:clrMapOvr>
+    <a:masterClrMapping xmlns:a="http://schemas.openxmlformats.org/drawingml/2006/main"/>
+  </p:clrMapOvr>
+</p:notes>
+</file>
+
+<file path=ppt/notesSlides/notesSlide29.xml><?xml version="1.0" encoding="utf-8"?>
 <p:notes xmlns:p="http://schemas.openxmlformats.org/presentationml/2006/main">
   <p:cSld>
     <p:spTree>
@@ -2800,7 +3013,7 @@
   </p:cSld>
   <p:clrMap bg1="lt1" tx1="dk1" bg2="lt2" tx2="dk2" accent1="accent1" accent2="accent2" accent3="accent3" accent4="accent4" accent5="accent5" accent6="accent6" hlink="hlink" folHlink="folHlink"/>
   <p:sldLayoutIdLst>
-    <p:sldLayoutId xmlns:r="http://schemas.openxmlformats.org/officeDocument/2006/relationships" id="2147483649" r:id="Re5e623b6362c4da3"/>
+    <p:sldLayoutId xmlns:r="http://schemas.openxmlformats.org/officeDocument/2006/relationships" id="2147483649" r:id="R84be41399f4146a9"/>
   </p:sldLayoutIdLst>
   <p:txStyles>
     <p:titleStyle>
@@ -3815,6 +4028,7 @@
           <a:lstStyle xmlns:a="http://schemas.openxmlformats.org/drawingml/2006/main"/>
           <a:p xmlns:a="http://schemas.openxmlformats.org/drawingml/2006/main">
             <a:pPr>
+              <a:buNone/>
               <a:defRPr sz="2550">
                 <a:solidFill>
                   <a:srgbClr val="EAF1EF"/>
@@ -3872,6 +4086,7 @@
           <a:lstStyle xmlns:a="http://schemas.openxmlformats.org/drawingml/2006/main"/>
           <a:p xmlns:a="http://schemas.openxmlformats.org/drawingml/2006/main">
             <a:pPr>
+              <a:buNone/>
               <a:defRPr sz="3225">
                 <a:solidFill>
                   <a:srgbClr val="B7EDDB"/>
@@ -3929,6 +4144,7 @@
           <a:lstStyle xmlns:a="http://schemas.openxmlformats.org/drawingml/2006/main"/>
           <a:p xmlns:a="http://schemas.openxmlformats.org/drawingml/2006/main">
             <a:pPr>
+              <a:buNone/>
               <a:defRPr sz="2250">
                 <a:solidFill>
                   <a:srgbClr val="EAF1EF"/>
@@ -3986,6 +4202,7 @@
           <a:lstStyle xmlns:a="http://schemas.openxmlformats.org/drawingml/2006/main"/>
           <a:p xmlns:a="http://schemas.openxmlformats.org/drawingml/2006/main">
             <a:pPr>
+              <a:buNone/>
               <a:defRPr sz="2325">
                 <a:solidFill>
                   <a:srgbClr val="EAF1EF"/>
@@ -4043,6 +4260,7 @@
           <a:lstStyle xmlns:a="http://schemas.openxmlformats.org/drawingml/2006/main"/>
           <a:p xmlns:a="http://schemas.openxmlformats.org/drawingml/2006/main">
             <a:pPr>
+              <a:buNone/>
               <a:defRPr sz="2175">
                 <a:solidFill>
                   <a:srgbClr val="B7EDDB"/>
@@ -4100,6 +4318,7 @@
           <a:lstStyle xmlns:a="http://schemas.openxmlformats.org/drawingml/2006/main"/>
           <a:p xmlns:a="http://schemas.openxmlformats.org/drawingml/2006/main">
             <a:pPr>
+              <a:buNone/>
               <a:defRPr sz="2325">
                 <a:solidFill>
                   <a:srgbClr val="EAF1EF"/>
@@ -4157,6 +4376,7 @@
           <a:lstStyle xmlns:a="http://schemas.openxmlformats.org/drawingml/2006/main"/>
           <a:p xmlns:a="http://schemas.openxmlformats.org/drawingml/2006/main">
             <a:pPr>
+              <a:buNone/>
               <a:defRPr sz="2250">
                 <a:solidFill>
                   <a:srgbClr val="EAF1EF"/>
@@ -4214,6 +4434,7 @@
           <a:lstStyle xmlns:a="http://schemas.openxmlformats.org/drawingml/2006/main"/>
           <a:p xmlns:a="http://schemas.openxmlformats.org/drawingml/2006/main">
             <a:pPr>
+              <a:buNone/>
               <a:defRPr sz="1875">
                 <a:solidFill>
                   <a:srgbClr val="A8C6C4"/>
@@ -13715,7 +13936,7 @@
                 <a:ea typeface="Hiragino Sans GB"/>
                 <a:cs typeface="Hiragino Sans GB"/>
               </a:rPr>
-              <a:t>通过交大云盘提交作业</a:t>
+              <a:t>下载最终源码</a:t>
             </a:r>
           </a:p>
         </p:txBody>
@@ -14121,7 +14342,7 @@
                 <a:ea typeface="Hiragino Sans GB"/>
                 <a:cs typeface="Hiragino Sans GB"/>
               </a:rPr>
-              <a:t>按 Lab 整理源码、报告与日志，建议命名：学号_姓名_Lab编号.zip</a:t>
+              <a:t>两条下载命令按当前 Lab 选择，分别上传对应的源码收集任务</a:t>
             </a:r>
           </a:p>
         </p:txBody>
@@ -14179,7 +14400,7 @@
                 <a:ea typeface="Hiragino Sans GB"/>
                 <a:cs typeface="Hiragino Sans GB"/>
               </a:rPr>
-              <a:t>上传教师指定的云盘收件入口，重新下载核对并保留提交记录</a:t>
+              <a:t>源码单独提交 .c 文件，报告与日志按课程指定入口另交</a:t>
             </a:r>
           </a:p>
         </p:txBody>
@@ -14237,7 +14458,7 @@
                 <a:ea typeface="Hiragino Sans GB"/>
                 <a:cs typeface="Hiragino Sans GB"/>
               </a:rPr>
-              <a:t>以题面和截止时间为准。云盘上传后由教师统一评分，不会触发 GitHub 自动测试。</a:t>
+              <a:t>上传前打开本地文件，核对已保存的最终代码。保留本地副本与提交记录。</a:t>
             </a:r>
           </a:p>
         </p:txBody>
@@ -14253,6 +14474,1467 @@
 </file>
 
 <file path=ppt/slides/slide25.xml><?xml version="1.0" encoding="utf-8"?>
+<p:sld xmlns:p="http://schemas.openxmlformats.org/presentationml/2006/main">
+  <p:cSld>
+    <p:bg>
+      <p:bgPr>
+        <a:solidFill xmlns:a="http://schemas.openxmlformats.org/drawingml/2006/main">
+          <a:srgbClr val="102C35"/>
+        </a:solidFill>
+      </p:bgPr>
+    </p:bg>
+    <p:spTree>
+      <p:nvGrpSpPr>
+        <p:cNvPr id="1" name=""/>
+        <p:cNvGrpSpPr/>
+        <p:nvPr/>
+      </p:nvGrpSpPr>
+      <p:grpSpPr>
+        <a:xfrm xmlns:a="http://schemas.openxmlformats.org/drawingml/2006/main"/>
+      </p:grpSpPr>
+      <p:sp>
+        <p:nvSpPr>
+          <p:cNvPr id="9" name="">
+            <a:extLst xmlns:a="http://schemas.openxmlformats.org/drawingml/2006/main">
+              <a:ext uri="{FF2B5EF4-FFF2-40B4-BE49-F238E27FC236}">
+                <a16:creationId xmlns:a16="http://schemas.microsoft.com/office/drawing/2014/main" id="{974B2865-DC00-4E59-9F3A-640A7913DC3C}"/>
+              </a:ext>
+            </a:extLst>
+          </p:cNvPr>
+          <p:cNvSpPr>
+            <a:spLocks xmlns:a="http://schemas.openxmlformats.org/drawingml/2006/main" noGrp="1"/>
+          </p:cNvSpPr>
+          <p:nvPr/>
+        </p:nvSpPr>
+        <p:spPr>
+          <a:xfrm xmlns:a="http://schemas.openxmlformats.org/drawingml/2006/main">
+            <a:off x="838200" y="628650"/>
+            <a:ext cx="13477875" cy="838200"/>
+          </a:xfrm>
+          <a:prstGeom xmlns:a="http://schemas.openxmlformats.org/drawingml/2006/main" prst="rect">
+            <a:avLst/>
+          </a:prstGeom>
+          <a:noFill xmlns:a="http://schemas.openxmlformats.org/drawingml/2006/main"/>
+          <a:ln xmlns:a="http://schemas.openxmlformats.org/drawingml/2006/main" w="0">
+            <a:noFill/>
+          </a:ln>
+        </p:spPr>
+        <p:txBody>
+          <a:bodyPr xmlns:a="http://schemas.openxmlformats.org/drawingml/2006/main" wrap="none" lIns="0" tIns="0" rIns="0" bIns="0" anchor="t">
+            <a:noAutofit/>
+          </a:bodyPr>
+          <a:lstStyle xmlns:a="http://schemas.openxmlformats.org/drawingml/2006/main"/>
+          <a:p xmlns:a="http://schemas.openxmlformats.org/drawingml/2006/main">
+            <a:pPr>
+              <a:buNone/>
+              <a:defRPr sz="3900" b="1">
+                <a:solidFill>
+                  <a:srgbClr val="EAF1EF"/>
+                </a:solidFill>
+                <a:latin typeface="Hiragino Sans GB"/>
+                <a:ea typeface="Hiragino Sans GB"/>
+                <a:cs typeface="Hiragino Sans GB"/>
+              </a:defRPr>
+            </a:pPr>
+            <a:r>
+              <a:rPr sz="3900" b="1">
+                <a:solidFill>
+                  <a:srgbClr val="EAF1EF"/>
+                </a:solidFill>
+                <a:latin typeface="Hiragino Sans GB"/>
+                <a:ea typeface="Hiragino Sans GB"/>
+                <a:cs typeface="Hiragino Sans GB"/>
+              </a:rPr>
+              <a:t>云盘源码提交要求</a:t>
+            </a:r>
+          </a:p>
+        </p:txBody>
+      </p:sp>
+      <p:sp>
+        <p:nvSpPr>
+          <p:cNvPr id="2" name="">
+            <a:extLst xmlns:a="http://schemas.openxmlformats.org/drawingml/2006/main">
+              <a:ext uri="{FF2B5EF4-FFF2-40B4-BE49-F238E27FC236}">
+                <a16:creationId xmlns:a16="http://schemas.microsoft.com/office/drawing/2014/main" id="{AFA67C7E-1DCE-457B-9A22-9FD38D176CF9}"/>
+              </a:ext>
+            </a:extLst>
+          </p:cNvPr>
+          <p:cNvSpPr>
+            <a:spLocks xmlns:a="http://schemas.openxmlformats.org/drawingml/2006/main" noGrp="1"/>
+          </p:cNvSpPr>
+          <p:nvPr/>
+        </p:nvSpPr>
+        <p:spPr>
+          <a:xfrm xmlns:a="http://schemas.openxmlformats.org/drawingml/2006/main">
+            <a:off x="13906500" y="7972425"/>
+            <a:ext cx="514350" cy="323850"/>
+          </a:xfrm>
+          <a:prstGeom xmlns:a="http://schemas.openxmlformats.org/drawingml/2006/main" prst="rect">
+            <a:avLst/>
+          </a:prstGeom>
+          <a:noFill xmlns:a="http://schemas.openxmlformats.org/drawingml/2006/main"/>
+          <a:ln xmlns:a="http://schemas.openxmlformats.org/drawingml/2006/main" w="0">
+            <a:noFill/>
+          </a:ln>
+        </p:spPr>
+        <p:txBody>
+          <a:bodyPr xmlns:a="http://schemas.openxmlformats.org/drawingml/2006/main" wrap="none" lIns="0" tIns="0" rIns="0" bIns="0" anchor="t">
+            <a:noAutofit/>
+          </a:bodyPr>
+          <a:lstStyle xmlns:a="http://schemas.openxmlformats.org/drawingml/2006/main"/>
+          <a:p xmlns:a="http://schemas.openxmlformats.org/drawingml/2006/main">
+            <a:pPr>
+              <a:buNone/>
+              <a:defRPr sz="1650" b="0">
+                <a:solidFill>
+                  <a:srgbClr val="A8C6C4"/>
+                </a:solidFill>
+                <a:latin typeface="Hiragino Sans GB"/>
+                <a:ea typeface="Hiragino Sans GB"/>
+                <a:cs typeface="Hiragino Sans GB"/>
+              </a:defRPr>
+            </a:pPr>
+            <a:r>
+              <a:rPr sz="1650" b="0">
+                <a:solidFill>
+                  <a:srgbClr val="A8C6C4"/>
+                </a:solidFill>
+                <a:latin typeface="Hiragino Sans GB"/>
+                <a:ea typeface="Hiragino Sans GB"/>
+                <a:cs typeface="Hiragino Sans GB"/>
+              </a:rPr>
+              <a:t>25</a:t>
+            </a:r>
+          </a:p>
+        </p:txBody>
+      </p:sp>
+      <p:sp>
+        <p:nvSpPr>
+          <p:cNvPr id="10" name="submission-2">
+            <a:extLst xmlns:a="http://schemas.openxmlformats.org/drawingml/2006/main">
+              <a:ext uri="{FF2B5EF4-FFF2-40B4-BE49-F238E27FC236}">
+                <a16:creationId xmlns:a16="http://schemas.microsoft.com/office/drawing/2014/main" id="{41E209A0-A5C8-459B-A580-C1C0B41A5C13}"/>
+              </a:ext>
+            </a:extLst>
+          </p:cNvPr>
+          <p:cNvSpPr>
+            <a:spLocks xmlns:a="http://schemas.openxmlformats.org/drawingml/2006/main" noGrp="1"/>
+          </p:cNvSpPr>
+          <p:nvPr/>
+        </p:nvSpPr>
+        <p:spPr>
+          <a:xfrm xmlns:a="http://schemas.openxmlformats.org/drawingml/2006/main">
+            <a:off x="876300" y="1809750"/>
+            <a:ext cx="13335000" cy="628650"/>
+          </a:xfrm>
+          <a:prstGeom xmlns:a="http://schemas.openxmlformats.org/drawingml/2006/main" prst="rect">
+            <a:avLst/>
+          </a:prstGeom>
+          <a:noFill xmlns:a="http://schemas.openxmlformats.org/drawingml/2006/main"/>
+          <a:ln xmlns:a="http://schemas.openxmlformats.org/drawingml/2006/main" w="0">
+            <a:noFill/>
+          </a:ln>
+        </p:spPr>
+        <p:txBody>
+          <a:bodyPr xmlns:a="http://schemas.openxmlformats.org/drawingml/2006/main" wrap="none">
+            <a:noAutofit/>
+          </a:bodyPr>
+          <a:lstStyle xmlns:a="http://schemas.openxmlformats.org/drawingml/2006/main"/>
+          <a:p xmlns:a="http://schemas.openxmlformats.org/drawingml/2006/main">
+            <a:pPr>
+              <a:defRPr sz="2550">
+                <a:solidFill>
+                  <a:srgbClr val="EAF1EF"/>
+                </a:solidFill>
+                <a:latin typeface="Hiragino Sans GB"/>
+                <a:ea typeface="Hiragino Sans GB"/>
+                <a:cs typeface="Hiragino Sans GB"/>
+              </a:defRPr>
+            </a:pPr>
+            <a:r>
+              <a:rPr sz="2550">
+                <a:solidFill>
+                  <a:srgbClr val="EAF1EF"/>
+                </a:solidFill>
+                <a:latin typeface="Hiragino Sans GB"/>
+                <a:ea typeface="Hiragino Sans GB"/>
+                <a:cs typeface="Hiragino Sans GB"/>
+              </a:rPr>
+              <a:t>Lab 1：上传 bits.c，填写文件内的本人姓名和学号</a:t>
+            </a:r>
+          </a:p>
+        </p:txBody>
+      </p:sp>
+      <p:sp>
+        <p:nvSpPr>
+          <p:cNvPr id="11" name="submission-3">
+            <a:extLst xmlns:a="http://schemas.openxmlformats.org/drawingml/2006/main">
+              <a:ext uri="{FF2B5EF4-FFF2-40B4-BE49-F238E27FC236}">
+                <a16:creationId xmlns:a16="http://schemas.microsoft.com/office/drawing/2014/main" id="{42A89DEE-DF42-4946-91BC-6D625230A111}"/>
+              </a:ext>
+            </a:extLst>
+          </p:cNvPr>
+          <p:cNvSpPr>
+            <a:spLocks xmlns:a="http://schemas.openxmlformats.org/drawingml/2006/main" noGrp="1"/>
+          </p:cNvSpPr>
+          <p:nvPr/>
+        </p:nvSpPr>
+        <p:spPr>
+          <a:xfrm xmlns:a="http://schemas.openxmlformats.org/drawingml/2006/main">
+            <a:off x="876300" y="2714625"/>
+            <a:ext cx="13335000" cy="628650"/>
+          </a:xfrm>
+          <a:prstGeom xmlns:a="http://schemas.openxmlformats.org/drawingml/2006/main" prst="rect">
+            <a:avLst/>
+          </a:prstGeom>
+          <a:noFill xmlns:a="http://schemas.openxmlformats.org/drawingml/2006/main"/>
+          <a:ln xmlns:a="http://schemas.openxmlformats.org/drawingml/2006/main" w="0">
+            <a:noFill/>
+          </a:ln>
+        </p:spPr>
+        <p:txBody>
+          <a:bodyPr xmlns:a="http://schemas.openxmlformats.org/drawingml/2006/main" wrap="none">
+            <a:noAutofit/>
+          </a:bodyPr>
+          <a:lstStyle xmlns:a="http://schemas.openxmlformats.org/drawingml/2006/main"/>
+          <a:p xmlns:a="http://schemas.openxmlformats.org/drawingml/2006/main">
+            <a:pPr>
+              <a:defRPr sz="2550">
+                <a:solidFill>
+                  <a:srgbClr val="EAF1EF"/>
+                </a:solidFill>
+                <a:latin typeface="Hiragino Sans GB"/>
+                <a:ea typeface="Hiragino Sans GB"/>
+                <a:cs typeface="Hiragino Sans GB"/>
+              </a:defRPr>
+            </a:pPr>
+            <a:r>
+              <a:rPr sz="2550">
+                <a:solidFill>
+                  <a:srgbClr val="EAF1EF"/>
+                </a:solidFill>
+                <a:latin typeface="Hiragino Sans GB"/>
+                <a:ea typeface="Hiragino Sans GB"/>
+                <a:cs typeface="Hiragino Sans GB"/>
+              </a:rPr>
+              <a:t>Lab 2：上传 mygemm.c，保留题目规定的函数接口</a:t>
+            </a:r>
+          </a:p>
+        </p:txBody>
+      </p:sp>
+      <p:sp>
+        <p:nvSpPr>
+          <p:cNvPr id="12" name="submission-4">
+            <a:extLst xmlns:a="http://schemas.openxmlformats.org/drawingml/2006/main">
+              <a:ext uri="{FF2B5EF4-FFF2-40B4-BE49-F238E27FC236}">
+                <a16:creationId xmlns:a16="http://schemas.microsoft.com/office/drawing/2014/main" id="{E1E99566-D968-43CD-BA1A-8F763AC2F373}"/>
+              </a:ext>
+            </a:extLst>
+          </p:cNvPr>
+          <p:cNvSpPr>
+            <a:spLocks xmlns:a="http://schemas.openxmlformats.org/drawingml/2006/main" noGrp="1"/>
+          </p:cNvSpPr>
+          <p:nvPr/>
+        </p:nvSpPr>
+        <p:spPr>
+          <a:xfrm xmlns:a="http://schemas.openxmlformats.org/drawingml/2006/main">
+            <a:off x="876300" y="3714750"/>
+            <a:ext cx="13335000" cy="628650"/>
+          </a:xfrm>
+          <a:prstGeom xmlns:a="http://schemas.openxmlformats.org/drawingml/2006/main" prst="rect">
+            <a:avLst/>
+          </a:prstGeom>
+          <a:noFill xmlns:a="http://schemas.openxmlformats.org/drawingml/2006/main"/>
+          <a:ln xmlns:a="http://schemas.openxmlformats.org/drawingml/2006/main" w="0">
+            <a:noFill/>
+          </a:ln>
+        </p:spPr>
+        <p:txBody>
+          <a:bodyPr xmlns:a="http://schemas.openxmlformats.org/drawingml/2006/main" wrap="none">
+            <a:noAutofit/>
+          </a:bodyPr>
+          <a:lstStyle xmlns:a="http://schemas.openxmlformats.org/drawingml/2006/main"/>
+          <a:p xmlns:a="http://schemas.openxmlformats.org/drawingml/2006/main">
+            <a:pPr>
+              <a:defRPr sz="2550">
+                <a:solidFill>
+                  <a:srgbClr val="EAF1EF"/>
+                </a:solidFill>
+                <a:latin typeface="Hiragino Sans GB"/>
+                <a:ea typeface="Hiragino Sans GB"/>
+                <a:cs typeface="Hiragino Sans GB"/>
+              </a:defRPr>
+            </a:pPr>
+            <a:r>
+              <a:rPr sz="2550">
+                <a:solidFill>
+                  <a:srgbClr val="EAF1EF"/>
+                </a:solidFill>
+                <a:latin typeface="Hiragino Sans GB"/>
+                <a:ea typeface="Hiragino Sans GB"/>
+                <a:cs typeface="Hiragino Sans GB"/>
+              </a:rPr>
+              <a:t>打开对应 Lab 的“源码提交”链接，填写学号与姓名</a:t>
+            </a:r>
+          </a:p>
+        </p:txBody>
+      </p:sp>
+      <p:sp>
+        <p:nvSpPr>
+          <p:cNvPr id="13" name="submission-5">
+            <a:extLst xmlns:a="http://schemas.openxmlformats.org/drawingml/2006/main">
+              <a:ext uri="{FF2B5EF4-FFF2-40B4-BE49-F238E27FC236}">
+                <a16:creationId xmlns:a16="http://schemas.microsoft.com/office/drawing/2014/main" id="{02CD9E1D-4D77-45B5-B8A9-FC906E6DF5FA}"/>
+              </a:ext>
+            </a:extLst>
+          </p:cNvPr>
+          <p:cNvSpPr>
+            <a:spLocks xmlns:a="http://schemas.openxmlformats.org/drawingml/2006/main" noGrp="1"/>
+          </p:cNvSpPr>
+          <p:nvPr/>
+        </p:nvSpPr>
+        <p:spPr>
+          <a:xfrm xmlns:a="http://schemas.openxmlformats.org/drawingml/2006/main">
+            <a:off x="876300" y="4619625"/>
+            <a:ext cx="13335000" cy="628650"/>
+          </a:xfrm>
+          <a:prstGeom xmlns:a="http://schemas.openxmlformats.org/drawingml/2006/main" prst="rect">
+            <a:avLst/>
+          </a:prstGeom>
+          <a:noFill xmlns:a="http://schemas.openxmlformats.org/drawingml/2006/main"/>
+          <a:ln xmlns:a="http://schemas.openxmlformats.org/drawingml/2006/main" w="0">
+            <a:noFill/>
+          </a:ln>
+        </p:spPr>
+        <p:txBody>
+          <a:bodyPr xmlns:a="http://schemas.openxmlformats.org/drawingml/2006/main" wrap="none">
+            <a:noAutofit/>
+          </a:bodyPr>
+          <a:lstStyle xmlns:a="http://schemas.openxmlformats.org/drawingml/2006/main"/>
+          <a:p xmlns:a="http://schemas.openxmlformats.org/drawingml/2006/main">
+            <a:pPr>
+              <a:defRPr sz="2550">
+                <a:solidFill>
+                  <a:srgbClr val="B7EDDB"/>
+                </a:solidFill>
+                <a:latin typeface="Menlo"/>
+                <a:ea typeface="Menlo"/>
+                <a:cs typeface="Menlo"/>
+              </a:defRPr>
+            </a:pPr>
+            <a:r>
+              <a:rPr sz="2550">
+                <a:solidFill>
+                  <a:srgbClr val="B7EDDB"/>
+                </a:solidFill>
+                <a:latin typeface="Menlo"/>
+                <a:ea typeface="Menlo"/>
+                <a:cs typeface="Menlo"/>
+              </a:rPr>
+              <a:t>云盘统一命名，例如：0001_示例甲.c</a:t>
+            </a:r>
+          </a:p>
+        </p:txBody>
+      </p:sp>
+      <p:sp>
+        <p:nvSpPr>
+          <p:cNvPr id="14" name="submission-6">
+            <a:extLst xmlns:a="http://schemas.openxmlformats.org/drawingml/2006/main">
+              <a:ext uri="{FF2B5EF4-FFF2-40B4-BE49-F238E27FC236}">
+                <a16:creationId xmlns:a16="http://schemas.microsoft.com/office/drawing/2014/main" id="{0978764D-C50E-4EA7-BA0D-3C592E25B790}"/>
+              </a:ext>
+            </a:extLst>
+          </p:cNvPr>
+          <p:cNvSpPr>
+            <a:spLocks xmlns:a="http://schemas.openxmlformats.org/drawingml/2006/main" noGrp="1"/>
+          </p:cNvSpPr>
+          <p:nvPr/>
+        </p:nvSpPr>
+        <p:spPr>
+          <a:xfrm xmlns:a="http://schemas.openxmlformats.org/drawingml/2006/main">
+            <a:off x="876300" y="5619750"/>
+            <a:ext cx="13335000" cy="628650"/>
+          </a:xfrm>
+          <a:prstGeom xmlns:a="http://schemas.openxmlformats.org/drawingml/2006/main" prst="rect">
+            <a:avLst/>
+          </a:prstGeom>
+          <a:noFill xmlns:a="http://schemas.openxmlformats.org/drawingml/2006/main"/>
+          <a:ln xmlns:a="http://schemas.openxmlformats.org/drawingml/2006/main" w="0">
+            <a:noFill/>
+          </a:ln>
+        </p:spPr>
+        <p:txBody>
+          <a:bodyPr xmlns:a="http://schemas.openxmlformats.org/drawingml/2006/main" wrap="none">
+            <a:noAutofit/>
+          </a:bodyPr>
+          <a:lstStyle xmlns:a="http://schemas.openxmlformats.org/drawingml/2006/main"/>
+          <a:p xmlns:a="http://schemas.openxmlformats.org/drawingml/2006/main">
+            <a:pPr>
+              <a:defRPr sz="2550">
+                <a:solidFill>
+                  <a:srgbClr val="EAF1EF"/>
+                </a:solidFill>
+                <a:latin typeface="Hiragino Sans GB"/>
+                <a:ea typeface="Hiragino Sans GB"/>
+                <a:cs typeface="Hiragino Sans GB"/>
+              </a:defRPr>
+            </a:pPr>
+            <a:r>
+              <a:rPr sz="2550">
+                <a:solidFill>
+                  <a:srgbClr val="EAF1EF"/>
+                </a:solidFill>
+                <a:latin typeface="Hiragino Sans GB"/>
+                <a:ea typeface="Hiragino Sans GB"/>
+                <a:cs typeface="Hiragino Sans GB"/>
+              </a:rPr>
+              <a:t>每个 Lab 分开提交，报告与实验日志按通知另交</a:t>
+            </a:r>
+          </a:p>
+        </p:txBody>
+      </p:sp>
+      <p:sp>
+        <p:nvSpPr>
+          <p:cNvPr id="15" name="submission-7">
+            <a:extLst xmlns:a="http://schemas.openxmlformats.org/drawingml/2006/main">
+              <a:ext uri="{FF2B5EF4-FFF2-40B4-BE49-F238E27FC236}">
+                <a16:creationId xmlns:a16="http://schemas.microsoft.com/office/drawing/2014/main" id="{8C150200-50A3-4E14-87D0-3B3369573731}"/>
+              </a:ext>
+            </a:extLst>
+          </p:cNvPr>
+          <p:cNvSpPr>
+            <a:spLocks xmlns:a="http://schemas.openxmlformats.org/drawingml/2006/main" noGrp="1"/>
+          </p:cNvSpPr>
+          <p:nvPr/>
+        </p:nvSpPr>
+        <p:spPr>
+          <a:xfrm xmlns:a="http://schemas.openxmlformats.org/drawingml/2006/main">
+            <a:off x="876300" y="7239000"/>
+            <a:ext cx="13335000" cy="628650"/>
+          </a:xfrm>
+          <a:prstGeom xmlns:a="http://schemas.openxmlformats.org/drawingml/2006/main" prst="rect">
+            <a:avLst/>
+          </a:prstGeom>
+          <a:noFill xmlns:a="http://schemas.openxmlformats.org/drawingml/2006/main"/>
+          <a:ln xmlns:a="http://schemas.openxmlformats.org/drawingml/2006/main" w="0">
+            <a:noFill/>
+          </a:ln>
+        </p:spPr>
+        <p:txBody>
+          <a:bodyPr xmlns:a="http://schemas.openxmlformats.org/drawingml/2006/main" wrap="none">
+            <a:noAutofit/>
+          </a:bodyPr>
+          <a:lstStyle xmlns:a="http://schemas.openxmlformats.org/drawingml/2006/main"/>
+          <a:p xmlns:a="http://schemas.openxmlformats.org/drawingml/2006/main">
+            <a:pPr>
+              <a:defRPr sz="2025">
+                <a:solidFill>
+                  <a:srgbClr val="A8C6C4"/>
+                </a:solidFill>
+                <a:latin typeface="Hiragino Sans GB"/>
+                <a:ea typeface="Hiragino Sans GB"/>
+                <a:cs typeface="Hiragino Sans GB"/>
+              </a:defRPr>
+            </a:pPr>
+            <a:r>
+              <a:rPr sz="2025">
+                <a:solidFill>
+                  <a:srgbClr val="A8C6C4"/>
+                </a:solidFill>
+                <a:latin typeface="Hiragino Sans GB"/>
+                <a:ea typeface="Hiragino Sans GB"/>
+                <a:cs typeface="Hiragino Sans GB"/>
+              </a:rPr>
+              <a:t>源码收集接受单个 .c。多文件实验采用教师指定的 ZIP 结构。</a:t>
+            </a:r>
+          </a:p>
+        </p:txBody>
+      </p:sp>
+    </p:spTree>
+    <p:extLst>
+      <p:ext uri="{BB962C8B-B14F-4D97-AF65-F5344CB8AC3E}">
+        <p14:creationId xmlns:p14="http://schemas.microsoft.com/office/powerpoint/2010/main" val="297403261"/>
+      </p:ext>
+    </p:extLst>
+  </p:cSld>
+</p:sld>
+</file>
+
+<file path=ppt/slides/slide26.xml><?xml version="1.0" encoding="utf-8"?>
+<p:sld xmlns:p="http://schemas.openxmlformats.org/presentationml/2006/main">
+  <p:cSld>
+    <p:bg>
+      <p:bgPr>
+        <a:solidFill xmlns:a="http://schemas.openxmlformats.org/drawingml/2006/main">
+          <a:srgbClr val="102C35"/>
+        </a:solidFill>
+      </p:bgPr>
+    </p:bg>
+    <p:spTree>
+      <p:nvGrpSpPr>
+        <p:cNvPr id="1" name=""/>
+        <p:cNvGrpSpPr/>
+        <p:nvPr/>
+      </p:nvGrpSpPr>
+      <p:grpSpPr>
+        <a:xfrm xmlns:a="http://schemas.openxmlformats.org/drawingml/2006/main"/>
+      </p:grpSpPr>
+      <p:sp>
+        <p:nvSpPr>
+          <p:cNvPr id="9" name="">
+            <a:extLst xmlns:a="http://schemas.openxmlformats.org/drawingml/2006/main">
+              <a:ext uri="{FF2B5EF4-FFF2-40B4-BE49-F238E27FC236}">
+                <a16:creationId xmlns:a16="http://schemas.microsoft.com/office/drawing/2014/main" id="{974B2865-DC00-4E59-9F3A-640A7913DC3C}"/>
+              </a:ext>
+            </a:extLst>
+          </p:cNvPr>
+          <p:cNvSpPr>
+            <a:spLocks xmlns:a="http://schemas.openxmlformats.org/drawingml/2006/main" noGrp="1"/>
+          </p:cNvSpPr>
+          <p:nvPr/>
+        </p:nvSpPr>
+        <p:spPr>
+          <a:xfrm xmlns:a="http://schemas.openxmlformats.org/drawingml/2006/main">
+            <a:off x="838200" y="628650"/>
+            <a:ext cx="13477875" cy="838200"/>
+          </a:xfrm>
+          <a:prstGeom xmlns:a="http://schemas.openxmlformats.org/drawingml/2006/main" prst="rect">
+            <a:avLst/>
+          </a:prstGeom>
+          <a:noFill xmlns:a="http://schemas.openxmlformats.org/drawingml/2006/main"/>
+          <a:ln xmlns:a="http://schemas.openxmlformats.org/drawingml/2006/main" w="0">
+            <a:noFill/>
+          </a:ln>
+        </p:spPr>
+        <p:txBody>
+          <a:bodyPr xmlns:a="http://schemas.openxmlformats.org/drawingml/2006/main" wrap="none" lIns="0" tIns="0" rIns="0" bIns="0" anchor="t">
+            <a:noAutofit/>
+          </a:bodyPr>
+          <a:lstStyle xmlns:a="http://schemas.openxmlformats.org/drawingml/2006/main"/>
+          <a:p xmlns:a="http://schemas.openxmlformats.org/drawingml/2006/main">
+            <a:pPr>
+              <a:buNone/>
+              <a:defRPr sz="3900" b="1">
+                <a:solidFill>
+                  <a:srgbClr val="EAF1EF"/>
+                </a:solidFill>
+                <a:latin typeface="Hiragino Sans GB"/>
+                <a:ea typeface="Hiragino Sans GB"/>
+                <a:cs typeface="Hiragino Sans GB"/>
+              </a:defRPr>
+            </a:pPr>
+            <a:r>
+              <a:rPr sz="3900" b="1">
+                <a:solidFill>
+                  <a:srgbClr val="EAF1EF"/>
+                </a:solidFill>
+                <a:latin typeface="Hiragino Sans GB"/>
+                <a:ea typeface="Hiragino Sans GB"/>
+                <a:cs typeface="Hiragino Sans GB"/>
+              </a:rPr>
+              <a:t>云盘上传与重新提交</a:t>
+            </a:r>
+          </a:p>
+        </p:txBody>
+      </p:sp>
+      <p:sp>
+        <p:nvSpPr>
+          <p:cNvPr id="2" name="">
+            <a:extLst xmlns:a="http://schemas.openxmlformats.org/drawingml/2006/main">
+              <a:ext uri="{FF2B5EF4-FFF2-40B4-BE49-F238E27FC236}">
+                <a16:creationId xmlns:a16="http://schemas.microsoft.com/office/drawing/2014/main" id="{AFA67C7E-1DCE-457B-9A22-9FD38D176CF9}"/>
+              </a:ext>
+            </a:extLst>
+          </p:cNvPr>
+          <p:cNvSpPr>
+            <a:spLocks xmlns:a="http://schemas.openxmlformats.org/drawingml/2006/main" noGrp="1"/>
+          </p:cNvSpPr>
+          <p:nvPr/>
+        </p:nvSpPr>
+        <p:spPr>
+          <a:xfrm xmlns:a="http://schemas.openxmlformats.org/drawingml/2006/main">
+            <a:off x="13906500" y="7972425"/>
+            <a:ext cx="514350" cy="323850"/>
+          </a:xfrm>
+          <a:prstGeom xmlns:a="http://schemas.openxmlformats.org/drawingml/2006/main" prst="rect">
+            <a:avLst/>
+          </a:prstGeom>
+          <a:noFill xmlns:a="http://schemas.openxmlformats.org/drawingml/2006/main"/>
+          <a:ln xmlns:a="http://schemas.openxmlformats.org/drawingml/2006/main" w="0">
+            <a:noFill/>
+          </a:ln>
+        </p:spPr>
+        <p:txBody>
+          <a:bodyPr xmlns:a="http://schemas.openxmlformats.org/drawingml/2006/main" wrap="none" lIns="0" tIns="0" rIns="0" bIns="0" anchor="t">
+            <a:noAutofit/>
+          </a:bodyPr>
+          <a:lstStyle xmlns:a="http://schemas.openxmlformats.org/drawingml/2006/main"/>
+          <a:p xmlns:a="http://schemas.openxmlformats.org/drawingml/2006/main">
+            <a:pPr>
+              <a:buNone/>
+              <a:defRPr sz="1650" b="0">
+                <a:solidFill>
+                  <a:srgbClr val="A8C6C4"/>
+                </a:solidFill>
+                <a:latin typeface="Hiragino Sans GB"/>
+                <a:ea typeface="Hiragino Sans GB"/>
+                <a:cs typeface="Hiragino Sans GB"/>
+              </a:defRPr>
+            </a:pPr>
+            <a:r>
+              <a:rPr sz="1650" b="0">
+                <a:solidFill>
+                  <a:srgbClr val="A8C6C4"/>
+                </a:solidFill>
+                <a:latin typeface="Hiragino Sans GB"/>
+                <a:ea typeface="Hiragino Sans GB"/>
+                <a:cs typeface="Hiragino Sans GB"/>
+              </a:rPr>
+              <a:t>26</a:t>
+            </a:r>
+          </a:p>
+        </p:txBody>
+      </p:sp>
+      <p:sp>
+        <p:nvSpPr>
+          <p:cNvPr id="10" name="submission-2">
+            <a:extLst xmlns:a="http://schemas.openxmlformats.org/drawingml/2006/main">
+              <a:ext uri="{FF2B5EF4-FFF2-40B4-BE49-F238E27FC236}">
+                <a16:creationId xmlns:a16="http://schemas.microsoft.com/office/drawing/2014/main" id="{2032E798-D2F7-4C74-9308-C65AC98A17E2}"/>
+              </a:ext>
+            </a:extLst>
+          </p:cNvPr>
+          <p:cNvSpPr>
+            <a:spLocks xmlns:a="http://schemas.openxmlformats.org/drawingml/2006/main" noGrp="1"/>
+          </p:cNvSpPr>
+          <p:nvPr/>
+        </p:nvSpPr>
+        <p:spPr>
+          <a:xfrm xmlns:a="http://schemas.openxmlformats.org/drawingml/2006/main">
+            <a:off x="876300" y="1762125"/>
+            <a:ext cx="13335000" cy="762000"/>
+          </a:xfrm>
+          <a:prstGeom xmlns:a="http://schemas.openxmlformats.org/drawingml/2006/main" prst="rect">
+            <a:avLst/>
+          </a:prstGeom>
+          <a:noFill xmlns:a="http://schemas.openxmlformats.org/drawingml/2006/main"/>
+          <a:ln xmlns:a="http://schemas.openxmlformats.org/drawingml/2006/main" w="0">
+            <a:noFill/>
+          </a:ln>
+        </p:spPr>
+        <p:txBody>
+          <a:bodyPr xmlns:a="http://schemas.openxmlformats.org/drawingml/2006/main" wrap="none">
+            <a:noAutofit/>
+          </a:bodyPr>
+          <a:lstStyle xmlns:a="http://schemas.openxmlformats.org/drawingml/2006/main"/>
+          <a:p xmlns:a="http://schemas.openxmlformats.org/drawingml/2006/main">
+            <a:pPr>
+              <a:defRPr sz="2475">
+                <a:solidFill>
+                  <a:srgbClr val="EAF1EF"/>
+                </a:solidFill>
+                <a:latin typeface="Hiragino Sans GB"/>
+                <a:ea typeface="Hiragino Sans GB"/>
+                <a:cs typeface="Hiragino Sans GB"/>
+              </a:defRPr>
+            </a:pPr>
+            <a:r>
+              <a:rPr sz="2475">
+                <a:solidFill>
+                  <a:srgbClr val="EAF1EF"/>
+                </a:solidFill>
+                <a:latin typeface="Hiragino Sans GB"/>
+                <a:ea typeface="Hiragino Sans GB"/>
+                <a:cs typeface="Hiragino Sans GB"/>
+              </a:rPr>
+              <a:t>1  打开教师发布的当前 Lab 源码收集链接并登录</a:t>
+            </a:r>
+          </a:p>
+        </p:txBody>
+      </p:sp>
+      <p:sp>
+        <p:nvSpPr>
+          <p:cNvPr id="11" name="submission-3">
+            <a:extLst xmlns:a="http://schemas.openxmlformats.org/drawingml/2006/main">
+              <a:ext uri="{FF2B5EF4-FFF2-40B4-BE49-F238E27FC236}">
+                <a16:creationId xmlns:a16="http://schemas.microsoft.com/office/drawing/2014/main" id="{31A9C603-AD76-4A02-87FC-D87FC3C0C036}"/>
+              </a:ext>
+            </a:extLst>
+          </p:cNvPr>
+          <p:cNvSpPr>
+            <a:spLocks xmlns:a="http://schemas.openxmlformats.org/drawingml/2006/main" noGrp="1"/>
+          </p:cNvSpPr>
+          <p:nvPr/>
+        </p:nvSpPr>
+        <p:spPr>
+          <a:xfrm xmlns:a="http://schemas.openxmlformats.org/drawingml/2006/main">
+            <a:off x="876300" y="2771775"/>
+            <a:ext cx="13335000" cy="762000"/>
+          </a:xfrm>
+          <a:prstGeom xmlns:a="http://schemas.openxmlformats.org/drawingml/2006/main" prst="rect">
+            <a:avLst/>
+          </a:prstGeom>
+          <a:noFill xmlns:a="http://schemas.openxmlformats.org/drawingml/2006/main"/>
+          <a:ln xmlns:a="http://schemas.openxmlformats.org/drawingml/2006/main" w="0">
+            <a:noFill/>
+          </a:ln>
+        </p:spPr>
+        <p:txBody>
+          <a:bodyPr xmlns:a="http://schemas.openxmlformats.org/drawingml/2006/main" wrap="none">
+            <a:noAutofit/>
+          </a:bodyPr>
+          <a:lstStyle xmlns:a="http://schemas.openxmlformats.org/drawingml/2006/main"/>
+          <a:p xmlns:a="http://schemas.openxmlformats.org/drawingml/2006/main">
+            <a:pPr>
+              <a:defRPr sz="2475">
+                <a:solidFill>
+                  <a:srgbClr val="EAF1EF"/>
+                </a:solidFill>
+                <a:latin typeface="Hiragino Sans GB"/>
+                <a:ea typeface="Hiragino Sans GB"/>
+                <a:cs typeface="Hiragino Sans GB"/>
+              </a:defRPr>
+            </a:pPr>
+            <a:r>
+              <a:rPr sz="2475">
+                <a:solidFill>
+                  <a:srgbClr val="EAF1EF"/>
+                </a:solidFill>
+                <a:latin typeface="Hiragino Sans GB"/>
+                <a:ea typeface="Hiragino Sans GB"/>
+                <a:cs typeface="Hiragino Sans GB"/>
+              </a:rPr>
+              <a:t>2  填写本人学号、姓名，选择已经自测的本地源码</a:t>
+            </a:r>
+          </a:p>
+        </p:txBody>
+      </p:sp>
+      <p:sp>
+        <p:nvSpPr>
+          <p:cNvPr id="12" name="submission-4">
+            <a:extLst xmlns:a="http://schemas.openxmlformats.org/drawingml/2006/main">
+              <a:ext uri="{FF2B5EF4-FFF2-40B4-BE49-F238E27FC236}">
+                <a16:creationId xmlns:a16="http://schemas.microsoft.com/office/drawing/2014/main" id="{D026A457-5399-46C6-AB70-BE38F322AEBB}"/>
+              </a:ext>
+            </a:extLst>
+          </p:cNvPr>
+          <p:cNvSpPr>
+            <a:spLocks xmlns:a="http://schemas.openxmlformats.org/drawingml/2006/main" noGrp="1"/>
+          </p:cNvSpPr>
+          <p:nvPr/>
+        </p:nvSpPr>
+        <p:spPr>
+          <a:xfrm xmlns:a="http://schemas.openxmlformats.org/drawingml/2006/main">
+            <a:off x="876300" y="3781425"/>
+            <a:ext cx="13335000" cy="762000"/>
+          </a:xfrm>
+          <a:prstGeom xmlns:a="http://schemas.openxmlformats.org/drawingml/2006/main" prst="rect">
+            <a:avLst/>
+          </a:prstGeom>
+          <a:noFill xmlns:a="http://schemas.openxmlformats.org/drawingml/2006/main"/>
+          <a:ln xmlns:a="http://schemas.openxmlformats.org/drawingml/2006/main" w="0">
+            <a:noFill/>
+          </a:ln>
+        </p:spPr>
+        <p:txBody>
+          <a:bodyPr xmlns:a="http://schemas.openxmlformats.org/drawingml/2006/main" wrap="none">
+            <a:noAutofit/>
+          </a:bodyPr>
+          <a:lstStyle xmlns:a="http://schemas.openxmlformats.org/drawingml/2006/main"/>
+          <a:p xmlns:a="http://schemas.openxmlformats.org/drawingml/2006/main">
+            <a:pPr>
+              <a:defRPr sz="2475">
+                <a:solidFill>
+                  <a:srgbClr val="EAF1EF"/>
+                </a:solidFill>
+                <a:latin typeface="Hiragino Sans GB"/>
+                <a:ea typeface="Hiragino Sans GB"/>
+                <a:cs typeface="Hiragino Sans GB"/>
+              </a:defRPr>
+            </a:pPr>
+            <a:r>
+              <a:rPr sz="2475">
+                <a:solidFill>
+                  <a:srgbClr val="EAF1EF"/>
+                </a:solidFill>
+                <a:latin typeface="Hiragino Sans GB"/>
+                <a:ea typeface="Hiragino Sans GB"/>
+                <a:cs typeface="Hiragino Sans GB"/>
+              </a:rPr>
+              <a:t>3  点击提交，等待上传完成，检查自己的提交记录</a:t>
+            </a:r>
+          </a:p>
+        </p:txBody>
+      </p:sp>
+      <p:sp>
+        <p:nvSpPr>
+          <p:cNvPr id="13" name="submission-5">
+            <a:extLst xmlns:a="http://schemas.openxmlformats.org/drawingml/2006/main">
+              <a:ext uri="{FF2B5EF4-FFF2-40B4-BE49-F238E27FC236}">
+                <a16:creationId xmlns:a16="http://schemas.microsoft.com/office/drawing/2014/main" id="{61637B50-329A-428C-ACBD-395C69E1AE6C}"/>
+              </a:ext>
+            </a:extLst>
+          </p:cNvPr>
+          <p:cNvSpPr>
+            <a:spLocks xmlns:a="http://schemas.openxmlformats.org/drawingml/2006/main" noGrp="1"/>
+          </p:cNvSpPr>
+          <p:nvPr/>
+        </p:nvSpPr>
+        <p:spPr>
+          <a:xfrm xmlns:a="http://schemas.openxmlformats.org/drawingml/2006/main">
+            <a:off x="876300" y="4791075"/>
+            <a:ext cx="13335000" cy="762000"/>
+          </a:xfrm>
+          <a:prstGeom xmlns:a="http://schemas.openxmlformats.org/drawingml/2006/main" prst="rect">
+            <a:avLst/>
+          </a:prstGeom>
+          <a:noFill xmlns:a="http://schemas.openxmlformats.org/drawingml/2006/main"/>
+          <a:ln xmlns:a="http://schemas.openxmlformats.org/drawingml/2006/main" w="0">
+            <a:noFill/>
+          </a:ln>
+        </p:spPr>
+        <p:txBody>
+          <a:bodyPr xmlns:a="http://schemas.openxmlformats.org/drawingml/2006/main" wrap="none">
+            <a:noAutofit/>
+          </a:bodyPr>
+          <a:lstStyle xmlns:a="http://schemas.openxmlformats.org/drawingml/2006/main"/>
+          <a:p xmlns:a="http://schemas.openxmlformats.org/drawingml/2006/main">
+            <a:pPr>
+              <a:defRPr sz="2475">
+                <a:solidFill>
+                  <a:srgbClr val="EAF1EF"/>
+                </a:solidFill>
+                <a:latin typeface="Hiragino Sans GB"/>
+                <a:ea typeface="Hiragino Sans GB"/>
+                <a:cs typeface="Hiragino Sans GB"/>
+              </a:defRPr>
+            </a:pPr>
+            <a:r>
+              <a:rPr sz="2475">
+                <a:solidFill>
+                  <a:srgbClr val="EAF1EF"/>
+                </a:solidFill>
+                <a:latin typeface="Hiragino Sans GB"/>
+                <a:ea typeface="Hiragino Sans GB"/>
+                <a:cs typeface="Hiragino Sans GB"/>
+              </a:rPr>
+              <a:t>4  修改后在相同入口重新上传，选择替换旧文件</a:t>
+            </a:r>
+          </a:p>
+        </p:txBody>
+      </p:sp>
+      <p:sp>
+        <p:nvSpPr>
+          <p:cNvPr id="14" name="submission-6">
+            <a:extLst xmlns:a="http://schemas.openxmlformats.org/drawingml/2006/main">
+              <a:ext uri="{FF2B5EF4-FFF2-40B4-BE49-F238E27FC236}">
+                <a16:creationId xmlns:a16="http://schemas.microsoft.com/office/drawing/2014/main" id="{96B86450-0F7F-4011-99AE-E91A433ED414}"/>
+              </a:ext>
+            </a:extLst>
+          </p:cNvPr>
+          <p:cNvSpPr>
+            <a:spLocks xmlns:a="http://schemas.openxmlformats.org/drawingml/2006/main" noGrp="1"/>
+          </p:cNvSpPr>
+          <p:nvPr/>
+        </p:nvSpPr>
+        <p:spPr>
+          <a:xfrm xmlns:a="http://schemas.openxmlformats.org/drawingml/2006/main">
+            <a:off x="876300" y="5800725"/>
+            <a:ext cx="13335000" cy="762000"/>
+          </a:xfrm>
+          <a:prstGeom xmlns:a="http://schemas.openxmlformats.org/drawingml/2006/main" prst="rect">
+            <a:avLst/>
+          </a:prstGeom>
+          <a:noFill xmlns:a="http://schemas.openxmlformats.org/drawingml/2006/main"/>
+          <a:ln xmlns:a="http://schemas.openxmlformats.org/drawingml/2006/main" w="0">
+            <a:noFill/>
+          </a:ln>
+        </p:spPr>
+        <p:txBody>
+          <a:bodyPr xmlns:a="http://schemas.openxmlformats.org/drawingml/2006/main" wrap="none">
+            <a:noAutofit/>
+          </a:bodyPr>
+          <a:lstStyle xmlns:a="http://schemas.openxmlformats.org/drawingml/2006/main"/>
+          <a:p xmlns:a="http://schemas.openxmlformats.org/drawingml/2006/main">
+            <a:pPr>
+              <a:defRPr sz="2475">
+                <a:solidFill>
+                  <a:srgbClr val="EAF1EF"/>
+                </a:solidFill>
+                <a:latin typeface="Hiragino Sans GB"/>
+                <a:ea typeface="Hiragino Sans GB"/>
+                <a:cs typeface="Hiragino Sans GB"/>
+              </a:defRPr>
+            </a:pPr>
+            <a:r>
+              <a:rPr sz="2475">
+                <a:solidFill>
+                  <a:srgbClr val="EAF1EF"/>
+                </a:solidFill>
+                <a:latin typeface="Hiragino Sans GB"/>
+                <a:ea typeface="Hiragino Sans GB"/>
+                <a:cs typeface="Hiragino Sans GB"/>
+              </a:rPr>
+              <a:t>5  在截止前确认最终版本，保留本地源码和提交记录</a:t>
+            </a:r>
+          </a:p>
+        </p:txBody>
+      </p:sp>
+      <p:sp>
+        <p:nvSpPr>
+          <p:cNvPr id="15" name="submission-7">
+            <a:extLst xmlns:a="http://schemas.openxmlformats.org/drawingml/2006/main">
+              <a:ext uri="{FF2B5EF4-FFF2-40B4-BE49-F238E27FC236}">
+                <a16:creationId xmlns:a16="http://schemas.microsoft.com/office/drawing/2014/main" id="{B755FA88-6259-4A2D-BBAC-0E03A668EEF3}"/>
+              </a:ext>
+            </a:extLst>
+          </p:cNvPr>
+          <p:cNvSpPr>
+            <a:spLocks xmlns:a="http://schemas.openxmlformats.org/drawingml/2006/main" noGrp="1"/>
+          </p:cNvSpPr>
+          <p:nvPr/>
+        </p:nvSpPr>
+        <p:spPr>
+          <a:xfrm xmlns:a="http://schemas.openxmlformats.org/drawingml/2006/main">
+            <a:off x="876300" y="7239000"/>
+            <a:ext cx="13335000" cy="628650"/>
+          </a:xfrm>
+          <a:prstGeom xmlns:a="http://schemas.openxmlformats.org/drawingml/2006/main" prst="rect">
+            <a:avLst/>
+          </a:prstGeom>
+          <a:noFill xmlns:a="http://schemas.openxmlformats.org/drawingml/2006/main"/>
+          <a:ln xmlns:a="http://schemas.openxmlformats.org/drawingml/2006/main" w="0">
+            <a:noFill/>
+          </a:ln>
+        </p:spPr>
+        <p:txBody>
+          <a:bodyPr xmlns:a="http://schemas.openxmlformats.org/drawingml/2006/main" wrap="none">
+            <a:noAutofit/>
+          </a:bodyPr>
+          <a:lstStyle xmlns:a="http://schemas.openxmlformats.org/drawingml/2006/main"/>
+          <a:p xmlns:a="http://schemas.openxmlformats.org/drawingml/2006/main">
+            <a:pPr>
+              <a:defRPr sz="2025">
+                <a:solidFill>
+                  <a:srgbClr val="A8C6C4"/>
+                </a:solidFill>
+                <a:latin typeface="Hiragino Sans GB"/>
+                <a:ea typeface="Hiragino Sans GB"/>
+                <a:cs typeface="Hiragino Sans GB"/>
+              </a:defRPr>
+            </a:pPr>
+            <a:r>
+              <a:rPr sz="2025">
+                <a:solidFill>
+                  <a:srgbClr val="A8C6C4"/>
+                </a:solidFill>
+                <a:latin typeface="Hiragino Sans GB"/>
+                <a:ea typeface="Hiragino Sans GB"/>
+                <a:cs typeface="Hiragino Sans GB"/>
+              </a:rPr>
+              <a:t>云盘上传负责交件。正确性测试需自行运行，助教下载后统一评分。</a:t>
+            </a:r>
+          </a:p>
+        </p:txBody>
+      </p:sp>
+    </p:spTree>
+    <p:extLst>
+      <p:ext uri="{BB962C8B-B14F-4D97-AF65-F5344CB8AC3E}">
+        <p14:creationId xmlns:p14="http://schemas.microsoft.com/office/powerpoint/2010/main" val="297403261"/>
+      </p:ext>
+    </p:extLst>
+  </p:cSld>
+</p:sld>
+</file>
+
+<file path=ppt/slides/slide27.xml><?xml version="1.0" encoding="utf-8"?>
+<p:sld xmlns:p="http://schemas.openxmlformats.org/presentationml/2006/main">
+  <p:cSld>
+    <p:bg>
+      <p:bgPr>
+        <a:solidFill xmlns:a="http://schemas.openxmlformats.org/drawingml/2006/main">
+          <a:srgbClr val="102C35"/>
+        </a:solidFill>
+      </p:bgPr>
+    </p:bg>
+    <p:spTree>
+      <p:nvGrpSpPr>
+        <p:cNvPr id="1" name=""/>
+        <p:cNvGrpSpPr/>
+        <p:nvPr/>
+      </p:nvGrpSpPr>
+      <p:grpSpPr>
+        <a:xfrm xmlns:a="http://schemas.openxmlformats.org/drawingml/2006/main"/>
+      </p:grpSpPr>
+      <p:sp>
+        <p:nvSpPr>
+          <p:cNvPr id="9" name="">
+            <a:extLst xmlns:a="http://schemas.openxmlformats.org/drawingml/2006/main">
+              <a:ext uri="{FF2B5EF4-FFF2-40B4-BE49-F238E27FC236}">
+                <a16:creationId xmlns:a16="http://schemas.microsoft.com/office/drawing/2014/main" id="{974B2865-DC00-4E59-9F3A-640A7913DC3C}"/>
+              </a:ext>
+            </a:extLst>
+          </p:cNvPr>
+          <p:cNvSpPr>
+            <a:spLocks xmlns:a="http://schemas.openxmlformats.org/drawingml/2006/main" noGrp="1"/>
+          </p:cNvSpPr>
+          <p:nvPr/>
+        </p:nvSpPr>
+        <p:spPr>
+          <a:xfrm xmlns:a="http://schemas.openxmlformats.org/drawingml/2006/main">
+            <a:off x="838200" y="628650"/>
+            <a:ext cx="13477875" cy="838200"/>
+          </a:xfrm>
+          <a:prstGeom xmlns:a="http://schemas.openxmlformats.org/drawingml/2006/main" prst="rect">
+            <a:avLst/>
+          </a:prstGeom>
+          <a:noFill xmlns:a="http://schemas.openxmlformats.org/drawingml/2006/main"/>
+          <a:ln xmlns:a="http://schemas.openxmlformats.org/drawingml/2006/main" w="0">
+            <a:noFill/>
+          </a:ln>
+        </p:spPr>
+        <p:txBody>
+          <a:bodyPr xmlns:a="http://schemas.openxmlformats.org/drawingml/2006/main" wrap="none" lIns="0" tIns="0" rIns="0" bIns="0" anchor="t">
+            <a:noAutofit/>
+          </a:bodyPr>
+          <a:lstStyle xmlns:a="http://schemas.openxmlformats.org/drawingml/2006/main"/>
+          <a:p xmlns:a="http://schemas.openxmlformats.org/drawingml/2006/main">
+            <a:pPr>
+              <a:buNone/>
+              <a:defRPr sz="3900" b="1">
+                <a:solidFill>
+                  <a:srgbClr val="EAF1EF"/>
+                </a:solidFill>
+                <a:latin typeface="Hiragino Sans GB"/>
+                <a:ea typeface="Hiragino Sans GB"/>
+                <a:cs typeface="Hiragino Sans GB"/>
+              </a:defRPr>
+            </a:pPr>
+            <a:r>
+              <a:rPr sz="3900" b="1">
+                <a:solidFill>
+                  <a:srgbClr val="EAF1EF"/>
+                </a:solidFill>
+                <a:latin typeface="Hiragino Sans GB"/>
+                <a:ea typeface="Hiragino Sans GB"/>
+                <a:cs typeface="Hiragino Sans GB"/>
+              </a:rPr>
+              <a:t>正确性反馈与复查</a:t>
+            </a:r>
+          </a:p>
+        </p:txBody>
+      </p:sp>
+      <p:sp>
+        <p:nvSpPr>
+          <p:cNvPr id="2" name="">
+            <a:extLst xmlns:a="http://schemas.openxmlformats.org/drawingml/2006/main">
+              <a:ext uri="{FF2B5EF4-FFF2-40B4-BE49-F238E27FC236}">
+                <a16:creationId xmlns:a16="http://schemas.microsoft.com/office/drawing/2014/main" id="{AFA67C7E-1DCE-457B-9A22-9FD38D176CF9}"/>
+              </a:ext>
+            </a:extLst>
+          </p:cNvPr>
+          <p:cNvSpPr>
+            <a:spLocks xmlns:a="http://schemas.openxmlformats.org/drawingml/2006/main" noGrp="1"/>
+          </p:cNvSpPr>
+          <p:nvPr/>
+        </p:nvSpPr>
+        <p:spPr>
+          <a:xfrm xmlns:a="http://schemas.openxmlformats.org/drawingml/2006/main">
+            <a:off x="13906500" y="7972425"/>
+            <a:ext cx="514350" cy="323850"/>
+          </a:xfrm>
+          <a:prstGeom xmlns:a="http://schemas.openxmlformats.org/drawingml/2006/main" prst="rect">
+            <a:avLst/>
+          </a:prstGeom>
+          <a:noFill xmlns:a="http://schemas.openxmlformats.org/drawingml/2006/main"/>
+          <a:ln xmlns:a="http://schemas.openxmlformats.org/drawingml/2006/main" w="0">
+            <a:noFill/>
+          </a:ln>
+        </p:spPr>
+        <p:txBody>
+          <a:bodyPr xmlns:a="http://schemas.openxmlformats.org/drawingml/2006/main" wrap="none" lIns="0" tIns="0" rIns="0" bIns="0" anchor="t">
+            <a:noAutofit/>
+          </a:bodyPr>
+          <a:lstStyle xmlns:a="http://schemas.openxmlformats.org/drawingml/2006/main"/>
+          <a:p xmlns:a="http://schemas.openxmlformats.org/drawingml/2006/main">
+            <a:pPr>
+              <a:buNone/>
+              <a:defRPr sz="1650" b="0">
+                <a:solidFill>
+                  <a:srgbClr val="A8C6C4"/>
+                </a:solidFill>
+                <a:latin typeface="Hiragino Sans GB"/>
+                <a:ea typeface="Hiragino Sans GB"/>
+                <a:cs typeface="Hiragino Sans GB"/>
+              </a:defRPr>
+            </a:pPr>
+            <a:r>
+              <a:rPr sz="1650" b="0">
+                <a:solidFill>
+                  <a:srgbClr val="A8C6C4"/>
+                </a:solidFill>
+                <a:latin typeface="Hiragino Sans GB"/>
+                <a:ea typeface="Hiragino Sans GB"/>
+                <a:cs typeface="Hiragino Sans GB"/>
+              </a:rPr>
+              <a:t>27</a:t>
+            </a:r>
+          </a:p>
+        </p:txBody>
+      </p:sp>
+      <p:sp>
+        <p:nvSpPr>
+          <p:cNvPr id="10" name="submission-2">
+            <a:extLst xmlns:a="http://schemas.openxmlformats.org/drawingml/2006/main">
+              <a:ext uri="{FF2B5EF4-FFF2-40B4-BE49-F238E27FC236}">
+                <a16:creationId xmlns:a16="http://schemas.microsoft.com/office/drawing/2014/main" id="{833FCE93-5FE9-41C8-A0C1-74D06587435A}"/>
+              </a:ext>
+            </a:extLst>
+          </p:cNvPr>
+          <p:cNvSpPr>
+            <a:spLocks xmlns:a="http://schemas.openxmlformats.org/drawingml/2006/main" noGrp="1"/>
+          </p:cNvSpPr>
+          <p:nvPr/>
+        </p:nvSpPr>
+        <p:spPr>
+          <a:xfrm xmlns:a="http://schemas.openxmlformats.org/drawingml/2006/main">
+            <a:off x="876300" y="1714500"/>
+            <a:ext cx="13335000" cy="628650"/>
+          </a:xfrm>
+          <a:prstGeom xmlns:a="http://schemas.openxmlformats.org/drawingml/2006/main" prst="rect">
+            <a:avLst/>
+          </a:prstGeom>
+          <a:noFill xmlns:a="http://schemas.openxmlformats.org/drawingml/2006/main"/>
+          <a:ln xmlns:a="http://schemas.openxmlformats.org/drawingml/2006/main" w="0">
+            <a:noFill/>
+          </a:ln>
+        </p:spPr>
+        <p:txBody>
+          <a:bodyPr xmlns:a="http://schemas.openxmlformats.org/drawingml/2006/main" wrap="none">
+            <a:noAutofit/>
+          </a:bodyPr>
+          <a:lstStyle xmlns:a="http://schemas.openxmlformats.org/drawingml/2006/main"/>
+          <a:p xmlns:a="http://schemas.openxmlformats.org/drawingml/2006/main">
+            <a:pPr>
+              <a:defRPr sz="2550">
+                <a:solidFill>
+                  <a:srgbClr val="EAF1EF"/>
+                </a:solidFill>
+                <a:latin typeface="Hiragino Sans GB"/>
+                <a:ea typeface="Hiragino Sans GB"/>
+                <a:cs typeface="Hiragino Sans GB"/>
+              </a:defRPr>
+            </a:pPr>
+            <a:r>
+              <a:rPr sz="2550">
+                <a:solidFill>
+                  <a:srgbClr val="EAF1EF"/>
+                </a:solidFill>
+                <a:latin typeface="Hiragino Sans GB"/>
+                <a:ea typeface="Hiragino Sans GB"/>
+                <a:cs typeface="Hiragino Sans GB"/>
+              </a:rPr>
+              <a:t>助教使用收到的源码重新编译，按函数检查正确性</a:t>
+            </a:r>
+          </a:p>
+        </p:txBody>
+      </p:sp>
+      <p:sp>
+        <p:nvSpPr>
+          <p:cNvPr id="11" name="submission-3">
+            <a:extLst xmlns:a="http://schemas.openxmlformats.org/drawingml/2006/main">
+              <a:ext uri="{FF2B5EF4-FFF2-40B4-BE49-F238E27FC236}">
+                <a16:creationId xmlns:a16="http://schemas.microsoft.com/office/drawing/2014/main" id="{2DDED857-57DC-40FB-85E2-29ECEF81237E}"/>
+              </a:ext>
+            </a:extLst>
+          </p:cNvPr>
+          <p:cNvSpPr>
+            <a:spLocks xmlns:a="http://schemas.openxmlformats.org/drawingml/2006/main" noGrp="1"/>
+          </p:cNvSpPr>
+          <p:nvPr/>
+        </p:nvSpPr>
+        <p:spPr>
+          <a:xfrm xmlns:a="http://schemas.openxmlformats.org/drawingml/2006/main">
+            <a:off x="876300" y="2762250"/>
+            <a:ext cx="13335000" cy="628650"/>
+          </a:xfrm>
+          <a:prstGeom xmlns:a="http://schemas.openxmlformats.org/drawingml/2006/main" prst="rect">
+            <a:avLst/>
+          </a:prstGeom>
+          <a:noFill xmlns:a="http://schemas.openxmlformats.org/drawingml/2006/main"/>
+          <a:ln xmlns:a="http://schemas.openxmlformats.org/drawingml/2006/main" w="0">
+            <a:noFill/>
+          </a:ln>
+        </p:spPr>
+        <p:txBody>
+          <a:bodyPr xmlns:a="http://schemas.openxmlformats.org/drawingml/2006/main" wrap="none">
+            <a:noAutofit/>
+          </a:bodyPr>
+          <a:lstStyle xmlns:a="http://schemas.openxmlformats.org/drawingml/2006/main"/>
+          <a:p xmlns:a="http://schemas.openxmlformats.org/drawingml/2006/main">
+            <a:pPr>
+              <a:defRPr sz="2400">
+                <a:solidFill>
+                  <a:srgbClr val="EAF1EF"/>
+                </a:solidFill>
+                <a:latin typeface="Hiragino Sans GB"/>
+                <a:ea typeface="Hiragino Sans GB"/>
+                <a:cs typeface="Hiragino Sans GB"/>
+              </a:defRPr>
+            </a:pPr>
+            <a:r>
+              <a:rPr sz="2400">
+                <a:solidFill>
+                  <a:srgbClr val="EAF1EF"/>
+                </a:solidFill>
+                <a:latin typeface="Hiragino Sans GB"/>
+                <a:ea typeface="Hiragino Sans GB"/>
+                <a:cs typeface="Hiragino Sans GB"/>
+              </a:rPr>
+              <a:t>编译失败：查看编译日志，检查语法、文件与函数接口</a:t>
+            </a:r>
+          </a:p>
+        </p:txBody>
+      </p:sp>
+      <p:sp>
+        <p:nvSpPr>
+          <p:cNvPr id="12" name="submission-4">
+            <a:extLst xmlns:a="http://schemas.openxmlformats.org/drawingml/2006/main">
+              <a:ext uri="{FF2B5EF4-FFF2-40B4-BE49-F238E27FC236}">
+                <a16:creationId xmlns:a16="http://schemas.microsoft.com/office/drawing/2014/main" id="{48F8858D-3042-4842-A11C-E8F68F86BA2F}"/>
+              </a:ext>
+            </a:extLst>
+          </p:cNvPr>
+          <p:cNvSpPr>
+            <a:spLocks xmlns:a="http://schemas.openxmlformats.org/drawingml/2006/main" noGrp="1"/>
+          </p:cNvSpPr>
+          <p:nvPr/>
+        </p:nvSpPr>
+        <p:spPr>
+          <a:xfrm xmlns:a="http://schemas.openxmlformats.org/drawingml/2006/main">
+            <a:off x="876300" y="3714750"/>
+            <a:ext cx="13335000" cy="628650"/>
+          </a:xfrm>
+          <a:prstGeom xmlns:a="http://schemas.openxmlformats.org/drawingml/2006/main" prst="rect">
+            <a:avLst/>
+          </a:prstGeom>
+          <a:noFill xmlns:a="http://schemas.openxmlformats.org/drawingml/2006/main"/>
+          <a:ln xmlns:a="http://schemas.openxmlformats.org/drawingml/2006/main" w="0">
+            <a:noFill/>
+          </a:ln>
+        </p:spPr>
+        <p:txBody>
+          <a:bodyPr xmlns:a="http://schemas.openxmlformats.org/drawingml/2006/main" wrap="none">
+            <a:noAutofit/>
+          </a:bodyPr>
+          <a:lstStyle xmlns:a="http://schemas.openxmlformats.org/drawingml/2006/main"/>
+          <a:p xmlns:a="http://schemas.openxmlformats.org/drawingml/2006/main">
+            <a:pPr>
+              <a:defRPr sz="2400">
+                <a:solidFill>
+                  <a:srgbClr val="EAF1EF"/>
+                </a:solidFill>
+                <a:latin typeface="Hiragino Sans GB"/>
+                <a:ea typeface="Hiragino Sans GB"/>
+                <a:cs typeface="Hiragino Sans GB"/>
+              </a:defRPr>
+            </a:pPr>
+            <a:r>
+              <a:rPr sz="2400">
+                <a:solidFill>
+                  <a:srgbClr val="EAF1EF"/>
+                </a:solidFill>
+                <a:latin typeface="Hiragino Sans GB"/>
+                <a:ea typeface="Hiragino Sans GB"/>
+                <a:cs typeface="Hiragino Sans GB"/>
+              </a:rPr>
+              <a:t>结果错误：根据失败函数与输入定位问题，再运行公开测试</a:t>
+            </a:r>
+          </a:p>
+        </p:txBody>
+      </p:sp>
+      <p:sp>
+        <p:nvSpPr>
+          <p:cNvPr id="13" name="submission-5">
+            <a:extLst xmlns:a="http://schemas.openxmlformats.org/drawingml/2006/main">
+              <a:ext uri="{FF2B5EF4-FFF2-40B4-BE49-F238E27FC236}">
+                <a16:creationId xmlns:a16="http://schemas.microsoft.com/office/drawing/2014/main" id="{ABFB9E32-64CB-4327-B2E8-23CE2C5F79C2}"/>
+              </a:ext>
+            </a:extLst>
+          </p:cNvPr>
+          <p:cNvSpPr>
+            <a:spLocks xmlns:a="http://schemas.openxmlformats.org/drawingml/2006/main" noGrp="1"/>
+          </p:cNvSpPr>
+          <p:nvPr/>
+        </p:nvSpPr>
+        <p:spPr>
+          <a:xfrm xmlns:a="http://schemas.openxmlformats.org/drawingml/2006/main">
+            <a:off x="876300" y="4667250"/>
+            <a:ext cx="13335000" cy="628650"/>
+          </a:xfrm>
+          <a:prstGeom xmlns:a="http://schemas.openxmlformats.org/drawingml/2006/main" prst="rect">
+            <a:avLst/>
+          </a:prstGeom>
+          <a:noFill xmlns:a="http://schemas.openxmlformats.org/drawingml/2006/main"/>
+          <a:ln xmlns:a="http://schemas.openxmlformats.org/drawingml/2006/main" w="0">
+            <a:noFill/>
+          </a:ln>
+        </p:spPr>
+        <p:txBody>
+          <a:bodyPr xmlns:a="http://schemas.openxmlformats.org/drawingml/2006/main" wrap="none">
+            <a:noAutofit/>
+          </a:bodyPr>
+          <a:lstStyle xmlns:a="http://schemas.openxmlformats.org/drawingml/2006/main"/>
+          <a:p xmlns:a="http://schemas.openxmlformats.org/drawingml/2006/main">
+            <a:pPr>
+              <a:defRPr sz="2400">
+                <a:solidFill>
+                  <a:srgbClr val="EAF1EF"/>
+                </a:solidFill>
+                <a:latin typeface="Hiragino Sans GB"/>
+                <a:ea typeface="Hiragino Sans GB"/>
+                <a:cs typeface="Hiragino Sans GB"/>
+              </a:defRPr>
+            </a:pPr>
+            <a:r>
+              <a:rPr sz="2400">
+                <a:solidFill>
+                  <a:srgbClr val="EAF1EF"/>
+                </a:solidFill>
+                <a:latin typeface="Hiragino Sans GB"/>
+                <a:ea typeface="Hiragino Sans GB"/>
+                <a:cs typeface="Hiragino Sans GB"/>
+              </a:rPr>
+              <a:t>超时或崩溃：检查循环是否结束、数组访问是否越界</a:t>
+            </a:r>
+          </a:p>
+        </p:txBody>
+      </p:sp>
+      <p:sp>
+        <p:nvSpPr>
+          <p:cNvPr id="14" name="submission-6">
+            <a:extLst xmlns:a="http://schemas.openxmlformats.org/drawingml/2006/main">
+              <a:ext uri="{FF2B5EF4-FFF2-40B4-BE49-F238E27FC236}">
+                <a16:creationId xmlns:a16="http://schemas.microsoft.com/office/drawing/2014/main" id="{8F701B04-393D-4877-AD07-5BA31F2F4232}"/>
+              </a:ext>
+            </a:extLst>
+          </p:cNvPr>
+          <p:cNvSpPr>
+            <a:spLocks xmlns:a="http://schemas.openxmlformats.org/drawingml/2006/main" noGrp="1"/>
+          </p:cNvSpPr>
+          <p:nvPr/>
+        </p:nvSpPr>
+        <p:spPr>
+          <a:xfrm xmlns:a="http://schemas.openxmlformats.org/drawingml/2006/main">
+            <a:off x="876300" y="5619750"/>
+            <a:ext cx="13335000" cy="628650"/>
+          </a:xfrm>
+          <a:prstGeom xmlns:a="http://schemas.openxmlformats.org/drawingml/2006/main" prst="rect">
+            <a:avLst/>
+          </a:prstGeom>
+          <a:noFill xmlns:a="http://schemas.openxmlformats.org/drawingml/2006/main"/>
+          <a:ln xmlns:a="http://schemas.openxmlformats.org/drawingml/2006/main" w="0">
+            <a:noFill/>
+          </a:ln>
+        </p:spPr>
+        <p:txBody>
+          <a:bodyPr xmlns:a="http://schemas.openxmlformats.org/drawingml/2006/main" wrap="none">
+            <a:noAutofit/>
+          </a:bodyPr>
+          <a:lstStyle xmlns:a="http://schemas.openxmlformats.org/drawingml/2006/main"/>
+          <a:p xmlns:a="http://schemas.openxmlformats.org/drawingml/2006/main">
+            <a:pPr>
+              <a:defRPr sz="2400">
+                <a:solidFill>
+                  <a:srgbClr val="EAF1EF"/>
+                </a:solidFill>
+                <a:latin typeface="Hiragino Sans GB"/>
+                <a:ea typeface="Hiragino Sans GB"/>
+                <a:cs typeface="Hiragino Sans GB"/>
+              </a:defRPr>
+            </a:pPr>
+            <a:r>
+              <a:rPr sz="2400">
+                <a:solidFill>
+                  <a:srgbClr val="EAF1EF"/>
+                </a:solidFill>
+                <a:latin typeface="Hiragino Sans GB"/>
+                <a:ea typeface="Hiragino Sans GB"/>
+                <a:cs typeface="Hiragino Sans GB"/>
+              </a:rPr>
+              <a:t>缺交、重复或身份不符：先核对云盘提交记录并联系助教</a:t>
+            </a:r>
+          </a:p>
+        </p:txBody>
+      </p:sp>
+      <p:sp>
+        <p:nvSpPr>
+          <p:cNvPr id="15" name="submission-7">
+            <a:extLst xmlns:a="http://schemas.openxmlformats.org/drawingml/2006/main">
+              <a:ext uri="{FF2B5EF4-FFF2-40B4-BE49-F238E27FC236}">
+                <a16:creationId xmlns:a16="http://schemas.microsoft.com/office/drawing/2014/main" id="{7D688176-BFF1-4371-9B7C-B494D97E85B6}"/>
+              </a:ext>
+            </a:extLst>
+          </p:cNvPr>
+          <p:cNvSpPr>
+            <a:spLocks xmlns:a="http://schemas.openxmlformats.org/drawingml/2006/main" noGrp="1"/>
+          </p:cNvSpPr>
+          <p:nvPr/>
+        </p:nvSpPr>
+        <p:spPr>
+          <a:xfrm xmlns:a="http://schemas.openxmlformats.org/drawingml/2006/main">
+            <a:off x="876300" y="7239000"/>
+            <a:ext cx="13335000" cy="628650"/>
+          </a:xfrm>
+          <a:prstGeom xmlns:a="http://schemas.openxmlformats.org/drawingml/2006/main" prst="rect">
+            <a:avLst/>
+          </a:prstGeom>
+          <a:noFill xmlns:a="http://schemas.openxmlformats.org/drawingml/2006/main"/>
+          <a:ln xmlns:a="http://schemas.openxmlformats.org/drawingml/2006/main" w="0">
+            <a:noFill/>
+          </a:ln>
+        </p:spPr>
+        <p:txBody>
+          <a:bodyPr xmlns:a="http://schemas.openxmlformats.org/drawingml/2006/main" wrap="none">
+            <a:noAutofit/>
+          </a:bodyPr>
+          <a:lstStyle xmlns:a="http://schemas.openxmlformats.org/drawingml/2006/main"/>
+          <a:p xmlns:a="http://schemas.openxmlformats.org/drawingml/2006/main">
+            <a:pPr>
+              <a:defRPr sz="2025">
+                <a:solidFill>
+                  <a:srgbClr val="A8C6C4"/>
+                </a:solidFill>
+                <a:latin typeface="Hiragino Sans GB"/>
+                <a:ea typeface="Hiragino Sans GB"/>
+                <a:cs typeface="Hiragino Sans GB"/>
+              </a:defRPr>
+            </a:pPr>
+            <a:r>
+              <a:rPr sz="2025">
+                <a:solidFill>
+                  <a:srgbClr val="A8C6C4"/>
+                </a:solidFill>
+                <a:latin typeface="Hiragino Sans GB"/>
+                <a:ea typeface="Hiragino Sans GB"/>
+                <a:cs typeface="Hiragino Sans GB"/>
+              </a:rPr>
+              <a:t>自动分数只计算正确性。编码规则另行检查，复查使用已归档的源码。</a:t>
+            </a:r>
+          </a:p>
+        </p:txBody>
+      </p:sp>
+    </p:spTree>
+    <p:extLst>
+      <p:ext uri="{BB962C8B-B14F-4D97-AF65-F5344CB8AC3E}">
+        <p14:creationId xmlns:p14="http://schemas.microsoft.com/office/powerpoint/2010/main" val="297403261"/>
+      </p:ext>
+    </p:extLst>
+  </p:cSld>
+</p:sld>
+</file>
+
+<file path=ppt/slides/slide28.xml><?xml version="1.0" encoding="utf-8"?>
 <p:sld xmlns:p="http://schemas.openxmlformats.org/presentationml/2006/main">
   <p:cSld>
     <p:bg>
@@ -14382,7 +16064,7 @@
                 <a:ea typeface="Hiragino Sans GB"/>
                 <a:cs typeface="Hiragino Sans GB"/>
               </a:rPr>
-              <a:t>25</a:t>
+              <a:t>28</a:t>
             </a:r>
           </a:p>
         </p:txBody>
@@ -14958,7 +16640,7 @@
 </p:sld>
 </file>
 
-<file path=ppt/slides/slide26.xml><?xml version="1.0" encoding="utf-8"?>
+<file path=ppt/slides/slide29.xml><?xml version="1.0" encoding="utf-8"?>
 <p:sld xmlns:p="http://schemas.openxmlformats.org/presentationml/2006/main">
   <p:cSld>
     <p:bg>
@@ -15088,7 +16770,7 @@
                 <a:ea typeface="Hiragino Sans GB"/>
                 <a:cs typeface="Hiragino Sans GB"/>
               </a:rPr>
-              <a:t>26</a:t>
+              <a:t>29</a:t>
             </a:r>
           </a:p>
         </p:txBody>
@@ -15228,7 +16910,7 @@
                 <a:ea typeface="Hiragino Sans GB"/>
                 <a:cs typeface="Hiragino Sans GB"/>
               </a:rPr>
-              <a:t>2. 申请计算节点，编译并检查两个 Lab</a:t>
+              <a:t>2. 申请计算节点，编译并检查当前 Lab</a:t>
             </a:r>
           </a:p>
           <a:p xmlns:a="http://schemas.openxmlformats.org/drawingml/2006/main">
@@ -15252,7 +16934,7 @@
                 <a:ea typeface="Hiragino Sans GB"/>
                 <a:cs typeface="Hiragino Sans GB"/>
               </a:rPr>
-              <a:t>3. 提交批处理作业，下载日志和最终源码</a:t>
+              <a:t>3. 下载已经保存并测试的最终源码</a:t>
             </a:r>
           </a:p>
           <a:p xmlns:a="http://schemas.openxmlformats.org/drawingml/2006/main">
@@ -15276,7 +16958,7 @@
                 <a:ea typeface="Hiragino Sans GB"/>
                 <a:cs typeface="Hiragino Sans GB"/>
               </a:rPr>
-              <a:t>4. 整理作业包，上传云盘并重新下载核对</a:t>
+              <a:t>4. 上传对应的云盘源码任务，核对提交记录</a:t>
             </a:r>
           </a:p>
         </p:txBody>
@@ -15391,7 +17073,7 @@
                 <a:latin typeface="Hiragino Sans GB"/>
                 <a:ea typeface="Hiragino Sans GB"/>
                 <a:cs typeface="Hiragino Sans GB"/>
-                <a:hlinkClick xmlns:r="http://schemas.openxmlformats.org/officeDocument/2006/relationships" r:id="Raffda06f91e348a9"/>
+                <a:hlinkClick xmlns:r="http://schemas.openxmlformats.org/officeDocument/2006/relationships" r:id="Rad89e489e6ca4f4c"/>
               </a:rPr>
               <a:t>登录与账号</a:t>
             </a:r>
@@ -15450,7 +17132,7 @@
                 <a:latin typeface="Hiragino Sans GB"/>
                 <a:ea typeface="Hiragino Sans GB"/>
                 <a:cs typeface="Hiragino Sans GB"/>
-                <a:hlinkClick xmlns:r="http://schemas.openxmlformats.org/officeDocument/2006/relationships" r:id="R93e3a0889a814e3a"/>
+                <a:hlinkClick xmlns:r="http://schemas.openxmlformats.org/officeDocument/2006/relationships" r:id="R841043cfe6b94dcc"/>
               </a:rPr>
               <a:t>Slurm 作业管理</a:t>
             </a:r>
@@ -15509,7 +17191,7 @@
                 <a:latin typeface="Hiragino Sans GB"/>
                 <a:ea typeface="Hiragino Sans GB"/>
                 <a:cs typeface="Hiragino Sans GB"/>
-                <a:hlinkClick xmlns:r="http://schemas.openxmlformats.org/officeDocument/2006/relationships" r:id="R5e723d233c024b1a"/>
+                <a:hlinkClick xmlns:r="http://schemas.openxmlformats.org/officeDocument/2006/relationships" r:id="R232b39c2ca6e462b"/>
               </a:rPr>
               <a:t>文件传输</a:t>
             </a:r>
@@ -18479,6 +20161,7 @@
           <a:lstStyle xmlns:a="http://schemas.openxmlformats.org/drawingml/2006/main"/>
           <a:p xmlns:a="http://schemas.openxmlformats.org/drawingml/2006/main">
             <a:pPr>
+              <a:buNone/>
               <a:defRPr sz="2325">
                 <a:solidFill>
                   <a:srgbClr val="EAF1EF"/>
@@ -18536,6 +20219,7 @@
           <a:lstStyle xmlns:a="http://schemas.openxmlformats.org/drawingml/2006/main"/>
           <a:p xmlns:a="http://schemas.openxmlformats.org/drawingml/2006/main">
             <a:pPr>
+              <a:buNone/>
               <a:defRPr sz="2325">
                 <a:solidFill>
                   <a:srgbClr val="EAF1EF"/>
@@ -18593,6 +20277,7 @@
           <a:lstStyle xmlns:a="http://schemas.openxmlformats.org/drawingml/2006/main"/>
           <a:p xmlns:a="http://schemas.openxmlformats.org/drawingml/2006/main">
             <a:pPr>
+              <a:buNone/>
               <a:defRPr sz="2250">
                 <a:solidFill>
                   <a:srgbClr val="B7EDDB"/>
@@ -18650,6 +20335,7 @@
           <a:lstStyle xmlns:a="http://schemas.openxmlformats.org/drawingml/2006/main"/>
           <a:p xmlns:a="http://schemas.openxmlformats.org/drawingml/2006/main">
             <a:pPr>
+              <a:buNone/>
               <a:defRPr sz="2250">
                 <a:solidFill>
                   <a:srgbClr val="B7EDDB"/>
@@ -18707,6 +20393,7 @@
           <a:lstStyle xmlns:a="http://schemas.openxmlformats.org/drawingml/2006/main"/>
           <a:p xmlns:a="http://schemas.openxmlformats.org/drawingml/2006/main">
             <a:pPr>
+              <a:buNone/>
               <a:defRPr sz="2250">
                 <a:solidFill>
                   <a:srgbClr val="B7EDDB"/>
@@ -18764,6 +20451,7 @@
           <a:lstStyle xmlns:a="http://schemas.openxmlformats.org/drawingml/2006/main"/>
           <a:p xmlns:a="http://schemas.openxmlformats.org/drawingml/2006/main">
             <a:pPr>
+              <a:buNone/>
               <a:defRPr sz="2250">
                 <a:solidFill>
                   <a:srgbClr val="B7EDDB"/>
@@ -18821,6 +20509,7 @@
           <a:lstStyle xmlns:a="http://schemas.openxmlformats.org/drawingml/2006/main"/>
           <a:p xmlns:a="http://schemas.openxmlformats.org/drawingml/2006/main">
             <a:pPr>
+              <a:buNone/>
               <a:defRPr sz="2250">
                 <a:solidFill>
                   <a:srgbClr val="B7EDDB"/>
@@ -18878,6 +20567,7 @@
           <a:lstStyle xmlns:a="http://schemas.openxmlformats.org/drawingml/2006/main"/>
           <a:p xmlns:a="http://schemas.openxmlformats.org/drawingml/2006/main">
             <a:pPr>
+              <a:buNone/>
               <a:defRPr sz="2325">
                 <a:solidFill>
                   <a:srgbClr val="EAF1EF"/>
@@ -18935,6 +20625,7 @@
           <a:lstStyle xmlns:a="http://schemas.openxmlformats.org/drawingml/2006/main"/>
           <a:p xmlns:a="http://schemas.openxmlformats.org/drawingml/2006/main">
             <a:pPr>
+              <a:buNone/>
               <a:defRPr sz="1875">
                 <a:solidFill>
                   <a:srgbClr val="A8C6C4"/>
@@ -19137,6 +20828,7 @@
           <a:lstStyle xmlns:a="http://schemas.openxmlformats.org/drawingml/2006/main"/>
           <a:p xmlns:a="http://schemas.openxmlformats.org/drawingml/2006/main">
             <a:pPr>
+              <a:buNone/>
               <a:defRPr sz="2325">
                 <a:solidFill>
                   <a:srgbClr val="EAF1EF"/>
@@ -19194,6 +20886,7 @@
           <a:lstStyle xmlns:a="http://schemas.openxmlformats.org/drawingml/2006/main"/>
           <a:p xmlns:a="http://schemas.openxmlformats.org/drawingml/2006/main">
             <a:pPr>
+              <a:buNone/>
               <a:defRPr sz="2250">
                 <a:solidFill>
                   <a:srgbClr val="B7EDDB"/>
@@ -19251,6 +20944,7 @@
           <a:lstStyle xmlns:a="http://schemas.openxmlformats.org/drawingml/2006/main"/>
           <a:p xmlns:a="http://schemas.openxmlformats.org/drawingml/2006/main">
             <a:pPr>
+              <a:buNone/>
               <a:defRPr sz="2250">
                 <a:solidFill>
                   <a:srgbClr val="B7EDDB"/>
@@ -19308,6 +21002,7 @@
           <a:lstStyle xmlns:a="http://schemas.openxmlformats.org/drawingml/2006/main"/>
           <a:p xmlns:a="http://schemas.openxmlformats.org/drawingml/2006/main">
             <a:pPr>
+              <a:buNone/>
               <a:defRPr sz="2250">
                 <a:solidFill>
                   <a:srgbClr val="B7EDDB"/>
@@ -19365,6 +21060,7 @@
           <a:lstStyle xmlns:a="http://schemas.openxmlformats.org/drawingml/2006/main"/>
           <a:p xmlns:a="http://schemas.openxmlformats.org/drawingml/2006/main">
             <a:pPr>
+              <a:buNone/>
               <a:defRPr sz="2250">
                 <a:solidFill>
                   <a:srgbClr val="B7EDDB"/>
@@ -19422,6 +21118,7 @@
           <a:lstStyle xmlns:a="http://schemas.openxmlformats.org/drawingml/2006/main"/>
           <a:p xmlns:a="http://schemas.openxmlformats.org/drawingml/2006/main">
             <a:pPr>
+              <a:buNone/>
               <a:defRPr sz="2325">
                 <a:solidFill>
                   <a:srgbClr val="EAF1EF"/>
@@ -19479,6 +21176,7 @@
           <a:lstStyle xmlns:a="http://schemas.openxmlformats.org/drawingml/2006/main"/>
           <a:p xmlns:a="http://schemas.openxmlformats.org/drawingml/2006/main">
             <a:pPr>
+              <a:buNone/>
               <a:defRPr sz="1875">
                 <a:solidFill>
                   <a:srgbClr val="A8C6C4"/>
@@ -19681,6 +21379,7 @@
           <a:lstStyle xmlns:a="http://schemas.openxmlformats.org/drawingml/2006/main"/>
           <a:p xmlns:a="http://schemas.openxmlformats.org/drawingml/2006/main">
             <a:pPr>
+              <a:buNone/>
               <a:defRPr sz="2400">
                 <a:solidFill>
                   <a:srgbClr val="EAF1EF"/>
@@ -19738,6 +21437,7 @@
           <a:lstStyle xmlns:a="http://schemas.openxmlformats.org/drawingml/2006/main"/>
           <a:p xmlns:a="http://schemas.openxmlformats.org/drawingml/2006/main">
             <a:pPr>
+              <a:buNone/>
               <a:defRPr sz="2325">
                 <a:solidFill>
                   <a:srgbClr val="EAF1EF"/>
@@ -19795,6 +21495,7 @@
           <a:lstStyle xmlns:a="http://schemas.openxmlformats.org/drawingml/2006/main"/>
           <a:p xmlns:a="http://schemas.openxmlformats.org/drawingml/2006/main">
             <a:pPr>
+              <a:buNone/>
               <a:defRPr sz="2400">
                 <a:solidFill>
                   <a:srgbClr val="B7EDDB"/>
@@ -19852,6 +21553,7 @@
           <a:lstStyle xmlns:a="http://schemas.openxmlformats.org/drawingml/2006/main"/>
           <a:p xmlns:a="http://schemas.openxmlformats.org/drawingml/2006/main">
             <a:pPr>
+              <a:buNone/>
               <a:defRPr sz="2400">
                 <a:solidFill>
                   <a:srgbClr val="B7EDDB"/>
@@ -19909,6 +21611,7 @@
           <a:lstStyle xmlns:a="http://schemas.openxmlformats.org/drawingml/2006/main"/>
           <a:p xmlns:a="http://schemas.openxmlformats.org/drawingml/2006/main">
             <a:pPr>
+              <a:buNone/>
               <a:defRPr sz="2400">
                 <a:solidFill>
                   <a:srgbClr val="B7EDDB"/>
@@ -19966,6 +21669,7 @@
           <a:lstStyle xmlns:a="http://schemas.openxmlformats.org/drawingml/2006/main"/>
           <a:p xmlns:a="http://schemas.openxmlformats.org/drawingml/2006/main">
             <a:pPr>
+              <a:buNone/>
               <a:defRPr sz="2325">
                 <a:solidFill>
                   <a:srgbClr val="EAF1EF"/>
@@ -20023,6 +21727,7 @@
           <a:lstStyle xmlns:a="http://schemas.openxmlformats.org/drawingml/2006/main"/>
           <a:p xmlns:a="http://schemas.openxmlformats.org/drawingml/2006/main">
             <a:pPr>
+              <a:buNone/>
               <a:defRPr sz="2250">
                 <a:solidFill>
                   <a:srgbClr val="EAF1EF"/>
@@ -20080,6 +21785,7 @@
           <a:lstStyle xmlns:a="http://schemas.openxmlformats.org/drawingml/2006/main"/>
           <a:p xmlns:a="http://schemas.openxmlformats.org/drawingml/2006/main">
             <a:pPr>
+              <a:buNone/>
               <a:defRPr sz="1875">
                 <a:solidFill>
                   <a:srgbClr val="A8C6C4"/>

</xml_diff>

<commit_message>
Fix tutorial command prerequisites and platform steps
</commit_message>
<xml_diff>
--- a/docs/交我算平台Lab运行指南-学生版.pptx
+++ b/docs/交我算平台Lab运行指南-学生版.pptx
@@ -2,41 +2,41 @@
 <file path=ppt/presentation.xml><?xml version="1.0" encoding="utf-8"?>
 <p:presentation xmlns:p="http://schemas.openxmlformats.org/presentationml/2006/main">
   <p:sldMasterIdLst>
-    <p:sldMasterId xmlns:r="http://schemas.openxmlformats.org/officeDocument/2006/relationships" id="2147483648" r:id="R8e8b2b72a4e4427a"/>
+    <p:sldMasterId xmlns:r="http://schemas.openxmlformats.org/officeDocument/2006/relationships" id="2147483648" r:id="Rcd447baf31eb4ec3"/>
   </p:sldMasterIdLst>
   <p:notesMasterIdLst>
-    <p:notesMasterId xmlns:r="http://schemas.openxmlformats.org/officeDocument/2006/relationships" r:id="R4a1295cde87746a5"/>
+    <p:notesMasterId xmlns:r="http://schemas.openxmlformats.org/officeDocument/2006/relationships" r:id="Rb87a0392fb964659"/>
   </p:notesMasterIdLst>
   <p:sldIdLst>
-    <p:sldId xmlns:r="http://schemas.openxmlformats.org/officeDocument/2006/relationships" id="256" r:id="R7fee738532d746e1"/>
-    <p:sldId xmlns:r="http://schemas.openxmlformats.org/officeDocument/2006/relationships" id="257" r:id="R697a093346934758"/>
-    <p:sldId xmlns:r="http://schemas.openxmlformats.org/officeDocument/2006/relationships" id="258" r:id="R978f60e158e34e1a"/>
-    <p:sldId xmlns:r="http://schemas.openxmlformats.org/officeDocument/2006/relationships" id="259" r:id="Ree067b619d48410e"/>
-    <p:sldId xmlns:r="http://schemas.openxmlformats.org/officeDocument/2006/relationships" id="260" r:id="R769425df93e04fa6"/>
-    <p:sldId xmlns:r="http://schemas.openxmlformats.org/officeDocument/2006/relationships" id="261" r:id="R0f4db516a1f64eef"/>
-    <p:sldId xmlns:r="http://schemas.openxmlformats.org/officeDocument/2006/relationships" id="262" r:id="Rc0b1a19997fb4dfc"/>
-    <p:sldId xmlns:r="http://schemas.openxmlformats.org/officeDocument/2006/relationships" id="263" r:id="Raa213ea74d02432a"/>
-    <p:sldId xmlns:r="http://schemas.openxmlformats.org/officeDocument/2006/relationships" id="264" r:id="R198c39ae379a4152"/>
-    <p:sldId xmlns:r="http://schemas.openxmlformats.org/officeDocument/2006/relationships" id="265" r:id="R492a68928f7f4161"/>
-    <p:sldId xmlns:r="http://schemas.openxmlformats.org/officeDocument/2006/relationships" id="266" r:id="R1134c625252940b1"/>
-    <p:sldId xmlns:r="http://schemas.openxmlformats.org/officeDocument/2006/relationships" id="267" r:id="Rc7620d0c8c124863"/>
-    <p:sldId xmlns:r="http://schemas.openxmlformats.org/officeDocument/2006/relationships" id="268" r:id="R8c4ab4dd80364d87"/>
-    <p:sldId xmlns:r="http://schemas.openxmlformats.org/officeDocument/2006/relationships" id="269" r:id="Re7c70e650fe24c03"/>
-    <p:sldId xmlns:r="http://schemas.openxmlformats.org/officeDocument/2006/relationships" id="270" r:id="Rb478e241d3a44a81"/>
-    <p:sldId xmlns:r="http://schemas.openxmlformats.org/officeDocument/2006/relationships" id="271" r:id="R6108d92f0ac046f9"/>
-    <p:sldId xmlns:r="http://schemas.openxmlformats.org/officeDocument/2006/relationships" id="272" r:id="Rfee98f6ffe5843cb"/>
-    <p:sldId xmlns:r="http://schemas.openxmlformats.org/officeDocument/2006/relationships" id="273" r:id="R1425fda4eb404fbb"/>
-    <p:sldId xmlns:r="http://schemas.openxmlformats.org/officeDocument/2006/relationships" id="274" r:id="R627b1938d9334a24"/>
-    <p:sldId xmlns:r="http://schemas.openxmlformats.org/officeDocument/2006/relationships" id="275" r:id="R135c7721aa964f9b"/>
-    <p:sldId xmlns:r="http://schemas.openxmlformats.org/officeDocument/2006/relationships" id="276" r:id="R3fe350374cad449a"/>
-    <p:sldId xmlns:r="http://schemas.openxmlformats.org/officeDocument/2006/relationships" id="277" r:id="R731551d6f50f4a0e"/>
-    <p:sldId xmlns:r="http://schemas.openxmlformats.org/officeDocument/2006/relationships" id="278" r:id="R47ae73d605bd44d6"/>
-    <p:sldId xmlns:r="http://schemas.openxmlformats.org/officeDocument/2006/relationships" id="279" r:id="R825a2d3fb6d24de5"/>
-    <p:sldId xmlns:r="http://schemas.openxmlformats.org/officeDocument/2006/relationships" id="280" r:id="Re6256507a12f422a"/>
-    <p:sldId xmlns:r="http://schemas.openxmlformats.org/officeDocument/2006/relationships" id="281" r:id="R8af782a649704f12"/>
-    <p:sldId xmlns:r="http://schemas.openxmlformats.org/officeDocument/2006/relationships" id="282" r:id="Rb69d1f6484a2470b"/>
-    <p:sldId xmlns:r="http://schemas.openxmlformats.org/officeDocument/2006/relationships" id="283" r:id="Ra41586e90b134f66"/>
-    <p:sldId xmlns:r="http://schemas.openxmlformats.org/officeDocument/2006/relationships" id="284" r:id="R30d346fe10364253"/>
+    <p:sldId xmlns:r="http://schemas.openxmlformats.org/officeDocument/2006/relationships" id="256" r:id="Rceef44d9b35c40d4"/>
+    <p:sldId xmlns:r="http://schemas.openxmlformats.org/officeDocument/2006/relationships" id="257" r:id="R81cc83877b61473d"/>
+    <p:sldId xmlns:r="http://schemas.openxmlformats.org/officeDocument/2006/relationships" id="258" r:id="R02eb1f8d294341ff"/>
+    <p:sldId xmlns:r="http://schemas.openxmlformats.org/officeDocument/2006/relationships" id="259" r:id="R5c40457137ee487b"/>
+    <p:sldId xmlns:r="http://schemas.openxmlformats.org/officeDocument/2006/relationships" id="260" r:id="Rdae68cedb146413b"/>
+    <p:sldId xmlns:r="http://schemas.openxmlformats.org/officeDocument/2006/relationships" id="261" r:id="Rb1d1f198c00b4f6d"/>
+    <p:sldId xmlns:r="http://schemas.openxmlformats.org/officeDocument/2006/relationships" id="262" r:id="Rffd71c5590104c3a"/>
+    <p:sldId xmlns:r="http://schemas.openxmlformats.org/officeDocument/2006/relationships" id="263" r:id="R8b0cb4fa3fe940e0"/>
+    <p:sldId xmlns:r="http://schemas.openxmlformats.org/officeDocument/2006/relationships" id="264" r:id="R0f5c04ea19c14b11"/>
+    <p:sldId xmlns:r="http://schemas.openxmlformats.org/officeDocument/2006/relationships" id="265" r:id="R7152c27092494639"/>
+    <p:sldId xmlns:r="http://schemas.openxmlformats.org/officeDocument/2006/relationships" id="266" r:id="R9c185575ed4d4807"/>
+    <p:sldId xmlns:r="http://schemas.openxmlformats.org/officeDocument/2006/relationships" id="267" r:id="R94aabbb4f9e944a2"/>
+    <p:sldId xmlns:r="http://schemas.openxmlformats.org/officeDocument/2006/relationships" id="268" r:id="R2b847ff9507a4f93"/>
+    <p:sldId xmlns:r="http://schemas.openxmlformats.org/officeDocument/2006/relationships" id="269" r:id="R54633310f3a84a26"/>
+    <p:sldId xmlns:r="http://schemas.openxmlformats.org/officeDocument/2006/relationships" id="270" r:id="R3b7a2960af004c2d"/>
+    <p:sldId xmlns:r="http://schemas.openxmlformats.org/officeDocument/2006/relationships" id="271" r:id="Rc64e4aae331b411f"/>
+    <p:sldId xmlns:r="http://schemas.openxmlformats.org/officeDocument/2006/relationships" id="272" r:id="R6349eaeffc1047df"/>
+    <p:sldId xmlns:r="http://schemas.openxmlformats.org/officeDocument/2006/relationships" id="273" r:id="R8f8cda8f3bfb4e74"/>
+    <p:sldId xmlns:r="http://schemas.openxmlformats.org/officeDocument/2006/relationships" id="274" r:id="R54583e3fc4a84ab1"/>
+    <p:sldId xmlns:r="http://schemas.openxmlformats.org/officeDocument/2006/relationships" id="275" r:id="R178a47f32ffd4a09"/>
+    <p:sldId xmlns:r="http://schemas.openxmlformats.org/officeDocument/2006/relationships" id="276" r:id="R2cd2a2e9841d4733"/>
+    <p:sldId xmlns:r="http://schemas.openxmlformats.org/officeDocument/2006/relationships" id="277" r:id="R892fbf944dd44229"/>
+    <p:sldId xmlns:r="http://schemas.openxmlformats.org/officeDocument/2006/relationships" id="278" r:id="Ra389f48c50b0476c"/>
+    <p:sldId xmlns:r="http://schemas.openxmlformats.org/officeDocument/2006/relationships" id="279" r:id="R2edde5bb1dec4512"/>
+    <p:sldId xmlns:r="http://schemas.openxmlformats.org/officeDocument/2006/relationships" id="280" r:id="Re0b20362b0534737"/>
+    <p:sldId xmlns:r="http://schemas.openxmlformats.org/officeDocument/2006/relationships" id="281" r:id="R85bdb7f2b5bf4a90"/>
+    <p:sldId xmlns:r="http://schemas.openxmlformats.org/officeDocument/2006/relationships" id="282" r:id="R8044b303c463435b"/>
+    <p:sldId xmlns:r="http://schemas.openxmlformats.org/officeDocument/2006/relationships" id="283" r:id="R53ec4c548a614136"/>
+    <p:sldId xmlns:r="http://schemas.openxmlformats.org/officeDocument/2006/relationships" id="284" r:id="R9c6186924d3740eb"/>
   </p:sldIdLst>
   <p:sldSz cx="15240000" cy="8572500"/>
   <p:notesSz cx="6858000" cy="9144000"/>
@@ -573,6 +573,11 @@
               <a:t>https://man.openbsd.org/ssh-keygen</a:t>
             </a:r>
           </a:p>
+          <a:p xmlns:a="http://schemas.openxmlformats.org/drawingml/2006/main">
+            <a:r>
+              <a:t>PreferredAuthentications=publickey 限制为公钥认证方法，该方法包含证书与普通公钥；在交我算平台使用已签发的证书。重新一键生成会生成新密钥，必须同时更新私钥与证书。来源：https://man.openbsd.org/ssh_config 和 https://docs.hpc.sjtu.edu.cn/accounts/security.html</a:t>
+            </a:r>
+          </a:p>
         </p:txBody>
       </p:sp>
       <p:sp>
@@ -640,7 +645,7 @@
           <a:lstStyle xmlns:a="http://schemas.openxmlformats.org/drawingml/2006/main"/>
           <a:p xmlns:a="http://schemas.openxmlformats.org/drawingml/2006/main">
             <a:r>
-              <a:t>先在独立终端测试 SSH，再打开 VS Code 远程连接。打开文件夹时若 ~ 未展开，使用普通 SSH 会话 pwd 确认的绝对路径。保存改变的是服务器上的文件，提交云盘前要下载最终源码。集成终端初始通常在登录节点。</a:t>
+              <a:t>首次上传流程适用于 macOS、Linux 及具备 OpenSSH 客户端的 Windows。课程根目录应包含 labs/。不要传入本地构建产物。macOS/Linux 的 rsync 过滤示例见讲义。云盘分享链接可能需要登录或提取码，不一定是 wget 可用的文件直链。</a:t>
             </a:r>
           </a:p>
           <a:p xmlns:a="http://schemas.openxmlformats.org/drawingml/2006/main">
@@ -655,12 +660,7 @@
           </a:p>
           <a:p xmlns:a="http://schemas.openxmlformats.org/drawingml/2006/main">
             <a:r>
-              <a:t>https://docs.hpc.sjtu.edu.cn/login/vscode.html</a:t>
-            </a:r>
-          </a:p>
-          <a:p xmlns:a="http://schemas.openxmlformats.org/drawingml/2006/main">
-            <a:r>
-              <a:t>https://code.visualstudio.com/docs/remote/ssh</a:t>
+              <a:t>https://docs.hpc.sjtu.edu.cn/transport/transportsolution.html</a:t>
             </a:r>
           </a:p>
         </p:txBody>
@@ -730,7 +730,7 @@
           <a:lstStyle xmlns:a="http://schemas.openxmlformats.org/drawingml/2006/main"/>
           <a:p xmlns:a="http://schemas.openxmlformats.org/drawingml/2006/main">
             <a:r>
-              <a:t>已有用户设置时合并字段，不覆盖其他配置。别名找不到检查本地 config 路径和文件后缀。SSH 失败先检查校内网络、账号认证和证书。终端正常但 VS Code 不稳定时检查普通 SSH 活跃会话，以及负载均衡入口导致不同连接落到不同节点的问题。扩展的依赖下载可能仍需另行处理。</a:t>
+              <a:t>先在独立终端测试 SSH，再打开 VS Code 远程连接。打开文件夹时若 ~ 未展开，使用普通 SSH 会话 pwd 确认的绝对路径。保存改变的是服务器上的文件，提交云盘前要下载最终源码。集成终端初始通常在登录节点。</a:t>
             </a:r>
           </a:p>
           <a:p xmlns:a="http://schemas.openxmlformats.org/drawingml/2006/main">
@@ -751,11 +751,6 @@
           <a:p xmlns:a="http://schemas.openxmlformats.org/drawingml/2006/main">
             <a:r>
               <a:t>https://code.visualstudio.com/docs/remote/ssh</a:t>
-            </a:r>
-          </a:p>
-          <a:p xmlns:a="http://schemas.openxmlformats.org/drawingml/2006/main">
-            <a:r>
-              <a:t>https://code.visualstudio.com/docs/remote/troubleshooting</a:t>
             </a:r>
           </a:p>
         </p:txBody>
@@ -825,7 +820,7 @@
           <a:lstStyle xmlns:a="http://schemas.openxmlformats.org/drawingml/2006/main"/>
           <a:p xmlns:a="http://schemas.openxmlformats.org/drawingml/2006/main">
             <a:r>
-              <a:t>首次上传流程适用于 macOS、Linux 及具备 OpenSSH 客户端的 Windows。课程根目录应包含 labs/。不要传入本地构建产物。macOS/Linux 的 rsync 过滤示例见讲义。云盘分享链接可能需要登录或提取码，不一定是 wget 可用的文件直链。</a:t>
+              <a:t>已有用户设置时合并字段，不覆盖其他配置。别名找不到检查本地 config 路径和文件后缀。SSH 失败先检查校内网络、账号认证和证书。终端正常但 VS Code 不稳定时检查普通 SSH 活跃会话，以及负载均衡入口导致不同连接落到不同节点的问题。扩展的依赖下载可能仍需另行处理。</a:t>
             </a:r>
           </a:p>
           <a:p xmlns:a="http://schemas.openxmlformats.org/drawingml/2006/main">
@@ -840,7 +835,17 @@
           </a:p>
           <a:p xmlns:a="http://schemas.openxmlformats.org/drawingml/2006/main">
             <a:r>
-              <a:t>https://docs.hpc.sjtu.edu.cn/transport/transportsolution.html</a:t>
+              <a:t>https://docs.hpc.sjtu.edu.cn/login/vscode.html</a:t>
+            </a:r>
+          </a:p>
+          <a:p xmlns:a="http://schemas.openxmlformats.org/drawingml/2006/main">
+            <a:r>
+              <a:t>https://code.visualstudio.com/docs/remote/ssh</a:t>
+            </a:r>
+          </a:p>
+          <a:p xmlns:a="http://schemas.openxmlformats.org/drawingml/2006/main">
+            <a:r>
+              <a:t>https://code.visualstudio.com/docs/remote/troubleshooting</a:t>
             </a:r>
           </a:p>
         </p:txBody>
@@ -938,6 +943,11 @@
               <a:t>https://docs.hpc.sjtu.edu.cn/job/kos.html</a:t>
             </a:r>
           </a:p>
+          <a:p xmlns:a="http://schemas.openxmlformats.org/drawingml/2006/main">
+            <a:r>
+              <a:t>srun 分配后启动登录 shell，初始化计算节点的软件模块环境。module load cmake 加载默认版本；若不可用或版本低于 3.16，从 module avail cmake 选择实际存在的版本。官方 KOS 页面示例为 cmake/3.26.3-gcc-8.5.0，账号权限和模块版本以现场查询为准。来源：https://docs.hpc.sjtu.edu.cn/job/kos.html 和 https://docs.hpc.sjtu.edu.cn/app/module.html</a:t>
+            </a:r>
+          </a:p>
         </p:txBody>
       </p:sp>
       <p:sp>
@@ -1023,6 +1033,11 @@
               <a:t>课程仓库 labs/lab1-datalab/README.md、Makefile、bits.c（2026-09-27）</a:t>
             </a:r>
           </a:p>
+          <a:p xmlns:a="http://schemas.openxmlformats.org/drawingml/2006/main">
+            <a:r>
+              <a:t>仓库 dlc 的文件模式为 100644，云盘/Windows 传输也可能丢失执行位，首次执行前需 chmod u+x ./dlc。dlc 为 x86-64 Linux ELF，应在 π2.0 CPU 计算节点运行。make selftest 执行 btest -S -g，是参考函数/框架自检；make grade 才检查学生实现。依据 labs/lab1-datalab/Makefile、README.md 与文件模式。</a:t>
+            </a:r>
+          </a:p>
         </p:txBody>
       </p:sp>
       <p:sp>
@@ -1193,6 +1208,11 @@
               <a:t>课程仓库 labs/lab2-matrix/CMakeLists.txt、README.md、benchmarks/*.c、scripts/*.sh（2026-09-27）</a:t>
             </a:r>
           </a:p>
+          <a:p xmlns:a="http://schemas.openxmlformats.org/drawingml/2006/main">
+            <a:r>
+              <a:t>reg_reuse 接受多个矩阵维度；cache_part3/cache_part4 接受 n 和块大小 b。6、12、24、48 均满足 6 的倍数要求，48 可被 6 整除。学生空模板会返回非零；ctest 不覆盖学生矩阵实现。依据 benchmarks/*.c、CMakeLists.txt。</a:t>
+            </a:r>
+          </a:p>
         </p:txBody>
       </p:sp>
       <p:sp>
@@ -1373,6 +1393,11 @@
               <a:t>课程仓库 labs/lab1-datalab/README.md、Makefile、bits.c（2026-09-27）</a:t>
             </a:r>
           </a:p>
+          <a:p xmlns:a="http://schemas.openxmlformats.org/drawingml/2006/main">
+            <a:r>
+              <a:t>在登录节点从 course-labs 根目录提交，先 mkdir -p results。日志目录必须在作业启动前存在。VS Code 右下角选 LF，避免 Windows CRLF 导致 sbatch 拒绝脚本。set -e 会在首个失败命令处停止。来源：https://slurm.schedmd.com/sbatch.html；命令目标依据 labs/lab1-datalab/Makefile。</a:t>
+            </a:r>
+          </a:p>
         </p:txBody>
       </p:sp>
       <p:sp>
@@ -1553,6 +1578,11 @@
               <a:t>课程仓库 labs/lab2-matrix/CMakeLists.txt、README.md、benchmarks/*.c、scripts/*.sh（2026-09-27）</a:t>
             </a:r>
           </a:p>
+          <a:p xmlns:a="http://schemas.openxmlformats.org/drawingml/2006/main">
+            <a:r>
+              <a:t>批处理脚本自身加载 CMake；交互节点内的 module load 不会自动改变登录节点随后提交的独立作业。登录 shell 初始化模块命令。默认版本必须 ≥3.16，必要时改为 module avail cmake 中确认的具体版本。来源：https://docs.hpc.sjtu.edu.cn/app/module.html 和 https://slurm.schedmd.com/sbatch.html</a:t>
+            </a:r>
+          </a:p>
         </p:txBody>
       </p:sp>
       <p:sp>
@@ -1723,6 +1753,11 @@
               <a:t>https://docs.hpc.sjtu.edu.cn/job/slurm.html</a:t>
             </a:r>
           </a:p>
+          <a:p xmlns:a="http://schemas.openxmlformats.org/drawingml/2006/main">
+            <a:r>
+              <a:t>将 123456 替换为本次 Lab2 的作业 ID。排队时日志可能尚未创建，tail -F 会等待文件出现；退出查看只中断 tail，不会取消作业。作业完成后 sacct 可查看状态与退出码。来源：https://www.gnu.org/software/coreutils/manual/html_node/tail-invocation.html 和 https://slurm.schedmd.com/sacct.html</a:t>
+            </a:r>
+          </a:p>
         </p:txBody>
       </p:sp>
       <p:sp>
@@ -1806,6 +1841,11 @@
           <a:p xmlns:a="http://schemas.openxmlformats.org/drawingml/2006/main">
             <a:r>
               <a:t>https://docs.hpc.sjtu.edu.cn/transport/transportsolution.html</a:t>
+            </a:r>
+          </a:p>
+          <a:p xmlns:a="http://schemas.openxmlformats.org/drawingml/2006/main">
+            <a:r>
+              <a:t>Windows 默认没有 rsync。本例统一使用 OpenSSH scp -r 下载目录；目标 pi2-results 已创建，因此 results 目录存放于其中。macOS/Linux 的 rsync 可作为讲义中的可选命令。传输从本地发起。来源：https://docs.hpc.sjtu.edu.cn/transport/transportsolution.html 和 https://man.openbsd.org/scp</a:t>
             </a:r>
           </a:p>
         </p:txBody>
@@ -3013,7 +3053,7 @@
   </p:cSld>
   <p:clrMap bg1="lt1" tx1="dk1" bg2="lt2" tx2="dk2" accent1="accent1" accent2="accent2" accent3="accent3" accent4="accent4" accent5="accent5" accent6="accent6" hlink="hlink" folHlink="folHlink"/>
   <p:sldLayoutIdLst>
-    <p:sldLayoutId xmlns:r="http://schemas.openxmlformats.org/officeDocument/2006/relationships" id="2147483649" r:id="R84be41399f4146a9"/>
+    <p:sldLayoutId xmlns:r="http://schemas.openxmlformats.org/officeDocument/2006/relationships" id="2147483649" r:id="Rc865df411be44c1f"/>
   </p:sldLayoutIdLst>
   <p:txStyles>
     <p:titleStyle>
@@ -4221,7 +4261,7 @@
                 <a:ea typeface="Hiragino Sans GB"/>
                 <a:cs typeface="Hiragino Sans GB"/>
               </a:rPr>
-              <a:t>可选：仅测试证书认证，避免回退到账号密码</a:t>
+              <a:t>可选：仅允许公钥类认证（含证书），避免回退到账号密码</a:t>
             </a:r>
           </a:p>
         </p:txBody>
@@ -4395,7 +4435,7 @@
                 <a:ea typeface="Hiragino Sans GB"/>
                 <a:cs typeface="Hiragino Sans GB"/>
               </a:rPr>
-              <a:t>证书过期后重新申请，更新本地证书文件并再次登录</a:t>
+              <a:t>续签时更新证书；若重新一键生成，私钥与证书都要更新</a:t>
             </a:r>
           </a:p>
         </p:txBody>
@@ -4489,10 +4529,10 @@
       </p:grpSpPr>
       <p:sp>
         <p:nvSpPr>
-          <p:cNvPr id="9" name="">
-            <a:extLst xmlns:a="http://schemas.openxmlformats.org/drawingml/2006/main">
-              <a:ext uri="{FF2B5EF4-FFF2-40B4-BE49-F238E27FC236}">
-                <a16:creationId xmlns:a16="http://schemas.microsoft.com/office/drawing/2014/main" id="{974B2865-DC00-4E59-9F3A-640A7913DC3C}"/>
+          <p:cNvPr id="13" name="">
+            <a:extLst xmlns:a="http://schemas.openxmlformats.org/drawingml/2006/main">
+              <a:ext uri="{FF2B5EF4-FFF2-40B4-BE49-F238E27FC236}">
+                <a16:creationId xmlns:a16="http://schemas.microsoft.com/office/drawing/2014/main" id="{F72D8CD2-C378-452E-BD65-A32051B5A5F1}"/>
               </a:ext>
             </a:extLst>
           </p:cNvPr>
@@ -4540,7 +4580,7 @@
                 <a:ea typeface="Hiragino Sans GB"/>
                 <a:cs typeface="Hiragino Sans GB"/>
               </a:rPr>
-              <a:t>VS Code 连接与编辑</a:t>
+              <a:t>从云盘获取并上传源码</a:t>
             </a:r>
           </a:p>
         </p:txBody>
@@ -4550,7 +4590,7 @@
           <p:cNvPr id="2" name="">
             <a:extLst xmlns:a="http://schemas.openxmlformats.org/drawingml/2006/main">
               <a:ext uri="{FF2B5EF4-FFF2-40B4-BE49-F238E27FC236}">
-                <a16:creationId xmlns:a16="http://schemas.microsoft.com/office/drawing/2014/main" id="{AFA67C7E-1DCE-457B-9A22-9FD38D176CF9}"/>
+                <a16:creationId xmlns:a16="http://schemas.microsoft.com/office/drawing/2014/main" id="{C465AA1C-7538-452B-A075-B36D60CDEA34}"/>
               </a:ext>
             </a:extLst>
           </p:cNvPr>
@@ -4605,22 +4645,22 @@
       </p:sp>
       <p:sp>
         <p:nvSpPr>
-          <p:cNvPr id="10" name="content-2">
-            <a:extLst xmlns:a="http://schemas.openxmlformats.org/drawingml/2006/main">
-              <a:ext uri="{FF2B5EF4-FFF2-40B4-BE49-F238E27FC236}">
-                <a16:creationId xmlns:a16="http://schemas.microsoft.com/office/drawing/2014/main" id="{609A6770-9ABC-4A99-908D-A58F5C357EAD}"/>
-              </a:ext>
-            </a:extLst>
-          </p:cNvPr>
-          <p:cNvSpPr>
-            <a:spLocks xmlns:a="http://schemas.openxmlformats.org/drawingml/2006/main" noGrp="1"/>
-          </p:cNvSpPr>
-          <p:nvPr/>
-        </p:nvSpPr>
-        <p:spPr>
-          <a:xfrm xmlns:a="http://schemas.openxmlformats.org/drawingml/2006/main">
-            <a:off x="876300" y="1857375"/>
-            <a:ext cx="13335000" cy="723900"/>
+          <p:cNvPr id="14" name="content-2">
+            <a:extLst xmlns:a="http://schemas.openxmlformats.org/drawingml/2006/main">
+              <a:ext uri="{FF2B5EF4-FFF2-40B4-BE49-F238E27FC236}">
+                <a16:creationId xmlns:a16="http://schemas.microsoft.com/office/drawing/2014/main" id="{3CD37B2F-FD3B-43C0-AF11-E2F282B23F19}"/>
+              </a:ext>
+            </a:extLst>
+          </p:cNvPr>
+          <p:cNvSpPr>
+            <a:spLocks xmlns:a="http://schemas.openxmlformats.org/drawingml/2006/main" noGrp="1"/>
+          </p:cNvSpPr>
+          <p:nvPr/>
+        </p:nvSpPr>
+        <p:spPr>
+          <a:xfrm xmlns:a="http://schemas.openxmlformats.org/drawingml/2006/main">
+            <a:off x="876300" y="1714500"/>
+            <a:ext cx="13335000" cy="571500"/>
           </a:xfrm>
           <a:prstGeom xmlns:a="http://schemas.openxmlformats.org/drawingml/2006/main" prst="rect">
             <a:avLst/>
@@ -4638,47 +4678,163 @@
           <a:p xmlns:a="http://schemas.openxmlformats.org/drawingml/2006/main">
             <a:pPr>
               <a:buNone/>
+              <a:defRPr sz="2325" b="0">
+                <a:solidFill>
+                  <a:srgbClr val="EAF1EF"/>
+                </a:solidFill>
+                <a:latin typeface="Hiragino Sans GB"/>
+                <a:ea typeface="Hiragino Sans GB"/>
+                <a:cs typeface="Hiragino Sans GB"/>
+              </a:defRPr>
+            </a:pPr>
+            <a:r>
+              <a:rPr sz="2325" b="0">
+                <a:solidFill>
+                  <a:srgbClr val="EAF1EF"/>
+                </a:solidFill>
+                <a:latin typeface="Hiragino Sans GB"/>
+                <a:ea typeface="Hiragino Sans GB"/>
+                <a:cs typeface="Hiragino Sans GB"/>
+              </a:rPr>
+              <a:t>浏览器下载教师发布的学生包，解压后将根目录命名为 course-labs</a:t>
+            </a:r>
+          </a:p>
+        </p:txBody>
+      </p:sp>
+      <p:sp>
+        <p:nvSpPr>
+          <p:cNvPr id="15" name="content-3">
+            <a:extLst xmlns:a="http://schemas.openxmlformats.org/drawingml/2006/main">
+              <a:ext uri="{FF2B5EF4-FFF2-40B4-BE49-F238E27FC236}">
+                <a16:creationId xmlns:a16="http://schemas.microsoft.com/office/drawing/2014/main" id="{D62A69DB-A711-41DD-99E3-FB2F155CD279}"/>
+              </a:ext>
+            </a:extLst>
+          </p:cNvPr>
+          <p:cNvSpPr>
+            <a:spLocks xmlns:a="http://schemas.openxmlformats.org/drawingml/2006/main" noGrp="1"/>
+          </p:cNvSpPr>
+          <p:nvPr/>
+        </p:nvSpPr>
+        <p:spPr>
+          <a:xfrm xmlns:a="http://schemas.openxmlformats.org/drawingml/2006/main">
+            <a:off x="876300" y="2667000"/>
+            <a:ext cx="13335000" cy="571500"/>
+          </a:xfrm>
+          <a:prstGeom xmlns:a="http://schemas.openxmlformats.org/drawingml/2006/main" prst="rect">
+            <a:avLst/>
+          </a:prstGeom>
+          <a:noFill xmlns:a="http://schemas.openxmlformats.org/drawingml/2006/main"/>
+          <a:ln xmlns:a="http://schemas.openxmlformats.org/drawingml/2006/main" w="0">
+            <a:noFill/>
+          </a:ln>
+        </p:spPr>
+        <p:txBody>
+          <a:bodyPr xmlns:a="http://schemas.openxmlformats.org/drawingml/2006/main" wrap="none">
+            <a:noAutofit/>
+          </a:bodyPr>
+          <a:lstStyle xmlns:a="http://schemas.openxmlformats.org/drawingml/2006/main"/>
+          <a:p xmlns:a="http://schemas.openxmlformats.org/drawingml/2006/main">
+            <a:pPr>
+              <a:buNone/>
+              <a:defRPr sz="2250" b="0">
+                <a:solidFill>
+                  <a:srgbClr val="EAF1EF"/>
+                </a:solidFill>
+                <a:latin typeface="Hiragino Sans GB"/>
+                <a:ea typeface="Hiragino Sans GB"/>
+                <a:cs typeface="Hiragino Sans GB"/>
+              </a:defRPr>
+            </a:pPr>
+            <a:r>
+              <a:rPr sz="2250" b="0">
+                <a:solidFill>
+                  <a:srgbClr val="EAF1EF"/>
+                </a:solidFill>
+                <a:latin typeface="Hiragino Sans GB"/>
+                <a:ea typeface="Hiragino Sans GB"/>
+                <a:cs typeface="Hiragino Sans GB"/>
+              </a:rPr>
+              <a:t>本地终端：在 course-labs 的上一级目录执行</a:t>
+            </a:r>
+          </a:p>
+        </p:txBody>
+      </p:sp>
+      <p:sp>
+        <p:nvSpPr>
+          <p:cNvPr id="16" name="content-4">
+            <a:extLst xmlns:a="http://schemas.openxmlformats.org/drawingml/2006/main">
+              <a:ext uri="{FF2B5EF4-FFF2-40B4-BE49-F238E27FC236}">
+                <a16:creationId xmlns:a16="http://schemas.microsoft.com/office/drawing/2014/main" id="{0D69CE6B-B379-4948-A86D-27F985503B52}"/>
+              </a:ext>
+            </a:extLst>
+          </p:cNvPr>
+          <p:cNvSpPr>
+            <a:spLocks xmlns:a="http://schemas.openxmlformats.org/drawingml/2006/main" noGrp="1"/>
+          </p:cNvSpPr>
+          <p:nvPr/>
+        </p:nvSpPr>
+        <p:spPr>
+          <a:xfrm xmlns:a="http://schemas.openxmlformats.org/drawingml/2006/main">
+            <a:off x="876300" y="3429000"/>
+            <a:ext cx="13335000" cy="571500"/>
+          </a:xfrm>
+          <a:prstGeom xmlns:a="http://schemas.openxmlformats.org/drawingml/2006/main" prst="rect">
+            <a:avLst/>
+          </a:prstGeom>
+          <a:noFill xmlns:a="http://schemas.openxmlformats.org/drawingml/2006/main"/>
+          <a:ln xmlns:a="http://schemas.openxmlformats.org/drawingml/2006/main" w="0">
+            <a:noFill/>
+          </a:ln>
+        </p:spPr>
+        <p:txBody>
+          <a:bodyPr xmlns:a="http://schemas.openxmlformats.org/drawingml/2006/main" wrap="none">
+            <a:noAutofit/>
+          </a:bodyPr>
+          <a:lstStyle xmlns:a="http://schemas.openxmlformats.org/drawingml/2006/main"/>
+          <a:p xmlns:a="http://schemas.openxmlformats.org/drawingml/2006/main">
+            <a:pPr>
+              <a:buNone/>
               <a:defRPr sz="2550" b="0">
                 <a:solidFill>
-                  <a:srgbClr val="EAF1EF"/>
-                </a:solidFill>
-                <a:latin typeface="Hiragino Sans GB"/>
-                <a:ea typeface="Hiragino Sans GB"/>
-                <a:cs typeface="Hiragino Sans GB"/>
+                  <a:srgbClr val="B7EDDB"/>
+                </a:solidFill>
+                <a:latin typeface="Menlo"/>
+                <a:ea typeface="Menlo"/>
+                <a:cs typeface="Menlo"/>
               </a:defRPr>
             </a:pPr>
             <a:r>
               <a:rPr sz="2550" b="0">
                 <a:solidFill>
-                  <a:srgbClr val="EAF1EF"/>
-                </a:solidFill>
-                <a:latin typeface="Hiragino Sans GB"/>
-                <a:ea typeface="Hiragino Sans GB"/>
-                <a:cs typeface="Hiragino Sans GB"/>
-              </a:rPr>
-              <a:t>1  在本地安装 Microsoft Remote - SSH 扩展</a:t>
-            </a:r>
-          </a:p>
-        </p:txBody>
-      </p:sp>
-      <p:sp>
-        <p:nvSpPr>
-          <p:cNvPr id="11" name="content-3">
-            <a:extLst xmlns:a="http://schemas.openxmlformats.org/drawingml/2006/main">
-              <a:ext uri="{FF2B5EF4-FFF2-40B4-BE49-F238E27FC236}">
-                <a16:creationId xmlns:a16="http://schemas.microsoft.com/office/drawing/2014/main" id="{F6AC5F6B-C396-4397-AC0E-98B406E1A93E}"/>
-              </a:ext>
-            </a:extLst>
-          </p:cNvPr>
-          <p:cNvSpPr>
-            <a:spLocks xmlns:a="http://schemas.openxmlformats.org/drawingml/2006/main" noGrp="1"/>
-          </p:cNvSpPr>
-          <p:nvPr/>
-        </p:nvSpPr>
-        <p:spPr>
-          <a:xfrm xmlns:a="http://schemas.openxmlformats.org/drawingml/2006/main">
-            <a:off x="876300" y="2828925"/>
-            <a:ext cx="13335000" cy="723900"/>
+                  <a:srgbClr val="B7EDDB"/>
+                </a:solidFill>
+                <a:latin typeface="Menlo"/>
+                <a:ea typeface="Menlo"/>
+                <a:cs typeface="Menlo"/>
+              </a:rPr>
+              <a:t>scp -r ./course-labs jiaowosuan-data:</a:t>
+            </a:r>
+          </a:p>
+        </p:txBody>
+      </p:sp>
+      <p:sp>
+        <p:nvSpPr>
+          <p:cNvPr id="17" name="content-5">
+            <a:extLst xmlns:a="http://schemas.openxmlformats.org/drawingml/2006/main">
+              <a:ext uri="{FF2B5EF4-FFF2-40B4-BE49-F238E27FC236}">
+                <a16:creationId xmlns:a16="http://schemas.microsoft.com/office/drawing/2014/main" id="{EAA7F502-16FD-4D2E-8D0C-602787B128A8}"/>
+              </a:ext>
+            </a:extLst>
+          </p:cNvPr>
+          <p:cNvSpPr>
+            <a:spLocks xmlns:a="http://schemas.openxmlformats.org/drawingml/2006/main" noGrp="1"/>
+          </p:cNvSpPr>
+          <p:nvPr/>
+        </p:nvSpPr>
+        <p:spPr>
+          <a:xfrm xmlns:a="http://schemas.openxmlformats.org/drawingml/2006/main">
+            <a:off x="876300" y="4095750"/>
+            <a:ext cx="13335000" cy="571500"/>
           </a:xfrm>
           <a:prstGeom xmlns:a="http://schemas.openxmlformats.org/drawingml/2006/main" prst="rect">
             <a:avLst/>
@@ -4698,45 +4854,45 @@
               <a:buNone/>
               <a:defRPr sz="2550" b="0">
                 <a:solidFill>
-                  <a:srgbClr val="EAF1EF"/>
-                </a:solidFill>
-                <a:latin typeface="Hiragino Sans GB"/>
-                <a:ea typeface="Hiragino Sans GB"/>
-                <a:cs typeface="Hiragino Sans GB"/>
+                  <a:srgbClr val="B7EDDB"/>
+                </a:solidFill>
+                <a:latin typeface="Menlo"/>
+                <a:ea typeface="Menlo"/>
+                <a:cs typeface="Menlo"/>
               </a:defRPr>
             </a:pPr>
             <a:r>
               <a:rPr sz="2550" b="0">
                 <a:solidFill>
-                  <a:srgbClr val="EAF1EF"/>
-                </a:solidFill>
-                <a:latin typeface="Hiragino Sans GB"/>
-                <a:ea typeface="Hiragino Sans GB"/>
-                <a:cs typeface="Hiragino Sans GB"/>
-              </a:rPr>
-              <a:t>2  按 F1，搜索 Remote-SSH: Connect to Host...</a:t>
-            </a:r>
-          </a:p>
-        </p:txBody>
-      </p:sp>
-      <p:sp>
-        <p:nvSpPr>
-          <p:cNvPr id="12" name="content-4">
-            <a:extLst xmlns:a="http://schemas.openxmlformats.org/drawingml/2006/main">
-              <a:ext uri="{FF2B5EF4-FFF2-40B4-BE49-F238E27FC236}">
-                <a16:creationId xmlns:a16="http://schemas.microsoft.com/office/drawing/2014/main" id="{5EA8E908-6F4A-451C-99F3-EAD1E96F7421}"/>
-              </a:ext>
-            </a:extLst>
-          </p:cNvPr>
-          <p:cNvSpPr>
-            <a:spLocks xmlns:a="http://schemas.openxmlformats.org/drawingml/2006/main" noGrp="1"/>
-          </p:cNvSpPr>
-          <p:nvPr/>
-        </p:nvSpPr>
-        <p:spPr>
-          <a:xfrm xmlns:a="http://schemas.openxmlformats.org/drawingml/2006/main">
-            <a:off x="876300" y="3800475"/>
-            <a:ext cx="13335000" cy="723900"/>
+                  <a:srgbClr val="B7EDDB"/>
+                </a:solidFill>
+                <a:latin typeface="Menlo"/>
+                <a:ea typeface="Menlo"/>
+                <a:cs typeface="Menlo"/>
+              </a:rPr>
+              <a:t>ssh jiaowosuan</a:t>
+            </a:r>
+          </a:p>
+        </p:txBody>
+      </p:sp>
+      <p:sp>
+        <p:nvSpPr>
+          <p:cNvPr id="18" name="content-6">
+            <a:extLst xmlns:a="http://schemas.openxmlformats.org/drawingml/2006/main">
+              <a:ext uri="{FF2B5EF4-FFF2-40B4-BE49-F238E27FC236}">
+                <a16:creationId xmlns:a16="http://schemas.microsoft.com/office/drawing/2014/main" id="{1A2AD3A8-95AB-4F39-8AE6-9E8ECE9C9D3A}"/>
+              </a:ext>
+            </a:extLst>
+          </p:cNvPr>
+          <p:cNvSpPr>
+            <a:spLocks xmlns:a="http://schemas.openxmlformats.org/drawingml/2006/main" noGrp="1"/>
+          </p:cNvSpPr>
+          <p:nvPr/>
+        </p:nvSpPr>
+        <p:spPr>
+          <a:xfrm xmlns:a="http://schemas.openxmlformats.org/drawingml/2006/main">
+            <a:off x="876300" y="4762500"/>
+            <a:ext cx="13335000" cy="571500"/>
           </a:xfrm>
           <a:prstGeom xmlns:a="http://schemas.openxmlformats.org/drawingml/2006/main" prst="rect">
             <a:avLst/>
@@ -4756,45 +4912,45 @@
               <a:buNone/>
               <a:defRPr sz="2550" b="0">
                 <a:solidFill>
-                  <a:srgbClr val="EAF1EF"/>
-                </a:solidFill>
-                <a:latin typeface="Hiragino Sans GB"/>
-                <a:ea typeface="Hiragino Sans GB"/>
-                <a:cs typeface="Hiragino Sans GB"/>
+                  <a:srgbClr val="B7EDDB"/>
+                </a:solidFill>
+                <a:latin typeface="Menlo"/>
+                <a:ea typeface="Menlo"/>
+                <a:cs typeface="Menlo"/>
               </a:defRPr>
             </a:pPr>
             <a:r>
               <a:rPr sz="2550" b="0">
                 <a:solidFill>
-                  <a:srgbClr val="EAF1EF"/>
-                </a:solidFill>
-                <a:latin typeface="Hiragino Sans GB"/>
-                <a:ea typeface="Hiragino Sans GB"/>
-                <a:cs typeface="Hiragino Sans GB"/>
-              </a:rPr>
-              <a:t>3  选择 jiaowosuan，远端系统选择 Linux，完成认证</a:t>
-            </a:r>
-          </a:p>
-        </p:txBody>
-      </p:sp>
-      <p:sp>
-        <p:nvSpPr>
-          <p:cNvPr id="13" name="content-5">
-            <a:extLst xmlns:a="http://schemas.openxmlformats.org/drawingml/2006/main">
-              <a:ext uri="{FF2B5EF4-FFF2-40B4-BE49-F238E27FC236}">
-                <a16:creationId xmlns:a16="http://schemas.microsoft.com/office/drawing/2014/main" id="{E4B232E0-1C31-447C-9365-51793F3457C1}"/>
-              </a:ext>
-            </a:extLst>
-          </p:cNvPr>
-          <p:cNvSpPr>
-            <a:spLocks xmlns:a="http://schemas.openxmlformats.org/drawingml/2006/main" noGrp="1"/>
-          </p:cNvSpPr>
-          <p:nvPr/>
-        </p:nvSpPr>
-        <p:spPr>
-          <a:xfrm xmlns:a="http://schemas.openxmlformats.org/drawingml/2006/main">
-            <a:off x="876300" y="4772025"/>
-            <a:ext cx="13335000" cy="723900"/>
+                  <a:srgbClr val="B7EDDB"/>
+                </a:solidFill>
+                <a:latin typeface="Menlo"/>
+                <a:ea typeface="Menlo"/>
+                <a:cs typeface="Menlo"/>
+              </a:rPr>
+              <a:t>cd ~/course-labs</a:t>
+            </a:r>
+          </a:p>
+        </p:txBody>
+      </p:sp>
+      <p:sp>
+        <p:nvSpPr>
+          <p:cNvPr id="19" name="content-7">
+            <a:extLst xmlns:a="http://schemas.openxmlformats.org/drawingml/2006/main">
+              <a:ext uri="{FF2B5EF4-FFF2-40B4-BE49-F238E27FC236}">
+                <a16:creationId xmlns:a16="http://schemas.microsoft.com/office/drawing/2014/main" id="{E3011C2E-F30F-4713-A05E-1E74279643FA}"/>
+              </a:ext>
+            </a:extLst>
+          </p:cNvPr>
+          <p:cNvSpPr>
+            <a:spLocks xmlns:a="http://schemas.openxmlformats.org/drawingml/2006/main" noGrp="1"/>
+          </p:cNvSpPr>
+          <p:nvPr/>
+        </p:nvSpPr>
+        <p:spPr>
+          <a:xfrm xmlns:a="http://schemas.openxmlformats.org/drawingml/2006/main">
+            <a:off x="876300" y="5429250"/>
+            <a:ext cx="13335000" cy="571500"/>
           </a:xfrm>
           <a:prstGeom xmlns:a="http://schemas.openxmlformats.org/drawingml/2006/main" prst="rect">
             <a:avLst/>
@@ -4814,91 +4970,33 @@
               <a:buNone/>
               <a:defRPr sz="2550" b="0">
                 <a:solidFill>
-                  <a:srgbClr val="EAF1EF"/>
-                </a:solidFill>
-                <a:latin typeface="Hiragino Sans GB"/>
-                <a:ea typeface="Hiragino Sans GB"/>
-                <a:cs typeface="Hiragino Sans GB"/>
+                  <a:srgbClr val="B7EDDB"/>
+                </a:solidFill>
+                <a:latin typeface="Menlo"/>
+                <a:ea typeface="Menlo"/>
+                <a:cs typeface="Menlo"/>
               </a:defRPr>
             </a:pPr>
             <a:r>
               <a:rPr sz="2550" b="0">
                 <a:solidFill>
-                  <a:srgbClr val="EAF1EF"/>
-                </a:solidFill>
-                <a:latin typeface="Hiragino Sans GB"/>
-                <a:ea typeface="Hiragino Sans GB"/>
-                <a:cs typeface="Hiragino Sans GB"/>
-              </a:rPr>
-              <a:t>4  打开远端 ~/course-labs，确认左下角的 SSH 主机名</a:t>
-            </a:r>
-          </a:p>
-        </p:txBody>
-      </p:sp>
-      <p:sp>
-        <p:nvSpPr>
-          <p:cNvPr id="14" name="content-6">
-            <a:extLst xmlns:a="http://schemas.openxmlformats.org/drawingml/2006/main">
-              <a:ext uri="{FF2B5EF4-FFF2-40B4-BE49-F238E27FC236}">
-                <a16:creationId xmlns:a16="http://schemas.microsoft.com/office/drawing/2014/main" id="{E3C73381-BF7D-462B-A43C-BB822C080341}"/>
-              </a:ext>
-            </a:extLst>
-          </p:cNvPr>
-          <p:cNvSpPr>
-            <a:spLocks xmlns:a="http://schemas.openxmlformats.org/drawingml/2006/main" noGrp="1"/>
-          </p:cNvSpPr>
-          <p:nvPr/>
-        </p:nvSpPr>
-        <p:spPr>
-          <a:xfrm xmlns:a="http://schemas.openxmlformats.org/drawingml/2006/main">
-            <a:off x="876300" y="5743575"/>
-            <a:ext cx="13335000" cy="723900"/>
-          </a:xfrm>
-          <a:prstGeom xmlns:a="http://schemas.openxmlformats.org/drawingml/2006/main" prst="rect">
-            <a:avLst/>
-          </a:prstGeom>
-          <a:noFill xmlns:a="http://schemas.openxmlformats.org/drawingml/2006/main"/>
-          <a:ln xmlns:a="http://schemas.openxmlformats.org/drawingml/2006/main" w="0">
-            <a:noFill/>
-          </a:ln>
-        </p:spPr>
-        <p:txBody>
-          <a:bodyPr xmlns:a="http://schemas.openxmlformats.org/drawingml/2006/main" wrap="none">
-            <a:noAutofit/>
-          </a:bodyPr>
-          <a:lstStyle xmlns:a="http://schemas.openxmlformats.org/drawingml/2006/main"/>
-          <a:p xmlns:a="http://schemas.openxmlformats.org/drawingml/2006/main">
-            <a:pPr>
-              <a:buNone/>
-              <a:defRPr sz="2550" b="0">
-                <a:solidFill>
-                  <a:srgbClr val="EAF1EF"/>
-                </a:solidFill>
-                <a:latin typeface="Hiragino Sans GB"/>
-                <a:ea typeface="Hiragino Sans GB"/>
-                <a:cs typeface="Hiragino Sans GB"/>
-              </a:defRPr>
-            </a:pPr>
-            <a:r>
-              <a:rPr sz="2550" b="0">
-                <a:solidFill>
-                  <a:srgbClr val="EAF1EF"/>
-                </a:solidFill>
-                <a:latin typeface="Hiragino Sans GB"/>
-                <a:ea typeface="Hiragino Sans GB"/>
-                <a:cs typeface="Hiragino Sans GB"/>
-              </a:rPr>
-              <a:t>5  保存源码后，在集成终端先申请计算资源，再编译</a:t>
-            </a:r>
-          </a:p>
-        </p:txBody>
-      </p:sp>
-      <p:sp>
-        <p:nvSpPr>
-          <p:cNvPr id="15" name="content-7">
-            <a:extLst xmlns:a="http://schemas.openxmlformats.org/drawingml/2006/main">
-              <a:ext uri="{FF2B5EF4-FFF2-40B4-BE49-F238E27FC236}">
-                <a16:creationId xmlns:a16="http://schemas.microsoft.com/office/drawing/2014/main" id="{7BF07F11-E49B-460E-98AA-7ECD07BD97E7}"/>
+                  <a:srgbClr val="B7EDDB"/>
+                </a:solidFill>
+                <a:latin typeface="Menlo"/>
+                <a:ea typeface="Menlo"/>
+                <a:cs typeface="Menlo"/>
+              </a:rPr>
+              <a:t>ls labs</a:t>
+            </a:r>
+          </a:p>
+        </p:txBody>
+      </p:sp>
+      <p:sp>
+        <p:nvSpPr>
+          <p:cNvPr id="20" name="content-8">
+            <a:extLst xmlns:a="http://schemas.openxmlformats.org/drawingml/2006/main">
+              <a:ext uri="{FF2B5EF4-FFF2-40B4-BE49-F238E27FC236}">
+                <a16:creationId xmlns:a16="http://schemas.microsoft.com/office/drawing/2014/main" id="{17AB631B-C4A0-4DD9-BAB1-9AF59624C7F1}"/>
               </a:ext>
             </a:extLst>
           </p:cNvPr>
@@ -4946,7 +5044,7 @@
                 <a:ea typeface="Hiragino Sans GB"/>
                 <a:cs typeface="Hiragino Sans GB"/>
               </a:rPr>
-              <a:t>使用期间保持一个普通 ssh jiaowosuan 会话打开，满足平台的活跃会话要求。</a:t>
+              <a:t>后续更新先保存远端修改，再合并新版本。分享页面下载到本地后，通过数据节点上传。</a:t>
             </a:r>
           </a:p>
         </p:txBody>
@@ -4954,7 +5052,7 @@
     </p:spTree>
     <p:extLst>
       <p:ext uri="{BB962C8B-B14F-4D97-AF65-F5344CB8AC3E}">
-        <p14:creationId xmlns:p14="http://schemas.microsoft.com/office/powerpoint/2010/main" val="297403261"/>
+        <p14:creationId xmlns:p14="http://schemas.microsoft.com/office/powerpoint/2010/main" val="1523425400"/>
       </p:ext>
     </p:extLst>
   </p:cSld>
@@ -5033,7 +5131,7 @@
                 <a:ea typeface="Hiragino Sans GB"/>
                 <a:cs typeface="Hiragino Sans GB"/>
               </a:rPr>
-              <a:t>VS Code 首次连接与排错</a:t>
+              <a:t>VS Code 连接与编辑</a:t>
             </a:r>
           </a:p>
         </p:txBody>
@@ -5101,19 +5199,19 @@
           <p:cNvPr id="10" name="content-2">
             <a:extLst xmlns:a="http://schemas.openxmlformats.org/drawingml/2006/main">
               <a:ext uri="{FF2B5EF4-FFF2-40B4-BE49-F238E27FC236}">
-                <a16:creationId xmlns:a16="http://schemas.microsoft.com/office/drawing/2014/main" id="{5CCE61FE-A847-416B-9481-60FAAB30628B}"/>
-              </a:ext>
-            </a:extLst>
-          </p:cNvPr>
-          <p:cNvSpPr>
-            <a:spLocks xmlns:a="http://schemas.openxmlformats.org/drawingml/2006/main" noGrp="1"/>
-          </p:cNvSpPr>
-          <p:nvPr/>
-        </p:nvSpPr>
-        <p:spPr>
-          <a:xfrm xmlns:a="http://schemas.openxmlformats.org/drawingml/2006/main">
-            <a:off x="876300" y="1762125"/>
-            <a:ext cx="13335000" cy="571500"/>
+                <a16:creationId xmlns:a16="http://schemas.microsoft.com/office/drawing/2014/main" id="{609A6770-9ABC-4A99-908D-A58F5C357EAD}"/>
+              </a:ext>
+            </a:extLst>
+          </p:cNvPr>
+          <p:cNvSpPr>
+            <a:spLocks xmlns:a="http://schemas.openxmlformats.org/drawingml/2006/main" noGrp="1"/>
+          </p:cNvSpPr>
+          <p:nvPr/>
+        </p:nvSpPr>
+        <p:spPr>
+          <a:xfrm xmlns:a="http://schemas.openxmlformats.org/drawingml/2006/main">
+            <a:off x="876300" y="1857375"/>
+            <a:ext cx="13335000" cy="723900"/>
           </a:xfrm>
           <a:prstGeom xmlns:a="http://schemas.openxmlformats.org/drawingml/2006/main" prst="rect">
             <a:avLst/>
@@ -5149,7 +5247,7 @@
                 <a:ea typeface="Hiragino Sans GB"/>
                 <a:cs typeface="Hiragino Sans GB"/>
               </a:rPr>
-              <a:t>连接卡住时，查看“输出”中的 Remote - SSH 日志</a:t>
+              <a:t>1  在本地安装 Microsoft Remote - SSH 扩展</a:t>
             </a:r>
           </a:p>
         </p:txBody>
@@ -5159,19 +5257,19 @@
           <p:cNvPr id="11" name="content-3">
             <a:extLst xmlns:a="http://schemas.openxmlformats.org/drawingml/2006/main">
               <a:ext uri="{FF2B5EF4-FFF2-40B4-BE49-F238E27FC236}">
-                <a16:creationId xmlns:a16="http://schemas.microsoft.com/office/drawing/2014/main" id="{C137CDE4-D6A2-49AC-BC00-0A18974051AC}"/>
-              </a:ext>
-            </a:extLst>
-          </p:cNvPr>
-          <p:cNvSpPr>
-            <a:spLocks xmlns:a="http://schemas.openxmlformats.org/drawingml/2006/main" noGrp="1"/>
-          </p:cNvSpPr>
-          <p:nvPr/>
-        </p:nvSpPr>
-        <p:spPr>
-          <a:xfrm xmlns:a="http://schemas.openxmlformats.org/drawingml/2006/main">
-            <a:off x="876300" y="2619375"/>
-            <a:ext cx="13335000" cy="571500"/>
+                <a16:creationId xmlns:a16="http://schemas.microsoft.com/office/drawing/2014/main" id="{F6AC5F6B-C396-4397-AC0E-98B406E1A93E}"/>
+              </a:ext>
+            </a:extLst>
+          </p:cNvPr>
+          <p:cNvSpPr>
+            <a:spLocks xmlns:a="http://schemas.openxmlformats.org/drawingml/2006/main" noGrp="1"/>
+          </p:cNvSpPr>
+          <p:nvPr/>
+        </p:nvSpPr>
+        <p:spPr>
+          <a:xfrm xmlns:a="http://schemas.openxmlformats.org/drawingml/2006/main">
+            <a:off x="876300" y="2828925"/>
+            <a:ext cx="13335000" cy="723900"/>
           </a:xfrm>
           <a:prstGeom xmlns:a="http://schemas.openxmlformats.org/drawingml/2006/main" prst="rect">
             <a:avLst/>
@@ -5189,7 +5287,7 @@
           <a:p xmlns:a="http://schemas.openxmlformats.org/drawingml/2006/main">
             <a:pPr>
               <a:buNone/>
-              <a:defRPr sz="2400" b="0">
+              <a:defRPr sz="2550" b="0">
                 <a:solidFill>
                   <a:srgbClr val="EAF1EF"/>
                 </a:solidFill>
@@ -5199,7 +5297,7 @@
               </a:defRPr>
             </a:pPr>
             <a:r>
-              <a:rPr sz="2400" b="0">
+              <a:rPr sz="2550" b="0">
                 <a:solidFill>
                   <a:srgbClr val="EAF1EF"/>
                 </a:solidFill>
@@ -5207,7 +5305,7 @@
                 <a:ea typeface="Hiragino Sans GB"/>
                 <a:cs typeface="Hiragino Sans GB"/>
               </a:rPr>
-              <a:t>可在本地“用户设置(JSON)”中合并以下字段</a:t>
+              <a:t>2  按 F1，搜索 Remote-SSH: Connect to Host...</a:t>
             </a:r>
           </a:p>
         </p:txBody>
@@ -5217,19 +5315,19 @@
           <p:cNvPr id="12" name="content-4">
             <a:extLst xmlns:a="http://schemas.openxmlformats.org/drawingml/2006/main">
               <a:ext uri="{FF2B5EF4-FFF2-40B4-BE49-F238E27FC236}">
-                <a16:creationId xmlns:a16="http://schemas.microsoft.com/office/drawing/2014/main" id="{8B010679-3E7B-438D-B6F0-6C7495E2121F}"/>
-              </a:ext>
-            </a:extLst>
-          </p:cNvPr>
-          <p:cNvSpPr>
-            <a:spLocks xmlns:a="http://schemas.openxmlformats.org/drawingml/2006/main" noGrp="1"/>
-          </p:cNvSpPr>
-          <p:nvPr/>
-        </p:nvSpPr>
-        <p:spPr>
-          <a:xfrm xmlns:a="http://schemas.openxmlformats.org/drawingml/2006/main">
-            <a:off x="876300" y="3476625"/>
-            <a:ext cx="13335000" cy="571500"/>
+                <a16:creationId xmlns:a16="http://schemas.microsoft.com/office/drawing/2014/main" id="{5EA8E908-6F4A-451C-99F3-EAD1E96F7421}"/>
+              </a:ext>
+            </a:extLst>
+          </p:cNvPr>
+          <p:cNvSpPr>
+            <a:spLocks xmlns:a="http://schemas.openxmlformats.org/drawingml/2006/main" noGrp="1"/>
+          </p:cNvSpPr>
+          <p:nvPr/>
+        </p:nvSpPr>
+        <p:spPr>
+          <a:xfrm xmlns:a="http://schemas.openxmlformats.org/drawingml/2006/main">
+            <a:off x="876300" y="3800475"/>
+            <a:ext cx="13335000" cy="723900"/>
           </a:xfrm>
           <a:prstGeom xmlns:a="http://schemas.openxmlformats.org/drawingml/2006/main" prst="rect">
             <a:avLst/>
@@ -5247,25 +5345,25 @@
           <a:p xmlns:a="http://schemas.openxmlformats.org/drawingml/2006/main">
             <a:pPr>
               <a:buNone/>
-              <a:defRPr sz="2400" b="0">
-                <a:solidFill>
-                  <a:srgbClr val="B7EDDB"/>
-                </a:solidFill>
-                <a:latin typeface="Menlo"/>
-                <a:ea typeface="Menlo"/>
-                <a:cs typeface="Menlo"/>
-              </a:defRPr>
-            </a:pPr>
-            <a:r>
-              <a:rPr sz="2400" b="0">
-                <a:solidFill>
-                  <a:srgbClr val="B7EDDB"/>
-                </a:solidFill>
-                <a:latin typeface="Menlo"/>
-                <a:ea typeface="Menlo"/>
-                <a:cs typeface="Menlo"/>
-              </a:rPr>
-              <a:t>{</a:t>
+              <a:defRPr sz="2550" b="0">
+                <a:solidFill>
+                  <a:srgbClr val="EAF1EF"/>
+                </a:solidFill>
+                <a:latin typeface="Hiragino Sans GB"/>
+                <a:ea typeface="Hiragino Sans GB"/>
+                <a:cs typeface="Hiragino Sans GB"/>
+              </a:defRPr>
+            </a:pPr>
+            <a:r>
+              <a:rPr sz="2550" b="0">
+                <a:solidFill>
+                  <a:srgbClr val="EAF1EF"/>
+                </a:solidFill>
+                <a:latin typeface="Hiragino Sans GB"/>
+                <a:ea typeface="Hiragino Sans GB"/>
+                <a:cs typeface="Hiragino Sans GB"/>
+              </a:rPr>
+              <a:t>3  选择 jiaowosuan，远端系统选择 Linux，完成认证</a:t>
             </a:r>
           </a:p>
         </p:txBody>
@@ -5275,19 +5373,19 @@
           <p:cNvPr id="13" name="content-5">
             <a:extLst xmlns:a="http://schemas.openxmlformats.org/drawingml/2006/main">
               <a:ext uri="{FF2B5EF4-FFF2-40B4-BE49-F238E27FC236}">
-                <a16:creationId xmlns:a16="http://schemas.microsoft.com/office/drawing/2014/main" id="{E5703089-D1CE-4E4B-B6D2-9455DFE52B7A}"/>
-              </a:ext>
-            </a:extLst>
-          </p:cNvPr>
-          <p:cNvSpPr>
-            <a:spLocks xmlns:a="http://schemas.openxmlformats.org/drawingml/2006/main" noGrp="1"/>
-          </p:cNvSpPr>
-          <p:nvPr/>
-        </p:nvSpPr>
-        <p:spPr>
-          <a:xfrm xmlns:a="http://schemas.openxmlformats.org/drawingml/2006/main">
-            <a:off x="876300" y="4048125"/>
-            <a:ext cx="13335000" cy="571500"/>
+                <a16:creationId xmlns:a16="http://schemas.microsoft.com/office/drawing/2014/main" id="{E4B232E0-1C31-447C-9365-51793F3457C1}"/>
+              </a:ext>
+            </a:extLst>
+          </p:cNvPr>
+          <p:cNvSpPr>
+            <a:spLocks xmlns:a="http://schemas.openxmlformats.org/drawingml/2006/main" noGrp="1"/>
+          </p:cNvSpPr>
+          <p:nvPr/>
+        </p:nvSpPr>
+        <p:spPr>
+          <a:xfrm xmlns:a="http://schemas.openxmlformats.org/drawingml/2006/main">
+            <a:off x="876300" y="4772025"/>
+            <a:ext cx="13335000" cy="723900"/>
           </a:xfrm>
           <a:prstGeom xmlns:a="http://schemas.openxmlformats.org/drawingml/2006/main" prst="rect">
             <a:avLst/>
@@ -5305,25 +5403,25 @@
           <a:p xmlns:a="http://schemas.openxmlformats.org/drawingml/2006/main">
             <a:pPr>
               <a:buNone/>
-              <a:defRPr sz="2400" b="0">
-                <a:solidFill>
-                  <a:srgbClr val="B7EDDB"/>
-                </a:solidFill>
-                <a:latin typeface="Menlo"/>
-                <a:ea typeface="Menlo"/>
-                <a:cs typeface="Menlo"/>
-              </a:defRPr>
-            </a:pPr>
-            <a:r>
-              <a:rPr sz="2400" b="0">
-                <a:solidFill>
-                  <a:srgbClr val="B7EDDB"/>
-                </a:solidFill>
-                <a:latin typeface="Menlo"/>
-                <a:ea typeface="Menlo"/>
-                <a:cs typeface="Menlo"/>
-              </a:rPr>
-              <a:t>  "remote.SSH.showLoginTerminal": true,</a:t>
+              <a:defRPr sz="2550" b="0">
+                <a:solidFill>
+                  <a:srgbClr val="EAF1EF"/>
+                </a:solidFill>
+                <a:latin typeface="Hiragino Sans GB"/>
+                <a:ea typeface="Hiragino Sans GB"/>
+                <a:cs typeface="Hiragino Sans GB"/>
+              </a:defRPr>
+            </a:pPr>
+            <a:r>
+              <a:rPr sz="2550" b="0">
+                <a:solidFill>
+                  <a:srgbClr val="EAF1EF"/>
+                </a:solidFill>
+                <a:latin typeface="Hiragino Sans GB"/>
+                <a:ea typeface="Hiragino Sans GB"/>
+                <a:cs typeface="Hiragino Sans GB"/>
+              </a:rPr>
+              <a:t>4  打开远端 ~/course-labs，确认左下角的 SSH 主机名</a:t>
             </a:r>
           </a:p>
         </p:txBody>
@@ -5333,19 +5431,19 @@
           <p:cNvPr id="14" name="content-6">
             <a:extLst xmlns:a="http://schemas.openxmlformats.org/drawingml/2006/main">
               <a:ext uri="{FF2B5EF4-FFF2-40B4-BE49-F238E27FC236}">
-                <a16:creationId xmlns:a16="http://schemas.microsoft.com/office/drawing/2014/main" id="{EAFF8F4D-C17D-436D-AEEA-5FBF852D5EC3}"/>
-              </a:ext>
-            </a:extLst>
-          </p:cNvPr>
-          <p:cNvSpPr>
-            <a:spLocks xmlns:a="http://schemas.openxmlformats.org/drawingml/2006/main" noGrp="1"/>
-          </p:cNvSpPr>
-          <p:nvPr/>
-        </p:nvSpPr>
-        <p:spPr>
-          <a:xfrm xmlns:a="http://schemas.openxmlformats.org/drawingml/2006/main">
-            <a:off x="876300" y="4619625"/>
-            <a:ext cx="13335000" cy="571500"/>
+                <a16:creationId xmlns:a16="http://schemas.microsoft.com/office/drawing/2014/main" id="{E3C73381-BF7D-462B-A43C-BB822C080341}"/>
+              </a:ext>
+            </a:extLst>
+          </p:cNvPr>
+          <p:cNvSpPr>
+            <a:spLocks xmlns:a="http://schemas.openxmlformats.org/drawingml/2006/main" noGrp="1"/>
+          </p:cNvSpPr>
+          <p:nvPr/>
+        </p:nvSpPr>
+        <p:spPr>
+          <a:xfrm xmlns:a="http://schemas.openxmlformats.org/drawingml/2006/main">
+            <a:off x="876300" y="5743575"/>
+            <a:ext cx="13335000" cy="723900"/>
           </a:xfrm>
           <a:prstGeom xmlns:a="http://schemas.openxmlformats.org/drawingml/2006/main" prst="rect">
             <a:avLst/>
@@ -5363,25 +5461,25 @@
           <a:p xmlns:a="http://schemas.openxmlformats.org/drawingml/2006/main">
             <a:pPr>
               <a:buNone/>
-              <a:defRPr sz="2400" b="0">
-                <a:solidFill>
-                  <a:srgbClr val="B7EDDB"/>
-                </a:solidFill>
-                <a:latin typeface="Menlo"/>
-                <a:ea typeface="Menlo"/>
-                <a:cs typeface="Menlo"/>
-              </a:defRPr>
-            </a:pPr>
-            <a:r>
-              <a:rPr sz="2400" b="0">
-                <a:solidFill>
-                  <a:srgbClr val="B7EDDB"/>
-                </a:solidFill>
-                <a:latin typeface="Menlo"/>
-                <a:ea typeface="Menlo"/>
-                <a:cs typeface="Menlo"/>
-              </a:rPr>
-              <a:t>  "remote.SSH.localServerDownload": "always"</a:t>
+              <a:defRPr sz="2550" b="0">
+                <a:solidFill>
+                  <a:srgbClr val="EAF1EF"/>
+                </a:solidFill>
+                <a:latin typeface="Hiragino Sans GB"/>
+                <a:ea typeface="Hiragino Sans GB"/>
+                <a:cs typeface="Hiragino Sans GB"/>
+              </a:defRPr>
+            </a:pPr>
+            <a:r>
+              <a:rPr sz="2550" b="0">
+                <a:solidFill>
+                  <a:srgbClr val="EAF1EF"/>
+                </a:solidFill>
+                <a:latin typeface="Hiragino Sans GB"/>
+                <a:ea typeface="Hiragino Sans GB"/>
+                <a:cs typeface="Hiragino Sans GB"/>
+              </a:rPr>
+              <a:t>5  保存源码后，在集成终端先申请计算资源，再编译</a:t>
             </a:r>
           </a:p>
         </p:txBody>
@@ -5391,123 +5489,7 @@
           <p:cNvPr id="15" name="content-7">
             <a:extLst xmlns:a="http://schemas.openxmlformats.org/drawingml/2006/main">
               <a:ext uri="{FF2B5EF4-FFF2-40B4-BE49-F238E27FC236}">
-                <a16:creationId xmlns:a16="http://schemas.microsoft.com/office/drawing/2014/main" id="{4824C8D1-448A-4D18-A24C-4E4879B7FC9E}"/>
-              </a:ext>
-            </a:extLst>
-          </p:cNvPr>
-          <p:cNvSpPr>
-            <a:spLocks xmlns:a="http://schemas.openxmlformats.org/drawingml/2006/main" noGrp="1"/>
-          </p:cNvSpPr>
-          <p:nvPr/>
-        </p:nvSpPr>
-        <p:spPr>
-          <a:xfrm xmlns:a="http://schemas.openxmlformats.org/drawingml/2006/main">
-            <a:off x="876300" y="5191125"/>
-            <a:ext cx="13335000" cy="571500"/>
-          </a:xfrm>
-          <a:prstGeom xmlns:a="http://schemas.openxmlformats.org/drawingml/2006/main" prst="rect">
-            <a:avLst/>
-          </a:prstGeom>
-          <a:noFill xmlns:a="http://schemas.openxmlformats.org/drawingml/2006/main"/>
-          <a:ln xmlns:a="http://schemas.openxmlformats.org/drawingml/2006/main" w="0">
-            <a:noFill/>
-          </a:ln>
-        </p:spPr>
-        <p:txBody>
-          <a:bodyPr xmlns:a="http://schemas.openxmlformats.org/drawingml/2006/main" wrap="none">
-            <a:noAutofit/>
-          </a:bodyPr>
-          <a:lstStyle xmlns:a="http://schemas.openxmlformats.org/drawingml/2006/main"/>
-          <a:p xmlns:a="http://schemas.openxmlformats.org/drawingml/2006/main">
-            <a:pPr>
-              <a:buNone/>
-              <a:defRPr sz="2400" b="0">
-                <a:solidFill>
-                  <a:srgbClr val="B7EDDB"/>
-                </a:solidFill>
-                <a:latin typeface="Menlo"/>
-                <a:ea typeface="Menlo"/>
-                <a:cs typeface="Menlo"/>
-              </a:defRPr>
-            </a:pPr>
-            <a:r>
-              <a:rPr sz="2400" b="0">
-                <a:solidFill>
-                  <a:srgbClr val="B7EDDB"/>
-                </a:solidFill>
-                <a:latin typeface="Menlo"/>
-                <a:ea typeface="Menlo"/>
-                <a:cs typeface="Menlo"/>
-              </a:rPr>
-              <a:t>}</a:t>
-            </a:r>
-          </a:p>
-        </p:txBody>
-      </p:sp>
-      <p:sp>
-        <p:nvSpPr>
-          <p:cNvPr id="16" name="content-8">
-            <a:extLst xmlns:a="http://schemas.openxmlformats.org/drawingml/2006/main">
-              <a:ext uri="{FF2B5EF4-FFF2-40B4-BE49-F238E27FC236}">
-                <a16:creationId xmlns:a16="http://schemas.microsoft.com/office/drawing/2014/main" id="{4F7B3432-35A0-40A7-A3D6-D83F099AF5E4}"/>
-              </a:ext>
-            </a:extLst>
-          </p:cNvPr>
-          <p:cNvSpPr>
-            <a:spLocks xmlns:a="http://schemas.openxmlformats.org/drawingml/2006/main" noGrp="1"/>
-          </p:cNvSpPr>
-          <p:nvPr/>
-        </p:nvSpPr>
-        <p:spPr>
-          <a:xfrm xmlns:a="http://schemas.openxmlformats.org/drawingml/2006/main">
-            <a:off x="876300" y="6238875"/>
-            <a:ext cx="13335000" cy="571500"/>
-          </a:xfrm>
-          <a:prstGeom xmlns:a="http://schemas.openxmlformats.org/drawingml/2006/main" prst="rect">
-            <a:avLst/>
-          </a:prstGeom>
-          <a:noFill xmlns:a="http://schemas.openxmlformats.org/drawingml/2006/main"/>
-          <a:ln xmlns:a="http://schemas.openxmlformats.org/drawingml/2006/main" w="0">
-            <a:noFill/>
-          </a:ln>
-        </p:spPr>
-        <p:txBody>
-          <a:bodyPr xmlns:a="http://schemas.openxmlformats.org/drawingml/2006/main" wrap="none">
-            <a:noAutofit/>
-          </a:bodyPr>
-          <a:lstStyle xmlns:a="http://schemas.openxmlformats.org/drawingml/2006/main"/>
-          <a:p xmlns:a="http://schemas.openxmlformats.org/drawingml/2006/main">
-            <a:pPr>
-              <a:buNone/>
-              <a:defRPr sz="2250" b="0">
-                <a:solidFill>
-                  <a:srgbClr val="EAF1EF"/>
-                </a:solidFill>
-                <a:latin typeface="Hiragino Sans GB"/>
-                <a:ea typeface="Hiragino Sans GB"/>
-                <a:cs typeface="Hiragino Sans GB"/>
-              </a:defRPr>
-            </a:pPr>
-            <a:r>
-              <a:rPr sz="2250" b="0">
-                <a:solidFill>
-                  <a:srgbClr val="EAF1EF"/>
-                </a:solidFill>
-                <a:latin typeface="Hiragino Sans GB"/>
-                <a:ea typeface="Hiragino Sans GB"/>
-                <a:cs typeface="Hiragino Sans GB"/>
-              </a:rPr>
-              <a:t>显示登录提示；远端下载失败时，由本地下载 Server 再传入</a:t>
-            </a:r>
-          </a:p>
-        </p:txBody>
-      </p:sp>
-      <p:sp>
-        <p:nvSpPr>
-          <p:cNvPr id="17" name="content-9">
-            <a:extLst xmlns:a="http://schemas.openxmlformats.org/drawingml/2006/main">
-              <a:ext uri="{FF2B5EF4-FFF2-40B4-BE49-F238E27FC236}">
-                <a16:creationId xmlns:a16="http://schemas.microsoft.com/office/drawing/2014/main" id="{8D169129-2695-4378-85CA-25A48C8AE42F}"/>
+                <a16:creationId xmlns:a16="http://schemas.microsoft.com/office/drawing/2014/main" id="{7BF07F11-E49B-460E-98AA-7ECD07BD97E7}"/>
               </a:ext>
             </a:extLst>
           </p:cNvPr>
@@ -5555,7 +5537,7 @@
                 <a:ea typeface="Hiragino Sans GB"/>
                 <a:cs typeface="Hiragino Sans GB"/>
               </a:rPr>
-              <a:t>本地需要能访问微软下载服务。SSH config 与 VS Code 用户设置均独立于仓库。</a:t>
+              <a:t>使用期间保持一个普通 ssh jiaowosuan 会话打开，满足平台的活跃会话要求。</a:t>
             </a:r>
           </a:p>
         </p:txBody>
@@ -5591,10 +5573,10 @@
       </p:grpSpPr>
       <p:sp>
         <p:nvSpPr>
-          <p:cNvPr id="13" name="">
-            <a:extLst xmlns:a="http://schemas.openxmlformats.org/drawingml/2006/main">
-              <a:ext uri="{FF2B5EF4-FFF2-40B4-BE49-F238E27FC236}">
-                <a16:creationId xmlns:a16="http://schemas.microsoft.com/office/drawing/2014/main" id="{F72D8CD2-C378-452E-BD65-A32051B5A5F1}"/>
+          <p:cNvPr id="9" name="">
+            <a:extLst xmlns:a="http://schemas.openxmlformats.org/drawingml/2006/main">
+              <a:ext uri="{FF2B5EF4-FFF2-40B4-BE49-F238E27FC236}">
+                <a16:creationId xmlns:a16="http://schemas.microsoft.com/office/drawing/2014/main" id="{974B2865-DC00-4E59-9F3A-640A7913DC3C}"/>
               </a:ext>
             </a:extLst>
           </p:cNvPr>
@@ -5642,7 +5624,7 @@
                 <a:ea typeface="Hiragino Sans GB"/>
                 <a:cs typeface="Hiragino Sans GB"/>
               </a:rPr>
-              <a:t>从云盘获取并上传源码</a:t>
+              <a:t>VS Code 首次连接与排错</a:t>
             </a:r>
           </a:p>
         </p:txBody>
@@ -5652,7 +5634,7 @@
           <p:cNvPr id="2" name="">
             <a:extLst xmlns:a="http://schemas.openxmlformats.org/drawingml/2006/main">
               <a:ext uri="{FF2B5EF4-FFF2-40B4-BE49-F238E27FC236}">
-                <a16:creationId xmlns:a16="http://schemas.microsoft.com/office/drawing/2014/main" id="{C465AA1C-7538-452B-A075-B36D60CDEA34}"/>
+                <a16:creationId xmlns:a16="http://schemas.microsoft.com/office/drawing/2014/main" id="{AFA67C7E-1DCE-457B-9A22-9FD38D176CF9}"/>
               </a:ext>
             </a:extLst>
           </p:cNvPr>
@@ -5707,21 +5689,21 @@
       </p:sp>
       <p:sp>
         <p:nvSpPr>
-          <p:cNvPr id="14" name="content-2">
-            <a:extLst xmlns:a="http://schemas.openxmlformats.org/drawingml/2006/main">
-              <a:ext uri="{FF2B5EF4-FFF2-40B4-BE49-F238E27FC236}">
-                <a16:creationId xmlns:a16="http://schemas.microsoft.com/office/drawing/2014/main" id="{3CD37B2F-FD3B-43C0-AF11-E2F282B23F19}"/>
-              </a:ext>
-            </a:extLst>
-          </p:cNvPr>
-          <p:cNvSpPr>
-            <a:spLocks xmlns:a="http://schemas.openxmlformats.org/drawingml/2006/main" noGrp="1"/>
-          </p:cNvSpPr>
-          <p:nvPr/>
-        </p:nvSpPr>
-        <p:spPr>
-          <a:xfrm xmlns:a="http://schemas.openxmlformats.org/drawingml/2006/main">
-            <a:off x="876300" y="1714500"/>
+          <p:cNvPr id="10" name="content-2">
+            <a:extLst xmlns:a="http://schemas.openxmlformats.org/drawingml/2006/main">
+              <a:ext uri="{FF2B5EF4-FFF2-40B4-BE49-F238E27FC236}">
+                <a16:creationId xmlns:a16="http://schemas.microsoft.com/office/drawing/2014/main" id="{5CCE61FE-A847-416B-9481-60FAAB30628B}"/>
+              </a:ext>
+            </a:extLst>
+          </p:cNvPr>
+          <p:cNvSpPr>
+            <a:spLocks xmlns:a="http://schemas.openxmlformats.org/drawingml/2006/main" noGrp="1"/>
+          </p:cNvSpPr>
+          <p:nvPr/>
+        </p:nvSpPr>
+        <p:spPr>
+          <a:xfrm xmlns:a="http://schemas.openxmlformats.org/drawingml/2006/main">
+            <a:off x="876300" y="1762125"/>
             <a:ext cx="13335000" cy="571500"/>
           </a:xfrm>
           <a:prstGeom xmlns:a="http://schemas.openxmlformats.org/drawingml/2006/main" prst="rect">
@@ -5740,7 +5722,7 @@
           <a:p xmlns:a="http://schemas.openxmlformats.org/drawingml/2006/main">
             <a:pPr>
               <a:buNone/>
-              <a:defRPr sz="2325" b="0">
+              <a:defRPr sz="2550" b="0">
                 <a:solidFill>
                   <a:srgbClr val="EAF1EF"/>
                 </a:solidFill>
@@ -5750,7 +5732,7 @@
               </a:defRPr>
             </a:pPr>
             <a:r>
-              <a:rPr sz="2325" b="0">
+              <a:rPr sz="2550" b="0">
                 <a:solidFill>
                   <a:srgbClr val="EAF1EF"/>
                 </a:solidFill>
@@ -5758,28 +5740,28 @@
                 <a:ea typeface="Hiragino Sans GB"/>
                 <a:cs typeface="Hiragino Sans GB"/>
               </a:rPr>
-              <a:t>浏览器下载教师发布的学生包，解压后将根目录命名为 course-labs</a:t>
-            </a:r>
-          </a:p>
-        </p:txBody>
-      </p:sp>
-      <p:sp>
-        <p:nvSpPr>
-          <p:cNvPr id="15" name="content-3">
-            <a:extLst xmlns:a="http://schemas.openxmlformats.org/drawingml/2006/main">
-              <a:ext uri="{FF2B5EF4-FFF2-40B4-BE49-F238E27FC236}">
-                <a16:creationId xmlns:a16="http://schemas.microsoft.com/office/drawing/2014/main" id="{D62A69DB-A711-41DD-99E3-FB2F155CD279}"/>
-              </a:ext>
-            </a:extLst>
-          </p:cNvPr>
-          <p:cNvSpPr>
-            <a:spLocks xmlns:a="http://schemas.openxmlformats.org/drawingml/2006/main" noGrp="1"/>
-          </p:cNvSpPr>
-          <p:nvPr/>
-        </p:nvSpPr>
-        <p:spPr>
-          <a:xfrm xmlns:a="http://schemas.openxmlformats.org/drawingml/2006/main">
-            <a:off x="876300" y="2667000"/>
+              <a:t>连接卡住时，查看“输出”中的 Remote - SSH 日志</a:t>
+            </a:r>
+          </a:p>
+        </p:txBody>
+      </p:sp>
+      <p:sp>
+        <p:nvSpPr>
+          <p:cNvPr id="11" name="content-3">
+            <a:extLst xmlns:a="http://schemas.openxmlformats.org/drawingml/2006/main">
+              <a:ext uri="{FF2B5EF4-FFF2-40B4-BE49-F238E27FC236}">
+                <a16:creationId xmlns:a16="http://schemas.microsoft.com/office/drawing/2014/main" id="{C137CDE4-D6A2-49AC-BC00-0A18974051AC}"/>
+              </a:ext>
+            </a:extLst>
+          </p:cNvPr>
+          <p:cNvSpPr>
+            <a:spLocks xmlns:a="http://schemas.openxmlformats.org/drawingml/2006/main" noGrp="1"/>
+          </p:cNvSpPr>
+          <p:nvPr/>
+        </p:nvSpPr>
+        <p:spPr>
+          <a:xfrm xmlns:a="http://schemas.openxmlformats.org/drawingml/2006/main">
+            <a:off x="876300" y="2619375"/>
             <a:ext cx="13335000" cy="571500"/>
           </a:xfrm>
           <a:prstGeom xmlns:a="http://schemas.openxmlformats.org/drawingml/2006/main" prst="rect">
@@ -5798,6 +5780,296 @@
           <a:p xmlns:a="http://schemas.openxmlformats.org/drawingml/2006/main">
             <a:pPr>
               <a:buNone/>
+              <a:defRPr sz="2400" b="0">
+                <a:solidFill>
+                  <a:srgbClr val="EAF1EF"/>
+                </a:solidFill>
+                <a:latin typeface="Hiragino Sans GB"/>
+                <a:ea typeface="Hiragino Sans GB"/>
+                <a:cs typeface="Hiragino Sans GB"/>
+              </a:defRPr>
+            </a:pPr>
+            <a:r>
+              <a:rPr sz="2400" b="0">
+                <a:solidFill>
+                  <a:srgbClr val="EAF1EF"/>
+                </a:solidFill>
+                <a:latin typeface="Hiragino Sans GB"/>
+                <a:ea typeface="Hiragino Sans GB"/>
+                <a:cs typeface="Hiragino Sans GB"/>
+              </a:rPr>
+              <a:t>可在本地“用户设置(JSON)”中合并以下字段</a:t>
+            </a:r>
+          </a:p>
+        </p:txBody>
+      </p:sp>
+      <p:sp>
+        <p:nvSpPr>
+          <p:cNvPr id="12" name="content-4">
+            <a:extLst xmlns:a="http://schemas.openxmlformats.org/drawingml/2006/main">
+              <a:ext uri="{FF2B5EF4-FFF2-40B4-BE49-F238E27FC236}">
+                <a16:creationId xmlns:a16="http://schemas.microsoft.com/office/drawing/2014/main" id="{8B010679-3E7B-438D-B6F0-6C7495E2121F}"/>
+              </a:ext>
+            </a:extLst>
+          </p:cNvPr>
+          <p:cNvSpPr>
+            <a:spLocks xmlns:a="http://schemas.openxmlformats.org/drawingml/2006/main" noGrp="1"/>
+          </p:cNvSpPr>
+          <p:nvPr/>
+        </p:nvSpPr>
+        <p:spPr>
+          <a:xfrm xmlns:a="http://schemas.openxmlformats.org/drawingml/2006/main">
+            <a:off x="876300" y="3476625"/>
+            <a:ext cx="13335000" cy="571500"/>
+          </a:xfrm>
+          <a:prstGeom xmlns:a="http://schemas.openxmlformats.org/drawingml/2006/main" prst="rect">
+            <a:avLst/>
+          </a:prstGeom>
+          <a:noFill xmlns:a="http://schemas.openxmlformats.org/drawingml/2006/main"/>
+          <a:ln xmlns:a="http://schemas.openxmlformats.org/drawingml/2006/main" w="0">
+            <a:noFill/>
+          </a:ln>
+        </p:spPr>
+        <p:txBody>
+          <a:bodyPr xmlns:a="http://schemas.openxmlformats.org/drawingml/2006/main" wrap="none">
+            <a:noAutofit/>
+          </a:bodyPr>
+          <a:lstStyle xmlns:a="http://schemas.openxmlformats.org/drawingml/2006/main"/>
+          <a:p xmlns:a="http://schemas.openxmlformats.org/drawingml/2006/main">
+            <a:pPr>
+              <a:buNone/>
+              <a:defRPr sz="2400" b="0">
+                <a:solidFill>
+                  <a:srgbClr val="B7EDDB"/>
+                </a:solidFill>
+                <a:latin typeface="Menlo"/>
+                <a:ea typeface="Menlo"/>
+                <a:cs typeface="Menlo"/>
+              </a:defRPr>
+            </a:pPr>
+            <a:r>
+              <a:rPr sz="2400" b="0">
+                <a:solidFill>
+                  <a:srgbClr val="B7EDDB"/>
+                </a:solidFill>
+                <a:latin typeface="Menlo"/>
+                <a:ea typeface="Menlo"/>
+                <a:cs typeface="Menlo"/>
+              </a:rPr>
+              <a:t>{</a:t>
+            </a:r>
+          </a:p>
+        </p:txBody>
+      </p:sp>
+      <p:sp>
+        <p:nvSpPr>
+          <p:cNvPr id="13" name="content-5">
+            <a:extLst xmlns:a="http://schemas.openxmlformats.org/drawingml/2006/main">
+              <a:ext uri="{FF2B5EF4-FFF2-40B4-BE49-F238E27FC236}">
+                <a16:creationId xmlns:a16="http://schemas.microsoft.com/office/drawing/2014/main" id="{E5703089-D1CE-4E4B-B6D2-9455DFE52B7A}"/>
+              </a:ext>
+            </a:extLst>
+          </p:cNvPr>
+          <p:cNvSpPr>
+            <a:spLocks xmlns:a="http://schemas.openxmlformats.org/drawingml/2006/main" noGrp="1"/>
+          </p:cNvSpPr>
+          <p:nvPr/>
+        </p:nvSpPr>
+        <p:spPr>
+          <a:xfrm xmlns:a="http://schemas.openxmlformats.org/drawingml/2006/main">
+            <a:off x="876300" y="4048125"/>
+            <a:ext cx="13335000" cy="571500"/>
+          </a:xfrm>
+          <a:prstGeom xmlns:a="http://schemas.openxmlformats.org/drawingml/2006/main" prst="rect">
+            <a:avLst/>
+          </a:prstGeom>
+          <a:noFill xmlns:a="http://schemas.openxmlformats.org/drawingml/2006/main"/>
+          <a:ln xmlns:a="http://schemas.openxmlformats.org/drawingml/2006/main" w="0">
+            <a:noFill/>
+          </a:ln>
+        </p:spPr>
+        <p:txBody>
+          <a:bodyPr xmlns:a="http://schemas.openxmlformats.org/drawingml/2006/main" wrap="none">
+            <a:noAutofit/>
+          </a:bodyPr>
+          <a:lstStyle xmlns:a="http://schemas.openxmlformats.org/drawingml/2006/main"/>
+          <a:p xmlns:a="http://schemas.openxmlformats.org/drawingml/2006/main">
+            <a:pPr>
+              <a:buNone/>
+              <a:defRPr sz="2400" b="0">
+                <a:solidFill>
+                  <a:srgbClr val="B7EDDB"/>
+                </a:solidFill>
+                <a:latin typeface="Menlo"/>
+                <a:ea typeface="Menlo"/>
+                <a:cs typeface="Menlo"/>
+              </a:defRPr>
+            </a:pPr>
+            <a:r>
+              <a:rPr sz="2400" b="0">
+                <a:solidFill>
+                  <a:srgbClr val="B7EDDB"/>
+                </a:solidFill>
+                <a:latin typeface="Menlo"/>
+                <a:ea typeface="Menlo"/>
+                <a:cs typeface="Menlo"/>
+              </a:rPr>
+              <a:t>  "remote.SSH.showLoginTerminal": true,</a:t>
+            </a:r>
+          </a:p>
+        </p:txBody>
+      </p:sp>
+      <p:sp>
+        <p:nvSpPr>
+          <p:cNvPr id="14" name="content-6">
+            <a:extLst xmlns:a="http://schemas.openxmlformats.org/drawingml/2006/main">
+              <a:ext uri="{FF2B5EF4-FFF2-40B4-BE49-F238E27FC236}">
+                <a16:creationId xmlns:a16="http://schemas.microsoft.com/office/drawing/2014/main" id="{EAFF8F4D-C17D-436D-AEEA-5FBF852D5EC3}"/>
+              </a:ext>
+            </a:extLst>
+          </p:cNvPr>
+          <p:cNvSpPr>
+            <a:spLocks xmlns:a="http://schemas.openxmlformats.org/drawingml/2006/main" noGrp="1"/>
+          </p:cNvSpPr>
+          <p:nvPr/>
+        </p:nvSpPr>
+        <p:spPr>
+          <a:xfrm xmlns:a="http://schemas.openxmlformats.org/drawingml/2006/main">
+            <a:off x="876300" y="4619625"/>
+            <a:ext cx="13335000" cy="571500"/>
+          </a:xfrm>
+          <a:prstGeom xmlns:a="http://schemas.openxmlformats.org/drawingml/2006/main" prst="rect">
+            <a:avLst/>
+          </a:prstGeom>
+          <a:noFill xmlns:a="http://schemas.openxmlformats.org/drawingml/2006/main"/>
+          <a:ln xmlns:a="http://schemas.openxmlformats.org/drawingml/2006/main" w="0">
+            <a:noFill/>
+          </a:ln>
+        </p:spPr>
+        <p:txBody>
+          <a:bodyPr xmlns:a="http://schemas.openxmlformats.org/drawingml/2006/main" wrap="none">
+            <a:noAutofit/>
+          </a:bodyPr>
+          <a:lstStyle xmlns:a="http://schemas.openxmlformats.org/drawingml/2006/main"/>
+          <a:p xmlns:a="http://schemas.openxmlformats.org/drawingml/2006/main">
+            <a:pPr>
+              <a:buNone/>
+              <a:defRPr sz="2400" b="0">
+                <a:solidFill>
+                  <a:srgbClr val="B7EDDB"/>
+                </a:solidFill>
+                <a:latin typeface="Menlo"/>
+                <a:ea typeface="Menlo"/>
+                <a:cs typeface="Menlo"/>
+              </a:defRPr>
+            </a:pPr>
+            <a:r>
+              <a:rPr sz="2400" b="0">
+                <a:solidFill>
+                  <a:srgbClr val="B7EDDB"/>
+                </a:solidFill>
+                <a:latin typeface="Menlo"/>
+                <a:ea typeface="Menlo"/>
+                <a:cs typeface="Menlo"/>
+              </a:rPr>
+              <a:t>  "remote.SSH.localServerDownload": "always"</a:t>
+            </a:r>
+          </a:p>
+        </p:txBody>
+      </p:sp>
+      <p:sp>
+        <p:nvSpPr>
+          <p:cNvPr id="15" name="content-7">
+            <a:extLst xmlns:a="http://schemas.openxmlformats.org/drawingml/2006/main">
+              <a:ext uri="{FF2B5EF4-FFF2-40B4-BE49-F238E27FC236}">
+                <a16:creationId xmlns:a16="http://schemas.microsoft.com/office/drawing/2014/main" id="{4824C8D1-448A-4D18-A24C-4E4879B7FC9E}"/>
+              </a:ext>
+            </a:extLst>
+          </p:cNvPr>
+          <p:cNvSpPr>
+            <a:spLocks xmlns:a="http://schemas.openxmlformats.org/drawingml/2006/main" noGrp="1"/>
+          </p:cNvSpPr>
+          <p:nvPr/>
+        </p:nvSpPr>
+        <p:spPr>
+          <a:xfrm xmlns:a="http://schemas.openxmlformats.org/drawingml/2006/main">
+            <a:off x="876300" y="5191125"/>
+            <a:ext cx="13335000" cy="571500"/>
+          </a:xfrm>
+          <a:prstGeom xmlns:a="http://schemas.openxmlformats.org/drawingml/2006/main" prst="rect">
+            <a:avLst/>
+          </a:prstGeom>
+          <a:noFill xmlns:a="http://schemas.openxmlformats.org/drawingml/2006/main"/>
+          <a:ln xmlns:a="http://schemas.openxmlformats.org/drawingml/2006/main" w="0">
+            <a:noFill/>
+          </a:ln>
+        </p:spPr>
+        <p:txBody>
+          <a:bodyPr xmlns:a="http://schemas.openxmlformats.org/drawingml/2006/main" wrap="none">
+            <a:noAutofit/>
+          </a:bodyPr>
+          <a:lstStyle xmlns:a="http://schemas.openxmlformats.org/drawingml/2006/main"/>
+          <a:p xmlns:a="http://schemas.openxmlformats.org/drawingml/2006/main">
+            <a:pPr>
+              <a:buNone/>
+              <a:defRPr sz="2400" b="0">
+                <a:solidFill>
+                  <a:srgbClr val="B7EDDB"/>
+                </a:solidFill>
+                <a:latin typeface="Menlo"/>
+                <a:ea typeface="Menlo"/>
+                <a:cs typeface="Menlo"/>
+              </a:defRPr>
+            </a:pPr>
+            <a:r>
+              <a:rPr sz="2400" b="0">
+                <a:solidFill>
+                  <a:srgbClr val="B7EDDB"/>
+                </a:solidFill>
+                <a:latin typeface="Menlo"/>
+                <a:ea typeface="Menlo"/>
+                <a:cs typeface="Menlo"/>
+              </a:rPr>
+              <a:t>}</a:t>
+            </a:r>
+          </a:p>
+        </p:txBody>
+      </p:sp>
+      <p:sp>
+        <p:nvSpPr>
+          <p:cNvPr id="16" name="content-8">
+            <a:extLst xmlns:a="http://schemas.openxmlformats.org/drawingml/2006/main">
+              <a:ext uri="{FF2B5EF4-FFF2-40B4-BE49-F238E27FC236}">
+                <a16:creationId xmlns:a16="http://schemas.microsoft.com/office/drawing/2014/main" id="{4F7B3432-35A0-40A7-A3D6-D83F099AF5E4}"/>
+              </a:ext>
+            </a:extLst>
+          </p:cNvPr>
+          <p:cNvSpPr>
+            <a:spLocks xmlns:a="http://schemas.openxmlformats.org/drawingml/2006/main" noGrp="1"/>
+          </p:cNvSpPr>
+          <p:nvPr/>
+        </p:nvSpPr>
+        <p:spPr>
+          <a:xfrm xmlns:a="http://schemas.openxmlformats.org/drawingml/2006/main">
+            <a:off x="876300" y="6238875"/>
+            <a:ext cx="13335000" cy="571500"/>
+          </a:xfrm>
+          <a:prstGeom xmlns:a="http://schemas.openxmlformats.org/drawingml/2006/main" prst="rect">
+            <a:avLst/>
+          </a:prstGeom>
+          <a:noFill xmlns:a="http://schemas.openxmlformats.org/drawingml/2006/main"/>
+          <a:ln xmlns:a="http://schemas.openxmlformats.org/drawingml/2006/main" w="0">
+            <a:noFill/>
+          </a:ln>
+        </p:spPr>
+        <p:txBody>
+          <a:bodyPr xmlns:a="http://schemas.openxmlformats.org/drawingml/2006/main" wrap="none">
+            <a:noAutofit/>
+          </a:bodyPr>
+          <a:lstStyle xmlns:a="http://schemas.openxmlformats.org/drawingml/2006/main"/>
+          <a:p xmlns:a="http://schemas.openxmlformats.org/drawingml/2006/main">
+            <a:pPr>
+              <a:buNone/>
               <a:defRPr sz="2250" b="0">
                 <a:solidFill>
                   <a:srgbClr val="EAF1EF"/>
@@ -5816,249 +6088,17 @@
                 <a:ea typeface="Hiragino Sans GB"/>
                 <a:cs typeface="Hiragino Sans GB"/>
               </a:rPr>
-              <a:t>本地终端：在 course-labs 的上一级目录执行</a:t>
-            </a:r>
-          </a:p>
-        </p:txBody>
-      </p:sp>
-      <p:sp>
-        <p:nvSpPr>
-          <p:cNvPr id="16" name="content-4">
-            <a:extLst xmlns:a="http://schemas.openxmlformats.org/drawingml/2006/main">
-              <a:ext uri="{FF2B5EF4-FFF2-40B4-BE49-F238E27FC236}">
-                <a16:creationId xmlns:a16="http://schemas.microsoft.com/office/drawing/2014/main" id="{0D69CE6B-B379-4948-A86D-27F985503B52}"/>
-              </a:ext>
-            </a:extLst>
-          </p:cNvPr>
-          <p:cNvSpPr>
-            <a:spLocks xmlns:a="http://schemas.openxmlformats.org/drawingml/2006/main" noGrp="1"/>
-          </p:cNvSpPr>
-          <p:nvPr/>
-        </p:nvSpPr>
-        <p:spPr>
-          <a:xfrm xmlns:a="http://schemas.openxmlformats.org/drawingml/2006/main">
-            <a:off x="876300" y="3429000"/>
-            <a:ext cx="13335000" cy="571500"/>
-          </a:xfrm>
-          <a:prstGeom xmlns:a="http://schemas.openxmlformats.org/drawingml/2006/main" prst="rect">
-            <a:avLst/>
-          </a:prstGeom>
-          <a:noFill xmlns:a="http://schemas.openxmlformats.org/drawingml/2006/main"/>
-          <a:ln xmlns:a="http://schemas.openxmlformats.org/drawingml/2006/main" w="0">
-            <a:noFill/>
-          </a:ln>
-        </p:spPr>
-        <p:txBody>
-          <a:bodyPr xmlns:a="http://schemas.openxmlformats.org/drawingml/2006/main" wrap="none">
-            <a:noAutofit/>
-          </a:bodyPr>
-          <a:lstStyle xmlns:a="http://schemas.openxmlformats.org/drawingml/2006/main"/>
-          <a:p xmlns:a="http://schemas.openxmlformats.org/drawingml/2006/main">
-            <a:pPr>
-              <a:buNone/>
-              <a:defRPr sz="2550" b="0">
-                <a:solidFill>
-                  <a:srgbClr val="B7EDDB"/>
-                </a:solidFill>
-                <a:latin typeface="Menlo"/>
-                <a:ea typeface="Menlo"/>
-                <a:cs typeface="Menlo"/>
-              </a:defRPr>
-            </a:pPr>
-            <a:r>
-              <a:rPr sz="2550" b="0">
-                <a:solidFill>
-                  <a:srgbClr val="B7EDDB"/>
-                </a:solidFill>
-                <a:latin typeface="Menlo"/>
-                <a:ea typeface="Menlo"/>
-                <a:cs typeface="Menlo"/>
-              </a:rPr>
-              <a:t>scp -r ./course-labs jiaowosuan-data:</a:t>
-            </a:r>
-          </a:p>
-        </p:txBody>
-      </p:sp>
-      <p:sp>
-        <p:nvSpPr>
-          <p:cNvPr id="17" name="content-5">
-            <a:extLst xmlns:a="http://schemas.openxmlformats.org/drawingml/2006/main">
-              <a:ext uri="{FF2B5EF4-FFF2-40B4-BE49-F238E27FC236}">
-                <a16:creationId xmlns:a16="http://schemas.microsoft.com/office/drawing/2014/main" id="{EAA7F502-16FD-4D2E-8D0C-602787B128A8}"/>
-              </a:ext>
-            </a:extLst>
-          </p:cNvPr>
-          <p:cNvSpPr>
-            <a:spLocks xmlns:a="http://schemas.openxmlformats.org/drawingml/2006/main" noGrp="1"/>
-          </p:cNvSpPr>
-          <p:nvPr/>
-        </p:nvSpPr>
-        <p:spPr>
-          <a:xfrm xmlns:a="http://schemas.openxmlformats.org/drawingml/2006/main">
-            <a:off x="876300" y="4095750"/>
-            <a:ext cx="13335000" cy="571500"/>
-          </a:xfrm>
-          <a:prstGeom xmlns:a="http://schemas.openxmlformats.org/drawingml/2006/main" prst="rect">
-            <a:avLst/>
-          </a:prstGeom>
-          <a:noFill xmlns:a="http://schemas.openxmlformats.org/drawingml/2006/main"/>
-          <a:ln xmlns:a="http://schemas.openxmlformats.org/drawingml/2006/main" w="0">
-            <a:noFill/>
-          </a:ln>
-        </p:spPr>
-        <p:txBody>
-          <a:bodyPr xmlns:a="http://schemas.openxmlformats.org/drawingml/2006/main" wrap="none">
-            <a:noAutofit/>
-          </a:bodyPr>
-          <a:lstStyle xmlns:a="http://schemas.openxmlformats.org/drawingml/2006/main"/>
-          <a:p xmlns:a="http://schemas.openxmlformats.org/drawingml/2006/main">
-            <a:pPr>
-              <a:buNone/>
-              <a:defRPr sz="2550" b="0">
-                <a:solidFill>
-                  <a:srgbClr val="B7EDDB"/>
-                </a:solidFill>
-                <a:latin typeface="Menlo"/>
-                <a:ea typeface="Menlo"/>
-                <a:cs typeface="Menlo"/>
-              </a:defRPr>
-            </a:pPr>
-            <a:r>
-              <a:rPr sz="2550" b="0">
-                <a:solidFill>
-                  <a:srgbClr val="B7EDDB"/>
-                </a:solidFill>
-                <a:latin typeface="Menlo"/>
-                <a:ea typeface="Menlo"/>
-                <a:cs typeface="Menlo"/>
-              </a:rPr>
-              <a:t>ssh jiaowosuan</a:t>
-            </a:r>
-          </a:p>
-        </p:txBody>
-      </p:sp>
-      <p:sp>
-        <p:nvSpPr>
-          <p:cNvPr id="18" name="content-6">
-            <a:extLst xmlns:a="http://schemas.openxmlformats.org/drawingml/2006/main">
-              <a:ext uri="{FF2B5EF4-FFF2-40B4-BE49-F238E27FC236}">
-                <a16:creationId xmlns:a16="http://schemas.microsoft.com/office/drawing/2014/main" id="{1A2AD3A8-95AB-4F39-8AE6-9E8ECE9C9D3A}"/>
-              </a:ext>
-            </a:extLst>
-          </p:cNvPr>
-          <p:cNvSpPr>
-            <a:spLocks xmlns:a="http://schemas.openxmlformats.org/drawingml/2006/main" noGrp="1"/>
-          </p:cNvSpPr>
-          <p:nvPr/>
-        </p:nvSpPr>
-        <p:spPr>
-          <a:xfrm xmlns:a="http://schemas.openxmlformats.org/drawingml/2006/main">
-            <a:off x="876300" y="4762500"/>
-            <a:ext cx="13335000" cy="571500"/>
-          </a:xfrm>
-          <a:prstGeom xmlns:a="http://schemas.openxmlformats.org/drawingml/2006/main" prst="rect">
-            <a:avLst/>
-          </a:prstGeom>
-          <a:noFill xmlns:a="http://schemas.openxmlformats.org/drawingml/2006/main"/>
-          <a:ln xmlns:a="http://schemas.openxmlformats.org/drawingml/2006/main" w="0">
-            <a:noFill/>
-          </a:ln>
-        </p:spPr>
-        <p:txBody>
-          <a:bodyPr xmlns:a="http://schemas.openxmlformats.org/drawingml/2006/main" wrap="none">
-            <a:noAutofit/>
-          </a:bodyPr>
-          <a:lstStyle xmlns:a="http://schemas.openxmlformats.org/drawingml/2006/main"/>
-          <a:p xmlns:a="http://schemas.openxmlformats.org/drawingml/2006/main">
-            <a:pPr>
-              <a:buNone/>
-              <a:defRPr sz="2550" b="0">
-                <a:solidFill>
-                  <a:srgbClr val="B7EDDB"/>
-                </a:solidFill>
-                <a:latin typeface="Menlo"/>
-                <a:ea typeface="Menlo"/>
-                <a:cs typeface="Menlo"/>
-              </a:defRPr>
-            </a:pPr>
-            <a:r>
-              <a:rPr sz="2550" b="0">
-                <a:solidFill>
-                  <a:srgbClr val="B7EDDB"/>
-                </a:solidFill>
-                <a:latin typeface="Menlo"/>
-                <a:ea typeface="Menlo"/>
-                <a:cs typeface="Menlo"/>
-              </a:rPr>
-              <a:t>cd ~/course-labs</a:t>
-            </a:r>
-          </a:p>
-        </p:txBody>
-      </p:sp>
-      <p:sp>
-        <p:nvSpPr>
-          <p:cNvPr id="19" name="content-7">
-            <a:extLst xmlns:a="http://schemas.openxmlformats.org/drawingml/2006/main">
-              <a:ext uri="{FF2B5EF4-FFF2-40B4-BE49-F238E27FC236}">
-                <a16:creationId xmlns:a16="http://schemas.microsoft.com/office/drawing/2014/main" id="{E3011C2E-F30F-4713-A05E-1E74279643FA}"/>
-              </a:ext>
-            </a:extLst>
-          </p:cNvPr>
-          <p:cNvSpPr>
-            <a:spLocks xmlns:a="http://schemas.openxmlformats.org/drawingml/2006/main" noGrp="1"/>
-          </p:cNvSpPr>
-          <p:nvPr/>
-        </p:nvSpPr>
-        <p:spPr>
-          <a:xfrm xmlns:a="http://schemas.openxmlformats.org/drawingml/2006/main">
-            <a:off x="876300" y="5429250"/>
-            <a:ext cx="13335000" cy="571500"/>
-          </a:xfrm>
-          <a:prstGeom xmlns:a="http://schemas.openxmlformats.org/drawingml/2006/main" prst="rect">
-            <a:avLst/>
-          </a:prstGeom>
-          <a:noFill xmlns:a="http://schemas.openxmlformats.org/drawingml/2006/main"/>
-          <a:ln xmlns:a="http://schemas.openxmlformats.org/drawingml/2006/main" w="0">
-            <a:noFill/>
-          </a:ln>
-        </p:spPr>
-        <p:txBody>
-          <a:bodyPr xmlns:a="http://schemas.openxmlformats.org/drawingml/2006/main" wrap="none">
-            <a:noAutofit/>
-          </a:bodyPr>
-          <a:lstStyle xmlns:a="http://schemas.openxmlformats.org/drawingml/2006/main"/>
-          <a:p xmlns:a="http://schemas.openxmlformats.org/drawingml/2006/main">
-            <a:pPr>
-              <a:buNone/>
-              <a:defRPr sz="2550" b="0">
-                <a:solidFill>
-                  <a:srgbClr val="B7EDDB"/>
-                </a:solidFill>
-                <a:latin typeface="Menlo"/>
-                <a:ea typeface="Menlo"/>
-                <a:cs typeface="Menlo"/>
-              </a:defRPr>
-            </a:pPr>
-            <a:r>
-              <a:rPr sz="2550" b="0">
-                <a:solidFill>
-                  <a:srgbClr val="B7EDDB"/>
-                </a:solidFill>
-                <a:latin typeface="Menlo"/>
-                <a:ea typeface="Menlo"/>
-                <a:cs typeface="Menlo"/>
-              </a:rPr>
-              <a:t>ls labs</a:t>
-            </a:r>
-          </a:p>
-        </p:txBody>
-      </p:sp>
-      <p:sp>
-        <p:nvSpPr>
-          <p:cNvPr id="20" name="content-8">
-            <a:extLst xmlns:a="http://schemas.openxmlformats.org/drawingml/2006/main">
-              <a:ext uri="{FF2B5EF4-FFF2-40B4-BE49-F238E27FC236}">
-                <a16:creationId xmlns:a16="http://schemas.microsoft.com/office/drawing/2014/main" id="{17AB631B-C4A0-4DD9-BAB1-9AF59624C7F1}"/>
+              <a:t>显示登录提示；远端下载失败时，由本地下载 Server 再传入</a:t>
+            </a:r>
+          </a:p>
+        </p:txBody>
+      </p:sp>
+      <p:sp>
+        <p:nvSpPr>
+          <p:cNvPr id="17" name="content-9">
+            <a:extLst xmlns:a="http://schemas.openxmlformats.org/drawingml/2006/main">
+              <a:ext uri="{FF2B5EF4-FFF2-40B4-BE49-F238E27FC236}">
+                <a16:creationId xmlns:a16="http://schemas.microsoft.com/office/drawing/2014/main" id="{8D169129-2695-4378-85CA-25A48C8AE42F}"/>
               </a:ext>
             </a:extLst>
           </p:cNvPr>
@@ -6106,7 +6146,7 @@
                 <a:ea typeface="Hiragino Sans GB"/>
                 <a:cs typeface="Hiragino Sans GB"/>
               </a:rPr>
-              <a:t>后续更新先保存远端修改，再合并新版本。分享页面下载到本地后，通过数据节点上传。</a:t>
+              <a:t>本地需要能访问微软下载服务。SSH config 与 VS Code 用户设置均独立于仓库。</a:t>
             </a:r>
           </a:p>
         </p:txBody>
@@ -6114,7 +6154,7 @@
     </p:spTree>
     <p:extLst>
       <p:ext uri="{BB962C8B-B14F-4D97-AF65-F5344CB8AC3E}">
-        <p14:creationId xmlns:p14="http://schemas.microsoft.com/office/powerpoint/2010/main" val="1523425400"/>
+        <p14:creationId xmlns:p14="http://schemas.microsoft.com/office/powerpoint/2010/main" val="297403261"/>
       </p:ext>
     </p:extLst>
   </p:cSld>
@@ -6425,7 +6465,7 @@
                 <a:ea typeface="Menlo"/>
                 <a:cs typeface="Menlo"/>
               </a:rPr>
-              <a:t>  --cpu-bind=cores --pty /bin/bash</a:t>
+              <a:t>  --cpu-bind=cores --pty /bin/bash -l</a:t>
             </a:r>
           </a:p>
         </p:txBody>
@@ -6485,7 +6525,7 @@
         </p:nvSpPr>
         <p:spPr>
           <a:xfrm xmlns:a="http://schemas.openxmlformats.org/drawingml/2006/main">
-            <a:off x="914400" y="4000500"/>
+            <a:off x="914400" y="3667125"/>
             <a:ext cx="13430250" cy="581025"/>
           </a:xfrm>
           <a:prstGeom xmlns:a="http://schemas.openxmlformats.org/drawingml/2006/main" prst="rect">
@@ -6543,7 +6583,7 @@
         </p:nvSpPr>
         <p:spPr>
           <a:xfrm xmlns:a="http://schemas.openxmlformats.org/drawingml/2006/main">
-            <a:off x="914400" y="4505325"/>
+            <a:off x="914400" y="4171950"/>
             <a:ext cx="13430250" cy="581025"/>
           </a:xfrm>
           <a:prstGeom xmlns:a="http://schemas.openxmlformats.org/drawingml/2006/main" prst="rect">
@@ -6601,7 +6641,7 @@
         </p:nvSpPr>
         <p:spPr>
           <a:xfrm xmlns:a="http://schemas.openxmlformats.org/drawingml/2006/main">
-            <a:off x="914400" y="5010150"/>
+            <a:off x="914400" y="5686425"/>
             <a:ext cx="13430250" cy="581025"/>
           </a:xfrm>
           <a:prstGeom xmlns:a="http://schemas.openxmlformats.org/drawingml/2006/main" prst="rect">
@@ -6697,6 +6737,177 @@
                 <a:cs typeface="Hiragino Sans GB"/>
               </a:rPr>
               <a:t>分配后仅当前终端进入计算节点；新终端先核对 hostname。结束时输入 exit。</a:t>
+            </a:r>
+          </a:p>
+        </p:txBody>
+      </p:sp>
+      <p:sp>
+        <p:nvSpPr>
+          <p:cNvPr id="12" name="audit-10">
+            <a:extLst xmlns:a="http://schemas.openxmlformats.org/drawingml/2006/main">
+              <a:ext uri="{FF2B5EF4-FFF2-40B4-BE49-F238E27FC236}">
+                <a16:creationId xmlns:a16="http://schemas.microsoft.com/office/drawing/2014/main" id="{912E15DB-3987-4923-BA98-C7A06A2B2D39}"/>
+              </a:ext>
+            </a:extLst>
+          </p:cNvPr>
+          <p:cNvSpPr>
+            <a:spLocks xmlns:a="http://schemas.openxmlformats.org/drawingml/2006/main" noGrp="1"/>
+          </p:cNvSpPr>
+          <p:nvPr/>
+        </p:nvSpPr>
+        <p:spPr>
+          <a:xfrm xmlns:a="http://schemas.openxmlformats.org/drawingml/2006/main">
+            <a:off x="914400" y="4676775"/>
+            <a:ext cx="13430250" cy="523875"/>
+          </a:xfrm>
+          <a:prstGeom xmlns:a="http://schemas.openxmlformats.org/drawingml/2006/main" prst="rect">
+            <a:avLst/>
+          </a:prstGeom>
+          <a:noFill xmlns:a="http://schemas.openxmlformats.org/drawingml/2006/main"/>
+          <a:ln xmlns:a="http://schemas.openxmlformats.org/drawingml/2006/main" w="0">
+            <a:noFill/>
+          </a:ln>
+        </p:spPr>
+        <p:txBody>
+          <a:bodyPr xmlns:a="http://schemas.openxmlformats.org/drawingml/2006/main" wrap="none">
+            <a:noAutofit/>
+          </a:bodyPr>
+          <a:lstStyle xmlns:a="http://schemas.openxmlformats.org/drawingml/2006/main"/>
+          <a:p xmlns:a="http://schemas.openxmlformats.org/drawingml/2006/main">
+            <a:pPr>
+              <a:defRPr sz="2550">
+                <a:solidFill>
+                  <a:srgbClr val="B7EDDB"/>
+                </a:solidFill>
+                <a:latin typeface="Menlo"/>
+                <a:ea typeface="Menlo"/>
+                <a:cs typeface="Menlo"/>
+              </a:defRPr>
+            </a:pPr>
+            <a:r>
+              <a:rPr sz="2550">
+                <a:solidFill>
+                  <a:srgbClr val="B7EDDB"/>
+                </a:solidFill>
+                <a:latin typeface="Menlo"/>
+                <a:ea typeface="Menlo"/>
+                <a:cs typeface="Menlo"/>
+              </a:rPr>
+              <a:t>module avail cmake</a:t>
+            </a:r>
+          </a:p>
+        </p:txBody>
+      </p:sp>
+      <p:sp>
+        <p:nvSpPr>
+          <p:cNvPr id="13" name="audit-11">
+            <a:extLst xmlns:a="http://schemas.openxmlformats.org/drawingml/2006/main">
+              <a:ext uri="{FF2B5EF4-FFF2-40B4-BE49-F238E27FC236}">
+                <a16:creationId xmlns:a16="http://schemas.microsoft.com/office/drawing/2014/main" id="{FAE76524-301C-468D-BF1E-C00B21768A67}"/>
+              </a:ext>
+            </a:extLst>
+          </p:cNvPr>
+          <p:cNvSpPr>
+            <a:spLocks xmlns:a="http://schemas.openxmlformats.org/drawingml/2006/main" noGrp="1"/>
+          </p:cNvSpPr>
+          <p:nvPr/>
+        </p:nvSpPr>
+        <p:spPr>
+          <a:xfrm xmlns:a="http://schemas.openxmlformats.org/drawingml/2006/main">
+            <a:off x="914400" y="5181600"/>
+            <a:ext cx="13430250" cy="523875"/>
+          </a:xfrm>
+          <a:prstGeom xmlns:a="http://schemas.openxmlformats.org/drawingml/2006/main" prst="rect">
+            <a:avLst/>
+          </a:prstGeom>
+          <a:noFill xmlns:a="http://schemas.openxmlformats.org/drawingml/2006/main"/>
+          <a:ln xmlns:a="http://schemas.openxmlformats.org/drawingml/2006/main" w="0">
+            <a:noFill/>
+          </a:ln>
+        </p:spPr>
+        <p:txBody>
+          <a:bodyPr xmlns:a="http://schemas.openxmlformats.org/drawingml/2006/main" wrap="none">
+            <a:noAutofit/>
+          </a:bodyPr>
+          <a:lstStyle xmlns:a="http://schemas.openxmlformats.org/drawingml/2006/main"/>
+          <a:p xmlns:a="http://schemas.openxmlformats.org/drawingml/2006/main">
+            <a:pPr>
+              <a:defRPr sz="2550">
+                <a:solidFill>
+                  <a:srgbClr val="B7EDDB"/>
+                </a:solidFill>
+                <a:latin typeface="Menlo"/>
+                <a:ea typeface="Menlo"/>
+                <a:cs typeface="Menlo"/>
+              </a:defRPr>
+            </a:pPr>
+            <a:r>
+              <a:rPr sz="2550">
+                <a:solidFill>
+                  <a:srgbClr val="B7EDDB"/>
+                </a:solidFill>
+                <a:latin typeface="Menlo"/>
+                <a:ea typeface="Menlo"/>
+                <a:cs typeface="Menlo"/>
+              </a:rPr>
+              <a:t>module load cmake</a:t>
+            </a:r>
+          </a:p>
+        </p:txBody>
+      </p:sp>
+      <p:sp>
+        <p:nvSpPr>
+          <p:cNvPr id="14" name="audit-12">
+            <a:extLst xmlns:a="http://schemas.openxmlformats.org/drawingml/2006/main">
+              <a:ext uri="{FF2B5EF4-FFF2-40B4-BE49-F238E27FC236}">
+                <a16:creationId xmlns:a16="http://schemas.microsoft.com/office/drawing/2014/main" id="{17AE4FE9-BD97-443A-B9D8-AC3F09B9793F}"/>
+              </a:ext>
+            </a:extLst>
+          </p:cNvPr>
+          <p:cNvSpPr>
+            <a:spLocks xmlns:a="http://schemas.openxmlformats.org/drawingml/2006/main" noGrp="1"/>
+          </p:cNvSpPr>
+          <p:nvPr/>
+        </p:nvSpPr>
+        <p:spPr>
+          <a:xfrm xmlns:a="http://schemas.openxmlformats.org/drawingml/2006/main">
+            <a:off x="914400" y="6477000"/>
+            <a:ext cx="13430250" cy="523875"/>
+          </a:xfrm>
+          <a:prstGeom xmlns:a="http://schemas.openxmlformats.org/drawingml/2006/main" prst="rect">
+            <a:avLst/>
+          </a:prstGeom>
+          <a:noFill xmlns:a="http://schemas.openxmlformats.org/drawingml/2006/main"/>
+          <a:ln xmlns:a="http://schemas.openxmlformats.org/drawingml/2006/main" w="0">
+            <a:noFill/>
+          </a:ln>
+        </p:spPr>
+        <p:txBody>
+          <a:bodyPr xmlns:a="http://schemas.openxmlformats.org/drawingml/2006/main" wrap="none">
+            <a:noAutofit/>
+          </a:bodyPr>
+          <a:lstStyle xmlns:a="http://schemas.openxmlformats.org/drawingml/2006/main"/>
+          <a:p xmlns:a="http://schemas.openxmlformats.org/drawingml/2006/main">
+            <a:pPr>
+              <a:defRPr sz="2025">
+                <a:solidFill>
+                  <a:srgbClr val="A8C6C4"/>
+                </a:solidFill>
+                <a:latin typeface="Hiragino Sans GB"/>
+                <a:ea typeface="Hiragino Sans GB"/>
+                <a:cs typeface="Hiragino Sans GB"/>
+              </a:defRPr>
+            </a:pPr>
+            <a:r>
+              <a:rPr sz="2025">
+                <a:solidFill>
+                  <a:srgbClr val="A8C6C4"/>
+                </a:solidFill>
+                <a:latin typeface="Hiragino Sans GB"/>
+                <a:ea typeface="Hiragino Sans GB"/>
+                <a:cs typeface="Hiragino Sans GB"/>
+              </a:rPr>
+              <a:t>加载默认 CMake 模块并确认版本 ≥ 3.16；模块名称以实际查询为准</a:t>
             </a:r>
           </a:p>
         </p:txBody>
@@ -7191,7 +7402,7 @@
         </p:nvSpPr>
         <p:spPr>
           <a:xfrm xmlns:a="http://schemas.openxmlformats.org/drawingml/2006/main">
-            <a:off x="914400" y="5086350"/>
+            <a:off x="914400" y="5600700"/>
             <a:ext cx="13430250" cy="590550"/>
           </a:xfrm>
           <a:prstGeom xmlns:a="http://schemas.openxmlformats.org/drawingml/2006/main" prst="rect">
@@ -7287,6 +7498,120 @@
                 <a:cs typeface="Hiragino Sans GB"/>
               </a:rPr>
               <a:t>先填写 bits.c 的姓名和学号。btest 查正确性，dlc 只检查其支持的编码规则。</a:t>
+            </a:r>
+          </a:p>
+        </p:txBody>
+      </p:sp>
+      <p:sp>
+        <p:nvSpPr>
+          <p:cNvPr id="12" name="audit-10">
+            <a:extLst xmlns:a="http://schemas.openxmlformats.org/drawingml/2006/main">
+              <a:ext uri="{FF2B5EF4-FFF2-40B4-BE49-F238E27FC236}">
+                <a16:creationId xmlns:a16="http://schemas.microsoft.com/office/drawing/2014/main" id="{322707AA-3AD4-470A-93F8-948D9F701B56}"/>
+              </a:ext>
+            </a:extLst>
+          </p:cNvPr>
+          <p:cNvSpPr>
+            <a:spLocks xmlns:a="http://schemas.openxmlformats.org/drawingml/2006/main" noGrp="1"/>
+          </p:cNvSpPr>
+          <p:nvPr/>
+        </p:nvSpPr>
+        <p:spPr>
+          <a:xfrm xmlns:a="http://schemas.openxmlformats.org/drawingml/2006/main">
+            <a:off x="914400" y="5086350"/>
+            <a:ext cx="13430250" cy="523875"/>
+          </a:xfrm>
+          <a:prstGeom xmlns:a="http://schemas.openxmlformats.org/drawingml/2006/main" prst="rect">
+            <a:avLst/>
+          </a:prstGeom>
+          <a:noFill xmlns:a="http://schemas.openxmlformats.org/drawingml/2006/main"/>
+          <a:ln xmlns:a="http://schemas.openxmlformats.org/drawingml/2006/main" w="0">
+            <a:noFill/>
+          </a:ln>
+        </p:spPr>
+        <p:txBody>
+          <a:bodyPr xmlns:a="http://schemas.openxmlformats.org/drawingml/2006/main" wrap="none">
+            <a:noAutofit/>
+          </a:bodyPr>
+          <a:lstStyle xmlns:a="http://schemas.openxmlformats.org/drawingml/2006/main"/>
+          <a:p xmlns:a="http://schemas.openxmlformats.org/drawingml/2006/main">
+            <a:pPr>
+              <a:defRPr sz="2550">
+                <a:solidFill>
+                  <a:srgbClr val="B7EDDB"/>
+                </a:solidFill>
+                <a:latin typeface="Menlo"/>
+                <a:ea typeface="Menlo"/>
+                <a:cs typeface="Menlo"/>
+              </a:defRPr>
+            </a:pPr>
+            <a:r>
+              <a:rPr sz="2550">
+                <a:solidFill>
+                  <a:srgbClr val="B7EDDB"/>
+                </a:solidFill>
+                <a:latin typeface="Menlo"/>
+                <a:ea typeface="Menlo"/>
+                <a:cs typeface="Menlo"/>
+              </a:rPr>
+              <a:t>chmod u+x ./dlc</a:t>
+            </a:r>
+          </a:p>
+        </p:txBody>
+      </p:sp>
+      <p:sp>
+        <p:nvSpPr>
+          <p:cNvPr id="13" name="audit-11">
+            <a:extLst xmlns:a="http://schemas.openxmlformats.org/drawingml/2006/main">
+              <a:ext uri="{FF2B5EF4-FFF2-40B4-BE49-F238E27FC236}">
+                <a16:creationId xmlns:a16="http://schemas.microsoft.com/office/drawing/2014/main" id="{9DDAABF1-C846-4ABD-8CA2-9A79769A99C0}"/>
+              </a:ext>
+            </a:extLst>
+          </p:cNvPr>
+          <p:cNvSpPr>
+            <a:spLocks xmlns:a="http://schemas.openxmlformats.org/drawingml/2006/main" noGrp="1"/>
+          </p:cNvSpPr>
+          <p:nvPr/>
+        </p:nvSpPr>
+        <p:spPr>
+          <a:xfrm xmlns:a="http://schemas.openxmlformats.org/drawingml/2006/main">
+            <a:off x="914400" y="6477000"/>
+            <a:ext cx="13430250" cy="523875"/>
+          </a:xfrm>
+          <a:prstGeom xmlns:a="http://schemas.openxmlformats.org/drawingml/2006/main" prst="rect">
+            <a:avLst/>
+          </a:prstGeom>
+          <a:noFill xmlns:a="http://schemas.openxmlformats.org/drawingml/2006/main"/>
+          <a:ln xmlns:a="http://schemas.openxmlformats.org/drawingml/2006/main" w="0">
+            <a:noFill/>
+          </a:ln>
+        </p:spPr>
+        <p:txBody>
+          <a:bodyPr xmlns:a="http://schemas.openxmlformats.org/drawingml/2006/main" wrap="none">
+            <a:noAutofit/>
+          </a:bodyPr>
+          <a:lstStyle xmlns:a="http://schemas.openxmlformats.org/drawingml/2006/main"/>
+          <a:p xmlns:a="http://schemas.openxmlformats.org/drawingml/2006/main">
+            <a:pPr>
+              <a:defRPr sz="2025">
+                <a:solidFill>
+                  <a:srgbClr val="A8C6C4"/>
+                </a:solidFill>
+                <a:latin typeface="Hiragino Sans GB"/>
+                <a:ea typeface="Hiragino Sans GB"/>
+                <a:cs typeface="Hiragino Sans GB"/>
+              </a:defRPr>
+            </a:pPr>
+            <a:r>
+              <a:rPr sz="2025">
+                <a:solidFill>
+                  <a:srgbClr val="A8C6C4"/>
+                </a:solidFill>
+                <a:latin typeface="Hiragino Sans GB"/>
+                <a:ea typeface="Hiragino Sans GB"/>
+                <a:cs typeface="Hiragino Sans GB"/>
+              </a:rPr>
+              <a:t>selftest 的满分是框架自检结果；学生答案的得分看 make grade</a:t>
             </a:r>
           </a:p>
         </p:txBody>
@@ -8369,7 +8694,7 @@
                 <a:ea typeface="Hiragino Sans GB"/>
                 <a:cs typeface="Hiragino Sans GB"/>
               </a:rPr>
-              <a:t>出现 INVALID 时，先检查对应函数的数值结果</a:t>
+              <a:t>空模板出现 INVALID 是预期结果；实现函数后应全部通过</a:t>
             </a:r>
           </a:p>
         </p:txBody>
@@ -8428,6 +8753,63 @@
                 <a:cs typeface="Hiragino Sans GB"/>
               </a:rPr>
               <a:t>小规模全部通过后，再提交较长的性能实验。</a:t>
+            </a:r>
+          </a:p>
+        </p:txBody>
+      </p:sp>
+      <p:sp>
+        <p:nvSpPr>
+          <p:cNvPr id="12" name="audit-10">
+            <a:extLst xmlns:a="http://schemas.openxmlformats.org/drawingml/2006/main">
+              <a:ext uri="{FF2B5EF4-FFF2-40B4-BE49-F238E27FC236}">
+                <a16:creationId xmlns:a16="http://schemas.microsoft.com/office/drawing/2014/main" id="{A9988DE3-DB5E-4E6F-B2FA-7A18D235176D}"/>
+              </a:ext>
+            </a:extLst>
+          </p:cNvPr>
+          <p:cNvSpPr>
+            <a:spLocks xmlns:a="http://schemas.openxmlformats.org/drawingml/2006/main" noGrp="1"/>
+          </p:cNvSpPr>
+          <p:nvPr/>
+        </p:nvSpPr>
+        <p:spPr>
+          <a:xfrm xmlns:a="http://schemas.openxmlformats.org/drawingml/2006/main">
+            <a:off x="914400" y="1619250"/>
+            <a:ext cx="13430250" cy="523875"/>
+          </a:xfrm>
+          <a:prstGeom xmlns:a="http://schemas.openxmlformats.org/drawingml/2006/main" prst="rect">
+            <a:avLst/>
+          </a:prstGeom>
+          <a:noFill xmlns:a="http://schemas.openxmlformats.org/drawingml/2006/main"/>
+          <a:ln xmlns:a="http://schemas.openxmlformats.org/drawingml/2006/main" w="0">
+            <a:noFill/>
+          </a:ln>
+        </p:spPr>
+        <p:txBody>
+          <a:bodyPr xmlns:a="http://schemas.openxmlformats.org/drawingml/2006/main" wrap="none">
+            <a:noAutofit/>
+          </a:bodyPr>
+          <a:lstStyle xmlns:a="http://schemas.openxmlformats.org/drawingml/2006/main"/>
+          <a:p xmlns:a="http://schemas.openxmlformats.org/drawingml/2006/main">
+            <a:pPr>
+              <a:defRPr sz="2025">
+                <a:solidFill>
+                  <a:srgbClr val="A8C6C4"/>
+                </a:solidFill>
+                <a:latin typeface="Hiragino Sans GB"/>
+                <a:ea typeface="Hiragino Sans GB"/>
+                <a:cs typeface="Hiragino Sans GB"/>
+              </a:defRPr>
+            </a:pPr>
+            <a:r>
+              <a:rPr sz="2025">
+                <a:solidFill>
+                  <a:srgbClr val="A8C6C4"/>
+                </a:solidFill>
+                <a:latin typeface="Hiragino Sans GB"/>
+                <a:ea typeface="Hiragino Sans GB"/>
+                <a:cs typeface="Hiragino Sans GB"/>
+              </a:rPr>
+              <a:t>在计算节点的 ~/course-labs/labs/lab2-matrix 目录执行</a:t>
             </a:r>
           </a:p>
         </p:txBody>
@@ -10013,7 +10395,7 @@
                 <a:ea typeface="Hiragino Sans GB"/>
                 <a:cs typeface="Hiragino Sans GB"/>
               </a:rPr>
-              <a:t>每次作业使用单独的日志文件；姓名学号或答案未完成时，grade 可能失败。</a:t>
+              <a:t>保存为 UTF-8 / LF；提交前先创建 results。未完成答案时 grade 会返回非零。</a:t>
             </a:r>
           </a:p>
         </p:txBody>
@@ -10842,7 +11224,7 @@
                 <a:ea typeface="Hiragino Sans GB"/>
                 <a:cs typeface="Hiragino Sans GB"/>
               </a:rPr>
-              <a:t>保存为 lab2.slurm；左列接右列，完整版本见配套文字讲义</a:t>
+              <a:t>保存为 lab2.slurm（UTF-8 / LF）；左列接右列，完整版本见讲义</a:t>
             </a:r>
           </a:p>
         </p:txBody>
@@ -10900,7 +11282,7 @@
                 <a:ea typeface="Menlo"/>
                 <a:cs typeface="Menlo"/>
               </a:rPr>
-              <a:t>#!/bin/bash</a:t>
+              <a:t>#!/bin/bash -l</a:t>
             </a:r>
           </a:p>
         </p:txBody>
@@ -11308,6 +11690,702 @@
         </p:nvSpPr>
         <p:spPr>
           <a:xfrm xmlns:a="http://schemas.openxmlformats.org/drawingml/2006/main">
+            <a:off x="876300" y="6534150"/>
+            <a:ext cx="6667500" cy="523875"/>
+          </a:xfrm>
+          <a:prstGeom xmlns:a="http://schemas.openxmlformats.org/drawingml/2006/main" prst="rect">
+            <a:avLst/>
+          </a:prstGeom>
+          <a:noFill xmlns:a="http://schemas.openxmlformats.org/drawingml/2006/main"/>
+          <a:ln xmlns:a="http://schemas.openxmlformats.org/drawingml/2006/main" w="0">
+            <a:noFill/>
+          </a:ln>
+        </p:spPr>
+        <p:txBody>
+          <a:bodyPr xmlns:a="http://schemas.openxmlformats.org/drawingml/2006/main" wrap="none" lIns="0" tIns="0" rIns="0" bIns="0" anchor="t">
+            <a:noAutofit/>
+          </a:bodyPr>
+          <a:lstStyle xmlns:a="http://schemas.openxmlformats.org/drawingml/2006/main"/>
+          <a:p xmlns:a="http://schemas.openxmlformats.org/drawingml/2006/main">
+            <a:pPr>
+              <a:buNone/>
+              <a:defRPr sz="1875" b="0">
+                <a:solidFill>
+                  <a:srgbClr val="B7EDDB"/>
+                </a:solidFill>
+                <a:latin typeface="Menlo"/>
+                <a:ea typeface="Menlo"/>
+                <a:cs typeface="Menlo"/>
+              </a:defRPr>
+            </a:pPr>
+            <a:r>
+              <a:rPr sz="1875" b="0">
+                <a:solidFill>
+                  <a:srgbClr val="B7EDDB"/>
+                </a:solidFill>
+                <a:latin typeface="Menlo"/>
+                <a:ea typeface="Menlo"/>
+                <a:cs typeface="Menlo"/>
+              </a:rPr>
+              <a:t>B="build/pi2-lab2-$SLURM_JOB_ID"</a:t>
+            </a:r>
+          </a:p>
+        </p:txBody>
+      </p:sp>
+      <p:sp>
+        <p:nvSpPr>
+          <p:cNvPr id="13" name="">
+            <a:extLst xmlns:a="http://schemas.openxmlformats.org/drawingml/2006/main">
+              <a:ext uri="{FF2B5EF4-FFF2-40B4-BE49-F238E27FC236}">
+                <a16:creationId xmlns:a16="http://schemas.microsoft.com/office/drawing/2014/main" id="{35858B7D-F7EE-49B1-BA07-C07742C5AAAA}"/>
+              </a:ext>
+            </a:extLst>
+          </p:cNvPr>
+          <p:cNvSpPr>
+            <a:spLocks xmlns:a="http://schemas.openxmlformats.org/drawingml/2006/main" noGrp="1"/>
+          </p:cNvSpPr>
+          <p:nvPr/>
+        </p:nvSpPr>
+        <p:spPr>
+          <a:xfrm xmlns:a="http://schemas.openxmlformats.org/drawingml/2006/main">
+            <a:off x="7743825" y="2505075"/>
+            <a:ext cx="6810375" cy="523875"/>
+          </a:xfrm>
+          <a:prstGeom xmlns:a="http://schemas.openxmlformats.org/drawingml/2006/main" prst="rect">
+            <a:avLst/>
+          </a:prstGeom>
+          <a:noFill xmlns:a="http://schemas.openxmlformats.org/drawingml/2006/main"/>
+          <a:ln xmlns:a="http://schemas.openxmlformats.org/drawingml/2006/main" w="0">
+            <a:noFill/>
+          </a:ln>
+        </p:spPr>
+        <p:txBody>
+          <a:bodyPr xmlns:a="http://schemas.openxmlformats.org/drawingml/2006/main" wrap="none" lIns="0" tIns="0" rIns="0" bIns="0" anchor="t">
+            <a:noAutofit/>
+          </a:bodyPr>
+          <a:lstStyle xmlns:a="http://schemas.openxmlformats.org/drawingml/2006/main"/>
+          <a:p xmlns:a="http://schemas.openxmlformats.org/drawingml/2006/main">
+            <a:pPr>
+              <a:buNone/>
+              <a:defRPr sz="1725" b="0">
+                <a:solidFill>
+                  <a:srgbClr val="B7EDDB"/>
+                </a:solidFill>
+                <a:latin typeface="Menlo"/>
+                <a:ea typeface="Menlo"/>
+                <a:cs typeface="Menlo"/>
+              </a:defRPr>
+            </a:pPr>
+            <a:r>
+              <a:rPr sz="1725" b="0">
+                <a:solidFill>
+                  <a:srgbClr val="B7EDDB"/>
+                </a:solidFill>
+                <a:latin typeface="Menlo"/>
+                <a:ea typeface="Menlo"/>
+                <a:cs typeface="Menlo"/>
+              </a:rPr>
+              <a:t>cmake -S labs/lab2-matrix -B "$B" \</a:t>
+            </a:r>
+          </a:p>
+        </p:txBody>
+      </p:sp>
+      <p:sp>
+        <p:nvSpPr>
+          <p:cNvPr id="14" name="">
+            <a:extLst xmlns:a="http://schemas.openxmlformats.org/drawingml/2006/main">
+              <a:ext uri="{FF2B5EF4-FFF2-40B4-BE49-F238E27FC236}">
+                <a16:creationId xmlns:a16="http://schemas.microsoft.com/office/drawing/2014/main" id="{304483B2-D9A9-416A-BBD2-3671822F5DEF}"/>
+              </a:ext>
+            </a:extLst>
+          </p:cNvPr>
+          <p:cNvSpPr>
+            <a:spLocks xmlns:a="http://schemas.openxmlformats.org/drawingml/2006/main" noGrp="1"/>
+          </p:cNvSpPr>
+          <p:nvPr/>
+        </p:nvSpPr>
+        <p:spPr>
+          <a:xfrm xmlns:a="http://schemas.openxmlformats.org/drawingml/2006/main">
+            <a:off x="7743825" y="2952750"/>
+            <a:ext cx="6810375" cy="523875"/>
+          </a:xfrm>
+          <a:prstGeom xmlns:a="http://schemas.openxmlformats.org/drawingml/2006/main" prst="rect">
+            <a:avLst/>
+          </a:prstGeom>
+          <a:noFill xmlns:a="http://schemas.openxmlformats.org/drawingml/2006/main"/>
+          <a:ln xmlns:a="http://schemas.openxmlformats.org/drawingml/2006/main" w="0">
+            <a:noFill/>
+          </a:ln>
+        </p:spPr>
+        <p:txBody>
+          <a:bodyPr xmlns:a="http://schemas.openxmlformats.org/drawingml/2006/main" wrap="none" lIns="0" tIns="0" rIns="0" bIns="0" anchor="t">
+            <a:noAutofit/>
+          </a:bodyPr>
+          <a:lstStyle xmlns:a="http://schemas.openxmlformats.org/drawingml/2006/main"/>
+          <a:p xmlns:a="http://schemas.openxmlformats.org/drawingml/2006/main">
+            <a:pPr>
+              <a:buNone/>
+              <a:defRPr sz="1725" b="0">
+                <a:solidFill>
+                  <a:srgbClr val="B7EDDB"/>
+                </a:solidFill>
+                <a:latin typeface="Menlo"/>
+                <a:ea typeface="Menlo"/>
+                <a:cs typeface="Menlo"/>
+              </a:defRPr>
+            </a:pPr>
+            <a:r>
+              <a:rPr sz="1725" b="0">
+                <a:solidFill>
+                  <a:srgbClr val="B7EDDB"/>
+                </a:solidFill>
+                <a:latin typeface="Menlo"/>
+                <a:ea typeface="Menlo"/>
+                <a:cs typeface="Menlo"/>
+              </a:rPr>
+              <a:t>  -DBUILD_TESTING=ON \</a:t>
+            </a:r>
+          </a:p>
+        </p:txBody>
+      </p:sp>
+      <p:sp>
+        <p:nvSpPr>
+          <p:cNvPr id="15" name="">
+            <a:extLst xmlns:a="http://schemas.openxmlformats.org/drawingml/2006/main">
+              <a:ext uri="{FF2B5EF4-FFF2-40B4-BE49-F238E27FC236}">
+                <a16:creationId xmlns:a16="http://schemas.microsoft.com/office/drawing/2014/main" id="{DF2E9BA5-C49E-4D19-881C-D096A9A3F6ED}"/>
+              </a:ext>
+            </a:extLst>
+          </p:cNvPr>
+          <p:cNvSpPr>
+            <a:spLocks xmlns:a="http://schemas.openxmlformats.org/drawingml/2006/main" noGrp="1"/>
+          </p:cNvSpPr>
+          <p:nvPr/>
+        </p:nvSpPr>
+        <p:spPr>
+          <a:xfrm xmlns:a="http://schemas.openxmlformats.org/drawingml/2006/main">
+            <a:off x="7743825" y="3400425"/>
+            <a:ext cx="6810375" cy="523875"/>
+          </a:xfrm>
+          <a:prstGeom xmlns:a="http://schemas.openxmlformats.org/drawingml/2006/main" prst="rect">
+            <a:avLst/>
+          </a:prstGeom>
+          <a:noFill xmlns:a="http://schemas.openxmlformats.org/drawingml/2006/main"/>
+          <a:ln xmlns:a="http://schemas.openxmlformats.org/drawingml/2006/main" w="0">
+            <a:noFill/>
+          </a:ln>
+        </p:spPr>
+        <p:txBody>
+          <a:bodyPr xmlns:a="http://schemas.openxmlformats.org/drawingml/2006/main" wrap="none" lIns="0" tIns="0" rIns="0" bIns="0" anchor="t">
+            <a:noAutofit/>
+          </a:bodyPr>
+          <a:lstStyle xmlns:a="http://schemas.openxmlformats.org/drawingml/2006/main"/>
+          <a:p xmlns:a="http://schemas.openxmlformats.org/drawingml/2006/main">
+            <a:pPr>
+              <a:buNone/>
+              <a:defRPr sz="1725" b="0">
+                <a:solidFill>
+                  <a:srgbClr val="B7EDDB"/>
+                </a:solidFill>
+                <a:latin typeface="Menlo"/>
+                <a:ea typeface="Menlo"/>
+                <a:cs typeface="Menlo"/>
+              </a:defRPr>
+            </a:pPr>
+            <a:r>
+              <a:rPr sz="1725" b="0">
+                <a:solidFill>
+                  <a:srgbClr val="B7EDDB"/>
+                </a:solidFill>
+                <a:latin typeface="Menlo"/>
+                <a:ea typeface="Menlo"/>
+                <a:cs typeface="Menlo"/>
+              </a:rPr>
+              <a:t>  -DLAB_USE_SYSTEM_BLAS=OFF</a:t>
+            </a:r>
+          </a:p>
+        </p:txBody>
+      </p:sp>
+      <p:sp>
+        <p:nvSpPr>
+          <p:cNvPr id="16" name="">
+            <a:extLst xmlns:a="http://schemas.openxmlformats.org/drawingml/2006/main">
+              <a:ext uri="{FF2B5EF4-FFF2-40B4-BE49-F238E27FC236}">
+                <a16:creationId xmlns:a16="http://schemas.microsoft.com/office/drawing/2014/main" id="{DEB62359-7DF1-4B72-BDC9-1477374A235F}"/>
+              </a:ext>
+            </a:extLst>
+          </p:cNvPr>
+          <p:cNvSpPr>
+            <a:spLocks xmlns:a="http://schemas.openxmlformats.org/drawingml/2006/main" noGrp="1"/>
+          </p:cNvSpPr>
+          <p:nvPr/>
+        </p:nvSpPr>
+        <p:spPr>
+          <a:xfrm xmlns:a="http://schemas.openxmlformats.org/drawingml/2006/main">
+            <a:off x="7743825" y="3848100"/>
+            <a:ext cx="6810375" cy="523875"/>
+          </a:xfrm>
+          <a:prstGeom xmlns:a="http://schemas.openxmlformats.org/drawingml/2006/main" prst="rect">
+            <a:avLst/>
+          </a:prstGeom>
+          <a:noFill xmlns:a="http://schemas.openxmlformats.org/drawingml/2006/main"/>
+          <a:ln xmlns:a="http://schemas.openxmlformats.org/drawingml/2006/main" w="0">
+            <a:noFill/>
+          </a:ln>
+        </p:spPr>
+        <p:txBody>
+          <a:bodyPr xmlns:a="http://schemas.openxmlformats.org/drawingml/2006/main" wrap="none" lIns="0" tIns="0" rIns="0" bIns="0" anchor="t">
+            <a:noAutofit/>
+          </a:bodyPr>
+          <a:lstStyle xmlns:a="http://schemas.openxmlformats.org/drawingml/2006/main"/>
+          <a:p xmlns:a="http://schemas.openxmlformats.org/drawingml/2006/main">
+            <a:pPr>
+              <a:buNone/>
+              <a:defRPr sz="1725" b="0">
+                <a:solidFill>
+                  <a:srgbClr val="B7EDDB"/>
+                </a:solidFill>
+                <a:latin typeface="Menlo"/>
+                <a:ea typeface="Menlo"/>
+                <a:cs typeface="Menlo"/>
+              </a:defRPr>
+            </a:pPr>
+            <a:r>
+              <a:rPr sz="1725" b="0">
+                <a:solidFill>
+                  <a:srgbClr val="B7EDDB"/>
+                </a:solidFill>
+                <a:latin typeface="Menlo"/>
+                <a:ea typeface="Menlo"/>
+                <a:cs typeface="Menlo"/>
+              </a:rPr>
+              <a:t>cmake --build "$B" --parallel 1</a:t>
+            </a:r>
+          </a:p>
+        </p:txBody>
+      </p:sp>
+      <p:sp>
+        <p:nvSpPr>
+          <p:cNvPr id="17" name="">
+            <a:extLst xmlns:a="http://schemas.openxmlformats.org/drawingml/2006/main">
+              <a:ext uri="{FF2B5EF4-FFF2-40B4-BE49-F238E27FC236}">
+                <a16:creationId xmlns:a16="http://schemas.microsoft.com/office/drawing/2014/main" id="{19772A91-9F87-41A5-814E-709C0364D543}"/>
+              </a:ext>
+            </a:extLst>
+          </p:cNvPr>
+          <p:cNvSpPr>
+            <a:spLocks xmlns:a="http://schemas.openxmlformats.org/drawingml/2006/main" noGrp="1"/>
+          </p:cNvSpPr>
+          <p:nvPr/>
+        </p:nvSpPr>
+        <p:spPr>
+          <a:xfrm xmlns:a="http://schemas.openxmlformats.org/drawingml/2006/main">
+            <a:off x="7743825" y="4295775"/>
+            <a:ext cx="6810375" cy="523875"/>
+          </a:xfrm>
+          <a:prstGeom xmlns:a="http://schemas.openxmlformats.org/drawingml/2006/main" prst="rect">
+            <a:avLst/>
+          </a:prstGeom>
+          <a:noFill xmlns:a="http://schemas.openxmlformats.org/drawingml/2006/main"/>
+          <a:ln xmlns:a="http://schemas.openxmlformats.org/drawingml/2006/main" w="0">
+            <a:noFill/>
+          </a:ln>
+        </p:spPr>
+        <p:txBody>
+          <a:bodyPr xmlns:a="http://schemas.openxmlformats.org/drawingml/2006/main" wrap="none" lIns="0" tIns="0" rIns="0" bIns="0" anchor="t">
+            <a:noAutofit/>
+          </a:bodyPr>
+          <a:lstStyle xmlns:a="http://schemas.openxmlformats.org/drawingml/2006/main"/>
+          <a:p xmlns:a="http://schemas.openxmlformats.org/drawingml/2006/main">
+            <a:pPr>
+              <a:buNone/>
+              <a:defRPr sz="1725" b="0">
+                <a:solidFill>
+                  <a:srgbClr val="B7EDDB"/>
+                </a:solidFill>
+                <a:latin typeface="Menlo"/>
+                <a:ea typeface="Menlo"/>
+                <a:cs typeface="Menlo"/>
+              </a:defRPr>
+            </a:pPr>
+            <a:r>
+              <a:rPr sz="1725" b="0">
+                <a:solidFill>
+                  <a:srgbClr val="B7EDDB"/>
+                </a:solidFill>
+                <a:latin typeface="Menlo"/>
+                <a:ea typeface="Menlo"/>
+                <a:cs typeface="Menlo"/>
+              </a:rPr>
+              <a:t>(cd "$B" &amp;&amp; ctest --output-on-failure)</a:t>
+            </a:r>
+          </a:p>
+        </p:txBody>
+      </p:sp>
+      <p:sp>
+        <p:nvSpPr>
+          <p:cNvPr id="18" name="">
+            <a:extLst xmlns:a="http://schemas.openxmlformats.org/drawingml/2006/main">
+              <a:ext uri="{FF2B5EF4-FFF2-40B4-BE49-F238E27FC236}">
+                <a16:creationId xmlns:a16="http://schemas.microsoft.com/office/drawing/2014/main" id="{82D30D09-EADC-4F82-9C2F-DC571E6393A4}"/>
+              </a:ext>
+            </a:extLst>
+          </p:cNvPr>
+          <p:cNvSpPr>
+            <a:spLocks xmlns:a="http://schemas.openxmlformats.org/drawingml/2006/main" noGrp="1"/>
+          </p:cNvSpPr>
+          <p:nvPr/>
+        </p:nvSpPr>
+        <p:spPr>
+          <a:xfrm xmlns:a="http://schemas.openxmlformats.org/drawingml/2006/main">
+            <a:off x="7743825" y="4743450"/>
+            <a:ext cx="6810375" cy="523875"/>
+          </a:xfrm>
+          <a:prstGeom xmlns:a="http://schemas.openxmlformats.org/drawingml/2006/main" prst="rect">
+            <a:avLst/>
+          </a:prstGeom>
+          <a:noFill xmlns:a="http://schemas.openxmlformats.org/drawingml/2006/main"/>
+          <a:ln xmlns:a="http://schemas.openxmlformats.org/drawingml/2006/main" w="0">
+            <a:noFill/>
+          </a:ln>
+        </p:spPr>
+        <p:txBody>
+          <a:bodyPr xmlns:a="http://schemas.openxmlformats.org/drawingml/2006/main" wrap="none" lIns="0" tIns="0" rIns="0" bIns="0" anchor="t">
+            <a:noAutofit/>
+          </a:bodyPr>
+          <a:lstStyle xmlns:a="http://schemas.openxmlformats.org/drawingml/2006/main"/>
+          <a:p xmlns:a="http://schemas.openxmlformats.org/drawingml/2006/main">
+            <a:pPr>
+              <a:buNone/>
+              <a:defRPr sz="1725" b="0">
+                <a:solidFill>
+                  <a:srgbClr val="B7EDDB"/>
+                </a:solidFill>
+                <a:latin typeface="Menlo"/>
+                <a:ea typeface="Menlo"/>
+                <a:cs typeface="Menlo"/>
+              </a:defRPr>
+            </a:pPr>
+            <a:r>
+              <a:rPr sz="1725" b="0">
+                <a:solidFill>
+                  <a:srgbClr val="B7EDDB"/>
+                </a:solidFill>
+                <a:latin typeface="Menlo"/>
+                <a:ea typeface="Menlo"/>
+                <a:cs typeface="Menlo"/>
+              </a:rPr>
+              <a:t>srun --cpu-bind=cores "$B/reg_reuse" 6 12 24 48</a:t>
+            </a:r>
+          </a:p>
+        </p:txBody>
+      </p:sp>
+      <p:sp>
+        <p:nvSpPr>
+          <p:cNvPr id="19" name="">
+            <a:extLst xmlns:a="http://schemas.openxmlformats.org/drawingml/2006/main">
+              <a:ext uri="{FF2B5EF4-FFF2-40B4-BE49-F238E27FC236}">
+                <a16:creationId xmlns:a16="http://schemas.microsoft.com/office/drawing/2014/main" id="{3CEFDEFA-74FD-4B2D-A80C-D976BED8B0C1}"/>
+              </a:ext>
+            </a:extLst>
+          </p:cNvPr>
+          <p:cNvSpPr>
+            <a:spLocks xmlns:a="http://schemas.openxmlformats.org/drawingml/2006/main" noGrp="1"/>
+          </p:cNvSpPr>
+          <p:nvPr/>
+        </p:nvSpPr>
+        <p:spPr>
+          <a:xfrm xmlns:a="http://schemas.openxmlformats.org/drawingml/2006/main">
+            <a:off x="7743825" y="5191125"/>
+            <a:ext cx="6810375" cy="523875"/>
+          </a:xfrm>
+          <a:prstGeom xmlns:a="http://schemas.openxmlformats.org/drawingml/2006/main" prst="rect">
+            <a:avLst/>
+          </a:prstGeom>
+          <a:noFill xmlns:a="http://schemas.openxmlformats.org/drawingml/2006/main"/>
+          <a:ln xmlns:a="http://schemas.openxmlformats.org/drawingml/2006/main" w="0">
+            <a:noFill/>
+          </a:ln>
+        </p:spPr>
+        <p:txBody>
+          <a:bodyPr xmlns:a="http://schemas.openxmlformats.org/drawingml/2006/main" wrap="none" lIns="0" tIns="0" rIns="0" bIns="0" anchor="t">
+            <a:noAutofit/>
+          </a:bodyPr>
+          <a:lstStyle xmlns:a="http://schemas.openxmlformats.org/drawingml/2006/main"/>
+          <a:p xmlns:a="http://schemas.openxmlformats.org/drawingml/2006/main">
+            <a:pPr>
+              <a:buNone/>
+              <a:defRPr sz="1725" b="0">
+                <a:solidFill>
+                  <a:srgbClr val="B7EDDB"/>
+                </a:solidFill>
+                <a:latin typeface="Menlo"/>
+                <a:ea typeface="Menlo"/>
+                <a:cs typeface="Menlo"/>
+              </a:defRPr>
+            </a:pPr>
+            <a:r>
+              <a:rPr sz="1725" b="0">
+                <a:solidFill>
+                  <a:srgbClr val="B7EDDB"/>
+                </a:solidFill>
+                <a:latin typeface="Menlo"/>
+                <a:ea typeface="Menlo"/>
+                <a:cs typeface="Menlo"/>
+              </a:rPr>
+              <a:t>srun --cpu-bind=cores "$B/cache_part3" 48 6</a:t>
+            </a:r>
+          </a:p>
+        </p:txBody>
+      </p:sp>
+      <p:sp>
+        <p:nvSpPr>
+          <p:cNvPr id="20" name="">
+            <a:extLst xmlns:a="http://schemas.openxmlformats.org/drawingml/2006/main">
+              <a:ext uri="{FF2B5EF4-FFF2-40B4-BE49-F238E27FC236}">
+                <a16:creationId xmlns:a16="http://schemas.microsoft.com/office/drawing/2014/main" id="{67B726F1-DC39-4394-B788-A38D4B6AA784}"/>
+              </a:ext>
+            </a:extLst>
+          </p:cNvPr>
+          <p:cNvSpPr>
+            <a:spLocks xmlns:a="http://schemas.openxmlformats.org/drawingml/2006/main" noGrp="1"/>
+          </p:cNvSpPr>
+          <p:nvPr/>
+        </p:nvSpPr>
+        <p:spPr>
+          <a:xfrm xmlns:a="http://schemas.openxmlformats.org/drawingml/2006/main">
+            <a:off x="7743825" y="5638800"/>
+            <a:ext cx="6810375" cy="523875"/>
+          </a:xfrm>
+          <a:prstGeom xmlns:a="http://schemas.openxmlformats.org/drawingml/2006/main" prst="rect">
+            <a:avLst/>
+          </a:prstGeom>
+          <a:noFill xmlns:a="http://schemas.openxmlformats.org/drawingml/2006/main"/>
+          <a:ln xmlns:a="http://schemas.openxmlformats.org/drawingml/2006/main" w="0">
+            <a:noFill/>
+          </a:ln>
+        </p:spPr>
+        <p:txBody>
+          <a:bodyPr xmlns:a="http://schemas.openxmlformats.org/drawingml/2006/main" wrap="none" lIns="0" tIns="0" rIns="0" bIns="0" anchor="t">
+            <a:noAutofit/>
+          </a:bodyPr>
+          <a:lstStyle xmlns:a="http://schemas.openxmlformats.org/drawingml/2006/main"/>
+          <a:p xmlns:a="http://schemas.openxmlformats.org/drawingml/2006/main">
+            <a:pPr>
+              <a:buNone/>
+              <a:defRPr sz="1725" b="0">
+                <a:solidFill>
+                  <a:srgbClr val="B7EDDB"/>
+                </a:solidFill>
+                <a:latin typeface="Menlo"/>
+                <a:ea typeface="Menlo"/>
+                <a:cs typeface="Menlo"/>
+              </a:defRPr>
+            </a:pPr>
+            <a:r>
+              <a:rPr sz="1725" b="0">
+                <a:solidFill>
+                  <a:srgbClr val="B7EDDB"/>
+                </a:solidFill>
+                <a:latin typeface="Menlo"/>
+                <a:ea typeface="Menlo"/>
+                <a:cs typeface="Menlo"/>
+              </a:rPr>
+              <a:t>for opt in 0 1 2 3; do</a:t>
+            </a:r>
+          </a:p>
+        </p:txBody>
+      </p:sp>
+      <p:sp>
+        <p:nvSpPr>
+          <p:cNvPr id="21" name="">
+            <a:extLst xmlns:a="http://schemas.openxmlformats.org/drawingml/2006/main">
+              <a:ext uri="{FF2B5EF4-FFF2-40B4-BE49-F238E27FC236}">
+                <a16:creationId xmlns:a16="http://schemas.microsoft.com/office/drawing/2014/main" id="{C17C360F-FDC1-4892-A83F-C628121ADFBE}"/>
+              </a:ext>
+            </a:extLst>
+          </p:cNvPr>
+          <p:cNvSpPr>
+            <a:spLocks xmlns:a="http://schemas.openxmlformats.org/drawingml/2006/main" noGrp="1"/>
+          </p:cNvSpPr>
+          <p:nvPr/>
+        </p:nvSpPr>
+        <p:spPr>
+          <a:xfrm xmlns:a="http://schemas.openxmlformats.org/drawingml/2006/main">
+            <a:off x="7743825" y="6086475"/>
+            <a:ext cx="6810375" cy="523875"/>
+          </a:xfrm>
+          <a:prstGeom xmlns:a="http://schemas.openxmlformats.org/drawingml/2006/main" prst="rect">
+            <a:avLst/>
+          </a:prstGeom>
+          <a:noFill xmlns:a="http://schemas.openxmlformats.org/drawingml/2006/main"/>
+          <a:ln xmlns:a="http://schemas.openxmlformats.org/drawingml/2006/main" w="0">
+            <a:noFill/>
+          </a:ln>
+        </p:spPr>
+        <p:txBody>
+          <a:bodyPr xmlns:a="http://schemas.openxmlformats.org/drawingml/2006/main" wrap="none" lIns="0" tIns="0" rIns="0" bIns="0" anchor="t">
+            <a:noAutofit/>
+          </a:bodyPr>
+          <a:lstStyle xmlns:a="http://schemas.openxmlformats.org/drawingml/2006/main"/>
+          <a:p xmlns:a="http://schemas.openxmlformats.org/drawingml/2006/main">
+            <a:pPr>
+              <a:buNone/>
+              <a:defRPr sz="1725" b="0">
+                <a:solidFill>
+                  <a:srgbClr val="B7EDDB"/>
+                </a:solidFill>
+                <a:latin typeface="Menlo"/>
+                <a:ea typeface="Menlo"/>
+                <a:cs typeface="Menlo"/>
+              </a:defRPr>
+            </a:pPr>
+            <a:r>
+              <a:rPr sz="1725" b="0">
+                <a:solidFill>
+                  <a:srgbClr val="B7EDDB"/>
+                </a:solidFill>
+                <a:latin typeface="Menlo"/>
+                <a:ea typeface="Menlo"/>
+                <a:cs typeface="Menlo"/>
+              </a:rPr>
+              <a:t>  srun --cpu-bind=cores "$B/cache_part4_o$opt" 48 6</a:t>
+            </a:r>
+          </a:p>
+        </p:txBody>
+      </p:sp>
+      <p:sp>
+        <p:nvSpPr>
+          <p:cNvPr id="22" name="">
+            <a:extLst xmlns:a="http://schemas.openxmlformats.org/drawingml/2006/main">
+              <a:ext uri="{FF2B5EF4-FFF2-40B4-BE49-F238E27FC236}">
+                <a16:creationId xmlns:a16="http://schemas.microsoft.com/office/drawing/2014/main" id="{465FF2F7-9ED1-4B7C-A654-4EEA7CAB4575}"/>
+              </a:ext>
+            </a:extLst>
+          </p:cNvPr>
+          <p:cNvSpPr>
+            <a:spLocks xmlns:a="http://schemas.openxmlformats.org/drawingml/2006/main" noGrp="1"/>
+          </p:cNvSpPr>
+          <p:nvPr/>
+        </p:nvSpPr>
+        <p:spPr>
+          <a:xfrm xmlns:a="http://schemas.openxmlformats.org/drawingml/2006/main">
+            <a:off x="7743825" y="6534150"/>
+            <a:ext cx="6810375" cy="523875"/>
+          </a:xfrm>
+          <a:prstGeom xmlns:a="http://schemas.openxmlformats.org/drawingml/2006/main" prst="rect">
+            <a:avLst/>
+          </a:prstGeom>
+          <a:noFill xmlns:a="http://schemas.openxmlformats.org/drawingml/2006/main"/>
+          <a:ln xmlns:a="http://schemas.openxmlformats.org/drawingml/2006/main" w="0">
+            <a:noFill/>
+          </a:ln>
+        </p:spPr>
+        <p:txBody>
+          <a:bodyPr xmlns:a="http://schemas.openxmlformats.org/drawingml/2006/main" wrap="none" lIns="0" tIns="0" rIns="0" bIns="0" anchor="t">
+            <a:noAutofit/>
+          </a:bodyPr>
+          <a:lstStyle xmlns:a="http://schemas.openxmlformats.org/drawingml/2006/main"/>
+          <a:p xmlns:a="http://schemas.openxmlformats.org/drawingml/2006/main">
+            <a:pPr>
+              <a:buNone/>
+              <a:defRPr sz="1725" b="0">
+                <a:solidFill>
+                  <a:srgbClr val="B7EDDB"/>
+                </a:solidFill>
+                <a:latin typeface="Menlo"/>
+                <a:ea typeface="Menlo"/>
+                <a:cs typeface="Menlo"/>
+              </a:defRPr>
+            </a:pPr>
+            <a:r>
+              <a:rPr sz="1725" b="0">
+                <a:solidFill>
+                  <a:srgbClr val="B7EDDB"/>
+                </a:solidFill>
+                <a:latin typeface="Menlo"/>
+                <a:ea typeface="Menlo"/>
+                <a:cs typeface="Menlo"/>
+              </a:rPr>
+              <a:t>done</a:t>
+            </a:r>
+          </a:p>
+        </p:txBody>
+      </p:sp>
+      <p:sp>
+        <p:nvSpPr>
+          <p:cNvPr id="23" name="">
+            <a:extLst xmlns:a="http://schemas.openxmlformats.org/drawingml/2006/main">
+              <a:ext uri="{FF2B5EF4-FFF2-40B4-BE49-F238E27FC236}">
+                <a16:creationId xmlns:a16="http://schemas.microsoft.com/office/drawing/2014/main" id="{FE776CDA-94D2-4EC6-870F-E0C799743627}"/>
+              </a:ext>
+            </a:extLst>
+          </p:cNvPr>
+          <p:cNvSpPr>
+            <a:spLocks xmlns:a="http://schemas.openxmlformats.org/drawingml/2006/main" noGrp="1"/>
+          </p:cNvSpPr>
+          <p:nvPr/>
+        </p:nvSpPr>
+        <p:spPr>
+          <a:xfrm xmlns:a="http://schemas.openxmlformats.org/drawingml/2006/main">
+            <a:off x="876300" y="7467600"/>
+            <a:ext cx="13192125" cy="533400"/>
+          </a:xfrm>
+          <a:prstGeom xmlns:a="http://schemas.openxmlformats.org/drawingml/2006/main" prst="rect">
+            <a:avLst/>
+          </a:prstGeom>
+          <a:noFill xmlns:a="http://schemas.openxmlformats.org/drawingml/2006/main"/>
+          <a:ln xmlns:a="http://schemas.openxmlformats.org/drawingml/2006/main" w="0">
+            <a:noFill/>
+          </a:ln>
+        </p:spPr>
+        <p:txBody>
+          <a:bodyPr xmlns:a="http://schemas.openxmlformats.org/drawingml/2006/main" wrap="none" lIns="0" tIns="0" rIns="0" bIns="0" anchor="t">
+            <a:noAutofit/>
+          </a:bodyPr>
+          <a:lstStyle xmlns:a="http://schemas.openxmlformats.org/drawingml/2006/main"/>
+          <a:p xmlns:a="http://schemas.openxmlformats.org/drawingml/2006/main">
+            <a:pPr>
+              <a:buNone/>
+              <a:defRPr sz="1875" b="0">
+                <a:solidFill>
+                  <a:srgbClr val="A8C6C4"/>
+                </a:solidFill>
+                <a:latin typeface="Hiragino Sans GB"/>
+                <a:ea typeface="Hiragino Sans GB"/>
+                <a:cs typeface="Hiragino Sans GB"/>
+              </a:defRPr>
+            </a:pPr>
+            <a:r>
+              <a:rPr sz="1875" b="0">
+                <a:solidFill>
+                  <a:srgbClr val="A8C6C4"/>
+                </a:solidFill>
+                <a:latin typeface="Hiragino Sans GB"/>
+                <a:ea typeface="Hiragino Sans GB"/>
+                <a:cs typeface="Hiragino Sans GB"/>
+              </a:rPr>
+              <a:t>先创建 results，再从仓库根目录提交。任一步失败即停止；CMake 模块以实际列表为准。</a:t>
+            </a:r>
+          </a:p>
+        </p:txBody>
+      </p:sp>
+      <p:sp>
+        <p:nvSpPr>
+          <p:cNvPr id="25" name="audit-23">
+            <a:extLst xmlns:a="http://schemas.openxmlformats.org/drawingml/2006/main">
+              <a:ext uri="{FF2B5EF4-FFF2-40B4-BE49-F238E27FC236}">
+                <a16:creationId xmlns:a16="http://schemas.microsoft.com/office/drawing/2014/main" id="{66DB346E-4BE5-47F7-AE65-F8A63A912EB9}"/>
+              </a:ext>
+            </a:extLst>
+          </p:cNvPr>
+          <p:cNvSpPr>
+            <a:spLocks xmlns:a="http://schemas.openxmlformats.org/drawingml/2006/main" noGrp="1"/>
+          </p:cNvSpPr>
+          <p:nvPr/>
+        </p:nvSpPr>
+        <p:spPr>
+          <a:xfrm xmlns:a="http://schemas.openxmlformats.org/drawingml/2006/main">
             <a:off x="876300" y="6086475"/>
             <a:ext cx="6667500" cy="523875"/>
           </a:xfrm>
@@ -11320,14 +12398,13 @@
           </a:ln>
         </p:spPr>
         <p:txBody>
-          <a:bodyPr xmlns:a="http://schemas.openxmlformats.org/drawingml/2006/main" wrap="none" lIns="0" tIns="0" rIns="0" bIns="0" anchor="t">
-            <a:noAutofit/>
-          </a:bodyPr>
-          <a:lstStyle xmlns:a="http://schemas.openxmlformats.org/drawingml/2006/main"/>
-          <a:p xmlns:a="http://schemas.openxmlformats.org/drawingml/2006/main">
-            <a:pPr>
-              <a:buNone/>
-              <a:defRPr sz="1875" b="0">
+          <a:bodyPr xmlns:a="http://schemas.openxmlformats.org/drawingml/2006/main" wrap="none">
+            <a:noAutofit/>
+          </a:bodyPr>
+          <a:lstStyle xmlns:a="http://schemas.openxmlformats.org/drawingml/2006/main"/>
+          <a:p xmlns:a="http://schemas.openxmlformats.org/drawingml/2006/main">
+            <a:pPr>
+              <a:defRPr sz="2100">
                 <a:solidFill>
                   <a:srgbClr val="B7EDDB"/>
                 </a:solidFill>
@@ -11337,7 +12414,7 @@
               </a:defRPr>
             </a:pPr>
             <a:r>
-              <a:rPr sz="1875" b="0">
+              <a:rPr sz="2100">
                 <a:solidFill>
                   <a:srgbClr val="B7EDDB"/>
                 </a:solidFill>
@@ -11345,645 +12422,7 @@
                 <a:ea typeface="Menlo"/>
                 <a:cs typeface="Menlo"/>
               </a:rPr>
-              <a:t>B="build/pi2-lab2-$SLURM_JOB_ID"</a:t>
-            </a:r>
-          </a:p>
-        </p:txBody>
-      </p:sp>
-      <p:sp>
-        <p:nvSpPr>
-          <p:cNvPr id="13" name="">
-            <a:extLst xmlns:a="http://schemas.openxmlformats.org/drawingml/2006/main">
-              <a:ext uri="{FF2B5EF4-FFF2-40B4-BE49-F238E27FC236}">
-                <a16:creationId xmlns:a16="http://schemas.microsoft.com/office/drawing/2014/main" id="{35858B7D-F7EE-49B1-BA07-C07742C5AAAA}"/>
-              </a:ext>
-            </a:extLst>
-          </p:cNvPr>
-          <p:cNvSpPr>
-            <a:spLocks xmlns:a="http://schemas.openxmlformats.org/drawingml/2006/main" noGrp="1"/>
-          </p:cNvSpPr>
-          <p:nvPr/>
-        </p:nvSpPr>
-        <p:spPr>
-          <a:xfrm xmlns:a="http://schemas.openxmlformats.org/drawingml/2006/main">
-            <a:off x="7743825" y="2505075"/>
-            <a:ext cx="6810375" cy="523875"/>
-          </a:xfrm>
-          <a:prstGeom xmlns:a="http://schemas.openxmlformats.org/drawingml/2006/main" prst="rect">
-            <a:avLst/>
-          </a:prstGeom>
-          <a:noFill xmlns:a="http://schemas.openxmlformats.org/drawingml/2006/main"/>
-          <a:ln xmlns:a="http://schemas.openxmlformats.org/drawingml/2006/main" w="0">
-            <a:noFill/>
-          </a:ln>
-        </p:spPr>
-        <p:txBody>
-          <a:bodyPr xmlns:a="http://schemas.openxmlformats.org/drawingml/2006/main" wrap="none" lIns="0" tIns="0" rIns="0" bIns="0" anchor="t">
-            <a:noAutofit/>
-          </a:bodyPr>
-          <a:lstStyle xmlns:a="http://schemas.openxmlformats.org/drawingml/2006/main"/>
-          <a:p xmlns:a="http://schemas.openxmlformats.org/drawingml/2006/main">
-            <a:pPr>
-              <a:buNone/>
-              <a:defRPr sz="1725" b="0">
-                <a:solidFill>
-                  <a:srgbClr val="B7EDDB"/>
-                </a:solidFill>
-                <a:latin typeface="Menlo"/>
-                <a:ea typeface="Menlo"/>
-                <a:cs typeface="Menlo"/>
-              </a:defRPr>
-            </a:pPr>
-            <a:r>
-              <a:rPr sz="1725" b="0">
-                <a:solidFill>
-                  <a:srgbClr val="B7EDDB"/>
-                </a:solidFill>
-                <a:latin typeface="Menlo"/>
-                <a:ea typeface="Menlo"/>
-                <a:cs typeface="Menlo"/>
-              </a:rPr>
-              <a:t>cmake -S labs/lab2-matrix -B "$B" \</a:t>
-            </a:r>
-          </a:p>
-        </p:txBody>
-      </p:sp>
-      <p:sp>
-        <p:nvSpPr>
-          <p:cNvPr id="14" name="">
-            <a:extLst xmlns:a="http://schemas.openxmlformats.org/drawingml/2006/main">
-              <a:ext uri="{FF2B5EF4-FFF2-40B4-BE49-F238E27FC236}">
-                <a16:creationId xmlns:a16="http://schemas.microsoft.com/office/drawing/2014/main" id="{304483B2-D9A9-416A-BBD2-3671822F5DEF}"/>
-              </a:ext>
-            </a:extLst>
-          </p:cNvPr>
-          <p:cNvSpPr>
-            <a:spLocks xmlns:a="http://schemas.openxmlformats.org/drawingml/2006/main" noGrp="1"/>
-          </p:cNvSpPr>
-          <p:nvPr/>
-        </p:nvSpPr>
-        <p:spPr>
-          <a:xfrm xmlns:a="http://schemas.openxmlformats.org/drawingml/2006/main">
-            <a:off x="7743825" y="2952750"/>
-            <a:ext cx="6810375" cy="523875"/>
-          </a:xfrm>
-          <a:prstGeom xmlns:a="http://schemas.openxmlformats.org/drawingml/2006/main" prst="rect">
-            <a:avLst/>
-          </a:prstGeom>
-          <a:noFill xmlns:a="http://schemas.openxmlformats.org/drawingml/2006/main"/>
-          <a:ln xmlns:a="http://schemas.openxmlformats.org/drawingml/2006/main" w="0">
-            <a:noFill/>
-          </a:ln>
-        </p:spPr>
-        <p:txBody>
-          <a:bodyPr xmlns:a="http://schemas.openxmlformats.org/drawingml/2006/main" wrap="none" lIns="0" tIns="0" rIns="0" bIns="0" anchor="t">
-            <a:noAutofit/>
-          </a:bodyPr>
-          <a:lstStyle xmlns:a="http://schemas.openxmlformats.org/drawingml/2006/main"/>
-          <a:p xmlns:a="http://schemas.openxmlformats.org/drawingml/2006/main">
-            <a:pPr>
-              <a:buNone/>
-              <a:defRPr sz="1725" b="0">
-                <a:solidFill>
-                  <a:srgbClr val="B7EDDB"/>
-                </a:solidFill>
-                <a:latin typeface="Menlo"/>
-                <a:ea typeface="Menlo"/>
-                <a:cs typeface="Menlo"/>
-              </a:defRPr>
-            </a:pPr>
-            <a:r>
-              <a:rPr sz="1725" b="0">
-                <a:solidFill>
-                  <a:srgbClr val="B7EDDB"/>
-                </a:solidFill>
-                <a:latin typeface="Menlo"/>
-                <a:ea typeface="Menlo"/>
-                <a:cs typeface="Menlo"/>
-              </a:rPr>
-              <a:t>  -DBUILD_TESTING=ON \</a:t>
-            </a:r>
-          </a:p>
-        </p:txBody>
-      </p:sp>
-      <p:sp>
-        <p:nvSpPr>
-          <p:cNvPr id="15" name="">
-            <a:extLst xmlns:a="http://schemas.openxmlformats.org/drawingml/2006/main">
-              <a:ext uri="{FF2B5EF4-FFF2-40B4-BE49-F238E27FC236}">
-                <a16:creationId xmlns:a16="http://schemas.microsoft.com/office/drawing/2014/main" id="{DF2E9BA5-C49E-4D19-881C-D096A9A3F6ED}"/>
-              </a:ext>
-            </a:extLst>
-          </p:cNvPr>
-          <p:cNvSpPr>
-            <a:spLocks xmlns:a="http://schemas.openxmlformats.org/drawingml/2006/main" noGrp="1"/>
-          </p:cNvSpPr>
-          <p:nvPr/>
-        </p:nvSpPr>
-        <p:spPr>
-          <a:xfrm xmlns:a="http://schemas.openxmlformats.org/drawingml/2006/main">
-            <a:off x="7743825" y="3400425"/>
-            <a:ext cx="6810375" cy="523875"/>
-          </a:xfrm>
-          <a:prstGeom xmlns:a="http://schemas.openxmlformats.org/drawingml/2006/main" prst="rect">
-            <a:avLst/>
-          </a:prstGeom>
-          <a:noFill xmlns:a="http://schemas.openxmlformats.org/drawingml/2006/main"/>
-          <a:ln xmlns:a="http://schemas.openxmlformats.org/drawingml/2006/main" w="0">
-            <a:noFill/>
-          </a:ln>
-        </p:spPr>
-        <p:txBody>
-          <a:bodyPr xmlns:a="http://schemas.openxmlformats.org/drawingml/2006/main" wrap="none" lIns="0" tIns="0" rIns="0" bIns="0" anchor="t">
-            <a:noAutofit/>
-          </a:bodyPr>
-          <a:lstStyle xmlns:a="http://schemas.openxmlformats.org/drawingml/2006/main"/>
-          <a:p xmlns:a="http://schemas.openxmlformats.org/drawingml/2006/main">
-            <a:pPr>
-              <a:buNone/>
-              <a:defRPr sz="1725" b="0">
-                <a:solidFill>
-                  <a:srgbClr val="B7EDDB"/>
-                </a:solidFill>
-                <a:latin typeface="Menlo"/>
-                <a:ea typeface="Menlo"/>
-                <a:cs typeface="Menlo"/>
-              </a:defRPr>
-            </a:pPr>
-            <a:r>
-              <a:rPr sz="1725" b="0">
-                <a:solidFill>
-                  <a:srgbClr val="B7EDDB"/>
-                </a:solidFill>
-                <a:latin typeface="Menlo"/>
-                <a:ea typeface="Menlo"/>
-                <a:cs typeface="Menlo"/>
-              </a:rPr>
-              <a:t>  -DLAB_USE_SYSTEM_BLAS=OFF</a:t>
-            </a:r>
-          </a:p>
-        </p:txBody>
-      </p:sp>
-      <p:sp>
-        <p:nvSpPr>
-          <p:cNvPr id="16" name="">
-            <a:extLst xmlns:a="http://schemas.openxmlformats.org/drawingml/2006/main">
-              <a:ext uri="{FF2B5EF4-FFF2-40B4-BE49-F238E27FC236}">
-                <a16:creationId xmlns:a16="http://schemas.microsoft.com/office/drawing/2014/main" id="{DEB62359-7DF1-4B72-BDC9-1477374A235F}"/>
-              </a:ext>
-            </a:extLst>
-          </p:cNvPr>
-          <p:cNvSpPr>
-            <a:spLocks xmlns:a="http://schemas.openxmlformats.org/drawingml/2006/main" noGrp="1"/>
-          </p:cNvSpPr>
-          <p:nvPr/>
-        </p:nvSpPr>
-        <p:spPr>
-          <a:xfrm xmlns:a="http://schemas.openxmlformats.org/drawingml/2006/main">
-            <a:off x="7743825" y="3848100"/>
-            <a:ext cx="6810375" cy="523875"/>
-          </a:xfrm>
-          <a:prstGeom xmlns:a="http://schemas.openxmlformats.org/drawingml/2006/main" prst="rect">
-            <a:avLst/>
-          </a:prstGeom>
-          <a:noFill xmlns:a="http://schemas.openxmlformats.org/drawingml/2006/main"/>
-          <a:ln xmlns:a="http://schemas.openxmlformats.org/drawingml/2006/main" w="0">
-            <a:noFill/>
-          </a:ln>
-        </p:spPr>
-        <p:txBody>
-          <a:bodyPr xmlns:a="http://schemas.openxmlformats.org/drawingml/2006/main" wrap="none" lIns="0" tIns="0" rIns="0" bIns="0" anchor="t">
-            <a:noAutofit/>
-          </a:bodyPr>
-          <a:lstStyle xmlns:a="http://schemas.openxmlformats.org/drawingml/2006/main"/>
-          <a:p xmlns:a="http://schemas.openxmlformats.org/drawingml/2006/main">
-            <a:pPr>
-              <a:buNone/>
-              <a:defRPr sz="1725" b="0">
-                <a:solidFill>
-                  <a:srgbClr val="B7EDDB"/>
-                </a:solidFill>
-                <a:latin typeface="Menlo"/>
-                <a:ea typeface="Menlo"/>
-                <a:cs typeface="Menlo"/>
-              </a:defRPr>
-            </a:pPr>
-            <a:r>
-              <a:rPr sz="1725" b="0">
-                <a:solidFill>
-                  <a:srgbClr val="B7EDDB"/>
-                </a:solidFill>
-                <a:latin typeface="Menlo"/>
-                <a:ea typeface="Menlo"/>
-                <a:cs typeface="Menlo"/>
-              </a:rPr>
-              <a:t>cmake --build "$B" --parallel 1</a:t>
-            </a:r>
-          </a:p>
-        </p:txBody>
-      </p:sp>
-      <p:sp>
-        <p:nvSpPr>
-          <p:cNvPr id="17" name="">
-            <a:extLst xmlns:a="http://schemas.openxmlformats.org/drawingml/2006/main">
-              <a:ext uri="{FF2B5EF4-FFF2-40B4-BE49-F238E27FC236}">
-                <a16:creationId xmlns:a16="http://schemas.microsoft.com/office/drawing/2014/main" id="{19772A91-9F87-41A5-814E-709C0364D543}"/>
-              </a:ext>
-            </a:extLst>
-          </p:cNvPr>
-          <p:cNvSpPr>
-            <a:spLocks xmlns:a="http://schemas.openxmlformats.org/drawingml/2006/main" noGrp="1"/>
-          </p:cNvSpPr>
-          <p:nvPr/>
-        </p:nvSpPr>
-        <p:spPr>
-          <a:xfrm xmlns:a="http://schemas.openxmlformats.org/drawingml/2006/main">
-            <a:off x="7743825" y="4295775"/>
-            <a:ext cx="6810375" cy="523875"/>
-          </a:xfrm>
-          <a:prstGeom xmlns:a="http://schemas.openxmlformats.org/drawingml/2006/main" prst="rect">
-            <a:avLst/>
-          </a:prstGeom>
-          <a:noFill xmlns:a="http://schemas.openxmlformats.org/drawingml/2006/main"/>
-          <a:ln xmlns:a="http://schemas.openxmlformats.org/drawingml/2006/main" w="0">
-            <a:noFill/>
-          </a:ln>
-        </p:spPr>
-        <p:txBody>
-          <a:bodyPr xmlns:a="http://schemas.openxmlformats.org/drawingml/2006/main" wrap="none" lIns="0" tIns="0" rIns="0" bIns="0" anchor="t">
-            <a:noAutofit/>
-          </a:bodyPr>
-          <a:lstStyle xmlns:a="http://schemas.openxmlformats.org/drawingml/2006/main"/>
-          <a:p xmlns:a="http://schemas.openxmlformats.org/drawingml/2006/main">
-            <a:pPr>
-              <a:buNone/>
-              <a:defRPr sz="1725" b="0">
-                <a:solidFill>
-                  <a:srgbClr val="B7EDDB"/>
-                </a:solidFill>
-                <a:latin typeface="Menlo"/>
-                <a:ea typeface="Menlo"/>
-                <a:cs typeface="Menlo"/>
-              </a:defRPr>
-            </a:pPr>
-            <a:r>
-              <a:rPr sz="1725" b="0">
-                <a:solidFill>
-                  <a:srgbClr val="B7EDDB"/>
-                </a:solidFill>
-                <a:latin typeface="Menlo"/>
-                <a:ea typeface="Menlo"/>
-                <a:cs typeface="Menlo"/>
-              </a:rPr>
-              <a:t>(cd "$B" &amp;&amp; ctest --output-on-failure)</a:t>
-            </a:r>
-          </a:p>
-        </p:txBody>
-      </p:sp>
-      <p:sp>
-        <p:nvSpPr>
-          <p:cNvPr id="18" name="">
-            <a:extLst xmlns:a="http://schemas.openxmlformats.org/drawingml/2006/main">
-              <a:ext uri="{FF2B5EF4-FFF2-40B4-BE49-F238E27FC236}">
-                <a16:creationId xmlns:a16="http://schemas.microsoft.com/office/drawing/2014/main" id="{82D30D09-EADC-4F82-9C2F-DC571E6393A4}"/>
-              </a:ext>
-            </a:extLst>
-          </p:cNvPr>
-          <p:cNvSpPr>
-            <a:spLocks xmlns:a="http://schemas.openxmlformats.org/drawingml/2006/main" noGrp="1"/>
-          </p:cNvSpPr>
-          <p:nvPr/>
-        </p:nvSpPr>
-        <p:spPr>
-          <a:xfrm xmlns:a="http://schemas.openxmlformats.org/drawingml/2006/main">
-            <a:off x="7743825" y="4743450"/>
-            <a:ext cx="6810375" cy="523875"/>
-          </a:xfrm>
-          <a:prstGeom xmlns:a="http://schemas.openxmlformats.org/drawingml/2006/main" prst="rect">
-            <a:avLst/>
-          </a:prstGeom>
-          <a:noFill xmlns:a="http://schemas.openxmlformats.org/drawingml/2006/main"/>
-          <a:ln xmlns:a="http://schemas.openxmlformats.org/drawingml/2006/main" w="0">
-            <a:noFill/>
-          </a:ln>
-        </p:spPr>
-        <p:txBody>
-          <a:bodyPr xmlns:a="http://schemas.openxmlformats.org/drawingml/2006/main" wrap="none" lIns="0" tIns="0" rIns="0" bIns="0" anchor="t">
-            <a:noAutofit/>
-          </a:bodyPr>
-          <a:lstStyle xmlns:a="http://schemas.openxmlformats.org/drawingml/2006/main"/>
-          <a:p xmlns:a="http://schemas.openxmlformats.org/drawingml/2006/main">
-            <a:pPr>
-              <a:buNone/>
-              <a:defRPr sz="1725" b="0">
-                <a:solidFill>
-                  <a:srgbClr val="B7EDDB"/>
-                </a:solidFill>
-                <a:latin typeface="Menlo"/>
-                <a:ea typeface="Menlo"/>
-                <a:cs typeface="Menlo"/>
-              </a:defRPr>
-            </a:pPr>
-            <a:r>
-              <a:rPr sz="1725" b="0">
-                <a:solidFill>
-                  <a:srgbClr val="B7EDDB"/>
-                </a:solidFill>
-                <a:latin typeface="Menlo"/>
-                <a:ea typeface="Menlo"/>
-                <a:cs typeface="Menlo"/>
-              </a:rPr>
-              <a:t>srun --cpu-bind=cores "$B/reg_reuse" 6 12 24 48</a:t>
-            </a:r>
-          </a:p>
-        </p:txBody>
-      </p:sp>
-      <p:sp>
-        <p:nvSpPr>
-          <p:cNvPr id="19" name="">
-            <a:extLst xmlns:a="http://schemas.openxmlformats.org/drawingml/2006/main">
-              <a:ext uri="{FF2B5EF4-FFF2-40B4-BE49-F238E27FC236}">
-                <a16:creationId xmlns:a16="http://schemas.microsoft.com/office/drawing/2014/main" id="{3CEFDEFA-74FD-4B2D-A80C-D976BED8B0C1}"/>
-              </a:ext>
-            </a:extLst>
-          </p:cNvPr>
-          <p:cNvSpPr>
-            <a:spLocks xmlns:a="http://schemas.openxmlformats.org/drawingml/2006/main" noGrp="1"/>
-          </p:cNvSpPr>
-          <p:nvPr/>
-        </p:nvSpPr>
-        <p:spPr>
-          <a:xfrm xmlns:a="http://schemas.openxmlformats.org/drawingml/2006/main">
-            <a:off x="7743825" y="5191125"/>
-            <a:ext cx="6810375" cy="523875"/>
-          </a:xfrm>
-          <a:prstGeom xmlns:a="http://schemas.openxmlformats.org/drawingml/2006/main" prst="rect">
-            <a:avLst/>
-          </a:prstGeom>
-          <a:noFill xmlns:a="http://schemas.openxmlformats.org/drawingml/2006/main"/>
-          <a:ln xmlns:a="http://schemas.openxmlformats.org/drawingml/2006/main" w="0">
-            <a:noFill/>
-          </a:ln>
-        </p:spPr>
-        <p:txBody>
-          <a:bodyPr xmlns:a="http://schemas.openxmlformats.org/drawingml/2006/main" wrap="none" lIns="0" tIns="0" rIns="0" bIns="0" anchor="t">
-            <a:noAutofit/>
-          </a:bodyPr>
-          <a:lstStyle xmlns:a="http://schemas.openxmlformats.org/drawingml/2006/main"/>
-          <a:p xmlns:a="http://schemas.openxmlformats.org/drawingml/2006/main">
-            <a:pPr>
-              <a:buNone/>
-              <a:defRPr sz="1725" b="0">
-                <a:solidFill>
-                  <a:srgbClr val="B7EDDB"/>
-                </a:solidFill>
-                <a:latin typeface="Menlo"/>
-                <a:ea typeface="Menlo"/>
-                <a:cs typeface="Menlo"/>
-              </a:defRPr>
-            </a:pPr>
-            <a:r>
-              <a:rPr sz="1725" b="0">
-                <a:solidFill>
-                  <a:srgbClr val="B7EDDB"/>
-                </a:solidFill>
-                <a:latin typeface="Menlo"/>
-                <a:ea typeface="Menlo"/>
-                <a:cs typeface="Menlo"/>
-              </a:rPr>
-              <a:t>srun --cpu-bind=cores "$B/cache_part3" 48 6</a:t>
-            </a:r>
-          </a:p>
-        </p:txBody>
-      </p:sp>
-      <p:sp>
-        <p:nvSpPr>
-          <p:cNvPr id="20" name="">
-            <a:extLst xmlns:a="http://schemas.openxmlformats.org/drawingml/2006/main">
-              <a:ext uri="{FF2B5EF4-FFF2-40B4-BE49-F238E27FC236}">
-                <a16:creationId xmlns:a16="http://schemas.microsoft.com/office/drawing/2014/main" id="{67B726F1-DC39-4394-B788-A38D4B6AA784}"/>
-              </a:ext>
-            </a:extLst>
-          </p:cNvPr>
-          <p:cNvSpPr>
-            <a:spLocks xmlns:a="http://schemas.openxmlformats.org/drawingml/2006/main" noGrp="1"/>
-          </p:cNvSpPr>
-          <p:nvPr/>
-        </p:nvSpPr>
-        <p:spPr>
-          <a:xfrm xmlns:a="http://schemas.openxmlformats.org/drawingml/2006/main">
-            <a:off x="7743825" y="5638800"/>
-            <a:ext cx="6810375" cy="523875"/>
-          </a:xfrm>
-          <a:prstGeom xmlns:a="http://schemas.openxmlformats.org/drawingml/2006/main" prst="rect">
-            <a:avLst/>
-          </a:prstGeom>
-          <a:noFill xmlns:a="http://schemas.openxmlformats.org/drawingml/2006/main"/>
-          <a:ln xmlns:a="http://schemas.openxmlformats.org/drawingml/2006/main" w="0">
-            <a:noFill/>
-          </a:ln>
-        </p:spPr>
-        <p:txBody>
-          <a:bodyPr xmlns:a="http://schemas.openxmlformats.org/drawingml/2006/main" wrap="none" lIns="0" tIns="0" rIns="0" bIns="0" anchor="t">
-            <a:noAutofit/>
-          </a:bodyPr>
-          <a:lstStyle xmlns:a="http://schemas.openxmlformats.org/drawingml/2006/main"/>
-          <a:p xmlns:a="http://schemas.openxmlformats.org/drawingml/2006/main">
-            <a:pPr>
-              <a:buNone/>
-              <a:defRPr sz="1725" b="0">
-                <a:solidFill>
-                  <a:srgbClr val="B7EDDB"/>
-                </a:solidFill>
-                <a:latin typeface="Menlo"/>
-                <a:ea typeface="Menlo"/>
-                <a:cs typeface="Menlo"/>
-              </a:defRPr>
-            </a:pPr>
-            <a:r>
-              <a:rPr sz="1725" b="0">
-                <a:solidFill>
-                  <a:srgbClr val="B7EDDB"/>
-                </a:solidFill>
-                <a:latin typeface="Menlo"/>
-                <a:ea typeface="Menlo"/>
-                <a:cs typeface="Menlo"/>
-              </a:rPr>
-              <a:t>for opt in 0 1 2 3; do</a:t>
-            </a:r>
-          </a:p>
-        </p:txBody>
-      </p:sp>
-      <p:sp>
-        <p:nvSpPr>
-          <p:cNvPr id="21" name="">
-            <a:extLst xmlns:a="http://schemas.openxmlformats.org/drawingml/2006/main">
-              <a:ext uri="{FF2B5EF4-FFF2-40B4-BE49-F238E27FC236}">
-                <a16:creationId xmlns:a16="http://schemas.microsoft.com/office/drawing/2014/main" id="{C17C360F-FDC1-4892-A83F-C628121ADFBE}"/>
-              </a:ext>
-            </a:extLst>
-          </p:cNvPr>
-          <p:cNvSpPr>
-            <a:spLocks xmlns:a="http://schemas.openxmlformats.org/drawingml/2006/main" noGrp="1"/>
-          </p:cNvSpPr>
-          <p:nvPr/>
-        </p:nvSpPr>
-        <p:spPr>
-          <a:xfrm xmlns:a="http://schemas.openxmlformats.org/drawingml/2006/main">
-            <a:off x="7743825" y="6086475"/>
-            <a:ext cx="6810375" cy="523875"/>
-          </a:xfrm>
-          <a:prstGeom xmlns:a="http://schemas.openxmlformats.org/drawingml/2006/main" prst="rect">
-            <a:avLst/>
-          </a:prstGeom>
-          <a:noFill xmlns:a="http://schemas.openxmlformats.org/drawingml/2006/main"/>
-          <a:ln xmlns:a="http://schemas.openxmlformats.org/drawingml/2006/main" w="0">
-            <a:noFill/>
-          </a:ln>
-        </p:spPr>
-        <p:txBody>
-          <a:bodyPr xmlns:a="http://schemas.openxmlformats.org/drawingml/2006/main" wrap="none" lIns="0" tIns="0" rIns="0" bIns="0" anchor="t">
-            <a:noAutofit/>
-          </a:bodyPr>
-          <a:lstStyle xmlns:a="http://schemas.openxmlformats.org/drawingml/2006/main"/>
-          <a:p xmlns:a="http://schemas.openxmlformats.org/drawingml/2006/main">
-            <a:pPr>
-              <a:buNone/>
-              <a:defRPr sz="1725" b="0">
-                <a:solidFill>
-                  <a:srgbClr val="B7EDDB"/>
-                </a:solidFill>
-                <a:latin typeface="Menlo"/>
-                <a:ea typeface="Menlo"/>
-                <a:cs typeface="Menlo"/>
-              </a:defRPr>
-            </a:pPr>
-            <a:r>
-              <a:rPr sz="1725" b="0">
-                <a:solidFill>
-                  <a:srgbClr val="B7EDDB"/>
-                </a:solidFill>
-                <a:latin typeface="Menlo"/>
-                <a:ea typeface="Menlo"/>
-                <a:cs typeface="Menlo"/>
-              </a:rPr>
-              <a:t>  srun --cpu-bind=cores "$B/cache_part4_o$opt" 48 6</a:t>
-            </a:r>
-          </a:p>
-        </p:txBody>
-      </p:sp>
-      <p:sp>
-        <p:nvSpPr>
-          <p:cNvPr id="22" name="">
-            <a:extLst xmlns:a="http://schemas.openxmlformats.org/drawingml/2006/main">
-              <a:ext uri="{FF2B5EF4-FFF2-40B4-BE49-F238E27FC236}">
-                <a16:creationId xmlns:a16="http://schemas.microsoft.com/office/drawing/2014/main" id="{465FF2F7-9ED1-4B7C-A654-4EEA7CAB4575}"/>
-              </a:ext>
-            </a:extLst>
-          </p:cNvPr>
-          <p:cNvSpPr>
-            <a:spLocks xmlns:a="http://schemas.openxmlformats.org/drawingml/2006/main" noGrp="1"/>
-          </p:cNvSpPr>
-          <p:nvPr/>
-        </p:nvSpPr>
-        <p:spPr>
-          <a:xfrm xmlns:a="http://schemas.openxmlformats.org/drawingml/2006/main">
-            <a:off x="7743825" y="6534150"/>
-            <a:ext cx="6810375" cy="523875"/>
-          </a:xfrm>
-          <a:prstGeom xmlns:a="http://schemas.openxmlformats.org/drawingml/2006/main" prst="rect">
-            <a:avLst/>
-          </a:prstGeom>
-          <a:noFill xmlns:a="http://schemas.openxmlformats.org/drawingml/2006/main"/>
-          <a:ln xmlns:a="http://schemas.openxmlformats.org/drawingml/2006/main" w="0">
-            <a:noFill/>
-          </a:ln>
-        </p:spPr>
-        <p:txBody>
-          <a:bodyPr xmlns:a="http://schemas.openxmlformats.org/drawingml/2006/main" wrap="none" lIns="0" tIns="0" rIns="0" bIns="0" anchor="t">
-            <a:noAutofit/>
-          </a:bodyPr>
-          <a:lstStyle xmlns:a="http://schemas.openxmlformats.org/drawingml/2006/main"/>
-          <a:p xmlns:a="http://schemas.openxmlformats.org/drawingml/2006/main">
-            <a:pPr>
-              <a:buNone/>
-              <a:defRPr sz="1725" b="0">
-                <a:solidFill>
-                  <a:srgbClr val="B7EDDB"/>
-                </a:solidFill>
-                <a:latin typeface="Menlo"/>
-                <a:ea typeface="Menlo"/>
-                <a:cs typeface="Menlo"/>
-              </a:defRPr>
-            </a:pPr>
-            <a:r>
-              <a:rPr sz="1725" b="0">
-                <a:solidFill>
-                  <a:srgbClr val="B7EDDB"/>
-                </a:solidFill>
-                <a:latin typeface="Menlo"/>
-                <a:ea typeface="Menlo"/>
-                <a:cs typeface="Menlo"/>
-              </a:rPr>
-              <a:t>done</a:t>
-            </a:r>
-          </a:p>
-        </p:txBody>
-      </p:sp>
-      <p:sp>
-        <p:nvSpPr>
-          <p:cNvPr id="23" name="">
-            <a:extLst xmlns:a="http://schemas.openxmlformats.org/drawingml/2006/main">
-              <a:ext uri="{FF2B5EF4-FFF2-40B4-BE49-F238E27FC236}">
-                <a16:creationId xmlns:a16="http://schemas.microsoft.com/office/drawing/2014/main" id="{FE776CDA-94D2-4EC6-870F-E0C799743627}"/>
-              </a:ext>
-            </a:extLst>
-          </p:cNvPr>
-          <p:cNvSpPr>
-            <a:spLocks xmlns:a="http://schemas.openxmlformats.org/drawingml/2006/main" noGrp="1"/>
-          </p:cNvSpPr>
-          <p:nvPr/>
-        </p:nvSpPr>
-        <p:spPr>
-          <a:xfrm xmlns:a="http://schemas.openxmlformats.org/drawingml/2006/main">
-            <a:off x="876300" y="7467600"/>
-            <a:ext cx="13192125" cy="533400"/>
-          </a:xfrm>
-          <a:prstGeom xmlns:a="http://schemas.openxmlformats.org/drawingml/2006/main" prst="rect">
-            <a:avLst/>
-          </a:prstGeom>
-          <a:noFill xmlns:a="http://schemas.openxmlformats.org/drawingml/2006/main"/>
-          <a:ln xmlns:a="http://schemas.openxmlformats.org/drawingml/2006/main" w="0">
-            <a:noFill/>
-          </a:ln>
-        </p:spPr>
-        <p:txBody>
-          <a:bodyPr xmlns:a="http://schemas.openxmlformats.org/drawingml/2006/main" wrap="none" lIns="0" tIns="0" rIns="0" bIns="0" anchor="t">
-            <a:noAutofit/>
-          </a:bodyPr>
-          <a:lstStyle xmlns:a="http://schemas.openxmlformats.org/drawingml/2006/main"/>
-          <a:p xmlns:a="http://schemas.openxmlformats.org/drawingml/2006/main">
-            <a:pPr>
-              <a:buNone/>
-              <a:defRPr sz="1950" b="0">
-                <a:solidFill>
-                  <a:srgbClr val="C4D9D5"/>
-                </a:solidFill>
-                <a:latin typeface="Hiragino Sans GB"/>
-                <a:ea typeface="Hiragino Sans GB"/>
-                <a:cs typeface="Hiragino Sans GB"/>
-              </a:defRPr>
-            </a:pPr>
-            <a:r>
-              <a:rPr sz="1950" b="0">
-                <a:solidFill>
-                  <a:srgbClr val="C4D9D5"/>
-                </a:solidFill>
-                <a:latin typeface="Hiragino Sans GB"/>
-                <a:ea typeface="Hiragino Sans GB"/>
-                <a:cs typeface="Hiragino Sans GB"/>
-              </a:rPr>
-              <a:t>先 mkdir -p results，再从仓库根目录执行 sbatch lab2.slurm。</a:t>
+              <a:t>module load cmake</a:t>
             </a:r>
           </a:p>
         </p:txBody>
@@ -13124,7 +13563,7 @@
                 <a:ea typeface="Menlo"/>
                 <a:cs typeface="Menlo"/>
               </a:rPr>
-              <a:t>tail -f results/lab2-123456.log</a:t>
+              <a:t>tail -F results/lab2-123456.log</a:t>
             </a:r>
           </a:p>
         </p:txBody>
@@ -13145,7 +13584,7 @@
         </p:nvSpPr>
         <p:spPr>
           <a:xfrm xmlns:a="http://schemas.openxmlformats.org/drawingml/2006/main">
-            <a:off x="914400" y="5334000"/>
+            <a:off x="914400" y="6000750"/>
             <a:ext cx="13430250" cy="561975"/>
           </a:xfrm>
           <a:prstGeom xmlns:a="http://schemas.openxmlformats.org/drawingml/2006/main" prst="rect">
@@ -13241,6 +13680,120 @@
                 <a:cs typeface="Hiragino Sans GB"/>
               </a:rPr>
               <a:t>PD 表示排队，R 表示运行。123456 需要替换成 sbatch 返回的作业编号。</a:t>
+            </a:r>
+          </a:p>
+        </p:txBody>
+      </p:sp>
+      <p:sp>
+        <p:nvSpPr>
+          <p:cNvPr id="13" name="audit-11">
+            <a:extLst xmlns:a="http://schemas.openxmlformats.org/drawingml/2006/main">
+              <a:ext uri="{FF2B5EF4-FFF2-40B4-BE49-F238E27FC236}">
+                <a16:creationId xmlns:a16="http://schemas.microsoft.com/office/drawing/2014/main" id="{BB4B1ED5-F9C5-485E-B02E-63C51E19A62F}"/>
+              </a:ext>
+            </a:extLst>
+          </p:cNvPr>
+          <p:cNvSpPr>
+            <a:spLocks xmlns:a="http://schemas.openxmlformats.org/drawingml/2006/main" noGrp="1"/>
+          </p:cNvSpPr>
+          <p:nvPr/>
+        </p:nvSpPr>
+        <p:spPr>
+          <a:xfrm xmlns:a="http://schemas.openxmlformats.org/drawingml/2006/main">
+            <a:off x="914400" y="1476375"/>
+            <a:ext cx="13430250" cy="523875"/>
+          </a:xfrm>
+          <a:prstGeom xmlns:a="http://schemas.openxmlformats.org/drawingml/2006/main" prst="rect">
+            <a:avLst/>
+          </a:prstGeom>
+          <a:noFill xmlns:a="http://schemas.openxmlformats.org/drawingml/2006/main"/>
+          <a:ln xmlns:a="http://schemas.openxmlformats.org/drawingml/2006/main" w="0">
+            <a:noFill/>
+          </a:ln>
+        </p:spPr>
+        <p:txBody>
+          <a:bodyPr xmlns:a="http://schemas.openxmlformats.org/drawingml/2006/main" wrap="none">
+            <a:noAutofit/>
+          </a:bodyPr>
+          <a:lstStyle xmlns:a="http://schemas.openxmlformats.org/drawingml/2006/main"/>
+          <a:p xmlns:a="http://schemas.openxmlformats.org/drawingml/2006/main">
+            <a:pPr>
+              <a:defRPr sz="2025">
+                <a:solidFill>
+                  <a:srgbClr val="A8C6C4"/>
+                </a:solidFill>
+                <a:latin typeface="Hiragino Sans GB"/>
+                <a:ea typeface="Hiragino Sans GB"/>
+                <a:cs typeface="Hiragino Sans GB"/>
+              </a:defRPr>
+            </a:pPr>
+            <a:r>
+              <a:rPr sz="2025">
+                <a:solidFill>
+                  <a:srgbClr val="A8C6C4"/>
+                </a:solidFill>
+                <a:latin typeface="Hiragino Sans GB"/>
+                <a:ea typeface="Hiragino Sans GB"/>
+                <a:cs typeface="Hiragino Sans GB"/>
+              </a:rPr>
+              <a:t>在登录节点执行；若仍在交互计算节点，先 exit 返回</a:t>
+            </a:r>
+          </a:p>
+        </p:txBody>
+      </p:sp>
+      <p:sp>
+        <p:nvSpPr>
+          <p:cNvPr id="14" name="audit-12">
+            <a:extLst xmlns:a="http://schemas.openxmlformats.org/drawingml/2006/main">
+              <a:ext uri="{FF2B5EF4-FFF2-40B4-BE49-F238E27FC236}">
+                <a16:creationId xmlns:a16="http://schemas.microsoft.com/office/drawing/2014/main" id="{EC7173EC-7CAF-4009-9AED-C0E2058656A6}"/>
+              </a:ext>
+            </a:extLst>
+          </p:cNvPr>
+          <p:cNvSpPr>
+            <a:spLocks xmlns:a="http://schemas.openxmlformats.org/drawingml/2006/main" noGrp="1"/>
+          </p:cNvSpPr>
+          <p:nvPr/>
+        </p:nvSpPr>
+        <p:spPr>
+          <a:xfrm xmlns:a="http://schemas.openxmlformats.org/drawingml/2006/main">
+            <a:off x="914400" y="5524500"/>
+            <a:ext cx="13430250" cy="523875"/>
+          </a:xfrm>
+          <a:prstGeom xmlns:a="http://schemas.openxmlformats.org/drawingml/2006/main" prst="rect">
+            <a:avLst/>
+          </a:prstGeom>
+          <a:noFill xmlns:a="http://schemas.openxmlformats.org/drawingml/2006/main"/>
+          <a:ln xmlns:a="http://schemas.openxmlformats.org/drawingml/2006/main" w="0">
+            <a:noFill/>
+          </a:ln>
+        </p:spPr>
+        <p:txBody>
+          <a:bodyPr xmlns:a="http://schemas.openxmlformats.org/drawingml/2006/main" wrap="none">
+            <a:noAutofit/>
+          </a:bodyPr>
+          <a:lstStyle xmlns:a="http://schemas.openxmlformats.org/drawingml/2006/main"/>
+          <a:p xmlns:a="http://schemas.openxmlformats.org/drawingml/2006/main">
+            <a:pPr>
+              <a:defRPr sz="2025">
+                <a:solidFill>
+                  <a:srgbClr val="A8C6C4"/>
+                </a:solidFill>
+                <a:latin typeface="Hiragino Sans GB"/>
+                <a:ea typeface="Hiragino Sans GB"/>
+                <a:cs typeface="Hiragino Sans GB"/>
+              </a:defRPr>
+            </a:pPr>
+            <a:r>
+              <a:rPr sz="2025">
+                <a:solidFill>
+                  <a:srgbClr val="A8C6C4"/>
+                </a:solidFill>
+                <a:latin typeface="Hiragino Sans GB"/>
+                <a:ea typeface="Hiragino Sans GB"/>
+                <a:cs typeface="Hiragino Sans GB"/>
+              </a:rPr>
+              <a:t>按 Ctrl-C 结束日志查看，再执行下面的 sacct</a:t>
             </a:r>
           </a:p>
         </p:txBody>
@@ -13443,7 +13996,7 @@
                 <a:ea typeface="Hiragino Sans GB"/>
                 <a:cs typeface="Hiragino Sans GB"/>
               </a:rPr>
-              <a:t>在本地终端下载结果</a:t>
+              <a:t>在本地终端下载：macOS / Linux / Windows PowerShell</a:t>
             </a:r>
           </a:p>
         </p:txBody>
@@ -13501,7 +14054,7 @@
                 <a:ea typeface="Menlo"/>
                 <a:cs typeface="Menlo"/>
               </a:rPr>
-              <a:t>mkdir -p pi2-results</a:t>
+              <a:t>mkdir pi2-results</a:t>
             </a:r>
           </a:p>
         </p:txBody>
@@ -13559,123 +14112,7 @@
                 <a:ea typeface="Menlo"/>
                 <a:cs typeface="Menlo"/>
               </a:rPr>
-              <a:t>rsync -av \</a:t>
-            </a:r>
-          </a:p>
-        </p:txBody>
-      </p:sp>
-      <p:sp>
-        <p:nvSpPr>
-          <p:cNvPr id="6" name="">
-            <a:extLst xmlns:a="http://schemas.openxmlformats.org/drawingml/2006/main">
-              <a:ext uri="{FF2B5EF4-FFF2-40B4-BE49-F238E27FC236}">
-                <a16:creationId xmlns:a16="http://schemas.microsoft.com/office/drawing/2014/main" id="{5A68FED9-0F58-40C1-BCCD-F7CA88D077E4}"/>
-              </a:ext>
-            </a:extLst>
-          </p:cNvPr>
-          <p:cNvSpPr>
-            <a:spLocks xmlns:a="http://schemas.openxmlformats.org/drawingml/2006/main" noGrp="1"/>
-          </p:cNvSpPr>
-          <p:nvPr/>
-        </p:nvSpPr>
-        <p:spPr>
-          <a:xfrm xmlns:a="http://schemas.openxmlformats.org/drawingml/2006/main">
-            <a:off x="914400" y="3590925"/>
-            <a:ext cx="13430250" cy="590550"/>
-          </a:xfrm>
-          <a:prstGeom xmlns:a="http://schemas.openxmlformats.org/drawingml/2006/main" prst="rect">
-            <a:avLst/>
-          </a:prstGeom>
-          <a:noFill xmlns:a="http://schemas.openxmlformats.org/drawingml/2006/main"/>
-          <a:ln xmlns:a="http://schemas.openxmlformats.org/drawingml/2006/main" w="0">
-            <a:noFill/>
-          </a:ln>
-        </p:spPr>
-        <p:txBody>
-          <a:bodyPr xmlns:a="http://schemas.openxmlformats.org/drawingml/2006/main" wrap="none" lIns="0" tIns="0" rIns="0" bIns="0" anchor="t">
-            <a:noAutofit/>
-          </a:bodyPr>
-          <a:lstStyle xmlns:a="http://schemas.openxmlformats.org/drawingml/2006/main"/>
-          <a:p xmlns:a="http://schemas.openxmlformats.org/drawingml/2006/main">
-            <a:pPr>
-              <a:buNone/>
-              <a:defRPr sz="2175" b="0">
-                <a:solidFill>
-                  <a:srgbClr val="B7EDDB"/>
-                </a:solidFill>
-                <a:latin typeface="Menlo"/>
-                <a:ea typeface="Menlo"/>
-                <a:cs typeface="Menlo"/>
-              </a:defRPr>
-            </a:pPr>
-            <a:r>
-              <a:rPr sz="2175" b="0">
-                <a:solidFill>
-                  <a:srgbClr val="B7EDDB"/>
-                </a:solidFill>
-                <a:latin typeface="Menlo"/>
-                <a:ea typeface="Menlo"/>
-                <a:cs typeface="Menlo"/>
-              </a:rPr>
-              <a:t>  jiaowosuan-data:course-labs/results/ \</a:t>
-            </a:r>
-          </a:p>
-        </p:txBody>
-      </p:sp>
-      <p:sp>
-        <p:nvSpPr>
-          <p:cNvPr id="7" name="">
-            <a:extLst xmlns:a="http://schemas.openxmlformats.org/drawingml/2006/main">
-              <a:ext uri="{FF2B5EF4-FFF2-40B4-BE49-F238E27FC236}">
-                <a16:creationId xmlns:a16="http://schemas.microsoft.com/office/drawing/2014/main" id="{739569E8-5370-42D1-BD9E-28DE338D3F12}"/>
-              </a:ext>
-            </a:extLst>
-          </p:cNvPr>
-          <p:cNvSpPr>
-            <a:spLocks xmlns:a="http://schemas.openxmlformats.org/drawingml/2006/main" noGrp="1"/>
-          </p:cNvSpPr>
-          <p:nvPr/>
-        </p:nvSpPr>
-        <p:spPr>
-          <a:xfrm xmlns:a="http://schemas.openxmlformats.org/drawingml/2006/main">
-            <a:off x="914400" y="4105275"/>
-            <a:ext cx="13430250" cy="590550"/>
-          </a:xfrm>
-          <a:prstGeom xmlns:a="http://schemas.openxmlformats.org/drawingml/2006/main" prst="rect">
-            <a:avLst/>
-          </a:prstGeom>
-          <a:noFill xmlns:a="http://schemas.openxmlformats.org/drawingml/2006/main"/>
-          <a:ln xmlns:a="http://schemas.openxmlformats.org/drawingml/2006/main" w="0">
-            <a:noFill/>
-          </a:ln>
-        </p:spPr>
-        <p:txBody>
-          <a:bodyPr xmlns:a="http://schemas.openxmlformats.org/drawingml/2006/main" wrap="none" lIns="0" tIns="0" rIns="0" bIns="0" anchor="t">
-            <a:noAutofit/>
-          </a:bodyPr>
-          <a:lstStyle xmlns:a="http://schemas.openxmlformats.org/drawingml/2006/main"/>
-          <a:p xmlns:a="http://schemas.openxmlformats.org/drawingml/2006/main">
-            <a:pPr>
-              <a:buNone/>
-              <a:defRPr sz="2175" b="0">
-                <a:solidFill>
-                  <a:srgbClr val="B7EDDB"/>
-                </a:solidFill>
-                <a:latin typeface="Menlo"/>
-                <a:ea typeface="Menlo"/>
-                <a:cs typeface="Menlo"/>
-              </a:defRPr>
-            </a:pPr>
-            <a:r>
-              <a:rPr sz="2175" b="0">
-                <a:solidFill>
-                  <a:srgbClr val="B7EDDB"/>
-                </a:solidFill>
-                <a:latin typeface="Menlo"/>
-                <a:ea typeface="Menlo"/>
-                <a:cs typeface="Menlo"/>
-              </a:rPr>
-              <a:t>  ./pi2-results/</a:t>
+              <a:t>scp -r jiaowosuan-data:course-labs/results ./pi2-results/</a:t>
             </a:r>
           </a:p>
         </p:txBody>
@@ -13850,6 +14287,120 @@
                 <a:cs typeface="Hiragino Sans GB"/>
               </a:rPr>
               <a:t>关闭 SSH 后，sbatch 提交的作业仍会继续运行。交互作业结束时输入 exit。</a:t>
+            </a:r>
+          </a:p>
+        </p:txBody>
+      </p:sp>
+      <p:sp>
+        <p:nvSpPr>
+          <p:cNvPr id="12" name="audit-8">
+            <a:extLst xmlns:a="http://schemas.openxmlformats.org/drawingml/2006/main">
+              <a:ext uri="{FF2B5EF4-FFF2-40B4-BE49-F238E27FC236}">
+                <a16:creationId xmlns:a16="http://schemas.microsoft.com/office/drawing/2014/main" id="{44F9FA96-E8CF-4F32-89E3-600D8B3217F8}"/>
+              </a:ext>
+            </a:extLst>
+          </p:cNvPr>
+          <p:cNvSpPr>
+            <a:spLocks xmlns:a="http://schemas.openxmlformats.org/drawingml/2006/main" noGrp="1"/>
+          </p:cNvSpPr>
+          <p:nvPr/>
+        </p:nvSpPr>
+        <p:spPr>
+          <a:xfrm xmlns:a="http://schemas.openxmlformats.org/drawingml/2006/main">
+            <a:off x="914400" y="4095750"/>
+            <a:ext cx="13430250" cy="523875"/>
+          </a:xfrm>
+          <a:prstGeom xmlns:a="http://schemas.openxmlformats.org/drawingml/2006/main" prst="rect">
+            <a:avLst/>
+          </a:prstGeom>
+          <a:noFill xmlns:a="http://schemas.openxmlformats.org/drawingml/2006/main"/>
+          <a:ln xmlns:a="http://schemas.openxmlformats.org/drawingml/2006/main" w="0">
+            <a:noFill/>
+          </a:ln>
+        </p:spPr>
+        <p:txBody>
+          <a:bodyPr xmlns:a="http://schemas.openxmlformats.org/drawingml/2006/main" wrap="none">
+            <a:noAutofit/>
+          </a:bodyPr>
+          <a:lstStyle xmlns:a="http://schemas.openxmlformats.org/drawingml/2006/main"/>
+          <a:p xmlns:a="http://schemas.openxmlformats.org/drawingml/2006/main">
+            <a:pPr>
+              <a:defRPr sz="2175">
+                <a:solidFill>
+                  <a:srgbClr val="EAF1EF"/>
+                </a:solidFill>
+                <a:latin typeface="Hiragino Sans GB"/>
+                <a:ea typeface="Hiragino Sans GB"/>
+                <a:cs typeface="Hiragino Sans GB"/>
+              </a:defRPr>
+            </a:pPr>
+            <a:r>
+              <a:rPr sz="2175">
+                <a:solidFill>
+                  <a:srgbClr val="EAF1EF"/>
+                </a:solidFill>
+                <a:latin typeface="Hiragino Sans GB"/>
+                <a:ea typeface="Hiragino Sans GB"/>
+                <a:cs typeface="Hiragino Sans GB"/>
+              </a:rPr>
+              <a:t>日志位于 pi2-results/results/；已有同名目录时先核对版本</a:t>
+            </a:r>
+          </a:p>
+        </p:txBody>
+      </p:sp>
+      <p:sp>
+        <p:nvSpPr>
+          <p:cNvPr id="13" name="audit-9">
+            <a:extLst xmlns:a="http://schemas.openxmlformats.org/drawingml/2006/main">
+              <a:ext uri="{FF2B5EF4-FFF2-40B4-BE49-F238E27FC236}">
+                <a16:creationId xmlns:a16="http://schemas.microsoft.com/office/drawing/2014/main" id="{635AAA4D-73DD-4F65-8ACB-A58F4A192506}"/>
+              </a:ext>
+            </a:extLst>
+          </p:cNvPr>
+          <p:cNvSpPr>
+            <a:spLocks xmlns:a="http://schemas.openxmlformats.org/drawingml/2006/main" noGrp="1"/>
+          </p:cNvSpPr>
+          <p:nvPr/>
+        </p:nvSpPr>
+        <p:spPr>
+          <a:xfrm xmlns:a="http://schemas.openxmlformats.org/drawingml/2006/main">
+            <a:off x="914400" y="4600575"/>
+            <a:ext cx="13430250" cy="523875"/>
+          </a:xfrm>
+          <a:prstGeom xmlns:a="http://schemas.openxmlformats.org/drawingml/2006/main" prst="rect">
+            <a:avLst/>
+          </a:prstGeom>
+          <a:noFill xmlns:a="http://schemas.openxmlformats.org/drawingml/2006/main"/>
+          <a:ln xmlns:a="http://schemas.openxmlformats.org/drawingml/2006/main" w="0">
+            <a:noFill/>
+          </a:ln>
+        </p:spPr>
+        <p:txBody>
+          <a:bodyPr xmlns:a="http://schemas.openxmlformats.org/drawingml/2006/main" wrap="none">
+            <a:noAutofit/>
+          </a:bodyPr>
+          <a:lstStyle xmlns:a="http://schemas.openxmlformats.org/drawingml/2006/main"/>
+          <a:p xmlns:a="http://schemas.openxmlformats.org/drawingml/2006/main">
+            <a:pPr>
+              <a:defRPr sz="2175">
+                <a:solidFill>
+                  <a:srgbClr val="EAF1EF"/>
+                </a:solidFill>
+                <a:latin typeface="Hiragino Sans GB"/>
+                <a:ea typeface="Hiragino Sans GB"/>
+                <a:cs typeface="Hiragino Sans GB"/>
+              </a:defRPr>
+            </a:pPr>
+            <a:r>
+              <a:rPr sz="2175">
+                <a:solidFill>
+                  <a:srgbClr val="EAF1EF"/>
+                </a:solidFill>
+                <a:latin typeface="Hiragino Sans GB"/>
+                <a:ea typeface="Hiragino Sans GB"/>
+                <a:cs typeface="Hiragino Sans GB"/>
+              </a:rPr>
+              <a:t>本例使用各系统 OpenSSH 均提供的 scp，无需另装 rsync</a:t>
             </a:r>
           </a:p>
         </p:txBody>
@@ -14642,6 +15193,7 @@
           <a:lstStyle xmlns:a="http://schemas.openxmlformats.org/drawingml/2006/main"/>
           <a:p xmlns:a="http://schemas.openxmlformats.org/drawingml/2006/main">
             <a:pPr>
+              <a:buNone/>
               <a:defRPr sz="2550">
                 <a:solidFill>
                   <a:srgbClr val="EAF1EF"/>
@@ -14699,6 +15251,7 @@
           <a:lstStyle xmlns:a="http://schemas.openxmlformats.org/drawingml/2006/main"/>
           <a:p xmlns:a="http://schemas.openxmlformats.org/drawingml/2006/main">
             <a:pPr>
+              <a:buNone/>
               <a:defRPr sz="2550">
                 <a:solidFill>
                   <a:srgbClr val="EAF1EF"/>
@@ -14756,6 +15309,7 @@
           <a:lstStyle xmlns:a="http://schemas.openxmlformats.org/drawingml/2006/main"/>
           <a:p xmlns:a="http://schemas.openxmlformats.org/drawingml/2006/main">
             <a:pPr>
+              <a:buNone/>
               <a:defRPr sz="2550">
                 <a:solidFill>
                   <a:srgbClr val="EAF1EF"/>
@@ -14813,6 +15367,7 @@
           <a:lstStyle xmlns:a="http://schemas.openxmlformats.org/drawingml/2006/main"/>
           <a:p xmlns:a="http://schemas.openxmlformats.org/drawingml/2006/main">
             <a:pPr>
+              <a:buNone/>
               <a:defRPr sz="2550">
                 <a:solidFill>
                   <a:srgbClr val="B7EDDB"/>
@@ -14870,6 +15425,7 @@
           <a:lstStyle xmlns:a="http://schemas.openxmlformats.org/drawingml/2006/main"/>
           <a:p xmlns:a="http://schemas.openxmlformats.org/drawingml/2006/main">
             <a:pPr>
+              <a:buNone/>
               <a:defRPr sz="2550">
                 <a:solidFill>
                   <a:srgbClr val="EAF1EF"/>
@@ -14927,6 +15483,7 @@
           <a:lstStyle xmlns:a="http://schemas.openxmlformats.org/drawingml/2006/main"/>
           <a:p xmlns:a="http://schemas.openxmlformats.org/drawingml/2006/main">
             <a:pPr>
+              <a:buNone/>
               <a:defRPr sz="2025">
                 <a:solidFill>
                   <a:srgbClr val="A8C6C4"/>
@@ -15129,6 +15686,7 @@
           <a:lstStyle xmlns:a="http://schemas.openxmlformats.org/drawingml/2006/main"/>
           <a:p xmlns:a="http://schemas.openxmlformats.org/drawingml/2006/main">
             <a:pPr>
+              <a:buNone/>
               <a:defRPr sz="2475">
                 <a:solidFill>
                   <a:srgbClr val="EAF1EF"/>
@@ -15186,6 +15744,7 @@
           <a:lstStyle xmlns:a="http://schemas.openxmlformats.org/drawingml/2006/main"/>
           <a:p xmlns:a="http://schemas.openxmlformats.org/drawingml/2006/main">
             <a:pPr>
+              <a:buNone/>
               <a:defRPr sz="2475">
                 <a:solidFill>
                   <a:srgbClr val="EAF1EF"/>
@@ -15243,6 +15802,7 @@
           <a:lstStyle xmlns:a="http://schemas.openxmlformats.org/drawingml/2006/main"/>
           <a:p xmlns:a="http://schemas.openxmlformats.org/drawingml/2006/main">
             <a:pPr>
+              <a:buNone/>
               <a:defRPr sz="2475">
                 <a:solidFill>
                   <a:srgbClr val="EAF1EF"/>
@@ -15300,6 +15860,7 @@
           <a:lstStyle xmlns:a="http://schemas.openxmlformats.org/drawingml/2006/main"/>
           <a:p xmlns:a="http://schemas.openxmlformats.org/drawingml/2006/main">
             <a:pPr>
+              <a:buNone/>
               <a:defRPr sz="2475">
                 <a:solidFill>
                   <a:srgbClr val="EAF1EF"/>
@@ -15357,6 +15918,7 @@
           <a:lstStyle xmlns:a="http://schemas.openxmlformats.org/drawingml/2006/main"/>
           <a:p xmlns:a="http://schemas.openxmlformats.org/drawingml/2006/main">
             <a:pPr>
+              <a:buNone/>
               <a:defRPr sz="2475">
                 <a:solidFill>
                   <a:srgbClr val="EAF1EF"/>
@@ -15414,6 +15976,7 @@
           <a:lstStyle xmlns:a="http://schemas.openxmlformats.org/drawingml/2006/main"/>
           <a:p xmlns:a="http://schemas.openxmlformats.org/drawingml/2006/main">
             <a:pPr>
+              <a:buNone/>
               <a:defRPr sz="2025">
                 <a:solidFill>
                   <a:srgbClr val="A8C6C4"/>
@@ -15616,6 +16179,7 @@
           <a:lstStyle xmlns:a="http://schemas.openxmlformats.org/drawingml/2006/main"/>
           <a:p xmlns:a="http://schemas.openxmlformats.org/drawingml/2006/main">
             <a:pPr>
+              <a:buNone/>
               <a:defRPr sz="2550">
                 <a:solidFill>
                   <a:srgbClr val="EAF1EF"/>
@@ -15673,6 +16237,7 @@
           <a:lstStyle xmlns:a="http://schemas.openxmlformats.org/drawingml/2006/main"/>
           <a:p xmlns:a="http://schemas.openxmlformats.org/drawingml/2006/main">
             <a:pPr>
+              <a:buNone/>
               <a:defRPr sz="2400">
                 <a:solidFill>
                   <a:srgbClr val="EAF1EF"/>
@@ -15730,6 +16295,7 @@
           <a:lstStyle xmlns:a="http://schemas.openxmlformats.org/drawingml/2006/main"/>
           <a:p xmlns:a="http://schemas.openxmlformats.org/drawingml/2006/main">
             <a:pPr>
+              <a:buNone/>
               <a:defRPr sz="2400">
                 <a:solidFill>
                   <a:srgbClr val="EAF1EF"/>
@@ -15787,6 +16353,7 @@
           <a:lstStyle xmlns:a="http://schemas.openxmlformats.org/drawingml/2006/main"/>
           <a:p xmlns:a="http://schemas.openxmlformats.org/drawingml/2006/main">
             <a:pPr>
+              <a:buNone/>
               <a:defRPr sz="2400">
                 <a:solidFill>
                   <a:srgbClr val="EAF1EF"/>
@@ -15844,6 +16411,7 @@
           <a:lstStyle xmlns:a="http://schemas.openxmlformats.org/drawingml/2006/main"/>
           <a:p xmlns:a="http://schemas.openxmlformats.org/drawingml/2006/main">
             <a:pPr>
+              <a:buNone/>
               <a:defRPr sz="2400">
                 <a:solidFill>
                   <a:srgbClr val="EAF1EF"/>
@@ -15901,6 +16469,7 @@
           <a:lstStyle xmlns:a="http://schemas.openxmlformats.org/drawingml/2006/main"/>
           <a:p xmlns:a="http://schemas.openxmlformats.org/drawingml/2006/main">
             <a:pPr>
+              <a:buNone/>
               <a:defRPr sz="2025">
                 <a:solidFill>
                   <a:srgbClr val="A8C6C4"/>
@@ -17073,7 +17642,7 @@
                 <a:latin typeface="Hiragino Sans GB"/>
                 <a:ea typeface="Hiragino Sans GB"/>
                 <a:cs typeface="Hiragino Sans GB"/>
-                <a:hlinkClick xmlns:r="http://schemas.openxmlformats.org/officeDocument/2006/relationships" r:id="Rad89e489e6ca4f4c"/>
+                <a:hlinkClick xmlns:r="http://schemas.openxmlformats.org/officeDocument/2006/relationships" r:id="R92fff7d3cf094eb6"/>
               </a:rPr>
               <a:t>登录与账号</a:t>
             </a:r>
@@ -17132,7 +17701,7 @@
                 <a:latin typeface="Hiragino Sans GB"/>
                 <a:ea typeface="Hiragino Sans GB"/>
                 <a:cs typeface="Hiragino Sans GB"/>
-                <a:hlinkClick xmlns:r="http://schemas.openxmlformats.org/officeDocument/2006/relationships" r:id="R841043cfe6b94dcc"/>
+                <a:hlinkClick xmlns:r="http://schemas.openxmlformats.org/officeDocument/2006/relationships" r:id="Ra8c61309f03c4527"/>
               </a:rPr>
               <a:t>Slurm 作业管理</a:t>
             </a:r>
@@ -17191,7 +17760,7 @@
                 <a:latin typeface="Hiragino Sans GB"/>
                 <a:ea typeface="Hiragino Sans GB"/>
                 <a:cs typeface="Hiragino Sans GB"/>
-                <a:hlinkClick xmlns:r="http://schemas.openxmlformats.org/officeDocument/2006/relationships" r:id="R232b39c2ca6e462b"/>
+                <a:hlinkClick xmlns:r="http://schemas.openxmlformats.org/officeDocument/2006/relationships" r:id="R202ab1f9ec454f52"/>
               </a:rPr>
               <a:t>文件传输</a:t>
             </a:r>

</xml_diff>

<commit_message>
Set tutorial Slurm time limits to two hours
</commit_message>
<xml_diff>
--- a/docs/交我算平台Lab运行指南-学生版.pptx
+++ b/docs/交我算平台Lab运行指南-学生版.pptx
@@ -2,44 +2,148 @@
 <file path=ppt/presentation.xml><?xml version="1.0" encoding="utf-8"?>
 <p:presentation xmlns:p="http://schemas.openxmlformats.org/presentationml/2006/main">
   <p:sldMasterIdLst>
-    <p:sldMasterId xmlns:r="http://schemas.openxmlformats.org/officeDocument/2006/relationships" id="2147483648" r:id="Rcd447baf31eb4ec3"/>
+    <p:sldMasterId xmlns:r="http://schemas.openxmlformats.org/officeDocument/2006/relationships" id="2147483648" r:id="Ra4c5ed6fe29f4c16"/>
   </p:sldMasterIdLst>
   <p:notesMasterIdLst>
-    <p:notesMasterId xmlns:r="http://schemas.openxmlformats.org/officeDocument/2006/relationships" r:id="Rb87a0392fb964659"/>
+    <p:notesMasterId xmlns:r="http://schemas.openxmlformats.org/officeDocument/2006/relationships" r:id="Rd87fdbf007d24ba5"/>
   </p:notesMasterIdLst>
   <p:sldIdLst>
-    <p:sldId xmlns:r="http://schemas.openxmlformats.org/officeDocument/2006/relationships" id="256" r:id="Rceef44d9b35c40d4"/>
-    <p:sldId xmlns:r="http://schemas.openxmlformats.org/officeDocument/2006/relationships" id="257" r:id="R81cc83877b61473d"/>
-    <p:sldId xmlns:r="http://schemas.openxmlformats.org/officeDocument/2006/relationships" id="258" r:id="R02eb1f8d294341ff"/>
-    <p:sldId xmlns:r="http://schemas.openxmlformats.org/officeDocument/2006/relationships" id="259" r:id="R5c40457137ee487b"/>
-    <p:sldId xmlns:r="http://schemas.openxmlformats.org/officeDocument/2006/relationships" id="260" r:id="Rdae68cedb146413b"/>
-    <p:sldId xmlns:r="http://schemas.openxmlformats.org/officeDocument/2006/relationships" id="261" r:id="Rb1d1f198c00b4f6d"/>
-    <p:sldId xmlns:r="http://schemas.openxmlformats.org/officeDocument/2006/relationships" id="262" r:id="Rffd71c5590104c3a"/>
-    <p:sldId xmlns:r="http://schemas.openxmlformats.org/officeDocument/2006/relationships" id="263" r:id="R8b0cb4fa3fe940e0"/>
-    <p:sldId xmlns:r="http://schemas.openxmlformats.org/officeDocument/2006/relationships" id="264" r:id="R0f5c04ea19c14b11"/>
-    <p:sldId xmlns:r="http://schemas.openxmlformats.org/officeDocument/2006/relationships" id="265" r:id="R7152c27092494639"/>
-    <p:sldId xmlns:r="http://schemas.openxmlformats.org/officeDocument/2006/relationships" id="266" r:id="R9c185575ed4d4807"/>
-    <p:sldId xmlns:r="http://schemas.openxmlformats.org/officeDocument/2006/relationships" id="267" r:id="R94aabbb4f9e944a2"/>
-    <p:sldId xmlns:r="http://schemas.openxmlformats.org/officeDocument/2006/relationships" id="268" r:id="R2b847ff9507a4f93"/>
-    <p:sldId xmlns:r="http://schemas.openxmlformats.org/officeDocument/2006/relationships" id="269" r:id="R54633310f3a84a26"/>
-    <p:sldId xmlns:r="http://schemas.openxmlformats.org/officeDocument/2006/relationships" id="270" r:id="R3b7a2960af004c2d"/>
-    <p:sldId xmlns:r="http://schemas.openxmlformats.org/officeDocument/2006/relationships" id="271" r:id="Rc64e4aae331b411f"/>
-    <p:sldId xmlns:r="http://schemas.openxmlformats.org/officeDocument/2006/relationships" id="272" r:id="R6349eaeffc1047df"/>
-    <p:sldId xmlns:r="http://schemas.openxmlformats.org/officeDocument/2006/relationships" id="273" r:id="R8f8cda8f3bfb4e74"/>
-    <p:sldId xmlns:r="http://schemas.openxmlformats.org/officeDocument/2006/relationships" id="274" r:id="R54583e3fc4a84ab1"/>
-    <p:sldId xmlns:r="http://schemas.openxmlformats.org/officeDocument/2006/relationships" id="275" r:id="R178a47f32ffd4a09"/>
-    <p:sldId xmlns:r="http://schemas.openxmlformats.org/officeDocument/2006/relationships" id="276" r:id="R2cd2a2e9841d4733"/>
-    <p:sldId xmlns:r="http://schemas.openxmlformats.org/officeDocument/2006/relationships" id="277" r:id="R892fbf944dd44229"/>
-    <p:sldId xmlns:r="http://schemas.openxmlformats.org/officeDocument/2006/relationships" id="278" r:id="Ra389f48c50b0476c"/>
-    <p:sldId xmlns:r="http://schemas.openxmlformats.org/officeDocument/2006/relationships" id="279" r:id="R2edde5bb1dec4512"/>
-    <p:sldId xmlns:r="http://schemas.openxmlformats.org/officeDocument/2006/relationships" id="280" r:id="Re0b20362b0534737"/>
-    <p:sldId xmlns:r="http://schemas.openxmlformats.org/officeDocument/2006/relationships" id="281" r:id="R85bdb7f2b5bf4a90"/>
-    <p:sldId xmlns:r="http://schemas.openxmlformats.org/officeDocument/2006/relationships" id="282" r:id="R8044b303c463435b"/>
-    <p:sldId xmlns:r="http://schemas.openxmlformats.org/officeDocument/2006/relationships" id="283" r:id="R53ec4c548a614136"/>
-    <p:sldId xmlns:r="http://schemas.openxmlformats.org/officeDocument/2006/relationships" id="284" r:id="R9c6186924d3740eb"/>
+    <p:sldId xmlns:r="http://schemas.openxmlformats.org/officeDocument/2006/relationships" id="256" r:id="Rb2e02e3658e242c4"/>
+    <p:sldId xmlns:r="http://schemas.openxmlformats.org/officeDocument/2006/relationships" id="257" r:id="R077b516aac984132"/>
+    <p:sldId xmlns:r="http://schemas.openxmlformats.org/officeDocument/2006/relationships" id="258" r:id="Rdd88b9d90ca440da"/>
+    <p:sldId xmlns:r="http://schemas.openxmlformats.org/officeDocument/2006/relationships" id="259" r:id="Rb39e9ea4d1b44684"/>
+    <p:sldId xmlns:r="http://schemas.openxmlformats.org/officeDocument/2006/relationships" id="260" r:id="R963978e44e544dcb"/>
+    <p:sldId xmlns:r="http://schemas.openxmlformats.org/officeDocument/2006/relationships" id="261" r:id="Rf3486b0fa5664ed7"/>
+    <p:sldId xmlns:r="http://schemas.openxmlformats.org/officeDocument/2006/relationships" id="262" r:id="R7f3140123ed949d8"/>
+    <p:sldId xmlns:r="http://schemas.openxmlformats.org/officeDocument/2006/relationships" id="263" r:id="R904d08a020104248"/>
+    <p:sldId xmlns:r="http://schemas.openxmlformats.org/officeDocument/2006/relationships" id="264" r:id="R12ce80fa9a3f45a0"/>
+    <p:sldId xmlns:r="http://schemas.openxmlformats.org/officeDocument/2006/relationships" id="265" r:id="R0609406cb76d4725"/>
+    <p:sldId xmlns:r="http://schemas.openxmlformats.org/officeDocument/2006/relationships" id="266" r:id="R73620e1aaaf1468a"/>
+    <p:sldId xmlns:r="http://schemas.openxmlformats.org/officeDocument/2006/relationships" id="267" r:id="R72ea90d79e0f4c9a"/>
+    <p:sldId xmlns:r="http://schemas.openxmlformats.org/officeDocument/2006/relationships" id="268" r:id="R4e89228de51a4763"/>
+    <p:sldId xmlns:r="http://schemas.openxmlformats.org/officeDocument/2006/relationships" id="269" r:id="R5b3d2e833cc34200"/>
+    <p:sldId xmlns:r="http://schemas.openxmlformats.org/officeDocument/2006/relationships" id="270" r:id="R9031323ba1514dea"/>
+    <p:sldId xmlns:r="http://schemas.openxmlformats.org/officeDocument/2006/relationships" id="271" r:id="Rcf840c94f8d24177"/>
+    <p:sldId xmlns:r="http://schemas.openxmlformats.org/officeDocument/2006/relationships" id="272" r:id="Ree4a438615c7400b"/>
+    <p:sldId xmlns:r="http://schemas.openxmlformats.org/officeDocument/2006/relationships" id="273" r:id="R0aec5510e8864e09"/>
+    <p:sldId xmlns:r="http://schemas.openxmlformats.org/officeDocument/2006/relationships" id="274" r:id="R372b8df9c25c40ca"/>
+    <p:sldId xmlns:r="http://schemas.openxmlformats.org/officeDocument/2006/relationships" id="275" r:id="R32b9278eb9f444be"/>
+    <p:sldId xmlns:r="http://schemas.openxmlformats.org/officeDocument/2006/relationships" id="276" r:id="R5015dbc8bba64548"/>
+    <p:sldId xmlns:r="http://schemas.openxmlformats.org/officeDocument/2006/relationships" id="277" r:id="Re847fc68f05d4ead"/>
+    <p:sldId xmlns:r="http://schemas.openxmlformats.org/officeDocument/2006/relationships" id="278" r:id="R092be74401534158"/>
+    <p:sldId xmlns:r="http://schemas.openxmlformats.org/officeDocument/2006/relationships" id="279" r:id="Rcafa3f60cffd44ed"/>
+    <p:sldId xmlns:r="http://schemas.openxmlformats.org/officeDocument/2006/relationships" id="280" r:id="Rd80b3c5b6bcb47d3"/>
+    <p:sldId xmlns:r="http://schemas.openxmlformats.org/officeDocument/2006/relationships" id="281" r:id="R9989cde1ca27451b"/>
+    <p:sldId xmlns:r="http://schemas.openxmlformats.org/officeDocument/2006/relationships" id="282" r:id="R360088e82bec4135"/>
+    <p:sldId xmlns:r="http://schemas.openxmlformats.org/officeDocument/2006/relationships" id="283" r:id="Rc0ced8f2c64a4cbf"/>
+    <p:sldId xmlns:r="http://schemas.openxmlformats.org/officeDocument/2006/relationships" id="284" r:id="Rcfd5d3fb5c4642f7"/>
   </p:sldIdLst>
   <p:sldSz cx="15240000" cy="8572500"/>
   <p:notesSz cx="6858000" cy="9144000"/>
+  <p:defaultTextStyle>
+    <a:defPPr xmlns:a="http://schemas.openxmlformats.org/drawingml/2006/main">
+      <a:buNone/>
+    </a:defPPr>
+    <a:lvl1pPr xmlns:a="http://schemas.openxmlformats.org/drawingml/2006/main" marL="0" algn="l" defTabSz="914400">
+      <a:buNone/>
+      <a:defRPr sz="1800" kern="1200">
+        <a:solidFill>
+          <a:schemeClr val="tx1"/>
+        </a:solidFill>
+        <a:latin typeface="+mn-lt"/>
+        <a:ea typeface="+mn-lt"/>
+        <a:cs typeface="+mn-lt"/>
+      </a:defRPr>
+    </a:lvl1pPr>
+    <a:lvl2pPr xmlns:a="http://schemas.openxmlformats.org/drawingml/2006/main" marL="457200" algn="l" defTabSz="914400">
+      <a:buNone/>
+      <a:defRPr sz="1800" kern="1200">
+        <a:solidFill>
+          <a:schemeClr val="tx1"/>
+        </a:solidFill>
+        <a:latin typeface="+mn-lt"/>
+        <a:ea typeface="+mn-lt"/>
+        <a:cs typeface="+mn-lt"/>
+      </a:defRPr>
+    </a:lvl2pPr>
+    <a:lvl3pPr xmlns:a="http://schemas.openxmlformats.org/drawingml/2006/main" marL="914400" algn="l" defTabSz="914400">
+      <a:buNone/>
+      <a:defRPr sz="1800" kern="1200">
+        <a:solidFill>
+          <a:schemeClr val="tx1"/>
+        </a:solidFill>
+        <a:latin typeface="+mn-lt"/>
+        <a:ea typeface="+mn-lt"/>
+        <a:cs typeface="+mn-lt"/>
+      </a:defRPr>
+    </a:lvl3pPr>
+    <a:lvl4pPr xmlns:a="http://schemas.openxmlformats.org/drawingml/2006/main" marL="1371600" algn="l" defTabSz="914400">
+      <a:buNone/>
+      <a:defRPr sz="1800" kern="1200">
+        <a:solidFill>
+          <a:schemeClr val="tx1"/>
+        </a:solidFill>
+        <a:latin typeface="+mn-lt"/>
+        <a:ea typeface="+mn-lt"/>
+        <a:cs typeface="+mn-lt"/>
+      </a:defRPr>
+    </a:lvl4pPr>
+    <a:lvl5pPr xmlns:a="http://schemas.openxmlformats.org/drawingml/2006/main" marL="1828800" algn="l" defTabSz="914400">
+      <a:buNone/>
+      <a:defRPr sz="1800" kern="1200">
+        <a:solidFill>
+          <a:schemeClr val="tx1"/>
+        </a:solidFill>
+        <a:latin typeface="+mn-lt"/>
+        <a:ea typeface="+mn-lt"/>
+        <a:cs typeface="+mn-lt"/>
+      </a:defRPr>
+    </a:lvl5pPr>
+    <a:lvl6pPr xmlns:a="http://schemas.openxmlformats.org/drawingml/2006/main" marL="2286000" algn="l" defTabSz="914400">
+      <a:buNone/>
+      <a:defRPr sz="1800" kern="1200">
+        <a:solidFill>
+          <a:schemeClr val="tx1"/>
+        </a:solidFill>
+        <a:latin typeface="+mn-lt"/>
+        <a:ea typeface="+mn-lt"/>
+        <a:cs typeface="+mn-lt"/>
+      </a:defRPr>
+    </a:lvl6pPr>
+    <a:lvl7pPr xmlns:a="http://schemas.openxmlformats.org/drawingml/2006/main" marL="2743200" algn="l" defTabSz="914400">
+      <a:buNone/>
+      <a:defRPr sz="1800" kern="1200">
+        <a:solidFill>
+          <a:schemeClr val="tx1"/>
+        </a:solidFill>
+        <a:latin typeface="+mn-lt"/>
+        <a:ea typeface="+mn-lt"/>
+        <a:cs typeface="+mn-lt"/>
+      </a:defRPr>
+    </a:lvl7pPr>
+    <a:lvl8pPr xmlns:a="http://schemas.openxmlformats.org/drawingml/2006/main" marL="3200400" algn="l" defTabSz="914400">
+      <a:buNone/>
+      <a:defRPr sz="1800" kern="1200">
+        <a:solidFill>
+          <a:schemeClr val="tx1"/>
+        </a:solidFill>
+        <a:latin typeface="+mn-lt"/>
+        <a:ea typeface="+mn-lt"/>
+        <a:cs typeface="+mn-lt"/>
+      </a:defRPr>
+    </a:lvl8pPr>
+    <a:lvl9pPr xmlns:a="http://schemas.openxmlformats.org/drawingml/2006/main" marL="3657600" algn="l" defTabSz="914400">
+      <a:buNone/>
+      <a:defRPr sz="1800" kern="1200">
+        <a:solidFill>
+          <a:schemeClr val="tx1"/>
+        </a:solidFill>
+        <a:latin typeface="+mn-lt"/>
+        <a:ea typeface="+mn-lt"/>
+        <a:cs typeface="+mn-lt"/>
+      </a:defRPr>
+    </a:lvl9pPr>
+  </p:defaultTextStyle>
 </p:presentation>
 </file>
 
@@ -544,9 +648,7 @@
             </a:r>
           </a:p>
           <a:p xmlns:a="http://schemas.openxmlformats.org/drawingml/2006/main">
-            <a:r>
-              <a:t/>
-            </a:r>
+            <a:endParaRPr/>
           </a:p>
           <a:p xmlns:a="http://schemas.openxmlformats.org/drawingml/2006/main">
             <a:r>
@@ -649,9 +751,7 @@
             </a:r>
           </a:p>
           <a:p xmlns:a="http://schemas.openxmlformats.org/drawingml/2006/main">
-            <a:r>
-              <a:t/>
-            </a:r>
+            <a:endParaRPr/>
           </a:p>
           <a:p xmlns:a="http://schemas.openxmlformats.org/drawingml/2006/main">
             <a:r>
@@ -734,9 +834,7 @@
             </a:r>
           </a:p>
           <a:p xmlns:a="http://schemas.openxmlformats.org/drawingml/2006/main">
-            <a:r>
-              <a:t/>
-            </a:r>
+            <a:endParaRPr/>
           </a:p>
           <a:p xmlns:a="http://schemas.openxmlformats.org/drawingml/2006/main">
             <a:r>
@@ -824,9 +922,7 @@
             </a:r>
           </a:p>
           <a:p xmlns:a="http://schemas.openxmlformats.org/drawingml/2006/main">
-            <a:r>
-              <a:t/>
-            </a:r>
+            <a:endParaRPr/>
           </a:p>
           <a:p xmlns:a="http://schemas.openxmlformats.org/drawingml/2006/main">
             <a:r>
@@ -915,13 +1011,14 @@
           <a:lstStyle xmlns:a="http://schemas.openxmlformats.org/drawingml/2006/main"/>
           <a:p xmlns:a="http://schemas.openxmlformats.org/drawingml/2006/main">
             <a:r>
-              <a:t>在登录节点执行 srun。成功分配后才执行下方编译器检查，hostname 应显示计算节点。若排队，等待分配，不要退回登录节点直接运行实验。1 task、1 CPU 足以运行当前串行框架。20 分钟仅用于小规模调试。退出 bash 会释放交互式资源。登录节点于 2026-09-27 实测有 GCC 8.5.0、CMake 3.20.2，但计算节点仍需现场确认。</a:t>
+              <a:t>在登录节点执行 srun。成功分配后才执行下方编译器检查，hostname 应显示计算节点。若排队，等待分配，不要退回登录节点直接运行实验。1 task、1 CPU 足以运行当前串行框架。最长运行 2 小时，不含排队时间；编译、测试与交互终端空闲均计入时限。退出 bash 会释放交互式资源。登录节点于 2026-09-27 实测有 GCC 8.5.0、CMake 3.20.2，但计算节点仍需现场确认。</a:t>
             </a:r>
           </a:p>
           <a:p xmlns:a="http://schemas.openxmlformats.org/drawingml/2006/main">
             <a:r>
               <a:t/>
             </a:r>
+            <a:endParaRPr/>
           </a:p>
           <a:p xmlns:a="http://schemas.openxmlformats.org/drawingml/2006/main">
             <a:r>
@@ -946,6 +1043,11 @@
           <a:p xmlns:a="http://schemas.openxmlformats.org/drawingml/2006/main">
             <a:r>
               <a:t>srun 分配后启动登录 shell，初始化计算节点的软件模块环境。module load cmake 加载默认版本；若不可用或版本低于 3.16，从 module avail cmake 选择实际存在的版本。官方 KOS 页面示例为 cmake/3.26.3-gcc-8.5.0，账号权限和模块版本以现场查询为准。来源：https://docs.hpc.sjtu.edu.cn/job/kos.html 和 https://docs.hpc.sjtu.edu.cn/app/module.html</a:t>
+            </a:r>
+          </a:p>
+          <a:p xmlns:a="http://schemas.openxmlformats.org/drawingml/2006/main">
+            <a:r>
+              <a:t/>
             </a:r>
           </a:p>
         </p:txBody>
@@ -1019,9 +1121,7 @@
             </a:r>
           </a:p>
           <a:p xmlns:a="http://schemas.openxmlformats.org/drawingml/2006/main">
-            <a:r>
-              <a:t/>
-            </a:r>
+            <a:endParaRPr/>
           </a:p>
           <a:p xmlns:a="http://schemas.openxmlformats.org/drawingml/2006/main">
             <a:r>
@@ -1109,9 +1209,7 @@
             </a:r>
           </a:p>
           <a:p xmlns:a="http://schemas.openxmlformats.org/drawingml/2006/main">
-            <a:r>
-              <a:t/>
-            </a:r>
+            <a:endParaRPr/>
           </a:p>
           <a:p xmlns:a="http://schemas.openxmlformats.org/drawingml/2006/main">
             <a:r>
@@ -1194,9 +1292,7 @@
             </a:r>
           </a:p>
           <a:p xmlns:a="http://schemas.openxmlformats.org/drawingml/2006/main">
-            <a:r>
-              <a:t/>
-            </a:r>
+            <a:endParaRPr/>
           </a:p>
           <a:p xmlns:a="http://schemas.openxmlformats.org/drawingml/2006/main">
             <a:r>
@@ -1287,6 +1383,7 @@
             <a:r>
               <a:t/>
             </a:r>
+            <a:endParaRPr/>
           </a:p>
           <a:p xmlns:a="http://schemas.openxmlformats.org/drawingml/2006/main">
             <a:r>
@@ -1301,6 +1398,16 @@
           <a:p xmlns:a="http://schemas.openxmlformats.org/drawingml/2006/main">
             <a:r>
               <a:t>https://docs.hpc.sjtu.edu.cn/job/partition.html</a:t>
+            </a:r>
+          </a:p>
+          <a:p xmlns:a="http://schemas.openxmlformats.org/drawingml/2006/main">
+            <a:r>
+              <a:t/>
+            </a:r>
+          </a:p>
+          <a:p xmlns:a="http://schemas.openxmlformats.org/drawingml/2006/main">
+            <a:r>
+              <a:t>本教程的交互式申请和批处理脚本统一使用 02:00:00，即最长运行 2 小时。时限不含排队时间。提前结束会释放资源。正式实验按实测耗时分批或调整时限。</a:t>
             </a:r>
           </a:p>
         </p:txBody>
@@ -1374,9 +1481,7 @@
             </a:r>
           </a:p>
           <a:p xmlns:a="http://schemas.openxmlformats.org/drawingml/2006/main">
-            <a:r>
-              <a:t/>
-            </a:r>
+            <a:endParaRPr/>
           </a:p>
           <a:p xmlns:a="http://schemas.openxmlformats.org/drawingml/2006/main">
             <a:r>
@@ -1469,9 +1574,7 @@
             </a:r>
           </a:p>
           <a:p xmlns:a="http://schemas.openxmlformats.org/drawingml/2006/main">
-            <a:r>
-              <a:t/>
-            </a:r>
+            <a:endParaRPr/>
           </a:p>
           <a:p xmlns:a="http://schemas.openxmlformats.org/drawingml/2006/main">
             <a:r>
@@ -1555,13 +1658,14 @@
           <a:lstStyle xmlns:a="http://schemas.openxmlformats.org/drawingml/2006/main"/>
           <a:p xmlns:a="http://schemas.openxmlformats.org/drawingml/2006/main">
             <a:r>
-              <a:t>保存为 course-labs/lab2.slurm。左列接右列构成同一脚本，文字讲义提供完整可复制版本。每个作业使用包含 job ID 的独立构建目录，避免不同作业争用构建文件。这里执行小规模检查。正式实验应保留编译和正确性检查，再按课程题面添加运行命令并增加时限。若计算节点缺少工具，先 module avail，再加载实际存在的模块。</a:t>
+              <a:t>保存为 course-labs/lab2.slurm。左列接右列构成同一脚本，文字讲义提供完整可复制版本。每个作业使用包含 job ID 的独立构建目录，避免不同作业争用构建文件。这里执行小规模检查。正式实验应保留编译和正确性检查，再按课程题面添加运行命令并按实测耗时调整时限。若计算节点缺少工具，先 module avail，再加载实际存在的模块。</a:t>
             </a:r>
           </a:p>
           <a:p xmlns:a="http://schemas.openxmlformats.org/drawingml/2006/main">
             <a:r>
               <a:t/>
             </a:r>
+            <a:endParaRPr/>
           </a:p>
           <a:p xmlns:a="http://schemas.openxmlformats.org/drawingml/2006/main">
             <a:r>
@@ -1581,6 +1685,11 @@
           <a:p xmlns:a="http://schemas.openxmlformats.org/drawingml/2006/main">
             <a:r>
               <a:t>批处理脚本自身加载 CMake；交互节点内的 module load 不会自动改变登录节点随后提交的独立作业。登录 shell 初始化模块命令。默认版本必须 ≥3.16，必要时改为 module avail cmake 中确认的具体版本。来源：https://docs.hpc.sjtu.edu.cn/app/module.html 和 https://slurm.schedmd.com/sbatch.html</a:t>
+            </a:r>
+          </a:p>
+          <a:p xmlns:a="http://schemas.openxmlformats.org/drawingml/2006/main">
+            <a:r>
+              <a:t/>
             </a:r>
           </a:p>
         </p:txBody>
@@ -1654,9 +1763,7 @@
             </a:r>
           </a:p>
           <a:p xmlns:a="http://schemas.openxmlformats.org/drawingml/2006/main">
-            <a:r>
-              <a:t/>
-            </a:r>
+            <a:endParaRPr/>
           </a:p>
           <a:p xmlns:a="http://schemas.openxmlformats.org/drawingml/2006/main">
             <a:r>
@@ -1739,9 +1846,7 @@
             </a:r>
           </a:p>
           <a:p xmlns:a="http://schemas.openxmlformats.org/drawingml/2006/main">
-            <a:r>
-              <a:t/>
-            </a:r>
+            <a:endParaRPr/>
           </a:p>
           <a:p xmlns:a="http://schemas.openxmlformats.org/drawingml/2006/main">
             <a:r>
@@ -1829,9 +1934,7 @@
             </a:r>
           </a:p>
           <a:p xmlns:a="http://schemas.openxmlformats.org/drawingml/2006/main">
-            <a:r>
-              <a:t/>
-            </a:r>
+            <a:endParaRPr/>
           </a:p>
           <a:p xmlns:a="http://schemas.openxmlformats.org/drawingml/2006/main">
             <a:r>
@@ -2214,9 +2317,7 @@
             </a:r>
           </a:p>
           <a:p xmlns:a="http://schemas.openxmlformats.org/drawingml/2006/main">
-            <a:r>
-              <a:t/>
-            </a:r>
+            <a:endParaRPr/>
           </a:p>
           <a:p xmlns:a="http://schemas.openxmlformats.org/drawingml/2006/main">
             <a:r>
@@ -2314,9 +2415,7 @@
             </a:r>
           </a:p>
           <a:p xmlns:a="http://schemas.openxmlformats.org/drawingml/2006/main">
-            <a:r>
-              <a:t/>
-            </a:r>
+            <a:endParaRPr/>
           </a:p>
           <a:p xmlns:a="http://schemas.openxmlformats.org/drawingml/2006/main">
             <a:r>
@@ -2429,9 +2528,7 @@
             </a:r>
           </a:p>
           <a:p xmlns:a="http://schemas.openxmlformats.org/drawingml/2006/main">
-            <a:r>
-              <a:t/>
-            </a:r>
+            <a:endParaRPr/>
           </a:p>
           <a:p xmlns:a="http://schemas.openxmlformats.org/drawingml/2006/main">
             <a:r>
@@ -2514,9 +2611,7 @@
             </a:r>
           </a:p>
           <a:p xmlns:a="http://schemas.openxmlformats.org/drawingml/2006/main">
-            <a:r>
-              <a:t/>
-            </a:r>
+            <a:endParaRPr/>
           </a:p>
           <a:p xmlns:a="http://schemas.openxmlformats.org/drawingml/2006/main">
             <a:r>
@@ -2604,9 +2699,7 @@
             </a:r>
           </a:p>
           <a:p xmlns:a="http://schemas.openxmlformats.org/drawingml/2006/main">
-            <a:r>
-              <a:t/>
-            </a:r>
+            <a:endParaRPr/>
           </a:p>
           <a:p xmlns:a="http://schemas.openxmlformats.org/drawingml/2006/main">
             <a:r>
@@ -2694,9 +2787,7 @@
             </a:r>
           </a:p>
           <a:p xmlns:a="http://schemas.openxmlformats.org/drawingml/2006/main">
-            <a:r>
-              <a:t/>
-            </a:r>
+            <a:endParaRPr/>
           </a:p>
           <a:p xmlns:a="http://schemas.openxmlformats.org/drawingml/2006/main">
             <a:r>
@@ -2784,9 +2875,7 @@
             </a:r>
           </a:p>
           <a:p xmlns:a="http://schemas.openxmlformats.org/drawingml/2006/main">
-            <a:r>
-              <a:t/>
-            </a:r>
+            <a:endParaRPr/>
           </a:p>
           <a:p xmlns:a="http://schemas.openxmlformats.org/drawingml/2006/main">
             <a:r>
@@ -2874,9 +2963,7 @@
             </a:r>
           </a:p>
           <a:p xmlns:a="http://schemas.openxmlformats.org/drawingml/2006/main">
-            <a:r>
-              <a:t/>
-            </a:r>
+            <a:endParaRPr/>
           </a:p>
           <a:p xmlns:a="http://schemas.openxmlformats.org/drawingml/2006/main">
             <a:r>
@@ -2964,9 +3051,7 @@
             </a:r>
           </a:p>
           <a:p xmlns:a="http://schemas.openxmlformats.org/drawingml/2006/main">
-            <a:r>
-              <a:t/>
-            </a:r>
+            <a:endParaRPr/>
           </a:p>
           <a:p xmlns:a="http://schemas.openxmlformats.org/drawingml/2006/main">
             <a:r>
@@ -3053,7 +3138,7 @@
   </p:cSld>
   <p:clrMap bg1="lt1" tx1="dk1" bg2="lt2" tx2="dk2" accent1="accent1" accent2="accent2" accent3="accent3" accent4="accent4" accent5="accent5" accent6="accent6" hlink="hlink" folHlink="folHlink"/>
   <p:sldLayoutIdLst>
-    <p:sldLayoutId xmlns:r="http://schemas.openxmlformats.org/officeDocument/2006/relationships" id="2147483649" r:id="Rc865df411be44c1f"/>
+    <p:sldLayoutId xmlns:r="http://schemas.openxmlformats.org/officeDocument/2006/relationships" id="2147483649" r:id="R00558ab552644d69"/>
   </p:sldLayoutIdLst>
   <p:txStyles>
     <p:titleStyle>
@@ -3601,7 +3686,7 @@
       </p:grpSpPr>
       <p:sp>
         <p:nvSpPr>
-          <p:cNvPr id="6" name="">
+          <p:cNvPr id="6" name="矩形 5">
             <a:extLst xmlns:a="http://schemas.openxmlformats.org/drawingml/2006/main">
               <a:ext uri="{FF2B5EF4-FFF2-40B4-BE49-F238E27FC236}">
                 <a16:creationId xmlns:a16="http://schemas.microsoft.com/office/drawing/2014/main" id="{557E11AA-16BF-4B07-9424-186276CC8090}"/>
@@ -3659,7 +3744,7 @@
       </p:sp>
       <p:sp>
         <p:nvSpPr>
-          <p:cNvPr id="2" name="">
+          <p:cNvPr id="2" name="矩形 1">
             <a:extLst xmlns:a="http://schemas.openxmlformats.org/drawingml/2006/main">
               <a:ext uri="{FF2B5EF4-FFF2-40B4-BE49-F238E27FC236}">
                 <a16:creationId xmlns:a16="http://schemas.microsoft.com/office/drawing/2014/main" id="{358EB3C5-E753-4E42-AC5F-492EA4FF6FF7}"/>
@@ -3717,7 +3802,7 @@
       </p:sp>
       <p:sp>
         <p:nvSpPr>
-          <p:cNvPr id="3" name="">
+          <p:cNvPr id="3" name="矩形 2">
             <a:extLst xmlns:a="http://schemas.openxmlformats.org/drawingml/2006/main">
               <a:ext uri="{FF2B5EF4-FFF2-40B4-BE49-F238E27FC236}">
                 <a16:creationId xmlns:a16="http://schemas.microsoft.com/office/drawing/2014/main" id="{D4509EDD-CF67-4208-A430-22EBBD891A93}"/>
@@ -3775,7 +3860,7 @@
       </p:sp>
       <p:sp>
         <p:nvSpPr>
-          <p:cNvPr id="4" name="">
+          <p:cNvPr id="4" name="矩形 3">
             <a:extLst xmlns:a="http://schemas.openxmlformats.org/drawingml/2006/main">
               <a:ext uri="{FF2B5EF4-FFF2-40B4-BE49-F238E27FC236}">
                 <a16:creationId xmlns:a16="http://schemas.microsoft.com/office/drawing/2014/main" id="{72657BED-9824-420F-9E9E-7F38E208372F}"/>
@@ -3833,7 +3918,7 @@
       </p:sp>
       <p:sp>
         <p:nvSpPr>
-          <p:cNvPr id="5" name="">
+          <p:cNvPr id="5" name="矩形 4">
             <a:extLst xmlns:a="http://schemas.openxmlformats.org/drawingml/2006/main">
               <a:ext uri="{FF2B5EF4-FFF2-40B4-BE49-F238E27FC236}">
                 <a16:creationId xmlns:a16="http://schemas.microsoft.com/office/drawing/2014/main" id="{69800642-7ED1-4C7E-AB7A-90167418B180}"/>
@@ -3920,7 +4005,7 @@
       </p:grpSpPr>
       <p:sp>
         <p:nvSpPr>
-          <p:cNvPr id="9" name="">
+          <p:cNvPr id="9" name="矩形 8">
             <a:extLst xmlns:a="http://schemas.openxmlformats.org/drawingml/2006/main">
               <a:ext uri="{FF2B5EF4-FFF2-40B4-BE49-F238E27FC236}">
                 <a16:creationId xmlns:a16="http://schemas.microsoft.com/office/drawing/2014/main" id="{974B2865-DC00-4E59-9F3A-640A7913DC3C}"/>
@@ -3978,7 +4063,7 @@
       </p:sp>
       <p:sp>
         <p:nvSpPr>
-          <p:cNvPr id="2" name="">
+          <p:cNvPr id="2" name="矩形 1">
             <a:extLst xmlns:a="http://schemas.openxmlformats.org/drawingml/2006/main">
               <a:ext uri="{FF2B5EF4-FFF2-40B4-BE49-F238E27FC236}">
                 <a16:creationId xmlns:a16="http://schemas.microsoft.com/office/drawing/2014/main" id="{AFA67C7E-1DCE-457B-9A22-9FD38D176CF9}"/>
@@ -4529,7 +4614,7 @@
       </p:grpSpPr>
       <p:sp>
         <p:nvSpPr>
-          <p:cNvPr id="13" name="">
+          <p:cNvPr id="13" name="矩形 12">
             <a:extLst xmlns:a="http://schemas.openxmlformats.org/drawingml/2006/main">
               <a:ext uri="{FF2B5EF4-FFF2-40B4-BE49-F238E27FC236}">
                 <a16:creationId xmlns:a16="http://schemas.microsoft.com/office/drawing/2014/main" id="{F72D8CD2-C378-452E-BD65-A32051B5A5F1}"/>
@@ -4587,7 +4672,7 @@
       </p:sp>
       <p:sp>
         <p:nvSpPr>
-          <p:cNvPr id="2" name="">
+          <p:cNvPr id="2" name="矩形 1">
             <a:extLst xmlns:a="http://schemas.openxmlformats.org/drawingml/2006/main">
               <a:ext uri="{FF2B5EF4-FFF2-40B4-BE49-F238E27FC236}">
                 <a16:creationId xmlns:a16="http://schemas.microsoft.com/office/drawing/2014/main" id="{C465AA1C-7538-452B-A075-B36D60CDEA34}"/>
@@ -5080,7 +5165,7 @@
       </p:grpSpPr>
       <p:sp>
         <p:nvSpPr>
-          <p:cNvPr id="9" name="">
+          <p:cNvPr id="9" name="矩形 8">
             <a:extLst xmlns:a="http://schemas.openxmlformats.org/drawingml/2006/main">
               <a:ext uri="{FF2B5EF4-FFF2-40B4-BE49-F238E27FC236}">
                 <a16:creationId xmlns:a16="http://schemas.microsoft.com/office/drawing/2014/main" id="{974B2865-DC00-4E59-9F3A-640A7913DC3C}"/>
@@ -5138,7 +5223,7 @@
       </p:sp>
       <p:sp>
         <p:nvSpPr>
-          <p:cNvPr id="2" name="">
+          <p:cNvPr id="2" name="矩形 1">
             <a:extLst xmlns:a="http://schemas.openxmlformats.org/drawingml/2006/main">
               <a:ext uri="{FF2B5EF4-FFF2-40B4-BE49-F238E27FC236}">
                 <a16:creationId xmlns:a16="http://schemas.microsoft.com/office/drawing/2014/main" id="{AFA67C7E-1DCE-457B-9A22-9FD38D176CF9}"/>
@@ -5573,7 +5658,7 @@
       </p:grpSpPr>
       <p:sp>
         <p:nvSpPr>
-          <p:cNvPr id="9" name="">
+          <p:cNvPr id="9" name="矩形 8">
             <a:extLst xmlns:a="http://schemas.openxmlformats.org/drawingml/2006/main">
               <a:ext uri="{FF2B5EF4-FFF2-40B4-BE49-F238E27FC236}">
                 <a16:creationId xmlns:a16="http://schemas.microsoft.com/office/drawing/2014/main" id="{974B2865-DC00-4E59-9F3A-640A7913DC3C}"/>
@@ -5631,7 +5716,7 @@
       </p:sp>
       <p:sp>
         <p:nvSpPr>
-          <p:cNvPr id="2" name="">
+          <p:cNvPr id="2" name="矩形 1">
             <a:extLst xmlns:a="http://schemas.openxmlformats.org/drawingml/2006/main">
               <a:ext uri="{FF2B5EF4-FFF2-40B4-BE49-F238E27FC236}">
                 <a16:creationId xmlns:a16="http://schemas.microsoft.com/office/drawing/2014/main" id="{AFA67C7E-1DCE-457B-9A22-9FD38D176CF9}"/>
@@ -6182,7 +6267,7 @@
       </p:grpSpPr>
       <p:sp>
         <p:nvSpPr>
-          <p:cNvPr id="11" name="">
+          <p:cNvPr id="11" name="矩形 10">
             <a:extLst xmlns:a="http://schemas.openxmlformats.org/drawingml/2006/main">
               <a:ext uri="{FF2B5EF4-FFF2-40B4-BE49-F238E27FC236}">
                 <a16:creationId xmlns:a16="http://schemas.microsoft.com/office/drawing/2014/main" id="{5F8E6EC2-21DA-414B-AF6E-2782ACA9D20C}"/>
@@ -6235,12 +6320,53 @@
               </a:rPr>
               <a:t>申请一个计算核心</a:t>
             </a:r>
-          </a:p>
-        </p:txBody>
-      </p:sp>
-      <p:sp>
-        <p:nvSpPr>
-          <p:cNvPr id="2" name="">
+            <a:r>
+              <a:rPr sz="3900" b="1">
+                <a:solidFill>
+                  <a:srgbClr val="EAF1EF"/>
+                </a:solidFill>
+                <a:latin typeface="Hiragino Sans GB"/>
+                <a:ea typeface="Hiragino Sans GB"/>
+                <a:cs typeface="Hiragino Sans GB"/>
+              </a:rPr>
+              <a:t>(</a:t>
+            </a:r>
+            <a:r>
+              <a:rPr sz="3900" b="1">
+                <a:solidFill>
+                  <a:srgbClr val="EAF1EF"/>
+                </a:solidFill>
+                <a:latin typeface="Hiragino Sans GB"/>
+                <a:ea typeface="Hiragino Sans GB"/>
+                <a:cs typeface="Hiragino Sans GB"/>
+              </a:rPr>
+              <a:t>在登陆终端等待分配后直接进入计算终端</a:t>
+            </a:r>
+            <a:r>
+              <a:rPr sz="3900" b="1">
+                <a:solidFill>
+                  <a:srgbClr val="EAF1EF"/>
+                </a:solidFill>
+                <a:latin typeface="Hiragino Sans GB"/>
+                <a:ea typeface="Hiragino Sans GB"/>
+                <a:cs typeface="Hiragino Sans GB"/>
+              </a:rPr>
+              <a:t>)</a:t>
+            </a:r>
+            <a:endParaRPr sz="3900" b="1">
+              <a:solidFill>
+                <a:srgbClr val="EAF1EF"/>
+              </a:solidFill>
+              <a:latin typeface="Hiragino Sans GB"/>
+              <a:ea typeface="Hiragino Sans GB"/>
+              <a:cs typeface="Hiragino Sans GB"/>
+            </a:endParaRPr>
+          </a:p>
+        </p:txBody>
+      </p:sp>
+      <p:sp>
+        <p:nvSpPr>
+          <p:cNvPr id="2" name="矩形 1">
             <a:extLst xmlns:a="http://schemas.openxmlformats.org/drawingml/2006/main">
               <a:ext uri="{FF2B5EF4-FFF2-40B4-BE49-F238E27FC236}">
                 <a16:creationId xmlns:a16="http://schemas.microsoft.com/office/drawing/2014/main" id="{B799D959-7B71-430B-BCF8-02A54041924A}"/>
@@ -6298,7 +6424,7 @@
       </p:sp>
       <p:sp>
         <p:nvSpPr>
-          <p:cNvPr id="3" name="">
+          <p:cNvPr id="3" name="矩形 2">
             <a:extLst xmlns:a="http://schemas.openxmlformats.org/drawingml/2006/main">
               <a:ext uri="{FF2B5EF4-FFF2-40B4-BE49-F238E27FC236}">
                 <a16:creationId xmlns:a16="http://schemas.microsoft.com/office/drawing/2014/main" id="{5FE5EA2E-692B-4837-A4E3-AE2A6777D1F2}"/>
@@ -6356,7 +6482,7 @@
       </p:sp>
       <p:sp>
         <p:nvSpPr>
-          <p:cNvPr id="4" name="">
+          <p:cNvPr id="4" name="矩形 3">
             <a:extLst xmlns:a="http://schemas.openxmlformats.org/drawingml/2006/main">
               <a:ext uri="{FF2B5EF4-FFF2-40B4-BE49-F238E27FC236}">
                 <a16:creationId xmlns:a16="http://schemas.microsoft.com/office/drawing/2014/main" id="{E9088F77-E9A0-4DE3-8BCB-D7878E65AADA}"/>
@@ -6407,14 +6533,36 @@
                 <a:ea typeface="Menlo"/>
                 <a:cs typeface="Menlo"/>
               </a:rPr>
-              <a:t>srun -p cpu -N 1 -n 1 -c 1 -t 00:20:00 \</a:t>
-            </a:r>
-          </a:p>
-        </p:txBody>
-      </p:sp>
-      <p:sp>
-        <p:nvSpPr>
-          <p:cNvPr id="5" name="">
+              <a:t>srun -p cpu -N 1 -n 1 -c 1 -t </a:t>
+            </a:r>
+            <a:r>
+              <a:rPr sz="2325" b="0">
+                <a:solidFill>
+                  <a:srgbClr val="B7EDDB"/>
+                </a:solidFill>
+                <a:latin typeface="Menlo"/>
+                <a:ea typeface="Menlo"/>
+                <a:cs typeface="Menlo"/>
+              </a:rPr>
+              <a:t>02:00:00</a:t>
+            </a:r>
+            <a:r>
+              <a:rPr sz="2325" b="0">
+                <a:solidFill>
+                  <a:srgbClr val="B7EDDB"/>
+                </a:solidFill>
+                <a:latin typeface="Menlo"/>
+                <a:ea typeface="Menlo"/>
+                <a:cs typeface="Menlo"/>
+              </a:rPr>
+              <a:t> \</a:t>
+            </a:r>
+          </a:p>
+        </p:txBody>
+      </p:sp>
+      <p:sp>
+        <p:nvSpPr>
+          <p:cNvPr id="5" name="矩形 4">
             <a:extLst xmlns:a="http://schemas.openxmlformats.org/drawingml/2006/main">
               <a:ext uri="{FF2B5EF4-FFF2-40B4-BE49-F238E27FC236}">
                 <a16:creationId xmlns:a16="http://schemas.microsoft.com/office/drawing/2014/main" id="{A70A2566-3C56-4F19-AC4C-D066E5A3009B}"/>
@@ -6472,7 +6620,7 @@
       </p:sp>
       <p:sp>
         <p:nvSpPr>
-          <p:cNvPr id="6" name="">
+          <p:cNvPr id="6" name="矩形 5">
             <a:extLst xmlns:a="http://schemas.openxmlformats.org/drawingml/2006/main">
               <a:ext uri="{FF2B5EF4-FFF2-40B4-BE49-F238E27FC236}">
                 <a16:creationId xmlns:a16="http://schemas.microsoft.com/office/drawing/2014/main" id="{59C9D7A4-D17D-4381-A1E8-8356CADBAB78}"/>
@@ -6503,15 +6651,13 @@
           </a:bodyPr>
           <a:lstStyle xmlns:a="http://schemas.openxmlformats.org/drawingml/2006/main"/>
           <a:p xmlns:a="http://schemas.openxmlformats.org/drawingml/2006/main">
-            <a:r>
-              <a:t/>
-            </a:r>
-          </a:p>
-        </p:txBody>
-      </p:sp>
-      <p:sp>
-        <p:nvSpPr>
-          <p:cNvPr id="7" name="">
+            <a:endParaRPr/>
+          </a:p>
+        </p:txBody>
+      </p:sp>
+      <p:sp>
+        <p:nvSpPr>
+          <p:cNvPr id="7" name="矩形 6">
             <a:extLst xmlns:a="http://schemas.openxmlformats.org/drawingml/2006/main">
               <a:ext uri="{FF2B5EF4-FFF2-40B4-BE49-F238E27FC236}">
                 <a16:creationId xmlns:a16="http://schemas.microsoft.com/office/drawing/2014/main" id="{719F30DC-12EB-4A76-8418-ECAEF0FF1AA4}"/>
@@ -6569,7 +6715,7 @@
       </p:sp>
       <p:sp>
         <p:nvSpPr>
-          <p:cNvPr id="8" name="">
+          <p:cNvPr id="8" name="矩形 7">
             <a:extLst xmlns:a="http://schemas.openxmlformats.org/drawingml/2006/main">
               <a:ext uri="{FF2B5EF4-FFF2-40B4-BE49-F238E27FC236}">
                 <a16:creationId xmlns:a16="http://schemas.microsoft.com/office/drawing/2014/main" id="{131BFAE1-8FB9-4E50-AB14-10F440F291B2}"/>
@@ -6627,7 +6773,7 @@
       </p:sp>
       <p:sp>
         <p:nvSpPr>
-          <p:cNvPr id="9" name="">
+          <p:cNvPr id="9" name="矩形 8">
             <a:extLst xmlns:a="http://schemas.openxmlformats.org/drawingml/2006/main">
               <a:ext uri="{FF2B5EF4-FFF2-40B4-BE49-F238E27FC236}">
                 <a16:creationId xmlns:a16="http://schemas.microsoft.com/office/drawing/2014/main" id="{11414224-07BF-41F8-BB55-F196F21F8A56}"/>
@@ -6685,7 +6831,7 @@
       </p:sp>
       <p:sp>
         <p:nvSpPr>
-          <p:cNvPr id="10" name="">
+          <p:cNvPr id="10" name="矩形 9">
             <a:extLst xmlns:a="http://schemas.openxmlformats.org/drawingml/2006/main">
               <a:ext uri="{FF2B5EF4-FFF2-40B4-BE49-F238E27FC236}">
                 <a16:creationId xmlns:a16="http://schemas.microsoft.com/office/drawing/2014/main" id="{032040BB-3DB9-464D-8B2B-57338843F716}"/>
@@ -6775,6 +6921,7 @@
           <a:lstStyle xmlns:a="http://schemas.openxmlformats.org/drawingml/2006/main"/>
           <a:p xmlns:a="http://schemas.openxmlformats.org/drawingml/2006/main">
             <a:pPr>
+              <a:buNone/>
               <a:defRPr sz="2550">
                 <a:solidFill>
                   <a:srgbClr val="B7EDDB"/>
@@ -6832,6 +6979,7 @@
           <a:lstStyle xmlns:a="http://schemas.openxmlformats.org/drawingml/2006/main"/>
           <a:p xmlns:a="http://schemas.openxmlformats.org/drawingml/2006/main">
             <a:pPr>
+              <a:buNone/>
               <a:defRPr sz="2550">
                 <a:solidFill>
                   <a:srgbClr val="B7EDDB"/>
@@ -6889,6 +7037,7 @@
           <a:lstStyle xmlns:a="http://schemas.openxmlformats.org/drawingml/2006/main"/>
           <a:p xmlns:a="http://schemas.openxmlformats.org/drawingml/2006/main">
             <a:pPr>
+              <a:buNone/>
               <a:defRPr sz="2025">
                 <a:solidFill>
                   <a:srgbClr val="A8C6C4"/>
@@ -6943,7 +7092,7 @@
       </p:grpSpPr>
       <p:sp>
         <p:nvSpPr>
-          <p:cNvPr id="11" name="">
+          <p:cNvPr id="11" name="矩形 10">
             <a:extLst xmlns:a="http://schemas.openxmlformats.org/drawingml/2006/main">
               <a:ext uri="{FF2B5EF4-FFF2-40B4-BE49-F238E27FC236}">
                 <a16:creationId xmlns:a16="http://schemas.microsoft.com/office/drawing/2014/main" id="{28D724B1-87ED-4A13-A3F4-C120F4756ED2}"/>
@@ -7001,7 +7150,7 @@
       </p:sp>
       <p:sp>
         <p:nvSpPr>
-          <p:cNvPr id="2" name="">
+          <p:cNvPr id="2" name="矩形 1">
             <a:extLst xmlns:a="http://schemas.openxmlformats.org/drawingml/2006/main">
               <a:ext uri="{FF2B5EF4-FFF2-40B4-BE49-F238E27FC236}">
                 <a16:creationId xmlns:a16="http://schemas.microsoft.com/office/drawing/2014/main" id="{CD2D2784-7D4D-4795-BB5B-E9DE9E978393}"/>
@@ -7059,7 +7208,7 @@
       </p:sp>
       <p:sp>
         <p:nvSpPr>
-          <p:cNvPr id="3" name="">
+          <p:cNvPr id="3" name="矩形 2">
             <a:extLst xmlns:a="http://schemas.openxmlformats.org/drawingml/2006/main">
               <a:ext uri="{FF2B5EF4-FFF2-40B4-BE49-F238E27FC236}">
                 <a16:creationId xmlns:a16="http://schemas.microsoft.com/office/drawing/2014/main" id="{FB9A82E2-1865-4C13-A72E-A27ED55FE404}"/>
@@ -7117,7 +7266,7 @@
       </p:sp>
       <p:sp>
         <p:nvSpPr>
-          <p:cNvPr id="4" name="">
+          <p:cNvPr id="4" name="矩形 3">
             <a:extLst xmlns:a="http://schemas.openxmlformats.org/drawingml/2006/main">
               <a:ext uri="{FF2B5EF4-FFF2-40B4-BE49-F238E27FC236}">
                 <a16:creationId xmlns:a16="http://schemas.microsoft.com/office/drawing/2014/main" id="{B78C415D-F64F-4EC7-8ADD-7D1D8708359C}"/>
@@ -7175,7 +7324,7 @@
       </p:sp>
       <p:sp>
         <p:nvSpPr>
-          <p:cNvPr id="5" name="">
+          <p:cNvPr id="5" name="矩形 4">
             <a:extLst xmlns:a="http://schemas.openxmlformats.org/drawingml/2006/main">
               <a:ext uri="{FF2B5EF4-FFF2-40B4-BE49-F238E27FC236}">
                 <a16:creationId xmlns:a16="http://schemas.microsoft.com/office/drawing/2014/main" id="{CBF4F5BE-F2EA-406A-9983-2D488C201E33}"/>
@@ -7233,7 +7382,7 @@
       </p:sp>
       <p:sp>
         <p:nvSpPr>
-          <p:cNvPr id="6" name="">
+          <p:cNvPr id="6" name="矩形 5">
             <a:extLst xmlns:a="http://schemas.openxmlformats.org/drawingml/2006/main">
               <a:ext uri="{FF2B5EF4-FFF2-40B4-BE49-F238E27FC236}">
                 <a16:creationId xmlns:a16="http://schemas.microsoft.com/office/drawing/2014/main" id="{40E5022B-5E9F-4D7C-A317-95331801318E}"/>
@@ -7264,15 +7413,13 @@
           </a:bodyPr>
           <a:lstStyle xmlns:a="http://schemas.openxmlformats.org/drawingml/2006/main"/>
           <a:p xmlns:a="http://schemas.openxmlformats.org/drawingml/2006/main">
-            <a:r>
-              <a:t/>
-            </a:r>
-          </a:p>
-        </p:txBody>
-      </p:sp>
-      <p:sp>
-        <p:nvSpPr>
-          <p:cNvPr id="7" name="">
+            <a:endParaRPr/>
+          </a:p>
+        </p:txBody>
+      </p:sp>
+      <p:sp>
+        <p:nvSpPr>
+          <p:cNvPr id="7" name="矩形 6">
             <a:extLst xmlns:a="http://schemas.openxmlformats.org/drawingml/2006/main">
               <a:ext uri="{FF2B5EF4-FFF2-40B4-BE49-F238E27FC236}">
                 <a16:creationId xmlns:a16="http://schemas.microsoft.com/office/drawing/2014/main" id="{0A89E490-3A2D-4E07-9F9F-804C507D87BE}"/>
@@ -7330,7 +7477,7 @@
       </p:sp>
       <p:sp>
         <p:nvSpPr>
-          <p:cNvPr id="8" name="">
+          <p:cNvPr id="8" name="矩形 7">
             <a:extLst xmlns:a="http://schemas.openxmlformats.org/drawingml/2006/main">
               <a:ext uri="{FF2B5EF4-FFF2-40B4-BE49-F238E27FC236}">
                 <a16:creationId xmlns:a16="http://schemas.microsoft.com/office/drawing/2014/main" id="{2BBF4072-5926-4F7D-858E-C3481C0DE0C4}"/>
@@ -7388,7 +7535,7 @@
       </p:sp>
       <p:sp>
         <p:nvSpPr>
-          <p:cNvPr id="9" name="">
+          <p:cNvPr id="9" name="矩形 8">
             <a:extLst xmlns:a="http://schemas.openxmlformats.org/drawingml/2006/main">
               <a:ext uri="{FF2B5EF4-FFF2-40B4-BE49-F238E27FC236}">
                 <a16:creationId xmlns:a16="http://schemas.microsoft.com/office/drawing/2014/main" id="{AB358353-C40A-402E-A3AD-835C7F76A888}"/>
@@ -7446,7 +7593,7 @@
       </p:sp>
       <p:sp>
         <p:nvSpPr>
-          <p:cNvPr id="10" name="">
+          <p:cNvPr id="10" name="矩形 9">
             <a:extLst xmlns:a="http://schemas.openxmlformats.org/drawingml/2006/main">
               <a:ext uri="{FF2B5EF4-FFF2-40B4-BE49-F238E27FC236}">
                 <a16:creationId xmlns:a16="http://schemas.microsoft.com/office/drawing/2014/main" id="{A44B5A37-8EFE-4F06-9CAA-F6BE900DDD42}"/>
@@ -7536,6 +7683,7 @@
           <a:lstStyle xmlns:a="http://schemas.openxmlformats.org/drawingml/2006/main"/>
           <a:p xmlns:a="http://schemas.openxmlformats.org/drawingml/2006/main">
             <a:pPr>
+              <a:buNone/>
               <a:defRPr sz="2550">
                 <a:solidFill>
                   <a:srgbClr val="B7EDDB"/>
@@ -7593,6 +7741,7 @@
           <a:lstStyle xmlns:a="http://schemas.openxmlformats.org/drawingml/2006/main"/>
           <a:p xmlns:a="http://schemas.openxmlformats.org/drawingml/2006/main">
             <a:pPr>
+              <a:buNone/>
               <a:defRPr sz="2025">
                 <a:solidFill>
                   <a:srgbClr val="A8C6C4"/>
@@ -7647,7 +7796,7 @@
       </p:grpSpPr>
       <p:sp>
         <p:nvSpPr>
-          <p:cNvPr id="10" name="">
+          <p:cNvPr id="10" name="矩形 9">
             <a:extLst xmlns:a="http://schemas.openxmlformats.org/drawingml/2006/main">
               <a:ext uri="{FF2B5EF4-FFF2-40B4-BE49-F238E27FC236}">
                 <a16:creationId xmlns:a16="http://schemas.microsoft.com/office/drawing/2014/main" id="{E840FD5F-39E6-4985-8D14-D992FD4B43C1}"/>
@@ -7705,7 +7854,7 @@
       </p:sp>
       <p:sp>
         <p:nvSpPr>
-          <p:cNvPr id="2" name="">
+          <p:cNvPr id="2" name="矩形 1">
             <a:extLst xmlns:a="http://schemas.openxmlformats.org/drawingml/2006/main">
               <a:ext uri="{FF2B5EF4-FFF2-40B4-BE49-F238E27FC236}">
                 <a16:creationId xmlns:a16="http://schemas.microsoft.com/office/drawing/2014/main" id="{1CE26C0E-36C8-4374-80D8-2A76944BBC9F}"/>
@@ -7763,7 +7912,7 @@
       </p:sp>
       <p:sp>
         <p:nvSpPr>
-          <p:cNvPr id="3" name="">
+          <p:cNvPr id="3" name="矩形 2">
             <a:extLst xmlns:a="http://schemas.openxmlformats.org/drawingml/2006/main">
               <a:ext uri="{FF2B5EF4-FFF2-40B4-BE49-F238E27FC236}">
                 <a16:creationId xmlns:a16="http://schemas.microsoft.com/office/drawing/2014/main" id="{0580AA8B-605E-4FE7-8EC3-747760A6FEFE}"/>
@@ -7821,7 +7970,7 @@
       </p:sp>
       <p:sp>
         <p:nvSpPr>
-          <p:cNvPr id="4" name="">
+          <p:cNvPr id="4" name="矩形 3">
             <a:extLst xmlns:a="http://schemas.openxmlformats.org/drawingml/2006/main">
               <a:ext uri="{FF2B5EF4-FFF2-40B4-BE49-F238E27FC236}">
                 <a16:creationId xmlns:a16="http://schemas.microsoft.com/office/drawing/2014/main" id="{7E76CC0D-CE18-42EC-9EDB-A80FDC3D8B2A}"/>
@@ -7872,14 +8021,25 @@
                 <a:ea typeface="Menlo"/>
                 <a:cs typeface="Menlo"/>
               </a:rPr>
-              <a:t>cmake -S . -B build-pi2 -DBUILD_TESTING=ON \</a:t>
-            </a:r>
-          </a:p>
-        </p:txBody>
-      </p:sp>
-      <p:sp>
-        <p:nvSpPr>
-          <p:cNvPr id="5" name="">
+              <a:t>cmake</a:t>
+            </a:r>
+            <a:r>
+              <a:rPr sz="2325" b="0">
+                <a:solidFill>
+                  <a:srgbClr val="B7EDDB"/>
+                </a:solidFill>
+                <a:latin typeface="Menlo"/>
+                <a:ea typeface="Menlo"/>
+                <a:cs typeface="Menlo"/>
+              </a:rPr>
+              <a:t> -S . -B build-pi2 -DBUILD_TESTING=ON \</a:t>
+            </a:r>
+          </a:p>
+        </p:txBody>
+      </p:sp>
+      <p:sp>
+        <p:nvSpPr>
+          <p:cNvPr id="5" name="矩形 4">
             <a:extLst xmlns:a="http://schemas.openxmlformats.org/drawingml/2006/main">
               <a:ext uri="{FF2B5EF4-FFF2-40B4-BE49-F238E27FC236}">
                 <a16:creationId xmlns:a16="http://schemas.microsoft.com/office/drawing/2014/main" id="{D96ADF46-5637-4F54-BFD9-82250329430A}"/>
@@ -7937,7 +8097,7 @@
       </p:sp>
       <p:sp>
         <p:nvSpPr>
-          <p:cNvPr id="6" name="">
+          <p:cNvPr id="6" name="矩形 5">
             <a:extLst xmlns:a="http://schemas.openxmlformats.org/drawingml/2006/main">
               <a:ext uri="{FF2B5EF4-FFF2-40B4-BE49-F238E27FC236}">
                 <a16:creationId xmlns:a16="http://schemas.microsoft.com/office/drawing/2014/main" id="{A11D0A58-7B73-4327-8EE1-872F113CB14B}"/>
@@ -7988,14 +8148,25 @@
                 <a:ea typeface="Menlo"/>
                 <a:cs typeface="Menlo"/>
               </a:rPr>
-              <a:t>cmake --build build-pi2 --parallel 1</a:t>
-            </a:r>
-          </a:p>
-        </p:txBody>
-      </p:sp>
-      <p:sp>
-        <p:nvSpPr>
-          <p:cNvPr id="7" name="">
+              <a:t>cmake</a:t>
+            </a:r>
+            <a:r>
+              <a:rPr sz="2325" b="0">
+                <a:solidFill>
+                  <a:srgbClr val="B7EDDB"/>
+                </a:solidFill>
+                <a:latin typeface="Menlo"/>
+                <a:ea typeface="Menlo"/>
+                <a:cs typeface="Menlo"/>
+              </a:rPr>
+              <a:t> --build build-pi2 --parallel 1</a:t>
+            </a:r>
+          </a:p>
+        </p:txBody>
+      </p:sp>
+      <p:sp>
+        <p:nvSpPr>
+          <p:cNvPr id="7" name="矩形 6">
             <a:extLst xmlns:a="http://schemas.openxmlformats.org/drawingml/2006/main">
               <a:ext uri="{FF2B5EF4-FFF2-40B4-BE49-F238E27FC236}">
                 <a16:creationId xmlns:a16="http://schemas.microsoft.com/office/drawing/2014/main" id="{5DD9C4AC-744B-4A47-9E8A-CC90853D4CDA}"/>
@@ -8053,7 +8224,7 @@
       </p:sp>
       <p:sp>
         <p:nvSpPr>
-          <p:cNvPr id="8" name="">
+          <p:cNvPr id="8" name="矩形 7">
             <a:extLst xmlns:a="http://schemas.openxmlformats.org/drawingml/2006/main">
               <a:ext uri="{FF2B5EF4-FFF2-40B4-BE49-F238E27FC236}">
                 <a16:creationId xmlns:a16="http://schemas.microsoft.com/office/drawing/2014/main" id="{268CC32C-8FA1-4F4C-AA00-324DCAE38EDD}"/>
@@ -8111,7 +8282,7 @@
       </p:sp>
       <p:sp>
         <p:nvSpPr>
-          <p:cNvPr id="9" name="">
+          <p:cNvPr id="9" name="矩形 8">
             <a:extLst xmlns:a="http://schemas.openxmlformats.org/drawingml/2006/main">
               <a:ext uri="{FF2B5EF4-FFF2-40B4-BE49-F238E27FC236}">
                 <a16:creationId xmlns:a16="http://schemas.microsoft.com/office/drawing/2014/main" id="{2831D08D-8C62-42CB-91B9-795597BADE6C}"/>
@@ -8198,7 +8369,7 @@
       </p:grpSpPr>
       <p:sp>
         <p:nvSpPr>
-          <p:cNvPr id="11" name="">
+          <p:cNvPr id="11" name="矩形 10">
             <a:extLst xmlns:a="http://schemas.openxmlformats.org/drawingml/2006/main">
               <a:ext uri="{FF2B5EF4-FFF2-40B4-BE49-F238E27FC236}">
                 <a16:creationId xmlns:a16="http://schemas.microsoft.com/office/drawing/2014/main" id="{C586E408-4221-4D15-90EE-41ABC83275E6}"/>
@@ -8256,7 +8427,7 @@
       </p:sp>
       <p:sp>
         <p:nvSpPr>
-          <p:cNvPr id="2" name="">
+          <p:cNvPr id="2" name="矩形 1">
             <a:extLst xmlns:a="http://schemas.openxmlformats.org/drawingml/2006/main">
               <a:ext uri="{FF2B5EF4-FFF2-40B4-BE49-F238E27FC236}">
                 <a16:creationId xmlns:a16="http://schemas.microsoft.com/office/drawing/2014/main" id="{3A5BF6B0-2386-463E-A36F-5588CDE876FE}"/>
@@ -8314,7 +8485,7 @@
       </p:sp>
       <p:sp>
         <p:nvSpPr>
-          <p:cNvPr id="3" name="">
+          <p:cNvPr id="3" name="矩形 2">
             <a:extLst xmlns:a="http://schemas.openxmlformats.org/drawingml/2006/main">
               <a:ext uri="{FF2B5EF4-FFF2-40B4-BE49-F238E27FC236}">
                 <a16:creationId xmlns:a16="http://schemas.microsoft.com/office/drawing/2014/main" id="{E9B81390-D8EC-4DC0-A2B7-56D86E45E3EB}"/>
@@ -8365,14 +8536,36 @@
                 <a:ea typeface="Menlo"/>
                 <a:cs typeface="Menlo"/>
               </a:rPr>
-              <a:t>./build-pi2/reg_reuse 6 12 24 48</a:t>
-            </a:r>
-          </a:p>
-        </p:txBody>
-      </p:sp>
-      <p:sp>
-        <p:nvSpPr>
-          <p:cNvPr id="4" name="">
+              <a:t>./build-pi2/</a:t>
+            </a:r>
+            <a:r>
+              <a:rPr sz="2400" b="0">
+                <a:solidFill>
+                  <a:srgbClr val="B7EDDB"/>
+                </a:solidFill>
+                <a:latin typeface="Menlo"/>
+                <a:ea typeface="Menlo"/>
+                <a:cs typeface="Menlo"/>
+              </a:rPr>
+              <a:t>reg_reuse</a:t>
+            </a:r>
+            <a:r>
+              <a:rPr sz="2400" b="0">
+                <a:solidFill>
+                  <a:srgbClr val="B7EDDB"/>
+                </a:solidFill>
+                <a:latin typeface="Menlo"/>
+                <a:ea typeface="Menlo"/>
+                <a:cs typeface="Menlo"/>
+              </a:rPr>
+              <a:t> 6 12 24 48</a:t>
+            </a:r>
+          </a:p>
+        </p:txBody>
+      </p:sp>
+      <p:sp>
+        <p:nvSpPr>
+          <p:cNvPr id="4" name="矩形 3">
             <a:extLst xmlns:a="http://schemas.openxmlformats.org/drawingml/2006/main">
               <a:ext uri="{FF2B5EF4-FFF2-40B4-BE49-F238E27FC236}">
                 <a16:creationId xmlns:a16="http://schemas.microsoft.com/office/drawing/2014/main" id="{7E18FD51-6D86-40D4-BC67-21248FC38102}"/>
@@ -8430,7 +8623,7 @@
       </p:sp>
       <p:sp>
         <p:nvSpPr>
-          <p:cNvPr id="5" name="">
+          <p:cNvPr id="5" name="矩形 4">
             <a:extLst xmlns:a="http://schemas.openxmlformats.org/drawingml/2006/main">
               <a:ext uri="{FF2B5EF4-FFF2-40B4-BE49-F238E27FC236}">
                 <a16:creationId xmlns:a16="http://schemas.microsoft.com/office/drawing/2014/main" id="{B51B5E1A-9B26-48C1-A6C2-6EC8F5867410}"/>
@@ -8461,15 +8654,13 @@
           </a:bodyPr>
           <a:lstStyle xmlns:a="http://schemas.openxmlformats.org/drawingml/2006/main"/>
           <a:p xmlns:a="http://schemas.openxmlformats.org/drawingml/2006/main">
-            <a:r>
-              <a:t/>
-            </a:r>
-          </a:p>
-        </p:txBody>
-      </p:sp>
-      <p:sp>
-        <p:nvSpPr>
-          <p:cNvPr id="6" name="">
+            <a:endParaRPr/>
+          </a:p>
+        </p:txBody>
+      </p:sp>
+      <p:sp>
+        <p:nvSpPr>
+          <p:cNvPr id="6" name="矩形 5">
             <a:extLst xmlns:a="http://schemas.openxmlformats.org/drawingml/2006/main">
               <a:ext uri="{FF2B5EF4-FFF2-40B4-BE49-F238E27FC236}">
                 <a16:creationId xmlns:a16="http://schemas.microsoft.com/office/drawing/2014/main" id="{CEAE8D44-1B67-48CF-AC6F-586F45092B91}"/>
@@ -8527,7 +8718,7 @@
       </p:sp>
       <p:sp>
         <p:nvSpPr>
-          <p:cNvPr id="7" name="">
+          <p:cNvPr id="7" name="矩形 6">
             <a:extLst xmlns:a="http://schemas.openxmlformats.org/drawingml/2006/main">
               <a:ext uri="{FF2B5EF4-FFF2-40B4-BE49-F238E27FC236}">
                 <a16:creationId xmlns:a16="http://schemas.microsoft.com/office/drawing/2014/main" id="{E5A6BAEB-7FCD-48A9-89BD-1CD453FBBABC}"/>
@@ -8585,7 +8776,7 @@
       </p:sp>
       <p:sp>
         <p:nvSpPr>
-          <p:cNvPr id="8" name="">
+          <p:cNvPr id="8" name="矩形 7">
             <a:extLst xmlns:a="http://schemas.openxmlformats.org/drawingml/2006/main">
               <a:ext uri="{FF2B5EF4-FFF2-40B4-BE49-F238E27FC236}">
                 <a16:creationId xmlns:a16="http://schemas.microsoft.com/office/drawing/2014/main" id="{0CFB5CB8-A74C-457D-96B6-CA02FC1D1690}"/>
@@ -8643,7 +8834,7 @@
       </p:sp>
       <p:sp>
         <p:nvSpPr>
-          <p:cNvPr id="9" name="">
+          <p:cNvPr id="9" name="矩形 8">
             <a:extLst xmlns:a="http://schemas.openxmlformats.org/drawingml/2006/main">
               <a:ext uri="{FF2B5EF4-FFF2-40B4-BE49-F238E27FC236}">
                 <a16:creationId xmlns:a16="http://schemas.microsoft.com/office/drawing/2014/main" id="{C3059BCD-31A0-4D9A-B974-036865B61B2A}"/>
@@ -8701,7 +8892,7 @@
       </p:sp>
       <p:sp>
         <p:nvSpPr>
-          <p:cNvPr id="10" name="">
+          <p:cNvPr id="10" name="矩形 9">
             <a:extLst xmlns:a="http://schemas.openxmlformats.org/drawingml/2006/main">
               <a:ext uri="{FF2B5EF4-FFF2-40B4-BE49-F238E27FC236}">
                 <a16:creationId xmlns:a16="http://schemas.microsoft.com/office/drawing/2014/main" id="{64517ACE-DEF7-4E92-BDD2-A8BE10E6F65D}"/>
@@ -8791,6 +8982,7 @@
           <a:lstStyle xmlns:a="http://schemas.openxmlformats.org/drawingml/2006/main"/>
           <a:p xmlns:a="http://schemas.openxmlformats.org/drawingml/2006/main">
             <a:pPr>
+              <a:buNone/>
               <a:defRPr sz="2025">
                 <a:solidFill>
                   <a:srgbClr val="A8C6C4"/>
@@ -8845,7 +9037,7 @@
       </p:grpSpPr>
       <p:sp>
         <p:nvSpPr>
-          <p:cNvPr id="5" name="">
+          <p:cNvPr id="5" name="矩形 4">
             <a:extLst xmlns:a="http://schemas.openxmlformats.org/drawingml/2006/main">
               <a:ext uri="{FF2B5EF4-FFF2-40B4-BE49-F238E27FC236}">
                 <a16:creationId xmlns:a16="http://schemas.microsoft.com/office/drawing/2014/main" id="{FAED6441-C350-47FB-B161-F73F2510262C}"/>
@@ -8903,7 +9095,7 @@
       </p:sp>
       <p:sp>
         <p:nvSpPr>
-          <p:cNvPr id="2" name="">
+          <p:cNvPr id="2" name="矩形 1">
             <a:extLst xmlns:a="http://schemas.openxmlformats.org/drawingml/2006/main">
               <a:ext uri="{FF2B5EF4-FFF2-40B4-BE49-F238E27FC236}">
                 <a16:creationId xmlns:a16="http://schemas.microsoft.com/office/drawing/2014/main" id="{EF5B9B74-C802-425C-8CCC-F267D57F44A4}"/>
@@ -8961,7 +9153,7 @@
       </p:sp>
       <p:graphicFrame>
         <p:nvGraphicFramePr>
-          <p:cNvPr id="9" name=""/>
+          <p:cNvPr id="9" name="表格 8"/>
           <p:cNvGraphicFramePr/>
           <p:nvPr/>
         </p:nvGraphicFramePr>
@@ -8981,9 +9173,7 @@
               <a:tr h="819150">
                 <a:tc>
                   <a:txBody>
-                    <a:bodyPr lIns="190500" tIns="114300" rIns="142875" bIns="114300">
-                      <a:noAutofit/>
-                    </a:bodyPr>
+                    <a:bodyPr/>
                     <a:lstStyle/>
                     <a:p>
                       <a:r>
@@ -9007,9 +9197,7 @@
                 </a:tc>
                 <a:tc>
                   <a:txBody>
-                    <a:bodyPr lIns="190500" tIns="114300" rIns="142875" bIns="114300">
-                      <a:noAutofit/>
-                    </a:bodyPr>
+                    <a:bodyPr/>
                     <a:lstStyle/>
                     <a:p>
                       <a:r>
@@ -9033,9 +9221,7 @@
                 </a:tc>
                 <a:tc>
                   <a:txBody>
-                    <a:bodyPr lIns="190500" tIns="114300" rIns="142875" bIns="114300">
-                      <a:noAutofit/>
-                    </a:bodyPr>
+                    <a:bodyPr/>
                     <a:lstStyle/>
                     <a:p>
                       <a:r>
@@ -9061,9 +9247,7 @@
               <a:tr h="819150">
                 <a:tc>
                   <a:txBody>
-                    <a:bodyPr lIns="190500" tIns="114300" rIns="142875" bIns="114300">
-                      <a:noAutofit/>
-                    </a:bodyPr>
+                    <a:bodyPr/>
                     <a:lstStyle/>
                     <a:p>
                       <a:r>
@@ -9087,9 +9271,7 @@
                 </a:tc>
                 <a:tc>
                   <a:txBody>
-                    <a:bodyPr lIns="190500" tIns="114300" rIns="142875" bIns="114300">
-                      <a:noAutofit/>
-                    </a:bodyPr>
+                    <a:bodyPr/>
                     <a:lstStyle/>
                     <a:p>
                       <a:r>
@@ -9113,9 +9295,7 @@
                 </a:tc>
                 <a:tc>
                   <a:txBody>
-                    <a:bodyPr lIns="190500" tIns="114300" rIns="142875" bIns="114300">
-                      <a:noAutofit/>
-                    </a:bodyPr>
+                    <a:bodyPr/>
                     <a:lstStyle/>
                     <a:p>
                       <a:r>
@@ -9141,9 +9321,7 @@
               <a:tr h="819150">
                 <a:tc>
                   <a:txBody>
-                    <a:bodyPr lIns="190500" tIns="114300" rIns="142875" bIns="114300">
-                      <a:noAutofit/>
-                    </a:bodyPr>
+                    <a:bodyPr/>
                     <a:lstStyle/>
                     <a:p>
                       <a:r>
@@ -9167,9 +9345,7 @@
                 </a:tc>
                 <a:tc>
                   <a:txBody>
-                    <a:bodyPr lIns="190500" tIns="114300" rIns="142875" bIns="114300">
-                      <a:noAutofit/>
-                    </a:bodyPr>
+                    <a:bodyPr/>
                     <a:lstStyle/>
                     <a:p>
                       <a:r>
@@ -9193,9 +9369,7 @@
                 </a:tc>
                 <a:tc>
                   <a:txBody>
-                    <a:bodyPr lIns="190500" tIns="114300" rIns="142875" bIns="114300">
-                      <a:noAutofit/>
-                    </a:bodyPr>
+                    <a:bodyPr/>
                     <a:lstStyle/>
                     <a:p>
                       <a:r>
@@ -9221,9 +9395,7 @@
               <a:tr h="819150">
                 <a:tc>
                   <a:txBody>
-                    <a:bodyPr lIns="190500" tIns="114300" rIns="142875" bIns="114300">
-                      <a:noAutofit/>
-                    </a:bodyPr>
+                    <a:bodyPr/>
                     <a:lstStyle/>
                     <a:p>
                       <a:r>
@@ -9247,9 +9419,7 @@
                 </a:tc>
                 <a:tc>
                   <a:txBody>
-                    <a:bodyPr lIns="190500" tIns="114300" rIns="142875" bIns="114300">
-                      <a:noAutofit/>
-                    </a:bodyPr>
+                    <a:bodyPr/>
                     <a:lstStyle/>
                     <a:p>
                       <a:r>
@@ -9273,9 +9443,7 @@
                 </a:tc>
                 <a:tc>
                   <a:txBody>
-                    <a:bodyPr lIns="190500" tIns="114300" rIns="142875" bIns="114300">
-                      <a:noAutofit/>
-                    </a:bodyPr>
+                    <a:bodyPr/>
                     <a:lstStyle/>
                     <a:p>
                       <a:r>
@@ -9301,9 +9469,7 @@
               <a:tr h="819150">
                 <a:tc>
                   <a:txBody>
-                    <a:bodyPr lIns="190500" tIns="114300" rIns="142875" bIns="114300">
-                      <a:noAutofit/>
-                    </a:bodyPr>
+                    <a:bodyPr/>
                     <a:lstStyle/>
                     <a:p>
                       <a:r>
@@ -9327,9 +9493,7 @@
                 </a:tc>
                 <a:tc>
                   <a:txBody>
-                    <a:bodyPr lIns="190500" tIns="114300" rIns="142875" bIns="114300">
-                      <a:noAutofit/>
-                    </a:bodyPr>
+                    <a:bodyPr/>
                     <a:lstStyle/>
                     <a:p>
                       <a:r>
@@ -9353,9 +9517,7 @@
                 </a:tc>
                 <a:tc>
                   <a:txBody>
-                    <a:bodyPr lIns="190500" tIns="114300" rIns="142875" bIns="114300">
-                      <a:noAutofit/>
-                    </a:bodyPr>
+                    <a:bodyPr/>
                     <a:lstStyle/>
                     <a:p>
                       <a:r>
@@ -9381,9 +9543,7 @@
               <a:tr h="819150">
                 <a:tc>
                   <a:txBody>
-                    <a:bodyPr lIns="190500" tIns="114300" rIns="142875" bIns="114300">
-                      <a:noAutofit/>
-                    </a:bodyPr>
+                    <a:bodyPr/>
                     <a:lstStyle/>
                     <a:p>
                       <a:r>
@@ -9407,9 +9567,7 @@
                 </a:tc>
                 <a:tc>
                   <a:txBody>
-                    <a:bodyPr lIns="190500" tIns="114300" rIns="142875" bIns="114300">
-                      <a:noAutofit/>
-                    </a:bodyPr>
+                    <a:bodyPr/>
                     <a:lstStyle/>
                     <a:p>
                       <a:r>
@@ -9421,7 +9579,7 @@
                           <a:ea typeface="Hiragino Sans GB"/>
                           <a:cs typeface="Hiragino Sans GB"/>
                         </a:rPr>
-                        <a:t>00:20:00</a:t>
+                        <a:t>02:00:00</a:t>
                       </a:r>
                     </a:p>
                   </a:txBody>
@@ -9433,9 +9591,7 @@
                 </a:tc>
                 <a:tc>
                   <a:txBody>
-                    <a:bodyPr lIns="190500" tIns="114300" rIns="142875" bIns="114300">
-                      <a:noAutofit/>
-                    </a:bodyPr>
+                    <a:bodyPr/>
                     <a:lstStyle/>
                     <a:p>
                       <a:r>
@@ -9447,7 +9603,7 @@
                           <a:ea typeface="Hiragino Sans GB"/>
                           <a:cs typeface="Hiragino Sans GB"/>
                         </a:rPr>
-                        <a:t>小规模检查最多运行 20 分钟</a:t>
+                        <a:t>最多运行 2 小时，不含排队时间</a:t>
                       </a:r>
                     </a:p>
                   </a:txBody>
@@ -9464,7 +9620,7 @@
       </p:graphicFrame>
       <p:sp>
         <p:nvSpPr>
-          <p:cNvPr id="4" name="">
+          <p:cNvPr id="4" name="矩形 3">
             <a:extLst xmlns:a="http://schemas.openxmlformats.org/drawingml/2006/main">
               <a:ext uri="{FF2B5EF4-FFF2-40B4-BE49-F238E27FC236}">
                 <a16:creationId xmlns:a16="http://schemas.microsoft.com/office/drawing/2014/main" id="{D4C8EA9F-FB44-43A8-A20C-972A36D3E161}"/>
@@ -9551,7 +9707,7 @@
       </p:grpSpPr>
       <p:sp>
         <p:nvSpPr>
-          <p:cNvPr id="16" name="">
+          <p:cNvPr id="16" name="矩形 15">
             <a:extLst xmlns:a="http://schemas.openxmlformats.org/drawingml/2006/main">
               <a:ext uri="{FF2B5EF4-FFF2-40B4-BE49-F238E27FC236}">
                 <a16:creationId xmlns:a16="http://schemas.microsoft.com/office/drawing/2014/main" id="{2825D593-FF83-4A87-9AE7-3DD0D9627B62}"/>
@@ -9609,7 +9765,7 @@
       </p:sp>
       <p:sp>
         <p:nvSpPr>
-          <p:cNvPr id="2" name="">
+          <p:cNvPr id="2" name="矩形 1">
             <a:extLst xmlns:a="http://schemas.openxmlformats.org/drawingml/2006/main">
               <a:ext uri="{FF2B5EF4-FFF2-40B4-BE49-F238E27FC236}">
                 <a16:creationId xmlns:a16="http://schemas.microsoft.com/office/drawing/2014/main" id="{23653FC4-AC56-4EDD-BAC4-B45B5083DE61}"/>
@@ -9667,7 +9823,7 @@
       </p:sp>
       <p:sp>
         <p:nvSpPr>
-          <p:cNvPr id="3" name="">
+          <p:cNvPr id="3" name="矩形 2">
             <a:extLst xmlns:a="http://schemas.openxmlformats.org/drawingml/2006/main">
               <a:ext uri="{FF2B5EF4-FFF2-40B4-BE49-F238E27FC236}">
                 <a16:creationId xmlns:a16="http://schemas.microsoft.com/office/drawing/2014/main" id="{7595D150-0668-459C-AE77-9AA1DBA18F38}"/>
@@ -9725,7 +9881,7 @@
       </p:sp>
       <p:sp>
         <p:nvSpPr>
-          <p:cNvPr id="4" name="">
+          <p:cNvPr id="4" name="矩形 3">
             <a:extLst xmlns:a="http://schemas.openxmlformats.org/drawingml/2006/main">
               <a:ext uri="{FF2B5EF4-FFF2-40B4-BE49-F238E27FC236}">
                 <a16:creationId xmlns:a16="http://schemas.microsoft.com/office/drawing/2014/main" id="{F5AEA266-7F1B-4DFB-BE5D-D5EC42B5F36F}"/>
@@ -9783,7 +9939,7 @@
       </p:sp>
       <p:sp>
         <p:nvSpPr>
-          <p:cNvPr id="5" name="">
+          <p:cNvPr id="5" name="矩形 4">
             <a:extLst xmlns:a="http://schemas.openxmlformats.org/drawingml/2006/main">
               <a:ext uri="{FF2B5EF4-FFF2-40B4-BE49-F238E27FC236}">
                 <a16:creationId xmlns:a16="http://schemas.microsoft.com/office/drawing/2014/main" id="{DF5A557F-CAA0-4F6E-A37E-F1C4E5660A42}"/>
@@ -9841,7 +9997,7 @@
       </p:sp>
       <p:sp>
         <p:nvSpPr>
-          <p:cNvPr id="6" name="">
+          <p:cNvPr id="6" name="矩形 5">
             <a:extLst xmlns:a="http://schemas.openxmlformats.org/drawingml/2006/main">
               <a:ext uri="{FF2B5EF4-FFF2-40B4-BE49-F238E27FC236}">
                 <a16:creationId xmlns:a16="http://schemas.microsoft.com/office/drawing/2014/main" id="{B098FDD5-37A7-4110-93C9-5D6C6023F9B6}"/>
@@ -9899,7 +10055,7 @@
       </p:sp>
       <p:sp>
         <p:nvSpPr>
-          <p:cNvPr id="7" name="">
+          <p:cNvPr id="7" name="矩形 6">
             <a:extLst xmlns:a="http://schemas.openxmlformats.org/drawingml/2006/main">
               <a:ext uri="{FF2B5EF4-FFF2-40B4-BE49-F238E27FC236}">
                 <a16:creationId xmlns:a16="http://schemas.microsoft.com/office/drawing/2014/main" id="{983816B4-D237-403A-9060-CC9E513F9502}"/>
@@ -9950,14 +10106,25 @@
                 <a:ea typeface="Menlo"/>
                 <a:cs typeface="Menlo"/>
               </a:rPr>
-              <a:t>#SBATCH -t 00:20:00</a:t>
-            </a:r>
-          </a:p>
-        </p:txBody>
-      </p:sp>
-      <p:sp>
-        <p:nvSpPr>
-          <p:cNvPr id="8" name="">
+              <a:t>#SBATCH -t </a:t>
+            </a:r>
+            <a:r>
+              <a:rPr sz="2175" b="0">
+                <a:solidFill>
+                  <a:srgbClr val="B7EDDB"/>
+                </a:solidFill>
+                <a:latin typeface="Menlo"/>
+                <a:ea typeface="Menlo"/>
+                <a:cs typeface="Menlo"/>
+              </a:rPr>
+              <a:t>02:00:00</a:t>
+            </a:r>
+          </a:p>
+        </p:txBody>
+      </p:sp>
+      <p:sp>
+        <p:nvSpPr>
+          <p:cNvPr id="8" name="矩形 7">
             <a:extLst xmlns:a="http://schemas.openxmlformats.org/drawingml/2006/main">
               <a:ext uri="{FF2B5EF4-FFF2-40B4-BE49-F238E27FC236}">
                 <a16:creationId xmlns:a16="http://schemas.microsoft.com/office/drawing/2014/main" id="{3C48A46E-7125-4647-92A9-656F30ED35CF}"/>
@@ -10015,7 +10182,7 @@
       </p:sp>
       <p:sp>
         <p:nvSpPr>
-          <p:cNvPr id="9" name="">
+          <p:cNvPr id="9" name="矩形 8">
             <a:extLst xmlns:a="http://schemas.openxmlformats.org/drawingml/2006/main">
               <a:ext uri="{FF2B5EF4-FFF2-40B4-BE49-F238E27FC236}">
                 <a16:creationId xmlns:a16="http://schemas.microsoft.com/office/drawing/2014/main" id="{D1BBD5BF-2939-4B86-91DB-5BE1B0DEF5C7}"/>
@@ -10046,15 +10213,13 @@
           </a:bodyPr>
           <a:lstStyle xmlns:a="http://schemas.openxmlformats.org/drawingml/2006/main"/>
           <a:p xmlns:a="http://schemas.openxmlformats.org/drawingml/2006/main">
-            <a:r>
-              <a:t/>
-            </a:r>
-          </a:p>
-        </p:txBody>
-      </p:sp>
-      <p:sp>
-        <p:nvSpPr>
-          <p:cNvPr id="10" name="">
+            <a:endParaRPr/>
+          </a:p>
+        </p:txBody>
+      </p:sp>
+      <p:sp>
+        <p:nvSpPr>
+          <p:cNvPr id="10" name="矩形 9">
             <a:extLst xmlns:a="http://schemas.openxmlformats.org/drawingml/2006/main">
               <a:ext uri="{FF2B5EF4-FFF2-40B4-BE49-F238E27FC236}">
                 <a16:creationId xmlns:a16="http://schemas.microsoft.com/office/drawing/2014/main" id="{1AAFEF14-2324-4424-969E-E7D80BDA1CCA}"/>
@@ -10112,7 +10277,7 @@
       </p:sp>
       <p:sp>
         <p:nvSpPr>
-          <p:cNvPr id="11" name="">
+          <p:cNvPr id="11" name="矩形 10">
             <a:extLst xmlns:a="http://schemas.openxmlformats.org/drawingml/2006/main">
               <a:ext uri="{FF2B5EF4-FFF2-40B4-BE49-F238E27FC236}">
                 <a16:creationId xmlns:a16="http://schemas.microsoft.com/office/drawing/2014/main" id="{FF69E6C6-F290-4907-B336-5757222C8D64}"/>
@@ -10170,7 +10335,7 @@
       </p:sp>
       <p:sp>
         <p:nvSpPr>
-          <p:cNvPr id="12" name="">
+          <p:cNvPr id="12" name="矩形 11">
             <a:extLst xmlns:a="http://schemas.openxmlformats.org/drawingml/2006/main">
               <a:ext uri="{FF2B5EF4-FFF2-40B4-BE49-F238E27FC236}">
                 <a16:creationId xmlns:a16="http://schemas.microsoft.com/office/drawing/2014/main" id="{F91B1DE3-20D9-43EE-BC91-861667484DBF}"/>
@@ -10228,7 +10393,7 @@
       </p:sp>
       <p:sp>
         <p:nvSpPr>
-          <p:cNvPr id="13" name="">
+          <p:cNvPr id="13" name="矩形 12">
             <a:extLst xmlns:a="http://schemas.openxmlformats.org/drawingml/2006/main">
               <a:ext uri="{FF2B5EF4-FFF2-40B4-BE49-F238E27FC236}">
                 <a16:creationId xmlns:a16="http://schemas.microsoft.com/office/drawing/2014/main" id="{CF3D62B4-888E-4A06-9749-BB11FC87B67C}"/>
@@ -10286,7 +10451,7 @@
       </p:sp>
       <p:sp>
         <p:nvSpPr>
-          <p:cNvPr id="14" name="">
+          <p:cNvPr id="14" name="矩形 13">
             <a:extLst xmlns:a="http://schemas.openxmlformats.org/drawingml/2006/main">
               <a:ext uri="{FF2B5EF4-FFF2-40B4-BE49-F238E27FC236}">
                 <a16:creationId xmlns:a16="http://schemas.microsoft.com/office/drawing/2014/main" id="{E219E713-9AE5-47A9-B3C0-0209ECA24B93}"/>
@@ -10344,7 +10509,7 @@
       </p:sp>
       <p:sp>
         <p:nvSpPr>
-          <p:cNvPr id="15" name="">
+          <p:cNvPr id="15" name="矩形 14">
             <a:extLst xmlns:a="http://schemas.openxmlformats.org/drawingml/2006/main">
               <a:ext uri="{FF2B5EF4-FFF2-40B4-BE49-F238E27FC236}">
                 <a16:creationId xmlns:a16="http://schemas.microsoft.com/office/drawing/2014/main" id="{8D09A94C-64E1-4003-BB13-C7880B4014A8}"/>
@@ -10431,7 +10596,7 @@
       </p:grpSpPr>
       <p:sp>
         <p:nvSpPr>
-          <p:cNvPr id="5" name="">
+          <p:cNvPr id="5" name="矩形 4">
             <a:extLst xmlns:a="http://schemas.openxmlformats.org/drawingml/2006/main">
               <a:ext uri="{FF2B5EF4-FFF2-40B4-BE49-F238E27FC236}">
                 <a16:creationId xmlns:a16="http://schemas.microsoft.com/office/drawing/2014/main" id="{FF864DFF-97F5-4DC2-9259-17655D5F950D}"/>
@@ -10489,7 +10654,7 @@
       </p:sp>
       <p:sp>
         <p:nvSpPr>
-          <p:cNvPr id="2" name="">
+          <p:cNvPr id="2" name="矩形 1">
             <a:extLst xmlns:a="http://schemas.openxmlformats.org/drawingml/2006/main">
               <a:ext uri="{FF2B5EF4-FFF2-40B4-BE49-F238E27FC236}">
                 <a16:creationId xmlns:a16="http://schemas.microsoft.com/office/drawing/2014/main" id="{88157980-2E95-4A25-BFA1-50A82769C723}"/>
@@ -10547,7 +10712,7 @@
       </p:sp>
       <p:graphicFrame>
         <p:nvGraphicFramePr>
-          <p:cNvPr id="9" name=""/>
+          <p:cNvPr id="9" name="表格 8"/>
           <p:cNvGraphicFramePr/>
           <p:nvPr/>
         </p:nvGraphicFramePr>
@@ -10567,9 +10732,7 @@
               <a:tr h="971550">
                 <a:tc>
                   <a:txBody>
-                    <a:bodyPr lIns="190500" tIns="114300" rIns="142875" bIns="114300">
-                      <a:noAutofit/>
-                    </a:bodyPr>
+                    <a:bodyPr/>
                     <a:lstStyle/>
                     <a:p>
                       <a:r>
@@ -10593,9 +10756,7 @@
                 </a:tc>
                 <a:tc>
                   <a:txBody>
-                    <a:bodyPr lIns="190500" tIns="114300" rIns="142875" bIns="114300">
-                      <a:noAutofit/>
-                    </a:bodyPr>
+                    <a:bodyPr/>
                     <a:lstStyle/>
                     <a:p>
                       <a:r>
@@ -10619,9 +10780,7 @@
                 </a:tc>
                 <a:tc>
                   <a:txBody>
-                    <a:bodyPr lIns="190500" tIns="114300" rIns="142875" bIns="114300">
-                      <a:noAutofit/>
-                    </a:bodyPr>
+                    <a:bodyPr/>
                     <a:lstStyle/>
                     <a:p>
                       <a:r>
@@ -10647,9 +10806,7 @@
               <a:tr h="971550">
                 <a:tc>
                   <a:txBody>
-                    <a:bodyPr lIns="190500" tIns="114300" rIns="142875" bIns="114300">
-                      <a:noAutofit/>
-                    </a:bodyPr>
+                    <a:bodyPr/>
                     <a:lstStyle/>
                     <a:p>
                       <a:r>
@@ -10673,9 +10830,7 @@
                 </a:tc>
                 <a:tc>
                   <a:txBody>
-                    <a:bodyPr lIns="190500" tIns="114300" rIns="142875" bIns="114300">
-                      <a:noAutofit/>
-                    </a:bodyPr>
+                    <a:bodyPr/>
                     <a:lstStyle/>
                     <a:p>
                       <a:r>
@@ -10699,9 +10854,7 @@
                 </a:tc>
                 <a:tc>
                   <a:txBody>
-                    <a:bodyPr lIns="190500" tIns="114300" rIns="142875" bIns="114300">
-                      <a:noAutofit/>
-                    </a:bodyPr>
+                    <a:bodyPr/>
                     <a:lstStyle/>
                     <a:p>
                       <a:r>
@@ -10727,9 +10880,7 @@
               <a:tr h="971550">
                 <a:tc>
                   <a:txBody>
-                    <a:bodyPr lIns="190500" tIns="114300" rIns="142875" bIns="114300">
-                      <a:noAutofit/>
-                    </a:bodyPr>
+                    <a:bodyPr/>
                     <a:lstStyle/>
                     <a:p>
                       <a:r>
@@ -10753,9 +10904,7 @@
                 </a:tc>
                 <a:tc>
                   <a:txBody>
-                    <a:bodyPr lIns="190500" tIns="114300" rIns="142875" bIns="114300">
-                      <a:noAutofit/>
-                    </a:bodyPr>
+                    <a:bodyPr/>
                     <a:lstStyle/>
                     <a:p>
                       <a:r>
@@ -10779,9 +10928,7 @@
                 </a:tc>
                 <a:tc>
                   <a:txBody>
-                    <a:bodyPr lIns="190500" tIns="114300" rIns="142875" bIns="114300">
-                      <a:noAutofit/>
-                    </a:bodyPr>
+                    <a:bodyPr/>
                     <a:lstStyle/>
                     <a:p>
                       <a:r>
@@ -10807,9 +10954,7 @@
               <a:tr h="971550">
                 <a:tc>
                   <a:txBody>
-                    <a:bodyPr lIns="190500" tIns="114300" rIns="142875" bIns="114300">
-                      <a:noAutofit/>
-                    </a:bodyPr>
+                    <a:bodyPr/>
                     <a:lstStyle/>
                     <a:p>
                       <a:r>
@@ -10833,9 +10978,7 @@
                 </a:tc>
                 <a:tc>
                   <a:txBody>
-                    <a:bodyPr lIns="190500" tIns="114300" rIns="142875" bIns="114300">
-                      <a:noAutofit/>
-                    </a:bodyPr>
+                    <a:bodyPr/>
                     <a:lstStyle/>
                     <a:p>
                       <a:r>
@@ -10859,9 +11002,7 @@
                 </a:tc>
                 <a:tc>
                   <a:txBody>
-                    <a:bodyPr lIns="190500" tIns="114300" rIns="142875" bIns="114300">
-                      <a:noAutofit/>
-                    </a:bodyPr>
+                    <a:bodyPr/>
                     <a:lstStyle/>
                     <a:p>
                       <a:r>
@@ -10887,9 +11028,7 @@
               <a:tr h="971550">
                 <a:tc>
                   <a:txBody>
-                    <a:bodyPr lIns="190500" tIns="114300" rIns="142875" bIns="114300">
-                      <a:noAutofit/>
-                    </a:bodyPr>
+                    <a:bodyPr/>
                     <a:lstStyle/>
                     <a:p>
                       <a:r>
@@ -10913,9 +11052,7 @@
                 </a:tc>
                 <a:tc>
                   <a:txBody>
-                    <a:bodyPr lIns="190500" tIns="114300" rIns="142875" bIns="114300">
-                      <a:noAutofit/>
-                    </a:bodyPr>
+                    <a:bodyPr/>
                     <a:lstStyle/>
                     <a:p>
                       <a:r>
@@ -10939,9 +11076,7 @@
                 </a:tc>
                 <a:tc>
                   <a:txBody>
-                    <a:bodyPr lIns="190500" tIns="114300" rIns="142875" bIns="114300">
-                      <a:noAutofit/>
-                    </a:bodyPr>
+                    <a:bodyPr/>
                     <a:lstStyle/>
                     <a:p>
                       <a:r>
@@ -10970,7 +11105,7 @@
       </p:graphicFrame>
       <p:sp>
         <p:nvSpPr>
-          <p:cNvPr id="4" name="">
+          <p:cNvPr id="4" name="矩形 3">
             <a:extLst xmlns:a="http://schemas.openxmlformats.org/drawingml/2006/main">
               <a:ext uri="{FF2B5EF4-FFF2-40B4-BE49-F238E27FC236}">
                 <a16:creationId xmlns:a16="http://schemas.microsoft.com/office/drawing/2014/main" id="{C846B664-C546-491C-A7DA-8C0EDE7EE19C}"/>
@@ -11057,7 +11192,7 @@
       </p:grpSpPr>
       <p:sp>
         <p:nvSpPr>
-          <p:cNvPr id="24" name="">
+          <p:cNvPr id="24" name="矩形 23">
             <a:extLst xmlns:a="http://schemas.openxmlformats.org/drawingml/2006/main">
               <a:ext uri="{FF2B5EF4-FFF2-40B4-BE49-F238E27FC236}">
                 <a16:creationId xmlns:a16="http://schemas.microsoft.com/office/drawing/2014/main" id="{86A64C19-1774-4F49-B25C-5CC322AB6BC6}"/>
@@ -11115,7 +11250,7 @@
       </p:sp>
       <p:sp>
         <p:nvSpPr>
-          <p:cNvPr id="2" name="">
+          <p:cNvPr id="2" name="矩形 1">
             <a:extLst xmlns:a="http://schemas.openxmlformats.org/drawingml/2006/main">
               <a:ext uri="{FF2B5EF4-FFF2-40B4-BE49-F238E27FC236}">
                 <a16:creationId xmlns:a16="http://schemas.microsoft.com/office/drawing/2014/main" id="{D7CF88A7-F97A-40C0-9E0D-FC882091EA80}"/>
@@ -11173,7 +11308,7 @@
       </p:sp>
       <p:sp>
         <p:nvSpPr>
-          <p:cNvPr id="3" name="">
+          <p:cNvPr id="3" name="矩形 2">
             <a:extLst xmlns:a="http://schemas.openxmlformats.org/drawingml/2006/main">
               <a:ext uri="{FF2B5EF4-FFF2-40B4-BE49-F238E27FC236}">
                 <a16:creationId xmlns:a16="http://schemas.microsoft.com/office/drawing/2014/main" id="{0D3C0FF3-0558-4BEB-ACE6-ED7FF2F1461C}"/>
@@ -11231,7 +11366,7 @@
       </p:sp>
       <p:sp>
         <p:nvSpPr>
-          <p:cNvPr id="4" name="">
+          <p:cNvPr id="4" name="矩形 3">
             <a:extLst xmlns:a="http://schemas.openxmlformats.org/drawingml/2006/main">
               <a:ext uri="{FF2B5EF4-FFF2-40B4-BE49-F238E27FC236}">
                 <a16:creationId xmlns:a16="http://schemas.microsoft.com/office/drawing/2014/main" id="{3A00B188-256B-4888-AA3F-FC71A3AE96DB}"/>
@@ -11289,7 +11424,7 @@
       </p:sp>
       <p:sp>
         <p:nvSpPr>
-          <p:cNvPr id="5" name="">
+          <p:cNvPr id="5" name="矩形 4">
             <a:extLst xmlns:a="http://schemas.openxmlformats.org/drawingml/2006/main">
               <a:ext uri="{FF2B5EF4-FFF2-40B4-BE49-F238E27FC236}">
                 <a16:creationId xmlns:a16="http://schemas.microsoft.com/office/drawing/2014/main" id="{D19A1864-9B0E-4933-88B2-3F76904E77DB}"/>
@@ -11347,7 +11482,7 @@
       </p:sp>
       <p:sp>
         <p:nvSpPr>
-          <p:cNvPr id="6" name="">
+          <p:cNvPr id="6" name="矩形 5">
             <a:extLst xmlns:a="http://schemas.openxmlformats.org/drawingml/2006/main">
               <a:ext uri="{FF2B5EF4-FFF2-40B4-BE49-F238E27FC236}">
                 <a16:creationId xmlns:a16="http://schemas.microsoft.com/office/drawing/2014/main" id="{85D376D3-336F-429A-B0A1-C72365128B01}"/>
@@ -11405,7 +11540,7 @@
       </p:sp>
       <p:sp>
         <p:nvSpPr>
-          <p:cNvPr id="7" name="">
+          <p:cNvPr id="7" name="矩形 6">
             <a:extLst xmlns:a="http://schemas.openxmlformats.org/drawingml/2006/main">
               <a:ext uri="{FF2B5EF4-FFF2-40B4-BE49-F238E27FC236}">
                 <a16:creationId xmlns:a16="http://schemas.microsoft.com/office/drawing/2014/main" id="{51B067CF-98EB-4287-B58B-7D5420292EBF}"/>
@@ -11456,14 +11591,25 @@
                 <a:ea typeface="Menlo"/>
                 <a:cs typeface="Menlo"/>
               </a:rPr>
-              <a:t>#SBATCH -t 00:20:00</a:t>
-            </a:r>
-          </a:p>
-        </p:txBody>
-      </p:sp>
-      <p:sp>
-        <p:nvSpPr>
-          <p:cNvPr id="8" name="">
+              <a:t>#SBATCH -t </a:t>
+            </a:r>
+            <a:r>
+              <a:rPr sz="1875" b="0">
+                <a:solidFill>
+                  <a:srgbClr val="B7EDDB"/>
+                </a:solidFill>
+                <a:latin typeface="Menlo"/>
+                <a:ea typeface="Menlo"/>
+                <a:cs typeface="Menlo"/>
+              </a:rPr>
+              <a:t>02:00:00</a:t>
+            </a:r>
+          </a:p>
+        </p:txBody>
+      </p:sp>
+      <p:sp>
+        <p:nvSpPr>
+          <p:cNvPr id="8" name="矩形 7">
             <a:extLst xmlns:a="http://schemas.openxmlformats.org/drawingml/2006/main">
               <a:ext uri="{FF2B5EF4-FFF2-40B4-BE49-F238E27FC236}">
                 <a16:creationId xmlns:a16="http://schemas.microsoft.com/office/drawing/2014/main" id="{9B9E48A0-16A2-4440-BDD7-284C309DCA74}"/>
@@ -11521,7 +11667,7 @@
       </p:sp>
       <p:sp>
         <p:nvSpPr>
-          <p:cNvPr id="9" name="">
+          <p:cNvPr id="9" name="矩形 8">
             <a:extLst xmlns:a="http://schemas.openxmlformats.org/drawingml/2006/main">
               <a:ext uri="{FF2B5EF4-FFF2-40B4-BE49-F238E27FC236}">
                 <a16:creationId xmlns:a16="http://schemas.microsoft.com/office/drawing/2014/main" id="{9242565C-9C12-43F5-BA3D-D685A9518A29}"/>
@@ -11552,15 +11698,13 @@
           </a:bodyPr>
           <a:lstStyle xmlns:a="http://schemas.openxmlformats.org/drawingml/2006/main"/>
           <a:p xmlns:a="http://schemas.openxmlformats.org/drawingml/2006/main">
-            <a:r>
-              <a:t/>
-            </a:r>
-          </a:p>
-        </p:txBody>
-      </p:sp>
-      <p:sp>
-        <p:nvSpPr>
-          <p:cNvPr id="10" name="">
+            <a:endParaRPr/>
+          </a:p>
+        </p:txBody>
+      </p:sp>
+      <p:sp>
+        <p:nvSpPr>
+          <p:cNvPr id="10" name="矩形 9">
             <a:extLst xmlns:a="http://schemas.openxmlformats.org/drawingml/2006/main">
               <a:ext uri="{FF2B5EF4-FFF2-40B4-BE49-F238E27FC236}">
                 <a16:creationId xmlns:a16="http://schemas.microsoft.com/office/drawing/2014/main" id="{CC175A1D-A4C5-44FC-A3DF-ABD2C329EFFA}"/>
@@ -11618,7 +11762,7 @@
       </p:sp>
       <p:sp>
         <p:nvSpPr>
-          <p:cNvPr id="11" name="">
+          <p:cNvPr id="11" name="矩形 10">
             <a:extLst xmlns:a="http://schemas.openxmlformats.org/drawingml/2006/main">
               <a:ext uri="{FF2B5EF4-FFF2-40B4-BE49-F238E27FC236}">
                 <a16:creationId xmlns:a16="http://schemas.microsoft.com/office/drawing/2014/main" id="{8EEAF85C-4C1B-4DE4-92BD-D1D23204A001}"/>
@@ -11676,7 +11820,7 @@
       </p:sp>
       <p:sp>
         <p:nvSpPr>
-          <p:cNvPr id="12" name="">
+          <p:cNvPr id="12" name="矩形 11">
             <a:extLst xmlns:a="http://schemas.openxmlformats.org/drawingml/2006/main">
               <a:ext uri="{FF2B5EF4-FFF2-40B4-BE49-F238E27FC236}">
                 <a16:creationId xmlns:a16="http://schemas.microsoft.com/office/drawing/2014/main" id="{3C35A968-CF4F-4790-B9C8-D54FE8BC8A64}"/>
@@ -11734,7 +11878,7 @@
       </p:sp>
       <p:sp>
         <p:nvSpPr>
-          <p:cNvPr id="13" name="">
+          <p:cNvPr id="13" name="矩形 12">
             <a:extLst xmlns:a="http://schemas.openxmlformats.org/drawingml/2006/main">
               <a:ext uri="{FF2B5EF4-FFF2-40B4-BE49-F238E27FC236}">
                 <a16:creationId xmlns:a16="http://schemas.microsoft.com/office/drawing/2014/main" id="{35858B7D-F7EE-49B1-BA07-C07742C5AAAA}"/>
@@ -11792,7 +11936,7 @@
       </p:sp>
       <p:sp>
         <p:nvSpPr>
-          <p:cNvPr id="14" name="">
+          <p:cNvPr id="14" name="矩形 13">
             <a:extLst xmlns:a="http://schemas.openxmlformats.org/drawingml/2006/main">
               <a:ext uri="{FF2B5EF4-FFF2-40B4-BE49-F238E27FC236}">
                 <a16:creationId xmlns:a16="http://schemas.microsoft.com/office/drawing/2014/main" id="{304483B2-D9A9-416A-BBD2-3671822F5DEF}"/>
@@ -11850,7 +11994,7 @@
       </p:sp>
       <p:sp>
         <p:nvSpPr>
-          <p:cNvPr id="15" name="">
+          <p:cNvPr id="15" name="矩形 14">
             <a:extLst xmlns:a="http://schemas.openxmlformats.org/drawingml/2006/main">
               <a:ext uri="{FF2B5EF4-FFF2-40B4-BE49-F238E27FC236}">
                 <a16:creationId xmlns:a16="http://schemas.microsoft.com/office/drawing/2014/main" id="{DF2E9BA5-C49E-4D19-881C-D096A9A3F6ED}"/>
@@ -11908,7 +12052,7 @@
       </p:sp>
       <p:sp>
         <p:nvSpPr>
-          <p:cNvPr id="16" name="">
+          <p:cNvPr id="16" name="矩形 15">
             <a:extLst xmlns:a="http://schemas.openxmlformats.org/drawingml/2006/main">
               <a:ext uri="{FF2B5EF4-FFF2-40B4-BE49-F238E27FC236}">
                 <a16:creationId xmlns:a16="http://schemas.microsoft.com/office/drawing/2014/main" id="{DEB62359-7DF1-4B72-BDC9-1477374A235F}"/>
@@ -11966,7 +12110,7 @@
       </p:sp>
       <p:sp>
         <p:nvSpPr>
-          <p:cNvPr id="17" name="">
+          <p:cNvPr id="17" name="矩形 16">
             <a:extLst xmlns:a="http://schemas.openxmlformats.org/drawingml/2006/main">
               <a:ext uri="{FF2B5EF4-FFF2-40B4-BE49-F238E27FC236}">
                 <a16:creationId xmlns:a16="http://schemas.microsoft.com/office/drawing/2014/main" id="{19772A91-9F87-41A5-814E-709C0364D543}"/>
@@ -12024,7 +12168,7 @@
       </p:sp>
       <p:sp>
         <p:nvSpPr>
-          <p:cNvPr id="18" name="">
+          <p:cNvPr id="18" name="矩形 17">
             <a:extLst xmlns:a="http://schemas.openxmlformats.org/drawingml/2006/main">
               <a:ext uri="{FF2B5EF4-FFF2-40B4-BE49-F238E27FC236}">
                 <a16:creationId xmlns:a16="http://schemas.microsoft.com/office/drawing/2014/main" id="{82D30D09-EADC-4F82-9C2F-DC571E6393A4}"/>
@@ -12082,7 +12226,7 @@
       </p:sp>
       <p:sp>
         <p:nvSpPr>
-          <p:cNvPr id="19" name="">
+          <p:cNvPr id="19" name="矩形 18">
             <a:extLst xmlns:a="http://schemas.openxmlformats.org/drawingml/2006/main">
               <a:ext uri="{FF2B5EF4-FFF2-40B4-BE49-F238E27FC236}">
                 <a16:creationId xmlns:a16="http://schemas.microsoft.com/office/drawing/2014/main" id="{3CEFDEFA-74FD-4B2D-A80C-D976BED8B0C1}"/>
@@ -12140,7 +12284,7 @@
       </p:sp>
       <p:sp>
         <p:nvSpPr>
-          <p:cNvPr id="20" name="">
+          <p:cNvPr id="20" name="矩形 19">
             <a:extLst xmlns:a="http://schemas.openxmlformats.org/drawingml/2006/main">
               <a:ext uri="{FF2B5EF4-FFF2-40B4-BE49-F238E27FC236}">
                 <a16:creationId xmlns:a16="http://schemas.microsoft.com/office/drawing/2014/main" id="{67B726F1-DC39-4394-B788-A38D4B6AA784}"/>
@@ -12198,7 +12342,7 @@
       </p:sp>
       <p:sp>
         <p:nvSpPr>
-          <p:cNvPr id="21" name="">
+          <p:cNvPr id="21" name="矩形 20">
             <a:extLst xmlns:a="http://schemas.openxmlformats.org/drawingml/2006/main">
               <a:ext uri="{FF2B5EF4-FFF2-40B4-BE49-F238E27FC236}">
                 <a16:creationId xmlns:a16="http://schemas.microsoft.com/office/drawing/2014/main" id="{C17C360F-FDC1-4892-A83F-C628121ADFBE}"/>
@@ -12256,7 +12400,7 @@
       </p:sp>
       <p:sp>
         <p:nvSpPr>
-          <p:cNvPr id="22" name="">
+          <p:cNvPr id="22" name="矩形 21">
             <a:extLst xmlns:a="http://schemas.openxmlformats.org/drawingml/2006/main">
               <a:ext uri="{FF2B5EF4-FFF2-40B4-BE49-F238E27FC236}">
                 <a16:creationId xmlns:a16="http://schemas.microsoft.com/office/drawing/2014/main" id="{465FF2F7-9ED1-4B7C-A654-4EEA7CAB4575}"/>
@@ -12314,7 +12458,7 @@
       </p:sp>
       <p:sp>
         <p:nvSpPr>
-          <p:cNvPr id="23" name="">
+          <p:cNvPr id="23" name="矩形 22">
             <a:extLst xmlns:a="http://schemas.openxmlformats.org/drawingml/2006/main">
               <a:ext uri="{FF2B5EF4-FFF2-40B4-BE49-F238E27FC236}">
                 <a16:creationId xmlns:a16="http://schemas.microsoft.com/office/drawing/2014/main" id="{FE776CDA-94D2-4EC6-870F-E0C799743627}"/>
@@ -12404,6 +12548,7 @@
           <a:lstStyle xmlns:a="http://schemas.openxmlformats.org/drawingml/2006/main"/>
           <a:p xmlns:a="http://schemas.openxmlformats.org/drawingml/2006/main">
             <a:pPr>
+              <a:buNone/>
               <a:defRPr sz="2100">
                 <a:solidFill>
                   <a:srgbClr val="B7EDDB"/>
@@ -12458,7 +12603,7 @@
       </p:grpSpPr>
       <p:sp>
         <p:nvSpPr>
-          <p:cNvPr id="11" name="">
+          <p:cNvPr id="11" name="矩形 10">
             <a:extLst xmlns:a="http://schemas.openxmlformats.org/drawingml/2006/main">
               <a:ext uri="{FF2B5EF4-FFF2-40B4-BE49-F238E27FC236}">
                 <a16:creationId xmlns:a16="http://schemas.microsoft.com/office/drawing/2014/main" id="{B8857A87-6BCA-4769-9841-3CE59A0E1AF5}"/>
@@ -12516,7 +12661,7 @@
       </p:sp>
       <p:sp>
         <p:nvSpPr>
-          <p:cNvPr id="2" name="">
+          <p:cNvPr id="2" name="矩形 1">
             <a:extLst xmlns:a="http://schemas.openxmlformats.org/drawingml/2006/main">
               <a:ext uri="{FF2B5EF4-FFF2-40B4-BE49-F238E27FC236}">
                 <a16:creationId xmlns:a16="http://schemas.microsoft.com/office/drawing/2014/main" id="{E69CA58D-2761-4BD3-A521-597D915A29E8}"/>
@@ -12574,7 +12719,7 @@
       </p:sp>
       <p:sp>
         <p:nvSpPr>
-          <p:cNvPr id="3" name="">
+          <p:cNvPr id="3" name="矩形 2">
             <a:extLst xmlns:a="http://schemas.openxmlformats.org/drawingml/2006/main">
               <a:ext uri="{FF2B5EF4-FFF2-40B4-BE49-F238E27FC236}">
                 <a16:creationId xmlns:a16="http://schemas.microsoft.com/office/drawing/2014/main" id="{FE053918-C4D3-49B8-B2E8-B5DCB7FFDCD8}"/>
@@ -12632,7 +12777,7 @@
       </p:sp>
       <p:sp>
         <p:nvSpPr>
-          <p:cNvPr id="4" name="">
+          <p:cNvPr id="4" name="矩形 3">
             <a:extLst xmlns:a="http://schemas.openxmlformats.org/drawingml/2006/main">
               <a:ext uri="{FF2B5EF4-FFF2-40B4-BE49-F238E27FC236}">
                 <a16:creationId xmlns:a16="http://schemas.microsoft.com/office/drawing/2014/main" id="{D7011224-D9B4-471D-A5E4-7DF58C99EFCD}"/>
@@ -12690,7 +12835,7 @@
       </p:sp>
       <p:sp>
         <p:nvSpPr>
-          <p:cNvPr id="5" name="">
+          <p:cNvPr id="5" name="矩形 4">
             <a:extLst xmlns:a="http://schemas.openxmlformats.org/drawingml/2006/main">
               <a:ext uri="{FF2B5EF4-FFF2-40B4-BE49-F238E27FC236}">
                 <a16:creationId xmlns:a16="http://schemas.microsoft.com/office/drawing/2014/main" id="{12F906E6-C954-435C-8566-212CEC6BAD55}"/>
@@ -12748,7 +12893,7 @@
       </p:sp>
       <p:sp>
         <p:nvSpPr>
-          <p:cNvPr id="6" name="">
+          <p:cNvPr id="6" name="矩形 5">
             <a:extLst xmlns:a="http://schemas.openxmlformats.org/drawingml/2006/main">
               <a:ext uri="{FF2B5EF4-FFF2-40B4-BE49-F238E27FC236}">
                 <a16:creationId xmlns:a16="http://schemas.microsoft.com/office/drawing/2014/main" id="{2FFB82A7-400F-4834-AF07-0AF09AE64483}"/>
@@ -12806,7 +12951,7 @@
       </p:sp>
       <p:sp>
         <p:nvSpPr>
-          <p:cNvPr id="7" name="">
+          <p:cNvPr id="7" name="矩形 6">
             <a:extLst xmlns:a="http://schemas.openxmlformats.org/drawingml/2006/main">
               <a:ext uri="{FF2B5EF4-FFF2-40B4-BE49-F238E27FC236}">
                 <a16:creationId xmlns:a16="http://schemas.microsoft.com/office/drawing/2014/main" id="{5B5AD37A-2FF2-48C2-A41C-D802573435BB}"/>
@@ -12864,7 +13009,7 @@
       </p:sp>
       <p:sp>
         <p:nvSpPr>
-          <p:cNvPr id="8" name="">
+          <p:cNvPr id="8" name="矩形 7">
             <a:extLst xmlns:a="http://schemas.openxmlformats.org/drawingml/2006/main">
               <a:ext uri="{FF2B5EF4-FFF2-40B4-BE49-F238E27FC236}">
                 <a16:creationId xmlns:a16="http://schemas.microsoft.com/office/drawing/2014/main" id="{C609C3C0-3A64-4412-9206-0E15895BB14B}"/>
@@ -12922,7 +13067,7 @@
       </p:sp>
       <p:sp>
         <p:nvSpPr>
-          <p:cNvPr id="9" name="">
+          <p:cNvPr id="9" name="矩形 8">
             <a:extLst xmlns:a="http://schemas.openxmlformats.org/drawingml/2006/main">
               <a:ext uri="{FF2B5EF4-FFF2-40B4-BE49-F238E27FC236}">
                 <a16:creationId xmlns:a16="http://schemas.microsoft.com/office/drawing/2014/main" id="{18706BA5-E0D2-4479-9693-4C6C09F4B666}"/>
@@ -12980,7 +13125,7 @@
       </p:sp>
       <p:sp>
         <p:nvSpPr>
-          <p:cNvPr id="10" name="">
+          <p:cNvPr id="10" name="矩形 9">
             <a:extLst xmlns:a="http://schemas.openxmlformats.org/drawingml/2006/main">
               <a:ext uri="{FF2B5EF4-FFF2-40B4-BE49-F238E27FC236}">
                 <a16:creationId xmlns:a16="http://schemas.microsoft.com/office/drawing/2014/main" id="{4A90E704-0090-4552-8B1D-56CCAB2DA038}"/>
@@ -13067,7 +13212,7 @@
       </p:grpSpPr>
       <p:sp>
         <p:nvSpPr>
-          <p:cNvPr id="12" name="">
+          <p:cNvPr id="12" name="矩形 11">
             <a:extLst xmlns:a="http://schemas.openxmlformats.org/drawingml/2006/main">
               <a:ext uri="{FF2B5EF4-FFF2-40B4-BE49-F238E27FC236}">
                 <a16:creationId xmlns:a16="http://schemas.microsoft.com/office/drawing/2014/main" id="{612394CC-8575-4464-AFFB-B6076536CCE1}"/>
@@ -13125,7 +13270,7 @@
       </p:sp>
       <p:sp>
         <p:nvSpPr>
-          <p:cNvPr id="2" name="">
+          <p:cNvPr id="2" name="矩形 1">
             <a:extLst xmlns:a="http://schemas.openxmlformats.org/drawingml/2006/main">
               <a:ext uri="{FF2B5EF4-FFF2-40B4-BE49-F238E27FC236}">
                 <a16:creationId xmlns:a16="http://schemas.microsoft.com/office/drawing/2014/main" id="{6158A11F-D6F6-48EE-ADBB-EDFD897BBB1D}"/>
@@ -13183,7 +13328,7 @@
       </p:sp>
       <p:sp>
         <p:nvSpPr>
-          <p:cNvPr id="3" name="">
+          <p:cNvPr id="3" name="矩形 2">
             <a:extLst xmlns:a="http://schemas.openxmlformats.org/drawingml/2006/main">
               <a:ext uri="{FF2B5EF4-FFF2-40B4-BE49-F238E27FC236}">
                 <a16:creationId xmlns:a16="http://schemas.microsoft.com/office/drawing/2014/main" id="{08B9CC70-AE56-4592-A003-4568EB08C383}"/>
@@ -13241,7 +13386,7 @@
       </p:sp>
       <p:sp>
         <p:nvSpPr>
-          <p:cNvPr id="4" name="">
+          <p:cNvPr id="4" name="矩形 3">
             <a:extLst xmlns:a="http://schemas.openxmlformats.org/drawingml/2006/main">
               <a:ext uri="{FF2B5EF4-FFF2-40B4-BE49-F238E27FC236}">
                 <a16:creationId xmlns:a16="http://schemas.microsoft.com/office/drawing/2014/main" id="{B14F1CBD-B84F-49C4-8470-7E62BD262BE2}"/>
@@ -13299,7 +13444,7 @@
       </p:sp>
       <p:sp>
         <p:nvSpPr>
-          <p:cNvPr id="5" name="">
+          <p:cNvPr id="5" name="矩形 4">
             <a:extLst xmlns:a="http://schemas.openxmlformats.org/drawingml/2006/main">
               <a:ext uri="{FF2B5EF4-FFF2-40B4-BE49-F238E27FC236}">
                 <a16:creationId xmlns:a16="http://schemas.microsoft.com/office/drawing/2014/main" id="{7860441D-2A63-4E32-AE12-9D90B1AF56A0}"/>
@@ -13357,7 +13502,7 @@
       </p:sp>
       <p:sp>
         <p:nvSpPr>
-          <p:cNvPr id="6" name="">
+          <p:cNvPr id="6" name="矩形 5">
             <a:extLst xmlns:a="http://schemas.openxmlformats.org/drawingml/2006/main">
               <a:ext uri="{FF2B5EF4-FFF2-40B4-BE49-F238E27FC236}">
                 <a16:creationId xmlns:a16="http://schemas.microsoft.com/office/drawing/2014/main" id="{3525BE3C-2016-4364-B632-4CB47B8293A6}"/>
@@ -13415,7 +13560,7 @@
       </p:sp>
       <p:sp>
         <p:nvSpPr>
-          <p:cNvPr id="7" name="">
+          <p:cNvPr id="7" name="矩形 6">
             <a:extLst xmlns:a="http://schemas.openxmlformats.org/drawingml/2006/main">
               <a:ext uri="{FF2B5EF4-FFF2-40B4-BE49-F238E27FC236}">
                 <a16:creationId xmlns:a16="http://schemas.microsoft.com/office/drawing/2014/main" id="{6F4A74E6-1059-4592-A886-07DE4756C316}"/>
@@ -13473,7 +13618,7 @@
       </p:sp>
       <p:sp>
         <p:nvSpPr>
-          <p:cNvPr id="8" name="">
+          <p:cNvPr id="8" name="矩形 7">
             <a:extLst xmlns:a="http://schemas.openxmlformats.org/drawingml/2006/main">
               <a:ext uri="{FF2B5EF4-FFF2-40B4-BE49-F238E27FC236}">
                 <a16:creationId xmlns:a16="http://schemas.microsoft.com/office/drawing/2014/main" id="{689C195E-CADB-4978-ADF6-AB906E525FB5}"/>
@@ -13504,15 +13649,13 @@
           </a:bodyPr>
           <a:lstStyle xmlns:a="http://schemas.openxmlformats.org/drawingml/2006/main"/>
           <a:p xmlns:a="http://schemas.openxmlformats.org/drawingml/2006/main">
-            <a:r>
-              <a:t/>
-            </a:r>
-          </a:p>
-        </p:txBody>
-      </p:sp>
-      <p:sp>
-        <p:nvSpPr>
-          <p:cNvPr id="9" name="">
+            <a:endParaRPr/>
+          </a:p>
+        </p:txBody>
+      </p:sp>
+      <p:sp>
+        <p:nvSpPr>
+          <p:cNvPr id="9" name="矩形 8">
             <a:extLst xmlns:a="http://schemas.openxmlformats.org/drawingml/2006/main">
               <a:ext uri="{FF2B5EF4-FFF2-40B4-BE49-F238E27FC236}">
                 <a16:creationId xmlns:a16="http://schemas.microsoft.com/office/drawing/2014/main" id="{B0E0F2F9-C2D3-4E6E-BD74-17FCB90AA6A0}"/>
@@ -13570,7 +13713,7 @@
       </p:sp>
       <p:sp>
         <p:nvSpPr>
-          <p:cNvPr id="10" name="">
+          <p:cNvPr id="10" name="矩形 9">
             <a:extLst xmlns:a="http://schemas.openxmlformats.org/drawingml/2006/main">
               <a:ext uri="{FF2B5EF4-FFF2-40B4-BE49-F238E27FC236}">
                 <a16:creationId xmlns:a16="http://schemas.microsoft.com/office/drawing/2014/main" id="{BB6AF41C-1C31-41F9-8CAF-A7DD965E05E5}"/>
@@ -13628,7 +13771,7 @@
       </p:sp>
       <p:sp>
         <p:nvSpPr>
-          <p:cNvPr id="11" name="">
+          <p:cNvPr id="11" name="矩形 10">
             <a:extLst xmlns:a="http://schemas.openxmlformats.org/drawingml/2006/main">
               <a:ext uri="{FF2B5EF4-FFF2-40B4-BE49-F238E27FC236}">
                 <a16:creationId xmlns:a16="http://schemas.microsoft.com/office/drawing/2014/main" id="{CF9932E0-745F-4F79-9C99-BBD793044858}"/>
@@ -13718,6 +13861,7 @@
           <a:lstStyle xmlns:a="http://schemas.openxmlformats.org/drawingml/2006/main"/>
           <a:p xmlns:a="http://schemas.openxmlformats.org/drawingml/2006/main">
             <a:pPr>
+              <a:buNone/>
               <a:defRPr sz="2025">
                 <a:solidFill>
                   <a:srgbClr val="A8C6C4"/>
@@ -13775,6 +13919,7 @@
           <a:lstStyle xmlns:a="http://schemas.openxmlformats.org/drawingml/2006/main"/>
           <a:p xmlns:a="http://schemas.openxmlformats.org/drawingml/2006/main">
             <a:pPr>
+              <a:buNone/>
               <a:defRPr sz="2025">
                 <a:solidFill>
                   <a:srgbClr val="A8C6C4"/>
@@ -13829,7 +13974,7 @@
       </p:grpSpPr>
       <p:sp>
         <p:nvSpPr>
-          <p:cNvPr id="11" name="">
+          <p:cNvPr id="11" name="矩形 10">
             <a:extLst xmlns:a="http://schemas.openxmlformats.org/drawingml/2006/main">
               <a:ext uri="{FF2B5EF4-FFF2-40B4-BE49-F238E27FC236}">
                 <a16:creationId xmlns:a16="http://schemas.microsoft.com/office/drawing/2014/main" id="{C7871AF5-F767-424E-8B08-4F54E40B9BD5}"/>
@@ -13887,7 +14032,7 @@
       </p:sp>
       <p:sp>
         <p:nvSpPr>
-          <p:cNvPr id="2" name="">
+          <p:cNvPr id="2" name="矩形 1">
             <a:extLst xmlns:a="http://schemas.openxmlformats.org/drawingml/2006/main">
               <a:ext uri="{FF2B5EF4-FFF2-40B4-BE49-F238E27FC236}">
                 <a16:creationId xmlns:a16="http://schemas.microsoft.com/office/drawing/2014/main" id="{E6CA767A-97FF-49CD-B2D8-DA59CD7AC7A3}"/>
@@ -13945,7 +14090,7 @@
       </p:sp>
       <p:sp>
         <p:nvSpPr>
-          <p:cNvPr id="3" name="">
+          <p:cNvPr id="3" name="矩形 2">
             <a:extLst xmlns:a="http://schemas.openxmlformats.org/drawingml/2006/main">
               <a:ext uri="{FF2B5EF4-FFF2-40B4-BE49-F238E27FC236}">
                 <a16:creationId xmlns:a16="http://schemas.microsoft.com/office/drawing/2014/main" id="{78A8C3A1-15A0-463E-A9F1-91F488315F82}"/>
@@ -14003,7 +14148,7 @@
       </p:sp>
       <p:sp>
         <p:nvSpPr>
-          <p:cNvPr id="4" name="">
+          <p:cNvPr id="4" name="矩形 3">
             <a:extLst xmlns:a="http://schemas.openxmlformats.org/drawingml/2006/main">
               <a:ext uri="{FF2B5EF4-FFF2-40B4-BE49-F238E27FC236}">
                 <a16:creationId xmlns:a16="http://schemas.microsoft.com/office/drawing/2014/main" id="{A44B2688-9120-4F84-BDED-4DEBCDF1FFD5}"/>
@@ -14061,7 +14206,7 @@
       </p:sp>
       <p:sp>
         <p:nvSpPr>
-          <p:cNvPr id="5" name="">
+          <p:cNvPr id="5" name="矩形 4">
             <a:extLst xmlns:a="http://schemas.openxmlformats.org/drawingml/2006/main">
               <a:ext uri="{FF2B5EF4-FFF2-40B4-BE49-F238E27FC236}">
                 <a16:creationId xmlns:a16="http://schemas.microsoft.com/office/drawing/2014/main" id="{E5BC9EFE-46D4-40F9-8F83-AE28ACEFC87D}"/>
@@ -14119,7 +14264,7 @@
       </p:sp>
       <p:sp>
         <p:nvSpPr>
-          <p:cNvPr id="8" name="">
+          <p:cNvPr id="8" name="矩形 7">
             <a:extLst xmlns:a="http://schemas.openxmlformats.org/drawingml/2006/main">
               <a:ext uri="{FF2B5EF4-FFF2-40B4-BE49-F238E27FC236}">
                 <a16:creationId xmlns:a16="http://schemas.microsoft.com/office/drawing/2014/main" id="{46271CCE-BC83-4B44-BF3C-89AEEB7DF4CD}"/>
@@ -14177,7 +14322,7 @@
       </p:sp>
       <p:sp>
         <p:nvSpPr>
-          <p:cNvPr id="9" name="">
+          <p:cNvPr id="9" name="矩形 8">
             <a:extLst xmlns:a="http://schemas.openxmlformats.org/drawingml/2006/main">
               <a:ext uri="{FF2B5EF4-FFF2-40B4-BE49-F238E27FC236}">
                 <a16:creationId xmlns:a16="http://schemas.microsoft.com/office/drawing/2014/main" id="{354FE189-E016-49D2-AB17-3606BDA318FD}"/>
@@ -14235,7 +14380,7 @@
       </p:sp>
       <p:sp>
         <p:nvSpPr>
-          <p:cNvPr id="10" name="">
+          <p:cNvPr id="10" name="矩形 9">
             <a:extLst xmlns:a="http://schemas.openxmlformats.org/drawingml/2006/main">
               <a:ext uri="{FF2B5EF4-FFF2-40B4-BE49-F238E27FC236}">
                 <a16:creationId xmlns:a16="http://schemas.microsoft.com/office/drawing/2014/main" id="{9F6225F3-F43E-4509-88A0-2F468547D14A}"/>
@@ -14325,6 +14470,7 @@
           <a:lstStyle xmlns:a="http://schemas.openxmlformats.org/drawingml/2006/main"/>
           <a:p xmlns:a="http://schemas.openxmlformats.org/drawingml/2006/main">
             <a:pPr>
+              <a:buNone/>
               <a:defRPr sz="2175">
                 <a:solidFill>
                   <a:srgbClr val="EAF1EF"/>
@@ -14382,6 +14528,7 @@
           <a:lstStyle xmlns:a="http://schemas.openxmlformats.org/drawingml/2006/main"/>
           <a:p xmlns:a="http://schemas.openxmlformats.org/drawingml/2006/main">
             <a:pPr>
+              <a:buNone/>
               <a:defRPr sz="2175">
                 <a:solidFill>
                   <a:srgbClr val="EAF1EF"/>
@@ -14436,7 +14583,7 @@
       </p:grpSpPr>
       <p:sp>
         <p:nvSpPr>
-          <p:cNvPr id="9" name="">
+          <p:cNvPr id="9" name="矩形 8">
             <a:extLst xmlns:a="http://schemas.openxmlformats.org/drawingml/2006/main">
               <a:ext uri="{FF2B5EF4-FFF2-40B4-BE49-F238E27FC236}">
                 <a16:creationId xmlns:a16="http://schemas.microsoft.com/office/drawing/2014/main" id="{974B2865-DC00-4E59-9F3A-640A7913DC3C}"/>
@@ -14494,7 +14641,7 @@
       </p:sp>
       <p:sp>
         <p:nvSpPr>
-          <p:cNvPr id="2" name="">
+          <p:cNvPr id="2" name="矩形 1">
             <a:extLst xmlns:a="http://schemas.openxmlformats.org/drawingml/2006/main">
               <a:ext uri="{FF2B5EF4-FFF2-40B4-BE49-F238E27FC236}">
                 <a16:creationId xmlns:a16="http://schemas.microsoft.com/office/drawing/2014/main" id="{AFA67C7E-1DCE-457B-9A22-9FD38D176CF9}"/>
@@ -15045,7 +15192,7 @@
       </p:grpSpPr>
       <p:sp>
         <p:nvSpPr>
-          <p:cNvPr id="9" name="">
+          <p:cNvPr id="9" name="矩形 8">
             <a:extLst xmlns:a="http://schemas.openxmlformats.org/drawingml/2006/main">
               <a:ext uri="{FF2B5EF4-FFF2-40B4-BE49-F238E27FC236}">
                 <a16:creationId xmlns:a16="http://schemas.microsoft.com/office/drawing/2014/main" id="{974B2865-DC00-4E59-9F3A-640A7913DC3C}"/>
@@ -15103,7 +15250,7 @@
       </p:sp>
       <p:sp>
         <p:nvSpPr>
-          <p:cNvPr id="2" name="">
+          <p:cNvPr id="2" name="矩形 1">
             <a:extLst xmlns:a="http://schemas.openxmlformats.org/drawingml/2006/main">
               <a:ext uri="{FF2B5EF4-FFF2-40B4-BE49-F238E27FC236}">
                 <a16:creationId xmlns:a16="http://schemas.microsoft.com/office/drawing/2014/main" id="{AFA67C7E-1DCE-457B-9A22-9FD38D176CF9}"/>
@@ -15538,7 +15685,7 @@
       </p:grpSpPr>
       <p:sp>
         <p:nvSpPr>
-          <p:cNvPr id="9" name="">
+          <p:cNvPr id="9" name="矩形 8">
             <a:extLst xmlns:a="http://schemas.openxmlformats.org/drawingml/2006/main">
               <a:ext uri="{FF2B5EF4-FFF2-40B4-BE49-F238E27FC236}">
                 <a16:creationId xmlns:a16="http://schemas.microsoft.com/office/drawing/2014/main" id="{974B2865-DC00-4E59-9F3A-640A7913DC3C}"/>
@@ -15596,7 +15743,7 @@
       </p:sp>
       <p:sp>
         <p:nvSpPr>
-          <p:cNvPr id="2" name="">
+          <p:cNvPr id="2" name="矩形 1">
             <a:extLst xmlns:a="http://schemas.openxmlformats.org/drawingml/2006/main">
               <a:ext uri="{FF2B5EF4-FFF2-40B4-BE49-F238E27FC236}">
                 <a16:creationId xmlns:a16="http://schemas.microsoft.com/office/drawing/2014/main" id="{AFA67C7E-1DCE-457B-9A22-9FD38D176CF9}"/>
@@ -16031,7 +16178,7 @@
       </p:grpSpPr>
       <p:sp>
         <p:nvSpPr>
-          <p:cNvPr id="9" name="">
+          <p:cNvPr id="9" name="矩形 8">
             <a:extLst xmlns:a="http://schemas.openxmlformats.org/drawingml/2006/main">
               <a:ext uri="{FF2B5EF4-FFF2-40B4-BE49-F238E27FC236}">
                 <a16:creationId xmlns:a16="http://schemas.microsoft.com/office/drawing/2014/main" id="{974B2865-DC00-4E59-9F3A-640A7913DC3C}"/>
@@ -16089,7 +16236,7 @@
       </p:sp>
       <p:sp>
         <p:nvSpPr>
-          <p:cNvPr id="2" name="">
+          <p:cNvPr id="2" name="矩形 1">
             <a:extLst xmlns:a="http://schemas.openxmlformats.org/drawingml/2006/main">
               <a:ext uri="{FF2B5EF4-FFF2-40B4-BE49-F238E27FC236}">
                 <a16:creationId xmlns:a16="http://schemas.microsoft.com/office/drawing/2014/main" id="{AFA67C7E-1DCE-457B-9A22-9FD38D176CF9}"/>
@@ -16524,7 +16671,7 @@
       </p:grpSpPr>
       <p:sp>
         <p:nvSpPr>
-          <p:cNvPr id="5" name="">
+          <p:cNvPr id="5" name="矩形 4">
             <a:extLst xmlns:a="http://schemas.openxmlformats.org/drawingml/2006/main">
               <a:ext uri="{FF2B5EF4-FFF2-40B4-BE49-F238E27FC236}">
                 <a16:creationId xmlns:a16="http://schemas.microsoft.com/office/drawing/2014/main" id="{0A3171DB-808B-4A18-9ACA-95A6DBF51D17}"/>
@@ -16582,7 +16729,7 @@
       </p:sp>
       <p:sp>
         <p:nvSpPr>
-          <p:cNvPr id="2" name="">
+          <p:cNvPr id="2" name="矩形 1">
             <a:extLst xmlns:a="http://schemas.openxmlformats.org/drawingml/2006/main">
               <a:ext uri="{FF2B5EF4-FFF2-40B4-BE49-F238E27FC236}">
                 <a16:creationId xmlns:a16="http://schemas.microsoft.com/office/drawing/2014/main" id="{E040DB76-BAC7-4FD5-99D5-BF57651601C9}"/>
@@ -16640,7 +16787,7 @@
       </p:sp>
       <p:graphicFrame>
         <p:nvGraphicFramePr>
-          <p:cNvPr id="9" name=""/>
+          <p:cNvPr id="9" name="表格 8"/>
           <p:cNvGraphicFramePr/>
           <p:nvPr/>
         </p:nvGraphicFramePr>
@@ -16660,9 +16807,7 @@
               <a:tr h="828675">
                 <a:tc>
                   <a:txBody>
-                    <a:bodyPr lIns="190500" tIns="114300" rIns="142875" bIns="114300">
-                      <a:noAutofit/>
-                    </a:bodyPr>
+                    <a:bodyPr/>
                     <a:lstStyle/>
                     <a:p>
                       <a:r>
@@ -16686,9 +16831,7 @@
                 </a:tc>
                 <a:tc>
                   <a:txBody>
-                    <a:bodyPr lIns="190500" tIns="114300" rIns="142875" bIns="114300">
-                      <a:noAutofit/>
-                    </a:bodyPr>
+                    <a:bodyPr/>
                     <a:lstStyle/>
                     <a:p>
                       <a:r>
@@ -16712,9 +16855,7 @@
                 </a:tc>
                 <a:tc>
                   <a:txBody>
-                    <a:bodyPr lIns="190500" tIns="114300" rIns="142875" bIns="114300">
-                      <a:noAutofit/>
-                    </a:bodyPr>
+                    <a:bodyPr/>
                     <a:lstStyle/>
                     <a:p>
                       <a:r>
@@ -16740,9 +16881,7 @@
               <a:tr h="828675">
                 <a:tc>
                   <a:txBody>
-                    <a:bodyPr lIns="190500" tIns="114300" rIns="142875" bIns="114300">
-                      <a:noAutofit/>
-                    </a:bodyPr>
+                    <a:bodyPr/>
                     <a:lstStyle/>
                     <a:p>
                       <a:r>
@@ -16766,9 +16905,7 @@
                 </a:tc>
                 <a:tc>
                   <a:txBody>
-                    <a:bodyPr lIns="190500" tIns="114300" rIns="142875" bIns="114300">
-                      <a:noAutofit/>
-                    </a:bodyPr>
+                    <a:bodyPr/>
                     <a:lstStyle/>
                     <a:p>
                       <a:r>
@@ -16792,9 +16929,7 @@
                 </a:tc>
                 <a:tc>
                   <a:txBody>
-                    <a:bodyPr lIns="190500" tIns="114300" rIns="142875" bIns="114300">
-                      <a:noAutofit/>
-                    </a:bodyPr>
+                    <a:bodyPr/>
                     <a:lstStyle/>
                     <a:p>
                       <a:r>
@@ -16820,9 +16955,7 @@
               <a:tr h="828675">
                 <a:tc>
                   <a:txBody>
-                    <a:bodyPr lIns="190500" tIns="114300" rIns="142875" bIns="114300">
-                      <a:noAutofit/>
-                    </a:bodyPr>
+                    <a:bodyPr/>
                     <a:lstStyle/>
                     <a:p>
                       <a:r>
@@ -16846,9 +16979,7 @@
                 </a:tc>
                 <a:tc>
                   <a:txBody>
-                    <a:bodyPr lIns="190500" tIns="114300" rIns="142875" bIns="114300">
-                      <a:noAutofit/>
-                    </a:bodyPr>
+                    <a:bodyPr/>
                     <a:lstStyle/>
                     <a:p>
                       <a:r>
@@ -16872,9 +17003,7 @@
                 </a:tc>
                 <a:tc>
                   <a:txBody>
-                    <a:bodyPr lIns="190500" tIns="114300" rIns="142875" bIns="114300">
-                      <a:noAutofit/>
-                    </a:bodyPr>
+                    <a:bodyPr/>
                     <a:lstStyle/>
                     <a:p>
                       <a:r>
@@ -16900,9 +17029,7 @@
               <a:tr h="828675">
                 <a:tc>
                   <a:txBody>
-                    <a:bodyPr lIns="190500" tIns="114300" rIns="142875" bIns="114300">
-                      <a:noAutofit/>
-                    </a:bodyPr>
+                    <a:bodyPr/>
                     <a:lstStyle/>
                     <a:p>
                       <a:r>
@@ -16926,9 +17053,7 @@
                 </a:tc>
                 <a:tc>
                   <a:txBody>
-                    <a:bodyPr lIns="190500" tIns="114300" rIns="142875" bIns="114300">
-                      <a:noAutofit/>
-                    </a:bodyPr>
+                    <a:bodyPr/>
                     <a:lstStyle/>
                     <a:p>
                       <a:r>
@@ -16952,9 +17077,7 @@
                 </a:tc>
                 <a:tc>
                   <a:txBody>
-                    <a:bodyPr lIns="190500" tIns="114300" rIns="142875" bIns="114300">
-                      <a:noAutofit/>
-                    </a:bodyPr>
+                    <a:bodyPr/>
                     <a:lstStyle/>
                     <a:p>
                       <a:r>
@@ -16980,9 +17103,7 @@
               <a:tr h="828675">
                 <a:tc>
                   <a:txBody>
-                    <a:bodyPr lIns="190500" tIns="114300" rIns="142875" bIns="114300">
-                      <a:noAutofit/>
-                    </a:bodyPr>
+                    <a:bodyPr/>
                     <a:lstStyle/>
                     <a:p>
                       <a:r>
@@ -17006,9 +17127,7 @@
                 </a:tc>
                 <a:tc>
                   <a:txBody>
-                    <a:bodyPr lIns="190500" tIns="114300" rIns="142875" bIns="114300">
-                      <a:noAutofit/>
-                    </a:bodyPr>
+                    <a:bodyPr/>
                     <a:lstStyle/>
                     <a:p>
                       <a:r>
@@ -17032,9 +17151,7 @@
                 </a:tc>
                 <a:tc>
                   <a:txBody>
-                    <a:bodyPr lIns="190500" tIns="114300" rIns="142875" bIns="114300">
-                      <a:noAutofit/>
-                    </a:bodyPr>
+                    <a:bodyPr/>
                     <a:lstStyle/>
                     <a:p>
                       <a:r>
@@ -17060,9 +17177,7 @@
               <a:tr h="828675">
                 <a:tc>
                   <a:txBody>
-                    <a:bodyPr lIns="190500" tIns="114300" rIns="142875" bIns="114300">
-                      <a:noAutofit/>
-                    </a:bodyPr>
+                    <a:bodyPr/>
                     <a:lstStyle/>
                     <a:p>
                       <a:r>
@@ -17086,9 +17201,7 @@
                 </a:tc>
                 <a:tc>
                   <a:txBody>
-                    <a:bodyPr lIns="190500" tIns="114300" rIns="142875" bIns="114300">
-                      <a:noAutofit/>
-                    </a:bodyPr>
+                    <a:bodyPr/>
                     <a:lstStyle/>
                     <a:p>
                       <a:r>
@@ -17112,9 +17225,7 @@
                 </a:tc>
                 <a:tc>
                   <a:txBody>
-                    <a:bodyPr lIns="190500" tIns="114300" rIns="142875" bIns="114300">
-                      <a:noAutofit/>
-                    </a:bodyPr>
+                    <a:bodyPr/>
                     <a:lstStyle/>
                     <a:p>
                       <a:r>
@@ -17143,7 +17254,7 @@
       </p:graphicFrame>
       <p:sp>
         <p:nvSpPr>
-          <p:cNvPr id="4" name="">
+          <p:cNvPr id="4" name="矩形 3">
             <a:extLst xmlns:a="http://schemas.openxmlformats.org/drawingml/2006/main">
               <a:ext uri="{FF2B5EF4-FFF2-40B4-BE49-F238E27FC236}">
                 <a16:creationId xmlns:a16="http://schemas.microsoft.com/office/drawing/2014/main" id="{30AAA11F-66AD-444C-93C4-06C79BEE30B8}"/>
@@ -17230,7 +17341,7 @@
       </p:grpSpPr>
       <p:sp>
         <p:nvSpPr>
-          <p:cNvPr id="9" name="">
+          <p:cNvPr id="9" name="矩形 8">
             <a:extLst xmlns:a="http://schemas.openxmlformats.org/drawingml/2006/main">
               <a:ext uri="{FF2B5EF4-FFF2-40B4-BE49-F238E27FC236}">
                 <a16:creationId xmlns:a16="http://schemas.microsoft.com/office/drawing/2014/main" id="{1AF6722A-A459-4877-B5CF-BEDD709EC73F}"/>
@@ -17288,7 +17399,7 @@
       </p:sp>
       <p:sp>
         <p:nvSpPr>
-          <p:cNvPr id="2" name="">
+          <p:cNvPr id="2" name="矩形 1">
             <a:extLst xmlns:a="http://schemas.openxmlformats.org/drawingml/2006/main">
               <a:ext uri="{FF2B5EF4-FFF2-40B4-BE49-F238E27FC236}">
                 <a16:creationId xmlns:a16="http://schemas.microsoft.com/office/drawing/2014/main" id="{C5377480-1642-4A8D-83FC-1C9CC5056F6C}"/>
@@ -17346,7 +17457,7 @@
       </p:sp>
       <p:sp>
         <p:nvSpPr>
-          <p:cNvPr id="3" name="">
+          <p:cNvPr id="3" name="矩形 2">
             <a:extLst xmlns:a="http://schemas.openxmlformats.org/drawingml/2006/main">
               <a:ext uri="{FF2B5EF4-FFF2-40B4-BE49-F238E27FC236}">
                 <a16:creationId xmlns:a16="http://schemas.microsoft.com/office/drawing/2014/main" id="{F9FD56CD-76B5-4F6E-8714-F7AA4A7BFD7B}"/>
@@ -17404,7 +17515,7 @@
       </p:sp>
       <p:sp>
         <p:nvSpPr>
-          <p:cNvPr id="4" name="">
+          <p:cNvPr id="4" name="矩形 3">
             <a:extLst xmlns:a="http://schemas.openxmlformats.org/drawingml/2006/main">
               <a:ext uri="{FF2B5EF4-FFF2-40B4-BE49-F238E27FC236}">
                 <a16:creationId xmlns:a16="http://schemas.microsoft.com/office/drawing/2014/main" id="{FD41C933-B09A-47AC-BBC6-88DC43E68CA6}"/>
@@ -17534,7 +17645,7 @@
       </p:sp>
       <p:sp>
         <p:nvSpPr>
-          <p:cNvPr id="5" name="">
+          <p:cNvPr id="5" name="矩形 4">
             <a:extLst xmlns:a="http://schemas.openxmlformats.org/drawingml/2006/main">
               <a:ext uri="{FF2B5EF4-FFF2-40B4-BE49-F238E27FC236}">
                 <a16:creationId xmlns:a16="http://schemas.microsoft.com/office/drawing/2014/main" id="{A5CD8DAC-05D9-4A50-BC6F-5F4F6FD259B8}"/>
@@ -17592,7 +17703,7 @@
       </p:sp>
       <p:sp>
         <p:nvSpPr>
-          <p:cNvPr id="6" name="">
+          <p:cNvPr id="6" name="矩形 5">
             <a:extLst xmlns:a="http://schemas.openxmlformats.org/drawingml/2006/main">
               <a:ext uri="{FF2B5EF4-FFF2-40B4-BE49-F238E27FC236}">
                 <a16:creationId xmlns:a16="http://schemas.microsoft.com/office/drawing/2014/main" id="{17F9CCE5-F9C2-4501-A882-CB8AAA2DC801}"/>
@@ -17642,7 +17753,7 @@
                 <a:latin typeface="Hiragino Sans GB"/>
                 <a:ea typeface="Hiragino Sans GB"/>
                 <a:cs typeface="Hiragino Sans GB"/>
-                <a:hlinkClick xmlns:r="http://schemas.openxmlformats.org/officeDocument/2006/relationships" r:id="R92fff7d3cf094eb6"/>
+                <a:hlinkClick xmlns:r="http://schemas.openxmlformats.org/officeDocument/2006/relationships" r:id="R4f5e6c3a6a484155"/>
               </a:rPr>
               <a:t>登录与账号</a:t>
             </a:r>
@@ -17651,7 +17762,7 @@
       </p:sp>
       <p:sp>
         <p:nvSpPr>
-          <p:cNvPr id="7" name="">
+          <p:cNvPr id="7" name="矩形 6">
             <a:extLst xmlns:a="http://schemas.openxmlformats.org/drawingml/2006/main">
               <a:ext uri="{FF2B5EF4-FFF2-40B4-BE49-F238E27FC236}">
                 <a16:creationId xmlns:a16="http://schemas.microsoft.com/office/drawing/2014/main" id="{4E80C01E-7DFC-45C1-B0D2-2DDDAD0B5EF1}"/>
@@ -17701,7 +17812,7 @@
                 <a:latin typeface="Hiragino Sans GB"/>
                 <a:ea typeface="Hiragino Sans GB"/>
                 <a:cs typeface="Hiragino Sans GB"/>
-                <a:hlinkClick xmlns:r="http://schemas.openxmlformats.org/officeDocument/2006/relationships" r:id="Ra8c61309f03c4527"/>
+                <a:hlinkClick xmlns:r="http://schemas.openxmlformats.org/officeDocument/2006/relationships" r:id="R50204793a52a482d"/>
               </a:rPr>
               <a:t>Slurm 作业管理</a:t>
             </a:r>
@@ -17710,7 +17821,7 @@
       </p:sp>
       <p:sp>
         <p:nvSpPr>
-          <p:cNvPr id="8" name="">
+          <p:cNvPr id="8" name="矩形 7">
             <a:extLst xmlns:a="http://schemas.openxmlformats.org/drawingml/2006/main">
               <a:ext uri="{FF2B5EF4-FFF2-40B4-BE49-F238E27FC236}">
                 <a16:creationId xmlns:a16="http://schemas.microsoft.com/office/drawing/2014/main" id="{6A53C6D5-E03E-43B4-AD6E-0E08D932A710}"/>
@@ -17760,7 +17871,7 @@
                 <a:latin typeface="Hiragino Sans GB"/>
                 <a:ea typeface="Hiragino Sans GB"/>
                 <a:cs typeface="Hiragino Sans GB"/>
-                <a:hlinkClick xmlns:r="http://schemas.openxmlformats.org/officeDocument/2006/relationships" r:id="R202ab1f9ec454f52"/>
+                <a:hlinkClick xmlns:r="http://schemas.openxmlformats.org/officeDocument/2006/relationships" r:id="Rcc91daad88024d54"/>
               </a:rPr>
               <a:t>文件传输</a:t>
             </a:r>
@@ -17798,7 +17909,7 @@
       </p:grpSpPr>
       <p:sp>
         <p:nvSpPr>
-          <p:cNvPr id="9" name="">
+          <p:cNvPr id="9" name="矩形 8">
             <a:extLst xmlns:a="http://schemas.openxmlformats.org/drawingml/2006/main">
               <a:ext uri="{FF2B5EF4-FFF2-40B4-BE49-F238E27FC236}">
                 <a16:creationId xmlns:a16="http://schemas.microsoft.com/office/drawing/2014/main" id="{974B2865-DC00-4E59-9F3A-640A7913DC3C}"/>
@@ -17856,7 +17967,7 @@
       </p:sp>
       <p:sp>
         <p:nvSpPr>
-          <p:cNvPr id="2" name="">
+          <p:cNvPr id="2" name="矩形 1">
             <a:extLst xmlns:a="http://schemas.openxmlformats.org/drawingml/2006/main">
               <a:ext uri="{FF2B5EF4-FFF2-40B4-BE49-F238E27FC236}">
                 <a16:creationId xmlns:a16="http://schemas.microsoft.com/office/drawing/2014/main" id="{AFA67C7E-1DCE-457B-9A22-9FD38D176CF9}"/>
@@ -17914,7 +18025,7 @@
       </p:sp>
       <p:sp>
         <p:nvSpPr>
-          <p:cNvPr id="3" name="">
+          <p:cNvPr id="3" name="矩形 2">
             <a:extLst xmlns:a="http://schemas.openxmlformats.org/drawingml/2006/main">
               <a:ext uri="{FF2B5EF4-FFF2-40B4-BE49-F238E27FC236}">
                 <a16:creationId xmlns:a16="http://schemas.microsoft.com/office/drawing/2014/main" id="{C7B9B1E8-0A26-4E7E-9FBD-B0E2555C9468}"/>
@@ -17972,7 +18083,7 @@
       </p:sp>
       <p:sp>
         <p:nvSpPr>
-          <p:cNvPr id="4" name="">
+          <p:cNvPr id="4" name="矩形 3">
             <a:extLst xmlns:a="http://schemas.openxmlformats.org/drawingml/2006/main">
               <a:ext uri="{FF2B5EF4-FFF2-40B4-BE49-F238E27FC236}">
                 <a16:creationId xmlns:a16="http://schemas.microsoft.com/office/drawing/2014/main" id="{7FCFEF93-934B-4D01-9AC2-2312D5DFEA01}"/>
@@ -18030,7 +18141,7 @@
       </p:sp>
       <p:sp>
         <p:nvSpPr>
-          <p:cNvPr id="5" name="">
+          <p:cNvPr id="5" name="矩形 4">
             <a:extLst xmlns:a="http://schemas.openxmlformats.org/drawingml/2006/main">
               <a:ext uri="{FF2B5EF4-FFF2-40B4-BE49-F238E27FC236}">
                 <a16:creationId xmlns:a16="http://schemas.microsoft.com/office/drawing/2014/main" id="{5C2BEB3C-1B69-4AD7-8964-2838E6DA0137}"/>
@@ -18088,7 +18199,7 @@
       </p:sp>
       <p:sp>
         <p:nvSpPr>
-          <p:cNvPr id="6" name="">
+          <p:cNvPr id="6" name="矩形 5">
             <a:extLst xmlns:a="http://schemas.openxmlformats.org/drawingml/2006/main">
               <a:ext uri="{FF2B5EF4-FFF2-40B4-BE49-F238E27FC236}">
                 <a16:creationId xmlns:a16="http://schemas.microsoft.com/office/drawing/2014/main" id="{26EB50A4-4CA3-4266-9F3F-5910109D4958}"/>
@@ -18146,7 +18257,7 @@
       </p:sp>
       <p:sp>
         <p:nvSpPr>
-          <p:cNvPr id="7" name="">
+          <p:cNvPr id="7" name="矩形 6">
             <a:extLst xmlns:a="http://schemas.openxmlformats.org/drawingml/2006/main">
               <a:ext uri="{FF2B5EF4-FFF2-40B4-BE49-F238E27FC236}">
                 <a16:creationId xmlns:a16="http://schemas.microsoft.com/office/drawing/2014/main" id="{0E3D5CA9-B242-4F6B-9A39-5ABB485F682B}"/>
@@ -18204,7 +18315,7 @@
       </p:sp>
       <p:sp>
         <p:nvSpPr>
-          <p:cNvPr id="8" name="">
+          <p:cNvPr id="8" name="矩形 7">
             <a:extLst xmlns:a="http://schemas.openxmlformats.org/drawingml/2006/main">
               <a:ext uri="{FF2B5EF4-FFF2-40B4-BE49-F238E27FC236}">
                 <a16:creationId xmlns:a16="http://schemas.microsoft.com/office/drawing/2014/main" id="{2D2E6DC5-2158-444A-8B32-E35DBB429F1F}"/>
@@ -18291,7 +18402,7 @@
       </p:grpSpPr>
       <p:sp>
         <p:nvSpPr>
-          <p:cNvPr id="9" name="">
+          <p:cNvPr id="9" name="矩形 8">
             <a:extLst xmlns:a="http://schemas.openxmlformats.org/drawingml/2006/main">
               <a:ext uri="{FF2B5EF4-FFF2-40B4-BE49-F238E27FC236}">
                 <a16:creationId xmlns:a16="http://schemas.microsoft.com/office/drawing/2014/main" id="{974B2865-DC00-4E59-9F3A-640A7913DC3C}"/>
@@ -18349,7 +18460,7 @@
       </p:sp>
       <p:sp>
         <p:nvSpPr>
-          <p:cNvPr id="2" name="">
+          <p:cNvPr id="2" name="矩形 1">
             <a:extLst xmlns:a="http://schemas.openxmlformats.org/drawingml/2006/main">
               <a:ext uri="{FF2B5EF4-FFF2-40B4-BE49-F238E27FC236}">
                 <a16:creationId xmlns:a16="http://schemas.microsoft.com/office/drawing/2014/main" id="{AFA67C7E-1DCE-457B-9A22-9FD38D176CF9}"/>
@@ -18900,7 +19011,7 @@
       </p:grpSpPr>
       <p:sp>
         <p:nvSpPr>
-          <p:cNvPr id="9" name="">
+          <p:cNvPr id="9" name="矩形 8">
             <a:extLst xmlns:a="http://schemas.openxmlformats.org/drawingml/2006/main">
               <a:ext uri="{FF2B5EF4-FFF2-40B4-BE49-F238E27FC236}">
                 <a16:creationId xmlns:a16="http://schemas.microsoft.com/office/drawing/2014/main" id="{974B2865-DC00-4E59-9F3A-640A7913DC3C}"/>
@@ -18958,7 +19069,7 @@
       </p:sp>
       <p:sp>
         <p:nvSpPr>
-          <p:cNvPr id="2" name="">
+          <p:cNvPr id="2" name="矩形 1">
             <a:extLst xmlns:a="http://schemas.openxmlformats.org/drawingml/2006/main">
               <a:ext uri="{FF2B5EF4-FFF2-40B4-BE49-F238E27FC236}">
                 <a16:creationId xmlns:a16="http://schemas.microsoft.com/office/drawing/2014/main" id="{AFA67C7E-1DCE-457B-9A22-9FD38D176CF9}"/>
@@ -19973,7 +20084,7 @@
       </p:grpSpPr>
       <p:sp>
         <p:nvSpPr>
-          <p:cNvPr id="9" name="">
+          <p:cNvPr id="9" name="矩形 8">
             <a:extLst xmlns:a="http://schemas.openxmlformats.org/drawingml/2006/main">
               <a:ext uri="{FF2B5EF4-FFF2-40B4-BE49-F238E27FC236}">
                 <a16:creationId xmlns:a16="http://schemas.microsoft.com/office/drawing/2014/main" id="{974B2865-DC00-4E59-9F3A-640A7913DC3C}"/>
@@ -20031,7 +20142,7 @@
       </p:sp>
       <p:sp>
         <p:nvSpPr>
-          <p:cNvPr id="2" name="">
+          <p:cNvPr id="2" name="矩形 1">
             <a:extLst xmlns:a="http://schemas.openxmlformats.org/drawingml/2006/main">
               <a:ext uri="{FF2B5EF4-FFF2-40B4-BE49-F238E27FC236}">
                 <a16:creationId xmlns:a16="http://schemas.microsoft.com/office/drawing/2014/main" id="{AFA67C7E-1DCE-457B-9A22-9FD38D176CF9}"/>
@@ -20582,7 +20693,7 @@
       </p:grpSpPr>
       <p:sp>
         <p:nvSpPr>
-          <p:cNvPr id="9" name="">
+          <p:cNvPr id="9" name="矩形 8">
             <a:extLst xmlns:a="http://schemas.openxmlformats.org/drawingml/2006/main">
               <a:ext uri="{FF2B5EF4-FFF2-40B4-BE49-F238E27FC236}">
                 <a16:creationId xmlns:a16="http://schemas.microsoft.com/office/drawing/2014/main" id="{974B2865-DC00-4E59-9F3A-640A7913DC3C}"/>
@@ -20640,7 +20751,7 @@
       </p:sp>
       <p:sp>
         <p:nvSpPr>
-          <p:cNvPr id="2" name="">
+          <p:cNvPr id="2" name="矩形 1">
             <a:extLst xmlns:a="http://schemas.openxmlformats.org/drawingml/2006/main">
               <a:ext uri="{FF2B5EF4-FFF2-40B4-BE49-F238E27FC236}">
                 <a16:creationId xmlns:a16="http://schemas.microsoft.com/office/drawing/2014/main" id="{AFA67C7E-1DCE-457B-9A22-9FD38D176CF9}"/>
@@ -21249,7 +21360,7 @@
       </p:grpSpPr>
       <p:sp>
         <p:nvSpPr>
-          <p:cNvPr id="9" name="">
+          <p:cNvPr id="9" name="矩形 8">
             <a:extLst xmlns:a="http://schemas.openxmlformats.org/drawingml/2006/main">
               <a:ext uri="{FF2B5EF4-FFF2-40B4-BE49-F238E27FC236}">
                 <a16:creationId xmlns:a16="http://schemas.microsoft.com/office/drawing/2014/main" id="{974B2865-DC00-4E59-9F3A-640A7913DC3C}"/>
@@ -21307,7 +21418,7 @@
       </p:sp>
       <p:sp>
         <p:nvSpPr>
-          <p:cNvPr id="2" name="">
+          <p:cNvPr id="2" name="矩形 1">
             <a:extLst xmlns:a="http://schemas.openxmlformats.org/drawingml/2006/main">
               <a:ext uri="{FF2B5EF4-FFF2-40B4-BE49-F238E27FC236}">
                 <a16:creationId xmlns:a16="http://schemas.microsoft.com/office/drawing/2014/main" id="{AFA67C7E-1DCE-457B-9A22-9FD38D176CF9}"/>
@@ -21800,7 +21911,7 @@
       </p:grpSpPr>
       <p:sp>
         <p:nvSpPr>
-          <p:cNvPr id="9" name="">
+          <p:cNvPr id="9" name="矩形 8">
             <a:extLst xmlns:a="http://schemas.openxmlformats.org/drawingml/2006/main">
               <a:ext uri="{FF2B5EF4-FFF2-40B4-BE49-F238E27FC236}">
                 <a16:creationId xmlns:a16="http://schemas.microsoft.com/office/drawing/2014/main" id="{974B2865-DC00-4E59-9F3A-640A7913DC3C}"/>
@@ -21858,7 +21969,7 @@
       </p:sp>
       <p:sp>
         <p:nvSpPr>
-          <p:cNvPr id="2" name="">
+          <p:cNvPr id="2" name="矩形 1">
             <a:extLst xmlns:a="http://schemas.openxmlformats.org/drawingml/2006/main">
               <a:ext uri="{FF2B5EF4-FFF2-40B4-BE49-F238E27FC236}">
                 <a16:creationId xmlns:a16="http://schemas.microsoft.com/office/drawing/2014/main" id="{AFA67C7E-1DCE-457B-9A22-9FD38D176CF9}"/>

</xml_diff>

<commit_message>
Align register experiment sizes with divisibility requirement
</commit_message>
<xml_diff>
--- a/docs/交我算平台Lab运行指南-学生版.pptx
+++ b/docs/交我算平台Lab运行指南-学生版.pptx
@@ -2,47 +2,47 @@
 <file path=ppt/presentation.xml><?xml version="1.0" encoding="utf-8"?>
 <p:presentation xmlns:p="http://schemas.openxmlformats.org/presentationml/2006/main">
   <p:sldMasterIdLst>
-    <p:sldMasterId xmlns:r="http://schemas.openxmlformats.org/officeDocument/2006/relationships" id="2147483648" r:id="R3b5be99ea7fc43fe"/>
+    <p:sldMasterId xmlns:r="http://schemas.openxmlformats.org/officeDocument/2006/relationships" id="2147483648" r:id="R5a10bd07fb45401d"/>
   </p:sldMasterIdLst>
   <p:notesMasterIdLst>
-    <p:notesMasterId xmlns:r="http://schemas.openxmlformats.org/officeDocument/2006/relationships" r:id="Re9c31ff4d3734fc5"/>
+    <p:notesMasterId xmlns:r="http://schemas.openxmlformats.org/officeDocument/2006/relationships" r:id="R244890ac6e02451c"/>
   </p:notesMasterIdLst>
   <p:sldIdLst>
-    <p:sldId xmlns:r="http://schemas.openxmlformats.org/officeDocument/2006/relationships" id="256" r:id="R8ef416d2e6104817"/>
-    <p:sldId xmlns:r="http://schemas.openxmlformats.org/officeDocument/2006/relationships" id="257" r:id="Rb467d9ad9dd94644"/>
-    <p:sldId xmlns:r="http://schemas.openxmlformats.org/officeDocument/2006/relationships" id="258" r:id="Rffa192c319f641a7"/>
-    <p:sldId xmlns:r="http://schemas.openxmlformats.org/officeDocument/2006/relationships" id="259" r:id="R4864e844e8a24bc6"/>
-    <p:sldId xmlns:r="http://schemas.openxmlformats.org/officeDocument/2006/relationships" id="260" r:id="Ra9256131bbf94859"/>
-    <p:sldId xmlns:r="http://schemas.openxmlformats.org/officeDocument/2006/relationships" id="261" r:id="Ref59529e5c564a1f"/>
-    <p:sldId xmlns:r="http://schemas.openxmlformats.org/officeDocument/2006/relationships" id="262" r:id="R75f895febe5845fe"/>
-    <p:sldId xmlns:r="http://schemas.openxmlformats.org/officeDocument/2006/relationships" id="263" r:id="R5a02f858e4d8477e"/>
-    <p:sldId xmlns:r="http://schemas.openxmlformats.org/officeDocument/2006/relationships" id="264" r:id="Ra72b2444d7df436f"/>
-    <p:sldId xmlns:r="http://schemas.openxmlformats.org/officeDocument/2006/relationships" id="265" r:id="R0152135cc6f44990"/>
-    <p:sldId xmlns:r="http://schemas.openxmlformats.org/officeDocument/2006/relationships" id="266" r:id="R6e401afaa915434d"/>
-    <p:sldId xmlns:r="http://schemas.openxmlformats.org/officeDocument/2006/relationships" id="267" r:id="Re8057363590f4b04"/>
-    <p:sldId xmlns:r="http://schemas.openxmlformats.org/officeDocument/2006/relationships" id="268" r:id="Rb9162008eedd4bcd"/>
-    <p:sldId xmlns:r="http://schemas.openxmlformats.org/officeDocument/2006/relationships" id="269" r:id="Rd73ae4b7b8f04a5d"/>
-    <p:sldId xmlns:r="http://schemas.openxmlformats.org/officeDocument/2006/relationships" id="270" r:id="Rdb43e1ab8fad493f"/>
-    <p:sldId xmlns:r="http://schemas.openxmlformats.org/officeDocument/2006/relationships" id="271" r:id="Rbd0db9d398fd4f6c"/>
-    <p:sldId xmlns:r="http://schemas.openxmlformats.org/officeDocument/2006/relationships" id="272" r:id="Rf1997a6d9c1d4ee3"/>
-    <p:sldId xmlns:r="http://schemas.openxmlformats.org/officeDocument/2006/relationships" id="273" r:id="Rc5f5770405d64642"/>
-    <p:sldId xmlns:r="http://schemas.openxmlformats.org/officeDocument/2006/relationships" id="274" r:id="R2266d51504134680"/>
-    <p:sldId xmlns:r="http://schemas.openxmlformats.org/officeDocument/2006/relationships" id="275" r:id="R6138b17a8686492d"/>
-    <p:sldId xmlns:r="http://schemas.openxmlformats.org/officeDocument/2006/relationships" id="276" r:id="Rd9fda2107c15476f"/>
-    <p:sldId xmlns:r="http://schemas.openxmlformats.org/officeDocument/2006/relationships" id="277" r:id="R4bd2d109ea9a43b9"/>
-    <p:sldId xmlns:r="http://schemas.openxmlformats.org/officeDocument/2006/relationships" id="278" r:id="R513b1dcdf7be4d03"/>
-    <p:sldId xmlns:r="http://schemas.openxmlformats.org/officeDocument/2006/relationships" id="279" r:id="Rc5090e06255744be"/>
-    <p:sldId xmlns:r="http://schemas.openxmlformats.org/officeDocument/2006/relationships" id="280" r:id="R3152f1625b304ee0"/>
-    <p:sldId xmlns:r="http://schemas.openxmlformats.org/officeDocument/2006/relationships" id="281" r:id="R38b2646cf9f34a8f"/>
-    <p:sldId xmlns:r="http://schemas.openxmlformats.org/officeDocument/2006/relationships" id="282" r:id="Rb7e3db5956604c74"/>
-    <p:sldId xmlns:r="http://schemas.openxmlformats.org/officeDocument/2006/relationships" id="283" r:id="Rc6cd97606af44255"/>
-    <p:sldId xmlns:r="http://schemas.openxmlformats.org/officeDocument/2006/relationships" id="284" r:id="Rc7860a129ebd4f4d"/>
-    <p:sldId xmlns:r="http://schemas.openxmlformats.org/officeDocument/2006/relationships" id="285" r:id="R34eeb180615e4bef"/>
-    <p:sldId xmlns:r="http://schemas.openxmlformats.org/officeDocument/2006/relationships" id="286" r:id="R767e39d9443e4afd"/>
-    <p:sldId xmlns:r="http://schemas.openxmlformats.org/officeDocument/2006/relationships" id="287" r:id="R84fcfe2c137549ef"/>
-    <p:sldId xmlns:r="http://schemas.openxmlformats.org/officeDocument/2006/relationships" id="288" r:id="R4fcc23b9c4ed4d11"/>
-    <p:sldId xmlns:r="http://schemas.openxmlformats.org/officeDocument/2006/relationships" id="289" r:id="Re021bf59e62e431f"/>
-    <p:sldId xmlns:r="http://schemas.openxmlformats.org/officeDocument/2006/relationships" id="290" r:id="Rb97a855da7834986"/>
+    <p:sldId xmlns:r="http://schemas.openxmlformats.org/officeDocument/2006/relationships" id="256" r:id="Rb97d8377e39649d0"/>
+    <p:sldId xmlns:r="http://schemas.openxmlformats.org/officeDocument/2006/relationships" id="257" r:id="Reb659c45f8d44b6b"/>
+    <p:sldId xmlns:r="http://schemas.openxmlformats.org/officeDocument/2006/relationships" id="258" r:id="R174a1353a8ef41bb"/>
+    <p:sldId xmlns:r="http://schemas.openxmlformats.org/officeDocument/2006/relationships" id="259" r:id="R48072fc7357c4746"/>
+    <p:sldId xmlns:r="http://schemas.openxmlformats.org/officeDocument/2006/relationships" id="260" r:id="R01f08e0209e24a5b"/>
+    <p:sldId xmlns:r="http://schemas.openxmlformats.org/officeDocument/2006/relationships" id="261" r:id="R0254adb0c8f640da"/>
+    <p:sldId xmlns:r="http://schemas.openxmlformats.org/officeDocument/2006/relationships" id="262" r:id="R0f0f7ca44b0b496c"/>
+    <p:sldId xmlns:r="http://schemas.openxmlformats.org/officeDocument/2006/relationships" id="263" r:id="Rba623d8432954590"/>
+    <p:sldId xmlns:r="http://schemas.openxmlformats.org/officeDocument/2006/relationships" id="264" r:id="R1a910f93d01e49b1"/>
+    <p:sldId xmlns:r="http://schemas.openxmlformats.org/officeDocument/2006/relationships" id="265" r:id="Rb588f9f651aa4add"/>
+    <p:sldId xmlns:r="http://schemas.openxmlformats.org/officeDocument/2006/relationships" id="266" r:id="R501b4b6f31fc4b0f"/>
+    <p:sldId xmlns:r="http://schemas.openxmlformats.org/officeDocument/2006/relationships" id="267" r:id="R91e04c403424486e"/>
+    <p:sldId xmlns:r="http://schemas.openxmlformats.org/officeDocument/2006/relationships" id="268" r:id="R75f7e2d087ba432f"/>
+    <p:sldId xmlns:r="http://schemas.openxmlformats.org/officeDocument/2006/relationships" id="269" r:id="Rfa99c87fc73c4b0f"/>
+    <p:sldId xmlns:r="http://schemas.openxmlformats.org/officeDocument/2006/relationships" id="270" r:id="Ra3d7fbbd8ef44d2c"/>
+    <p:sldId xmlns:r="http://schemas.openxmlformats.org/officeDocument/2006/relationships" id="271" r:id="R77ce96926536464c"/>
+    <p:sldId xmlns:r="http://schemas.openxmlformats.org/officeDocument/2006/relationships" id="272" r:id="R66fc69a0c9b34cd1"/>
+    <p:sldId xmlns:r="http://schemas.openxmlformats.org/officeDocument/2006/relationships" id="273" r:id="R0da19f867c3b4a33"/>
+    <p:sldId xmlns:r="http://schemas.openxmlformats.org/officeDocument/2006/relationships" id="274" r:id="R218128924b03461d"/>
+    <p:sldId xmlns:r="http://schemas.openxmlformats.org/officeDocument/2006/relationships" id="275" r:id="R349ea0c71c75494a"/>
+    <p:sldId xmlns:r="http://schemas.openxmlformats.org/officeDocument/2006/relationships" id="276" r:id="R32d0ad3cdacc47f1"/>
+    <p:sldId xmlns:r="http://schemas.openxmlformats.org/officeDocument/2006/relationships" id="277" r:id="R9dd4b70195ae4917"/>
+    <p:sldId xmlns:r="http://schemas.openxmlformats.org/officeDocument/2006/relationships" id="278" r:id="Rceddce5e90594c5d"/>
+    <p:sldId xmlns:r="http://schemas.openxmlformats.org/officeDocument/2006/relationships" id="279" r:id="Rcf368fba6da04216"/>
+    <p:sldId xmlns:r="http://schemas.openxmlformats.org/officeDocument/2006/relationships" id="280" r:id="R1603923731c548a4"/>
+    <p:sldId xmlns:r="http://schemas.openxmlformats.org/officeDocument/2006/relationships" id="281" r:id="R2c27ab6732814c3b"/>
+    <p:sldId xmlns:r="http://schemas.openxmlformats.org/officeDocument/2006/relationships" id="282" r:id="R28d81451706941df"/>
+    <p:sldId xmlns:r="http://schemas.openxmlformats.org/officeDocument/2006/relationships" id="283" r:id="R870b50df966648ae"/>
+    <p:sldId xmlns:r="http://schemas.openxmlformats.org/officeDocument/2006/relationships" id="284" r:id="R529c9dc11ae64179"/>
+    <p:sldId xmlns:r="http://schemas.openxmlformats.org/officeDocument/2006/relationships" id="285" r:id="R56bfad23828f4fd1"/>
+    <p:sldId xmlns:r="http://schemas.openxmlformats.org/officeDocument/2006/relationships" id="286" r:id="Ref19afa7834148ac"/>
+    <p:sldId xmlns:r="http://schemas.openxmlformats.org/officeDocument/2006/relationships" id="287" r:id="Rf80962e00bbd4d72"/>
+    <p:sldId xmlns:r="http://schemas.openxmlformats.org/officeDocument/2006/relationships" id="288" r:id="Rd5a4849e29554b1d"/>
+    <p:sldId xmlns:r="http://schemas.openxmlformats.org/officeDocument/2006/relationships" id="289" r:id="Re6fe4bfcc84e406f"/>
+    <p:sldId xmlns:r="http://schemas.openxmlformats.org/officeDocument/2006/relationships" id="290" r:id="R78d5c3b9df5e43c6"/>
   </p:sldIdLst>
   <p:sldSz cx="15240000" cy="8572500"/>
   <p:notesSz cx="6858000" cy="9144000"/>
@@ -1789,7 +1789,12 @@
           </a:p>
           <a:p xmlns:a="http://schemas.openxmlformats.org/drawingml/2006/main">
             <a:r>
-              <a:t>README §6.4 的“n 可被 6 整除”与 §8.2 的正式规模冲突，需教师统一后执行寄存器实验。 当前参考 dgemm3 为 3×3 分块，没有处理非 3 倍数的尾部；reg_reuse 64 会出现 INVALID。</a:t>
+              <a:t>README §6.4 要求寄存器实验的 n 能被 6 整除。第 8.2 节正式命令与第 9.2 节报告表格统一使用 66、126、258、510、1026、2046，与 benchmarks/reg_reuse.c 的默认规模一致。循环次序实验按第 8.3 节使用 n=2048、b=64。</a:t>
+            </a:r>
+          </a:p>
+          <a:p xmlns:a="http://schemas.openxmlformats.org/drawingml/2006/main">
+            <a:r>
+              <a:t/>
             </a:r>
           </a:p>
         </p:txBody>
@@ -2299,7 +2304,13 @@
           </a:p>
           <a:p xmlns:a="http://schemas.openxmlformats.org/drawingml/2006/main">
             <a:r>
-              <a:t>该脚本只做额外默认批量检查，不替代正式流程。它不会调用 sbatch，必须在计算节点运行。默认 n、b 与 README 正式规模不同，故单列说明。</a:t>
+              <a:t>该脚本只做额外默认批量检查，不替代正式流程。它不会调用 sbatch，必须在计算节点运行。寄存器默认规模与 README 第 8.2 节相同；Part 3 和 Part 4 的默认 n、b 与正式实验参数不同。</a:t>
+            </a:r>
+            <a:endParaRPr/>
+          </a:p>
+          <a:p xmlns:a="http://schemas.openxmlformats.org/drawingml/2006/main">
+            <a:r>
+              <a:t/>
             </a:r>
             <a:endParaRPr/>
           </a:p>
@@ -3661,7 +3672,7 @@
   </p:cSld>
   <p:clrMap bg1="lt1" tx1="dk1" bg2="lt2" tx2="dk2" accent1="accent1" accent2="accent2" accent3="accent3" accent4="accent4" accent5="accent5" accent6="accent6" hlink="hlink" folHlink="folHlink"/>
   <p:sldLayoutIdLst>
-    <p:sldLayoutId xmlns:r="http://schemas.openxmlformats.org/officeDocument/2006/relationships" id="2147483649" r:id="R8dde0b35e9234769"/>
+    <p:sldLayoutId xmlns:r="http://schemas.openxmlformats.org/officeDocument/2006/relationships" id="2147483649" r:id="R4226e492139f40ab"/>
   </p:sldLayoutIdLst>
   <p:txStyles>
     <p:titleStyle>
@@ -7763,6 +7774,7 @@
           <a:lstStyle xmlns:a="http://schemas.openxmlformats.org/drawingml/2006/main"/>
           <a:p xmlns:a="http://schemas.openxmlformats.org/drawingml/2006/main">
             <a:pPr>
+              <a:buNone/>
               <a:defRPr sz="2550" b="0">
                 <a:solidFill>
                   <a:srgbClr val="B7EDDB"/>
@@ -7820,6 +7832,7 @@
           <a:lstStyle xmlns:a="http://schemas.openxmlformats.org/drawingml/2006/main"/>
           <a:p xmlns:a="http://schemas.openxmlformats.org/drawingml/2006/main">
             <a:pPr>
+              <a:buNone/>
               <a:defRPr sz="2550" b="0">
                 <a:solidFill>
                   <a:srgbClr val="B7EDDB"/>
@@ -7877,6 +7890,7 @@
           <a:lstStyle xmlns:a="http://schemas.openxmlformats.org/drawingml/2006/main"/>
           <a:p xmlns:a="http://schemas.openxmlformats.org/drawingml/2006/main">
             <a:pPr>
+              <a:buNone/>
               <a:defRPr sz="2550" b="0">
                 <a:solidFill>
                   <a:srgbClr val="B7EDDB"/>
@@ -7934,6 +7948,7 @@
           <a:lstStyle xmlns:a="http://schemas.openxmlformats.org/drawingml/2006/main"/>
           <a:p xmlns:a="http://schemas.openxmlformats.org/drawingml/2006/main">
             <a:pPr>
+              <a:buNone/>
               <a:defRPr sz="2550" b="0">
                 <a:solidFill>
                   <a:srgbClr val="B7EDDB"/>
@@ -7991,6 +8006,7 @@
           <a:lstStyle xmlns:a="http://schemas.openxmlformats.org/drawingml/2006/main"/>
           <a:p xmlns:a="http://schemas.openxmlformats.org/drawingml/2006/main">
             <a:pPr>
+              <a:buNone/>
               <a:defRPr sz="2550" b="0">
                 <a:solidFill>
                   <a:srgbClr val="B7EDDB"/>
@@ -8048,6 +8064,7 @@
           <a:lstStyle xmlns:a="http://schemas.openxmlformats.org/drawingml/2006/main"/>
           <a:p xmlns:a="http://schemas.openxmlformats.org/drawingml/2006/main">
             <a:pPr>
+              <a:buNone/>
               <a:defRPr sz="2550" b="0">
                 <a:solidFill>
                   <a:srgbClr val="B7EDDB"/>
@@ -8105,6 +8122,7 @@
           <a:lstStyle xmlns:a="http://schemas.openxmlformats.org/drawingml/2006/main"/>
           <a:p xmlns:a="http://schemas.openxmlformats.org/drawingml/2006/main">
             <a:pPr>
+              <a:buNone/>
               <a:defRPr sz="2550" b="0">
                 <a:solidFill>
                   <a:srgbClr val="B7EDDB"/>
@@ -8162,6 +8180,7 @@
           <a:lstStyle xmlns:a="http://schemas.openxmlformats.org/drawingml/2006/main"/>
           <a:p xmlns:a="http://schemas.openxmlformats.org/drawingml/2006/main">
             <a:pPr>
+              <a:buNone/>
               <a:defRPr sz="2175" b="0">
                 <a:solidFill>
                   <a:srgbClr val="EAF1EF"/>
@@ -8219,6 +8238,7 @@
           <a:lstStyle xmlns:a="http://schemas.openxmlformats.org/drawingml/2006/main"/>
           <a:p xmlns:a="http://schemas.openxmlformats.org/drawingml/2006/main">
             <a:pPr>
+              <a:buNone/>
               <a:defRPr sz="2100" b="0">
                 <a:solidFill>
                   <a:srgbClr val="EAF1EF"/>
@@ -8276,6 +8296,7 @@
           <a:lstStyle xmlns:a="http://schemas.openxmlformats.org/drawingml/2006/main"/>
           <a:p xmlns:a="http://schemas.openxmlformats.org/drawingml/2006/main">
             <a:pPr>
+              <a:buNone/>
               <a:defRPr sz="2025" b="0">
                 <a:solidFill>
                   <a:srgbClr val="A8C6C4"/>
@@ -8478,6 +8499,7 @@
           <a:lstStyle xmlns:a="http://schemas.openxmlformats.org/drawingml/2006/main"/>
           <a:p xmlns:a="http://schemas.openxmlformats.org/drawingml/2006/main">
             <a:pPr>
+              <a:buNone/>
               <a:defRPr sz="2550" b="0">
                 <a:solidFill>
                   <a:srgbClr val="B7EDDB"/>
@@ -8535,6 +8557,7 @@
           <a:lstStyle xmlns:a="http://schemas.openxmlformats.org/drawingml/2006/main"/>
           <a:p xmlns:a="http://schemas.openxmlformats.org/drawingml/2006/main">
             <a:pPr>
+              <a:buNone/>
               <a:defRPr sz="2550" b="0">
                 <a:solidFill>
                   <a:srgbClr val="B7EDDB"/>
@@ -8592,6 +8615,7 @@
           <a:lstStyle xmlns:a="http://schemas.openxmlformats.org/drawingml/2006/main"/>
           <a:p xmlns:a="http://schemas.openxmlformats.org/drawingml/2006/main">
             <a:pPr>
+              <a:buNone/>
               <a:defRPr sz="2550" b="0">
                 <a:solidFill>
                   <a:srgbClr val="B7EDDB"/>
@@ -8649,6 +8673,7 @@
           <a:lstStyle xmlns:a="http://schemas.openxmlformats.org/drawingml/2006/main"/>
           <a:p xmlns:a="http://schemas.openxmlformats.org/drawingml/2006/main">
             <a:pPr>
+              <a:buNone/>
               <a:defRPr sz="2550" b="0">
                 <a:solidFill>
                   <a:srgbClr val="B7EDDB"/>
@@ -8706,6 +8731,7 @@
           <a:lstStyle xmlns:a="http://schemas.openxmlformats.org/drawingml/2006/main"/>
           <a:p xmlns:a="http://schemas.openxmlformats.org/drawingml/2006/main">
             <a:pPr>
+              <a:buNone/>
               <a:defRPr sz="2325" b="0">
                 <a:solidFill>
                   <a:srgbClr val="EAF1EF"/>
@@ -8763,6 +8789,7 @@
           <a:lstStyle xmlns:a="http://schemas.openxmlformats.org/drawingml/2006/main"/>
           <a:p xmlns:a="http://schemas.openxmlformats.org/drawingml/2006/main">
             <a:pPr>
+              <a:buNone/>
               <a:defRPr sz="2325" b="0">
                 <a:solidFill>
                   <a:srgbClr val="EAF1EF"/>
@@ -8820,6 +8847,7 @@
           <a:lstStyle xmlns:a="http://schemas.openxmlformats.org/drawingml/2006/main"/>
           <a:p xmlns:a="http://schemas.openxmlformats.org/drawingml/2006/main">
             <a:pPr>
+              <a:buNone/>
               <a:defRPr sz="2100" b="0">
                 <a:solidFill>
                   <a:srgbClr val="EAF1EF"/>
@@ -8877,6 +8905,7 @@
           <a:lstStyle xmlns:a="http://schemas.openxmlformats.org/drawingml/2006/main"/>
           <a:p xmlns:a="http://schemas.openxmlformats.org/drawingml/2006/main">
             <a:pPr>
+              <a:buNone/>
               <a:defRPr sz="2250" b="0">
                 <a:solidFill>
                   <a:srgbClr val="B7EDDB"/>
@@ -8934,6 +8963,7 @@
           <a:lstStyle xmlns:a="http://schemas.openxmlformats.org/drawingml/2006/main"/>
           <a:p xmlns:a="http://schemas.openxmlformats.org/drawingml/2006/main">
             <a:pPr>
+              <a:buNone/>
               <a:defRPr sz="2025" b="0">
                 <a:solidFill>
                   <a:srgbClr val="A8C6C4"/>
@@ -9136,6 +9166,7 @@
           <a:lstStyle xmlns:a="http://schemas.openxmlformats.org/drawingml/2006/main"/>
           <a:p xmlns:a="http://schemas.openxmlformats.org/drawingml/2006/main">
             <a:pPr>
+              <a:buNone/>
               <a:defRPr sz="2100" b="0">
                 <a:solidFill>
                   <a:srgbClr val="A8C6C4"/>
@@ -9193,6 +9224,7 @@
           <a:lstStyle xmlns:a="http://schemas.openxmlformats.org/drawingml/2006/main"/>
           <a:p xmlns:a="http://schemas.openxmlformats.org/drawingml/2006/main">
             <a:pPr>
+              <a:buNone/>
               <a:defRPr sz="2550" b="0">
                 <a:solidFill>
                   <a:srgbClr val="B7EDDB"/>
@@ -9250,6 +9282,7 @@
           <a:lstStyle xmlns:a="http://schemas.openxmlformats.org/drawingml/2006/main"/>
           <a:p xmlns:a="http://schemas.openxmlformats.org/drawingml/2006/main">
             <a:pPr>
+              <a:buNone/>
               <a:defRPr sz="2550" b="0">
                 <a:solidFill>
                   <a:srgbClr val="B7EDDB"/>
@@ -9307,6 +9340,7 @@
           <a:lstStyle xmlns:a="http://schemas.openxmlformats.org/drawingml/2006/main"/>
           <a:p xmlns:a="http://schemas.openxmlformats.org/drawingml/2006/main">
             <a:pPr>
+              <a:buNone/>
               <a:defRPr sz="2550" b="0">
                 <a:solidFill>
                   <a:srgbClr val="B7EDDB"/>
@@ -9364,6 +9398,7 @@
           <a:lstStyle xmlns:a="http://schemas.openxmlformats.org/drawingml/2006/main"/>
           <a:p xmlns:a="http://schemas.openxmlformats.org/drawingml/2006/main">
             <a:pPr>
+              <a:buNone/>
               <a:defRPr sz="2550" b="0">
                 <a:solidFill>
                   <a:srgbClr val="B7EDDB"/>
@@ -9421,6 +9456,7 @@
           <a:lstStyle xmlns:a="http://schemas.openxmlformats.org/drawingml/2006/main"/>
           <a:p xmlns:a="http://schemas.openxmlformats.org/drawingml/2006/main">
             <a:pPr>
+              <a:buNone/>
               <a:defRPr sz="2550" b="0">
                 <a:solidFill>
                   <a:srgbClr val="B7EDDB"/>
@@ -9478,6 +9514,7 @@
           <a:lstStyle xmlns:a="http://schemas.openxmlformats.org/drawingml/2006/main"/>
           <a:p xmlns:a="http://schemas.openxmlformats.org/drawingml/2006/main">
             <a:pPr>
+              <a:buNone/>
               <a:defRPr sz="2550" b="0">
                 <a:solidFill>
                   <a:srgbClr val="B7EDDB"/>
@@ -9535,6 +9572,7 @@
           <a:lstStyle xmlns:a="http://schemas.openxmlformats.org/drawingml/2006/main"/>
           <a:p xmlns:a="http://schemas.openxmlformats.org/drawingml/2006/main">
             <a:pPr>
+              <a:buNone/>
               <a:defRPr sz="2550" b="0">
                 <a:solidFill>
                   <a:srgbClr val="B7EDDB"/>
@@ -9592,6 +9630,7 @@
           <a:lstStyle xmlns:a="http://schemas.openxmlformats.org/drawingml/2006/main"/>
           <a:p xmlns:a="http://schemas.openxmlformats.org/drawingml/2006/main">
             <a:pPr>
+              <a:buNone/>
               <a:defRPr sz="2250" b="0">
                 <a:solidFill>
                   <a:srgbClr val="EAF1EF"/>
@@ -9649,6 +9688,7 @@
           <a:lstStyle xmlns:a="http://schemas.openxmlformats.org/drawingml/2006/main"/>
           <a:p xmlns:a="http://schemas.openxmlformats.org/drawingml/2006/main">
             <a:pPr>
+              <a:buNone/>
               <a:defRPr sz="2025" b="0">
                 <a:solidFill>
                   <a:srgbClr val="A8C6C4"/>
@@ -10521,6 +10561,7 @@
           <a:lstStyle xmlns:a="http://schemas.openxmlformats.org/drawingml/2006/main"/>
           <a:p xmlns:a="http://schemas.openxmlformats.org/drawingml/2006/main">
             <a:pPr>
+              <a:buNone/>
               <a:defRPr sz="2175" b="0">
                 <a:solidFill>
                   <a:srgbClr val="EAF1EF"/>
@@ -10578,6 +10619,7 @@
           <a:lstStyle xmlns:a="http://schemas.openxmlformats.org/drawingml/2006/main"/>
           <a:p xmlns:a="http://schemas.openxmlformats.org/drawingml/2006/main">
             <a:pPr>
+              <a:buNone/>
               <a:defRPr sz="2250" b="0">
                 <a:solidFill>
                   <a:srgbClr val="B7EDDB"/>
@@ -10635,6 +10677,7 @@
           <a:lstStyle xmlns:a="http://schemas.openxmlformats.org/drawingml/2006/main"/>
           <a:p xmlns:a="http://schemas.openxmlformats.org/drawingml/2006/main">
             <a:pPr>
+              <a:buNone/>
               <a:defRPr sz="2250" b="0">
                 <a:solidFill>
                   <a:srgbClr val="B7EDDB"/>
@@ -10692,6 +10735,7 @@
           <a:lstStyle xmlns:a="http://schemas.openxmlformats.org/drawingml/2006/main"/>
           <a:p xmlns:a="http://schemas.openxmlformats.org/drawingml/2006/main">
             <a:pPr>
+              <a:buNone/>
               <a:defRPr sz="2250" b="0">
                 <a:solidFill>
                   <a:srgbClr val="B7EDDB"/>
@@ -10749,6 +10793,7 @@
           <a:lstStyle xmlns:a="http://schemas.openxmlformats.org/drawingml/2006/main"/>
           <a:p xmlns:a="http://schemas.openxmlformats.org/drawingml/2006/main">
             <a:pPr>
+              <a:buNone/>
               <a:defRPr sz="2250" b="0">
                 <a:solidFill>
                   <a:srgbClr val="B7EDDB"/>
@@ -10806,6 +10851,7 @@
           <a:lstStyle xmlns:a="http://schemas.openxmlformats.org/drawingml/2006/main"/>
           <a:p xmlns:a="http://schemas.openxmlformats.org/drawingml/2006/main">
             <a:pPr>
+              <a:buNone/>
               <a:defRPr sz="2250" b="0">
                 <a:solidFill>
                   <a:srgbClr val="B7EDDB"/>
@@ -10863,6 +10909,7 @@
           <a:lstStyle xmlns:a="http://schemas.openxmlformats.org/drawingml/2006/main"/>
           <a:p xmlns:a="http://schemas.openxmlformats.org/drawingml/2006/main">
             <a:pPr>
+              <a:buNone/>
               <a:defRPr sz="2250" b="0">
                 <a:solidFill>
                   <a:srgbClr val="B7EDDB"/>
@@ -10920,6 +10967,7 @@
           <a:lstStyle xmlns:a="http://schemas.openxmlformats.org/drawingml/2006/main"/>
           <a:p xmlns:a="http://schemas.openxmlformats.org/drawingml/2006/main">
             <a:pPr>
+              <a:buNone/>
               <a:defRPr sz="2250" b="0">
                 <a:solidFill>
                   <a:srgbClr val="B7EDDB"/>
@@ -10977,6 +11025,7 @@
           <a:lstStyle xmlns:a="http://schemas.openxmlformats.org/drawingml/2006/main"/>
           <a:p xmlns:a="http://schemas.openxmlformats.org/drawingml/2006/main">
             <a:pPr>
+              <a:buNone/>
               <a:defRPr sz="2250" b="0">
                 <a:solidFill>
                   <a:srgbClr val="B7EDDB"/>
@@ -11034,6 +11083,7 @@
           <a:lstStyle xmlns:a="http://schemas.openxmlformats.org/drawingml/2006/main"/>
           <a:p xmlns:a="http://schemas.openxmlformats.org/drawingml/2006/main">
             <a:pPr>
+              <a:buNone/>
               <a:defRPr sz="2250" b="0">
                 <a:solidFill>
                   <a:srgbClr val="B7EDDB"/>
@@ -11091,6 +11141,7 @@
           <a:lstStyle xmlns:a="http://schemas.openxmlformats.org/drawingml/2006/main"/>
           <a:p xmlns:a="http://schemas.openxmlformats.org/drawingml/2006/main">
             <a:pPr>
+              <a:buNone/>
               <a:defRPr sz="2025" b="0">
                 <a:solidFill>
                   <a:srgbClr val="A8C6C4"/>
@@ -11889,6 +11940,7 @@
           <a:lstStyle xmlns:a="http://schemas.openxmlformats.org/drawingml/2006/main"/>
           <a:p xmlns:a="http://schemas.openxmlformats.org/drawingml/2006/main">
             <a:pPr>
+              <a:buNone/>
               <a:defRPr sz="2100" b="0">
                 <a:solidFill>
                   <a:srgbClr val="EAF1EF"/>
@@ -11946,6 +11998,7 @@
           <a:lstStyle xmlns:a="http://schemas.openxmlformats.org/drawingml/2006/main"/>
           <a:p xmlns:a="http://schemas.openxmlformats.org/drawingml/2006/main">
             <a:pPr>
+              <a:buNone/>
               <a:defRPr sz="2100" b="0">
                 <a:solidFill>
                   <a:srgbClr val="B7EDDB"/>
@@ -12003,6 +12056,7 @@
           <a:lstStyle xmlns:a="http://schemas.openxmlformats.org/drawingml/2006/main"/>
           <a:p xmlns:a="http://schemas.openxmlformats.org/drawingml/2006/main">
             <a:pPr>
+              <a:buNone/>
               <a:defRPr sz="2100" b="0">
                 <a:solidFill>
                   <a:srgbClr val="B7EDDB"/>
@@ -12060,6 +12114,7 @@
           <a:lstStyle xmlns:a="http://schemas.openxmlformats.org/drawingml/2006/main"/>
           <a:p xmlns:a="http://schemas.openxmlformats.org/drawingml/2006/main">
             <a:pPr>
+              <a:buNone/>
               <a:defRPr sz="2100" b="0">
                 <a:solidFill>
                   <a:srgbClr val="B7EDDB"/>
@@ -12117,6 +12172,7 @@
           <a:lstStyle xmlns:a="http://schemas.openxmlformats.org/drawingml/2006/main"/>
           <a:p xmlns:a="http://schemas.openxmlformats.org/drawingml/2006/main">
             <a:pPr>
+              <a:buNone/>
               <a:defRPr sz="2100" b="0">
                 <a:solidFill>
                   <a:srgbClr val="B7EDDB"/>
@@ -12174,6 +12230,7 @@
           <a:lstStyle xmlns:a="http://schemas.openxmlformats.org/drawingml/2006/main"/>
           <a:p xmlns:a="http://schemas.openxmlformats.org/drawingml/2006/main">
             <a:pPr>
+              <a:buNone/>
               <a:defRPr sz="2100" b="0">
                 <a:solidFill>
                   <a:srgbClr val="B7EDDB"/>
@@ -12231,6 +12288,7 @@
           <a:lstStyle xmlns:a="http://schemas.openxmlformats.org/drawingml/2006/main"/>
           <a:p xmlns:a="http://schemas.openxmlformats.org/drawingml/2006/main">
             <a:pPr>
+              <a:buNone/>
               <a:defRPr sz="2100" b="0">
                 <a:solidFill>
                   <a:srgbClr val="B7EDDB"/>
@@ -12288,6 +12346,7 @@
           <a:lstStyle xmlns:a="http://schemas.openxmlformats.org/drawingml/2006/main"/>
           <a:p xmlns:a="http://schemas.openxmlformats.org/drawingml/2006/main">
             <a:pPr>
+              <a:buNone/>
               <a:defRPr sz="2100" b="0">
                 <a:solidFill>
                   <a:srgbClr val="B7EDDB"/>
@@ -12345,6 +12404,7 @@
           <a:lstStyle xmlns:a="http://schemas.openxmlformats.org/drawingml/2006/main"/>
           <a:p xmlns:a="http://schemas.openxmlformats.org/drawingml/2006/main">
             <a:pPr>
+              <a:buNone/>
               <a:defRPr sz="2100" b="0">
                 <a:solidFill>
                   <a:srgbClr val="B7EDDB"/>
@@ -12402,6 +12462,7 @@
           <a:lstStyle xmlns:a="http://schemas.openxmlformats.org/drawingml/2006/main"/>
           <a:p xmlns:a="http://schemas.openxmlformats.org/drawingml/2006/main">
             <a:pPr>
+              <a:buNone/>
               <a:defRPr sz="2100" b="0">
                 <a:solidFill>
                   <a:srgbClr val="B7EDDB"/>
@@ -12459,6 +12520,7 @@
           <a:lstStyle xmlns:a="http://schemas.openxmlformats.org/drawingml/2006/main"/>
           <a:p xmlns:a="http://schemas.openxmlformats.org/drawingml/2006/main">
             <a:pPr>
+              <a:buNone/>
               <a:defRPr sz="2100" b="0">
                 <a:solidFill>
                   <a:srgbClr val="B7EDDB"/>
@@ -12516,6 +12578,7 @@
           <a:lstStyle xmlns:a="http://schemas.openxmlformats.org/drawingml/2006/main"/>
           <a:p xmlns:a="http://schemas.openxmlformats.org/drawingml/2006/main">
             <a:pPr>
+              <a:buNone/>
               <a:defRPr sz="2100" b="0">
                 <a:solidFill>
                   <a:srgbClr val="B7EDDB"/>
@@ -12573,6 +12636,7 @@
           <a:lstStyle xmlns:a="http://schemas.openxmlformats.org/drawingml/2006/main"/>
           <a:p xmlns:a="http://schemas.openxmlformats.org/drawingml/2006/main">
             <a:pPr>
+              <a:buNone/>
               <a:defRPr sz="2100" b="0">
                 <a:solidFill>
                   <a:srgbClr val="B7EDDB"/>
@@ -12630,6 +12694,7 @@
           <a:lstStyle xmlns:a="http://schemas.openxmlformats.org/drawingml/2006/main"/>
           <a:p xmlns:a="http://schemas.openxmlformats.org/drawingml/2006/main">
             <a:pPr>
+              <a:buNone/>
               <a:defRPr sz="2100" b="0">
                 <a:solidFill>
                   <a:srgbClr val="B7EDDB"/>
@@ -12687,6 +12752,7 @@
           <a:lstStyle xmlns:a="http://schemas.openxmlformats.org/drawingml/2006/main"/>
           <a:p xmlns:a="http://schemas.openxmlformats.org/drawingml/2006/main">
             <a:pPr>
+              <a:buNone/>
               <a:defRPr sz="2100" b="0">
                 <a:solidFill>
                   <a:srgbClr val="B7EDDB"/>
@@ -12744,6 +12810,7 @@
           <a:lstStyle xmlns:a="http://schemas.openxmlformats.org/drawingml/2006/main"/>
           <a:p xmlns:a="http://schemas.openxmlformats.org/drawingml/2006/main">
             <a:pPr>
+              <a:buNone/>
               <a:defRPr sz="2100" b="0">
                 <a:solidFill>
                   <a:srgbClr val="B7EDDB"/>
@@ -12801,6 +12868,7 @@
           <a:lstStyle xmlns:a="http://schemas.openxmlformats.org/drawingml/2006/main"/>
           <a:p xmlns:a="http://schemas.openxmlformats.org/drawingml/2006/main">
             <a:pPr>
+              <a:buNone/>
               <a:defRPr sz="2100" b="0">
                 <a:solidFill>
                   <a:srgbClr val="B7EDDB"/>
@@ -12858,6 +12926,7 @@
           <a:lstStyle xmlns:a="http://schemas.openxmlformats.org/drawingml/2006/main"/>
           <a:p xmlns:a="http://schemas.openxmlformats.org/drawingml/2006/main">
             <a:pPr>
+              <a:buNone/>
               <a:defRPr sz="1950" b="0">
                 <a:solidFill>
                   <a:srgbClr val="A8C6C4"/>
@@ -12915,6 +12984,7 @@
           <a:lstStyle xmlns:a="http://schemas.openxmlformats.org/drawingml/2006/main"/>
           <a:p xmlns:a="http://schemas.openxmlformats.org/drawingml/2006/main">
             <a:pPr>
+              <a:buNone/>
               <a:defRPr sz="1950" b="0">
                 <a:solidFill>
                   <a:srgbClr val="A8C6C4"/>
@@ -13117,6 +13187,7 @@
           <a:lstStyle xmlns:a="http://schemas.openxmlformats.org/drawingml/2006/main"/>
           <a:p xmlns:a="http://schemas.openxmlformats.org/drawingml/2006/main">
             <a:pPr>
+              <a:buNone/>
               <a:defRPr sz="2100" b="0">
                 <a:solidFill>
                   <a:srgbClr val="506C78"/>
@@ -13174,6 +13245,7 @@
           <a:lstStyle xmlns:a="http://schemas.openxmlformats.org/drawingml/2006/main"/>
           <a:p xmlns:a="http://schemas.openxmlformats.org/drawingml/2006/main">
             <a:pPr>
+              <a:buNone/>
               <a:defRPr sz="2250" b="0">
                 <a:solidFill>
                   <a:srgbClr val="087F75"/>
@@ -13231,6 +13303,7 @@
           <a:lstStyle xmlns:a="http://schemas.openxmlformats.org/drawingml/2006/main"/>
           <a:p xmlns:a="http://schemas.openxmlformats.org/drawingml/2006/main">
             <a:pPr>
+              <a:buNone/>
               <a:defRPr sz="2250" b="0">
                 <a:solidFill>
                   <a:srgbClr val="087F75"/>
@@ -13249,7 +13322,29 @@
                 <a:ea typeface="Menlo"/>
                 <a:cs typeface="Menlo"/>
               </a:rPr>
-              <a:t>srun --cpu-bind=cores ./build/reg_reuse 64 128 256 512 1024 2048 \</a:t>
+              <a:t>srun --cpu-bind=cores ./build/reg_reuse </a:t>
+            </a:r>
+            <a:r>
+              <a:rPr sz="2250" b="0">
+                <a:solidFill>
+                  <a:srgbClr val="087F75"/>
+                </a:solidFill>
+                <a:latin typeface="Menlo"/>
+                <a:ea typeface="Menlo"/>
+                <a:cs typeface="Menlo"/>
+              </a:rPr>
+              <a:t>66 126 258 510 1026 2046</a:t>
+            </a:r>
+            <a:r>
+              <a:rPr sz="2250" b="0">
+                <a:solidFill>
+                  <a:srgbClr val="087F75"/>
+                </a:solidFill>
+                <a:latin typeface="Menlo"/>
+                <a:ea typeface="Menlo"/>
+                <a:cs typeface="Menlo"/>
+              </a:rPr>
+              <a:t> \</a:t>
             </a:r>
           </a:p>
         </p:txBody>
@@ -13288,6 +13383,7 @@
           <a:lstStyle xmlns:a="http://schemas.openxmlformats.org/drawingml/2006/main"/>
           <a:p xmlns:a="http://schemas.openxmlformats.org/drawingml/2006/main">
             <a:pPr>
+              <a:buNone/>
               <a:defRPr sz="2250" b="0">
                 <a:solidFill>
                   <a:srgbClr val="087F75"/>
@@ -13345,6 +13441,7 @@
           <a:lstStyle xmlns:a="http://schemas.openxmlformats.org/drawingml/2006/main"/>
           <a:p xmlns:a="http://schemas.openxmlformats.org/drawingml/2006/main">
             <a:pPr>
+              <a:buNone/>
               <a:defRPr sz="2250" b="0">
                 <a:solidFill>
                   <a:srgbClr val="087F75"/>
@@ -13402,6 +13499,7 @@
           <a:lstStyle xmlns:a="http://schemas.openxmlformats.org/drawingml/2006/main"/>
           <a:p xmlns:a="http://schemas.openxmlformats.org/drawingml/2006/main">
             <a:pPr>
+              <a:buNone/>
               <a:defRPr sz="2250" b="0">
                 <a:solidFill>
                   <a:srgbClr val="087F75"/>
@@ -13459,6 +13557,7 @@
           <a:lstStyle xmlns:a="http://schemas.openxmlformats.org/drawingml/2006/main"/>
           <a:p xmlns:a="http://schemas.openxmlformats.org/drawingml/2006/main">
             <a:pPr>
+              <a:buNone/>
               <a:defRPr sz="2175" b="0">
                 <a:solidFill>
                   <a:srgbClr val="172D36"/>
@@ -13516,9 +13615,10 @@
           <a:lstStyle xmlns:a="http://schemas.openxmlformats.org/drawingml/2006/main"/>
           <a:p xmlns:a="http://schemas.openxmlformats.org/drawingml/2006/main">
             <a:pPr>
+              <a:buNone/>
               <a:defRPr sz="2100" b="1">
                 <a:solidFill>
-                  <a:srgbClr val="A04228"/>
+                  <a:srgbClr val="172D36"/>
                 </a:solidFill>
                 <a:latin typeface="Hiragino Sans GB"/>
                 <a:ea typeface="Hiragino Sans GB"/>
@@ -13528,13 +13628,13 @@
             <a:r>
               <a:rPr sz="2100" b="1">
                 <a:solidFill>
-                  <a:srgbClr val="A04228"/>
-                </a:solidFill>
-                <a:latin typeface="Hiragino Sans GB"/>
-                <a:ea typeface="Hiragino Sans GB"/>
-                <a:cs typeface="Hiragino Sans GB"/>
-              </a:rPr>
-              <a:t>寄存器规模待统一：§6.4 的 6 整除条件与 §8.2 的规模冲突</a:t>
+                  <a:srgbClr val="172D36"/>
+                </a:solidFill>
+                <a:latin typeface="Hiragino Sans GB"/>
+                <a:ea typeface="Hiragino Sans GB"/>
+                <a:cs typeface="Hiragino Sans GB"/>
+              </a:rPr>
+              <a:t>寄存器实验：n 必须能被 6 整除，使用上方指定的六个规模</a:t>
             </a:r>
           </a:p>
         </p:txBody>
@@ -13573,9 +13673,10 @@
           <a:lstStyle xmlns:a="http://schemas.openxmlformats.org/drawingml/2006/main"/>
           <a:p xmlns:a="http://schemas.openxmlformats.org/drawingml/2006/main">
             <a:pPr>
+              <a:buNone/>
               <a:defRPr sz="2025" b="0">
                 <a:solidFill>
-                  <a:srgbClr val="A04228"/>
+                  <a:srgbClr val="506C78"/>
                 </a:solidFill>
                 <a:latin typeface="Hiragino Sans GB"/>
                 <a:ea typeface="Hiragino Sans GB"/>
@@ -13585,13 +13686,13 @@
             <a:r>
               <a:rPr sz="2025" b="0">
                 <a:solidFill>
-                  <a:srgbClr val="A04228"/>
-                </a:solidFill>
-                <a:latin typeface="Hiragino Sans GB"/>
-                <a:ea typeface="Hiragino Sans GB"/>
-                <a:cs typeface="Hiragino Sans GB"/>
-              </a:rPr>
-              <a:t>当前参考 dgemm3 在 n=64 时 INVALID；确认题面后再执行寄存器实验</a:t>
+                  <a:srgbClr val="506C78"/>
+                </a:solidFill>
+                <a:latin typeface="Hiragino Sans GB"/>
+                <a:ea typeface="Hiragino Sans GB"/>
+                <a:cs typeface="Hiragino Sans GB"/>
+              </a:rPr>
+              <a:t>循环次序实验：n=2048、b=64；两项实验分别记录结果</a:t>
             </a:r>
           </a:p>
         </p:txBody>
@@ -13775,6 +13876,7 @@
           <a:lstStyle xmlns:a="http://schemas.openxmlformats.org/drawingml/2006/main"/>
           <a:p xmlns:a="http://schemas.openxmlformats.org/drawingml/2006/main">
             <a:pPr>
+              <a:buNone/>
               <a:defRPr sz="2100" b="0">
                 <a:solidFill>
                   <a:srgbClr val="506C78"/>
@@ -13832,6 +13934,7 @@
           <a:lstStyle xmlns:a="http://schemas.openxmlformats.org/drawingml/2006/main"/>
           <a:p xmlns:a="http://schemas.openxmlformats.org/drawingml/2006/main">
             <a:pPr>
+              <a:buNone/>
               <a:defRPr sz="2250" b="0">
                 <a:solidFill>
                   <a:srgbClr val="087F75"/>
@@ -13889,6 +13992,7 @@
           <a:lstStyle xmlns:a="http://schemas.openxmlformats.org/drawingml/2006/main"/>
           <a:p xmlns:a="http://schemas.openxmlformats.org/drawingml/2006/main">
             <a:pPr>
+              <a:buNone/>
               <a:defRPr sz="2250" b="0">
                 <a:solidFill>
                   <a:srgbClr val="087F75"/>
@@ -13946,6 +14050,7 @@
           <a:lstStyle xmlns:a="http://schemas.openxmlformats.org/drawingml/2006/main"/>
           <a:p xmlns:a="http://schemas.openxmlformats.org/drawingml/2006/main">
             <a:pPr>
+              <a:buNone/>
               <a:defRPr sz="2250" b="0">
                 <a:solidFill>
                   <a:srgbClr val="087F75"/>
@@ -14003,6 +14108,7 @@
           <a:lstStyle xmlns:a="http://schemas.openxmlformats.org/drawingml/2006/main"/>
           <a:p xmlns:a="http://schemas.openxmlformats.org/drawingml/2006/main">
             <a:pPr>
+              <a:buNone/>
               <a:defRPr sz="2250" b="0">
                 <a:solidFill>
                   <a:srgbClr val="087F75"/>
@@ -14060,6 +14166,7 @@
           <a:lstStyle xmlns:a="http://schemas.openxmlformats.org/drawingml/2006/main"/>
           <a:p xmlns:a="http://schemas.openxmlformats.org/drawingml/2006/main">
             <a:pPr>
+              <a:buNone/>
               <a:defRPr sz="2250" b="0">
                 <a:solidFill>
                   <a:srgbClr val="087F75"/>
@@ -14117,6 +14224,7 @@
           <a:lstStyle xmlns:a="http://schemas.openxmlformats.org/drawingml/2006/main"/>
           <a:p xmlns:a="http://schemas.openxmlformats.org/drawingml/2006/main">
             <a:pPr>
+              <a:buNone/>
               <a:defRPr sz="2250" b="0">
                 <a:solidFill>
                   <a:srgbClr val="087F75"/>
@@ -14174,6 +14282,7 @@
           <a:lstStyle xmlns:a="http://schemas.openxmlformats.org/drawingml/2006/main"/>
           <a:p xmlns:a="http://schemas.openxmlformats.org/drawingml/2006/main">
             <a:pPr>
+              <a:buNone/>
               <a:defRPr sz="2325" b="0">
                 <a:solidFill>
                   <a:srgbClr val="172D36"/>
@@ -14231,6 +14340,7 @@
           <a:lstStyle xmlns:a="http://schemas.openxmlformats.org/drawingml/2006/main"/>
           <a:p xmlns:a="http://schemas.openxmlformats.org/drawingml/2006/main">
             <a:pPr>
+              <a:buNone/>
               <a:defRPr sz="2025" b="0">
                 <a:solidFill>
                   <a:srgbClr val="506C78"/>
@@ -14433,6 +14543,7 @@
           <a:lstStyle xmlns:a="http://schemas.openxmlformats.org/drawingml/2006/main"/>
           <a:p xmlns:a="http://schemas.openxmlformats.org/drawingml/2006/main">
             <a:pPr>
+              <a:buNone/>
               <a:defRPr sz="2100" b="0">
                 <a:solidFill>
                   <a:srgbClr val="506C78"/>
@@ -14490,6 +14601,7 @@
           <a:lstStyle xmlns:a="http://schemas.openxmlformats.org/drawingml/2006/main"/>
           <a:p xmlns:a="http://schemas.openxmlformats.org/drawingml/2006/main">
             <a:pPr>
+              <a:buNone/>
               <a:defRPr sz="2250" b="0">
                 <a:solidFill>
                   <a:srgbClr val="087F75"/>
@@ -14547,6 +14659,7 @@
           <a:lstStyle xmlns:a="http://schemas.openxmlformats.org/drawingml/2006/main"/>
           <a:p xmlns:a="http://schemas.openxmlformats.org/drawingml/2006/main">
             <a:pPr>
+              <a:buNone/>
               <a:defRPr sz="2250" b="0">
                 <a:solidFill>
                   <a:srgbClr val="087F75"/>
@@ -14604,6 +14717,7 @@
           <a:lstStyle xmlns:a="http://schemas.openxmlformats.org/drawingml/2006/main"/>
           <a:p xmlns:a="http://schemas.openxmlformats.org/drawingml/2006/main">
             <a:pPr>
+              <a:buNone/>
               <a:defRPr sz="2250" b="0">
                 <a:solidFill>
                   <a:srgbClr val="087F75"/>
@@ -14661,6 +14775,7 @@
           <a:lstStyle xmlns:a="http://schemas.openxmlformats.org/drawingml/2006/main"/>
           <a:p xmlns:a="http://schemas.openxmlformats.org/drawingml/2006/main">
             <a:pPr>
+              <a:buNone/>
               <a:defRPr sz="2250" b="0">
                 <a:solidFill>
                   <a:srgbClr val="087F75"/>
@@ -14718,6 +14833,7 @@
           <a:lstStyle xmlns:a="http://schemas.openxmlformats.org/drawingml/2006/main"/>
           <a:p xmlns:a="http://schemas.openxmlformats.org/drawingml/2006/main">
             <a:pPr>
+              <a:buNone/>
               <a:defRPr sz="2250" b="0">
                 <a:solidFill>
                   <a:srgbClr val="087F75"/>
@@ -14775,6 +14891,7 @@
           <a:lstStyle xmlns:a="http://schemas.openxmlformats.org/drawingml/2006/main"/>
           <a:p xmlns:a="http://schemas.openxmlformats.org/drawingml/2006/main">
             <a:pPr>
+              <a:buNone/>
               <a:defRPr sz="2250" b="0">
                 <a:solidFill>
                   <a:srgbClr val="087F75"/>
@@ -14832,6 +14949,7 @@
           <a:lstStyle xmlns:a="http://schemas.openxmlformats.org/drawingml/2006/main"/>
           <a:p xmlns:a="http://schemas.openxmlformats.org/drawingml/2006/main">
             <a:pPr>
+              <a:buNone/>
               <a:defRPr sz="2250" b="0">
                 <a:solidFill>
                   <a:srgbClr val="087F75"/>
@@ -14889,6 +15007,7 @@
           <a:lstStyle xmlns:a="http://schemas.openxmlformats.org/drawingml/2006/main"/>
           <a:p xmlns:a="http://schemas.openxmlformats.org/drawingml/2006/main">
             <a:pPr>
+              <a:buNone/>
               <a:defRPr sz="2250" b="0">
                 <a:solidFill>
                   <a:srgbClr val="172D36"/>
@@ -14946,6 +15065,7 @@
           <a:lstStyle xmlns:a="http://schemas.openxmlformats.org/drawingml/2006/main"/>
           <a:p xmlns:a="http://schemas.openxmlformats.org/drawingml/2006/main">
             <a:pPr>
+              <a:buNone/>
               <a:defRPr sz="2025" b="0">
                 <a:solidFill>
                   <a:srgbClr val="506C78"/>
@@ -15148,6 +15268,7 @@
           <a:lstStyle xmlns:a="http://schemas.openxmlformats.org/drawingml/2006/main"/>
           <a:p xmlns:a="http://schemas.openxmlformats.org/drawingml/2006/main">
             <a:pPr>
+              <a:buNone/>
               <a:defRPr sz="2100" b="0">
                 <a:solidFill>
                   <a:srgbClr val="506C78"/>
@@ -15205,6 +15326,7 @@
           <a:lstStyle xmlns:a="http://schemas.openxmlformats.org/drawingml/2006/main"/>
           <a:p xmlns:a="http://schemas.openxmlformats.org/drawingml/2006/main">
             <a:pPr>
+              <a:buNone/>
               <a:defRPr sz="2250" b="0">
                 <a:solidFill>
                   <a:srgbClr val="087F75"/>
@@ -15262,6 +15384,7 @@
           <a:lstStyle xmlns:a="http://schemas.openxmlformats.org/drawingml/2006/main"/>
           <a:p xmlns:a="http://schemas.openxmlformats.org/drawingml/2006/main">
             <a:pPr>
+              <a:buNone/>
               <a:defRPr sz="2250" b="0">
                 <a:solidFill>
                   <a:srgbClr val="087F75"/>
@@ -15319,6 +15442,7 @@
           <a:lstStyle xmlns:a="http://schemas.openxmlformats.org/drawingml/2006/main"/>
           <a:p xmlns:a="http://schemas.openxmlformats.org/drawingml/2006/main">
             <a:pPr>
+              <a:buNone/>
               <a:defRPr sz="2250" b="0">
                 <a:solidFill>
                   <a:srgbClr val="087F75"/>
@@ -15376,6 +15500,7 @@
           <a:lstStyle xmlns:a="http://schemas.openxmlformats.org/drawingml/2006/main"/>
           <a:p xmlns:a="http://schemas.openxmlformats.org/drawingml/2006/main">
             <a:pPr>
+              <a:buNone/>
               <a:defRPr sz="2250" b="0">
                 <a:solidFill>
                   <a:srgbClr val="087F75"/>
@@ -15433,6 +15558,7 @@
           <a:lstStyle xmlns:a="http://schemas.openxmlformats.org/drawingml/2006/main"/>
           <a:p xmlns:a="http://schemas.openxmlformats.org/drawingml/2006/main">
             <a:pPr>
+              <a:buNone/>
               <a:defRPr sz="2400" b="0">
                 <a:solidFill>
                   <a:srgbClr val="172D36"/>
@@ -15490,6 +15616,7 @@
           <a:lstStyle xmlns:a="http://schemas.openxmlformats.org/drawingml/2006/main"/>
           <a:p xmlns:a="http://schemas.openxmlformats.org/drawingml/2006/main">
             <a:pPr>
+              <a:buNone/>
               <a:defRPr sz="2175" b="0">
                 <a:solidFill>
                   <a:srgbClr val="172D36"/>
@@ -15547,6 +15674,7 @@
           <a:lstStyle xmlns:a="http://schemas.openxmlformats.org/drawingml/2006/main"/>
           <a:p xmlns:a="http://schemas.openxmlformats.org/drawingml/2006/main">
             <a:pPr>
+              <a:buNone/>
               <a:defRPr sz="2025" b="0">
                 <a:solidFill>
                   <a:srgbClr val="506C78"/>
@@ -15749,6 +15877,7 @@
           <a:lstStyle xmlns:a="http://schemas.openxmlformats.org/drawingml/2006/main"/>
           <a:p xmlns:a="http://schemas.openxmlformats.org/drawingml/2006/main">
             <a:pPr>
+              <a:buNone/>
               <a:defRPr sz="2100" b="0">
                 <a:solidFill>
                   <a:srgbClr val="506C78"/>
@@ -15806,6 +15935,7 @@
           <a:lstStyle xmlns:a="http://schemas.openxmlformats.org/drawingml/2006/main"/>
           <a:p xmlns:a="http://schemas.openxmlformats.org/drawingml/2006/main">
             <a:pPr>
+              <a:buNone/>
               <a:defRPr sz="2250" b="0">
                 <a:solidFill>
                   <a:srgbClr val="087F75"/>
@@ -15863,6 +15993,7 @@
           <a:lstStyle xmlns:a="http://schemas.openxmlformats.org/drawingml/2006/main"/>
           <a:p xmlns:a="http://schemas.openxmlformats.org/drawingml/2006/main">
             <a:pPr>
+              <a:buNone/>
               <a:defRPr sz="2250" b="0">
                 <a:solidFill>
                   <a:srgbClr val="087F75"/>
@@ -15920,6 +16051,7 @@
           <a:lstStyle xmlns:a="http://schemas.openxmlformats.org/drawingml/2006/main"/>
           <a:p xmlns:a="http://schemas.openxmlformats.org/drawingml/2006/main">
             <a:pPr>
+              <a:buNone/>
               <a:defRPr sz="2250" b="0">
                 <a:solidFill>
                   <a:srgbClr val="087F75"/>
@@ -15977,6 +16109,7 @@
           <a:lstStyle xmlns:a="http://schemas.openxmlformats.org/drawingml/2006/main"/>
           <a:p xmlns:a="http://schemas.openxmlformats.org/drawingml/2006/main">
             <a:pPr>
+              <a:buNone/>
               <a:defRPr sz="2250" b="0">
                 <a:solidFill>
                   <a:srgbClr val="087F75"/>
@@ -16034,6 +16167,7 @@
           <a:lstStyle xmlns:a="http://schemas.openxmlformats.org/drawingml/2006/main"/>
           <a:p xmlns:a="http://schemas.openxmlformats.org/drawingml/2006/main">
             <a:pPr>
+              <a:buNone/>
               <a:defRPr sz="2250" b="0">
                 <a:solidFill>
                   <a:srgbClr val="087F75"/>
@@ -16091,6 +16225,7 @@
           <a:lstStyle xmlns:a="http://schemas.openxmlformats.org/drawingml/2006/main"/>
           <a:p xmlns:a="http://schemas.openxmlformats.org/drawingml/2006/main">
             <a:pPr>
+              <a:buNone/>
               <a:defRPr sz="2250" b="0">
                 <a:solidFill>
                   <a:srgbClr val="087F75"/>
@@ -16148,6 +16283,7 @@
           <a:lstStyle xmlns:a="http://schemas.openxmlformats.org/drawingml/2006/main"/>
           <a:p xmlns:a="http://schemas.openxmlformats.org/drawingml/2006/main">
             <a:pPr>
+              <a:buNone/>
               <a:defRPr sz="2250" b="0">
                 <a:solidFill>
                   <a:srgbClr val="172D36"/>
@@ -16205,6 +16341,7 @@
           <a:lstStyle xmlns:a="http://schemas.openxmlformats.org/drawingml/2006/main"/>
           <a:p xmlns:a="http://schemas.openxmlformats.org/drawingml/2006/main">
             <a:pPr>
+              <a:buNone/>
               <a:defRPr sz="2025" b="0">
                 <a:solidFill>
                   <a:srgbClr val="506C78"/>
@@ -16407,6 +16544,7 @@
           <a:lstStyle xmlns:a="http://schemas.openxmlformats.org/drawingml/2006/main"/>
           <a:p xmlns:a="http://schemas.openxmlformats.org/drawingml/2006/main">
             <a:pPr>
+              <a:buNone/>
               <a:defRPr sz="2100" b="0">
                 <a:solidFill>
                   <a:srgbClr val="506C78"/>
@@ -16464,6 +16602,7 @@
           <a:lstStyle xmlns:a="http://schemas.openxmlformats.org/drawingml/2006/main"/>
           <a:p xmlns:a="http://schemas.openxmlformats.org/drawingml/2006/main">
             <a:pPr>
+              <a:buNone/>
               <a:defRPr sz="2100" b="0">
                 <a:solidFill>
                   <a:srgbClr val="087F75"/>
@@ -16521,6 +16660,7 @@
           <a:lstStyle xmlns:a="http://schemas.openxmlformats.org/drawingml/2006/main"/>
           <a:p xmlns:a="http://schemas.openxmlformats.org/drawingml/2006/main">
             <a:pPr>
+              <a:buNone/>
               <a:defRPr sz="2100" b="0">
                 <a:solidFill>
                   <a:srgbClr val="087F75"/>
@@ -16578,6 +16718,7 @@
           <a:lstStyle xmlns:a="http://schemas.openxmlformats.org/drawingml/2006/main"/>
           <a:p xmlns:a="http://schemas.openxmlformats.org/drawingml/2006/main">
             <a:pPr>
+              <a:buNone/>
               <a:defRPr sz="2100" b="0">
                 <a:solidFill>
                   <a:srgbClr val="087F75"/>
@@ -16635,6 +16776,7 @@
           <a:lstStyle xmlns:a="http://schemas.openxmlformats.org/drawingml/2006/main"/>
           <a:p xmlns:a="http://schemas.openxmlformats.org/drawingml/2006/main">
             <a:pPr>
+              <a:buNone/>
               <a:defRPr sz="2100" b="0">
                 <a:solidFill>
                   <a:srgbClr val="087F75"/>
@@ -16692,6 +16834,7 @@
           <a:lstStyle xmlns:a="http://schemas.openxmlformats.org/drawingml/2006/main"/>
           <a:p xmlns:a="http://schemas.openxmlformats.org/drawingml/2006/main">
             <a:pPr>
+              <a:buNone/>
               <a:defRPr sz="2100" b="0">
                 <a:solidFill>
                   <a:srgbClr val="087F75"/>
@@ -16749,6 +16892,7 @@
           <a:lstStyle xmlns:a="http://schemas.openxmlformats.org/drawingml/2006/main"/>
           <a:p xmlns:a="http://schemas.openxmlformats.org/drawingml/2006/main">
             <a:pPr>
+              <a:buNone/>
               <a:defRPr sz="2100" b="0">
                 <a:solidFill>
                   <a:srgbClr val="087F75"/>
@@ -16806,6 +16950,7 @@
           <a:lstStyle xmlns:a="http://schemas.openxmlformats.org/drawingml/2006/main"/>
           <a:p xmlns:a="http://schemas.openxmlformats.org/drawingml/2006/main">
             <a:pPr>
+              <a:buNone/>
               <a:defRPr sz="2100" b="0">
                 <a:solidFill>
                   <a:srgbClr val="087F75"/>
@@ -16863,6 +17008,7 @@
           <a:lstStyle xmlns:a="http://schemas.openxmlformats.org/drawingml/2006/main"/>
           <a:p xmlns:a="http://schemas.openxmlformats.org/drawingml/2006/main">
             <a:pPr>
+              <a:buNone/>
               <a:defRPr sz="2100" b="0">
                 <a:solidFill>
                   <a:srgbClr val="087F75"/>
@@ -16920,6 +17066,7 @@
           <a:lstStyle xmlns:a="http://schemas.openxmlformats.org/drawingml/2006/main"/>
           <a:p xmlns:a="http://schemas.openxmlformats.org/drawingml/2006/main">
             <a:pPr>
+              <a:buNone/>
               <a:defRPr sz="2100" b="0">
                 <a:solidFill>
                   <a:srgbClr val="087F75"/>
@@ -16977,6 +17124,7 @@
           <a:lstStyle xmlns:a="http://schemas.openxmlformats.org/drawingml/2006/main"/>
           <a:p xmlns:a="http://schemas.openxmlformats.org/drawingml/2006/main">
             <a:pPr>
+              <a:buNone/>
               <a:defRPr sz="2100" b="0">
                 <a:solidFill>
                   <a:srgbClr val="087F75"/>
@@ -17034,6 +17182,7 @@
           <a:lstStyle xmlns:a="http://schemas.openxmlformats.org/drawingml/2006/main"/>
           <a:p xmlns:a="http://schemas.openxmlformats.org/drawingml/2006/main">
             <a:pPr>
+              <a:buNone/>
               <a:defRPr sz="2475" b="1">
                 <a:solidFill>
                   <a:srgbClr val="172D36"/>
@@ -17091,6 +17240,7 @@
           <a:lstStyle xmlns:a="http://schemas.openxmlformats.org/drawingml/2006/main"/>
           <a:p xmlns:a="http://schemas.openxmlformats.org/drawingml/2006/main">
             <a:pPr>
+              <a:buNone/>
               <a:defRPr sz="2175" b="0">
                 <a:solidFill>
                   <a:srgbClr val="172D36"/>
@@ -17148,6 +17298,7 @@
           <a:lstStyle xmlns:a="http://schemas.openxmlformats.org/drawingml/2006/main"/>
           <a:p xmlns:a="http://schemas.openxmlformats.org/drawingml/2006/main">
             <a:pPr>
+              <a:buNone/>
               <a:defRPr sz="2175" b="0">
                 <a:solidFill>
                   <a:srgbClr val="172D36"/>
@@ -17205,6 +17356,7 @@
           <a:lstStyle xmlns:a="http://schemas.openxmlformats.org/drawingml/2006/main"/>
           <a:p xmlns:a="http://schemas.openxmlformats.org/drawingml/2006/main">
             <a:pPr>
+              <a:buNone/>
               <a:defRPr sz="2175" b="0">
                 <a:solidFill>
                   <a:srgbClr val="172D36"/>
@@ -17262,6 +17414,7 @@
           <a:lstStyle xmlns:a="http://schemas.openxmlformats.org/drawingml/2006/main"/>
           <a:p xmlns:a="http://schemas.openxmlformats.org/drawingml/2006/main">
             <a:pPr>
+              <a:buNone/>
               <a:defRPr sz="2175" b="0">
                 <a:solidFill>
                   <a:srgbClr val="172D36"/>
@@ -17319,6 +17472,7 @@
           <a:lstStyle xmlns:a="http://schemas.openxmlformats.org/drawingml/2006/main"/>
           <a:p xmlns:a="http://schemas.openxmlformats.org/drawingml/2006/main">
             <a:pPr>
+              <a:buNone/>
               <a:defRPr sz="1950" b="0">
                 <a:solidFill>
                   <a:srgbClr val="506C78"/>
@@ -17521,6 +17675,7 @@
           <a:lstStyle xmlns:a="http://schemas.openxmlformats.org/drawingml/2006/main"/>
           <a:p xmlns:a="http://schemas.openxmlformats.org/drawingml/2006/main">
             <a:pPr>
+              <a:buNone/>
               <a:defRPr sz="2100" b="0">
                 <a:solidFill>
                   <a:srgbClr val="506C78"/>
@@ -17578,6 +17733,7 @@
           <a:lstStyle xmlns:a="http://schemas.openxmlformats.org/drawingml/2006/main"/>
           <a:p xmlns:a="http://schemas.openxmlformats.org/drawingml/2006/main">
             <a:pPr>
+              <a:buNone/>
               <a:defRPr sz="2550" b="0">
                 <a:solidFill>
                   <a:srgbClr val="087F75"/>
@@ -17635,6 +17791,7 @@
           <a:lstStyle xmlns:a="http://schemas.openxmlformats.org/drawingml/2006/main"/>
           <a:p xmlns:a="http://schemas.openxmlformats.org/drawingml/2006/main">
             <a:pPr>
+              <a:buNone/>
               <a:defRPr sz="2325" b="0">
                 <a:solidFill>
                   <a:srgbClr val="172D36"/>
@@ -17692,6 +17849,7 @@
           <a:lstStyle xmlns:a="http://schemas.openxmlformats.org/drawingml/2006/main"/>
           <a:p xmlns:a="http://schemas.openxmlformats.org/drawingml/2006/main">
             <a:pPr>
+              <a:buNone/>
               <a:defRPr sz="2250" b="0">
                 <a:solidFill>
                   <a:srgbClr val="172D36"/>
@@ -17749,6 +17907,7 @@
           <a:lstStyle xmlns:a="http://schemas.openxmlformats.org/drawingml/2006/main"/>
           <a:p xmlns:a="http://schemas.openxmlformats.org/drawingml/2006/main">
             <a:pPr>
+              <a:buNone/>
               <a:defRPr sz="2250" b="0">
                 <a:solidFill>
                   <a:srgbClr val="172D36"/>
@@ -17767,7 +17926,7 @@
                 <a:ea typeface="Hiragino Sans GB"/>
                 <a:cs typeface="Hiragino Sans GB"/>
               </a:rPr>
-              <a:t>寄存器：66、126、258、510、1026、2046</a:t>
+              <a:t>寄存器：66、126、258、510、1026、2046（与正式实验相同）</a:t>
             </a:r>
           </a:p>
         </p:txBody>
@@ -17806,6 +17965,7 @@
           <a:lstStyle xmlns:a="http://schemas.openxmlformats.org/drawingml/2006/main"/>
           <a:p xmlns:a="http://schemas.openxmlformats.org/drawingml/2006/main">
             <a:pPr>
+              <a:buNone/>
               <a:defRPr sz="2250" b="0">
                 <a:solidFill>
                   <a:srgbClr val="172D36"/>
@@ -17863,6 +18023,7 @@
           <a:lstStyle xmlns:a="http://schemas.openxmlformats.org/drawingml/2006/main"/>
           <a:p xmlns:a="http://schemas.openxmlformats.org/drawingml/2006/main">
             <a:pPr>
+              <a:buNone/>
               <a:defRPr sz="2325" b="0">
                 <a:solidFill>
                   <a:srgbClr val="172D36"/>
@@ -17920,6 +18081,7 @@
           <a:lstStyle xmlns:a="http://schemas.openxmlformats.org/drawingml/2006/main"/>
           <a:p xmlns:a="http://schemas.openxmlformats.org/drawingml/2006/main">
             <a:pPr>
+              <a:buNone/>
               <a:defRPr sz="2025" b="0">
                 <a:solidFill>
                   <a:srgbClr val="506C78"/>
@@ -18884,6 +19046,7 @@
           <a:lstStyle xmlns:a="http://schemas.openxmlformats.org/drawingml/2006/main"/>
           <a:p xmlns:a="http://schemas.openxmlformats.org/drawingml/2006/main">
             <a:pPr>
+              <a:buNone/>
               <a:defRPr sz="2175" b="0">
                 <a:solidFill>
                   <a:srgbClr val="EAF1EF"/>
@@ -18941,6 +19104,7 @@
           <a:lstStyle xmlns:a="http://schemas.openxmlformats.org/drawingml/2006/main"/>
           <a:p xmlns:a="http://schemas.openxmlformats.org/drawingml/2006/main">
             <a:pPr>
+              <a:buNone/>
               <a:defRPr sz="2100" b="0">
                 <a:solidFill>
                   <a:srgbClr val="B7EDDB"/>
@@ -18998,6 +19162,7 @@
           <a:lstStyle xmlns:a="http://schemas.openxmlformats.org/drawingml/2006/main"/>
           <a:p xmlns:a="http://schemas.openxmlformats.org/drawingml/2006/main">
             <a:pPr>
+              <a:buNone/>
               <a:defRPr sz="2100" b="0">
                 <a:solidFill>
                   <a:srgbClr val="B7EDDB"/>
@@ -19055,6 +19220,7 @@
           <a:lstStyle xmlns:a="http://schemas.openxmlformats.org/drawingml/2006/main"/>
           <a:p xmlns:a="http://schemas.openxmlformats.org/drawingml/2006/main">
             <a:pPr>
+              <a:buNone/>
               <a:defRPr sz="2100" b="0">
                 <a:solidFill>
                   <a:srgbClr val="B7EDDB"/>
@@ -19112,6 +19278,7 @@
           <a:lstStyle xmlns:a="http://schemas.openxmlformats.org/drawingml/2006/main"/>
           <a:p xmlns:a="http://schemas.openxmlformats.org/drawingml/2006/main">
             <a:pPr>
+              <a:buNone/>
               <a:defRPr sz="2100" b="0">
                 <a:solidFill>
                   <a:srgbClr val="EAF1EF"/>
@@ -19169,6 +19336,7 @@
           <a:lstStyle xmlns:a="http://schemas.openxmlformats.org/drawingml/2006/main"/>
           <a:p xmlns:a="http://schemas.openxmlformats.org/drawingml/2006/main">
             <a:pPr>
+              <a:buNone/>
               <a:defRPr sz="2100" b="0">
                 <a:solidFill>
                   <a:srgbClr val="EAF1EF"/>
@@ -19226,6 +19394,7 @@
           <a:lstStyle xmlns:a="http://schemas.openxmlformats.org/drawingml/2006/main"/>
           <a:p xmlns:a="http://schemas.openxmlformats.org/drawingml/2006/main">
             <a:pPr>
+              <a:buNone/>
               <a:defRPr sz="2100" b="0">
                 <a:solidFill>
                   <a:srgbClr val="EAF1EF"/>
@@ -19283,6 +19452,7 @@
           <a:lstStyle xmlns:a="http://schemas.openxmlformats.org/drawingml/2006/main"/>
           <a:p xmlns:a="http://schemas.openxmlformats.org/drawingml/2006/main">
             <a:pPr>
+              <a:buNone/>
               <a:defRPr sz="2325" b="0">
                 <a:solidFill>
                   <a:srgbClr val="B7EDDB"/>
@@ -19340,6 +19510,7 @@
           <a:lstStyle xmlns:a="http://schemas.openxmlformats.org/drawingml/2006/main"/>
           <a:p xmlns:a="http://schemas.openxmlformats.org/drawingml/2006/main">
             <a:pPr>
+              <a:buNone/>
               <a:defRPr sz="1950" b="0">
                 <a:solidFill>
                   <a:srgbClr val="A8C6C4"/>
@@ -23057,7 +23228,7 @@
                 <a:latin typeface="Hiragino Sans GB"/>
                 <a:ea typeface="Hiragino Sans GB"/>
                 <a:cs typeface="Hiragino Sans GB"/>
-                <a:hlinkClick xmlns:r="http://schemas.openxmlformats.org/officeDocument/2006/relationships" r:id="R7f35b4bfb5c54e90"/>
+                <a:hlinkClick xmlns:r="http://schemas.openxmlformats.org/officeDocument/2006/relationships" r:id="Rde5d1650da4841f1"/>
               </a:rPr>
               <a:t>登录与账号</a:t>
             </a:r>
@@ -23116,7 +23287,7 @@
                 <a:latin typeface="Hiragino Sans GB"/>
                 <a:ea typeface="Hiragino Sans GB"/>
                 <a:cs typeface="Hiragino Sans GB"/>
-                <a:hlinkClick xmlns:r="http://schemas.openxmlformats.org/officeDocument/2006/relationships" r:id="R4107e92665da4edb"/>
+                <a:hlinkClick xmlns:r="http://schemas.openxmlformats.org/officeDocument/2006/relationships" r:id="R71132a1cc58f44cb"/>
               </a:rPr>
               <a:t>Slurm 作业管理</a:t>
             </a:r>
@@ -23175,7 +23346,7 @@
                 <a:latin typeface="Hiragino Sans GB"/>
                 <a:ea typeface="Hiragino Sans GB"/>
                 <a:cs typeface="Hiragino Sans GB"/>
-                <a:hlinkClick xmlns:r="http://schemas.openxmlformats.org/officeDocument/2006/relationships" r:id="Rc1a9a0b902444c60"/>
+                <a:hlinkClick xmlns:r="http://schemas.openxmlformats.org/officeDocument/2006/relationships" r:id="R5989a7101caf4ef8"/>
               </a:rPr>
               <a:t>文件传输</a:t>
             </a:r>

</xml_diff>

<commit_message>
Unify tutorial dark theme and restore twenty-minute jobs
</commit_message>
<xml_diff>
--- a/docs/交我算平台Lab运行指南-学生版.pptx
+++ b/docs/交我算平台Lab运行指南-学生版.pptx
@@ -2,47 +2,47 @@
 <file path=ppt/presentation.xml><?xml version="1.0" encoding="utf-8"?>
 <p:presentation xmlns:p="http://schemas.openxmlformats.org/presentationml/2006/main">
   <p:sldMasterIdLst>
-    <p:sldMasterId xmlns:r="http://schemas.openxmlformats.org/officeDocument/2006/relationships" id="2147483648" r:id="R5a10bd07fb45401d"/>
+    <p:sldMasterId xmlns:r="http://schemas.openxmlformats.org/officeDocument/2006/relationships" id="2147483648" r:id="R927377ac83cc472f"/>
   </p:sldMasterIdLst>
   <p:notesMasterIdLst>
-    <p:notesMasterId xmlns:r="http://schemas.openxmlformats.org/officeDocument/2006/relationships" r:id="R244890ac6e02451c"/>
+    <p:notesMasterId xmlns:r="http://schemas.openxmlformats.org/officeDocument/2006/relationships" r:id="R6eed5ffe2fb74892"/>
   </p:notesMasterIdLst>
   <p:sldIdLst>
-    <p:sldId xmlns:r="http://schemas.openxmlformats.org/officeDocument/2006/relationships" id="256" r:id="Rb97d8377e39649d0"/>
-    <p:sldId xmlns:r="http://schemas.openxmlformats.org/officeDocument/2006/relationships" id="257" r:id="Reb659c45f8d44b6b"/>
-    <p:sldId xmlns:r="http://schemas.openxmlformats.org/officeDocument/2006/relationships" id="258" r:id="R174a1353a8ef41bb"/>
-    <p:sldId xmlns:r="http://schemas.openxmlformats.org/officeDocument/2006/relationships" id="259" r:id="R48072fc7357c4746"/>
-    <p:sldId xmlns:r="http://schemas.openxmlformats.org/officeDocument/2006/relationships" id="260" r:id="R01f08e0209e24a5b"/>
-    <p:sldId xmlns:r="http://schemas.openxmlformats.org/officeDocument/2006/relationships" id="261" r:id="R0254adb0c8f640da"/>
-    <p:sldId xmlns:r="http://schemas.openxmlformats.org/officeDocument/2006/relationships" id="262" r:id="R0f0f7ca44b0b496c"/>
-    <p:sldId xmlns:r="http://schemas.openxmlformats.org/officeDocument/2006/relationships" id="263" r:id="Rba623d8432954590"/>
-    <p:sldId xmlns:r="http://schemas.openxmlformats.org/officeDocument/2006/relationships" id="264" r:id="R1a910f93d01e49b1"/>
-    <p:sldId xmlns:r="http://schemas.openxmlformats.org/officeDocument/2006/relationships" id="265" r:id="Rb588f9f651aa4add"/>
-    <p:sldId xmlns:r="http://schemas.openxmlformats.org/officeDocument/2006/relationships" id="266" r:id="R501b4b6f31fc4b0f"/>
-    <p:sldId xmlns:r="http://schemas.openxmlformats.org/officeDocument/2006/relationships" id="267" r:id="R91e04c403424486e"/>
-    <p:sldId xmlns:r="http://schemas.openxmlformats.org/officeDocument/2006/relationships" id="268" r:id="R75f7e2d087ba432f"/>
-    <p:sldId xmlns:r="http://schemas.openxmlformats.org/officeDocument/2006/relationships" id="269" r:id="Rfa99c87fc73c4b0f"/>
-    <p:sldId xmlns:r="http://schemas.openxmlformats.org/officeDocument/2006/relationships" id="270" r:id="Ra3d7fbbd8ef44d2c"/>
-    <p:sldId xmlns:r="http://schemas.openxmlformats.org/officeDocument/2006/relationships" id="271" r:id="R77ce96926536464c"/>
-    <p:sldId xmlns:r="http://schemas.openxmlformats.org/officeDocument/2006/relationships" id="272" r:id="R66fc69a0c9b34cd1"/>
-    <p:sldId xmlns:r="http://schemas.openxmlformats.org/officeDocument/2006/relationships" id="273" r:id="R0da19f867c3b4a33"/>
-    <p:sldId xmlns:r="http://schemas.openxmlformats.org/officeDocument/2006/relationships" id="274" r:id="R218128924b03461d"/>
-    <p:sldId xmlns:r="http://schemas.openxmlformats.org/officeDocument/2006/relationships" id="275" r:id="R349ea0c71c75494a"/>
-    <p:sldId xmlns:r="http://schemas.openxmlformats.org/officeDocument/2006/relationships" id="276" r:id="R32d0ad3cdacc47f1"/>
-    <p:sldId xmlns:r="http://schemas.openxmlformats.org/officeDocument/2006/relationships" id="277" r:id="R9dd4b70195ae4917"/>
-    <p:sldId xmlns:r="http://schemas.openxmlformats.org/officeDocument/2006/relationships" id="278" r:id="Rceddce5e90594c5d"/>
-    <p:sldId xmlns:r="http://schemas.openxmlformats.org/officeDocument/2006/relationships" id="279" r:id="Rcf368fba6da04216"/>
-    <p:sldId xmlns:r="http://schemas.openxmlformats.org/officeDocument/2006/relationships" id="280" r:id="R1603923731c548a4"/>
-    <p:sldId xmlns:r="http://schemas.openxmlformats.org/officeDocument/2006/relationships" id="281" r:id="R2c27ab6732814c3b"/>
-    <p:sldId xmlns:r="http://schemas.openxmlformats.org/officeDocument/2006/relationships" id="282" r:id="R28d81451706941df"/>
-    <p:sldId xmlns:r="http://schemas.openxmlformats.org/officeDocument/2006/relationships" id="283" r:id="R870b50df966648ae"/>
-    <p:sldId xmlns:r="http://schemas.openxmlformats.org/officeDocument/2006/relationships" id="284" r:id="R529c9dc11ae64179"/>
-    <p:sldId xmlns:r="http://schemas.openxmlformats.org/officeDocument/2006/relationships" id="285" r:id="R56bfad23828f4fd1"/>
-    <p:sldId xmlns:r="http://schemas.openxmlformats.org/officeDocument/2006/relationships" id="286" r:id="Ref19afa7834148ac"/>
-    <p:sldId xmlns:r="http://schemas.openxmlformats.org/officeDocument/2006/relationships" id="287" r:id="Rf80962e00bbd4d72"/>
-    <p:sldId xmlns:r="http://schemas.openxmlformats.org/officeDocument/2006/relationships" id="288" r:id="Rd5a4849e29554b1d"/>
-    <p:sldId xmlns:r="http://schemas.openxmlformats.org/officeDocument/2006/relationships" id="289" r:id="Re6fe4bfcc84e406f"/>
-    <p:sldId xmlns:r="http://schemas.openxmlformats.org/officeDocument/2006/relationships" id="290" r:id="R78d5c3b9df5e43c6"/>
+    <p:sldId xmlns:r="http://schemas.openxmlformats.org/officeDocument/2006/relationships" id="256" r:id="Ra56022e4c19540bc"/>
+    <p:sldId xmlns:r="http://schemas.openxmlformats.org/officeDocument/2006/relationships" id="257" r:id="R6aacd11cb52341e8"/>
+    <p:sldId xmlns:r="http://schemas.openxmlformats.org/officeDocument/2006/relationships" id="258" r:id="R4bf80267caec44ed"/>
+    <p:sldId xmlns:r="http://schemas.openxmlformats.org/officeDocument/2006/relationships" id="259" r:id="R229dc654e102476b"/>
+    <p:sldId xmlns:r="http://schemas.openxmlformats.org/officeDocument/2006/relationships" id="260" r:id="R3ba076d47f844f63"/>
+    <p:sldId xmlns:r="http://schemas.openxmlformats.org/officeDocument/2006/relationships" id="261" r:id="R2681934d9a014e18"/>
+    <p:sldId xmlns:r="http://schemas.openxmlformats.org/officeDocument/2006/relationships" id="262" r:id="R3c98f2fa152d4ef1"/>
+    <p:sldId xmlns:r="http://schemas.openxmlformats.org/officeDocument/2006/relationships" id="263" r:id="R1b3a07c64a4b467c"/>
+    <p:sldId xmlns:r="http://schemas.openxmlformats.org/officeDocument/2006/relationships" id="264" r:id="R67f43a921bab4162"/>
+    <p:sldId xmlns:r="http://schemas.openxmlformats.org/officeDocument/2006/relationships" id="265" r:id="R27e5f3c0d618404b"/>
+    <p:sldId xmlns:r="http://schemas.openxmlformats.org/officeDocument/2006/relationships" id="266" r:id="Rc244b24142c24692"/>
+    <p:sldId xmlns:r="http://schemas.openxmlformats.org/officeDocument/2006/relationships" id="267" r:id="R427bebbc798e4304"/>
+    <p:sldId xmlns:r="http://schemas.openxmlformats.org/officeDocument/2006/relationships" id="268" r:id="R3485278cfe804f13"/>
+    <p:sldId xmlns:r="http://schemas.openxmlformats.org/officeDocument/2006/relationships" id="269" r:id="Ree8c429b86a146d8"/>
+    <p:sldId xmlns:r="http://schemas.openxmlformats.org/officeDocument/2006/relationships" id="270" r:id="R714659cc643d4bee"/>
+    <p:sldId xmlns:r="http://schemas.openxmlformats.org/officeDocument/2006/relationships" id="271" r:id="R9e50e593fc474ed4"/>
+    <p:sldId xmlns:r="http://schemas.openxmlformats.org/officeDocument/2006/relationships" id="272" r:id="Ra3266cf68c034dcd"/>
+    <p:sldId xmlns:r="http://schemas.openxmlformats.org/officeDocument/2006/relationships" id="273" r:id="Rea222d61349c4fa9"/>
+    <p:sldId xmlns:r="http://schemas.openxmlformats.org/officeDocument/2006/relationships" id="274" r:id="Rd83a2cb950f94334"/>
+    <p:sldId xmlns:r="http://schemas.openxmlformats.org/officeDocument/2006/relationships" id="275" r:id="R6e64b142545c4d77"/>
+    <p:sldId xmlns:r="http://schemas.openxmlformats.org/officeDocument/2006/relationships" id="276" r:id="Rd549f739e8494a3a"/>
+    <p:sldId xmlns:r="http://schemas.openxmlformats.org/officeDocument/2006/relationships" id="277" r:id="R01ee70f6453b4f8c"/>
+    <p:sldId xmlns:r="http://schemas.openxmlformats.org/officeDocument/2006/relationships" id="278" r:id="Rf624bea7bfcb44e9"/>
+    <p:sldId xmlns:r="http://schemas.openxmlformats.org/officeDocument/2006/relationships" id="279" r:id="R29cba9b63f5d44aa"/>
+    <p:sldId xmlns:r="http://schemas.openxmlformats.org/officeDocument/2006/relationships" id="280" r:id="R734199445a124cce"/>
+    <p:sldId xmlns:r="http://schemas.openxmlformats.org/officeDocument/2006/relationships" id="281" r:id="R0ddfc15393824003"/>
+    <p:sldId xmlns:r="http://schemas.openxmlformats.org/officeDocument/2006/relationships" id="282" r:id="R454068d6cb1244fa"/>
+    <p:sldId xmlns:r="http://schemas.openxmlformats.org/officeDocument/2006/relationships" id="283" r:id="Rdae7e0a296d14293"/>
+    <p:sldId xmlns:r="http://schemas.openxmlformats.org/officeDocument/2006/relationships" id="284" r:id="R222f85dd30094eb9"/>
+    <p:sldId xmlns:r="http://schemas.openxmlformats.org/officeDocument/2006/relationships" id="285" r:id="R0fe13afbfaf6474c"/>
+    <p:sldId xmlns:r="http://schemas.openxmlformats.org/officeDocument/2006/relationships" id="286" r:id="Re594158437634572"/>
+    <p:sldId xmlns:r="http://schemas.openxmlformats.org/officeDocument/2006/relationships" id="287" r:id="R52160da98b224581"/>
+    <p:sldId xmlns:r="http://schemas.openxmlformats.org/officeDocument/2006/relationships" id="288" r:id="Recb7905c90f54724"/>
+    <p:sldId xmlns:r="http://schemas.openxmlformats.org/officeDocument/2006/relationships" id="289" r:id="R0ee1a5b3a9c14e57"/>
+    <p:sldId xmlns:r="http://schemas.openxmlformats.org/officeDocument/2006/relationships" id="290" r:id="R880c548df6e34340"/>
   </p:sldIdLst>
   <p:sldSz cx="15240000" cy="8572500"/>
   <p:notesSz cx="6858000" cy="9144000"/>
@@ -1017,7 +1017,7 @@
           <a:lstStyle xmlns:a="http://schemas.openxmlformats.org/drawingml/2006/main"/>
           <a:p xmlns:a="http://schemas.openxmlformats.org/drawingml/2006/main">
             <a:r>
-              <a:t>在登录节点执行 srun。成功分配后才执行下方编译器检查，hostname 应显示计算节点。若排队，等待分配，不要退回登录节点直接运行实验。1 task、1 CPU 足以运行当前串行框架。最长运行 2 小时，不含排队时间；编译、测试与交互终端空闲均计入时限。退出 bash 会释放交互式资源。登录节点于 2026-09-27 实测有 GCC 8.5.0、CMake 3.20.2，但计算节点仍需现场确认。</a:t>
+              <a:t>在登录节点执行 srun。成功分配后才执行下方编译器检查，hostname 应显示计算节点。若排队，等待分配，不要退回登录节点直接运行实验。1 task、1 CPU 足以运行当前串行框架。最长运行 20 分钟，不含排队时间；编译、测试与交互终端空闲均计入时限。退出 bash 会释放交互式资源。登录节点于 2026-09-27 实测有 GCC 8.5.0、CMake 3.20.2，但计算节点仍需现场确认。</a:t>
             </a:r>
           </a:p>
           <a:p xmlns:a="http://schemas.openxmlformats.org/drawingml/2006/main">
@@ -1064,6 +1064,11 @@
           <a:p xmlns:a="http://schemas.openxmlformats.org/drawingml/2006/main">
             <a:r>
               <a:t>CMake 3.20 开始支持 ctest --test-dir；3.16～3.19 使用 (cd build &amp;&amp; ctest --output-on-failure)。来源：https://cmake.org/cmake/help/v3.20/release/3.20.html#ctest</a:t>
+            </a:r>
+          </a:p>
+          <a:p xmlns:a="http://schemas.openxmlformats.org/drawingml/2006/main">
+            <a:r>
+              <a:t/>
             </a:r>
           </a:p>
         </p:txBody>
@@ -1374,7 +1379,12 @@
           </a:p>
           <a:p xmlns:a="http://schemas.openxmlformats.org/drawingml/2006/main">
             <a:r>
-              <a:t>本教程的交互式申请和批处理脚本统一使用 02:00:00，即最长运行 2 小时。时限不含排队时间。提前结束会释放资源。正式实验按实测耗时分批或调整时限。</a:t>
+              <a:t>本教程的交互式申请和批处理脚本统一使用 00:20:00，即最长运行 20 分钟。时限不含排队时间。提前结束会释放资源。正式实验按实测耗时分批或调整时限。</a:t>
+            </a:r>
+          </a:p>
+          <a:p xmlns:a="http://schemas.openxmlformats.org/drawingml/2006/main">
+            <a:r>
+              <a:t/>
             </a:r>
           </a:p>
         </p:txBody>
@@ -1633,7 +1643,7 @@
           </a:p>
           <a:p xmlns:a="http://schemas.openxmlformats.org/drawingml/2006/main">
             <a:r>
-              <a:t>#SBATCH -t 02:00:00</a:t>
+              <a:t>#SBATCH -t 00:20:00</a:t>
             </a:r>
           </a:p>
           <a:p xmlns:a="http://schemas.openxmlformats.org/drawingml/2006/main">
@@ -1709,6 +1719,11 @@
           <a:p xmlns:a="http://schemas.openxmlformats.org/drawingml/2006/main">
             <a:r>
               <a:t>CMake 3.20 开始支持 ctest --test-dir；3.16～3.19 使用 (cd build &amp;&amp; ctest --output-on-failure)。来源：https://cmake.org/cmake/help/v3.20/release/3.20.html#ctest</a:t>
+            </a:r>
+          </a:p>
+          <a:p xmlns:a="http://schemas.openxmlformats.org/drawingml/2006/main">
+            <a:r>
+              <a:t/>
             </a:r>
           </a:p>
         </p:txBody>
@@ -3672,7 +3687,7 @@
   </p:cSld>
   <p:clrMap bg1="lt1" tx1="dk1" bg2="lt2" tx2="dk2" accent1="accent1" accent2="accent2" accent3="accent3" accent4="accent4" accent5="accent5" accent6="accent6" hlink="hlink" folHlink="folHlink"/>
   <p:sldLayoutIdLst>
-    <p:sldLayoutId xmlns:r="http://schemas.openxmlformats.org/officeDocument/2006/relationships" id="2147483649" r:id="R4226e492139f40ab"/>
+    <p:sldLayoutId xmlns:r="http://schemas.openxmlformats.org/officeDocument/2006/relationships" id="2147483649" r:id="R885e1f29b21b4dab"/>
   </p:sldLayoutIdLst>
   <p:txStyles>
     <p:titleStyle>
@@ -7078,7 +7093,7 @@
                 <a:ea typeface="Menlo"/>
                 <a:cs typeface="Menlo"/>
               </a:rPr>
-              <a:t>02:00:00</a:t>
+              <a:t>00:20:00</a:t>
             </a:r>
             <a:r>
               <a:rPr sz="2325" b="0">
@@ -9728,7 +9743,7 @@
     <p:bg>
       <p:bgPr>
         <a:solidFill xmlns:a="http://schemas.openxmlformats.org/drawingml/2006/main">
-          <a:srgbClr val="F7F6F2"/>
+          <a:srgbClr val="102C35"/>
         </a:solidFill>
       </p:bgPr>
     </p:bg>
@@ -9778,7 +9793,7 @@
               <a:buNone/>
               <a:defRPr sz="3900" b="1">
                 <a:solidFill>
-                  <a:srgbClr val="172D36"/>
+                  <a:srgbClr val="EAF1EF"/>
                 </a:solidFill>
                 <a:latin typeface="Hiragino Sans GB"/>
                 <a:ea typeface="Hiragino Sans GB"/>
@@ -9788,7 +9803,7 @@
             <a:r>
               <a:rPr sz="3900" b="1">
                 <a:solidFill>
-                  <a:srgbClr val="172D36"/>
+                  <a:srgbClr val="EAF1EF"/>
                 </a:solidFill>
                 <a:latin typeface="Hiragino Sans GB"/>
                 <a:ea typeface="Hiragino Sans GB"/>
@@ -9836,7 +9851,7 @@
               <a:buNone/>
               <a:defRPr sz="1650" b="0">
                 <a:solidFill>
-                  <a:srgbClr val="526971"/>
+                  <a:srgbClr val="A8C6C4"/>
                 </a:solidFill>
                 <a:latin typeface="Hiragino Sans GB"/>
                 <a:ea typeface="Hiragino Sans GB"/>
@@ -9846,7 +9861,7 @@
             <a:r>
               <a:rPr sz="1650" b="0">
                 <a:solidFill>
-                  <a:srgbClr val="526971"/>
+                  <a:srgbClr val="A8C6C4"/>
                 </a:solidFill>
                 <a:latin typeface="Hiragino Sans GB"/>
                 <a:ea typeface="Hiragino Sans GB"/>
@@ -9885,7 +9900,7 @@
                       <a:r>
                         <a:rPr sz="2100" b="1">
                           <a:solidFill>
-                            <a:srgbClr val="FFFFFF"/>
+                            <a:srgbClr val="EAF1EF"/>
                           </a:solidFill>
                           <a:latin typeface="Hiragino Sans GB"/>
                           <a:ea typeface="Hiragino Sans GB"/>
@@ -9897,7 +9912,7 @@
                   </a:txBody>
                   <a:tcPr marL="91440" marR="91440" marT="45720" marB="45720" anchor="ctr">
                     <a:solidFill>
-                      <a:srgbClr val="167A70"/>
+                      <a:srgbClr val="16665F"/>
                     </a:solidFill>
                   </a:tcPr>
                 </a:tc>
@@ -9909,7 +9924,7 @@
                       <a:r>
                         <a:rPr sz="2100" b="1">
                           <a:solidFill>
-                            <a:srgbClr val="FFFFFF"/>
+                            <a:srgbClr val="EAF1EF"/>
                           </a:solidFill>
                           <a:latin typeface="Hiragino Sans GB"/>
                           <a:ea typeface="Hiragino Sans GB"/>
@@ -9921,7 +9936,7 @@
                   </a:txBody>
                   <a:tcPr marL="91440" marR="91440" marT="45720" marB="45720" anchor="ctr">
                     <a:solidFill>
-                      <a:srgbClr val="167A70"/>
+                      <a:srgbClr val="16665F"/>
                     </a:solidFill>
                   </a:tcPr>
                 </a:tc>
@@ -9933,7 +9948,7 @@
                       <a:r>
                         <a:rPr sz="2100" b="1">
                           <a:solidFill>
-                            <a:srgbClr val="FFFFFF"/>
+                            <a:srgbClr val="EAF1EF"/>
                           </a:solidFill>
                           <a:latin typeface="Hiragino Sans GB"/>
                           <a:ea typeface="Hiragino Sans GB"/>
@@ -9945,7 +9960,7 @@
                   </a:txBody>
                   <a:tcPr marL="91440" marR="91440" marT="45720" marB="45720" anchor="ctr">
                     <a:solidFill>
-                      <a:srgbClr val="167A70"/>
+                      <a:srgbClr val="16665F"/>
                     </a:solidFill>
                   </a:tcPr>
                 </a:tc>
@@ -9959,7 +9974,7 @@
                       <a:r>
                         <a:rPr sz="2100" b="0">
                           <a:solidFill>
-                            <a:srgbClr val="172D36"/>
+                            <a:srgbClr val="EAF1EF"/>
                           </a:solidFill>
                           <a:latin typeface="Hiragino Sans GB"/>
                           <a:ea typeface="Hiragino Sans GB"/>
@@ -9971,7 +9986,7 @@
                   </a:txBody>
                   <a:tcPr marL="91440" marR="91440" marT="45720" marB="45720" anchor="ctr">
                     <a:solidFill>
-                      <a:srgbClr val="FFFFFF"/>
+                      <a:srgbClr val="173A44"/>
                     </a:solidFill>
                   </a:tcPr>
                 </a:tc>
@@ -9983,7 +9998,7 @@
                       <a:r>
                         <a:rPr sz="2100" b="0">
                           <a:solidFill>
-                            <a:srgbClr val="172D36"/>
+                            <a:srgbClr val="EAF1EF"/>
                           </a:solidFill>
                           <a:latin typeface="Hiragino Sans GB"/>
                           <a:ea typeface="Hiragino Sans GB"/>
@@ -9995,7 +10010,7 @@
                   </a:txBody>
                   <a:tcPr marL="91440" marR="91440" marT="45720" marB="45720" anchor="ctr">
                     <a:solidFill>
-                      <a:srgbClr val="FFFFFF"/>
+                      <a:srgbClr val="173A44"/>
                     </a:solidFill>
                   </a:tcPr>
                 </a:tc>
@@ -10007,7 +10022,7 @@
                       <a:r>
                         <a:rPr sz="2100" b="0">
                           <a:solidFill>
-                            <a:srgbClr val="172D36"/>
+                            <a:srgbClr val="EAF1EF"/>
                           </a:solidFill>
                           <a:latin typeface="Hiragino Sans GB"/>
                           <a:ea typeface="Hiragino Sans GB"/>
@@ -10019,7 +10034,7 @@
                   </a:txBody>
                   <a:tcPr marL="91440" marR="91440" marT="45720" marB="45720" anchor="ctr">
                     <a:solidFill>
-                      <a:srgbClr val="FFFFFF"/>
+                      <a:srgbClr val="173A44"/>
                     </a:solidFill>
                   </a:tcPr>
                 </a:tc>
@@ -10033,7 +10048,7 @@
                       <a:r>
                         <a:rPr sz="2100" b="0">
                           <a:solidFill>
-                            <a:srgbClr val="172D36"/>
+                            <a:srgbClr val="EAF1EF"/>
                           </a:solidFill>
                           <a:latin typeface="Hiragino Sans GB"/>
                           <a:ea typeface="Hiragino Sans GB"/>
@@ -10045,7 +10060,7 @@
                   </a:txBody>
                   <a:tcPr marL="91440" marR="91440" marT="45720" marB="45720" anchor="ctr">
                     <a:solidFill>
-                      <a:srgbClr val="EDF1ED"/>
+                      <a:srgbClr val="1D4650"/>
                     </a:solidFill>
                   </a:tcPr>
                 </a:tc>
@@ -10057,7 +10072,7 @@
                       <a:r>
                         <a:rPr sz="2100" b="0">
                           <a:solidFill>
-                            <a:srgbClr val="172D36"/>
+                            <a:srgbClr val="EAF1EF"/>
                           </a:solidFill>
                           <a:latin typeface="Hiragino Sans GB"/>
                           <a:ea typeface="Hiragino Sans GB"/>
@@ -10069,7 +10084,7 @@
                   </a:txBody>
                   <a:tcPr marL="91440" marR="91440" marT="45720" marB="45720" anchor="ctr">
                     <a:solidFill>
-                      <a:srgbClr val="EDF1ED"/>
+                      <a:srgbClr val="1D4650"/>
                     </a:solidFill>
                   </a:tcPr>
                 </a:tc>
@@ -10081,7 +10096,7 @@
                       <a:r>
                         <a:rPr sz="2100" b="0">
                           <a:solidFill>
-                            <a:srgbClr val="172D36"/>
+                            <a:srgbClr val="EAF1EF"/>
                           </a:solidFill>
                           <a:latin typeface="Hiragino Sans GB"/>
                           <a:ea typeface="Hiragino Sans GB"/>
@@ -10093,7 +10108,7 @@
                   </a:txBody>
                   <a:tcPr marL="91440" marR="91440" marT="45720" marB="45720" anchor="ctr">
                     <a:solidFill>
-                      <a:srgbClr val="EDF1ED"/>
+                      <a:srgbClr val="1D4650"/>
                     </a:solidFill>
                   </a:tcPr>
                 </a:tc>
@@ -10107,7 +10122,7 @@
                       <a:r>
                         <a:rPr sz="2100" b="0">
                           <a:solidFill>
-                            <a:srgbClr val="172D36"/>
+                            <a:srgbClr val="EAF1EF"/>
                           </a:solidFill>
                           <a:latin typeface="Hiragino Sans GB"/>
                           <a:ea typeface="Hiragino Sans GB"/>
@@ -10119,7 +10134,7 @@
                   </a:txBody>
                   <a:tcPr marL="91440" marR="91440" marT="45720" marB="45720" anchor="ctr">
                     <a:solidFill>
-                      <a:srgbClr val="FFFFFF"/>
+                      <a:srgbClr val="173A44"/>
                     </a:solidFill>
                   </a:tcPr>
                 </a:tc>
@@ -10131,7 +10146,7 @@
                       <a:r>
                         <a:rPr sz="2100" b="0">
                           <a:solidFill>
-                            <a:srgbClr val="172D36"/>
+                            <a:srgbClr val="EAF1EF"/>
                           </a:solidFill>
                           <a:latin typeface="Hiragino Sans GB"/>
                           <a:ea typeface="Hiragino Sans GB"/>
@@ -10143,7 +10158,7 @@
                   </a:txBody>
                   <a:tcPr marL="91440" marR="91440" marT="45720" marB="45720" anchor="ctr">
                     <a:solidFill>
-                      <a:srgbClr val="FFFFFF"/>
+                      <a:srgbClr val="173A44"/>
                     </a:solidFill>
                   </a:tcPr>
                 </a:tc>
@@ -10155,7 +10170,7 @@
                       <a:r>
                         <a:rPr sz="2100" b="0">
                           <a:solidFill>
-                            <a:srgbClr val="172D36"/>
+                            <a:srgbClr val="EAF1EF"/>
                           </a:solidFill>
                           <a:latin typeface="Hiragino Sans GB"/>
                           <a:ea typeface="Hiragino Sans GB"/>
@@ -10167,7 +10182,7 @@
                   </a:txBody>
                   <a:tcPr marL="91440" marR="91440" marT="45720" marB="45720" anchor="ctr">
                     <a:solidFill>
-                      <a:srgbClr val="FFFFFF"/>
+                      <a:srgbClr val="173A44"/>
                     </a:solidFill>
                   </a:tcPr>
                 </a:tc>
@@ -10181,7 +10196,7 @@
                       <a:r>
                         <a:rPr sz="2100" b="0">
                           <a:solidFill>
-                            <a:srgbClr val="172D36"/>
+                            <a:srgbClr val="EAF1EF"/>
                           </a:solidFill>
                           <a:latin typeface="Hiragino Sans GB"/>
                           <a:ea typeface="Hiragino Sans GB"/>
@@ -10193,7 +10208,7 @@
                   </a:txBody>
                   <a:tcPr marL="91440" marR="91440" marT="45720" marB="45720" anchor="ctr">
                     <a:solidFill>
-                      <a:srgbClr val="EDF1ED"/>
+                      <a:srgbClr val="1D4650"/>
                     </a:solidFill>
                   </a:tcPr>
                 </a:tc>
@@ -10205,7 +10220,7 @@
                       <a:r>
                         <a:rPr sz="2100" b="0">
                           <a:solidFill>
-                            <a:srgbClr val="172D36"/>
+                            <a:srgbClr val="EAF1EF"/>
                           </a:solidFill>
                           <a:latin typeface="Hiragino Sans GB"/>
                           <a:ea typeface="Hiragino Sans GB"/>
@@ -10217,7 +10232,7 @@
                   </a:txBody>
                   <a:tcPr marL="91440" marR="91440" marT="45720" marB="45720" anchor="ctr">
                     <a:solidFill>
-                      <a:srgbClr val="EDF1ED"/>
+                      <a:srgbClr val="1D4650"/>
                     </a:solidFill>
                   </a:tcPr>
                 </a:tc>
@@ -10229,7 +10244,7 @@
                       <a:r>
                         <a:rPr sz="2100" b="0">
                           <a:solidFill>
-                            <a:srgbClr val="172D36"/>
+                            <a:srgbClr val="EAF1EF"/>
                           </a:solidFill>
                           <a:latin typeface="Hiragino Sans GB"/>
                           <a:ea typeface="Hiragino Sans GB"/>
@@ -10241,7 +10256,7 @@
                   </a:txBody>
                   <a:tcPr marL="91440" marR="91440" marT="45720" marB="45720" anchor="ctr">
                     <a:solidFill>
-                      <a:srgbClr val="EDF1ED"/>
+                      <a:srgbClr val="1D4650"/>
                     </a:solidFill>
                   </a:tcPr>
                 </a:tc>
@@ -10255,7 +10270,7 @@
                       <a:r>
                         <a:rPr sz="2100" b="0">
                           <a:solidFill>
-                            <a:srgbClr val="172D36"/>
+                            <a:srgbClr val="EAF1EF"/>
                           </a:solidFill>
                           <a:latin typeface="Hiragino Sans GB"/>
                           <a:ea typeface="Hiragino Sans GB"/>
@@ -10267,7 +10282,7 @@
                   </a:txBody>
                   <a:tcPr marL="91440" marR="91440" marT="45720" marB="45720" anchor="ctr">
                     <a:solidFill>
-                      <a:srgbClr val="FFFFFF"/>
+                      <a:srgbClr val="173A44"/>
                     </a:solidFill>
                   </a:tcPr>
                 </a:tc>
@@ -10279,19 +10294,19 @@
                       <a:r>
                         <a:rPr sz="2100" b="0">
                           <a:solidFill>
-                            <a:srgbClr val="172D36"/>
+                            <a:srgbClr val="EAF1EF"/>
                           </a:solidFill>
                           <a:latin typeface="Hiragino Sans GB"/>
                           <a:ea typeface="Hiragino Sans GB"/>
                           <a:cs typeface="Hiragino Sans GB"/>
                         </a:rPr>
-                        <a:t>02:00:00</a:t>
+                        <a:t>00:20:00</a:t>
                       </a:r>
                     </a:p>
                   </a:txBody>
                   <a:tcPr marL="91440" marR="91440" marT="45720" marB="45720" anchor="ctr">
                     <a:solidFill>
-                      <a:srgbClr val="FFFFFF"/>
+                      <a:srgbClr val="173A44"/>
                     </a:solidFill>
                   </a:tcPr>
                 </a:tc>
@@ -10303,19 +10318,41 @@
                       <a:r>
                         <a:rPr sz="2100" b="0">
                           <a:solidFill>
-                            <a:srgbClr val="172D36"/>
+                            <a:srgbClr val="EAF1EF"/>
                           </a:solidFill>
                           <a:latin typeface="Hiragino Sans GB"/>
                           <a:ea typeface="Hiragino Sans GB"/>
                           <a:cs typeface="Hiragino Sans GB"/>
                         </a:rPr>
-                        <a:t>最多运行 2 小时，不含排队时间</a:t>
+                        <a:t>最多运行 </a:t>
+                      </a:r>
+                      <a:r>
+                        <a:rPr sz="2100" b="0">
+                          <a:solidFill>
+                            <a:srgbClr val="EAF1EF"/>
+                          </a:solidFill>
+                          <a:latin typeface="Hiragino Sans GB"/>
+                          <a:ea typeface="Hiragino Sans GB"/>
+                          <a:cs typeface="Hiragino Sans GB"/>
+                        </a:rPr>
+                        <a:t>20 分钟</a:t>
+                      </a:r>
+                      <a:r>
+                        <a:rPr sz="2100" b="0">
+                          <a:solidFill>
+                            <a:srgbClr val="EAF1EF"/>
+                          </a:solidFill>
+                          <a:latin typeface="Hiragino Sans GB"/>
+                          <a:ea typeface="Hiragino Sans GB"/>
+                          <a:cs typeface="Hiragino Sans GB"/>
+                        </a:rPr>
+                        <a:t>，不含排队时间</a:t>
                       </a:r>
                     </a:p>
                   </a:txBody>
                   <a:tcPr marL="91440" marR="91440" marT="45720" marB="45720" anchor="ctr">
                     <a:solidFill>
-                      <a:srgbClr val="FFFFFF"/>
+                      <a:srgbClr val="173A44"/>
                     </a:solidFill>
                   </a:tcPr>
                 </a:tc>
@@ -10361,7 +10398,7 @@
               <a:buNone/>
               <a:defRPr sz="1950" b="0">
                 <a:solidFill>
-                  <a:srgbClr val="526971"/>
+                  <a:srgbClr val="A8C6C4"/>
                 </a:solidFill>
                 <a:latin typeface="Hiragino Sans GB"/>
                 <a:ea typeface="Hiragino Sans GB"/>
@@ -10371,7 +10408,7 @@
             <a:r>
               <a:rPr sz="1950" b="0">
                 <a:solidFill>
-                  <a:srgbClr val="526971"/>
+                  <a:srgbClr val="A8C6C4"/>
                 </a:solidFill>
                 <a:latin typeface="Hiragino Sans GB"/>
                 <a:ea typeface="Hiragino Sans GB"/>
@@ -10812,7 +10849,18 @@
                 <a:ea typeface="Menlo"/>
                 <a:cs typeface="Menlo"/>
               </a:rPr>
-              <a:t>#SBATCH -t 02:00:00</a:t>
+              <a:t>#SBATCH -t </a:t>
+            </a:r>
+            <a:r>
+              <a:rPr sz="2250" b="0">
+                <a:solidFill>
+                  <a:srgbClr val="B7EDDB"/>
+                </a:solidFill>
+                <a:latin typeface="Menlo"/>
+                <a:ea typeface="Menlo"/>
+                <a:cs typeface="Menlo"/>
+              </a:rPr>
+              <a:t>00:20:00</a:t>
             </a:r>
           </a:p>
         </p:txBody>
@@ -11181,7 +11229,7 @@
     <p:bg>
       <p:bgPr>
         <a:solidFill xmlns:a="http://schemas.openxmlformats.org/drawingml/2006/main">
-          <a:srgbClr val="F7F6F2"/>
+          <a:srgbClr val="102C35"/>
         </a:solidFill>
       </p:bgPr>
     </p:bg>
@@ -11231,7 +11279,7 @@
               <a:buNone/>
               <a:defRPr sz="3900" b="1">
                 <a:solidFill>
-                  <a:srgbClr val="172D36"/>
+                  <a:srgbClr val="EAF1EF"/>
                 </a:solidFill>
                 <a:latin typeface="Hiragino Sans GB"/>
                 <a:ea typeface="Hiragino Sans GB"/>
@@ -11241,7 +11289,7 @@
             <a:r>
               <a:rPr sz="3900" b="1">
                 <a:solidFill>
-                  <a:srgbClr val="172D36"/>
+                  <a:srgbClr val="EAF1EF"/>
                 </a:solidFill>
                 <a:latin typeface="Hiragino Sans GB"/>
                 <a:ea typeface="Hiragino Sans GB"/>
@@ -11289,7 +11337,7 @@
               <a:buNone/>
               <a:defRPr sz="1650" b="0">
                 <a:solidFill>
-                  <a:srgbClr val="526971"/>
+                  <a:srgbClr val="A8C6C4"/>
                 </a:solidFill>
                 <a:latin typeface="Hiragino Sans GB"/>
                 <a:ea typeface="Hiragino Sans GB"/>
@@ -11299,7 +11347,7 @@
             <a:r>
               <a:rPr sz="1650" b="0">
                 <a:solidFill>
-                  <a:srgbClr val="526971"/>
+                  <a:srgbClr val="A8C6C4"/>
                 </a:solidFill>
                 <a:latin typeface="Hiragino Sans GB"/>
                 <a:ea typeface="Hiragino Sans GB"/>
@@ -11338,7 +11386,7 @@
                       <a:r>
                         <a:rPr sz="2175" b="1">
                           <a:solidFill>
-                            <a:srgbClr val="FFFFFF"/>
+                            <a:srgbClr val="EAF1EF"/>
                           </a:solidFill>
                           <a:latin typeface="Hiragino Sans GB"/>
                           <a:ea typeface="Hiragino Sans GB"/>
@@ -11350,7 +11398,7 @@
                   </a:txBody>
                   <a:tcPr marL="91440" marR="91440" marT="45720" marB="45720" anchor="ctr">
                     <a:solidFill>
-                      <a:srgbClr val="167A70"/>
+                      <a:srgbClr val="16665F"/>
                     </a:solidFill>
                   </a:tcPr>
                 </a:tc>
@@ -11362,7 +11410,7 @@
                       <a:r>
                         <a:rPr sz="2175" b="1">
                           <a:solidFill>
-                            <a:srgbClr val="FFFFFF"/>
+                            <a:srgbClr val="EAF1EF"/>
                           </a:solidFill>
                           <a:latin typeface="Hiragino Sans GB"/>
                           <a:ea typeface="Hiragino Sans GB"/>
@@ -11374,7 +11422,7 @@
                   </a:txBody>
                   <a:tcPr marL="91440" marR="91440" marT="45720" marB="45720" anchor="ctr">
                     <a:solidFill>
-                      <a:srgbClr val="167A70"/>
+                      <a:srgbClr val="16665F"/>
                     </a:solidFill>
                   </a:tcPr>
                 </a:tc>
@@ -11386,7 +11434,7 @@
                       <a:r>
                         <a:rPr sz="2175" b="1">
                           <a:solidFill>
-                            <a:srgbClr val="FFFFFF"/>
+                            <a:srgbClr val="EAF1EF"/>
                           </a:solidFill>
                           <a:latin typeface="Hiragino Sans GB"/>
                           <a:ea typeface="Hiragino Sans GB"/>
@@ -11398,7 +11446,7 @@
                   </a:txBody>
                   <a:tcPr marL="91440" marR="91440" marT="45720" marB="45720" anchor="ctr">
                     <a:solidFill>
-                      <a:srgbClr val="167A70"/>
+                      <a:srgbClr val="16665F"/>
                     </a:solidFill>
                   </a:tcPr>
                 </a:tc>
@@ -11412,7 +11460,7 @@
                       <a:r>
                         <a:rPr sz="2175" b="0">
                           <a:solidFill>
-                            <a:srgbClr val="172D36"/>
+                            <a:srgbClr val="EAF1EF"/>
                           </a:solidFill>
                           <a:latin typeface="Hiragino Sans GB"/>
                           <a:ea typeface="Hiragino Sans GB"/>
@@ -11424,7 +11472,7 @@
                   </a:txBody>
                   <a:tcPr marL="91440" marR="91440" marT="45720" marB="45720" anchor="ctr">
                     <a:solidFill>
-                      <a:srgbClr val="FFFFFF"/>
+                      <a:srgbClr val="173A44"/>
                     </a:solidFill>
                   </a:tcPr>
                 </a:tc>
@@ -11436,7 +11484,7 @@
                       <a:r>
                         <a:rPr sz="2175" b="0">
                           <a:solidFill>
-                            <a:srgbClr val="172D36"/>
+                            <a:srgbClr val="EAF1EF"/>
                           </a:solidFill>
                           <a:latin typeface="Hiragino Sans GB"/>
                           <a:ea typeface="Hiragino Sans GB"/>
@@ -11448,7 +11496,7 @@
                   </a:txBody>
                   <a:tcPr marL="91440" marR="91440" marT="45720" marB="45720" anchor="ctr">
                     <a:solidFill>
-                      <a:srgbClr val="FFFFFF"/>
+                      <a:srgbClr val="173A44"/>
                     </a:solidFill>
                   </a:tcPr>
                 </a:tc>
@@ -11460,7 +11508,7 @@
                       <a:r>
                         <a:rPr sz="2175" b="0">
                           <a:solidFill>
-                            <a:srgbClr val="172D36"/>
+                            <a:srgbClr val="EAF1EF"/>
                           </a:solidFill>
                           <a:latin typeface="Hiragino Sans GB"/>
                           <a:ea typeface="Hiragino Sans GB"/>
@@ -11472,7 +11520,7 @@
                   </a:txBody>
                   <a:tcPr marL="91440" marR="91440" marT="45720" marB="45720" anchor="ctr">
                     <a:solidFill>
-                      <a:srgbClr val="FFFFFF"/>
+                      <a:srgbClr val="173A44"/>
                     </a:solidFill>
                   </a:tcPr>
                 </a:tc>
@@ -11486,7 +11534,7 @@
                       <a:r>
                         <a:rPr sz="2175" b="0">
                           <a:solidFill>
-                            <a:srgbClr val="172D36"/>
+                            <a:srgbClr val="EAF1EF"/>
                           </a:solidFill>
                           <a:latin typeface="Hiragino Sans GB"/>
                           <a:ea typeface="Hiragino Sans GB"/>
@@ -11498,7 +11546,7 @@
                   </a:txBody>
                   <a:tcPr marL="91440" marR="91440" marT="45720" marB="45720" anchor="ctr">
                     <a:solidFill>
-                      <a:srgbClr val="EDF1ED"/>
+                      <a:srgbClr val="1D4650"/>
                     </a:solidFill>
                   </a:tcPr>
                 </a:tc>
@@ -11510,7 +11558,7 @@
                       <a:r>
                         <a:rPr sz="2175" b="0">
                           <a:solidFill>
-                            <a:srgbClr val="172D36"/>
+                            <a:srgbClr val="EAF1EF"/>
                           </a:solidFill>
                           <a:latin typeface="Hiragino Sans GB"/>
                           <a:ea typeface="Hiragino Sans GB"/>
@@ -11522,7 +11570,7 @@
                   </a:txBody>
                   <a:tcPr marL="91440" marR="91440" marT="45720" marB="45720" anchor="ctr">
                     <a:solidFill>
-                      <a:srgbClr val="EDF1ED"/>
+                      <a:srgbClr val="1D4650"/>
                     </a:solidFill>
                   </a:tcPr>
                 </a:tc>
@@ -11534,7 +11582,7 @@
                       <a:r>
                         <a:rPr sz="2175" b="0">
                           <a:solidFill>
-                            <a:srgbClr val="172D36"/>
+                            <a:srgbClr val="EAF1EF"/>
                           </a:solidFill>
                           <a:latin typeface="Hiragino Sans GB"/>
                           <a:ea typeface="Hiragino Sans GB"/>
@@ -11546,7 +11594,7 @@
                   </a:txBody>
                   <a:tcPr marL="91440" marR="91440" marT="45720" marB="45720" anchor="ctr">
                     <a:solidFill>
-                      <a:srgbClr val="EDF1ED"/>
+                      <a:srgbClr val="1D4650"/>
                     </a:solidFill>
                   </a:tcPr>
                 </a:tc>
@@ -11560,7 +11608,7 @@
                       <a:r>
                         <a:rPr sz="2175" b="0">
                           <a:solidFill>
-                            <a:srgbClr val="172D36"/>
+                            <a:srgbClr val="EAF1EF"/>
                           </a:solidFill>
                           <a:latin typeface="Hiragino Sans GB"/>
                           <a:ea typeface="Hiragino Sans GB"/>
@@ -11572,7 +11620,7 @@
                   </a:txBody>
                   <a:tcPr marL="91440" marR="91440" marT="45720" marB="45720" anchor="ctr">
                     <a:solidFill>
-                      <a:srgbClr val="FFFFFF"/>
+                      <a:srgbClr val="173A44"/>
                     </a:solidFill>
                   </a:tcPr>
                 </a:tc>
@@ -11584,7 +11632,7 @@
                       <a:r>
                         <a:rPr sz="2175" b="0">
                           <a:solidFill>
-                            <a:srgbClr val="172D36"/>
+                            <a:srgbClr val="EAF1EF"/>
                           </a:solidFill>
                           <a:latin typeface="Hiragino Sans GB"/>
                           <a:ea typeface="Hiragino Sans GB"/>
@@ -11596,7 +11644,7 @@
                   </a:txBody>
                   <a:tcPr marL="91440" marR="91440" marT="45720" marB="45720" anchor="ctr">
                     <a:solidFill>
-                      <a:srgbClr val="FFFFFF"/>
+                      <a:srgbClr val="173A44"/>
                     </a:solidFill>
                   </a:tcPr>
                 </a:tc>
@@ -11608,7 +11656,7 @@
                       <a:r>
                         <a:rPr sz="2175" b="0">
                           <a:solidFill>
-                            <a:srgbClr val="172D36"/>
+                            <a:srgbClr val="EAF1EF"/>
                           </a:solidFill>
                           <a:latin typeface="Hiragino Sans GB"/>
                           <a:ea typeface="Hiragino Sans GB"/>
@@ -11620,7 +11668,7 @@
                   </a:txBody>
                   <a:tcPr marL="91440" marR="91440" marT="45720" marB="45720" anchor="ctr">
                     <a:solidFill>
-                      <a:srgbClr val="FFFFFF"/>
+                      <a:srgbClr val="173A44"/>
                     </a:solidFill>
                   </a:tcPr>
                 </a:tc>
@@ -11634,7 +11682,7 @@
                       <a:r>
                         <a:rPr sz="2175" b="0">
                           <a:solidFill>
-                            <a:srgbClr val="172D36"/>
+                            <a:srgbClr val="EAF1EF"/>
                           </a:solidFill>
                           <a:latin typeface="Hiragino Sans GB"/>
                           <a:ea typeface="Hiragino Sans GB"/>
@@ -11646,7 +11694,7 @@
                   </a:txBody>
                   <a:tcPr marL="91440" marR="91440" marT="45720" marB="45720" anchor="ctr">
                     <a:solidFill>
-                      <a:srgbClr val="EDF1ED"/>
+                      <a:srgbClr val="1D4650"/>
                     </a:solidFill>
                   </a:tcPr>
                 </a:tc>
@@ -11658,7 +11706,7 @@
                       <a:r>
                         <a:rPr sz="2175" b="0">
                           <a:solidFill>
-                            <a:srgbClr val="172D36"/>
+                            <a:srgbClr val="EAF1EF"/>
                           </a:solidFill>
                           <a:latin typeface="Hiragino Sans GB"/>
                           <a:ea typeface="Hiragino Sans GB"/>
@@ -11670,7 +11718,7 @@
                   </a:txBody>
                   <a:tcPr marL="91440" marR="91440" marT="45720" marB="45720" anchor="ctr">
                     <a:solidFill>
-                      <a:srgbClr val="EDF1ED"/>
+                      <a:srgbClr val="1D4650"/>
                     </a:solidFill>
                   </a:tcPr>
                 </a:tc>
@@ -11682,7 +11730,7 @@
                       <a:r>
                         <a:rPr sz="2175" b="0">
                           <a:solidFill>
-                            <a:srgbClr val="172D36"/>
+                            <a:srgbClr val="EAF1EF"/>
                           </a:solidFill>
                           <a:latin typeface="Hiragino Sans GB"/>
                           <a:ea typeface="Hiragino Sans GB"/>
@@ -11694,7 +11742,7 @@
                   </a:txBody>
                   <a:tcPr marL="91440" marR="91440" marT="45720" marB="45720" anchor="ctr">
                     <a:solidFill>
-                      <a:srgbClr val="EDF1ED"/>
+                      <a:srgbClr val="1D4650"/>
                     </a:solidFill>
                   </a:tcPr>
                 </a:tc>
@@ -11740,7 +11788,7 @@
               <a:buNone/>
               <a:defRPr sz="1950" b="0">
                 <a:solidFill>
-                  <a:srgbClr val="526971"/>
+                  <a:srgbClr val="A8C6C4"/>
                 </a:solidFill>
                 <a:latin typeface="Hiragino Sans GB"/>
                 <a:ea typeface="Hiragino Sans GB"/>
@@ -11750,7 +11798,7 @@
             <a:r>
               <a:rPr sz="1950" b="0">
                 <a:solidFill>
-                  <a:srgbClr val="526971"/>
+                  <a:srgbClr val="A8C6C4"/>
                 </a:solidFill>
                 <a:latin typeface="Hiragino Sans GB"/>
                 <a:ea typeface="Hiragino Sans GB"/>
@@ -12191,7 +12239,18 @@
                 <a:ea typeface="Menlo"/>
                 <a:cs typeface="Menlo"/>
               </a:rPr>
-              <a:t>#SBATCH -t 02:00:00</a:t>
+              <a:t>#SBATCH -t </a:t>
+            </a:r>
+            <a:r>
+              <a:rPr sz="2100" b="0">
+                <a:solidFill>
+                  <a:srgbClr val="B7EDDB"/>
+                </a:solidFill>
+                <a:latin typeface="Menlo"/>
+                <a:ea typeface="Menlo"/>
+                <a:cs typeface="Menlo"/>
+              </a:rPr>
+              <a:t>00:20:00</a:t>
             </a:r>
           </a:p>
         </p:txBody>
@@ -13024,7 +13083,7 @@
     <p:bg>
       <p:bgPr>
         <a:solidFill xmlns:a="http://schemas.openxmlformats.org/drawingml/2006/main">
-          <a:srgbClr val="F7F6F2"/>
+          <a:srgbClr val="102C35"/>
         </a:solidFill>
       </p:bgPr>
     </p:bg>
@@ -13074,7 +13133,7 @@
               <a:buNone/>
               <a:defRPr sz="3900" b="1">
                 <a:solidFill>
-                  <a:srgbClr val="172D36"/>
+                  <a:srgbClr val="EAF1EF"/>
                 </a:solidFill>
                 <a:latin typeface="Hiragino Sans GB"/>
                 <a:ea typeface="Hiragino Sans GB"/>
@@ -13084,7 +13143,7 @@
             <a:r>
               <a:rPr sz="3900" b="1">
                 <a:solidFill>
-                  <a:srgbClr val="172D36"/>
+                  <a:srgbClr val="EAF1EF"/>
                 </a:solidFill>
                 <a:latin typeface="Hiragino Sans GB"/>
                 <a:ea typeface="Hiragino Sans GB"/>
@@ -13132,7 +13191,7 @@
               <a:buNone/>
               <a:defRPr sz="1650" b="0">
                 <a:solidFill>
-                  <a:srgbClr val="526971"/>
+                  <a:srgbClr val="A8C6C4"/>
                 </a:solidFill>
                 <a:latin typeface="Hiragino Sans GB"/>
                 <a:ea typeface="Hiragino Sans GB"/>
@@ -13142,7 +13201,7 @@
             <a:r>
               <a:rPr sz="1650" b="0">
                 <a:solidFill>
-                  <a:srgbClr val="526971"/>
+                  <a:srgbClr val="A8C6C4"/>
                 </a:solidFill>
                 <a:latin typeface="Hiragino Sans GB"/>
                 <a:ea typeface="Hiragino Sans GB"/>
@@ -13190,7 +13249,7 @@
               <a:buNone/>
               <a:defRPr sz="2100" b="0">
                 <a:solidFill>
-                  <a:srgbClr val="506C78"/>
+                  <a:srgbClr val="A8C6C4"/>
                 </a:solidFill>
                 <a:latin typeface="Hiragino Sans GB"/>
                 <a:ea typeface="Hiragino Sans GB"/>
@@ -13200,7 +13259,7 @@
             <a:r>
               <a:rPr sz="2100" b="0">
                 <a:solidFill>
-                  <a:srgbClr val="506C78"/>
+                  <a:srgbClr val="A8C6C4"/>
                 </a:solidFill>
                 <a:latin typeface="Hiragino Sans GB"/>
                 <a:ea typeface="Hiragino Sans GB"/>
@@ -13248,7 +13307,7 @@
               <a:buNone/>
               <a:defRPr sz="2250" b="0">
                 <a:solidFill>
-                  <a:srgbClr val="087F75"/>
+                  <a:srgbClr val="B7EDDB"/>
                 </a:solidFill>
                 <a:latin typeface="Menlo"/>
                 <a:ea typeface="Menlo"/>
@@ -13258,7 +13317,7 @@
             <a:r>
               <a:rPr sz="2250" b="0">
                 <a:solidFill>
-                  <a:srgbClr val="087F75"/>
+                  <a:srgbClr val="B7EDDB"/>
                 </a:solidFill>
                 <a:latin typeface="Menlo"/>
                 <a:ea typeface="Menlo"/>
@@ -13306,7 +13365,7 @@
               <a:buNone/>
               <a:defRPr sz="2250" b="0">
                 <a:solidFill>
-                  <a:srgbClr val="087F75"/>
+                  <a:srgbClr val="B7EDDB"/>
                 </a:solidFill>
                 <a:latin typeface="Menlo"/>
                 <a:ea typeface="Menlo"/>
@@ -13316,7 +13375,7 @@
             <a:r>
               <a:rPr sz="2250" b="0">
                 <a:solidFill>
-                  <a:srgbClr val="087F75"/>
+                  <a:srgbClr val="B7EDDB"/>
                 </a:solidFill>
                 <a:latin typeface="Menlo"/>
                 <a:ea typeface="Menlo"/>
@@ -13327,7 +13386,7 @@
             <a:r>
               <a:rPr sz="2250" b="0">
                 <a:solidFill>
-                  <a:srgbClr val="087F75"/>
+                  <a:srgbClr val="B7EDDB"/>
                 </a:solidFill>
                 <a:latin typeface="Menlo"/>
                 <a:ea typeface="Menlo"/>
@@ -13338,7 +13397,7 @@
             <a:r>
               <a:rPr sz="2250" b="0">
                 <a:solidFill>
-                  <a:srgbClr val="087F75"/>
+                  <a:srgbClr val="B7EDDB"/>
                 </a:solidFill>
                 <a:latin typeface="Menlo"/>
                 <a:ea typeface="Menlo"/>
@@ -13386,7 +13445,7 @@
               <a:buNone/>
               <a:defRPr sz="2250" b="0">
                 <a:solidFill>
-                  <a:srgbClr val="087F75"/>
+                  <a:srgbClr val="B7EDDB"/>
                 </a:solidFill>
                 <a:latin typeface="Menlo"/>
                 <a:ea typeface="Menlo"/>
@@ -13396,7 +13455,7 @@
             <a:r>
               <a:rPr sz="2250" b="0">
                 <a:solidFill>
-                  <a:srgbClr val="087F75"/>
+                  <a:srgbClr val="B7EDDB"/>
                 </a:solidFill>
                 <a:latin typeface="Menlo"/>
                 <a:ea typeface="Menlo"/>
@@ -13444,7 +13503,7 @@
               <a:buNone/>
               <a:defRPr sz="2250" b="0">
                 <a:solidFill>
-                  <a:srgbClr val="087F75"/>
+                  <a:srgbClr val="B7EDDB"/>
                 </a:solidFill>
                 <a:latin typeface="Menlo"/>
                 <a:ea typeface="Menlo"/>
@@ -13454,7 +13513,7 @@
             <a:r>
               <a:rPr sz="2250" b="0">
                 <a:solidFill>
-                  <a:srgbClr val="087F75"/>
+                  <a:srgbClr val="B7EDDB"/>
                 </a:solidFill>
                 <a:latin typeface="Menlo"/>
                 <a:ea typeface="Menlo"/>
@@ -13502,7 +13561,7 @@
               <a:buNone/>
               <a:defRPr sz="2250" b="0">
                 <a:solidFill>
-                  <a:srgbClr val="087F75"/>
+                  <a:srgbClr val="B7EDDB"/>
                 </a:solidFill>
                 <a:latin typeface="Menlo"/>
                 <a:ea typeface="Menlo"/>
@@ -13512,7 +13571,7 @@
             <a:r>
               <a:rPr sz="2250" b="0">
                 <a:solidFill>
-                  <a:srgbClr val="087F75"/>
+                  <a:srgbClr val="B7EDDB"/>
                 </a:solidFill>
                 <a:latin typeface="Menlo"/>
                 <a:ea typeface="Menlo"/>
@@ -13560,7 +13619,7 @@
               <a:buNone/>
               <a:defRPr sz="2175" b="0">
                 <a:solidFill>
-                  <a:srgbClr val="172D36"/>
+                  <a:srgbClr val="EAF1EF"/>
                 </a:solidFill>
                 <a:latin typeface="Hiragino Sans GB"/>
                 <a:ea typeface="Hiragino Sans GB"/>
@@ -13570,7 +13629,7 @@
             <a:r>
               <a:rPr sz="2175" b="0">
                 <a:solidFill>
-                  <a:srgbClr val="172D36"/>
+                  <a:srgbClr val="EAF1EF"/>
                 </a:solidFill>
                 <a:latin typeface="Hiragino Sans GB"/>
                 <a:ea typeface="Hiragino Sans GB"/>
@@ -13618,7 +13677,7 @@
               <a:buNone/>
               <a:defRPr sz="2100" b="1">
                 <a:solidFill>
-                  <a:srgbClr val="172D36"/>
+                  <a:srgbClr val="EAF1EF"/>
                 </a:solidFill>
                 <a:latin typeface="Hiragino Sans GB"/>
                 <a:ea typeface="Hiragino Sans GB"/>
@@ -13628,7 +13687,7 @@
             <a:r>
               <a:rPr sz="2100" b="1">
                 <a:solidFill>
-                  <a:srgbClr val="172D36"/>
+                  <a:srgbClr val="EAF1EF"/>
                 </a:solidFill>
                 <a:latin typeface="Hiragino Sans GB"/>
                 <a:ea typeface="Hiragino Sans GB"/>
@@ -13676,7 +13735,7 @@
               <a:buNone/>
               <a:defRPr sz="2025" b="0">
                 <a:solidFill>
-                  <a:srgbClr val="506C78"/>
+                  <a:srgbClr val="A8C6C4"/>
                 </a:solidFill>
                 <a:latin typeface="Hiragino Sans GB"/>
                 <a:ea typeface="Hiragino Sans GB"/>
@@ -13686,7 +13745,7 @@
             <a:r>
               <a:rPr sz="2025" b="0">
                 <a:solidFill>
-                  <a:srgbClr val="506C78"/>
+                  <a:srgbClr val="A8C6C4"/>
                 </a:solidFill>
                 <a:latin typeface="Hiragino Sans GB"/>
                 <a:ea typeface="Hiragino Sans GB"/>
@@ -13713,7 +13772,7 @@
     <p:bg>
       <p:bgPr>
         <a:solidFill xmlns:a="http://schemas.openxmlformats.org/drawingml/2006/main">
-          <a:srgbClr val="F7F6F2"/>
+          <a:srgbClr val="102C35"/>
         </a:solidFill>
       </p:bgPr>
     </p:bg>
@@ -13763,7 +13822,7 @@
               <a:buNone/>
               <a:defRPr sz="3900" b="1">
                 <a:solidFill>
-                  <a:srgbClr val="172D36"/>
+                  <a:srgbClr val="EAF1EF"/>
                 </a:solidFill>
                 <a:latin typeface="Hiragino Sans GB"/>
                 <a:ea typeface="Hiragino Sans GB"/>
@@ -13773,7 +13832,7 @@
             <a:r>
               <a:rPr sz="3900" b="1">
                 <a:solidFill>
-                  <a:srgbClr val="172D36"/>
+                  <a:srgbClr val="EAF1EF"/>
                 </a:solidFill>
                 <a:latin typeface="Hiragino Sans GB"/>
                 <a:ea typeface="Hiragino Sans GB"/>
@@ -13821,7 +13880,7 @@
               <a:buNone/>
               <a:defRPr sz="1650" b="0">
                 <a:solidFill>
-                  <a:srgbClr val="526971"/>
+                  <a:srgbClr val="A8C6C4"/>
                 </a:solidFill>
                 <a:latin typeface="Hiragino Sans GB"/>
                 <a:ea typeface="Hiragino Sans GB"/>
@@ -13831,7 +13890,7 @@
             <a:r>
               <a:rPr sz="1650" b="0">
                 <a:solidFill>
-                  <a:srgbClr val="526971"/>
+                  <a:srgbClr val="A8C6C4"/>
                 </a:solidFill>
                 <a:latin typeface="Hiragino Sans GB"/>
                 <a:ea typeface="Hiragino Sans GB"/>
@@ -13879,7 +13938,7 @@
               <a:buNone/>
               <a:defRPr sz="2100" b="0">
                 <a:solidFill>
-                  <a:srgbClr val="506C78"/>
+                  <a:srgbClr val="A8C6C4"/>
                 </a:solidFill>
                 <a:latin typeface="Hiragino Sans GB"/>
                 <a:ea typeface="Hiragino Sans GB"/>
@@ -13889,7 +13948,7 @@
             <a:r>
               <a:rPr sz="2100" b="0">
                 <a:solidFill>
-                  <a:srgbClr val="506C78"/>
+                  <a:srgbClr val="A8C6C4"/>
                 </a:solidFill>
                 <a:latin typeface="Hiragino Sans GB"/>
                 <a:ea typeface="Hiragino Sans GB"/>
@@ -13937,7 +13996,7 @@
               <a:buNone/>
               <a:defRPr sz="2250" b="0">
                 <a:solidFill>
-                  <a:srgbClr val="087F75"/>
+                  <a:srgbClr val="B7EDDB"/>
                 </a:solidFill>
                 <a:latin typeface="Menlo"/>
                 <a:ea typeface="Menlo"/>
@@ -13947,7 +14006,7 @@
             <a:r>
               <a:rPr sz="2250" b="0">
                 <a:solidFill>
-                  <a:srgbClr val="087F75"/>
+                  <a:srgbClr val="B7EDDB"/>
                 </a:solidFill>
                 <a:latin typeface="Menlo"/>
                 <a:ea typeface="Menlo"/>
@@ -13995,7 +14054,7 @@
               <a:buNone/>
               <a:defRPr sz="2250" b="0">
                 <a:solidFill>
-                  <a:srgbClr val="087F75"/>
+                  <a:srgbClr val="B7EDDB"/>
                 </a:solidFill>
                 <a:latin typeface="Menlo"/>
                 <a:ea typeface="Menlo"/>
@@ -14005,7 +14064,7 @@
             <a:r>
               <a:rPr sz="2250" b="0">
                 <a:solidFill>
-                  <a:srgbClr val="087F75"/>
+                  <a:srgbClr val="B7EDDB"/>
                 </a:solidFill>
                 <a:latin typeface="Menlo"/>
                 <a:ea typeface="Menlo"/>
@@ -14053,7 +14112,7 @@
               <a:buNone/>
               <a:defRPr sz="2250" b="0">
                 <a:solidFill>
-                  <a:srgbClr val="087F75"/>
+                  <a:srgbClr val="B7EDDB"/>
                 </a:solidFill>
                 <a:latin typeface="Menlo"/>
                 <a:ea typeface="Menlo"/>
@@ -14063,7 +14122,7 @@
             <a:r>
               <a:rPr sz="2250" b="0">
                 <a:solidFill>
-                  <a:srgbClr val="087F75"/>
+                  <a:srgbClr val="B7EDDB"/>
                 </a:solidFill>
                 <a:latin typeface="Menlo"/>
                 <a:ea typeface="Menlo"/>
@@ -14111,7 +14170,7 @@
               <a:buNone/>
               <a:defRPr sz="2250" b="0">
                 <a:solidFill>
-                  <a:srgbClr val="087F75"/>
+                  <a:srgbClr val="B7EDDB"/>
                 </a:solidFill>
                 <a:latin typeface="Menlo"/>
                 <a:ea typeface="Menlo"/>
@@ -14121,7 +14180,7 @@
             <a:r>
               <a:rPr sz="2250" b="0">
                 <a:solidFill>
-                  <a:srgbClr val="087F75"/>
+                  <a:srgbClr val="B7EDDB"/>
                 </a:solidFill>
                 <a:latin typeface="Menlo"/>
                 <a:ea typeface="Menlo"/>
@@ -14169,7 +14228,7 @@
               <a:buNone/>
               <a:defRPr sz="2250" b="0">
                 <a:solidFill>
-                  <a:srgbClr val="087F75"/>
+                  <a:srgbClr val="B7EDDB"/>
                 </a:solidFill>
                 <a:latin typeface="Menlo"/>
                 <a:ea typeface="Menlo"/>
@@ -14179,7 +14238,7 @@
             <a:r>
               <a:rPr sz="2250" b="0">
                 <a:solidFill>
-                  <a:srgbClr val="087F75"/>
+                  <a:srgbClr val="B7EDDB"/>
                 </a:solidFill>
                 <a:latin typeface="Menlo"/>
                 <a:ea typeface="Menlo"/>
@@ -14227,7 +14286,7 @@
               <a:buNone/>
               <a:defRPr sz="2250" b="0">
                 <a:solidFill>
-                  <a:srgbClr val="087F75"/>
+                  <a:srgbClr val="B7EDDB"/>
                 </a:solidFill>
                 <a:latin typeface="Menlo"/>
                 <a:ea typeface="Menlo"/>
@@ -14237,7 +14296,7 @@
             <a:r>
               <a:rPr sz="2250" b="0">
                 <a:solidFill>
-                  <a:srgbClr val="087F75"/>
+                  <a:srgbClr val="B7EDDB"/>
                 </a:solidFill>
                 <a:latin typeface="Menlo"/>
                 <a:ea typeface="Menlo"/>
@@ -14285,7 +14344,7 @@
               <a:buNone/>
               <a:defRPr sz="2325" b="0">
                 <a:solidFill>
-                  <a:srgbClr val="172D36"/>
+                  <a:srgbClr val="EAF1EF"/>
                 </a:solidFill>
                 <a:latin typeface="Hiragino Sans GB"/>
                 <a:ea typeface="Hiragino Sans GB"/>
@@ -14295,7 +14354,7 @@
             <a:r>
               <a:rPr sz="2325" b="0">
                 <a:solidFill>
-                  <a:srgbClr val="172D36"/>
+                  <a:srgbClr val="EAF1EF"/>
                 </a:solidFill>
                 <a:latin typeface="Hiragino Sans GB"/>
                 <a:ea typeface="Hiragino Sans GB"/>
@@ -14343,7 +14402,7 @@
               <a:buNone/>
               <a:defRPr sz="2025" b="0">
                 <a:solidFill>
-                  <a:srgbClr val="506C78"/>
+                  <a:srgbClr val="A8C6C4"/>
                 </a:solidFill>
                 <a:latin typeface="Hiragino Sans GB"/>
                 <a:ea typeface="Hiragino Sans GB"/>
@@ -14353,7 +14412,7 @@
             <a:r>
               <a:rPr sz="2025" b="0">
                 <a:solidFill>
-                  <a:srgbClr val="506C78"/>
+                  <a:srgbClr val="A8C6C4"/>
                 </a:solidFill>
                 <a:latin typeface="Hiragino Sans GB"/>
                 <a:ea typeface="Hiragino Sans GB"/>
@@ -14380,7 +14439,7 @@
     <p:bg>
       <p:bgPr>
         <a:solidFill xmlns:a="http://schemas.openxmlformats.org/drawingml/2006/main">
-          <a:srgbClr val="F7F6F2"/>
+          <a:srgbClr val="102C35"/>
         </a:solidFill>
       </p:bgPr>
     </p:bg>
@@ -14430,7 +14489,7 @@
               <a:buNone/>
               <a:defRPr sz="3900" b="1">
                 <a:solidFill>
-                  <a:srgbClr val="172D36"/>
+                  <a:srgbClr val="EAF1EF"/>
                 </a:solidFill>
                 <a:latin typeface="Hiragino Sans GB"/>
                 <a:ea typeface="Hiragino Sans GB"/>
@@ -14440,7 +14499,7 @@
             <a:r>
               <a:rPr sz="3900" b="1">
                 <a:solidFill>
-                  <a:srgbClr val="172D36"/>
+                  <a:srgbClr val="EAF1EF"/>
                 </a:solidFill>
                 <a:latin typeface="Hiragino Sans GB"/>
                 <a:ea typeface="Hiragino Sans GB"/>
@@ -14488,7 +14547,7 @@
               <a:buNone/>
               <a:defRPr sz="1650" b="0">
                 <a:solidFill>
-                  <a:srgbClr val="526971"/>
+                  <a:srgbClr val="A8C6C4"/>
                 </a:solidFill>
                 <a:latin typeface="Hiragino Sans GB"/>
                 <a:ea typeface="Hiragino Sans GB"/>
@@ -14498,7 +14557,7 @@
             <a:r>
               <a:rPr sz="1650" b="0">
                 <a:solidFill>
-                  <a:srgbClr val="526971"/>
+                  <a:srgbClr val="A8C6C4"/>
                 </a:solidFill>
                 <a:latin typeface="Hiragino Sans GB"/>
                 <a:ea typeface="Hiragino Sans GB"/>
@@ -14546,7 +14605,7 @@
               <a:buNone/>
               <a:defRPr sz="2100" b="0">
                 <a:solidFill>
-                  <a:srgbClr val="506C78"/>
+                  <a:srgbClr val="A8C6C4"/>
                 </a:solidFill>
                 <a:latin typeface="Hiragino Sans GB"/>
                 <a:ea typeface="Hiragino Sans GB"/>
@@ -14556,7 +14615,7 @@
             <a:r>
               <a:rPr sz="2100" b="0">
                 <a:solidFill>
-                  <a:srgbClr val="506C78"/>
+                  <a:srgbClr val="A8C6C4"/>
                 </a:solidFill>
                 <a:latin typeface="Hiragino Sans GB"/>
                 <a:ea typeface="Hiragino Sans GB"/>
@@ -14604,7 +14663,7 @@
               <a:buNone/>
               <a:defRPr sz="2250" b="0">
                 <a:solidFill>
-                  <a:srgbClr val="087F75"/>
+                  <a:srgbClr val="B7EDDB"/>
                 </a:solidFill>
                 <a:latin typeface="Menlo"/>
                 <a:ea typeface="Menlo"/>
@@ -14614,7 +14673,7 @@
             <a:r>
               <a:rPr sz="2250" b="0">
                 <a:solidFill>
-                  <a:srgbClr val="087F75"/>
+                  <a:srgbClr val="B7EDDB"/>
                 </a:solidFill>
                 <a:latin typeface="Menlo"/>
                 <a:ea typeface="Menlo"/>
@@ -14662,7 +14721,7 @@
               <a:buNone/>
               <a:defRPr sz="2250" b="0">
                 <a:solidFill>
-                  <a:srgbClr val="087F75"/>
+                  <a:srgbClr val="B7EDDB"/>
                 </a:solidFill>
                 <a:latin typeface="Menlo"/>
                 <a:ea typeface="Menlo"/>
@@ -14672,7 +14731,7 @@
             <a:r>
               <a:rPr sz="2250" b="0">
                 <a:solidFill>
-                  <a:srgbClr val="087F75"/>
+                  <a:srgbClr val="B7EDDB"/>
                 </a:solidFill>
                 <a:latin typeface="Menlo"/>
                 <a:ea typeface="Menlo"/>
@@ -14720,7 +14779,7 @@
               <a:buNone/>
               <a:defRPr sz="2250" b="0">
                 <a:solidFill>
-                  <a:srgbClr val="087F75"/>
+                  <a:srgbClr val="B7EDDB"/>
                 </a:solidFill>
                 <a:latin typeface="Menlo"/>
                 <a:ea typeface="Menlo"/>
@@ -14730,7 +14789,7 @@
             <a:r>
               <a:rPr sz="2250" b="0">
                 <a:solidFill>
-                  <a:srgbClr val="087F75"/>
+                  <a:srgbClr val="B7EDDB"/>
                 </a:solidFill>
                 <a:latin typeface="Menlo"/>
                 <a:ea typeface="Menlo"/>
@@ -14778,7 +14837,7 @@
               <a:buNone/>
               <a:defRPr sz="2250" b="0">
                 <a:solidFill>
-                  <a:srgbClr val="087F75"/>
+                  <a:srgbClr val="B7EDDB"/>
                 </a:solidFill>
                 <a:latin typeface="Menlo"/>
                 <a:ea typeface="Menlo"/>
@@ -14788,7 +14847,7 @@
             <a:r>
               <a:rPr sz="2250" b="0">
                 <a:solidFill>
-                  <a:srgbClr val="087F75"/>
+                  <a:srgbClr val="B7EDDB"/>
                 </a:solidFill>
                 <a:latin typeface="Menlo"/>
                 <a:ea typeface="Menlo"/>
@@ -14836,7 +14895,7 @@
               <a:buNone/>
               <a:defRPr sz="2250" b="0">
                 <a:solidFill>
-                  <a:srgbClr val="087F75"/>
+                  <a:srgbClr val="B7EDDB"/>
                 </a:solidFill>
                 <a:latin typeface="Menlo"/>
                 <a:ea typeface="Menlo"/>
@@ -14846,7 +14905,7 @@
             <a:r>
               <a:rPr sz="2250" b="0">
                 <a:solidFill>
-                  <a:srgbClr val="087F75"/>
+                  <a:srgbClr val="B7EDDB"/>
                 </a:solidFill>
                 <a:latin typeface="Menlo"/>
                 <a:ea typeface="Menlo"/>
@@ -14894,7 +14953,7 @@
               <a:buNone/>
               <a:defRPr sz="2250" b="0">
                 <a:solidFill>
-                  <a:srgbClr val="087F75"/>
+                  <a:srgbClr val="B7EDDB"/>
                 </a:solidFill>
                 <a:latin typeface="Menlo"/>
                 <a:ea typeface="Menlo"/>
@@ -14904,7 +14963,7 @@
             <a:r>
               <a:rPr sz="2250" b="0">
                 <a:solidFill>
-                  <a:srgbClr val="087F75"/>
+                  <a:srgbClr val="B7EDDB"/>
                 </a:solidFill>
                 <a:latin typeface="Menlo"/>
                 <a:ea typeface="Menlo"/>
@@ -14952,7 +15011,7 @@
               <a:buNone/>
               <a:defRPr sz="2250" b="0">
                 <a:solidFill>
-                  <a:srgbClr val="087F75"/>
+                  <a:srgbClr val="B7EDDB"/>
                 </a:solidFill>
                 <a:latin typeface="Menlo"/>
                 <a:ea typeface="Menlo"/>
@@ -14962,7 +15021,7 @@
             <a:r>
               <a:rPr sz="2250" b="0">
                 <a:solidFill>
-                  <a:srgbClr val="087F75"/>
+                  <a:srgbClr val="B7EDDB"/>
                 </a:solidFill>
                 <a:latin typeface="Menlo"/>
                 <a:ea typeface="Menlo"/>
@@ -15010,7 +15069,7 @@
               <a:buNone/>
               <a:defRPr sz="2250" b="0">
                 <a:solidFill>
-                  <a:srgbClr val="172D36"/>
+                  <a:srgbClr val="EAF1EF"/>
                 </a:solidFill>
                 <a:latin typeface="Hiragino Sans GB"/>
                 <a:ea typeface="Hiragino Sans GB"/>
@@ -15020,7 +15079,7 @@
             <a:r>
               <a:rPr sz="2250" b="0">
                 <a:solidFill>
-                  <a:srgbClr val="172D36"/>
+                  <a:srgbClr val="EAF1EF"/>
                 </a:solidFill>
                 <a:latin typeface="Hiragino Sans GB"/>
                 <a:ea typeface="Hiragino Sans GB"/>
@@ -15068,7 +15127,7 @@
               <a:buNone/>
               <a:defRPr sz="2025" b="0">
                 <a:solidFill>
-                  <a:srgbClr val="506C78"/>
+                  <a:srgbClr val="A8C6C4"/>
                 </a:solidFill>
                 <a:latin typeface="Hiragino Sans GB"/>
                 <a:ea typeface="Hiragino Sans GB"/>
@@ -15078,7 +15137,7 @@
             <a:r>
               <a:rPr sz="2025" b="0">
                 <a:solidFill>
-                  <a:srgbClr val="506C78"/>
+                  <a:srgbClr val="A8C6C4"/>
                 </a:solidFill>
                 <a:latin typeface="Hiragino Sans GB"/>
                 <a:ea typeface="Hiragino Sans GB"/>
@@ -15105,7 +15164,7 @@
     <p:bg>
       <p:bgPr>
         <a:solidFill xmlns:a="http://schemas.openxmlformats.org/drawingml/2006/main">
-          <a:srgbClr val="F7F6F2"/>
+          <a:srgbClr val="102C35"/>
         </a:solidFill>
       </p:bgPr>
     </p:bg>
@@ -15155,7 +15214,7 @@
               <a:buNone/>
               <a:defRPr sz="3900" b="1">
                 <a:solidFill>
-                  <a:srgbClr val="172D36"/>
+                  <a:srgbClr val="EAF1EF"/>
                 </a:solidFill>
                 <a:latin typeface="Hiragino Sans GB"/>
                 <a:ea typeface="Hiragino Sans GB"/>
@@ -15165,7 +15224,7 @@
             <a:r>
               <a:rPr sz="3900" b="1">
                 <a:solidFill>
-                  <a:srgbClr val="172D36"/>
+                  <a:srgbClr val="EAF1EF"/>
                 </a:solidFill>
                 <a:latin typeface="Hiragino Sans GB"/>
                 <a:ea typeface="Hiragino Sans GB"/>
@@ -15213,7 +15272,7 @@
               <a:buNone/>
               <a:defRPr sz="1650" b="0">
                 <a:solidFill>
-                  <a:srgbClr val="526971"/>
+                  <a:srgbClr val="A8C6C4"/>
                 </a:solidFill>
                 <a:latin typeface="Hiragino Sans GB"/>
                 <a:ea typeface="Hiragino Sans GB"/>
@@ -15223,7 +15282,7 @@
             <a:r>
               <a:rPr sz="1650" b="0">
                 <a:solidFill>
-                  <a:srgbClr val="526971"/>
+                  <a:srgbClr val="A8C6C4"/>
                 </a:solidFill>
                 <a:latin typeface="Hiragino Sans GB"/>
                 <a:ea typeface="Hiragino Sans GB"/>
@@ -15271,7 +15330,7 @@
               <a:buNone/>
               <a:defRPr sz="2100" b="0">
                 <a:solidFill>
-                  <a:srgbClr val="506C78"/>
+                  <a:srgbClr val="A8C6C4"/>
                 </a:solidFill>
                 <a:latin typeface="Hiragino Sans GB"/>
                 <a:ea typeface="Hiragino Sans GB"/>
@@ -15281,7 +15340,7 @@
             <a:r>
               <a:rPr sz="2100" b="0">
                 <a:solidFill>
-                  <a:srgbClr val="506C78"/>
+                  <a:srgbClr val="A8C6C4"/>
                 </a:solidFill>
                 <a:latin typeface="Hiragino Sans GB"/>
                 <a:ea typeface="Hiragino Sans GB"/>
@@ -15329,7 +15388,7 @@
               <a:buNone/>
               <a:defRPr sz="2250" b="0">
                 <a:solidFill>
-                  <a:srgbClr val="087F75"/>
+                  <a:srgbClr val="B7EDDB"/>
                 </a:solidFill>
                 <a:latin typeface="Menlo"/>
                 <a:ea typeface="Menlo"/>
@@ -15339,7 +15398,7 @@
             <a:r>
               <a:rPr sz="2250" b="0">
                 <a:solidFill>
-                  <a:srgbClr val="087F75"/>
+                  <a:srgbClr val="B7EDDB"/>
                 </a:solidFill>
                 <a:latin typeface="Menlo"/>
                 <a:ea typeface="Menlo"/>
@@ -15387,7 +15446,7 @@
               <a:buNone/>
               <a:defRPr sz="2250" b="0">
                 <a:solidFill>
-                  <a:srgbClr val="087F75"/>
+                  <a:srgbClr val="B7EDDB"/>
                 </a:solidFill>
                 <a:latin typeface="Menlo"/>
                 <a:ea typeface="Menlo"/>
@@ -15397,7 +15456,7 @@
             <a:r>
               <a:rPr sz="2250" b="0">
                 <a:solidFill>
-                  <a:srgbClr val="087F75"/>
+                  <a:srgbClr val="B7EDDB"/>
                 </a:solidFill>
                 <a:latin typeface="Menlo"/>
                 <a:ea typeface="Menlo"/>
@@ -15445,7 +15504,7 @@
               <a:buNone/>
               <a:defRPr sz="2250" b="0">
                 <a:solidFill>
-                  <a:srgbClr val="087F75"/>
+                  <a:srgbClr val="B7EDDB"/>
                 </a:solidFill>
                 <a:latin typeface="Menlo"/>
                 <a:ea typeface="Menlo"/>
@@ -15455,7 +15514,7 @@
             <a:r>
               <a:rPr sz="2250" b="0">
                 <a:solidFill>
-                  <a:srgbClr val="087F75"/>
+                  <a:srgbClr val="B7EDDB"/>
                 </a:solidFill>
                 <a:latin typeface="Menlo"/>
                 <a:ea typeface="Menlo"/>
@@ -15503,7 +15562,7 @@
               <a:buNone/>
               <a:defRPr sz="2250" b="0">
                 <a:solidFill>
-                  <a:srgbClr val="087F75"/>
+                  <a:srgbClr val="B7EDDB"/>
                 </a:solidFill>
                 <a:latin typeface="Menlo"/>
                 <a:ea typeface="Menlo"/>
@@ -15513,7 +15572,7 @@
             <a:r>
               <a:rPr sz="2250" b="0">
                 <a:solidFill>
-                  <a:srgbClr val="087F75"/>
+                  <a:srgbClr val="B7EDDB"/>
                 </a:solidFill>
                 <a:latin typeface="Menlo"/>
                 <a:ea typeface="Menlo"/>
@@ -15561,7 +15620,7 @@
               <a:buNone/>
               <a:defRPr sz="2400" b="0">
                 <a:solidFill>
-                  <a:srgbClr val="172D36"/>
+                  <a:srgbClr val="EAF1EF"/>
                 </a:solidFill>
                 <a:latin typeface="Hiragino Sans GB"/>
                 <a:ea typeface="Hiragino Sans GB"/>
@@ -15571,7 +15630,7 @@
             <a:r>
               <a:rPr sz="2400" b="0">
                 <a:solidFill>
-                  <a:srgbClr val="172D36"/>
+                  <a:srgbClr val="EAF1EF"/>
                 </a:solidFill>
                 <a:latin typeface="Hiragino Sans GB"/>
                 <a:ea typeface="Hiragino Sans GB"/>
@@ -15619,7 +15678,7 @@
               <a:buNone/>
               <a:defRPr sz="2175" b="0">
                 <a:solidFill>
-                  <a:srgbClr val="172D36"/>
+                  <a:srgbClr val="EAF1EF"/>
                 </a:solidFill>
                 <a:latin typeface="Hiragino Sans GB"/>
                 <a:ea typeface="Hiragino Sans GB"/>
@@ -15629,7 +15688,7 @@
             <a:r>
               <a:rPr sz="2175" b="0">
                 <a:solidFill>
-                  <a:srgbClr val="172D36"/>
+                  <a:srgbClr val="EAF1EF"/>
                 </a:solidFill>
                 <a:latin typeface="Hiragino Sans GB"/>
                 <a:ea typeface="Hiragino Sans GB"/>
@@ -15677,7 +15736,7 @@
               <a:buNone/>
               <a:defRPr sz="2025" b="0">
                 <a:solidFill>
-                  <a:srgbClr val="506C78"/>
+                  <a:srgbClr val="A8C6C4"/>
                 </a:solidFill>
                 <a:latin typeface="Hiragino Sans GB"/>
                 <a:ea typeface="Hiragino Sans GB"/>
@@ -15687,7 +15746,7 @@
             <a:r>
               <a:rPr sz="2025" b="0">
                 <a:solidFill>
-                  <a:srgbClr val="506C78"/>
+                  <a:srgbClr val="A8C6C4"/>
                 </a:solidFill>
                 <a:latin typeface="Hiragino Sans GB"/>
                 <a:ea typeface="Hiragino Sans GB"/>
@@ -15714,7 +15773,7 @@
     <p:bg>
       <p:bgPr>
         <a:solidFill xmlns:a="http://schemas.openxmlformats.org/drawingml/2006/main">
-          <a:srgbClr val="F7F6F2"/>
+          <a:srgbClr val="102C35"/>
         </a:solidFill>
       </p:bgPr>
     </p:bg>
@@ -15764,7 +15823,7 @@
               <a:buNone/>
               <a:defRPr sz="3900" b="1">
                 <a:solidFill>
-                  <a:srgbClr val="172D36"/>
+                  <a:srgbClr val="EAF1EF"/>
                 </a:solidFill>
                 <a:latin typeface="Hiragino Sans GB"/>
                 <a:ea typeface="Hiragino Sans GB"/>
@@ -15774,7 +15833,7 @@
             <a:r>
               <a:rPr sz="3900" b="1">
                 <a:solidFill>
-                  <a:srgbClr val="172D36"/>
+                  <a:srgbClr val="EAF1EF"/>
                 </a:solidFill>
                 <a:latin typeface="Hiragino Sans GB"/>
                 <a:ea typeface="Hiragino Sans GB"/>
@@ -15822,7 +15881,7 @@
               <a:buNone/>
               <a:defRPr sz="1650" b="0">
                 <a:solidFill>
-                  <a:srgbClr val="526971"/>
+                  <a:srgbClr val="A8C6C4"/>
                 </a:solidFill>
                 <a:latin typeface="Hiragino Sans GB"/>
                 <a:ea typeface="Hiragino Sans GB"/>
@@ -15832,7 +15891,7 @@
             <a:r>
               <a:rPr sz="1650" b="0">
                 <a:solidFill>
-                  <a:srgbClr val="526971"/>
+                  <a:srgbClr val="A8C6C4"/>
                 </a:solidFill>
                 <a:latin typeface="Hiragino Sans GB"/>
                 <a:ea typeface="Hiragino Sans GB"/>
@@ -15880,7 +15939,7 @@
               <a:buNone/>
               <a:defRPr sz="2100" b="0">
                 <a:solidFill>
-                  <a:srgbClr val="506C78"/>
+                  <a:srgbClr val="A8C6C4"/>
                 </a:solidFill>
                 <a:latin typeface="Hiragino Sans GB"/>
                 <a:ea typeface="Hiragino Sans GB"/>
@@ -15890,7 +15949,7 @@
             <a:r>
               <a:rPr sz="2100" b="0">
                 <a:solidFill>
-                  <a:srgbClr val="506C78"/>
+                  <a:srgbClr val="A8C6C4"/>
                 </a:solidFill>
                 <a:latin typeface="Hiragino Sans GB"/>
                 <a:ea typeface="Hiragino Sans GB"/>
@@ -15938,7 +15997,7 @@
               <a:buNone/>
               <a:defRPr sz="2250" b="0">
                 <a:solidFill>
-                  <a:srgbClr val="087F75"/>
+                  <a:srgbClr val="B7EDDB"/>
                 </a:solidFill>
                 <a:latin typeface="Menlo"/>
                 <a:ea typeface="Menlo"/>
@@ -15948,7 +16007,7 @@
             <a:r>
               <a:rPr sz="2250" b="0">
                 <a:solidFill>
-                  <a:srgbClr val="087F75"/>
+                  <a:srgbClr val="B7EDDB"/>
                 </a:solidFill>
                 <a:latin typeface="Menlo"/>
                 <a:ea typeface="Menlo"/>
@@ -15996,7 +16055,7 @@
               <a:buNone/>
               <a:defRPr sz="2250" b="0">
                 <a:solidFill>
-                  <a:srgbClr val="087F75"/>
+                  <a:srgbClr val="B7EDDB"/>
                 </a:solidFill>
                 <a:latin typeface="Menlo"/>
                 <a:ea typeface="Menlo"/>
@@ -16006,7 +16065,7 @@
             <a:r>
               <a:rPr sz="2250" b="0">
                 <a:solidFill>
-                  <a:srgbClr val="087F75"/>
+                  <a:srgbClr val="B7EDDB"/>
                 </a:solidFill>
                 <a:latin typeface="Menlo"/>
                 <a:ea typeface="Menlo"/>
@@ -16054,7 +16113,7 @@
               <a:buNone/>
               <a:defRPr sz="2250" b="0">
                 <a:solidFill>
-                  <a:srgbClr val="087F75"/>
+                  <a:srgbClr val="B7EDDB"/>
                 </a:solidFill>
                 <a:latin typeface="Menlo"/>
                 <a:ea typeface="Menlo"/>
@@ -16064,7 +16123,7 @@
             <a:r>
               <a:rPr sz="2250" b="0">
                 <a:solidFill>
-                  <a:srgbClr val="087F75"/>
+                  <a:srgbClr val="B7EDDB"/>
                 </a:solidFill>
                 <a:latin typeface="Menlo"/>
                 <a:ea typeface="Menlo"/>
@@ -16112,7 +16171,7 @@
               <a:buNone/>
               <a:defRPr sz="2250" b="0">
                 <a:solidFill>
-                  <a:srgbClr val="087F75"/>
+                  <a:srgbClr val="B7EDDB"/>
                 </a:solidFill>
                 <a:latin typeface="Menlo"/>
                 <a:ea typeface="Menlo"/>
@@ -16122,7 +16181,7 @@
             <a:r>
               <a:rPr sz="2250" b="0">
                 <a:solidFill>
-                  <a:srgbClr val="087F75"/>
+                  <a:srgbClr val="B7EDDB"/>
                 </a:solidFill>
                 <a:latin typeface="Menlo"/>
                 <a:ea typeface="Menlo"/>
@@ -16170,7 +16229,7 @@
               <a:buNone/>
               <a:defRPr sz="2250" b="0">
                 <a:solidFill>
-                  <a:srgbClr val="087F75"/>
+                  <a:srgbClr val="B7EDDB"/>
                 </a:solidFill>
                 <a:latin typeface="Menlo"/>
                 <a:ea typeface="Menlo"/>
@@ -16180,7 +16239,7 @@
             <a:r>
               <a:rPr sz="2250" b="0">
                 <a:solidFill>
-                  <a:srgbClr val="087F75"/>
+                  <a:srgbClr val="B7EDDB"/>
                 </a:solidFill>
                 <a:latin typeface="Menlo"/>
                 <a:ea typeface="Menlo"/>
@@ -16228,7 +16287,7 @@
               <a:buNone/>
               <a:defRPr sz="2250" b="0">
                 <a:solidFill>
-                  <a:srgbClr val="087F75"/>
+                  <a:srgbClr val="B7EDDB"/>
                 </a:solidFill>
                 <a:latin typeface="Menlo"/>
                 <a:ea typeface="Menlo"/>
@@ -16238,7 +16297,7 @@
             <a:r>
               <a:rPr sz="2250" b="0">
                 <a:solidFill>
-                  <a:srgbClr val="087F75"/>
+                  <a:srgbClr val="B7EDDB"/>
                 </a:solidFill>
                 <a:latin typeface="Menlo"/>
                 <a:ea typeface="Menlo"/>
@@ -16286,7 +16345,7 @@
               <a:buNone/>
               <a:defRPr sz="2250" b="0">
                 <a:solidFill>
-                  <a:srgbClr val="172D36"/>
+                  <a:srgbClr val="EAF1EF"/>
                 </a:solidFill>
                 <a:latin typeface="Hiragino Sans GB"/>
                 <a:ea typeface="Hiragino Sans GB"/>
@@ -16296,7 +16355,7 @@
             <a:r>
               <a:rPr sz="2250" b="0">
                 <a:solidFill>
-                  <a:srgbClr val="172D36"/>
+                  <a:srgbClr val="EAF1EF"/>
                 </a:solidFill>
                 <a:latin typeface="Hiragino Sans GB"/>
                 <a:ea typeface="Hiragino Sans GB"/>
@@ -16344,7 +16403,7 @@
               <a:buNone/>
               <a:defRPr sz="2025" b="0">
                 <a:solidFill>
-                  <a:srgbClr val="506C78"/>
+                  <a:srgbClr val="A8C6C4"/>
                 </a:solidFill>
                 <a:latin typeface="Hiragino Sans GB"/>
                 <a:ea typeface="Hiragino Sans GB"/>
@@ -16354,7 +16413,7 @@
             <a:r>
               <a:rPr sz="2025" b="0">
                 <a:solidFill>
-                  <a:srgbClr val="506C78"/>
+                  <a:srgbClr val="A8C6C4"/>
                 </a:solidFill>
                 <a:latin typeface="Hiragino Sans GB"/>
                 <a:ea typeface="Hiragino Sans GB"/>
@@ -16381,7 +16440,7 @@
     <p:bg>
       <p:bgPr>
         <a:solidFill xmlns:a="http://schemas.openxmlformats.org/drawingml/2006/main">
-          <a:srgbClr val="F7F6F2"/>
+          <a:srgbClr val="102C35"/>
         </a:solidFill>
       </p:bgPr>
     </p:bg>
@@ -16431,7 +16490,7 @@
               <a:buNone/>
               <a:defRPr sz="3900" b="1">
                 <a:solidFill>
-                  <a:srgbClr val="172D36"/>
+                  <a:srgbClr val="EAF1EF"/>
                 </a:solidFill>
                 <a:latin typeface="Hiragino Sans GB"/>
                 <a:ea typeface="Hiragino Sans GB"/>
@@ -16441,7 +16500,7 @@
             <a:r>
               <a:rPr sz="3900" b="1">
                 <a:solidFill>
-                  <a:srgbClr val="172D36"/>
+                  <a:srgbClr val="EAF1EF"/>
                 </a:solidFill>
                 <a:latin typeface="Hiragino Sans GB"/>
                 <a:ea typeface="Hiragino Sans GB"/>
@@ -16489,7 +16548,7 @@
               <a:buNone/>
               <a:defRPr sz="1650" b="0">
                 <a:solidFill>
-                  <a:srgbClr val="526971"/>
+                  <a:srgbClr val="A8C6C4"/>
                 </a:solidFill>
                 <a:latin typeface="Hiragino Sans GB"/>
                 <a:ea typeface="Hiragino Sans GB"/>
@@ -16499,7 +16558,7 @@
             <a:r>
               <a:rPr sz="1650" b="0">
                 <a:solidFill>
-                  <a:srgbClr val="526971"/>
+                  <a:srgbClr val="A8C6C4"/>
                 </a:solidFill>
                 <a:latin typeface="Hiragino Sans GB"/>
                 <a:ea typeface="Hiragino Sans GB"/>
@@ -16547,7 +16606,7 @@
               <a:buNone/>
               <a:defRPr sz="2100" b="0">
                 <a:solidFill>
-                  <a:srgbClr val="506C78"/>
+                  <a:srgbClr val="A8C6C4"/>
                 </a:solidFill>
                 <a:latin typeface="Hiragino Sans GB"/>
                 <a:ea typeface="Hiragino Sans GB"/>
@@ -16557,7 +16616,7 @@
             <a:r>
               <a:rPr sz="2100" b="0">
                 <a:solidFill>
-                  <a:srgbClr val="506C78"/>
+                  <a:srgbClr val="A8C6C4"/>
                 </a:solidFill>
                 <a:latin typeface="Hiragino Sans GB"/>
                 <a:ea typeface="Hiragino Sans GB"/>
@@ -16605,7 +16664,7 @@
               <a:buNone/>
               <a:defRPr sz="2100" b="0">
                 <a:solidFill>
-                  <a:srgbClr val="087F75"/>
+                  <a:srgbClr val="B7EDDB"/>
                 </a:solidFill>
                 <a:latin typeface="Menlo"/>
                 <a:ea typeface="Menlo"/>
@@ -16615,7 +16674,7 @@
             <a:r>
               <a:rPr sz="2100" b="0">
                 <a:solidFill>
-                  <a:srgbClr val="087F75"/>
+                  <a:srgbClr val="B7EDDB"/>
                 </a:solidFill>
                 <a:latin typeface="Menlo"/>
                 <a:ea typeface="Menlo"/>
@@ -16663,7 +16722,7 @@
               <a:buNone/>
               <a:defRPr sz="2100" b="0">
                 <a:solidFill>
-                  <a:srgbClr val="087F75"/>
+                  <a:srgbClr val="B7EDDB"/>
                 </a:solidFill>
                 <a:latin typeface="Menlo"/>
                 <a:ea typeface="Menlo"/>
@@ -16673,7 +16732,7 @@
             <a:r>
               <a:rPr sz="2100" b="0">
                 <a:solidFill>
-                  <a:srgbClr val="087F75"/>
+                  <a:srgbClr val="B7EDDB"/>
                 </a:solidFill>
                 <a:latin typeface="Menlo"/>
                 <a:ea typeface="Menlo"/>
@@ -16721,7 +16780,7 @@
               <a:buNone/>
               <a:defRPr sz="2100" b="0">
                 <a:solidFill>
-                  <a:srgbClr val="087F75"/>
+                  <a:srgbClr val="B7EDDB"/>
                 </a:solidFill>
                 <a:latin typeface="Menlo"/>
                 <a:ea typeface="Menlo"/>
@@ -16731,7 +16790,7 @@
             <a:r>
               <a:rPr sz="2100" b="0">
                 <a:solidFill>
-                  <a:srgbClr val="087F75"/>
+                  <a:srgbClr val="B7EDDB"/>
                 </a:solidFill>
                 <a:latin typeface="Menlo"/>
                 <a:ea typeface="Menlo"/>
@@ -16779,7 +16838,7 @@
               <a:buNone/>
               <a:defRPr sz="2100" b="0">
                 <a:solidFill>
-                  <a:srgbClr val="087F75"/>
+                  <a:srgbClr val="B7EDDB"/>
                 </a:solidFill>
                 <a:latin typeface="Menlo"/>
                 <a:ea typeface="Menlo"/>
@@ -16789,7 +16848,7 @@
             <a:r>
               <a:rPr sz="2100" b="0">
                 <a:solidFill>
-                  <a:srgbClr val="087F75"/>
+                  <a:srgbClr val="B7EDDB"/>
                 </a:solidFill>
                 <a:latin typeface="Menlo"/>
                 <a:ea typeface="Menlo"/>
@@ -16837,7 +16896,7 @@
               <a:buNone/>
               <a:defRPr sz="2100" b="0">
                 <a:solidFill>
-                  <a:srgbClr val="087F75"/>
+                  <a:srgbClr val="B7EDDB"/>
                 </a:solidFill>
                 <a:latin typeface="Menlo"/>
                 <a:ea typeface="Menlo"/>
@@ -16847,7 +16906,7 @@
             <a:r>
               <a:rPr sz="2100" b="0">
                 <a:solidFill>
-                  <a:srgbClr val="087F75"/>
+                  <a:srgbClr val="B7EDDB"/>
                 </a:solidFill>
                 <a:latin typeface="Menlo"/>
                 <a:ea typeface="Menlo"/>
@@ -16895,7 +16954,7 @@
               <a:buNone/>
               <a:defRPr sz="2100" b="0">
                 <a:solidFill>
-                  <a:srgbClr val="087F75"/>
+                  <a:srgbClr val="B7EDDB"/>
                 </a:solidFill>
                 <a:latin typeface="Menlo"/>
                 <a:ea typeface="Menlo"/>
@@ -16905,7 +16964,7 @@
             <a:r>
               <a:rPr sz="2100" b="0">
                 <a:solidFill>
-                  <a:srgbClr val="087F75"/>
+                  <a:srgbClr val="B7EDDB"/>
                 </a:solidFill>
                 <a:latin typeface="Menlo"/>
                 <a:ea typeface="Menlo"/>
@@ -16953,7 +17012,7 @@
               <a:buNone/>
               <a:defRPr sz="2100" b="0">
                 <a:solidFill>
-                  <a:srgbClr val="087F75"/>
+                  <a:srgbClr val="B7EDDB"/>
                 </a:solidFill>
                 <a:latin typeface="Menlo"/>
                 <a:ea typeface="Menlo"/>
@@ -16963,7 +17022,7 @@
             <a:r>
               <a:rPr sz="2100" b="0">
                 <a:solidFill>
-                  <a:srgbClr val="087F75"/>
+                  <a:srgbClr val="B7EDDB"/>
                 </a:solidFill>
                 <a:latin typeface="Menlo"/>
                 <a:ea typeface="Menlo"/>
@@ -17011,7 +17070,7 @@
               <a:buNone/>
               <a:defRPr sz="2100" b="0">
                 <a:solidFill>
-                  <a:srgbClr val="087F75"/>
+                  <a:srgbClr val="B7EDDB"/>
                 </a:solidFill>
                 <a:latin typeface="Menlo"/>
                 <a:ea typeface="Menlo"/>
@@ -17021,7 +17080,7 @@
             <a:r>
               <a:rPr sz="2100" b="0">
                 <a:solidFill>
-                  <a:srgbClr val="087F75"/>
+                  <a:srgbClr val="B7EDDB"/>
                 </a:solidFill>
                 <a:latin typeface="Menlo"/>
                 <a:ea typeface="Menlo"/>
@@ -17069,7 +17128,7 @@
               <a:buNone/>
               <a:defRPr sz="2100" b="0">
                 <a:solidFill>
-                  <a:srgbClr val="087F75"/>
+                  <a:srgbClr val="B7EDDB"/>
                 </a:solidFill>
                 <a:latin typeface="Menlo"/>
                 <a:ea typeface="Menlo"/>
@@ -17079,7 +17138,7 @@
             <a:r>
               <a:rPr sz="2100" b="0">
                 <a:solidFill>
-                  <a:srgbClr val="087F75"/>
+                  <a:srgbClr val="B7EDDB"/>
                 </a:solidFill>
                 <a:latin typeface="Menlo"/>
                 <a:ea typeface="Menlo"/>
@@ -17127,7 +17186,7 @@
               <a:buNone/>
               <a:defRPr sz="2100" b="0">
                 <a:solidFill>
-                  <a:srgbClr val="087F75"/>
+                  <a:srgbClr val="B7EDDB"/>
                 </a:solidFill>
                 <a:latin typeface="Menlo"/>
                 <a:ea typeface="Menlo"/>
@@ -17137,7 +17196,7 @@
             <a:r>
               <a:rPr sz="2100" b="0">
                 <a:solidFill>
-                  <a:srgbClr val="087F75"/>
+                  <a:srgbClr val="B7EDDB"/>
                 </a:solidFill>
                 <a:latin typeface="Menlo"/>
                 <a:ea typeface="Menlo"/>
@@ -17185,7 +17244,7 @@
               <a:buNone/>
               <a:defRPr sz="2475" b="1">
                 <a:solidFill>
-                  <a:srgbClr val="172D36"/>
+                  <a:srgbClr val="EAF1EF"/>
                 </a:solidFill>
                 <a:latin typeface="Hiragino Sans GB"/>
                 <a:ea typeface="Hiragino Sans GB"/>
@@ -17195,7 +17254,7 @@
             <a:r>
               <a:rPr sz="2475" b="1">
                 <a:solidFill>
-                  <a:srgbClr val="172D36"/>
+                  <a:srgbClr val="EAF1EF"/>
                 </a:solidFill>
                 <a:latin typeface="Hiragino Sans GB"/>
                 <a:ea typeface="Hiragino Sans GB"/>
@@ -17243,7 +17302,7 @@
               <a:buNone/>
               <a:defRPr sz="2175" b="0">
                 <a:solidFill>
-                  <a:srgbClr val="172D36"/>
+                  <a:srgbClr val="EAF1EF"/>
                 </a:solidFill>
                 <a:latin typeface="Hiragino Sans GB"/>
                 <a:ea typeface="Hiragino Sans GB"/>
@@ -17253,7 +17312,7 @@
             <a:r>
               <a:rPr sz="2175" b="0">
                 <a:solidFill>
-                  <a:srgbClr val="172D36"/>
+                  <a:srgbClr val="EAF1EF"/>
                 </a:solidFill>
                 <a:latin typeface="Hiragino Sans GB"/>
                 <a:ea typeface="Hiragino Sans GB"/>
@@ -17301,7 +17360,7 @@
               <a:buNone/>
               <a:defRPr sz="2175" b="0">
                 <a:solidFill>
-                  <a:srgbClr val="172D36"/>
+                  <a:srgbClr val="EAF1EF"/>
                 </a:solidFill>
                 <a:latin typeface="Hiragino Sans GB"/>
                 <a:ea typeface="Hiragino Sans GB"/>
@@ -17311,7 +17370,7 @@
             <a:r>
               <a:rPr sz="2175" b="0">
                 <a:solidFill>
-                  <a:srgbClr val="172D36"/>
+                  <a:srgbClr val="EAF1EF"/>
                 </a:solidFill>
                 <a:latin typeface="Hiragino Sans GB"/>
                 <a:ea typeface="Hiragino Sans GB"/>
@@ -17359,7 +17418,7 @@
               <a:buNone/>
               <a:defRPr sz="2175" b="0">
                 <a:solidFill>
-                  <a:srgbClr val="172D36"/>
+                  <a:srgbClr val="EAF1EF"/>
                 </a:solidFill>
                 <a:latin typeface="Hiragino Sans GB"/>
                 <a:ea typeface="Hiragino Sans GB"/>
@@ -17369,7 +17428,7 @@
             <a:r>
               <a:rPr sz="2175" b="0">
                 <a:solidFill>
-                  <a:srgbClr val="172D36"/>
+                  <a:srgbClr val="EAF1EF"/>
                 </a:solidFill>
                 <a:latin typeface="Hiragino Sans GB"/>
                 <a:ea typeface="Hiragino Sans GB"/>
@@ -17417,7 +17476,7 @@
               <a:buNone/>
               <a:defRPr sz="2175" b="0">
                 <a:solidFill>
-                  <a:srgbClr val="172D36"/>
+                  <a:srgbClr val="EAF1EF"/>
                 </a:solidFill>
                 <a:latin typeface="Hiragino Sans GB"/>
                 <a:ea typeface="Hiragino Sans GB"/>
@@ -17427,7 +17486,7 @@
             <a:r>
               <a:rPr sz="2175" b="0">
                 <a:solidFill>
-                  <a:srgbClr val="172D36"/>
+                  <a:srgbClr val="EAF1EF"/>
                 </a:solidFill>
                 <a:latin typeface="Hiragino Sans GB"/>
                 <a:ea typeface="Hiragino Sans GB"/>
@@ -17475,7 +17534,7 @@
               <a:buNone/>
               <a:defRPr sz="1950" b="0">
                 <a:solidFill>
-                  <a:srgbClr val="506C78"/>
+                  <a:srgbClr val="A8C6C4"/>
                 </a:solidFill>
                 <a:latin typeface="Hiragino Sans GB"/>
                 <a:ea typeface="Hiragino Sans GB"/>
@@ -17485,7 +17544,7 @@
             <a:r>
               <a:rPr sz="1950" b="0">
                 <a:solidFill>
-                  <a:srgbClr val="506C78"/>
+                  <a:srgbClr val="A8C6C4"/>
                 </a:solidFill>
                 <a:latin typeface="Hiragino Sans GB"/>
                 <a:ea typeface="Hiragino Sans GB"/>
@@ -17512,7 +17571,7 @@
     <p:bg>
       <p:bgPr>
         <a:solidFill xmlns:a="http://schemas.openxmlformats.org/drawingml/2006/main">
-          <a:srgbClr val="F7F6F2"/>
+          <a:srgbClr val="102C35"/>
         </a:solidFill>
       </p:bgPr>
     </p:bg>
@@ -17562,7 +17621,7 @@
               <a:buNone/>
               <a:defRPr sz="3900" b="1">
                 <a:solidFill>
-                  <a:srgbClr val="172D36"/>
+                  <a:srgbClr val="EAF1EF"/>
                 </a:solidFill>
                 <a:latin typeface="Hiragino Sans GB"/>
                 <a:ea typeface="Hiragino Sans GB"/>
@@ -17572,7 +17631,7 @@
             <a:r>
               <a:rPr sz="3900" b="1">
                 <a:solidFill>
-                  <a:srgbClr val="172D36"/>
+                  <a:srgbClr val="EAF1EF"/>
                 </a:solidFill>
                 <a:latin typeface="Hiragino Sans GB"/>
                 <a:ea typeface="Hiragino Sans GB"/>
@@ -17620,7 +17679,7 @@
               <a:buNone/>
               <a:defRPr sz="1650" b="0">
                 <a:solidFill>
-                  <a:srgbClr val="526971"/>
+                  <a:srgbClr val="A8C6C4"/>
                 </a:solidFill>
                 <a:latin typeface="Hiragino Sans GB"/>
                 <a:ea typeface="Hiragino Sans GB"/>
@@ -17630,7 +17689,7 @@
             <a:r>
               <a:rPr sz="1650" b="0">
                 <a:solidFill>
-                  <a:srgbClr val="526971"/>
+                  <a:srgbClr val="A8C6C4"/>
                 </a:solidFill>
                 <a:latin typeface="Hiragino Sans GB"/>
                 <a:ea typeface="Hiragino Sans GB"/>
@@ -17678,7 +17737,7 @@
               <a:buNone/>
               <a:defRPr sz="2100" b="0">
                 <a:solidFill>
-                  <a:srgbClr val="506C78"/>
+                  <a:srgbClr val="A8C6C4"/>
                 </a:solidFill>
                 <a:latin typeface="Hiragino Sans GB"/>
                 <a:ea typeface="Hiragino Sans GB"/>
@@ -17688,7 +17747,7 @@
             <a:r>
               <a:rPr sz="2100" b="0">
                 <a:solidFill>
-                  <a:srgbClr val="506C78"/>
+                  <a:srgbClr val="A8C6C4"/>
                 </a:solidFill>
                 <a:latin typeface="Hiragino Sans GB"/>
                 <a:ea typeface="Hiragino Sans GB"/>
@@ -17736,7 +17795,7 @@
               <a:buNone/>
               <a:defRPr sz="2550" b="0">
                 <a:solidFill>
-                  <a:srgbClr val="087F75"/>
+                  <a:srgbClr val="B7EDDB"/>
                 </a:solidFill>
                 <a:latin typeface="Menlo"/>
                 <a:ea typeface="Menlo"/>
@@ -17746,7 +17805,7 @@
             <a:r>
               <a:rPr sz="2550" b="0">
                 <a:solidFill>
-                  <a:srgbClr val="087F75"/>
+                  <a:srgbClr val="B7EDDB"/>
                 </a:solidFill>
                 <a:latin typeface="Menlo"/>
                 <a:ea typeface="Menlo"/>
@@ -17794,7 +17853,7 @@
               <a:buNone/>
               <a:defRPr sz="2325" b="0">
                 <a:solidFill>
-                  <a:srgbClr val="172D36"/>
+                  <a:srgbClr val="EAF1EF"/>
                 </a:solidFill>
                 <a:latin typeface="Hiragino Sans GB"/>
                 <a:ea typeface="Hiragino Sans GB"/>
@@ -17804,7 +17863,7 @@
             <a:r>
               <a:rPr sz="2325" b="0">
                 <a:solidFill>
-                  <a:srgbClr val="172D36"/>
+                  <a:srgbClr val="EAF1EF"/>
                 </a:solidFill>
                 <a:latin typeface="Hiragino Sans GB"/>
                 <a:ea typeface="Hiragino Sans GB"/>
@@ -17852,7 +17911,7 @@
               <a:buNone/>
               <a:defRPr sz="2250" b="0">
                 <a:solidFill>
-                  <a:srgbClr val="172D36"/>
+                  <a:srgbClr val="EAF1EF"/>
                 </a:solidFill>
                 <a:latin typeface="Hiragino Sans GB"/>
                 <a:ea typeface="Hiragino Sans GB"/>
@@ -17862,7 +17921,7 @@
             <a:r>
               <a:rPr sz="2250" b="0">
                 <a:solidFill>
-                  <a:srgbClr val="172D36"/>
+                  <a:srgbClr val="EAF1EF"/>
                 </a:solidFill>
                 <a:latin typeface="Hiragino Sans GB"/>
                 <a:ea typeface="Hiragino Sans GB"/>
@@ -17910,7 +17969,7 @@
               <a:buNone/>
               <a:defRPr sz="2250" b="0">
                 <a:solidFill>
-                  <a:srgbClr val="172D36"/>
+                  <a:srgbClr val="EAF1EF"/>
                 </a:solidFill>
                 <a:latin typeface="Hiragino Sans GB"/>
                 <a:ea typeface="Hiragino Sans GB"/>
@@ -17920,7 +17979,7 @@
             <a:r>
               <a:rPr sz="2250" b="0">
                 <a:solidFill>
-                  <a:srgbClr val="172D36"/>
+                  <a:srgbClr val="EAF1EF"/>
                 </a:solidFill>
                 <a:latin typeface="Hiragino Sans GB"/>
                 <a:ea typeface="Hiragino Sans GB"/>
@@ -17968,7 +18027,7 @@
               <a:buNone/>
               <a:defRPr sz="2250" b="0">
                 <a:solidFill>
-                  <a:srgbClr val="172D36"/>
+                  <a:srgbClr val="EAF1EF"/>
                 </a:solidFill>
                 <a:latin typeface="Hiragino Sans GB"/>
                 <a:ea typeface="Hiragino Sans GB"/>
@@ -17978,7 +18037,7 @@
             <a:r>
               <a:rPr sz="2250" b="0">
                 <a:solidFill>
-                  <a:srgbClr val="172D36"/>
+                  <a:srgbClr val="EAF1EF"/>
                 </a:solidFill>
                 <a:latin typeface="Hiragino Sans GB"/>
                 <a:ea typeface="Hiragino Sans GB"/>
@@ -18026,7 +18085,7 @@
               <a:buNone/>
               <a:defRPr sz="2325" b="0">
                 <a:solidFill>
-                  <a:srgbClr val="172D36"/>
+                  <a:srgbClr val="EAF1EF"/>
                 </a:solidFill>
                 <a:latin typeface="Hiragino Sans GB"/>
                 <a:ea typeface="Hiragino Sans GB"/>
@@ -18036,7 +18095,7 @@
             <a:r>
               <a:rPr sz="2325" b="0">
                 <a:solidFill>
-                  <a:srgbClr val="172D36"/>
+                  <a:srgbClr val="EAF1EF"/>
                 </a:solidFill>
                 <a:latin typeface="Hiragino Sans GB"/>
                 <a:ea typeface="Hiragino Sans GB"/>
@@ -18084,7 +18143,7 @@
               <a:buNone/>
               <a:defRPr sz="2025" b="0">
                 <a:solidFill>
-                  <a:srgbClr val="506C78"/>
+                  <a:srgbClr val="A8C6C4"/>
                 </a:solidFill>
                 <a:latin typeface="Hiragino Sans GB"/>
                 <a:ea typeface="Hiragino Sans GB"/>
@@ -18094,7 +18153,7 @@
             <a:r>
               <a:rPr sz="2025" b="0">
                 <a:solidFill>
-                  <a:srgbClr val="506C78"/>
+                  <a:srgbClr val="A8C6C4"/>
                 </a:solidFill>
                 <a:latin typeface="Hiragino Sans GB"/>
                 <a:ea typeface="Hiragino Sans GB"/>
@@ -22131,7 +22190,7 @@
     <p:bg>
       <p:bgPr>
         <a:solidFill xmlns:a="http://schemas.openxmlformats.org/drawingml/2006/main">
-          <a:srgbClr val="F7F6F2"/>
+          <a:srgbClr val="102C35"/>
         </a:solidFill>
       </p:bgPr>
     </p:bg>
@@ -22181,7 +22240,7 @@
               <a:buNone/>
               <a:defRPr sz="3900" b="1">
                 <a:solidFill>
-                  <a:srgbClr val="172D36"/>
+                  <a:srgbClr val="EAF1EF"/>
                 </a:solidFill>
                 <a:latin typeface="Hiragino Sans GB"/>
                 <a:ea typeface="Hiragino Sans GB"/>
@@ -22191,7 +22250,7 @@
             <a:r>
               <a:rPr sz="3900" b="1">
                 <a:solidFill>
-                  <a:srgbClr val="172D36"/>
+                  <a:srgbClr val="EAF1EF"/>
                 </a:solidFill>
                 <a:latin typeface="Hiragino Sans GB"/>
                 <a:ea typeface="Hiragino Sans GB"/>
@@ -22239,7 +22298,7 @@
               <a:buNone/>
               <a:defRPr sz="1650" b="0">
                 <a:solidFill>
-                  <a:srgbClr val="526971"/>
+                  <a:srgbClr val="A8C6C4"/>
                 </a:solidFill>
                 <a:latin typeface="Hiragino Sans GB"/>
                 <a:ea typeface="Hiragino Sans GB"/>
@@ -22249,7 +22308,7 @@
             <a:r>
               <a:rPr sz="1650" b="0">
                 <a:solidFill>
-                  <a:srgbClr val="526971"/>
+                  <a:srgbClr val="A8C6C4"/>
                 </a:solidFill>
                 <a:latin typeface="Hiragino Sans GB"/>
                 <a:ea typeface="Hiragino Sans GB"/>
@@ -22288,7 +22347,7 @@
                       <a:r>
                         <a:rPr sz="2025" b="1">
                           <a:solidFill>
-                            <a:srgbClr val="FFFFFF"/>
+                            <a:srgbClr val="EAF1EF"/>
                           </a:solidFill>
                           <a:latin typeface="Hiragino Sans GB"/>
                           <a:ea typeface="Hiragino Sans GB"/>
@@ -22300,7 +22359,7 @@
                   </a:txBody>
                   <a:tcPr marL="91440" marR="91440" marT="45720" marB="45720" anchor="ctr">
                     <a:solidFill>
-                      <a:srgbClr val="167A70"/>
+                      <a:srgbClr val="16665F"/>
                     </a:solidFill>
                   </a:tcPr>
                 </a:tc>
@@ -22312,7 +22371,7 @@
                       <a:r>
                         <a:rPr sz="2025" b="1">
                           <a:solidFill>
-                            <a:srgbClr val="FFFFFF"/>
+                            <a:srgbClr val="EAF1EF"/>
                           </a:solidFill>
                           <a:latin typeface="Hiragino Sans GB"/>
                           <a:ea typeface="Hiragino Sans GB"/>
@@ -22324,7 +22383,7 @@
                   </a:txBody>
                   <a:tcPr marL="91440" marR="91440" marT="45720" marB="45720" anchor="ctr">
                     <a:solidFill>
-                      <a:srgbClr val="167A70"/>
+                      <a:srgbClr val="16665F"/>
                     </a:solidFill>
                   </a:tcPr>
                 </a:tc>
@@ -22336,7 +22395,7 @@
                       <a:r>
                         <a:rPr sz="2025" b="1">
                           <a:solidFill>
-                            <a:srgbClr val="FFFFFF"/>
+                            <a:srgbClr val="EAF1EF"/>
                           </a:solidFill>
                           <a:latin typeface="Hiragino Sans GB"/>
                           <a:ea typeface="Hiragino Sans GB"/>
@@ -22348,7 +22407,7 @@
                   </a:txBody>
                   <a:tcPr marL="91440" marR="91440" marT="45720" marB="45720" anchor="ctr">
                     <a:solidFill>
-                      <a:srgbClr val="167A70"/>
+                      <a:srgbClr val="16665F"/>
                     </a:solidFill>
                   </a:tcPr>
                 </a:tc>
@@ -22362,7 +22421,7 @@
                       <a:r>
                         <a:rPr sz="2025" b="0">
                           <a:solidFill>
-                            <a:srgbClr val="172D36"/>
+                            <a:srgbClr val="EAF1EF"/>
                           </a:solidFill>
                           <a:latin typeface="Hiragino Sans GB"/>
                           <a:ea typeface="Hiragino Sans GB"/>
@@ -22374,7 +22433,7 @@
                   </a:txBody>
                   <a:tcPr marL="91440" marR="91440" marT="45720" marB="45720" anchor="ctr">
                     <a:solidFill>
-                      <a:srgbClr val="FFFFFF"/>
+                      <a:srgbClr val="173A44"/>
                     </a:solidFill>
                   </a:tcPr>
                 </a:tc>
@@ -22386,7 +22445,7 @@
                       <a:r>
                         <a:rPr sz="2025" b="0">
                           <a:solidFill>
-                            <a:srgbClr val="172D36"/>
+                            <a:srgbClr val="EAF1EF"/>
                           </a:solidFill>
                           <a:latin typeface="Hiragino Sans GB"/>
                           <a:ea typeface="Hiragino Sans GB"/>
@@ -22398,7 +22457,7 @@
                   </a:txBody>
                   <a:tcPr marL="91440" marR="91440" marT="45720" marB="45720" anchor="ctr">
                     <a:solidFill>
-                      <a:srgbClr val="FFFFFF"/>
+                      <a:srgbClr val="173A44"/>
                     </a:solidFill>
                   </a:tcPr>
                 </a:tc>
@@ -22410,7 +22469,7 @@
                       <a:r>
                         <a:rPr sz="2025" b="0">
                           <a:solidFill>
-                            <a:srgbClr val="172D36"/>
+                            <a:srgbClr val="EAF1EF"/>
                           </a:solidFill>
                           <a:latin typeface="Hiragino Sans GB"/>
                           <a:ea typeface="Hiragino Sans GB"/>
@@ -22422,7 +22481,7 @@
                   </a:txBody>
                   <a:tcPr marL="91440" marR="91440" marT="45720" marB="45720" anchor="ctr">
                     <a:solidFill>
-                      <a:srgbClr val="FFFFFF"/>
+                      <a:srgbClr val="173A44"/>
                     </a:solidFill>
                   </a:tcPr>
                 </a:tc>
@@ -22436,7 +22495,7 @@
                       <a:r>
                         <a:rPr sz="2025" b="0">
                           <a:solidFill>
-                            <a:srgbClr val="172D36"/>
+                            <a:srgbClr val="EAF1EF"/>
                           </a:solidFill>
                           <a:latin typeface="Hiragino Sans GB"/>
                           <a:ea typeface="Hiragino Sans GB"/>
@@ -22448,7 +22507,7 @@
                   </a:txBody>
                   <a:tcPr marL="91440" marR="91440" marT="45720" marB="45720" anchor="ctr">
                     <a:solidFill>
-                      <a:srgbClr val="EDF1ED"/>
+                      <a:srgbClr val="1D4650"/>
                     </a:solidFill>
                   </a:tcPr>
                 </a:tc>
@@ -22460,7 +22519,7 @@
                       <a:r>
                         <a:rPr sz="2025" b="0">
                           <a:solidFill>
-                            <a:srgbClr val="172D36"/>
+                            <a:srgbClr val="EAF1EF"/>
                           </a:solidFill>
                           <a:latin typeface="Hiragino Sans GB"/>
                           <a:ea typeface="Hiragino Sans GB"/>
@@ -22472,7 +22531,7 @@
                   </a:txBody>
                   <a:tcPr marL="91440" marR="91440" marT="45720" marB="45720" anchor="ctr">
                     <a:solidFill>
-                      <a:srgbClr val="EDF1ED"/>
+                      <a:srgbClr val="1D4650"/>
                     </a:solidFill>
                   </a:tcPr>
                 </a:tc>
@@ -22484,7 +22543,7 @@
                       <a:r>
                         <a:rPr sz="2025" b="0">
                           <a:solidFill>
-                            <a:srgbClr val="172D36"/>
+                            <a:srgbClr val="EAF1EF"/>
                           </a:solidFill>
                           <a:latin typeface="Hiragino Sans GB"/>
                           <a:ea typeface="Hiragino Sans GB"/>
@@ -22496,7 +22555,7 @@
                   </a:txBody>
                   <a:tcPr marL="91440" marR="91440" marT="45720" marB="45720" anchor="ctr">
                     <a:solidFill>
-                      <a:srgbClr val="EDF1ED"/>
+                      <a:srgbClr val="1D4650"/>
                     </a:solidFill>
                   </a:tcPr>
                 </a:tc>
@@ -22510,7 +22569,7 @@
                       <a:r>
                         <a:rPr sz="2025" b="0">
                           <a:solidFill>
-                            <a:srgbClr val="172D36"/>
+                            <a:srgbClr val="EAF1EF"/>
                           </a:solidFill>
                           <a:latin typeface="Hiragino Sans GB"/>
                           <a:ea typeface="Hiragino Sans GB"/>
@@ -22522,7 +22581,7 @@
                   </a:txBody>
                   <a:tcPr marL="91440" marR="91440" marT="45720" marB="45720" anchor="ctr">
                     <a:solidFill>
-                      <a:srgbClr val="FFFFFF"/>
+                      <a:srgbClr val="173A44"/>
                     </a:solidFill>
                   </a:tcPr>
                 </a:tc>
@@ -22534,7 +22593,7 @@
                       <a:r>
                         <a:rPr sz="2025" b="0">
                           <a:solidFill>
-                            <a:srgbClr val="172D36"/>
+                            <a:srgbClr val="EAF1EF"/>
                           </a:solidFill>
                           <a:latin typeface="Hiragino Sans GB"/>
                           <a:ea typeface="Hiragino Sans GB"/>
@@ -22546,7 +22605,7 @@
                   </a:txBody>
                   <a:tcPr marL="91440" marR="91440" marT="45720" marB="45720" anchor="ctr">
                     <a:solidFill>
-                      <a:srgbClr val="FFFFFF"/>
+                      <a:srgbClr val="173A44"/>
                     </a:solidFill>
                   </a:tcPr>
                 </a:tc>
@@ -22558,7 +22617,7 @@
                       <a:r>
                         <a:rPr sz="2025" b="0">
                           <a:solidFill>
-                            <a:srgbClr val="172D36"/>
+                            <a:srgbClr val="EAF1EF"/>
                           </a:solidFill>
                           <a:latin typeface="Hiragino Sans GB"/>
                           <a:ea typeface="Hiragino Sans GB"/>
@@ -22570,7 +22629,7 @@
                   </a:txBody>
                   <a:tcPr marL="91440" marR="91440" marT="45720" marB="45720" anchor="ctr">
                     <a:solidFill>
-                      <a:srgbClr val="FFFFFF"/>
+                      <a:srgbClr val="173A44"/>
                     </a:solidFill>
                   </a:tcPr>
                 </a:tc>
@@ -22584,7 +22643,7 @@
                       <a:r>
                         <a:rPr sz="2025" b="0">
                           <a:solidFill>
-                            <a:srgbClr val="172D36"/>
+                            <a:srgbClr val="EAF1EF"/>
                           </a:solidFill>
                           <a:latin typeface="Hiragino Sans GB"/>
                           <a:ea typeface="Hiragino Sans GB"/>
@@ -22596,7 +22655,7 @@
                   </a:txBody>
                   <a:tcPr marL="91440" marR="91440" marT="45720" marB="45720" anchor="ctr">
                     <a:solidFill>
-                      <a:srgbClr val="EDF1ED"/>
+                      <a:srgbClr val="1D4650"/>
                     </a:solidFill>
                   </a:tcPr>
                 </a:tc>
@@ -22608,7 +22667,7 @@
                       <a:r>
                         <a:rPr sz="2025" b="0">
                           <a:solidFill>
-                            <a:srgbClr val="172D36"/>
+                            <a:srgbClr val="EAF1EF"/>
                           </a:solidFill>
                           <a:latin typeface="Hiragino Sans GB"/>
                           <a:ea typeface="Hiragino Sans GB"/>
@@ -22620,7 +22679,7 @@
                   </a:txBody>
                   <a:tcPr marL="91440" marR="91440" marT="45720" marB="45720" anchor="ctr">
                     <a:solidFill>
-                      <a:srgbClr val="EDF1ED"/>
+                      <a:srgbClr val="1D4650"/>
                     </a:solidFill>
                   </a:tcPr>
                 </a:tc>
@@ -22632,7 +22691,7 @@
                       <a:r>
                         <a:rPr sz="2025" b="0">
                           <a:solidFill>
-                            <a:srgbClr val="172D36"/>
+                            <a:srgbClr val="EAF1EF"/>
                           </a:solidFill>
                           <a:latin typeface="Hiragino Sans GB"/>
                           <a:ea typeface="Hiragino Sans GB"/>
@@ -22644,7 +22703,7 @@
                   </a:txBody>
                   <a:tcPr marL="91440" marR="91440" marT="45720" marB="45720" anchor="ctr">
                     <a:solidFill>
-                      <a:srgbClr val="EDF1ED"/>
+                      <a:srgbClr val="1D4650"/>
                     </a:solidFill>
                   </a:tcPr>
                 </a:tc>
@@ -22658,7 +22717,7 @@
                       <a:r>
                         <a:rPr sz="2025" b="0">
                           <a:solidFill>
-                            <a:srgbClr val="172D36"/>
+                            <a:srgbClr val="EAF1EF"/>
                           </a:solidFill>
                           <a:latin typeface="Hiragino Sans GB"/>
                           <a:ea typeface="Hiragino Sans GB"/>
@@ -22670,7 +22729,7 @@
                   </a:txBody>
                   <a:tcPr marL="91440" marR="91440" marT="45720" marB="45720" anchor="ctr">
                     <a:solidFill>
-                      <a:srgbClr val="FFFFFF"/>
+                      <a:srgbClr val="173A44"/>
                     </a:solidFill>
                   </a:tcPr>
                 </a:tc>
@@ -22682,7 +22741,7 @@
                       <a:r>
                         <a:rPr sz="2025" b="0">
                           <a:solidFill>
-                            <a:srgbClr val="172D36"/>
+                            <a:srgbClr val="EAF1EF"/>
                           </a:solidFill>
                           <a:latin typeface="Hiragino Sans GB"/>
                           <a:ea typeface="Hiragino Sans GB"/>
@@ -22694,7 +22753,7 @@
                   </a:txBody>
                   <a:tcPr marL="91440" marR="91440" marT="45720" marB="45720" anchor="ctr">
                     <a:solidFill>
-                      <a:srgbClr val="FFFFFF"/>
+                      <a:srgbClr val="173A44"/>
                     </a:solidFill>
                   </a:tcPr>
                 </a:tc>
@@ -22706,7 +22765,7 @@
                       <a:r>
                         <a:rPr sz="2025" b="0">
                           <a:solidFill>
-                            <a:srgbClr val="172D36"/>
+                            <a:srgbClr val="EAF1EF"/>
                           </a:solidFill>
                           <a:latin typeface="Hiragino Sans GB"/>
                           <a:ea typeface="Hiragino Sans GB"/>
@@ -22718,7 +22777,7 @@
                   </a:txBody>
                   <a:tcPr marL="91440" marR="91440" marT="45720" marB="45720" anchor="ctr">
                     <a:solidFill>
-                      <a:srgbClr val="FFFFFF"/>
+                      <a:srgbClr val="173A44"/>
                     </a:solidFill>
                   </a:tcPr>
                 </a:tc>
@@ -22764,7 +22823,7 @@
               <a:buNone/>
               <a:defRPr sz="1950" b="0">
                 <a:solidFill>
-                  <a:srgbClr val="526971"/>
+                  <a:srgbClr val="A8C6C4"/>
                 </a:solidFill>
                 <a:latin typeface="Hiragino Sans GB"/>
                 <a:ea typeface="Hiragino Sans GB"/>
@@ -22774,7 +22833,7 @@
             <a:r>
               <a:rPr sz="1950" b="0">
                 <a:solidFill>
-                  <a:srgbClr val="526971"/>
+                  <a:srgbClr val="A8C6C4"/>
                 </a:solidFill>
                 <a:latin typeface="Hiragino Sans GB"/>
                 <a:ea typeface="Hiragino Sans GB"/>
@@ -22801,7 +22860,7 @@
     <p:bg>
       <p:bgPr>
         <a:solidFill xmlns:a="http://schemas.openxmlformats.org/drawingml/2006/main">
-          <a:srgbClr val="F7F6F2"/>
+          <a:srgbClr val="102C35"/>
         </a:solidFill>
       </p:bgPr>
     </p:bg>
@@ -22851,7 +22910,7 @@
               <a:buNone/>
               <a:defRPr sz="3900" b="1">
                 <a:solidFill>
-                  <a:srgbClr val="172D36"/>
+                  <a:srgbClr val="EAF1EF"/>
                 </a:solidFill>
                 <a:latin typeface="Hiragino Sans GB"/>
                 <a:ea typeface="Hiragino Sans GB"/>
@@ -22861,7 +22920,7 @@
             <a:r>
               <a:rPr sz="3900" b="1">
                 <a:solidFill>
-                  <a:srgbClr val="172D36"/>
+                  <a:srgbClr val="EAF1EF"/>
                 </a:solidFill>
                 <a:latin typeface="Hiragino Sans GB"/>
                 <a:ea typeface="Hiragino Sans GB"/>
@@ -22909,7 +22968,7 @@
               <a:buNone/>
               <a:defRPr sz="1650" b="0">
                 <a:solidFill>
-                  <a:srgbClr val="526971"/>
+                  <a:srgbClr val="A8C6C4"/>
                 </a:solidFill>
                 <a:latin typeface="Hiragino Sans GB"/>
                 <a:ea typeface="Hiragino Sans GB"/>
@@ -22919,7 +22978,7 @@
             <a:r>
               <a:rPr sz="1650" b="0">
                 <a:solidFill>
-                  <a:srgbClr val="526971"/>
+                  <a:srgbClr val="A8C6C4"/>
                 </a:solidFill>
                 <a:latin typeface="Hiragino Sans GB"/>
                 <a:ea typeface="Hiragino Sans GB"/>
@@ -22967,7 +23026,7 @@
               <a:buNone/>
               <a:defRPr sz="2925" b="0">
                 <a:solidFill>
-                  <a:srgbClr val="172D36"/>
+                  <a:srgbClr val="EAF1EF"/>
                 </a:solidFill>
                 <a:latin typeface="Hiragino Sans GB"/>
                 <a:ea typeface="Hiragino Sans GB"/>
@@ -22977,7 +23036,7 @@
             <a:r>
               <a:rPr sz="2925" b="0">
                 <a:solidFill>
-                  <a:srgbClr val="172D36"/>
+                  <a:srgbClr val="EAF1EF"/>
                 </a:solidFill>
                 <a:latin typeface="Hiragino Sans GB"/>
                 <a:ea typeface="Hiragino Sans GB"/>
@@ -23025,7 +23084,7 @@
               <a:buNone/>
               <a:defRPr sz="2550" b="0">
                 <a:solidFill>
-                  <a:srgbClr val="172D36"/>
+                  <a:srgbClr val="EAF1EF"/>
                 </a:solidFill>
                 <a:latin typeface="Hiragino Sans GB"/>
                 <a:ea typeface="Hiragino Sans GB"/>
@@ -23035,7 +23094,7 @@
             <a:r>
               <a:rPr sz="2550" b="0">
                 <a:solidFill>
-                  <a:srgbClr val="172D36"/>
+                  <a:srgbClr val="EAF1EF"/>
                 </a:solidFill>
                 <a:latin typeface="Hiragino Sans GB"/>
                 <a:ea typeface="Hiragino Sans GB"/>
@@ -23049,7 +23108,7 @@
               <a:buNone/>
               <a:defRPr sz="2550" b="0">
                 <a:solidFill>
-                  <a:srgbClr val="172D36"/>
+                  <a:srgbClr val="EAF1EF"/>
                 </a:solidFill>
                 <a:latin typeface="Hiragino Sans GB"/>
                 <a:ea typeface="Hiragino Sans GB"/>
@@ -23059,7 +23118,7 @@
             <a:r>
               <a:rPr sz="2550" b="0">
                 <a:solidFill>
-                  <a:srgbClr val="172D36"/>
+                  <a:srgbClr val="EAF1EF"/>
                 </a:solidFill>
                 <a:latin typeface="Hiragino Sans GB"/>
                 <a:ea typeface="Hiragino Sans GB"/>
@@ -23073,7 +23132,7 @@
               <a:buNone/>
               <a:defRPr sz="2550" b="0">
                 <a:solidFill>
-                  <a:srgbClr val="172D36"/>
+                  <a:srgbClr val="EAF1EF"/>
                 </a:solidFill>
                 <a:latin typeface="Hiragino Sans GB"/>
                 <a:ea typeface="Hiragino Sans GB"/>
@@ -23083,7 +23142,7 @@
             <a:r>
               <a:rPr sz="2550" b="0">
                 <a:solidFill>
-                  <a:srgbClr val="172D36"/>
+                  <a:srgbClr val="EAF1EF"/>
                 </a:solidFill>
                 <a:latin typeface="Hiragino Sans GB"/>
                 <a:ea typeface="Hiragino Sans GB"/>
@@ -23097,7 +23156,7 @@
               <a:buNone/>
               <a:defRPr sz="2550" b="0">
                 <a:solidFill>
-                  <a:srgbClr val="172D36"/>
+                  <a:srgbClr val="EAF1EF"/>
                 </a:solidFill>
                 <a:latin typeface="Hiragino Sans GB"/>
                 <a:ea typeface="Hiragino Sans GB"/>
@@ -23107,7 +23166,7 @@
             <a:r>
               <a:rPr sz="2550" b="0">
                 <a:solidFill>
-                  <a:srgbClr val="172D36"/>
+                  <a:srgbClr val="EAF1EF"/>
                 </a:solidFill>
                 <a:latin typeface="Hiragino Sans GB"/>
                 <a:ea typeface="Hiragino Sans GB"/>
@@ -23155,7 +23214,7 @@
               <a:buNone/>
               <a:defRPr sz="2400" b="1">
                 <a:solidFill>
-                  <a:srgbClr val="172D36"/>
+                  <a:srgbClr val="EAF1EF"/>
                 </a:solidFill>
                 <a:latin typeface="Hiragino Sans GB"/>
                 <a:ea typeface="Hiragino Sans GB"/>
@@ -23165,7 +23224,7 @@
             <a:r>
               <a:rPr sz="2400" b="1">
                 <a:solidFill>
-                  <a:srgbClr val="172D36"/>
+                  <a:srgbClr val="EAF1EF"/>
                 </a:solidFill>
                 <a:latin typeface="Hiragino Sans GB"/>
                 <a:ea typeface="Hiragino Sans GB"/>
@@ -23213,7 +23272,7 @@
               <a:buNone/>
               <a:defRPr sz="2175" b="0">
                 <a:solidFill>
-                  <a:srgbClr val="167A70"/>
+                  <a:srgbClr val="B7EDDB"/>
                 </a:solidFill>
                 <a:latin typeface="Hiragino Sans GB"/>
                 <a:ea typeface="Hiragino Sans GB"/>
@@ -23223,12 +23282,12 @@
             <a:r>
               <a:rPr sz="2175" b="0">
                 <a:solidFill>
-                  <a:srgbClr val="167A70"/>
-                </a:solidFill>
-                <a:latin typeface="Hiragino Sans GB"/>
-                <a:ea typeface="Hiragino Sans GB"/>
-                <a:cs typeface="Hiragino Sans GB"/>
-                <a:hlinkClick xmlns:r="http://schemas.openxmlformats.org/officeDocument/2006/relationships" r:id="Rde5d1650da4841f1"/>
+                  <a:srgbClr val="B7EDDB"/>
+                </a:solidFill>
+                <a:latin typeface="Hiragino Sans GB"/>
+                <a:ea typeface="Hiragino Sans GB"/>
+                <a:cs typeface="Hiragino Sans GB"/>
+                <a:hlinkClick xmlns:r="http://schemas.openxmlformats.org/officeDocument/2006/relationships" r:id="Ra12f4bf9c95247a4"/>
               </a:rPr>
               <a:t>登录与账号</a:t>
             </a:r>
@@ -23272,7 +23331,7 @@
               <a:buNone/>
               <a:defRPr sz="2175" b="0">
                 <a:solidFill>
-                  <a:srgbClr val="167A70"/>
+                  <a:srgbClr val="B7EDDB"/>
                 </a:solidFill>
                 <a:latin typeface="Hiragino Sans GB"/>
                 <a:ea typeface="Hiragino Sans GB"/>
@@ -23282,12 +23341,12 @@
             <a:r>
               <a:rPr sz="2175" b="0">
                 <a:solidFill>
-                  <a:srgbClr val="167A70"/>
-                </a:solidFill>
-                <a:latin typeface="Hiragino Sans GB"/>
-                <a:ea typeface="Hiragino Sans GB"/>
-                <a:cs typeface="Hiragino Sans GB"/>
-                <a:hlinkClick xmlns:r="http://schemas.openxmlformats.org/officeDocument/2006/relationships" r:id="R71132a1cc58f44cb"/>
+                  <a:srgbClr val="B7EDDB"/>
+                </a:solidFill>
+                <a:latin typeface="Hiragino Sans GB"/>
+                <a:ea typeface="Hiragino Sans GB"/>
+                <a:cs typeface="Hiragino Sans GB"/>
+                <a:hlinkClick xmlns:r="http://schemas.openxmlformats.org/officeDocument/2006/relationships" r:id="R1110b0d6c809420a"/>
               </a:rPr>
               <a:t>Slurm 作业管理</a:t>
             </a:r>
@@ -23331,7 +23390,7 @@
               <a:buNone/>
               <a:defRPr sz="2175" b="0">
                 <a:solidFill>
-                  <a:srgbClr val="167A70"/>
+                  <a:srgbClr val="B7EDDB"/>
                 </a:solidFill>
                 <a:latin typeface="Hiragino Sans GB"/>
                 <a:ea typeface="Hiragino Sans GB"/>
@@ -23341,12 +23400,12 @@
             <a:r>
               <a:rPr sz="2175" b="0">
                 <a:solidFill>
-                  <a:srgbClr val="167A70"/>
-                </a:solidFill>
-                <a:latin typeface="Hiragino Sans GB"/>
-                <a:ea typeface="Hiragino Sans GB"/>
-                <a:cs typeface="Hiragino Sans GB"/>
-                <a:hlinkClick xmlns:r="http://schemas.openxmlformats.org/officeDocument/2006/relationships" r:id="R5989a7101caf4ef8"/>
+                  <a:srgbClr val="B7EDDB"/>
+                </a:solidFill>
+                <a:latin typeface="Hiragino Sans GB"/>
+                <a:ea typeface="Hiragino Sans GB"/>
+                <a:cs typeface="Hiragino Sans GB"/>
+                <a:hlinkClick xmlns:r="http://schemas.openxmlformats.org/officeDocument/2006/relationships" r:id="Rcaaccb6436884d98"/>
               </a:rPr>
               <a:t>文件传输</a:t>
             </a:r>

</xml_diff>

<commit_message>
chore: remove obsolete course materials and compatibility script
</commit_message>
<xml_diff>
--- a/docs/交我算平台Lab运行指南-学生版.pptx
+++ b/docs/交我算平台Lab运行指南-学生版.pptx
@@ -2,47 +2,47 @@
 <file path=ppt/presentation.xml><?xml version="1.0" encoding="utf-8"?>
 <p:presentation xmlns:p="http://schemas.openxmlformats.org/presentationml/2006/main">
   <p:sldMasterIdLst>
-    <p:sldMasterId xmlns:r="http://schemas.openxmlformats.org/officeDocument/2006/relationships" id="2147483648" r:id="R927377ac83cc472f"/>
+    <p:sldMasterId xmlns:r="http://schemas.openxmlformats.org/officeDocument/2006/relationships" id="2147483648" r:id="Rfcd11733302f4ccf"/>
   </p:sldMasterIdLst>
   <p:notesMasterIdLst>
-    <p:notesMasterId xmlns:r="http://schemas.openxmlformats.org/officeDocument/2006/relationships" r:id="R6eed5ffe2fb74892"/>
+    <p:notesMasterId xmlns:r="http://schemas.openxmlformats.org/officeDocument/2006/relationships" r:id="R69f3fb811bd44067"/>
   </p:notesMasterIdLst>
   <p:sldIdLst>
-    <p:sldId xmlns:r="http://schemas.openxmlformats.org/officeDocument/2006/relationships" id="256" r:id="Ra56022e4c19540bc"/>
-    <p:sldId xmlns:r="http://schemas.openxmlformats.org/officeDocument/2006/relationships" id="257" r:id="R6aacd11cb52341e8"/>
-    <p:sldId xmlns:r="http://schemas.openxmlformats.org/officeDocument/2006/relationships" id="258" r:id="R4bf80267caec44ed"/>
-    <p:sldId xmlns:r="http://schemas.openxmlformats.org/officeDocument/2006/relationships" id="259" r:id="R229dc654e102476b"/>
-    <p:sldId xmlns:r="http://schemas.openxmlformats.org/officeDocument/2006/relationships" id="260" r:id="R3ba076d47f844f63"/>
-    <p:sldId xmlns:r="http://schemas.openxmlformats.org/officeDocument/2006/relationships" id="261" r:id="R2681934d9a014e18"/>
-    <p:sldId xmlns:r="http://schemas.openxmlformats.org/officeDocument/2006/relationships" id="262" r:id="R3c98f2fa152d4ef1"/>
-    <p:sldId xmlns:r="http://schemas.openxmlformats.org/officeDocument/2006/relationships" id="263" r:id="R1b3a07c64a4b467c"/>
-    <p:sldId xmlns:r="http://schemas.openxmlformats.org/officeDocument/2006/relationships" id="264" r:id="R67f43a921bab4162"/>
-    <p:sldId xmlns:r="http://schemas.openxmlformats.org/officeDocument/2006/relationships" id="265" r:id="R27e5f3c0d618404b"/>
-    <p:sldId xmlns:r="http://schemas.openxmlformats.org/officeDocument/2006/relationships" id="266" r:id="Rc244b24142c24692"/>
-    <p:sldId xmlns:r="http://schemas.openxmlformats.org/officeDocument/2006/relationships" id="267" r:id="R427bebbc798e4304"/>
-    <p:sldId xmlns:r="http://schemas.openxmlformats.org/officeDocument/2006/relationships" id="268" r:id="R3485278cfe804f13"/>
-    <p:sldId xmlns:r="http://schemas.openxmlformats.org/officeDocument/2006/relationships" id="269" r:id="Ree8c429b86a146d8"/>
-    <p:sldId xmlns:r="http://schemas.openxmlformats.org/officeDocument/2006/relationships" id="270" r:id="R714659cc643d4bee"/>
-    <p:sldId xmlns:r="http://schemas.openxmlformats.org/officeDocument/2006/relationships" id="271" r:id="R9e50e593fc474ed4"/>
-    <p:sldId xmlns:r="http://schemas.openxmlformats.org/officeDocument/2006/relationships" id="272" r:id="Ra3266cf68c034dcd"/>
-    <p:sldId xmlns:r="http://schemas.openxmlformats.org/officeDocument/2006/relationships" id="273" r:id="Rea222d61349c4fa9"/>
-    <p:sldId xmlns:r="http://schemas.openxmlformats.org/officeDocument/2006/relationships" id="274" r:id="Rd83a2cb950f94334"/>
-    <p:sldId xmlns:r="http://schemas.openxmlformats.org/officeDocument/2006/relationships" id="275" r:id="R6e64b142545c4d77"/>
-    <p:sldId xmlns:r="http://schemas.openxmlformats.org/officeDocument/2006/relationships" id="276" r:id="Rd549f739e8494a3a"/>
-    <p:sldId xmlns:r="http://schemas.openxmlformats.org/officeDocument/2006/relationships" id="277" r:id="R01ee70f6453b4f8c"/>
-    <p:sldId xmlns:r="http://schemas.openxmlformats.org/officeDocument/2006/relationships" id="278" r:id="Rf624bea7bfcb44e9"/>
-    <p:sldId xmlns:r="http://schemas.openxmlformats.org/officeDocument/2006/relationships" id="279" r:id="R29cba9b63f5d44aa"/>
-    <p:sldId xmlns:r="http://schemas.openxmlformats.org/officeDocument/2006/relationships" id="280" r:id="R734199445a124cce"/>
-    <p:sldId xmlns:r="http://schemas.openxmlformats.org/officeDocument/2006/relationships" id="281" r:id="R0ddfc15393824003"/>
-    <p:sldId xmlns:r="http://schemas.openxmlformats.org/officeDocument/2006/relationships" id="282" r:id="R454068d6cb1244fa"/>
-    <p:sldId xmlns:r="http://schemas.openxmlformats.org/officeDocument/2006/relationships" id="283" r:id="Rdae7e0a296d14293"/>
-    <p:sldId xmlns:r="http://schemas.openxmlformats.org/officeDocument/2006/relationships" id="284" r:id="R222f85dd30094eb9"/>
-    <p:sldId xmlns:r="http://schemas.openxmlformats.org/officeDocument/2006/relationships" id="285" r:id="R0fe13afbfaf6474c"/>
-    <p:sldId xmlns:r="http://schemas.openxmlformats.org/officeDocument/2006/relationships" id="286" r:id="Re594158437634572"/>
-    <p:sldId xmlns:r="http://schemas.openxmlformats.org/officeDocument/2006/relationships" id="287" r:id="R52160da98b224581"/>
-    <p:sldId xmlns:r="http://schemas.openxmlformats.org/officeDocument/2006/relationships" id="288" r:id="Recb7905c90f54724"/>
-    <p:sldId xmlns:r="http://schemas.openxmlformats.org/officeDocument/2006/relationships" id="289" r:id="R0ee1a5b3a9c14e57"/>
-    <p:sldId xmlns:r="http://schemas.openxmlformats.org/officeDocument/2006/relationships" id="290" r:id="R880c548df6e34340"/>
+    <p:sldId xmlns:r="http://schemas.openxmlformats.org/officeDocument/2006/relationships" id="256" r:id="R267744d14b634a8b"/>
+    <p:sldId xmlns:r="http://schemas.openxmlformats.org/officeDocument/2006/relationships" id="257" r:id="R696942c9314049d5"/>
+    <p:sldId xmlns:r="http://schemas.openxmlformats.org/officeDocument/2006/relationships" id="258" r:id="Ree039175ee484467"/>
+    <p:sldId xmlns:r="http://schemas.openxmlformats.org/officeDocument/2006/relationships" id="259" r:id="Rab31ace019f74a78"/>
+    <p:sldId xmlns:r="http://schemas.openxmlformats.org/officeDocument/2006/relationships" id="260" r:id="R4010a85714be4c51"/>
+    <p:sldId xmlns:r="http://schemas.openxmlformats.org/officeDocument/2006/relationships" id="261" r:id="R750e583ce2a34ac3"/>
+    <p:sldId xmlns:r="http://schemas.openxmlformats.org/officeDocument/2006/relationships" id="262" r:id="R9ba922d7094c44b3"/>
+    <p:sldId xmlns:r="http://schemas.openxmlformats.org/officeDocument/2006/relationships" id="263" r:id="R64548caa82824c4c"/>
+    <p:sldId xmlns:r="http://schemas.openxmlformats.org/officeDocument/2006/relationships" id="264" r:id="Rf2ca0ea7c6f24c96"/>
+    <p:sldId xmlns:r="http://schemas.openxmlformats.org/officeDocument/2006/relationships" id="265" r:id="R7c89b6f009794216"/>
+    <p:sldId xmlns:r="http://schemas.openxmlformats.org/officeDocument/2006/relationships" id="266" r:id="R23abd02030ad460d"/>
+    <p:sldId xmlns:r="http://schemas.openxmlformats.org/officeDocument/2006/relationships" id="267" r:id="R669eccf00d414529"/>
+    <p:sldId xmlns:r="http://schemas.openxmlformats.org/officeDocument/2006/relationships" id="268" r:id="R243f2b9f75904f68"/>
+    <p:sldId xmlns:r="http://schemas.openxmlformats.org/officeDocument/2006/relationships" id="269" r:id="Rac6b8ebb9cfd491f"/>
+    <p:sldId xmlns:r="http://schemas.openxmlformats.org/officeDocument/2006/relationships" id="270" r:id="R555429a6826b413d"/>
+    <p:sldId xmlns:r="http://schemas.openxmlformats.org/officeDocument/2006/relationships" id="271" r:id="Rfaa418fd6b6d44be"/>
+    <p:sldId xmlns:r="http://schemas.openxmlformats.org/officeDocument/2006/relationships" id="272" r:id="Red79ef18c2c94e2e"/>
+    <p:sldId xmlns:r="http://schemas.openxmlformats.org/officeDocument/2006/relationships" id="273" r:id="R25b8b9239b4f4d96"/>
+    <p:sldId xmlns:r="http://schemas.openxmlformats.org/officeDocument/2006/relationships" id="274" r:id="R043aba2dc8f8410b"/>
+    <p:sldId xmlns:r="http://schemas.openxmlformats.org/officeDocument/2006/relationships" id="275" r:id="R57b0ef0882424329"/>
+    <p:sldId xmlns:r="http://schemas.openxmlformats.org/officeDocument/2006/relationships" id="276" r:id="Raafdb43ca7d747a7"/>
+    <p:sldId xmlns:r="http://schemas.openxmlformats.org/officeDocument/2006/relationships" id="277" r:id="R24507dfffd2d45b2"/>
+    <p:sldId xmlns:r="http://schemas.openxmlformats.org/officeDocument/2006/relationships" id="278" r:id="R4b8a5fc8af1046a3"/>
+    <p:sldId xmlns:r="http://schemas.openxmlformats.org/officeDocument/2006/relationships" id="279" r:id="R1de2a6eff9ff427b"/>
+    <p:sldId xmlns:r="http://schemas.openxmlformats.org/officeDocument/2006/relationships" id="280" r:id="Rd4f5aae7087c4e38"/>
+    <p:sldId xmlns:r="http://schemas.openxmlformats.org/officeDocument/2006/relationships" id="281" r:id="R406ec6ec6d844448"/>
+    <p:sldId xmlns:r="http://schemas.openxmlformats.org/officeDocument/2006/relationships" id="282" r:id="Rd3f7d335942344a9"/>
+    <p:sldId xmlns:r="http://schemas.openxmlformats.org/officeDocument/2006/relationships" id="283" r:id="Rff541385259144ff"/>
+    <p:sldId xmlns:r="http://schemas.openxmlformats.org/officeDocument/2006/relationships" id="284" r:id="Re7a2c51de64c408c"/>
+    <p:sldId xmlns:r="http://schemas.openxmlformats.org/officeDocument/2006/relationships" id="285" r:id="Ref6a5152ae0648dc"/>
+    <p:sldId xmlns:r="http://schemas.openxmlformats.org/officeDocument/2006/relationships" id="286" r:id="Rc950d08191ba49d4"/>
+    <p:sldId xmlns:r="http://schemas.openxmlformats.org/officeDocument/2006/relationships" id="287" r:id="R00afe8ace05e40a8"/>
+    <p:sldId xmlns:r="http://schemas.openxmlformats.org/officeDocument/2006/relationships" id="288" r:id="R8344d0cdc793428d"/>
+    <p:sldId xmlns:r="http://schemas.openxmlformats.org/officeDocument/2006/relationships" id="289" r:id="R511e105092a948a7"/>
+    <p:sldId xmlns:r="http://schemas.openxmlformats.org/officeDocument/2006/relationships" id="290" r:id="R2ac6ed7170c04621"/>
   </p:sldIdLst>
   <p:sldSz cx="15240000" cy="8572500"/>
   <p:notesSz cx="6858000" cy="9144000"/>
@@ -1021,9 +1021,6 @@
             </a:r>
           </a:p>
           <a:p xmlns:a="http://schemas.openxmlformats.org/drawingml/2006/main">
-            <a:r>
-              <a:t/>
-            </a:r>
             <a:endParaRPr/>
           </a:p>
           <a:p xmlns:a="http://schemas.openxmlformats.org/drawingml/2006/main">
@@ -1052,14 +1049,10 @@
             </a:r>
           </a:p>
           <a:p xmlns:a="http://schemas.openxmlformats.org/drawingml/2006/main">
-            <a:r>
-              <a:t/>
-            </a:r>
-          </a:p>
-          <a:p xmlns:a="http://schemas.openxmlformats.org/drawingml/2006/main">
-            <a:r>
-              <a:t/>
-            </a:r>
+            <a:endParaRPr/>
+          </a:p>
+          <a:p xmlns:a="http://schemas.openxmlformats.org/drawingml/2006/main">
+            <a:endParaRPr/>
           </a:p>
           <a:p xmlns:a="http://schemas.openxmlformats.org/drawingml/2006/main">
             <a:r>
@@ -1067,9 +1060,7 @@
             </a:r>
           </a:p>
           <a:p xmlns:a="http://schemas.openxmlformats.org/drawingml/2006/main">
-            <a:r>
-              <a:t/>
-            </a:r>
+            <a:endParaRPr/>
           </a:p>
         </p:txBody>
       </p:sp>
@@ -1352,9 +1343,6 @@
             </a:r>
           </a:p>
           <a:p xmlns:a="http://schemas.openxmlformats.org/drawingml/2006/main">
-            <a:r>
-              <a:t/>
-            </a:r>
             <a:endParaRPr/>
           </a:p>
           <a:p xmlns:a="http://schemas.openxmlformats.org/drawingml/2006/main">
@@ -1373,9 +1361,7 @@
             </a:r>
           </a:p>
           <a:p xmlns:a="http://schemas.openxmlformats.org/drawingml/2006/main">
-            <a:r>
-              <a:t/>
-            </a:r>
+            <a:endParaRPr/>
           </a:p>
           <a:p xmlns:a="http://schemas.openxmlformats.org/drawingml/2006/main">
             <a:r>
@@ -1383,9 +1369,7 @@
             </a:r>
           </a:p>
           <a:p xmlns:a="http://schemas.openxmlformats.org/drawingml/2006/main">
-            <a:r>
-              <a:t/>
-            </a:r>
+            <a:endParaRPr/>
           </a:p>
         </p:txBody>
       </p:sp>
@@ -1619,45 +1603,42 @@
             <a:r>
               <a:t>本页命令用于替换 lab2.slurm 的实验段，保留脚本的 set -euo pipefail、编译、CTest 和 mkdir -p results；脚本已经进入 Lab 2 目录。每次只运行一个阶段，同一源码目录一次只运行一个作业。程序前增加 srun --cpu-bind=cores，参数与 README 一致。在 srun --pty 打开的交互式计算终端，直接使用 README 不带 srun 前缀的程序命令，已有终端会话已绑定 CPU。</a:t>
             </a:r>
+          </a:p>
+          <a:p xmlns:a="http://schemas.openxmlformats.org/drawingml/2006/main">
+            <a:r>
+              <a:t>完整脚本：</a:t>
+            </a:r>
+          </a:p>
+          <a:p xmlns:a="http://schemas.openxmlformats.org/drawingml/2006/main">
+            <a:r>
+              <a:t>#!/bin/bash -l</a:t>
+            </a:r>
+          </a:p>
+          <a:p xmlns:a="http://schemas.openxmlformats.org/drawingml/2006/main">
+            <a:r>
+              <a:t>#SBATCH -J matrixlab</a:t>
+            </a:r>
+          </a:p>
+          <a:p xmlns:a="http://schemas.openxmlformats.org/drawingml/2006/main">
+            <a:r>
+              <a:t>#SBATCH -p cpu -N 1 -n 1 -c 1</a:t>
+            </a:r>
+          </a:p>
+          <a:p xmlns:a="http://schemas.openxmlformats.org/drawingml/2006/main">
+            <a:r>
+              <a:t>#SBATCH -t 00:20:00</a:t>
+            </a:r>
+          </a:p>
+          <a:p xmlns:a="http://schemas.openxmlformats.org/drawingml/2006/main">
+            <a:r>
+              <a:t>#SBATCH -o results/lab2-%j.log</a:t>
+            </a:r>
+          </a:p>
+          <a:p xmlns:a="http://schemas.openxmlformats.org/drawingml/2006/main">
             <a:endParaRPr/>
           </a:p>
           <a:p xmlns:a="http://schemas.openxmlformats.org/drawingml/2006/main">
             <a:r>
-              <a:t>完整脚本：</a:t>
-            </a:r>
-          </a:p>
-          <a:p xmlns:a="http://schemas.openxmlformats.org/drawingml/2006/main">
-            <a:r>
-              <a:t>#!/bin/bash -l</a:t>
-            </a:r>
-          </a:p>
-          <a:p xmlns:a="http://schemas.openxmlformats.org/drawingml/2006/main">
-            <a:r>
-              <a:t>#SBATCH -J matrixlab</a:t>
-            </a:r>
-          </a:p>
-          <a:p xmlns:a="http://schemas.openxmlformats.org/drawingml/2006/main">
-            <a:r>
-              <a:t>#SBATCH -p cpu -N 1 -n 1 -c 1</a:t>
-            </a:r>
-          </a:p>
-          <a:p xmlns:a="http://schemas.openxmlformats.org/drawingml/2006/main">
-            <a:r>
-              <a:t>#SBATCH -t 00:20:00</a:t>
-            </a:r>
-          </a:p>
-          <a:p xmlns:a="http://schemas.openxmlformats.org/drawingml/2006/main">
-            <a:r>
-              <a:t>#SBATCH -o results/lab2-%j.log</a:t>
-            </a:r>
-          </a:p>
-          <a:p xmlns:a="http://schemas.openxmlformats.org/drawingml/2006/main">
-            <a:r>
-              <a:t/>
-            </a:r>
-          </a:p>
-          <a:p xmlns:a="http://schemas.openxmlformats.org/drawingml/2006/main">
-            <a:r>
               <a:t>set -euo pipefail</a:t>
             </a:r>
           </a:p>
@@ -1697,9 +1678,7 @@
             </a:r>
           </a:p>
           <a:p xmlns:a="http://schemas.openxmlformats.org/drawingml/2006/main">
-            <a:r>
-              <a:t/>
-            </a:r>
+            <a:endParaRPr/>
           </a:p>
           <a:p xmlns:a="http://schemas.openxmlformats.org/drawingml/2006/main">
             <a:r>
@@ -1722,9 +1701,7 @@
             </a:r>
           </a:p>
           <a:p xmlns:a="http://schemas.openxmlformats.org/drawingml/2006/main">
-            <a:r>
-              <a:t/>
-            </a:r>
+            <a:endParaRPr/>
           </a:p>
         </p:txBody>
       </p:sp>
@@ -1800,17 +1777,14 @@
             <a:r>
               <a:t>本页命令用于替换 lab2.slurm 的实验段，保留脚本的 set -euo pipefail、编译、CTest 和 mkdir -p results；脚本已经进入 Lab 2 目录。每次只运行一个阶段，同一源码目录一次只运行一个作业。程序前增加 srun --cpu-bind=cores，参数与 README 一致。在 srun --pty 打开的交互式计算终端，直接使用 README 不带 srun 前缀的程序命令，已有终端会话已绑定 CPU。</a:t>
             </a:r>
+          </a:p>
+          <a:p xmlns:a="http://schemas.openxmlformats.org/drawingml/2006/main">
+            <a:r>
+              <a:t>README §6.4 要求寄存器实验的 n 能被 6 整除。第 8.2 节正式命令与第 9.2 节报告表格统一使用 66、126、258、510、1026、2046，与 benchmarks/reg_reuse.c 的默认规模一致。循环次序实验按第 8.3 节使用 n=2048、b=64。</a:t>
+            </a:r>
+          </a:p>
+          <a:p xmlns:a="http://schemas.openxmlformats.org/drawingml/2006/main">
             <a:endParaRPr/>
-          </a:p>
-          <a:p xmlns:a="http://schemas.openxmlformats.org/drawingml/2006/main">
-            <a:r>
-              <a:t>README §6.4 要求寄存器实验的 n 能被 6 整除。第 8.2 节正式命令与第 9.2 节报告表格统一使用 66、126、258、510、1026、2046，与 benchmarks/reg_reuse.c 的默认规模一致。循环次序实验按第 8.3 节使用 n=2048、b=64。</a:t>
-            </a:r>
-          </a:p>
-          <a:p xmlns:a="http://schemas.openxmlformats.org/drawingml/2006/main">
-            <a:r>
-              <a:t/>
-            </a:r>
           </a:p>
         </p:txBody>
       </p:sp>
@@ -1886,7 +1860,6 @@
             <a:r>
               <a:t>本页命令用于替换 lab2.slurm 的实验段，保留脚本的 set -euo pipefail、编译、CTest 和 mkdir -p results；脚本已经进入 Lab 2 目录。每次只运行一个阶段，同一源码目录一次只运行一个作业。程序前增加 srun --cpu-bind=cores，参数与 README 一致。在 srun --pty 打开的交互式计算终端，直接使用 README 不带 srun 前缀的程序命令，已有终端会话已绑定 CPU。 : &gt; 和 tee 会覆盖同名日志，重跑前保存上一批结果。cache_part3 每次都会运行全部 12 个算法。</a:t>
             </a:r>
-            <a:endParaRPr/>
           </a:p>
         </p:txBody>
       </p:sp>
@@ -1962,7 +1935,6 @@
             <a:r>
               <a:t>本页命令用于替换 lab2.slurm 的实验段，保留脚本的 set -euo pipefail、编译、CTest 和 mkdir -p results；脚本已经进入 Lab 2 目录。每次只运行一个阶段，同一源码目录一次只运行一个作业。程序前增加 srun --cpu-bind=cores，参数与 README 一致。在 srun --pty 打开的交互式计算终端，直接使用 README 不带 srun 前缀的程序命令，已有终端会话已绑定 CPU。 候选值来自 n=1024 的实际结果，最大规模确认后选择最终 b。</a:t>
             </a:r>
-            <a:endParaRPr/>
           </a:p>
         </p:txBody>
       </p:sp>
@@ -2038,7 +2010,6 @@
             <a:r>
               <a:t>本页命令用于替换 lab2.slurm 的实验段，保留脚本的 set -euo pipefail、编译、CTest 和 mkdir -p results；脚本已经进入 Lab 2 目录。每次只运行一个阶段，同一源码目录一次只运行一个作业。程序前增加 srun --cpu-bind=cores，参数与 README 一致。在 srun --pty 打开的交互式计算终端，直接使用 README 不带 srun 前缀的程序命令，已有终端会话已绑定 CPU。 四个优化级别必须保持同一 n、b 和源码。</a:t>
             </a:r>
-            <a:endParaRPr/>
           </a:p>
         </p:txBody>
       </p:sp>
@@ -2114,7 +2085,6 @@
             <a:r>
               <a:t>本页命令用于替换 lab2.slurm 的实验段，保留脚本的 set -euo pipefail、编译、CTest 和 mkdir -p results；脚本已经进入 Lab 2 目录。每次只运行一个阶段，同一源码目录一次只运行一个作业。程序前增加 srun --cpu-bind=cores，参数与 README 一致。在 srun --pty 打开的交互式计算终端，直接使用 README 不带 srun 前缀的程序命令，已有终端会话已绑定 CPU。 对其他正式配置也建议重复 3 次。保存同名文件旧版本，防止覆盖。记录正确性结果，INVALID 数据不作为有效性能数据。</a:t>
             </a:r>
-            <a:endParaRPr/>
           </a:p>
         </p:txBody>
       </p:sp>
@@ -2190,7 +2160,6 @@
             <a:r>
               <a:t>本页命令用于替换 lab2.slurm 的实验段，保留脚本的 set -euo pipefail、编译、CTest 和 mkdir -p results；脚本已经进入 Lab 2 目录。每次只运行一个阶段，同一源码目录一次只运行一个作业。程序前增加 srun --cpu-bind=cores，参数与 README 一致。在 srun --pty 打开的交互式计算终端，直接使用 README 不带 srun 前缀的程序命令，已有终端会话已绑定 CPU。</a:t>
             </a:r>
-            <a:endParaRPr/>
           </a:p>
           <a:p xmlns:a="http://schemas.openxmlformats.org/drawingml/2006/main">
             <a:r>
@@ -2321,12 +2290,8 @@
             <a:r>
               <a:t>该脚本只做额外默认批量检查，不替代正式流程。它不会调用 sbatch，必须在计算节点运行。寄存器默认规模与 README 第 8.2 节相同；Part 3 和 Part 4 的默认 n、b 与正式实验参数不同。</a:t>
             </a:r>
-            <a:endParaRPr/>
-          </a:p>
-          <a:p xmlns:a="http://schemas.openxmlformats.org/drawingml/2006/main">
-            <a:r>
-              <a:t/>
-            </a:r>
+          </a:p>
+          <a:p xmlns:a="http://schemas.openxmlformats.org/drawingml/2006/main">
             <a:endParaRPr/>
           </a:p>
         </p:txBody>
@@ -2932,7 +2897,7 @@
           <a:lstStyle xmlns:a="http://schemas.openxmlformats.org/drawingml/2006/main"/>
           <a:p xmlns:a="http://schemas.openxmlformats.org/drawingml/2006/main">
             <a:r>
-              <a:t>若 cmake 不存在或版本过旧，在分配的计算节点上 module avail cmake，再 module load 实际存在的完整模块名，随后验证 cmake --version。旧 CMake 缓存必须使用新的构建目录，不能跨本地和集群复用。当前 labs/lab2-matrix/scripts/submit.sh 仅是 run_all.sh 的包装，不调用 sbatch，因此不能直接在登录节点使用。</a:t>
+              <a:t>若 cmake 不存在或版本过旧，在分配的计算节点上 module avail cmake，再 module load 实际存在的完整模块名，随后验证 cmake --version。旧 CMake 缓存必须使用新的构建目录，不能跨本地和集群复用。在已申请的计算节点运行 scripts/run_all.sh；批处理作业在登录节点通过 sbatch 提交。</a:t>
             </a:r>
           </a:p>
           <a:p xmlns:a="http://schemas.openxmlformats.org/drawingml/2006/main">
@@ -2970,6 +2935,7 @@
             <a:r>
               <a:t/>
             </a:r>
+            <a:endParaRPr/>
           </a:p>
           <a:p xmlns:a="http://schemas.openxmlformats.org/drawingml/2006/main">
             <a:r>
@@ -3687,7 +3653,7 @@
   </p:cSld>
   <p:clrMap bg1="lt1" tx1="dk1" bg2="lt2" tx2="dk2" accent1="accent1" accent2="accent2" accent3="accent3" accent4="accent4" accent5="accent5" accent6="accent6" hlink="hlink" folHlink="folHlink"/>
   <p:sldLayoutIdLst>
-    <p:sldLayoutId xmlns:r="http://schemas.openxmlformats.org/officeDocument/2006/relationships" id="2147483649" r:id="R885e1f29b21b4dab"/>
+    <p:sldLayoutId xmlns:r="http://schemas.openxmlformats.org/officeDocument/2006/relationships" id="2147483649" r:id="R2cbd864ee68d4a77"/>
   </p:sldLayoutIdLst>
   <p:txStyles>
     <p:titleStyle>
@@ -6867,49 +6833,8 @@
                 <a:ea typeface="Hiragino Sans GB"/>
                 <a:cs typeface="Hiragino Sans GB"/>
               </a:rPr>
-              <a:t>申请一个计算核心</a:t>
-            </a:r>
-            <a:r>
-              <a:rPr sz="3900" b="1">
-                <a:solidFill>
-                  <a:srgbClr val="EAF1EF"/>
-                </a:solidFill>
-                <a:latin typeface="Hiragino Sans GB"/>
-                <a:ea typeface="Hiragino Sans GB"/>
-                <a:cs typeface="Hiragino Sans GB"/>
-              </a:rPr>
-              <a:t>(</a:t>
-            </a:r>
-            <a:r>
-              <a:rPr sz="3900" b="1">
-                <a:solidFill>
-                  <a:srgbClr val="EAF1EF"/>
-                </a:solidFill>
-                <a:latin typeface="Hiragino Sans GB"/>
-                <a:ea typeface="Hiragino Sans GB"/>
-                <a:cs typeface="Hiragino Sans GB"/>
-              </a:rPr>
-              <a:t>在登陆终端等待分配后直接进入计算终端</a:t>
-            </a:r>
-            <a:r>
-              <a:rPr sz="3900" b="1">
-                <a:solidFill>
-                  <a:srgbClr val="EAF1EF"/>
-                </a:solidFill>
-                <a:latin typeface="Hiragino Sans GB"/>
-                <a:ea typeface="Hiragino Sans GB"/>
-                <a:cs typeface="Hiragino Sans GB"/>
-              </a:rPr>
-              <a:t>)</a:t>
-            </a:r>
-            <a:endParaRPr sz="3900" b="1">
-              <a:solidFill>
-                <a:srgbClr val="EAF1EF"/>
-              </a:solidFill>
-              <a:latin typeface="Hiragino Sans GB"/>
-              <a:ea typeface="Hiragino Sans GB"/>
-              <a:cs typeface="Hiragino Sans GB"/>
-            </a:endParaRPr>
+              <a:t>申请一个计算核心(在登陆终端等待分配后直接进入计算终端)</a:t>
+            </a:r>
           </a:p>
         </p:txBody>
       </p:sp>
@@ -7082,29 +7007,7 @@
                 <a:ea typeface="Menlo"/>
                 <a:cs typeface="Menlo"/>
               </a:rPr>
-              <a:t>srun -p cpu -N 1 -n 1 -c 1 -t </a:t>
-            </a:r>
-            <a:r>
-              <a:rPr sz="2325" b="0">
-                <a:solidFill>
-                  <a:srgbClr val="B7EDDB"/>
-                </a:solidFill>
-                <a:latin typeface="Menlo"/>
-                <a:ea typeface="Menlo"/>
-                <a:cs typeface="Menlo"/>
-              </a:rPr>
-              <a:t>00:20:00</a:t>
-            </a:r>
-            <a:r>
-              <a:rPr sz="2325" b="0">
-                <a:solidFill>
-                  <a:srgbClr val="B7EDDB"/>
-                </a:solidFill>
-                <a:latin typeface="Menlo"/>
-                <a:ea typeface="Menlo"/>
-                <a:cs typeface="Menlo"/>
-              </a:rPr>
-              <a:t> \</a:t>
+              <a:t>srun -p cpu -N 1 -n 1 -c 1 -t 00:20:00 \</a:t>
             </a:r>
           </a:p>
         </p:txBody>
@@ -10324,29 +10227,7 @@
                           <a:ea typeface="Hiragino Sans GB"/>
                           <a:cs typeface="Hiragino Sans GB"/>
                         </a:rPr>
-                        <a:t>最多运行 </a:t>
-                      </a:r>
-                      <a:r>
-                        <a:rPr sz="2100" b="0">
-                          <a:solidFill>
-                            <a:srgbClr val="EAF1EF"/>
-                          </a:solidFill>
-                          <a:latin typeface="Hiragino Sans GB"/>
-                          <a:ea typeface="Hiragino Sans GB"/>
-                          <a:cs typeface="Hiragino Sans GB"/>
-                        </a:rPr>
-                        <a:t>20 分钟</a:t>
-                      </a:r>
-                      <a:r>
-                        <a:rPr sz="2100" b="0">
-                          <a:solidFill>
-                            <a:srgbClr val="EAF1EF"/>
-                          </a:solidFill>
-                          <a:latin typeface="Hiragino Sans GB"/>
-                          <a:ea typeface="Hiragino Sans GB"/>
-                          <a:cs typeface="Hiragino Sans GB"/>
-                        </a:rPr>
-                        <a:t>，不含排队时间</a:t>
+                        <a:t>最多运行 20 分钟，不含排队时间</a:t>
                       </a:r>
                     </a:p>
                   </a:txBody>
@@ -10849,18 +10730,7 @@
                 <a:ea typeface="Menlo"/>
                 <a:cs typeface="Menlo"/>
               </a:rPr>
-              <a:t>#SBATCH -t </a:t>
-            </a:r>
-            <a:r>
-              <a:rPr sz="2250" b="0">
-                <a:solidFill>
-                  <a:srgbClr val="B7EDDB"/>
-                </a:solidFill>
-                <a:latin typeface="Menlo"/>
-                <a:ea typeface="Menlo"/>
-                <a:cs typeface="Menlo"/>
-              </a:rPr>
-              <a:t>00:20:00</a:t>
+              <a:t>#SBATCH -t 00:20:00</a:t>
             </a:r>
           </a:p>
         </p:txBody>
@@ -12239,18 +12109,7 @@
                 <a:ea typeface="Menlo"/>
                 <a:cs typeface="Menlo"/>
               </a:rPr>
-              <a:t>#SBATCH -t </a:t>
-            </a:r>
-            <a:r>
-              <a:rPr sz="2100" b="0">
-                <a:solidFill>
-                  <a:srgbClr val="B7EDDB"/>
-                </a:solidFill>
-                <a:latin typeface="Menlo"/>
-                <a:ea typeface="Menlo"/>
-                <a:cs typeface="Menlo"/>
-              </a:rPr>
-              <a:t>00:20:00</a:t>
+              <a:t>#SBATCH -t 00:20:00</a:t>
             </a:r>
           </a:p>
         </p:txBody>
@@ -13381,29 +13240,7 @@
                 <a:ea typeface="Menlo"/>
                 <a:cs typeface="Menlo"/>
               </a:rPr>
-              <a:t>srun --cpu-bind=cores ./build/reg_reuse </a:t>
-            </a:r>
-            <a:r>
-              <a:rPr sz="2250" b="0">
-                <a:solidFill>
-                  <a:srgbClr val="B7EDDB"/>
-                </a:solidFill>
-                <a:latin typeface="Menlo"/>
-                <a:ea typeface="Menlo"/>
-                <a:cs typeface="Menlo"/>
-              </a:rPr>
-              <a:t>66 126 258 510 1026 2046</a:t>
-            </a:r>
-            <a:r>
-              <a:rPr sz="2250" b="0">
-                <a:solidFill>
-                  <a:srgbClr val="B7EDDB"/>
-                </a:solidFill>
-                <a:latin typeface="Menlo"/>
-                <a:ea typeface="Menlo"/>
-                <a:cs typeface="Menlo"/>
-              </a:rPr>
-              <a:t> \</a:t>
+              <a:t>srun --cpu-bind=cores ./build/reg_reuse 66 126 258 510 1026 2046 \</a:t>
             </a:r>
           </a:p>
         </p:txBody>
@@ -18159,7 +17996,7 @@
                 <a:ea typeface="Hiragino Sans GB"/>
                 <a:cs typeface="Hiragino Sans GB"/>
               </a:rPr>
-              <a:t>scripts/submit.sh 只是本地包装；向调度系统提交作业使用 sbatch</a:t>
+              <a:t>批量脚本在计算节点运行；向调度系统提交作业使用 sbatch</a:t>
             </a:r>
           </a:p>
         </p:txBody>
@@ -22839,7 +22676,7 @@
                 <a:ea typeface="Hiragino Sans GB"/>
                 <a:cs typeface="Hiragino Sans GB"/>
               </a:rPr>
-              <a:t>本仓库的 submit.sh 不会提交 Slurm。批处理使用 sbatch lab1.slurm / lab2.slurm。</a:t>
+              <a:t>批处理作业在登录节点提交：sbatch lab1.slurm 或 sbatch lab2.slurm。</a:t>
             </a:r>
           </a:p>
         </p:txBody>
@@ -23287,7 +23124,7 @@
                 <a:latin typeface="Hiragino Sans GB"/>
                 <a:ea typeface="Hiragino Sans GB"/>
                 <a:cs typeface="Hiragino Sans GB"/>
-                <a:hlinkClick xmlns:r="http://schemas.openxmlformats.org/officeDocument/2006/relationships" r:id="Ra12f4bf9c95247a4"/>
+                <a:hlinkClick xmlns:r="http://schemas.openxmlformats.org/officeDocument/2006/relationships" r:id="R766c294df41042c5"/>
               </a:rPr>
               <a:t>登录与账号</a:t>
             </a:r>
@@ -23346,7 +23183,7 @@
                 <a:latin typeface="Hiragino Sans GB"/>
                 <a:ea typeface="Hiragino Sans GB"/>
                 <a:cs typeface="Hiragino Sans GB"/>
-                <a:hlinkClick xmlns:r="http://schemas.openxmlformats.org/officeDocument/2006/relationships" r:id="R1110b0d6c809420a"/>
+                <a:hlinkClick xmlns:r="http://schemas.openxmlformats.org/officeDocument/2006/relationships" r:id="Rbdb48d6f0bee4448"/>
               </a:rPr>
               <a:t>Slurm 作业管理</a:t>
             </a:r>
@@ -23405,7 +23242,7 @@
                 <a:latin typeface="Hiragino Sans GB"/>
                 <a:ea typeface="Hiragino Sans GB"/>
                 <a:cs typeface="Hiragino Sans GB"/>
-                <a:hlinkClick xmlns:r="http://schemas.openxmlformats.org/officeDocument/2006/relationships" r:id="Rcaaccb6436884d98"/>
+                <a:hlinkClick xmlns:r="http://schemas.openxmlformats.org/officeDocument/2006/relationships" r:id="Ra3f49e51ea2c4108"/>
               </a:rPr>
               <a:t>文件传输</a:t>
             </a:r>

</xml_diff>

<commit_message>
feat: add course Slurm examples with three-hour limits
</commit_message>
<xml_diff>
--- a/docs/交我算平台Lab运行指南-学生版.pptx
+++ b/docs/交我算平台Lab运行指南-学生版.pptx
@@ -2,47 +2,47 @@
 <file path=ppt/presentation.xml><?xml version="1.0" encoding="utf-8"?>
 <p:presentation xmlns:p="http://schemas.openxmlformats.org/presentationml/2006/main">
   <p:sldMasterIdLst>
-    <p:sldMasterId xmlns:r="http://schemas.openxmlformats.org/officeDocument/2006/relationships" id="2147483648" r:id="Rfcd11733302f4ccf"/>
+    <p:sldMasterId xmlns:r="http://schemas.openxmlformats.org/officeDocument/2006/relationships" id="2147483648" r:id="R493418f1efc1463c"/>
   </p:sldMasterIdLst>
   <p:notesMasterIdLst>
-    <p:notesMasterId xmlns:r="http://schemas.openxmlformats.org/officeDocument/2006/relationships" r:id="R69f3fb811bd44067"/>
+    <p:notesMasterId xmlns:r="http://schemas.openxmlformats.org/officeDocument/2006/relationships" r:id="R1c440ace0b4b498b"/>
   </p:notesMasterIdLst>
   <p:sldIdLst>
-    <p:sldId xmlns:r="http://schemas.openxmlformats.org/officeDocument/2006/relationships" id="256" r:id="R267744d14b634a8b"/>
-    <p:sldId xmlns:r="http://schemas.openxmlformats.org/officeDocument/2006/relationships" id="257" r:id="R696942c9314049d5"/>
-    <p:sldId xmlns:r="http://schemas.openxmlformats.org/officeDocument/2006/relationships" id="258" r:id="Ree039175ee484467"/>
-    <p:sldId xmlns:r="http://schemas.openxmlformats.org/officeDocument/2006/relationships" id="259" r:id="Rab31ace019f74a78"/>
-    <p:sldId xmlns:r="http://schemas.openxmlformats.org/officeDocument/2006/relationships" id="260" r:id="R4010a85714be4c51"/>
-    <p:sldId xmlns:r="http://schemas.openxmlformats.org/officeDocument/2006/relationships" id="261" r:id="R750e583ce2a34ac3"/>
-    <p:sldId xmlns:r="http://schemas.openxmlformats.org/officeDocument/2006/relationships" id="262" r:id="R9ba922d7094c44b3"/>
-    <p:sldId xmlns:r="http://schemas.openxmlformats.org/officeDocument/2006/relationships" id="263" r:id="R64548caa82824c4c"/>
-    <p:sldId xmlns:r="http://schemas.openxmlformats.org/officeDocument/2006/relationships" id="264" r:id="Rf2ca0ea7c6f24c96"/>
-    <p:sldId xmlns:r="http://schemas.openxmlformats.org/officeDocument/2006/relationships" id="265" r:id="R7c89b6f009794216"/>
-    <p:sldId xmlns:r="http://schemas.openxmlformats.org/officeDocument/2006/relationships" id="266" r:id="R23abd02030ad460d"/>
-    <p:sldId xmlns:r="http://schemas.openxmlformats.org/officeDocument/2006/relationships" id="267" r:id="R669eccf00d414529"/>
-    <p:sldId xmlns:r="http://schemas.openxmlformats.org/officeDocument/2006/relationships" id="268" r:id="R243f2b9f75904f68"/>
-    <p:sldId xmlns:r="http://schemas.openxmlformats.org/officeDocument/2006/relationships" id="269" r:id="Rac6b8ebb9cfd491f"/>
-    <p:sldId xmlns:r="http://schemas.openxmlformats.org/officeDocument/2006/relationships" id="270" r:id="R555429a6826b413d"/>
-    <p:sldId xmlns:r="http://schemas.openxmlformats.org/officeDocument/2006/relationships" id="271" r:id="Rfaa418fd6b6d44be"/>
-    <p:sldId xmlns:r="http://schemas.openxmlformats.org/officeDocument/2006/relationships" id="272" r:id="Red79ef18c2c94e2e"/>
-    <p:sldId xmlns:r="http://schemas.openxmlformats.org/officeDocument/2006/relationships" id="273" r:id="R25b8b9239b4f4d96"/>
-    <p:sldId xmlns:r="http://schemas.openxmlformats.org/officeDocument/2006/relationships" id="274" r:id="R043aba2dc8f8410b"/>
-    <p:sldId xmlns:r="http://schemas.openxmlformats.org/officeDocument/2006/relationships" id="275" r:id="R57b0ef0882424329"/>
-    <p:sldId xmlns:r="http://schemas.openxmlformats.org/officeDocument/2006/relationships" id="276" r:id="Raafdb43ca7d747a7"/>
-    <p:sldId xmlns:r="http://schemas.openxmlformats.org/officeDocument/2006/relationships" id="277" r:id="R24507dfffd2d45b2"/>
-    <p:sldId xmlns:r="http://schemas.openxmlformats.org/officeDocument/2006/relationships" id="278" r:id="R4b8a5fc8af1046a3"/>
-    <p:sldId xmlns:r="http://schemas.openxmlformats.org/officeDocument/2006/relationships" id="279" r:id="R1de2a6eff9ff427b"/>
-    <p:sldId xmlns:r="http://schemas.openxmlformats.org/officeDocument/2006/relationships" id="280" r:id="Rd4f5aae7087c4e38"/>
-    <p:sldId xmlns:r="http://schemas.openxmlformats.org/officeDocument/2006/relationships" id="281" r:id="R406ec6ec6d844448"/>
-    <p:sldId xmlns:r="http://schemas.openxmlformats.org/officeDocument/2006/relationships" id="282" r:id="Rd3f7d335942344a9"/>
-    <p:sldId xmlns:r="http://schemas.openxmlformats.org/officeDocument/2006/relationships" id="283" r:id="Rff541385259144ff"/>
-    <p:sldId xmlns:r="http://schemas.openxmlformats.org/officeDocument/2006/relationships" id="284" r:id="Re7a2c51de64c408c"/>
-    <p:sldId xmlns:r="http://schemas.openxmlformats.org/officeDocument/2006/relationships" id="285" r:id="Ref6a5152ae0648dc"/>
-    <p:sldId xmlns:r="http://schemas.openxmlformats.org/officeDocument/2006/relationships" id="286" r:id="Rc950d08191ba49d4"/>
-    <p:sldId xmlns:r="http://schemas.openxmlformats.org/officeDocument/2006/relationships" id="287" r:id="R00afe8ace05e40a8"/>
-    <p:sldId xmlns:r="http://schemas.openxmlformats.org/officeDocument/2006/relationships" id="288" r:id="R8344d0cdc793428d"/>
-    <p:sldId xmlns:r="http://schemas.openxmlformats.org/officeDocument/2006/relationships" id="289" r:id="R511e105092a948a7"/>
-    <p:sldId xmlns:r="http://schemas.openxmlformats.org/officeDocument/2006/relationships" id="290" r:id="R2ac6ed7170c04621"/>
+    <p:sldId xmlns:r="http://schemas.openxmlformats.org/officeDocument/2006/relationships" id="256" r:id="R72ff58062e724736"/>
+    <p:sldId xmlns:r="http://schemas.openxmlformats.org/officeDocument/2006/relationships" id="257" r:id="Rffb4466b292b4551"/>
+    <p:sldId xmlns:r="http://schemas.openxmlformats.org/officeDocument/2006/relationships" id="258" r:id="Ra533eff978664dae"/>
+    <p:sldId xmlns:r="http://schemas.openxmlformats.org/officeDocument/2006/relationships" id="259" r:id="Ra68a8527b0ca44ae"/>
+    <p:sldId xmlns:r="http://schemas.openxmlformats.org/officeDocument/2006/relationships" id="260" r:id="R95f27af4555d4ad7"/>
+    <p:sldId xmlns:r="http://schemas.openxmlformats.org/officeDocument/2006/relationships" id="261" r:id="R33f307b6c03e407b"/>
+    <p:sldId xmlns:r="http://schemas.openxmlformats.org/officeDocument/2006/relationships" id="262" r:id="R4eb1e49eccb941c8"/>
+    <p:sldId xmlns:r="http://schemas.openxmlformats.org/officeDocument/2006/relationships" id="263" r:id="R7e8c35c7b8014989"/>
+    <p:sldId xmlns:r="http://schemas.openxmlformats.org/officeDocument/2006/relationships" id="264" r:id="R646b46ca12db4652"/>
+    <p:sldId xmlns:r="http://schemas.openxmlformats.org/officeDocument/2006/relationships" id="265" r:id="R3b62783d0f134714"/>
+    <p:sldId xmlns:r="http://schemas.openxmlformats.org/officeDocument/2006/relationships" id="266" r:id="R42f515e893234d19"/>
+    <p:sldId xmlns:r="http://schemas.openxmlformats.org/officeDocument/2006/relationships" id="267" r:id="R19ef538f754049c5"/>
+    <p:sldId xmlns:r="http://schemas.openxmlformats.org/officeDocument/2006/relationships" id="268" r:id="R3243cfb98a6d4665"/>
+    <p:sldId xmlns:r="http://schemas.openxmlformats.org/officeDocument/2006/relationships" id="269" r:id="Re95cac0353344f2c"/>
+    <p:sldId xmlns:r="http://schemas.openxmlformats.org/officeDocument/2006/relationships" id="270" r:id="R8268584687fd471f"/>
+    <p:sldId xmlns:r="http://schemas.openxmlformats.org/officeDocument/2006/relationships" id="271" r:id="R3ef341a755c54e9b"/>
+    <p:sldId xmlns:r="http://schemas.openxmlformats.org/officeDocument/2006/relationships" id="272" r:id="Rb5ca6a10bc104b9b"/>
+    <p:sldId xmlns:r="http://schemas.openxmlformats.org/officeDocument/2006/relationships" id="273" r:id="R18136eb127df4974"/>
+    <p:sldId xmlns:r="http://schemas.openxmlformats.org/officeDocument/2006/relationships" id="274" r:id="R98e1f03df5824ede"/>
+    <p:sldId xmlns:r="http://schemas.openxmlformats.org/officeDocument/2006/relationships" id="275" r:id="R40f5f6b8cf1149c1"/>
+    <p:sldId xmlns:r="http://schemas.openxmlformats.org/officeDocument/2006/relationships" id="276" r:id="Rf17a0c4ff9bf4ecf"/>
+    <p:sldId xmlns:r="http://schemas.openxmlformats.org/officeDocument/2006/relationships" id="277" r:id="R5466bbca83b14009"/>
+    <p:sldId xmlns:r="http://schemas.openxmlformats.org/officeDocument/2006/relationships" id="278" r:id="R39fc4b10bea94934"/>
+    <p:sldId xmlns:r="http://schemas.openxmlformats.org/officeDocument/2006/relationships" id="279" r:id="Ree0f3420640c44cf"/>
+    <p:sldId xmlns:r="http://schemas.openxmlformats.org/officeDocument/2006/relationships" id="280" r:id="R203b12f9b51d4de4"/>
+    <p:sldId xmlns:r="http://schemas.openxmlformats.org/officeDocument/2006/relationships" id="281" r:id="R31c85b4ab5b64649"/>
+    <p:sldId xmlns:r="http://schemas.openxmlformats.org/officeDocument/2006/relationships" id="282" r:id="R471bf77975d2454a"/>
+    <p:sldId xmlns:r="http://schemas.openxmlformats.org/officeDocument/2006/relationships" id="283" r:id="Ref47c10f445a44fe"/>
+    <p:sldId xmlns:r="http://schemas.openxmlformats.org/officeDocument/2006/relationships" id="284" r:id="R5dd64a7ebfaf47fa"/>
+    <p:sldId xmlns:r="http://schemas.openxmlformats.org/officeDocument/2006/relationships" id="285" r:id="R58c69408dc324362"/>
+    <p:sldId xmlns:r="http://schemas.openxmlformats.org/officeDocument/2006/relationships" id="286" r:id="Rdeac3502b3b34222"/>
+    <p:sldId xmlns:r="http://schemas.openxmlformats.org/officeDocument/2006/relationships" id="287" r:id="R63b0369a78b24f66"/>
+    <p:sldId xmlns:r="http://schemas.openxmlformats.org/officeDocument/2006/relationships" id="288" r:id="Rc73052361bff40df"/>
+    <p:sldId xmlns:r="http://schemas.openxmlformats.org/officeDocument/2006/relationships" id="289" r:id="R332ca5b1dd024d90"/>
+    <p:sldId xmlns:r="http://schemas.openxmlformats.org/officeDocument/2006/relationships" id="290" r:id="R095066e4c5264a01"/>
   </p:sldIdLst>
   <p:sldSz cx="15240000" cy="8572500"/>
   <p:notesSz cx="6858000" cy="9144000"/>
@@ -1017,10 +1017,13 @@
           <a:lstStyle xmlns:a="http://schemas.openxmlformats.org/drawingml/2006/main"/>
           <a:p xmlns:a="http://schemas.openxmlformats.org/drawingml/2006/main">
             <a:r>
-              <a:t>在登录节点执行 srun。成功分配后才执行下方编译器检查，hostname 应显示计算节点。若排队，等待分配，不要退回登录节点直接运行实验。1 task、1 CPU 足以运行当前串行框架。最长运行 20 分钟，不含排队时间；编译、测试与交互终端空闲均计入时限。退出 bash 会释放交互式资源。登录节点于 2026-09-27 实测有 GCC 8.5.0、CMake 3.20.2，但计算节点仍需现场确认。</a:t>
-            </a:r>
-          </a:p>
-          <a:p xmlns:a="http://schemas.openxmlformats.org/drawingml/2006/main">
+              <a:t>在登录节点执行 srun。成功分配后才执行下方编译器检查，hostname 应显示计算节点。若排队，等待分配，不要退回登录节点直接运行实验。1 task、1 CPU 足以运行当前串行框架。最长运行 3 小时，不含排队时间；编译、测试与交互终端空闲均计入时限。退出 bash 会释放交互式资源。登录节点于 2026-09-27 实测有 GCC 8.5.0、CMake 3.20.2，但计算节点仍需现场确认。</a:t>
+            </a:r>
+          </a:p>
+          <a:p xmlns:a="http://schemas.openxmlformats.org/drawingml/2006/main">
+            <a:r>
+              <a:t/>
+            </a:r>
             <a:endParaRPr/>
           </a:p>
           <a:p xmlns:a="http://schemas.openxmlformats.org/drawingml/2006/main">
@@ -1049,9 +1052,15 @@
             </a:r>
           </a:p>
           <a:p xmlns:a="http://schemas.openxmlformats.org/drawingml/2006/main">
+            <a:r>
+              <a:t/>
+            </a:r>
             <a:endParaRPr/>
           </a:p>
           <a:p xmlns:a="http://schemas.openxmlformats.org/drawingml/2006/main">
+            <a:r>
+              <a:t/>
+            </a:r>
             <a:endParaRPr/>
           </a:p>
           <a:p xmlns:a="http://schemas.openxmlformats.org/drawingml/2006/main">
@@ -1060,6 +1069,9 @@
             </a:r>
           </a:p>
           <a:p xmlns:a="http://schemas.openxmlformats.org/drawingml/2006/main">
+            <a:r>
+              <a:t/>
+            </a:r>
             <a:endParaRPr/>
           </a:p>
         </p:txBody>
@@ -1272,6 +1284,11 @@
               <a:t>来源：课程仓库 labs/lab2-matrix/README.md 第 5、7、8、9 节，CMakeLists.txt、scripts/run_all.sh（2026-09-27）。 与 README 第 7.2 节的六条程序命令完全一致。ctest 不覆盖这些学生函数。</a:t>
             </a:r>
           </a:p>
+          <a:p xmlns:a="http://schemas.openxmlformats.org/drawingml/2006/main">
+            <a:r>
+              <a:t>完整批处理脚本已提供：从课程根目录执行 mkdir -p results，再 sbatch slurm/lab2-check.slurm。</a:t>
+            </a:r>
+          </a:p>
         </p:txBody>
       </p:sp>
       <p:sp>
@@ -1343,6 +1360,9 @@
             </a:r>
           </a:p>
           <a:p xmlns:a="http://schemas.openxmlformats.org/drawingml/2006/main">
+            <a:r>
+              <a:t/>
+            </a:r>
             <a:endParaRPr/>
           </a:p>
           <a:p xmlns:a="http://schemas.openxmlformats.org/drawingml/2006/main">
@@ -1361,14 +1381,20 @@
             </a:r>
           </a:p>
           <a:p xmlns:a="http://schemas.openxmlformats.org/drawingml/2006/main">
+            <a:r>
+              <a:t/>
+            </a:r>
             <a:endParaRPr/>
           </a:p>
           <a:p xmlns:a="http://schemas.openxmlformats.org/drawingml/2006/main">
             <a:r>
-              <a:t>本教程的交互式申请和批处理脚本统一使用 00:20:00，即最长运行 20 分钟。时限不含排队时间。提前结束会释放资源。正式实验按实测耗时分批或调整时限。</a:t>
-            </a:r>
-          </a:p>
-          <a:p xmlns:a="http://schemas.openxmlformats.org/drawingml/2006/main">
+              <a:t>本教程的交互式申请和批处理脚本统一使用 03:00:00，即最长运行 3 小时。时限不含排队时间。提前结束会释放资源。正式实验按实测耗时分批或调整时限。</a:t>
+            </a:r>
+          </a:p>
+          <a:p xmlns:a="http://schemas.openxmlformats.org/drawingml/2006/main">
+            <a:r>
+              <a:t/>
+            </a:r>
             <a:endParaRPr/>
           </a:p>
         </p:txBody>
@@ -1441,6 +1467,121 @@
               <a:t>来源：课程仓库 labs/lab1-datalab/README.md 第 3、10、11、13 节和 Makefile（2026-09-27）。 脚本从仓库根目录提交。先在登录节点 mkdir -p results，Slurm 日志为根目录 results/lab1-%j.log。姓名学号未填或答案错误时返回非零。set -euo pipefail 在失败时停止。</a:t>
             </a:r>
           </a:p>
+          <a:p xmlns:a="http://schemas.openxmlformats.org/drawingml/2006/main">
+            <a:r>
+              <a:t>课程根目录已提供 lab1.slurm；页面展示默认评分的主要步骤，完整脚本还检查 Slurm 环境、参数数量，并支持 sbatch lab1.slurm bitCount。</a:t>
+            </a:r>
+          </a:p>
+          <a:p xmlns:a="http://schemas.openxmlformats.org/drawingml/2006/main">
+            <a:r>
+              <a:t>完整脚本：</a:t>
+            </a:r>
+          </a:p>
+          <a:p xmlns:a="http://schemas.openxmlformats.org/drawingml/2006/main">
+            <a:r>
+              <a:t>#!/bin/bash -l</a:t>
+            </a:r>
+          </a:p>
+          <a:p xmlns:a="http://schemas.openxmlformats.org/drawingml/2006/main">
+            <a:r>
+              <a:t>#SBATCH -J datalab</a:t>
+            </a:r>
+          </a:p>
+          <a:p xmlns:a="http://schemas.openxmlformats.org/drawingml/2006/main">
+            <a:r>
+              <a:t>#SBATCH -p cpu -N 1 -n 1 -c 1</a:t>
+            </a:r>
+          </a:p>
+          <a:p xmlns:a="http://schemas.openxmlformats.org/drawingml/2006/main">
+            <a:r>
+              <a:t>#SBATCH -t 03:00:00</a:t>
+            </a:r>
+          </a:p>
+          <a:p xmlns:a="http://schemas.openxmlformats.org/drawingml/2006/main">
+            <a:r>
+              <a:t>#SBATCH -o results/lab1-%j.log</a:t>
+            </a:r>
+          </a:p>
+          <a:p xmlns:a="http://schemas.openxmlformats.org/drawingml/2006/main">
+            <a:r>
+              <a:t/>
+            </a:r>
+          </a:p>
+          <a:p xmlns:a="http://schemas.openxmlformats.org/drawingml/2006/main">
+            <a:r>
+              <a:t>set -euo pipefail</a:t>
+            </a:r>
+          </a:p>
+          <a:p xmlns:a="http://schemas.openxmlformats.org/drawingml/2006/main">
+            <a:r>
+              <a:t>: "${SLURM_JOB_ID:?请使用 sbatch 提交作业，不要在登录节点直接运行}"</a:t>
+            </a:r>
+          </a:p>
+          <a:p xmlns:a="http://schemas.openxmlformats.org/drawingml/2006/main">
+            <a:r>
+              <a:t/>
+            </a:r>
+          </a:p>
+          <a:p xmlns:a="http://schemas.openxmlformats.org/drawingml/2006/main">
+            <a:r>
+              <a:t>if (( $# &gt; 1 )); then</a:t>
+            </a:r>
+          </a:p>
+          <a:p xmlns:a="http://schemas.openxmlformats.org/drawingml/2006/main">
+            <a:r>
+              <a:t>  echo "用法：sbatch lab1.slurm [函数名]" &gt;&amp;2</a:t>
+            </a:r>
+          </a:p>
+          <a:p xmlns:a="http://schemas.openxmlformats.org/drawingml/2006/main">
+            <a:r>
+              <a:t>  exit 2</a:t>
+            </a:r>
+          </a:p>
+          <a:p xmlns:a="http://schemas.openxmlformats.org/drawingml/2006/main">
+            <a:r>
+              <a:t>fi</a:t>
+            </a:r>
+          </a:p>
+          <a:p xmlns:a="http://schemas.openxmlformats.org/drawingml/2006/main">
+            <a:r>
+              <a:t>cd "${SLURM_SUBMIT_DIR:?请从课程根目录提交}/labs/lab1-datalab"</a:t>
+            </a:r>
+          </a:p>
+          <a:p xmlns:a="http://schemas.openxmlformats.org/drawingml/2006/main">
+            <a:r>
+              <a:t>make -j1</a:t>
+            </a:r>
+          </a:p>
+          <a:p xmlns:a="http://schemas.openxmlformats.org/drawingml/2006/main">
+            <a:r>
+              <a:t>if (( $# == 1 )); then</a:t>
+            </a:r>
+          </a:p>
+          <a:p xmlns:a="http://schemas.openxmlformats.org/drawingml/2006/main">
+            <a:r>
+              <a:t>  srun --cpu-bind=cores ./btest -f "$1"</a:t>
+            </a:r>
+          </a:p>
+          <a:p xmlns:a="http://schemas.openxmlformats.org/drawingml/2006/main">
+            <a:r>
+              <a:t>else</a:t>
+            </a:r>
+          </a:p>
+          <a:p xmlns:a="http://schemas.openxmlformats.org/drawingml/2006/main">
+            <a:r>
+              <a:t>  srun --cpu-bind=cores ./btest -g</a:t>
+            </a:r>
+          </a:p>
+          <a:p xmlns:a="http://schemas.openxmlformats.org/drawingml/2006/main">
+            <a:r>
+              <a:t>fi</a:t>
+            </a:r>
+          </a:p>
+          <a:p xmlns:a="http://schemas.openxmlformats.org/drawingml/2006/main">
+            <a:r>
+              <a:t/>
+            </a:r>
+          </a:p>
         </p:txBody>
       </p:sp>
       <p:sp>
@@ -1596,12 +1737,12 @@
           <a:lstStyle xmlns:a="http://schemas.openxmlformats.org/drawingml/2006/main"/>
           <a:p xmlns:a="http://schemas.openxmlformats.org/drawingml/2006/main">
             <a:r>
-              <a:t>来源：课程仓库 labs/lab2-matrix/README.md 第 5、7、8、9 节，CMakeLists.txt、scripts/run_all.sh（2026-09-27）。</a:t>
-            </a:r>
-          </a:p>
-          <a:p xmlns:a="http://schemas.openxmlformats.org/drawingml/2006/main">
-            <a:r>
-              <a:t>本页命令用于替换 lab2.slurm 的实验段，保留脚本的 set -euo pipefail、编译、CTest 和 mkdir -p results；脚本已经进入 Lab 2 目录。每次只运行一个阶段，同一源码目录一次只运行一个作业。程序前增加 srun --cpu-bind=cores，参数与 README 一致。在 srun --pty 打开的交互式计算终端，直接使用 README 不带 srun 前缀的程序命令，已有终端会话已绑定 CPU。</a:t>
+              <a:t>来源：课程仓库 labs/lab2-matrix/README.md 第 5、7、8、9 节及 lab2.slurm（2026-09-27）。</a:t>
+            </a:r>
+          </a:p>
+          <a:p xmlns:a="http://schemas.openxmlformats.org/drawingml/2006/main">
+            <a:r>
+              <a:t>课程已提供各阶段独立 Slurm 脚本，列表见 slurm/README.md。从课程根目录先 mkdir -p results，再用 sbatch 提交；脚本会完成编译、CTest 和环境记录，并进入 Lab 2 目录。下方代码展示实验命令。同一源码目录一次只运行一个作业。页面展示核心步骤，完整脚本还检查 Slurm 环境并自动记录环境。CTest 写法兼容 CMake 3.16 及以上版本。模块实际名称可由 CMAKE_MODULE 指定。</a:t>
             </a:r>
           </a:p>
           <a:p xmlns:a="http://schemas.openxmlformats.org/drawingml/2006/main">
@@ -1626,7 +1767,7 @@
           </a:p>
           <a:p xmlns:a="http://schemas.openxmlformats.org/drawingml/2006/main">
             <a:r>
-              <a:t>#SBATCH -t 00:20:00</a:t>
+              <a:t>#SBATCH -t 03:00:00</a:t>
             </a:r>
           </a:p>
           <a:p xmlns:a="http://schemas.openxmlformats.org/drawingml/2006/main">
@@ -1635,6 +1776,9 @@
             </a:r>
           </a:p>
           <a:p xmlns:a="http://schemas.openxmlformats.org/drawingml/2006/main">
+            <a:r>
+              <a:t/>
+            </a:r>
             <a:endParaRPr/>
           </a:p>
           <a:p xmlns:a="http://schemas.openxmlformats.org/drawingml/2006/main">
@@ -1644,17 +1788,22 @@
           </a:p>
           <a:p xmlns:a="http://schemas.openxmlformats.org/drawingml/2006/main">
             <a:r>
-              <a:t>cd "$SLURM_SUBMIT_DIR"</a:t>
-            </a:r>
-          </a:p>
-          <a:p xmlns:a="http://schemas.openxmlformats.org/drawingml/2006/main">
-            <a:r>
-              <a:t>cd labs/lab2-matrix</a:t>
-            </a:r>
-          </a:p>
-          <a:p xmlns:a="http://schemas.openxmlformats.org/drawingml/2006/main">
-            <a:r>
-              <a:t>module load cmake</a:t>
+              <a:t>: "${SLURM_JOB_ID:?请使用 sbatch 提交作业，不要在登录节点直接运行}"</a:t>
+            </a:r>
+          </a:p>
+          <a:p xmlns:a="http://schemas.openxmlformats.org/drawingml/2006/main">
+            <a:r>
+              <a:t/>
+            </a:r>
+          </a:p>
+          <a:p xmlns:a="http://schemas.openxmlformats.org/drawingml/2006/main">
+            <a:r>
+              <a:t>cd "${SLURM_SUBMIT_DIR:?请从课程根目录提交}/labs/lab2-matrix"</a:t>
+            </a:r>
+          </a:p>
+          <a:p xmlns:a="http://schemas.openxmlformats.org/drawingml/2006/main">
+            <a:r>
+              <a:t>module load "${CMAKE_MODULE:-cmake}"</a:t>
             </a:r>
           </a:p>
           <a:p xmlns:a="http://schemas.openxmlformats.org/drawingml/2006/main">
@@ -1669,38 +1818,111 @@
           </a:p>
           <a:p xmlns:a="http://schemas.openxmlformats.org/drawingml/2006/main">
             <a:r>
-              <a:t>ctest --test-dir build --output-on-failure</a:t>
+              <a:t>(cd build &amp;&amp; ctest --output-on-failure)</a:t>
             </a:r>
           </a:p>
           <a:p xmlns:a="http://schemas.openxmlformats.org/drawingml/2006/main">
             <a:r>
               <a:t>mkdir -p results</a:t>
             </a:r>
-          </a:p>
-          <a:p xmlns:a="http://schemas.openxmlformats.org/drawingml/2006/main">
             <a:endParaRPr/>
           </a:p>
           <a:p xmlns:a="http://schemas.openxmlformats.org/drawingml/2006/main">
             <a:r>
-              <a:t>srun --cpu-bind=cores \</a:t>
-            </a:r>
-          </a:p>
-          <a:p xmlns:a="http://schemas.openxmlformats.org/drawingml/2006/main">
-            <a:r>
-              <a:t>  ./build/cache_part3 2048 64 \</a:t>
-            </a:r>
+              <a:t/>
+            </a:r>
+          </a:p>
+          <a:p xmlns:a="http://schemas.openxmlformats.org/drawingml/2006/main">
+            <a:r>
+              <a:t>{</a:t>
+            </a:r>
+          </a:p>
+          <a:p xmlns:a="http://schemas.openxmlformats.org/drawingml/2006/main">
+            <a:r>
+              <a:t>  printf 'JobID: %s\n' "$SLURM_JOB_ID"</a:t>
+            </a:r>
+          </a:p>
+          <a:p xmlns:a="http://schemas.openxmlformats.org/drawingml/2006/main">
+            <a:r>
+              <a:t>  hostname</a:t>
+            </a:r>
+          </a:p>
+          <a:p xmlns:a="http://schemas.openxmlformats.org/drawingml/2006/main">
+            <a:r>
+              <a:t>  lscpu</a:t>
+            </a:r>
+            <a:endParaRPr/>
+          </a:p>
+          <a:p xmlns:a="http://schemas.openxmlformats.org/drawingml/2006/main">
+            <a:r>
+              <a:t>  gcc --version</a:t>
+            </a:r>
+            <a:endParaRPr/>
+          </a:p>
+          <a:p xmlns:a="http://schemas.openxmlformats.org/drawingml/2006/main">
+            <a:r>
+              <a:t>  cmake --version</a:t>
+            </a:r>
+            <a:endParaRPr/>
+          </a:p>
+          <a:p xmlns:a="http://schemas.openxmlformats.org/drawingml/2006/main">
+            <a:r>
+              <a:t>  uname -a</a:t>
+            </a:r>
+            <a:endParaRPr/>
+          </a:p>
+          <a:p xmlns:a="http://schemas.openxmlformats.org/drawingml/2006/main">
+            <a:r>
+              <a:t>} | tee results/environment.txt</a:t>
+            </a:r>
+            <a:endParaRPr/>
+          </a:p>
+          <a:p xmlns:a="http://schemas.openxmlformats.org/drawingml/2006/main">
+            <a:r>
+              <a:t/>
+            </a:r>
+            <a:endParaRPr/>
+          </a:p>
+          <a:p xmlns:a="http://schemas.openxmlformats.org/drawingml/2006/main">
+            <a:r>
+              <a:t># README §8.3：正式循环次序实验。</a:t>
+            </a:r>
+            <a:endParaRPr/>
+          </a:p>
+          <a:p xmlns:a="http://schemas.openxmlformats.org/drawingml/2006/main">
+            <a:r>
+              <a:t>srun --cpu-bind=cores ./build/cache_part3 2048 64 \</a:t>
+            </a:r>
+            <a:endParaRPr/>
           </a:p>
           <a:p xmlns:a="http://schemas.openxmlformats.org/drawingml/2006/main">
             <a:r>
               <a:t>  2&gt;&amp;1 | tee results/loop_orders.txt</a:t>
             </a:r>
-          </a:p>
-          <a:p xmlns:a="http://schemas.openxmlformats.org/drawingml/2006/main">
-            <a:r>
-              <a:t>CMake 3.20 开始支持 ctest --test-dir；3.16～3.19 使用 (cd build &amp;&amp; ctest --output-on-failure)。来源：https://cmake.org/cmake/help/v3.20/release/3.20.html#ctest</a:t>
-            </a:r>
-          </a:p>
-          <a:p xmlns:a="http://schemas.openxmlformats.org/drawingml/2006/main">
+            <a:endParaRPr/>
+          </a:p>
+          <a:p xmlns:a="http://schemas.openxmlformats.org/drawingml/2006/main">
+            <a:r>
+              <a:t/>
+            </a:r>
+            <a:endParaRPr/>
+          </a:p>
+          <a:p xmlns:a="http://schemas.openxmlformats.org/drawingml/2006/main">
+            <a:r>
+              <a:t>Slurm 参数依据：https://slurm.schedmd.com/sbatch.html</a:t>
+            </a:r>
+            <a:endParaRPr/>
+          </a:p>
+          <a:p xmlns:a="http://schemas.openxmlformats.org/drawingml/2006/main">
+            <a:r>
+              <a:t>https://slurm.schedmd.com/srun.html</a:t>
+            </a:r>
+            <a:endParaRPr/>
+          </a:p>
+          <a:p xmlns:a="http://schemas.openxmlformats.org/drawingml/2006/main">
+            <a:r>
+              <a:t/>
+            </a:r>
             <a:endParaRPr/>
           </a:p>
         </p:txBody>
@@ -1775,7 +1997,7 @@
           </a:p>
           <a:p xmlns:a="http://schemas.openxmlformats.org/drawingml/2006/main">
             <a:r>
-              <a:t>本页命令用于替换 lab2.slurm 的实验段，保留脚本的 set -euo pipefail、编译、CTest 和 mkdir -p results；脚本已经进入 Lab 2 目录。每次只运行一个阶段，同一源码目录一次只运行一个作业。程序前增加 srun --cpu-bind=cores，参数与 README 一致。在 srun --pty 打开的交互式计算终端，直接使用 README 不带 srun 前缀的程序命令，已有终端会话已绑定 CPU。</a:t>
+              <a:t>课程已提供各阶段独立 Slurm 脚本，列表见 slurm/README.md。从课程根目录先 mkdir -p results，再用 sbatch 提交；脚本会完成编译、CTest 和环境记录，并进入 Lab 2 目录。下方代码展示实验命令。每次只运行一个阶段，同一源码目录一次只运行一个作业。程序前增加 srun --cpu-bind=cores，参数与 README 一致。在 srun --pty 打开的交互式计算终端，直接使用 README 不带 srun 前缀的程序命令，已有终端会话已绑定 CPU。</a:t>
             </a:r>
           </a:p>
           <a:p xmlns:a="http://schemas.openxmlformats.org/drawingml/2006/main">
@@ -1784,6 +2006,9 @@
             </a:r>
           </a:p>
           <a:p xmlns:a="http://schemas.openxmlformats.org/drawingml/2006/main">
+            <a:r>
+              <a:t/>
+            </a:r>
             <a:endParaRPr/>
           </a:p>
         </p:txBody>
@@ -1858,7 +2083,7 @@
           </a:p>
           <a:p xmlns:a="http://schemas.openxmlformats.org/drawingml/2006/main">
             <a:r>
-              <a:t>本页命令用于替换 lab2.slurm 的实验段，保留脚本的 set -euo pipefail、编译、CTest 和 mkdir -p results；脚本已经进入 Lab 2 目录。每次只运行一个阶段，同一源码目录一次只运行一个作业。程序前增加 srun --cpu-bind=cores，参数与 README 一致。在 srun --pty 打开的交互式计算终端，直接使用 README 不带 srun 前缀的程序命令，已有终端会话已绑定 CPU。 : &gt; 和 tee 会覆盖同名日志，重跑前保存上一批结果。cache_part3 每次都会运行全部 12 个算法。</a:t>
+              <a:t>课程已提供各阶段独立 Slurm 脚本，列表见 slurm/README.md。从课程根目录先 mkdir -p results，再用 sbatch 提交；脚本会完成编译、CTest 和环境记录，并进入 Lab 2 目录。下方代码展示实验命令。每次只运行一个阶段，同一源码目录一次只运行一个作业。程序前增加 srun --cpu-bind=cores，参数与 README 一致。在 srun --pty 打开的交互式计算终端，直接使用 README 不带 srun 前缀的程序命令，已有终端会话已绑定 CPU。 : &gt; 和 tee 会覆盖同名日志，重跑前保存上一批结果。cache_part3 每次都会运行全部 12 个算法。</a:t>
             </a:r>
           </a:p>
         </p:txBody>
@@ -1933,7 +2158,7 @@
           </a:p>
           <a:p xmlns:a="http://schemas.openxmlformats.org/drawingml/2006/main">
             <a:r>
-              <a:t>本页命令用于替换 lab2.slurm 的实验段，保留脚本的 set -euo pipefail、编译、CTest 和 mkdir -p results；脚本已经进入 Lab 2 目录。每次只运行一个阶段，同一源码目录一次只运行一个作业。程序前增加 srun --cpu-bind=cores，参数与 README 一致。在 srun --pty 打开的交互式计算终端，直接使用 README 不带 srun 前缀的程序命令，已有终端会话已绑定 CPU。 候选值来自 n=1024 的实际结果，最大规模确认后选择最终 b。</a:t>
+              <a:t>课程已提供各阶段独立 Slurm 脚本，列表见 slurm/README.md。从课程根目录先 mkdir -p results，再用 sbatch 提交；脚本会完成编译、CTest 和环境记录，并进入 Lab 2 目录。下方代码展示实验命令。每次只运行一个阶段，同一源码目录一次只运行一个作业。程序前增加 srun --cpu-bind=cores，参数与 README 一致。在 srun --pty 打开的交互式计算终端，直接使用 README 不带 srun 前缀的程序命令，已有终端会话已绑定 CPU。 候选值来自 n=1024 的实际结果，最大规模确认后选择最终 b。</a:t>
             </a:r>
           </a:p>
         </p:txBody>
@@ -2008,7 +2233,7 @@
           </a:p>
           <a:p xmlns:a="http://schemas.openxmlformats.org/drawingml/2006/main">
             <a:r>
-              <a:t>本页命令用于替换 lab2.slurm 的实验段，保留脚本的 set -euo pipefail、编译、CTest 和 mkdir -p results；脚本已经进入 Lab 2 目录。每次只运行一个阶段，同一源码目录一次只运行一个作业。程序前增加 srun --cpu-bind=cores，参数与 README 一致。在 srun --pty 打开的交互式计算终端，直接使用 README 不带 srun 前缀的程序命令，已有终端会话已绑定 CPU。 四个优化级别必须保持同一 n、b 和源码。</a:t>
+              <a:t>课程已提供各阶段独立 Slurm 脚本，列表见 slurm/README.md。从课程根目录先 mkdir -p results，再用 sbatch 提交；脚本会完成编译、CTest 和环境记录，并进入 Lab 2 目录。下方代码展示实验命令。每次只运行一个阶段，同一源码目录一次只运行一个作业。程序前增加 srun --cpu-bind=cores，参数与 README 一致。在 srun --pty 打开的交互式计算终端，直接使用 README 不带 srun 前缀的程序命令，已有终端会话已绑定 CPU。 四个优化级别必须保持同一 n、b 和源码。</a:t>
             </a:r>
           </a:p>
         </p:txBody>
@@ -2083,7 +2308,7 @@
           </a:p>
           <a:p xmlns:a="http://schemas.openxmlformats.org/drawingml/2006/main">
             <a:r>
-              <a:t>本页命令用于替换 lab2.slurm 的实验段，保留脚本的 set -euo pipefail、编译、CTest 和 mkdir -p results；脚本已经进入 Lab 2 目录。每次只运行一个阶段，同一源码目录一次只运行一个作业。程序前增加 srun --cpu-bind=cores，参数与 README 一致。在 srun --pty 打开的交互式计算终端，直接使用 README 不带 srun 前缀的程序命令，已有终端会话已绑定 CPU。 对其他正式配置也建议重复 3 次。保存同名文件旧版本，防止覆盖。记录正确性结果，INVALID 数据不作为有效性能数据。</a:t>
+              <a:t>课程已提供各阶段独立 Slurm 脚本，列表见 slurm/README.md。从课程根目录先 mkdir -p results，再用 sbatch 提交；脚本会完成编译、CTest 和环境记录，并进入 Lab 2 目录。下方代码展示实验命令。每次只运行一个阶段，同一源码目录一次只运行一个作业。程序前增加 srun --cpu-bind=cores，参数与 README 一致。在 srun --pty 打开的交互式计算终端，直接使用 README 不带 srun 前缀的程序命令，已有终端会话已绑定 CPU。 对其他正式配置也建议重复 3 次。保存同名文件旧版本，防止覆盖。记录正确性结果，INVALID 数据不作为有效性能数据。</a:t>
             </a:r>
           </a:p>
         </p:txBody>
@@ -2158,7 +2383,7 @@
           </a:p>
           <a:p xmlns:a="http://schemas.openxmlformats.org/drawingml/2006/main">
             <a:r>
-              <a:t>本页命令用于替换 lab2.slurm 的实验段，保留脚本的 set -euo pipefail、编译、CTest 和 mkdir -p results；脚本已经进入 Lab 2 目录。每次只运行一个阶段，同一源码目录一次只运行一个作业。程序前增加 srun --cpu-bind=cores，参数与 README 一致。在 srun --pty 打开的交互式计算终端，直接使用 README 不带 srun 前缀的程序命令，已有终端会话已绑定 CPU。</a:t>
+              <a:t>各 Lab 2 Slurm 脚本自动记录环境信息和作业编号，保存在 results/environment.txt，并同时打印到作业总日志。本页代码用于交互式实验。每次只运行一个阶段，同一源码目录一次只运行一个作业。程序前增加 srun --cpu-bind=cores，参数与 README 一致。在 srun --pty 打开的交互式计算终端，直接使用 README 不带 srun 前缀的程序命令，已有终端会话已绑定 CPU。</a:t>
             </a:r>
           </a:p>
           <a:p xmlns:a="http://schemas.openxmlformats.org/drawingml/2006/main">
@@ -2292,6 +2517,15 @@
             </a:r>
           </a:p>
           <a:p xmlns:a="http://schemas.openxmlformats.org/drawingml/2006/main">
+            <a:r>
+              <a:t/>
+            </a:r>
+            <a:endParaRPr/>
+          </a:p>
+          <a:p xmlns:a="http://schemas.openxmlformats.org/drawingml/2006/main">
+            <a:r>
+              <a:t>课程提供 slurm/lab2-default-all.slurm，在登录节点从课程根目录先 mkdir -p results，再 sbatch slurm/lab2-default-all.slurm。作业内完成编译、CTest 和默认批量检查。</a:t>
+            </a:r>
             <a:endParaRPr/>
           </a:p>
         </p:txBody>
@@ -3653,7 +3887,7 @@
   </p:cSld>
   <p:clrMap bg1="lt1" tx1="dk1" bg2="lt2" tx2="dk2" accent1="accent1" accent2="accent2" accent3="accent3" accent4="accent4" accent5="accent5" accent6="accent6" hlink="hlink" folHlink="folHlink"/>
   <p:sldLayoutIdLst>
-    <p:sldLayoutId xmlns:r="http://schemas.openxmlformats.org/officeDocument/2006/relationships" id="2147483649" r:id="R2cbd864ee68d4a77"/>
+    <p:sldLayoutId xmlns:r="http://schemas.openxmlformats.org/officeDocument/2006/relationships" id="2147483649" r:id="R481f06f6d85f449a"/>
   </p:sldLayoutIdLst>
   <p:txStyles>
     <p:titleStyle>
@@ -7007,7 +7241,7 @@
                 <a:ea typeface="Menlo"/>
                 <a:cs typeface="Menlo"/>
               </a:rPr>
-              <a:t>srun -p cpu -N 1 -n 1 -c 1 -t 00:20:00 \</a:t>
+              <a:t>srun -p cpu -N 1 -n 1 -c 1 -t 03:00:00 \</a:t>
             </a:r>
           </a:p>
         </p:txBody>
@@ -9567,7 +9801,7 @@
                 <a:ea typeface="Hiragino Sans GB"/>
                 <a:cs typeface="Hiragino Sans GB"/>
               </a:rPr>
-              <a:t>每次修改 src/mygemm.c 后重新编译，再检查相应函数</a:t>
+              <a:t>批处理：sbatch slurm/lab2-check.slurm（从课程根目录提交）</a:t>
             </a:r>
           </a:p>
         </p:txBody>
@@ -10203,7 +10437,7 @@
                           <a:ea typeface="Hiragino Sans GB"/>
                           <a:cs typeface="Hiragino Sans GB"/>
                         </a:rPr>
-                        <a:t>00:20:00</a:t>
+                        <a:t>03:00:00</a:t>
                       </a:r>
                     </a:p>
                   </a:txBody>
@@ -10227,7 +10461,29 @@
                           <a:ea typeface="Hiragino Sans GB"/>
                           <a:cs typeface="Hiragino Sans GB"/>
                         </a:rPr>
-                        <a:t>最多运行 20 分钟，不含排队时间</a:t>
+                        <a:t>最多运行 </a:t>
+                      </a:r>
+                      <a:r>
+                        <a:rPr sz="2100" b="0">
+                          <a:solidFill>
+                            <a:srgbClr val="EAF1EF"/>
+                          </a:solidFill>
+                          <a:latin typeface="Hiragino Sans GB"/>
+                          <a:ea typeface="Hiragino Sans GB"/>
+                          <a:cs typeface="Hiragino Sans GB"/>
+                        </a:rPr>
+                        <a:t>3 小时</a:t>
+                      </a:r>
+                      <a:r>
+                        <a:rPr sz="2100" b="0">
+                          <a:solidFill>
+                            <a:srgbClr val="EAF1EF"/>
+                          </a:solidFill>
+                          <a:latin typeface="Hiragino Sans GB"/>
+                          <a:ea typeface="Hiragino Sans GB"/>
+                          <a:cs typeface="Hiragino Sans GB"/>
+                        </a:rPr>
+                        <a:t>，不含排队时间</a:t>
                       </a:r>
                     </a:p>
                   </a:txBody>
@@ -10498,7 +10754,7 @@
                 <a:ea typeface="Hiragino Sans GB"/>
                 <a:cs typeface="Hiragino Sans GB"/>
               </a:rPr>
-              <a:t>保存为仓库根目录 lab1.slurm（UTF-8 / LF）</a:t>
+              <a:t>已提供 lab1.slurm；下方展示默认评分的主要步骤</a:t>
             </a:r>
           </a:p>
         </p:txBody>
@@ -10556,7 +10812,7 @@
                 <a:ea typeface="Menlo"/>
                 <a:cs typeface="Menlo"/>
               </a:rPr>
-              <a:t>#!/bin/bash</a:t>
+              <a:t>#!/bin/bash -l</a:t>
             </a:r>
           </a:p>
         </p:txBody>
@@ -10730,7 +10986,7 @@
                 <a:ea typeface="Menlo"/>
                 <a:cs typeface="Menlo"/>
               </a:rPr>
-              <a:t>#SBATCH -t 00:20:00</a:t>
+              <a:t>#SBATCH -t 03:00:00</a:t>
             </a:r>
           </a:p>
         </p:txBody>
@@ -10962,7 +11218,7 @@
                 <a:ea typeface="Menlo"/>
                 <a:cs typeface="Menlo"/>
               </a:rPr>
-              <a:t>make</a:t>
+              <a:t>make -j1</a:t>
             </a:r>
           </a:p>
         </p:txBody>
@@ -11020,7 +11276,7 @@
                 <a:ea typeface="Menlo"/>
                 <a:cs typeface="Menlo"/>
               </a:rPr>
-              <a:t>./btest -g</a:t>
+              <a:t>srun --cpu-bind=cores ./btest -g</a:t>
             </a:r>
           </a:p>
         </p:txBody>
@@ -11078,7 +11334,7 @@
                 <a:ea typeface="Hiragino Sans GB"/>
                 <a:cs typeface="Hiragino Sans GB"/>
               </a:rPr>
-              <a:t>./btest -g 检查学生答案；编码规则按前面的 dlc 与人工检查另行核对</a:t>
+              <a:t>单题示例：sbatch lab1.slurm bitCount；编码规则仍需另行检查</a:t>
             </a:r>
           </a:p>
         </p:txBody>
@@ -11877,7 +12133,7 @@
                 <a:ea typeface="Hiragino Sans GB"/>
                 <a:cs typeface="Hiragino Sans GB"/>
               </a:rPr>
-              <a:t>lab2.slurm（UTF-8 / LF）；左列接右列，示例运行 README §8.3</a:t>
+              <a:t>已提供 lab2.slurm；左列接右列展示核心步骤，运行 README §8.3</a:t>
             </a:r>
           </a:p>
         </p:txBody>
@@ -12109,7 +12365,7 @@
                 <a:ea typeface="Menlo"/>
                 <a:cs typeface="Menlo"/>
               </a:rPr>
-              <a:t>#SBATCH -t 00:20:00</a:t>
+              <a:t>#SBATCH -t 03:00:00</a:t>
             </a:r>
           </a:p>
         </p:txBody>
@@ -12573,7 +12829,7 @@
                 <a:ea typeface="Menlo"/>
                 <a:cs typeface="Menlo"/>
               </a:rPr>
-              <a:t>ctest --test-dir build --output-on-failure</a:t>
+              <a:t>(cd build &amp;&amp; ctest --output-on-failure)</a:t>
             </a:r>
           </a:p>
         </p:txBody>
@@ -12863,7 +13119,7 @@
                 <a:ea typeface="Hiragino Sans GB"/>
                 <a:cs typeface="Hiragino Sans GB"/>
               </a:rPr>
-              <a:t>小规模通过后，每次替换末尾为一个正式阶段；同一 Lab 目录一次只跑一个作业</a:t>
+              <a:t>各阶段脚本与提交命令见 slurm/README.md；同一 Lab 目录一次只跑一个作业</a:t>
             </a:r>
           </a:p>
         </p:txBody>
@@ -13124,7 +13380,7 @@
                 <a:ea typeface="Hiragino Sans GB"/>
                 <a:cs typeface="Hiragino Sans GB"/>
               </a:rPr>
-              <a:t>README §8.2 / §8.3；本页及后续测量代码替换 lab2.slurm 的实验段</a:t>
+              <a:t>README §8.2 / §8.3；各阶段脚本已提供，下方展示实验命令</a:t>
             </a:r>
           </a:p>
         </p:txBody>
@@ -13588,7 +13844,7 @@
                 <a:ea typeface="Hiragino Sans GB"/>
                 <a:cs typeface="Hiragino Sans GB"/>
               </a:rPr>
-              <a:t>循环次序实验：n=2048、b=64；两项实验分别记录结果</a:t>
+              <a:t>分别提交：sbatch slurm/lab2-register.slurm 和 sbatch lab2.slurm</a:t>
             </a:r>
           </a:p>
         </p:txBody>
@@ -13791,7 +14047,7 @@
                 <a:ea typeface="Hiragino Sans GB"/>
                 <a:cs typeface="Hiragino Sans GB"/>
               </a:rPr>
-              <a:t>README §8.4；固定 n=1024，测试五个块大小</a:t>
+              <a:t>README §8.4；n=1024；提交 sbatch slurm/lab2-block-sweep.slurm</a:t>
             </a:r>
           </a:p>
         </p:txBody>
@@ -14980,7 +15236,7 @@
                 <a:ea typeface="Hiragino Sans GB"/>
                 <a:cs typeface="Hiragino Sans GB"/>
               </a:rPr>
-              <a:t>根据 2048 下的确认结果，为 optimal 选择最终块大小</a:t>
+              <a:t>提交示例：sbatch slurm/lab2-block-confirm.slurm 64 128</a:t>
             </a:r>
           </a:p>
         </p:txBody>
@@ -15473,7 +15729,7 @@
                 <a:ea typeface="Hiragino Sans GB"/>
                 <a:cs typeface="Hiragino Sans GB"/>
               </a:rPr>
-              <a:t>示例 b=64，替换为上一阶段确定的实际最佳块大小</a:t>
+              <a:t>提交示例：sbatch slurm/lab2-opt-levels.slurm 64；传入实际最佳 b</a:t>
             </a:r>
           </a:p>
         </p:txBody>
@@ -16198,7 +16454,7 @@
                 <a:ea typeface="Hiragino Sans GB"/>
                 <a:cs typeface="Hiragino Sans GB"/>
               </a:rPr>
-              <a:t>本页以 O3 为例；b=64 仍需替换为实际最佳块大小</a:t>
+              <a:t>提交示例：sbatch slurm/lab2-repeat.slurm 64；传入实际最佳 b</a:t>
             </a:r>
           </a:p>
         </p:txBody>
@@ -16459,7 +16715,7 @@
                 <a:ea typeface="Hiragino Sans GB"/>
                 <a:cs typeface="Hiragino Sans GB"/>
               </a:rPr>
-              <a:t>README §9；在实际运行实验的计算节点记录环境</a:t>
+              <a:t>README §9；各 Lab 2 脚本自动记录环境，下方为交互式记录方法</a:t>
             </a:r>
           </a:p>
         </p:txBody>
@@ -17996,7 +18252,7 @@
                 <a:ea typeface="Hiragino Sans GB"/>
                 <a:cs typeface="Hiragino Sans GB"/>
               </a:rPr>
-              <a:t>批量脚本在计算节点运行；向调度系统提交作业使用 sbatch</a:t>
+              <a:t>批处理：sbatch slurm/lab2-default-all.slurm（从课程根目录提交）</a:t>
             </a:r>
           </a:p>
         </p:txBody>
@@ -23124,7 +23380,7 @@
                 <a:latin typeface="Hiragino Sans GB"/>
                 <a:ea typeface="Hiragino Sans GB"/>
                 <a:cs typeface="Hiragino Sans GB"/>
-                <a:hlinkClick xmlns:r="http://schemas.openxmlformats.org/officeDocument/2006/relationships" r:id="R766c294df41042c5"/>
+                <a:hlinkClick xmlns:r="http://schemas.openxmlformats.org/officeDocument/2006/relationships" r:id="Rf2e2874232ae435e"/>
               </a:rPr>
               <a:t>登录与账号</a:t>
             </a:r>
@@ -23183,7 +23439,7 @@
                 <a:latin typeface="Hiragino Sans GB"/>
                 <a:ea typeface="Hiragino Sans GB"/>
                 <a:cs typeface="Hiragino Sans GB"/>
-                <a:hlinkClick xmlns:r="http://schemas.openxmlformats.org/officeDocument/2006/relationships" r:id="Rbdb48d6f0bee4448"/>
+                <a:hlinkClick xmlns:r="http://schemas.openxmlformats.org/officeDocument/2006/relationships" r:id="Rda742eda60e8498d"/>
               </a:rPr>
               <a:t>Slurm 作业管理</a:t>
             </a:r>
@@ -23242,7 +23498,7 @@
                 <a:latin typeface="Hiragino Sans GB"/>
                 <a:ea typeface="Hiragino Sans GB"/>
                 <a:cs typeface="Hiragino Sans GB"/>
-                <a:hlinkClick xmlns:r="http://schemas.openxmlformats.org/officeDocument/2006/relationships" r:id="Ra3f49e51ea2c4108"/>
+                <a:hlinkClick xmlns:r="http://schemas.openxmlformats.org/officeDocument/2006/relationships" r:id="R5003dcdc2046434c"/>
               </a:rPr>
               <a:t>文件传输</a:t>
             </a:r>

</xml_diff>

<commit_message>
refactor: organize Slurm scripts by README section
</commit_message>
<xml_diff>
--- a/docs/交我算平台Lab运行指南-学生版.pptx
+++ b/docs/交我算平台Lab运行指南-学生版.pptx
@@ -2,47 +2,47 @@
 <file path=ppt/presentation.xml><?xml version="1.0" encoding="utf-8"?>
 <p:presentation xmlns:p="http://schemas.openxmlformats.org/presentationml/2006/main">
   <p:sldMasterIdLst>
-    <p:sldMasterId xmlns:r="http://schemas.openxmlformats.org/officeDocument/2006/relationships" id="2147483648" r:id="R493418f1efc1463c"/>
+    <p:sldMasterId xmlns:r="http://schemas.openxmlformats.org/officeDocument/2006/relationships" id="2147483648" r:id="R200dc5bba935439d"/>
   </p:sldMasterIdLst>
   <p:notesMasterIdLst>
-    <p:notesMasterId xmlns:r="http://schemas.openxmlformats.org/officeDocument/2006/relationships" r:id="R1c440ace0b4b498b"/>
+    <p:notesMasterId xmlns:r="http://schemas.openxmlformats.org/officeDocument/2006/relationships" r:id="R1d1d16f7f01d4504"/>
   </p:notesMasterIdLst>
   <p:sldIdLst>
-    <p:sldId xmlns:r="http://schemas.openxmlformats.org/officeDocument/2006/relationships" id="256" r:id="R72ff58062e724736"/>
-    <p:sldId xmlns:r="http://schemas.openxmlformats.org/officeDocument/2006/relationships" id="257" r:id="Rffb4466b292b4551"/>
-    <p:sldId xmlns:r="http://schemas.openxmlformats.org/officeDocument/2006/relationships" id="258" r:id="Ra533eff978664dae"/>
-    <p:sldId xmlns:r="http://schemas.openxmlformats.org/officeDocument/2006/relationships" id="259" r:id="Ra68a8527b0ca44ae"/>
-    <p:sldId xmlns:r="http://schemas.openxmlformats.org/officeDocument/2006/relationships" id="260" r:id="R95f27af4555d4ad7"/>
-    <p:sldId xmlns:r="http://schemas.openxmlformats.org/officeDocument/2006/relationships" id="261" r:id="R33f307b6c03e407b"/>
-    <p:sldId xmlns:r="http://schemas.openxmlformats.org/officeDocument/2006/relationships" id="262" r:id="R4eb1e49eccb941c8"/>
-    <p:sldId xmlns:r="http://schemas.openxmlformats.org/officeDocument/2006/relationships" id="263" r:id="R7e8c35c7b8014989"/>
-    <p:sldId xmlns:r="http://schemas.openxmlformats.org/officeDocument/2006/relationships" id="264" r:id="R646b46ca12db4652"/>
-    <p:sldId xmlns:r="http://schemas.openxmlformats.org/officeDocument/2006/relationships" id="265" r:id="R3b62783d0f134714"/>
-    <p:sldId xmlns:r="http://schemas.openxmlformats.org/officeDocument/2006/relationships" id="266" r:id="R42f515e893234d19"/>
-    <p:sldId xmlns:r="http://schemas.openxmlformats.org/officeDocument/2006/relationships" id="267" r:id="R19ef538f754049c5"/>
-    <p:sldId xmlns:r="http://schemas.openxmlformats.org/officeDocument/2006/relationships" id="268" r:id="R3243cfb98a6d4665"/>
-    <p:sldId xmlns:r="http://schemas.openxmlformats.org/officeDocument/2006/relationships" id="269" r:id="Re95cac0353344f2c"/>
-    <p:sldId xmlns:r="http://schemas.openxmlformats.org/officeDocument/2006/relationships" id="270" r:id="R8268584687fd471f"/>
-    <p:sldId xmlns:r="http://schemas.openxmlformats.org/officeDocument/2006/relationships" id="271" r:id="R3ef341a755c54e9b"/>
-    <p:sldId xmlns:r="http://schemas.openxmlformats.org/officeDocument/2006/relationships" id="272" r:id="Rb5ca6a10bc104b9b"/>
-    <p:sldId xmlns:r="http://schemas.openxmlformats.org/officeDocument/2006/relationships" id="273" r:id="R18136eb127df4974"/>
-    <p:sldId xmlns:r="http://schemas.openxmlformats.org/officeDocument/2006/relationships" id="274" r:id="R98e1f03df5824ede"/>
-    <p:sldId xmlns:r="http://schemas.openxmlformats.org/officeDocument/2006/relationships" id="275" r:id="R40f5f6b8cf1149c1"/>
-    <p:sldId xmlns:r="http://schemas.openxmlformats.org/officeDocument/2006/relationships" id="276" r:id="Rf17a0c4ff9bf4ecf"/>
-    <p:sldId xmlns:r="http://schemas.openxmlformats.org/officeDocument/2006/relationships" id="277" r:id="R5466bbca83b14009"/>
-    <p:sldId xmlns:r="http://schemas.openxmlformats.org/officeDocument/2006/relationships" id="278" r:id="R39fc4b10bea94934"/>
-    <p:sldId xmlns:r="http://schemas.openxmlformats.org/officeDocument/2006/relationships" id="279" r:id="Ree0f3420640c44cf"/>
-    <p:sldId xmlns:r="http://schemas.openxmlformats.org/officeDocument/2006/relationships" id="280" r:id="R203b12f9b51d4de4"/>
-    <p:sldId xmlns:r="http://schemas.openxmlformats.org/officeDocument/2006/relationships" id="281" r:id="R31c85b4ab5b64649"/>
-    <p:sldId xmlns:r="http://schemas.openxmlformats.org/officeDocument/2006/relationships" id="282" r:id="R471bf77975d2454a"/>
-    <p:sldId xmlns:r="http://schemas.openxmlformats.org/officeDocument/2006/relationships" id="283" r:id="Ref47c10f445a44fe"/>
-    <p:sldId xmlns:r="http://schemas.openxmlformats.org/officeDocument/2006/relationships" id="284" r:id="R5dd64a7ebfaf47fa"/>
-    <p:sldId xmlns:r="http://schemas.openxmlformats.org/officeDocument/2006/relationships" id="285" r:id="R58c69408dc324362"/>
-    <p:sldId xmlns:r="http://schemas.openxmlformats.org/officeDocument/2006/relationships" id="286" r:id="Rdeac3502b3b34222"/>
-    <p:sldId xmlns:r="http://schemas.openxmlformats.org/officeDocument/2006/relationships" id="287" r:id="R63b0369a78b24f66"/>
-    <p:sldId xmlns:r="http://schemas.openxmlformats.org/officeDocument/2006/relationships" id="288" r:id="Rc73052361bff40df"/>
-    <p:sldId xmlns:r="http://schemas.openxmlformats.org/officeDocument/2006/relationships" id="289" r:id="R332ca5b1dd024d90"/>
-    <p:sldId xmlns:r="http://schemas.openxmlformats.org/officeDocument/2006/relationships" id="290" r:id="R095066e4c5264a01"/>
+    <p:sldId xmlns:r="http://schemas.openxmlformats.org/officeDocument/2006/relationships" id="256" r:id="Rd6c266e173cc446f"/>
+    <p:sldId xmlns:r="http://schemas.openxmlformats.org/officeDocument/2006/relationships" id="257" r:id="R3bbd3a918f0b476a"/>
+    <p:sldId xmlns:r="http://schemas.openxmlformats.org/officeDocument/2006/relationships" id="258" r:id="Rabe246a249f84b22"/>
+    <p:sldId xmlns:r="http://schemas.openxmlformats.org/officeDocument/2006/relationships" id="259" r:id="Rd7ebbf294e934afb"/>
+    <p:sldId xmlns:r="http://schemas.openxmlformats.org/officeDocument/2006/relationships" id="260" r:id="Ra2d915e8b6b04903"/>
+    <p:sldId xmlns:r="http://schemas.openxmlformats.org/officeDocument/2006/relationships" id="261" r:id="Re83843099e554df8"/>
+    <p:sldId xmlns:r="http://schemas.openxmlformats.org/officeDocument/2006/relationships" id="262" r:id="R0938464cbf6541ea"/>
+    <p:sldId xmlns:r="http://schemas.openxmlformats.org/officeDocument/2006/relationships" id="263" r:id="Rd5a7a541f5bd4e85"/>
+    <p:sldId xmlns:r="http://schemas.openxmlformats.org/officeDocument/2006/relationships" id="264" r:id="R4435c1a05ccc4ddb"/>
+    <p:sldId xmlns:r="http://schemas.openxmlformats.org/officeDocument/2006/relationships" id="265" r:id="R3d8a23b19c7440f1"/>
+    <p:sldId xmlns:r="http://schemas.openxmlformats.org/officeDocument/2006/relationships" id="266" r:id="Rdc7e9b6bb3054b5a"/>
+    <p:sldId xmlns:r="http://schemas.openxmlformats.org/officeDocument/2006/relationships" id="267" r:id="R9048597ebcf942bb"/>
+    <p:sldId xmlns:r="http://schemas.openxmlformats.org/officeDocument/2006/relationships" id="268" r:id="R6e46a834c0514ec9"/>
+    <p:sldId xmlns:r="http://schemas.openxmlformats.org/officeDocument/2006/relationships" id="269" r:id="Rd29f426a1f814d6a"/>
+    <p:sldId xmlns:r="http://schemas.openxmlformats.org/officeDocument/2006/relationships" id="270" r:id="Rb8fe0c33e1b049a0"/>
+    <p:sldId xmlns:r="http://schemas.openxmlformats.org/officeDocument/2006/relationships" id="271" r:id="R411690cc35364e1c"/>
+    <p:sldId xmlns:r="http://schemas.openxmlformats.org/officeDocument/2006/relationships" id="272" r:id="R1baada85fea04429"/>
+    <p:sldId xmlns:r="http://schemas.openxmlformats.org/officeDocument/2006/relationships" id="273" r:id="Re0eba6297a844b40"/>
+    <p:sldId xmlns:r="http://schemas.openxmlformats.org/officeDocument/2006/relationships" id="274" r:id="R5cae5579a372450a"/>
+    <p:sldId xmlns:r="http://schemas.openxmlformats.org/officeDocument/2006/relationships" id="275" r:id="R2e326f212d534675"/>
+    <p:sldId xmlns:r="http://schemas.openxmlformats.org/officeDocument/2006/relationships" id="276" r:id="R262f4ed772a740e0"/>
+    <p:sldId xmlns:r="http://schemas.openxmlformats.org/officeDocument/2006/relationships" id="277" r:id="Rafe88f8ca4864beb"/>
+    <p:sldId xmlns:r="http://schemas.openxmlformats.org/officeDocument/2006/relationships" id="278" r:id="R44bac2ccb4bc443b"/>
+    <p:sldId xmlns:r="http://schemas.openxmlformats.org/officeDocument/2006/relationships" id="279" r:id="Rd2c410aad7a94625"/>
+    <p:sldId xmlns:r="http://schemas.openxmlformats.org/officeDocument/2006/relationships" id="280" r:id="Re532d95e50a84ab5"/>
+    <p:sldId xmlns:r="http://schemas.openxmlformats.org/officeDocument/2006/relationships" id="281" r:id="R586f2b6e7b36474e"/>
+    <p:sldId xmlns:r="http://schemas.openxmlformats.org/officeDocument/2006/relationships" id="282" r:id="R6453057e21004c59"/>
+    <p:sldId xmlns:r="http://schemas.openxmlformats.org/officeDocument/2006/relationships" id="283" r:id="R9fcf4577490d4c7c"/>
+    <p:sldId xmlns:r="http://schemas.openxmlformats.org/officeDocument/2006/relationships" id="284" r:id="Ra4abc0a61d194acd"/>
+    <p:sldId xmlns:r="http://schemas.openxmlformats.org/officeDocument/2006/relationships" id="285" r:id="Re72a63e31cba4d83"/>
+    <p:sldId xmlns:r="http://schemas.openxmlformats.org/officeDocument/2006/relationships" id="286" r:id="R689aaa56846945c1"/>
+    <p:sldId xmlns:r="http://schemas.openxmlformats.org/officeDocument/2006/relationships" id="287" r:id="Rd9e8e89254a742f0"/>
+    <p:sldId xmlns:r="http://schemas.openxmlformats.org/officeDocument/2006/relationships" id="288" r:id="Rfc76eb1f0bd2410b"/>
+    <p:sldId xmlns:r="http://schemas.openxmlformats.org/officeDocument/2006/relationships" id="289" r:id="R52ca133db8634e1b"/>
+    <p:sldId xmlns:r="http://schemas.openxmlformats.org/officeDocument/2006/relationships" id="290" r:id="Rd3cf3cf8656c413d"/>
   </p:sldIdLst>
   <p:sldSz cx="15240000" cy="8572500"/>
   <p:notesSz cx="6858000" cy="9144000"/>
@@ -1286,7 +1286,7 @@
           </a:p>
           <a:p xmlns:a="http://schemas.openxmlformats.org/drawingml/2006/main">
             <a:r>
-              <a:t>完整批处理脚本已提供：从课程根目录执行 mkdir -p results，再 sbatch slurm/lab2-check.slurm。</a:t>
+              <a:t>完整批处理脚本已提供：从课程根目录执行 mkdir -p results，再 sbatch slurm/lab2-7.2.slurm。</a:t>
             </a:r>
           </a:p>
         </p:txBody>
@@ -1469,7 +1469,7 @@
           </a:p>
           <a:p xmlns:a="http://schemas.openxmlformats.org/drawingml/2006/main">
             <a:r>
-              <a:t>课程根目录已提供 lab1.slurm；页面展示默认评分的主要步骤，完整脚本还检查 Slurm 环境、参数数量，并支持 sbatch lab1.slurm bitCount。</a:t>
+              <a:t>课程已提供 slurm/lab1-10.slurm；页面展示默认评分的主要步骤，完整脚本还检查 Slurm 环境、参数数量，并支持 sbatch slurm/lab1-10.slurm bitCount。</a:t>
             </a:r>
           </a:p>
           <a:p xmlns:a="http://schemas.openxmlformats.org/drawingml/2006/main">
@@ -1529,7 +1529,7 @@
           </a:p>
           <a:p xmlns:a="http://schemas.openxmlformats.org/drawingml/2006/main">
             <a:r>
-              <a:t>  echo "用法：sbatch lab1.slurm [函数名]" &gt;&amp;2</a:t>
+              <a:t>  echo "用法：sbatch slurm/lab1-10.slurm [函数名]" &gt;&amp;2</a:t>
             </a:r>
           </a:p>
           <a:p xmlns:a="http://schemas.openxmlformats.org/drawingml/2006/main">
@@ -1737,7 +1737,7 @@
           <a:lstStyle xmlns:a="http://schemas.openxmlformats.org/drawingml/2006/main"/>
           <a:p xmlns:a="http://schemas.openxmlformats.org/drawingml/2006/main">
             <a:r>
-              <a:t>来源：课程仓库 labs/lab2-matrix/README.md 第 5、7、8、9 节及 lab2.slurm（2026-09-27）。</a:t>
+              <a:t>来源：课程仓库 labs/lab2-matrix/README.md 第 5、7、8、9 节及 slurm/lab2-8.3.slurm（2026-09-27）。</a:t>
             </a:r>
           </a:p>
           <a:p xmlns:a="http://schemas.openxmlformats.org/drawingml/2006/main">
@@ -2524,7 +2524,7 @@
           </a:p>
           <a:p xmlns:a="http://schemas.openxmlformats.org/drawingml/2006/main">
             <a:r>
-              <a:t>课程提供 slurm/lab2-default-all.slurm，在登录节点从课程根目录先 mkdir -p results，再 sbatch slurm/lab2-default-all.slurm。作业内完成编译、CTest 和默认批量检查。</a:t>
+              <a:t>课程提供 slurm/lab2-8.7.slurm，在登录节点从课程根目录先 mkdir -p results，再 sbatch slurm/lab2-8.7.slurm。作业内完成编译、CTest 和默认批量检查。</a:t>
             </a:r>
             <a:endParaRPr/>
           </a:p>
@@ -3887,7 +3887,7 @@
   </p:cSld>
   <p:clrMap bg1="lt1" tx1="dk1" bg2="lt2" tx2="dk2" accent1="accent1" accent2="accent2" accent3="accent3" accent4="accent4" accent5="accent5" accent6="accent6" hlink="hlink" folHlink="folHlink"/>
   <p:sldLayoutIdLst>
-    <p:sldLayoutId xmlns:r="http://schemas.openxmlformats.org/officeDocument/2006/relationships" id="2147483649" r:id="R481f06f6d85f449a"/>
+    <p:sldLayoutId xmlns:r="http://schemas.openxmlformats.org/officeDocument/2006/relationships" id="2147483649" r:id="Rcc60eebd370040d1"/>
   </p:sldLayoutIdLst>
   <p:txStyles>
     <p:titleStyle>
@@ -9801,7 +9801,7 @@
                 <a:ea typeface="Hiragino Sans GB"/>
                 <a:cs typeface="Hiragino Sans GB"/>
               </a:rPr>
-              <a:t>批处理：sbatch slurm/lab2-check.slurm（从课程根目录提交）</a:t>
+              <a:t>批处理：sbatch slurm/lab2-7.2.slurm（从课程根目录提交）</a:t>
             </a:r>
           </a:p>
         </p:txBody>
@@ -10754,7 +10754,7 @@
                 <a:ea typeface="Hiragino Sans GB"/>
                 <a:cs typeface="Hiragino Sans GB"/>
               </a:rPr>
-              <a:t>已提供 lab1.slurm；下方展示默认评分的主要步骤</a:t>
+              <a:t>已提供 slurm/lab1-10.slurm；下方展示默认评分的主要步骤</a:t>
             </a:r>
           </a:p>
         </p:txBody>
@@ -11334,7 +11334,7 @@
                 <a:ea typeface="Hiragino Sans GB"/>
                 <a:cs typeface="Hiragino Sans GB"/>
               </a:rPr>
-              <a:t>单题示例：sbatch lab1.slurm bitCount；编码规则仍需另行检查</a:t>
+              <a:t>单题示例：sbatch slurm/lab1-10.slurm bitCount；编码规则仍需另行检查</a:t>
             </a:r>
           </a:p>
         </p:txBody>
@@ -12133,7 +12133,7 @@
                 <a:ea typeface="Hiragino Sans GB"/>
                 <a:cs typeface="Hiragino Sans GB"/>
               </a:rPr>
-              <a:t>已提供 lab2.slurm；左列接右列展示核心步骤，运行 README §8.3</a:t>
+              <a:t>已提供 slurm/lab2-8.3.slurm；左列接右列展示核心步骤，运行 README §8.3</a:t>
             </a:r>
           </a:p>
         </p:txBody>
@@ -13844,7 +13844,7 @@
                 <a:ea typeface="Hiragino Sans GB"/>
                 <a:cs typeface="Hiragino Sans GB"/>
               </a:rPr>
-              <a:t>分别提交：sbatch slurm/lab2-register.slurm 和 sbatch lab2.slurm</a:t>
+              <a:t>分别提交：sbatch slurm/lab2-8.2.slurm 和 sbatch slurm/lab2-8.3.slurm</a:t>
             </a:r>
           </a:p>
         </p:txBody>
@@ -14047,7 +14047,7 @@
                 <a:ea typeface="Hiragino Sans GB"/>
                 <a:cs typeface="Hiragino Sans GB"/>
               </a:rPr>
-              <a:t>README §8.4；n=1024；提交 sbatch slurm/lab2-block-sweep.slurm</a:t>
+              <a:t>README §8.4；n=1024；提交 sbatch slurm/lab2-8.4-block-sweep.slurm</a:t>
             </a:r>
           </a:p>
         </p:txBody>
@@ -15236,7 +15236,7 @@
                 <a:ea typeface="Hiragino Sans GB"/>
                 <a:cs typeface="Hiragino Sans GB"/>
               </a:rPr>
-              <a:t>提交示例：sbatch slurm/lab2-block-confirm.slurm 64 128</a:t>
+              <a:t>提交示例：sbatch slurm/lab2-8.4-block-confirm.slurm 64 128</a:t>
             </a:r>
           </a:p>
         </p:txBody>
@@ -15729,7 +15729,7 @@
                 <a:ea typeface="Hiragino Sans GB"/>
                 <a:cs typeface="Hiragino Sans GB"/>
               </a:rPr>
-              <a:t>提交示例：sbatch slurm/lab2-opt-levels.slurm 64；传入实际最佳 b</a:t>
+              <a:t>提交示例：sbatch slurm/lab2-8.5.slurm 64；传入实际最佳 b</a:t>
             </a:r>
           </a:p>
         </p:txBody>
@@ -16454,7 +16454,7 @@
                 <a:ea typeface="Hiragino Sans GB"/>
                 <a:cs typeface="Hiragino Sans GB"/>
               </a:rPr>
-              <a:t>提交示例：sbatch slurm/lab2-repeat.slurm 64；传入实际最佳 b</a:t>
+              <a:t>提交示例：sbatch slurm/lab2-8.6.slurm 64；传入实际最佳 b</a:t>
             </a:r>
           </a:p>
         </p:txBody>
@@ -18252,7 +18252,7 @@
                 <a:ea typeface="Hiragino Sans GB"/>
                 <a:cs typeface="Hiragino Sans GB"/>
               </a:rPr>
-              <a:t>批处理：sbatch slurm/lab2-default-all.slurm（从课程根目录提交）</a:t>
+              <a:t>批处理：sbatch slurm/lab2-8.7.slurm（从课程根目录提交）</a:t>
             </a:r>
           </a:p>
         </p:txBody>
@@ -18571,7 +18571,7 @@
                 <a:ea typeface="Menlo"/>
                 <a:cs typeface="Menlo"/>
               </a:rPr>
-              <a:t>sbatch lab1.slurm</a:t>
+              <a:t>sbatch slurm/lab1-10.slurm</a:t>
             </a:r>
           </a:p>
         </p:txBody>
@@ -18629,7 +18629,7 @@
                 <a:ea typeface="Menlo"/>
                 <a:cs typeface="Menlo"/>
               </a:rPr>
-              <a:t>sbatch lab2.slurm</a:t>
+              <a:t>sbatch slurm/lab2-8.3.slurm</a:t>
             </a:r>
           </a:p>
         </p:txBody>
@@ -22932,7 +22932,7 @@
                 <a:ea typeface="Hiragino Sans GB"/>
                 <a:cs typeface="Hiragino Sans GB"/>
               </a:rPr>
-              <a:t>批处理作业在登录节点提交：sbatch lab1.slurm 或 sbatch lab2.slurm。</a:t>
+              <a:t>批处理作业在登录节点提交：sbatch slurm/lab1-10.slurm 或 sbatch slurm/lab2-8.3.slurm。</a:t>
             </a:r>
           </a:p>
         </p:txBody>
@@ -23380,7 +23380,7 @@
                 <a:latin typeface="Hiragino Sans GB"/>
                 <a:ea typeface="Hiragino Sans GB"/>
                 <a:cs typeface="Hiragino Sans GB"/>
-                <a:hlinkClick xmlns:r="http://schemas.openxmlformats.org/officeDocument/2006/relationships" r:id="Rf2e2874232ae435e"/>
+                <a:hlinkClick xmlns:r="http://schemas.openxmlformats.org/officeDocument/2006/relationships" r:id="R0bbc72e69a044184"/>
               </a:rPr>
               <a:t>登录与账号</a:t>
             </a:r>
@@ -23439,7 +23439,7 @@
                 <a:latin typeface="Hiragino Sans GB"/>
                 <a:ea typeface="Hiragino Sans GB"/>
                 <a:cs typeface="Hiragino Sans GB"/>
-                <a:hlinkClick xmlns:r="http://schemas.openxmlformats.org/officeDocument/2006/relationships" r:id="Rda742eda60e8498d"/>
+                <a:hlinkClick xmlns:r="http://schemas.openxmlformats.org/officeDocument/2006/relationships" r:id="R3ea5ce5390f642a9"/>
               </a:rPr>
               <a:t>Slurm 作业管理</a:t>
             </a:r>
@@ -23498,7 +23498,7 @@
                 <a:latin typeface="Hiragino Sans GB"/>
                 <a:ea typeface="Hiragino Sans GB"/>
                 <a:cs typeface="Hiragino Sans GB"/>
-                <a:hlinkClick xmlns:r="http://schemas.openxmlformats.org/officeDocument/2006/relationships" r:id="R5003dcdc2046434c"/>
+                <a:hlinkClick xmlns:r="http://schemas.openxmlformats.org/officeDocument/2006/relationships" r:id="R57a00844a1644d93"/>
               </a:rPr>
               <a:t>文件传输</a:t>
             </a:r>

</xml_diff>